<commit_message>
wip: sync [2026-06-10 20:13]
</commit_message>
<xml_diff>
--- a/josyn-intro.pptx
+++ b/josyn-intro.pptx
@@ -3772,10 +3772,10 @@
       </p:grpSpPr>
       <p:pic>
         <p:nvPicPr>
-          <p:cNvPr id="5" name="Grafik 4">
-            <a:extLst>
-              <a:ext uri="{FF2B5EF4-FFF2-40B4-BE49-F238E27FC236}">
-                <a16:creationId xmlns:a16="http://schemas.microsoft.com/office/drawing/2014/main" id="{0E9F2285-E023-1DF4-ED25-D67A46C8B388}"/>
+          <p:cNvPr id="10" name="Grafik 9">
+            <a:extLst>
+              <a:ext uri="{FF2B5EF4-FFF2-40B4-BE49-F238E27FC236}">
+                <a16:creationId xmlns:a16="http://schemas.microsoft.com/office/drawing/2014/main" id="{A615FBEC-2241-E2B6-FA16-C690E728082A}"/>
               </a:ext>
             </a:extLst>
           </p:cNvPr>
@@ -3792,8 +3792,8 @@
         </p:blipFill>
         <p:spPr>
           <a:xfrm>
-            <a:off x="2054942" y="215900"/>
-            <a:ext cx="7502559" cy="6248400"/>
+            <a:off x="2488078" y="283037"/>
+            <a:ext cx="7368244" cy="6146337"/>
           </a:xfrm>
           <a:prstGeom prst="rect">
             <a:avLst/>
@@ -3830,12 +3830,42 @@
           <a:chExt cx="0" cy="0"/>
         </a:xfrm>
       </p:grpSpPr>
+      <p:pic>
+        <p:nvPicPr>
+          <p:cNvPr id="17" name="Grafik 16">
+            <a:extLst>
+              <a:ext uri="{FF2B5EF4-FFF2-40B4-BE49-F238E27FC236}">
+                <a16:creationId xmlns:a16="http://schemas.microsoft.com/office/drawing/2014/main" id="{1058F159-EFC9-B7AB-6080-DF9EE4803380}"/>
+              </a:ext>
+            </a:extLst>
+          </p:cNvPr>
+          <p:cNvPicPr>
+            <a:picLocks noChangeAspect="1"/>
+          </p:cNvPicPr>
+          <p:nvPr/>
+        </p:nvPicPr>
+        <p:blipFill>
+          <a:blip r:embed="rId3"/>
+          <a:stretch>
+            <a:fillRect/>
+          </a:stretch>
+        </p:blipFill>
+        <p:spPr>
+          <a:xfrm>
+            <a:off x="4393078" y="283037"/>
+            <a:ext cx="7475072" cy="6235449"/>
+          </a:xfrm>
+          <a:prstGeom prst="rect">
+            <a:avLst/>
+          </a:prstGeom>
+        </p:spPr>
+      </p:pic>
       <p:grpSp>
         <p:nvGrpSpPr>
-          <p:cNvPr id="3" name="Gruppieren 2">
-            <a:extLst>
-              <a:ext uri="{FF2B5EF4-FFF2-40B4-BE49-F238E27FC236}">
-                <a16:creationId xmlns:a16="http://schemas.microsoft.com/office/drawing/2014/main" id="{1D78034D-5A69-9DBE-91EF-8C8351398613}"/>
+          <p:cNvPr id="8" name="Gruppieren 7">
+            <a:extLst>
+              <a:ext uri="{FF2B5EF4-FFF2-40B4-BE49-F238E27FC236}">
+                <a16:creationId xmlns:a16="http://schemas.microsoft.com/office/drawing/2014/main" id="{AA8F616E-2807-B6C3-829D-FDD577343009}"/>
               </a:ext>
             </a:extLst>
           </p:cNvPr>
@@ -3844,42 +3874,12 @@
         </p:nvGrpSpPr>
         <p:grpSpPr>
           <a:xfrm>
-            <a:off x="4363805" y="288396"/>
-            <a:ext cx="7502559" cy="6248400"/>
-            <a:chOff x="4363805" y="288396"/>
-            <a:chExt cx="7502559" cy="6248400"/>
+            <a:off x="439246" y="357128"/>
+            <a:ext cx="10941216" cy="6110876"/>
+            <a:chOff x="439246" y="357128"/>
+            <a:chExt cx="10941216" cy="6110876"/>
           </a:xfrm>
         </p:grpSpPr>
-        <p:pic>
-          <p:nvPicPr>
-            <p:cNvPr id="2" name="Grafik 1">
-              <a:extLst>
-                <a:ext uri="{FF2B5EF4-FFF2-40B4-BE49-F238E27FC236}">
-                  <a16:creationId xmlns:a16="http://schemas.microsoft.com/office/drawing/2014/main" id="{58F52D00-4E89-AAB6-C6F0-81B6DF5F9A92}"/>
-                </a:ext>
-              </a:extLst>
-            </p:cNvPr>
-            <p:cNvPicPr>
-              <a:picLocks noChangeAspect="1"/>
-            </p:cNvPicPr>
-            <p:nvPr/>
-          </p:nvPicPr>
-          <p:blipFill>
-            <a:blip r:embed="rId3"/>
-            <a:stretch>
-              <a:fillRect/>
-            </a:stretch>
-          </p:blipFill>
-          <p:spPr>
-            <a:xfrm>
-              <a:off x="4363805" y="288396"/>
-              <a:ext cx="7502559" cy="6248400"/>
-            </a:xfrm>
-            <a:prstGeom prst="rect">
-              <a:avLst/>
-            </a:prstGeom>
-          </p:spPr>
-        </p:pic>
         <p:sp>
           <p:nvSpPr>
             <p:cNvPr id="9" name="Ellipse 8">
@@ -4097,7 +4097,10 @@
               <a:avLst/>
             </a:prstGeom>
             <a:solidFill>
-              <a:schemeClr val="accent6"/>
+              <a:schemeClr val="tx2">
+                <a:lumMod val="50000"/>
+                <a:lumOff val="50000"/>
+              </a:schemeClr>
             </a:solidFill>
           </p:spPr>
           <p:style>
@@ -4231,33 +4234,12 @@
             </a:p>
           </p:txBody>
         </p:sp>
-      </p:grpSp>
-      <p:grpSp>
-        <p:nvGrpSpPr>
-          <p:cNvPr id="29" name="Gruppieren 28">
-            <a:extLst>
-              <a:ext uri="{FF2B5EF4-FFF2-40B4-BE49-F238E27FC236}">
-                <a16:creationId xmlns:a16="http://schemas.microsoft.com/office/drawing/2014/main" id="{529B4878-47E6-2A68-0C0E-70885CAAA946}"/>
-              </a:ext>
-            </a:extLst>
-          </p:cNvPr>
-          <p:cNvGrpSpPr/>
-          <p:nvPr/>
-        </p:nvGrpSpPr>
-        <p:grpSpPr>
-          <a:xfrm>
-            <a:off x="439246" y="357128"/>
-            <a:ext cx="3868230" cy="6110876"/>
-            <a:chOff x="439246" y="376178"/>
-            <a:chExt cx="3868230" cy="6110876"/>
-          </a:xfrm>
-        </p:grpSpPr>
         <p:grpSp>
           <p:nvGrpSpPr>
-            <p:cNvPr id="26" name="Gruppieren 25">
+            <p:cNvPr id="29" name="Gruppieren 28">
               <a:extLst>
                 <a:ext uri="{FF2B5EF4-FFF2-40B4-BE49-F238E27FC236}">
-                  <a16:creationId xmlns:a16="http://schemas.microsoft.com/office/drawing/2014/main" id="{16712B7D-636F-4DD2-F8AD-E63A3B11B065}"/>
+                  <a16:creationId xmlns:a16="http://schemas.microsoft.com/office/drawing/2014/main" id="{529B4878-47E6-2A68-0C0E-70885CAAA946}"/>
                 </a:ext>
               </a:extLst>
             </p:cNvPr>
@@ -4266,71 +4248,18 @@
           </p:nvGrpSpPr>
           <p:grpSpPr>
             <a:xfrm>
-              <a:off x="439246" y="376178"/>
+              <a:off x="439246" y="357128"/>
               <a:ext cx="3868230" cy="6110876"/>
-              <a:chOff x="533400" y="709954"/>
-              <a:chExt cx="3868230" cy="6008239"/>
+              <a:chOff x="439246" y="376178"/>
+              <a:chExt cx="3868230" cy="6110876"/>
             </a:xfrm>
           </p:grpSpPr>
-          <p:sp>
-            <p:nvSpPr>
-              <p:cNvPr id="25" name="Rechteck 24">
+          <p:grpSp>
+            <p:nvGrpSpPr>
+              <p:cNvPr id="26" name="Gruppieren 25">
                 <a:extLst>
                   <a:ext uri="{FF2B5EF4-FFF2-40B4-BE49-F238E27FC236}">
-                    <a16:creationId xmlns:a16="http://schemas.microsoft.com/office/drawing/2014/main" id="{7B747D87-04D4-2074-F96B-9C2E5405ADC9}"/>
-                  </a:ext>
-                </a:extLst>
-              </p:cNvPr>
-              <p:cNvSpPr/>
-              <p:nvPr/>
-            </p:nvSpPr>
-            <p:spPr>
-              <a:xfrm>
-                <a:off x="533400" y="714694"/>
-                <a:ext cx="3868230" cy="6003499"/>
-              </a:xfrm>
-              <a:prstGeom prst="rect">
-                <a:avLst/>
-              </a:prstGeom>
-              <a:solidFill>
-                <a:schemeClr val="tx2">
-                  <a:lumMod val="10000"/>
-                  <a:lumOff val="90000"/>
-                </a:schemeClr>
-              </a:solidFill>
-              <a:ln w="9525"/>
-            </p:spPr>
-            <p:style>
-              <a:lnRef idx="2">
-                <a:schemeClr val="accent1">
-                  <a:shade val="15000"/>
-                </a:schemeClr>
-              </a:lnRef>
-              <a:fillRef idx="1">
-                <a:schemeClr val="accent1"/>
-              </a:fillRef>
-              <a:effectRef idx="0">
-                <a:schemeClr val="accent1"/>
-              </a:effectRef>
-              <a:fontRef idx="minor">
-                <a:schemeClr val="lt1"/>
-              </a:fontRef>
-            </p:style>
-            <p:txBody>
-              <a:bodyPr rtlCol="0" anchor="ctr"/>
-              <a:lstStyle/>
-              <a:p>
-                <a:pPr algn="ctr"/>
-                <a:endParaRPr lang="de-DE"/>
-              </a:p>
-            </p:txBody>
-          </p:sp>
-          <p:grpSp>
-            <p:nvGrpSpPr>
-              <p:cNvPr id="24" name="Gruppieren 23">
-                <a:extLst>
-                  <a:ext uri="{FF2B5EF4-FFF2-40B4-BE49-F238E27FC236}">
-                    <a16:creationId xmlns:a16="http://schemas.microsoft.com/office/drawing/2014/main" id="{A77A9728-58C9-0037-9878-7944917C23DE}"/>
+                    <a16:creationId xmlns:a16="http://schemas.microsoft.com/office/drawing/2014/main" id="{16712B7D-636F-4DD2-F8AD-E63A3B11B065}"/>
                   </a:ext>
                 </a:extLst>
               </p:cNvPr>
@@ -4339,191 +4268,18 @@
             </p:nvGrpSpPr>
             <p:grpSpPr>
               <a:xfrm>
-                <a:off x="690329" y="709954"/>
-                <a:ext cx="3711301" cy="5794928"/>
-                <a:chOff x="8477360" y="773912"/>
-                <a:chExt cx="3711301" cy="5794928"/>
+                <a:off x="439246" y="376178"/>
+                <a:ext cx="3868230" cy="6110876"/>
+                <a:chOff x="533400" y="709954"/>
+                <a:chExt cx="3868230" cy="6008239"/>
               </a:xfrm>
             </p:grpSpPr>
             <p:sp>
               <p:nvSpPr>
-                <p:cNvPr id="16" name="Textfeld 15">
+                <p:cNvPr id="25" name="Rechteck 24">
                   <a:extLst>
                     <a:ext uri="{FF2B5EF4-FFF2-40B4-BE49-F238E27FC236}">
-                      <a16:creationId xmlns:a16="http://schemas.microsoft.com/office/drawing/2014/main" id="{8C6037E1-70AE-9798-6858-303404BF448A}"/>
-                    </a:ext>
-                  </a:extLst>
-                </p:cNvPr>
-                <p:cNvSpPr txBox="1"/>
-                <p:nvPr/>
-              </p:nvSpPr>
-              <p:spPr>
-                <a:xfrm>
-                  <a:off x="8825240" y="773912"/>
-                  <a:ext cx="3363421" cy="5794928"/>
-                </a:xfrm>
-                <a:prstGeom prst="rect">
-                  <a:avLst/>
-                </a:prstGeom>
-                <a:noFill/>
-              </p:spPr>
-              <p:txBody>
-                <a:bodyPr wrap="none" rtlCol="0">
-                  <a:spAutoFit/>
-                </a:bodyPr>
-                <a:lstStyle/>
-                <a:p>
-                  <a:endParaRPr lang="de-DE" b="1"/>
-                </a:p>
-                <a:p>
-                  <a:endParaRPr lang="de-DE" b="1"/>
-                </a:p>
-                <a:p>
-                  <a:r>
-                    <a:rPr lang="de-DE" sz="2000" b="1"/>
-                    <a:t>josyn-foundation</a:t>
-                  </a:r>
-                </a:p>
-                <a:p>
-                  <a:r>
-                    <a:rPr lang="de-DE" i="1"/>
-                    <a:t>- eternal!</a:t>
-                  </a:r>
-                </a:p>
-                <a:p>
-                  <a:r>
-                    <a:rPr lang="de-DE" i="1"/>
-                    <a:t>- 3 nugets</a:t>
-                  </a:r>
-                </a:p>
-                <a:p>
-                  <a:endParaRPr lang="de-DE"/>
-                </a:p>
-                <a:p>
-                  <a:r>
-                    <a:rPr lang="de-DE" sz="2000" b="1"/>
-                    <a:t>josyn-jap</a:t>
-                  </a:r>
-                </a:p>
-                <a:p>
-                  <a:r>
-                    <a:rPr lang="de-DE" i="1"/>
-                    <a:t>- the jap-protocol-</a:t>
-                  </a:r>
-                  <a:r>
-                    <a:rPr lang="de-DE" b="1" i="1">
-                      <a:solidFill>
-                        <a:srgbClr val="002060"/>
-                      </a:solidFill>
-                    </a:rPr>
-                    <a:t>contract</a:t>
-                  </a:r>
-                </a:p>
-                <a:p>
-                  <a:r>
-                    <a:rPr lang="de-DE" i="1"/>
-                    <a:t>- meant for evolution</a:t>
-                  </a:r>
-                </a:p>
-                <a:p>
-                  <a:pPr marL="285750" indent="-285750">
-                    <a:buFont typeface="Arial" panose="020B0604020202020204" pitchFamily="34" charset="0"/>
-                    <a:buChar char="•"/>
-                  </a:pPr>
-                  <a:endParaRPr lang="de-DE"/>
-                </a:p>
-                <a:p>
-                  <a:r>
-                    <a:rPr lang="de-DE" sz="2000" b="1"/>
-                    <a:t>josyn-commons</a:t>
-                  </a:r>
-                </a:p>
-                <a:p>
-                  <a:r>
-                    <a:rPr lang="de-DE" i="1"/>
-                    <a:t>- the useful satellite…</a:t>
-                  </a:r>
-                </a:p>
-                <a:p>
-                  <a:pPr marL="285750" indent="-285750">
-                    <a:buFont typeface="Arial" panose="020B0604020202020204" pitchFamily="34" charset="0"/>
-                    <a:buChar char="•"/>
-                  </a:pPr>
-                  <a:endParaRPr lang="de-DE"/>
-                </a:p>
-                <a:p>
-                  <a:r>
-                    <a:rPr lang="de-DE" sz="2000" b="1"/>
-                    <a:t>josyn-job-host</a:t>
-                  </a:r>
-                </a:p>
-                <a:p>
-                  <a:r>
-                    <a:rPr lang="de-DE" i="1"/>
-                    <a:t>- „one“ nuget</a:t>
-                  </a:r>
-                </a:p>
-                <a:p>
-                  <a:r>
-                    <a:rPr lang="de-DE" b="1" i="1">
-                      <a:solidFill>
-                        <a:srgbClr val="002060"/>
-                      </a:solidFill>
-                    </a:rPr>
-                    <a:t>- the developers perpective</a:t>
-                  </a:r>
-                </a:p>
-                <a:p>
-                  <a:r>
-                    <a:rPr lang="de-DE" sz="1400" i="1"/>
-                    <a:t>- implements the jap-client</a:t>
-                  </a:r>
-                </a:p>
-                <a:p>
-                  <a:pPr marL="285750" indent="-285750">
-                    <a:buFont typeface="Arial" panose="020B0604020202020204" pitchFamily="34" charset="0"/>
-                    <a:buChar char="•"/>
-                  </a:pPr>
-                  <a:endParaRPr lang="de-DE"/>
-                </a:p>
-                <a:p>
-                  <a:r>
-                    <a:rPr lang="de-DE" sz="2000" b="1"/>
-                    <a:t>josyn-backend</a:t>
-                  </a:r>
-                </a:p>
-                <a:p>
-                  <a:r>
-                    <a:rPr lang="de-DE" i="1"/>
-                    <a:t>- </a:t>
-                  </a:r>
-                  <a:r>
-                    <a:rPr lang="de-DE" b="1" i="1">
-                      <a:solidFill>
-                        <a:srgbClr val="002060"/>
-                      </a:solidFill>
-                    </a:rPr>
-                    <a:t>jap-server</a:t>
-                  </a:r>
-                  <a:r>
-                    <a:rPr lang="de-DE" i="1"/>
-                    <a:t> with a special role</a:t>
-                  </a:r>
-                </a:p>
-                <a:p>
-                  <a:r>
-                    <a:rPr lang="de-DE" sz="1100" i="1"/>
-                    <a:t>- the rest of the backend-iceberg out of scope here…</a:t>
-                  </a:r>
-                </a:p>
-              </p:txBody>
-            </p:sp>
-            <p:sp>
-              <p:nvSpPr>
-                <p:cNvPr id="18" name="Ellipse 17">
-                  <a:extLst>
-                    <a:ext uri="{FF2B5EF4-FFF2-40B4-BE49-F238E27FC236}">
-                      <a16:creationId xmlns:a16="http://schemas.microsoft.com/office/drawing/2014/main" id="{A92592C4-56D5-0262-68D0-18D0111A8A35}"/>
+                      <a16:creationId xmlns:a16="http://schemas.microsoft.com/office/drawing/2014/main" id="{7B747D87-04D4-2074-F96B-9C2E5405ADC9}"/>
                     </a:ext>
                   </a:extLst>
                 </p:cNvPr>
@@ -4532,12 +4288,19 @@
               </p:nvSpPr>
               <p:spPr>
                 <a:xfrm>
-                  <a:off x="8477360" y="1373452"/>
-                  <a:ext cx="323850" cy="323850"/>
+                  <a:off x="533400" y="714694"/>
+                  <a:ext cx="3868230" cy="6003499"/>
                 </a:xfrm>
-                <a:prstGeom prst="ellipse">
+                <a:prstGeom prst="rect">
                   <a:avLst/>
                 </a:prstGeom>
+                <a:solidFill>
+                  <a:schemeClr val="tx2">
+                    <a:lumMod val="10000"/>
+                    <a:lumOff val="90000"/>
+                  </a:schemeClr>
+                </a:solidFill>
+                <a:ln w="9525"/>
               </p:spPr>
               <p:style>
                 <a:lnRef idx="2">
@@ -4560,258 +4323,500 @@
                 <a:lstStyle/>
                 <a:p>
                   <a:pPr algn="ctr"/>
-                  <a:r>
-                    <a:rPr lang="de-DE" sz="2000" b="1"/>
-                    <a:t>1</a:t>
-                  </a:r>
+                  <a:endParaRPr lang="de-DE"/>
                 </a:p>
               </p:txBody>
             </p:sp>
-            <p:sp>
-              <p:nvSpPr>
-                <p:cNvPr id="19" name="Ellipse 18">
+            <p:grpSp>
+              <p:nvGrpSpPr>
+                <p:cNvPr id="24" name="Gruppieren 23">
                   <a:extLst>
                     <a:ext uri="{FF2B5EF4-FFF2-40B4-BE49-F238E27FC236}">
-                      <a16:creationId xmlns:a16="http://schemas.microsoft.com/office/drawing/2014/main" id="{D6190D3D-AD2E-3B23-9023-80BB6E2098F4}"/>
+                      <a16:creationId xmlns:a16="http://schemas.microsoft.com/office/drawing/2014/main" id="{A77A9728-58C9-0037-9878-7944917C23DE}"/>
                     </a:ext>
                   </a:extLst>
                 </p:cNvPr>
-                <p:cNvSpPr/>
+                <p:cNvGrpSpPr/>
                 <p:nvPr/>
-              </p:nvSpPr>
-              <p:spPr>
+              </p:nvGrpSpPr>
+              <p:grpSpPr>
                 <a:xfrm>
-                  <a:off x="8477360" y="2474423"/>
-                  <a:ext cx="323850" cy="323850"/>
+                  <a:off x="690329" y="709954"/>
+                  <a:ext cx="3711301" cy="5794928"/>
+                  <a:chOff x="8477360" y="773912"/>
+                  <a:chExt cx="3711301" cy="5794928"/>
                 </a:xfrm>
-                <a:prstGeom prst="ellipse">
-                  <a:avLst/>
-                </a:prstGeom>
-              </p:spPr>
-              <p:style>
-                <a:lnRef idx="2">
-                  <a:schemeClr val="accent1">
-                    <a:shade val="15000"/>
-                  </a:schemeClr>
-                </a:lnRef>
-                <a:fillRef idx="1">
-                  <a:schemeClr val="accent1"/>
-                </a:fillRef>
-                <a:effectRef idx="0">
-                  <a:schemeClr val="accent1"/>
-                </a:effectRef>
-                <a:fontRef idx="minor">
-                  <a:schemeClr val="lt1"/>
-                </a:fontRef>
-              </p:style>
-              <p:txBody>
-                <a:bodyPr rtlCol="0" anchor="ctr"/>
-                <a:lstStyle/>
-                <a:p>
-                  <a:pPr algn="ctr"/>
-                  <a:r>
-                    <a:rPr lang="de-DE" sz="2000" b="1"/>
-                    <a:t>2</a:t>
-                  </a:r>
-                </a:p>
-              </p:txBody>
-            </p:sp>
-            <p:sp>
-              <p:nvSpPr>
-                <p:cNvPr id="20" name="Ellipse 19">
-                  <a:extLst>
-                    <a:ext uri="{FF2B5EF4-FFF2-40B4-BE49-F238E27FC236}">
-                      <a16:creationId xmlns:a16="http://schemas.microsoft.com/office/drawing/2014/main" id="{F45B0A08-B968-B101-27CA-16CA54D81C07}"/>
-                    </a:ext>
-                  </a:extLst>
-                </p:cNvPr>
-                <p:cNvSpPr/>
-                <p:nvPr/>
-              </p:nvSpPr>
-              <p:spPr>
-                <a:xfrm>
-                  <a:off x="8477360" y="3579550"/>
-                  <a:ext cx="323850" cy="323850"/>
-                </a:xfrm>
-                <a:prstGeom prst="ellipse">
-                  <a:avLst/>
-                </a:prstGeom>
-              </p:spPr>
-              <p:style>
-                <a:lnRef idx="2">
-                  <a:schemeClr val="accent1">
-                    <a:shade val="15000"/>
-                  </a:schemeClr>
-                </a:lnRef>
-                <a:fillRef idx="1">
-                  <a:schemeClr val="accent1"/>
-                </a:fillRef>
-                <a:effectRef idx="0">
-                  <a:schemeClr val="accent1"/>
-                </a:effectRef>
-                <a:fontRef idx="minor">
-                  <a:schemeClr val="lt1"/>
-                </a:fontRef>
-              </p:style>
-              <p:txBody>
-                <a:bodyPr rtlCol="0" anchor="ctr"/>
-                <a:lstStyle/>
-                <a:p>
-                  <a:pPr algn="ctr"/>
-                  <a:r>
-                    <a:rPr lang="de-DE" sz="2000" b="1"/>
-                    <a:t>3</a:t>
-                  </a:r>
-                </a:p>
-              </p:txBody>
-            </p:sp>
-            <p:sp>
-              <p:nvSpPr>
-                <p:cNvPr id="21" name="Ellipse 20">
-                  <a:extLst>
-                    <a:ext uri="{FF2B5EF4-FFF2-40B4-BE49-F238E27FC236}">
-                      <a16:creationId xmlns:a16="http://schemas.microsoft.com/office/drawing/2014/main" id="{587D9FCF-DE67-CA31-CFE5-77166A0F3E4E}"/>
-                    </a:ext>
-                  </a:extLst>
-                </p:cNvPr>
-                <p:cNvSpPr/>
-                <p:nvPr/>
-              </p:nvSpPr>
-              <p:spPr>
-                <a:xfrm>
-                  <a:off x="8477360" y="4408934"/>
-                  <a:ext cx="323850" cy="323850"/>
-                </a:xfrm>
-                <a:prstGeom prst="ellipse">
-                  <a:avLst/>
-                </a:prstGeom>
-                <a:solidFill>
-                  <a:schemeClr val="accent6"/>
-                </a:solidFill>
-              </p:spPr>
-              <p:style>
-                <a:lnRef idx="2">
-                  <a:schemeClr val="accent1">
-                    <a:shade val="15000"/>
-                  </a:schemeClr>
-                </a:lnRef>
-                <a:fillRef idx="1">
-                  <a:schemeClr val="accent1"/>
-                </a:fillRef>
-                <a:effectRef idx="0">
-                  <a:schemeClr val="accent1"/>
-                </a:effectRef>
-                <a:fontRef idx="minor">
-                  <a:schemeClr val="lt1"/>
-                </a:fontRef>
-              </p:style>
-              <p:txBody>
-                <a:bodyPr rtlCol="0" anchor="ctr"/>
-                <a:lstStyle/>
-                <a:p>
-                  <a:pPr algn="ctr"/>
-                  <a:r>
-                    <a:rPr lang="de-DE" sz="2000" b="1"/>
-                    <a:t>4</a:t>
-                  </a:r>
-                </a:p>
-              </p:txBody>
-            </p:sp>
-            <p:sp>
-              <p:nvSpPr>
-                <p:cNvPr id="22" name="Ellipse 21">
-                  <a:extLst>
-                    <a:ext uri="{FF2B5EF4-FFF2-40B4-BE49-F238E27FC236}">
-                      <a16:creationId xmlns:a16="http://schemas.microsoft.com/office/drawing/2014/main" id="{2BFDA55F-8388-D4B9-467C-19A7E4DB472F}"/>
-                    </a:ext>
-                  </a:extLst>
-                </p:cNvPr>
-                <p:cNvSpPr/>
-                <p:nvPr/>
-              </p:nvSpPr>
-              <p:spPr>
-                <a:xfrm>
-                  <a:off x="8477360" y="5790448"/>
-                  <a:ext cx="323850" cy="323850"/>
-                </a:xfrm>
-                <a:prstGeom prst="ellipse">
-                  <a:avLst/>
-                </a:prstGeom>
-                <a:solidFill>
-                  <a:schemeClr val="accent5">
-                    <a:lumMod val="75000"/>
-                  </a:schemeClr>
-                </a:solidFill>
-              </p:spPr>
-              <p:style>
-                <a:lnRef idx="2">
-                  <a:schemeClr val="accent1">
-                    <a:shade val="15000"/>
-                  </a:schemeClr>
-                </a:lnRef>
-                <a:fillRef idx="1">
-                  <a:schemeClr val="accent1"/>
-                </a:fillRef>
-                <a:effectRef idx="0">
-                  <a:schemeClr val="accent1"/>
-                </a:effectRef>
-                <a:fontRef idx="minor">
-                  <a:schemeClr val="lt1"/>
-                </a:fontRef>
-              </p:style>
-              <p:txBody>
-                <a:bodyPr rtlCol="0" anchor="ctr"/>
-                <a:lstStyle/>
-                <a:p>
-                  <a:pPr algn="ctr"/>
-                  <a:r>
-                    <a:rPr lang="de-DE" sz="2000" b="1"/>
-                    <a:t>5</a:t>
-                  </a:r>
-                </a:p>
-              </p:txBody>
-            </p:sp>
+              </p:grpSpPr>
+              <p:sp>
+                <p:nvSpPr>
+                  <p:cNvPr id="16" name="Textfeld 15">
+                    <a:extLst>
+                      <a:ext uri="{FF2B5EF4-FFF2-40B4-BE49-F238E27FC236}">
+                        <a16:creationId xmlns:a16="http://schemas.microsoft.com/office/drawing/2014/main" id="{8C6037E1-70AE-9798-6858-303404BF448A}"/>
+                      </a:ext>
+                    </a:extLst>
+                  </p:cNvPr>
+                  <p:cNvSpPr txBox="1"/>
+                  <p:nvPr/>
+                </p:nvSpPr>
+                <p:spPr>
+                  <a:xfrm>
+                    <a:off x="8825240" y="773912"/>
+                    <a:ext cx="3363421" cy="5794928"/>
+                  </a:xfrm>
+                  <a:prstGeom prst="rect">
+                    <a:avLst/>
+                  </a:prstGeom>
+                  <a:noFill/>
+                </p:spPr>
+                <p:txBody>
+                  <a:bodyPr wrap="none" rtlCol="0">
+                    <a:spAutoFit/>
+                  </a:bodyPr>
+                  <a:lstStyle/>
+                  <a:p>
+                    <a:endParaRPr lang="de-DE" b="1"/>
+                  </a:p>
+                  <a:p>
+                    <a:endParaRPr lang="de-DE" b="1"/>
+                  </a:p>
+                  <a:p>
+                    <a:r>
+                      <a:rPr lang="de-DE" sz="2000" b="1"/>
+                      <a:t>josyn-foundation</a:t>
+                    </a:r>
+                  </a:p>
+                  <a:p>
+                    <a:r>
+                      <a:rPr lang="de-DE" i="1"/>
+                      <a:t>- eternal!</a:t>
+                    </a:r>
+                  </a:p>
+                  <a:p>
+                    <a:r>
+                      <a:rPr lang="de-DE" i="1"/>
+                      <a:t>- 3 nugets</a:t>
+                    </a:r>
+                  </a:p>
+                  <a:p>
+                    <a:endParaRPr lang="de-DE"/>
+                  </a:p>
+                  <a:p>
+                    <a:r>
+                      <a:rPr lang="de-DE" sz="2000" b="1"/>
+                      <a:t>josyn-jap</a:t>
+                    </a:r>
+                  </a:p>
+                  <a:p>
+                    <a:r>
+                      <a:rPr lang="de-DE" i="1"/>
+                      <a:t>- the jap-protocol-</a:t>
+                    </a:r>
+                    <a:r>
+                      <a:rPr lang="de-DE" b="1" i="1"/>
+                      <a:t>contract</a:t>
+                    </a:r>
+                  </a:p>
+                  <a:p>
+                    <a:r>
+                      <a:rPr lang="de-DE" i="1"/>
+                      <a:t>- meant for evolution…</a:t>
+                    </a:r>
+                  </a:p>
+                  <a:p>
+                    <a:pPr marL="285750" indent="-285750">
+                      <a:buFont typeface="Arial" panose="020B0604020202020204" pitchFamily="34" charset="0"/>
+                      <a:buChar char="•"/>
+                    </a:pPr>
+                    <a:endParaRPr lang="de-DE"/>
+                  </a:p>
+                  <a:p>
+                    <a:r>
+                      <a:rPr lang="de-DE" sz="2000" b="1"/>
+                      <a:t>josyn-commons</a:t>
+                    </a:r>
+                  </a:p>
+                  <a:p>
+                    <a:r>
+                      <a:rPr lang="de-DE" i="1"/>
+                      <a:t>- the useful satellite…</a:t>
+                    </a:r>
+                  </a:p>
+                  <a:p>
+                    <a:pPr marL="285750" indent="-285750">
+                      <a:buFont typeface="Arial" panose="020B0604020202020204" pitchFamily="34" charset="0"/>
+                      <a:buChar char="•"/>
+                    </a:pPr>
+                    <a:endParaRPr lang="de-DE"/>
+                  </a:p>
+                  <a:p>
+                    <a:r>
+                      <a:rPr lang="de-DE" sz="2000" b="1">
+                        <a:solidFill>
+                          <a:schemeClr val="tx2">
+                            <a:lumMod val="75000"/>
+                            <a:lumOff val="25000"/>
+                          </a:schemeClr>
+                        </a:solidFill>
+                      </a:rPr>
+                      <a:t>josyn-job-host</a:t>
+                    </a:r>
+                  </a:p>
+                  <a:p>
+                    <a:r>
+                      <a:rPr lang="de-DE" i="1"/>
+                      <a:t>- „one“ nuget</a:t>
+                    </a:r>
+                  </a:p>
+                  <a:p>
+                    <a:r>
+                      <a:rPr lang="de-DE" b="1" i="1"/>
+                      <a:t>- the developers perpective!</a:t>
+                    </a:r>
+                  </a:p>
+                  <a:p>
+                    <a:r>
+                      <a:rPr lang="de-DE" sz="1400" i="1"/>
+                      <a:t>- implements the jap-client</a:t>
+                    </a:r>
+                  </a:p>
+                  <a:p>
+                    <a:pPr marL="285750" indent="-285750">
+                      <a:buFont typeface="Arial" panose="020B0604020202020204" pitchFamily="34" charset="0"/>
+                      <a:buChar char="•"/>
+                    </a:pPr>
+                    <a:endParaRPr lang="de-DE"/>
+                  </a:p>
+                  <a:p>
+                    <a:r>
+                      <a:rPr lang="de-DE" sz="2000" b="1">
+                        <a:solidFill>
+                          <a:srgbClr val="7030A0"/>
+                        </a:solidFill>
+                      </a:rPr>
+                      <a:t>josyn-backend</a:t>
+                    </a:r>
+                  </a:p>
+                  <a:p>
+                    <a:r>
+                      <a:rPr lang="de-DE" i="1"/>
+                      <a:t>- </a:t>
+                    </a:r>
+                    <a:r>
+                      <a:rPr lang="de-DE" b="1" i="1"/>
+                      <a:t>jap-server</a:t>
+                    </a:r>
+                    <a:r>
+                      <a:rPr lang="de-DE" i="1"/>
+                      <a:t> with a special role</a:t>
+                    </a:r>
+                  </a:p>
+                  <a:p>
+                    <a:r>
+                      <a:rPr lang="de-DE" sz="1100" i="1"/>
+                      <a:t>- the rest of the backend-iceberg out of scope here…</a:t>
+                    </a:r>
+                  </a:p>
+                </p:txBody>
+              </p:sp>
+              <p:sp>
+                <p:nvSpPr>
+                  <p:cNvPr id="18" name="Ellipse 17">
+                    <a:extLst>
+                      <a:ext uri="{FF2B5EF4-FFF2-40B4-BE49-F238E27FC236}">
+                        <a16:creationId xmlns:a16="http://schemas.microsoft.com/office/drawing/2014/main" id="{A92592C4-56D5-0262-68D0-18D0111A8A35}"/>
+                      </a:ext>
+                    </a:extLst>
+                  </p:cNvPr>
+                  <p:cNvSpPr/>
+                  <p:nvPr/>
+                </p:nvSpPr>
+                <p:spPr>
+                  <a:xfrm>
+                    <a:off x="8477360" y="1373452"/>
+                    <a:ext cx="323850" cy="323850"/>
+                  </a:xfrm>
+                  <a:prstGeom prst="ellipse">
+                    <a:avLst/>
+                  </a:prstGeom>
+                </p:spPr>
+                <p:style>
+                  <a:lnRef idx="2">
+                    <a:schemeClr val="accent1">
+                      <a:shade val="15000"/>
+                    </a:schemeClr>
+                  </a:lnRef>
+                  <a:fillRef idx="1">
+                    <a:schemeClr val="accent1"/>
+                  </a:fillRef>
+                  <a:effectRef idx="0">
+                    <a:schemeClr val="accent1"/>
+                  </a:effectRef>
+                  <a:fontRef idx="minor">
+                    <a:schemeClr val="lt1"/>
+                  </a:fontRef>
+                </p:style>
+                <p:txBody>
+                  <a:bodyPr rtlCol="0" anchor="ctr"/>
+                  <a:lstStyle/>
+                  <a:p>
+                    <a:pPr algn="ctr"/>
+                    <a:r>
+                      <a:rPr lang="de-DE" sz="2000" b="1"/>
+                      <a:t>1</a:t>
+                    </a:r>
+                  </a:p>
+                </p:txBody>
+              </p:sp>
+              <p:sp>
+                <p:nvSpPr>
+                  <p:cNvPr id="19" name="Ellipse 18">
+                    <a:extLst>
+                      <a:ext uri="{FF2B5EF4-FFF2-40B4-BE49-F238E27FC236}">
+                        <a16:creationId xmlns:a16="http://schemas.microsoft.com/office/drawing/2014/main" id="{D6190D3D-AD2E-3B23-9023-80BB6E2098F4}"/>
+                      </a:ext>
+                    </a:extLst>
+                  </p:cNvPr>
+                  <p:cNvSpPr/>
+                  <p:nvPr/>
+                </p:nvSpPr>
+                <p:spPr>
+                  <a:xfrm>
+                    <a:off x="8477360" y="2474423"/>
+                    <a:ext cx="323850" cy="323850"/>
+                  </a:xfrm>
+                  <a:prstGeom prst="ellipse">
+                    <a:avLst/>
+                  </a:prstGeom>
+                </p:spPr>
+                <p:style>
+                  <a:lnRef idx="2">
+                    <a:schemeClr val="accent1">
+                      <a:shade val="15000"/>
+                    </a:schemeClr>
+                  </a:lnRef>
+                  <a:fillRef idx="1">
+                    <a:schemeClr val="accent1"/>
+                  </a:fillRef>
+                  <a:effectRef idx="0">
+                    <a:schemeClr val="accent1"/>
+                  </a:effectRef>
+                  <a:fontRef idx="minor">
+                    <a:schemeClr val="lt1"/>
+                  </a:fontRef>
+                </p:style>
+                <p:txBody>
+                  <a:bodyPr rtlCol="0" anchor="ctr"/>
+                  <a:lstStyle/>
+                  <a:p>
+                    <a:pPr algn="ctr"/>
+                    <a:r>
+                      <a:rPr lang="de-DE" sz="2000" b="1"/>
+                      <a:t>2</a:t>
+                    </a:r>
+                  </a:p>
+                </p:txBody>
+              </p:sp>
+              <p:sp>
+                <p:nvSpPr>
+                  <p:cNvPr id="20" name="Ellipse 19">
+                    <a:extLst>
+                      <a:ext uri="{FF2B5EF4-FFF2-40B4-BE49-F238E27FC236}">
+                        <a16:creationId xmlns:a16="http://schemas.microsoft.com/office/drawing/2014/main" id="{F45B0A08-B968-B101-27CA-16CA54D81C07}"/>
+                      </a:ext>
+                    </a:extLst>
+                  </p:cNvPr>
+                  <p:cNvSpPr/>
+                  <p:nvPr/>
+                </p:nvSpPr>
+                <p:spPr>
+                  <a:xfrm>
+                    <a:off x="8477360" y="3579550"/>
+                    <a:ext cx="323850" cy="323850"/>
+                  </a:xfrm>
+                  <a:prstGeom prst="ellipse">
+                    <a:avLst/>
+                  </a:prstGeom>
+                </p:spPr>
+                <p:style>
+                  <a:lnRef idx="2">
+                    <a:schemeClr val="accent1">
+                      <a:shade val="15000"/>
+                    </a:schemeClr>
+                  </a:lnRef>
+                  <a:fillRef idx="1">
+                    <a:schemeClr val="accent1"/>
+                  </a:fillRef>
+                  <a:effectRef idx="0">
+                    <a:schemeClr val="accent1"/>
+                  </a:effectRef>
+                  <a:fontRef idx="minor">
+                    <a:schemeClr val="lt1"/>
+                  </a:fontRef>
+                </p:style>
+                <p:txBody>
+                  <a:bodyPr rtlCol="0" anchor="ctr"/>
+                  <a:lstStyle/>
+                  <a:p>
+                    <a:pPr algn="ctr"/>
+                    <a:r>
+                      <a:rPr lang="de-DE" sz="2000" b="1"/>
+                      <a:t>3</a:t>
+                    </a:r>
+                  </a:p>
+                </p:txBody>
+              </p:sp>
+              <p:sp>
+                <p:nvSpPr>
+                  <p:cNvPr id="21" name="Ellipse 20">
+                    <a:extLst>
+                      <a:ext uri="{FF2B5EF4-FFF2-40B4-BE49-F238E27FC236}">
+                        <a16:creationId xmlns:a16="http://schemas.microsoft.com/office/drawing/2014/main" id="{587D9FCF-DE67-CA31-CFE5-77166A0F3E4E}"/>
+                      </a:ext>
+                    </a:extLst>
+                  </p:cNvPr>
+                  <p:cNvSpPr/>
+                  <p:nvPr/>
+                </p:nvSpPr>
+                <p:spPr>
+                  <a:xfrm>
+                    <a:off x="8477360" y="4408934"/>
+                    <a:ext cx="323850" cy="323850"/>
+                  </a:xfrm>
+                  <a:prstGeom prst="ellipse">
+                    <a:avLst/>
+                  </a:prstGeom>
+                  <a:solidFill>
+                    <a:schemeClr val="tx2">
+                      <a:lumMod val="50000"/>
+                      <a:lumOff val="50000"/>
+                    </a:schemeClr>
+                  </a:solidFill>
+                </p:spPr>
+                <p:style>
+                  <a:lnRef idx="2">
+                    <a:schemeClr val="accent1">
+                      <a:shade val="15000"/>
+                    </a:schemeClr>
+                  </a:lnRef>
+                  <a:fillRef idx="1">
+                    <a:schemeClr val="accent1"/>
+                  </a:fillRef>
+                  <a:effectRef idx="0">
+                    <a:schemeClr val="accent1"/>
+                  </a:effectRef>
+                  <a:fontRef idx="minor">
+                    <a:schemeClr val="lt1"/>
+                  </a:fontRef>
+                </p:style>
+                <p:txBody>
+                  <a:bodyPr rtlCol="0" anchor="ctr"/>
+                  <a:lstStyle/>
+                  <a:p>
+                    <a:pPr algn="ctr"/>
+                    <a:r>
+                      <a:rPr lang="de-DE" sz="2000" b="1"/>
+                      <a:t>4</a:t>
+                    </a:r>
+                  </a:p>
+                </p:txBody>
+              </p:sp>
+              <p:sp>
+                <p:nvSpPr>
+                  <p:cNvPr id="22" name="Ellipse 21">
+                    <a:extLst>
+                      <a:ext uri="{FF2B5EF4-FFF2-40B4-BE49-F238E27FC236}">
+                        <a16:creationId xmlns:a16="http://schemas.microsoft.com/office/drawing/2014/main" id="{2BFDA55F-8388-D4B9-467C-19A7E4DB472F}"/>
+                      </a:ext>
+                    </a:extLst>
+                  </p:cNvPr>
+                  <p:cNvSpPr/>
+                  <p:nvPr/>
+                </p:nvSpPr>
+                <p:spPr>
+                  <a:xfrm>
+                    <a:off x="8477360" y="5724893"/>
+                    <a:ext cx="323850" cy="323850"/>
+                  </a:xfrm>
+                  <a:prstGeom prst="ellipse">
+                    <a:avLst/>
+                  </a:prstGeom>
+                  <a:solidFill>
+                    <a:schemeClr val="accent5">
+                      <a:lumMod val="75000"/>
+                    </a:schemeClr>
+                  </a:solidFill>
+                </p:spPr>
+                <p:style>
+                  <a:lnRef idx="2">
+                    <a:schemeClr val="accent1">
+                      <a:shade val="15000"/>
+                    </a:schemeClr>
+                  </a:lnRef>
+                  <a:fillRef idx="1">
+                    <a:schemeClr val="accent1"/>
+                  </a:fillRef>
+                  <a:effectRef idx="0">
+                    <a:schemeClr val="accent1"/>
+                  </a:effectRef>
+                  <a:fontRef idx="minor">
+                    <a:schemeClr val="lt1"/>
+                  </a:fontRef>
+                </p:style>
+                <p:txBody>
+                  <a:bodyPr rtlCol="0" anchor="ctr"/>
+                  <a:lstStyle/>
+                  <a:p>
+                    <a:pPr algn="ctr"/>
+                    <a:r>
+                      <a:rPr lang="de-DE" sz="2000" b="1"/>
+                      <a:t>5</a:t>
+                    </a:r>
+                  </a:p>
+                </p:txBody>
+              </p:sp>
+            </p:grpSp>
           </p:grpSp>
+          <p:sp>
+            <p:nvSpPr>
+              <p:cNvPr id="28" name="Textfeld 27">
+                <a:extLst>
+                  <a:ext uri="{FF2B5EF4-FFF2-40B4-BE49-F238E27FC236}">
+                    <a16:creationId xmlns:a16="http://schemas.microsoft.com/office/drawing/2014/main" id="{04754427-7E09-2C7B-5A39-7749017684A5}"/>
+                  </a:ext>
+                </a:extLst>
+              </p:cNvPr>
+              <p:cNvSpPr txBox="1"/>
+              <p:nvPr/>
+            </p:nvSpPr>
+            <p:spPr>
+              <a:xfrm>
+                <a:off x="477344" y="409046"/>
+                <a:ext cx="2519855" cy="523220"/>
+              </a:xfrm>
+              <a:prstGeom prst="rect">
+                <a:avLst/>
+              </a:prstGeom>
+              <a:noFill/>
+            </p:spPr>
+            <p:txBody>
+              <a:bodyPr wrap="square">
+                <a:spAutoFit/>
+              </a:bodyPr>
+              <a:lstStyle/>
+              <a:p>
+                <a:r>
+                  <a:rPr lang="de-DE" sz="2800" b="1">
+                    <a:solidFill>
+                      <a:srgbClr val="002060"/>
+                    </a:solidFill>
+                  </a:rPr>
+                  <a:t>josyn-repos</a:t>
+                </a:r>
+              </a:p>
+            </p:txBody>
+          </p:sp>
         </p:grpSp>
-        <p:sp>
-          <p:nvSpPr>
-            <p:cNvPr id="28" name="Textfeld 27">
-              <a:extLst>
-                <a:ext uri="{FF2B5EF4-FFF2-40B4-BE49-F238E27FC236}">
-                  <a16:creationId xmlns:a16="http://schemas.microsoft.com/office/drawing/2014/main" id="{04754427-7E09-2C7B-5A39-7749017684A5}"/>
-                </a:ext>
-              </a:extLst>
-            </p:cNvPr>
-            <p:cNvSpPr txBox="1"/>
-            <p:nvPr/>
-          </p:nvSpPr>
-          <p:spPr>
-            <a:xfrm>
-              <a:off x="477344" y="409046"/>
-              <a:ext cx="2519855" cy="523220"/>
-            </a:xfrm>
-            <a:prstGeom prst="rect">
-              <a:avLst/>
-            </a:prstGeom>
-            <a:noFill/>
-          </p:spPr>
-          <p:txBody>
-            <a:bodyPr wrap="square">
-              <a:spAutoFit/>
-            </a:bodyPr>
-            <a:lstStyle/>
-            <a:p>
-              <a:r>
-                <a:rPr lang="de-DE" sz="2800" b="1">
-                  <a:solidFill>
-                    <a:srgbClr val="002060"/>
-                  </a:solidFill>
-                </a:rPr>
-                <a:t>josyn-repos</a:t>
-              </a:r>
-            </a:p>
-          </p:txBody>
-        </p:sp>
       </p:grpSp>
     </p:spTree>
     <p:extLst>
@@ -5401,7 +5406,7 @@
         </p:nvSpPr>
         <p:spPr>
           <a:xfrm>
-            <a:off x="838200" y="828675"/>
+            <a:off x="511332" y="346026"/>
             <a:ext cx="3532634" cy="2308324"/>
           </a:xfrm>
           <a:prstGeom prst="rect">
@@ -5466,8 +5471,8 @@
         </p:nvSpPr>
         <p:spPr>
           <a:xfrm>
-            <a:off x="8064883" y="474345"/>
-            <a:ext cx="3374642" cy="5909310"/>
+            <a:off x="7560174" y="367010"/>
+            <a:ext cx="4017831" cy="5909310"/>
           </a:xfrm>
           <a:prstGeom prst="rect">
             <a:avLst/>
@@ -5480,25 +5485,6 @@
           </a:bodyPr>
           <a:lstStyle/>
           <a:p>
-            <a:r>
-              <a:rPr lang="de-DE" b="1"/>
-              <a:t>storgae-realm</a:t>
-            </a:r>
-            <a:r>
-              <a:rPr lang="de-DE"/>
-              <a:t> / db</a:t>
-            </a:r>
-          </a:p>
-          <a:p>
-            <a:endParaRPr lang="de-DE"/>
-          </a:p>
-          <a:p>
-            <a:r>
-              <a:rPr lang="de-DE"/>
-              <a:t>deployment / bootsrip</a:t>
-            </a:r>
-          </a:p>
-          <a:p>
             <a:endParaRPr lang="de-DE"/>
           </a:p>
           <a:p>
@@ -5592,6 +5578,21 @@
             <a:r>
               <a:rPr lang="de-DE"/>
               <a:t>	people</a:t>
+            </a:r>
+          </a:p>
+          <a:p>
+            <a:endParaRPr lang="de-DE"/>
+          </a:p>
+          <a:p>
+            <a:r>
+              <a:rPr lang="de-DE"/>
+              <a:t>josyn als domain-agnostisches system</a:t>
+            </a:r>
+          </a:p>
+          <a:p>
+            <a:r>
+              <a:rPr lang="de-DE"/>
+              <a:t>Josyn als teil der domäne</a:t>
             </a:r>
           </a:p>
         </p:txBody>
@@ -5657,7 +5658,7 @@
         </p:nvSpPr>
         <p:spPr>
           <a:xfrm>
-            <a:off x="2622910" y="2824460"/>
+            <a:off x="3831983" y="2754481"/>
             <a:ext cx="3707682" cy="1477328"/>
           </a:xfrm>
           <a:prstGeom prst="rect">
@@ -5745,6 +5746,146 @@
             <a:r>
               <a:rPr lang="de-DE"/>
               <a:t>	</a:t>
+            </a:r>
+          </a:p>
+        </p:txBody>
+      </p:sp>
+      <p:sp>
+        <p:nvSpPr>
+          <p:cNvPr id="3" name="Textfeld 2">
+            <a:extLst>
+              <a:ext uri="{FF2B5EF4-FFF2-40B4-BE49-F238E27FC236}">
+                <a16:creationId xmlns:a16="http://schemas.microsoft.com/office/drawing/2014/main" id="{29C18F3B-60AA-F446-2720-EE185F5A41E4}"/>
+              </a:ext>
+            </a:extLst>
+          </p:cNvPr>
+          <p:cNvSpPr txBox="1"/>
+          <p:nvPr/>
+        </p:nvSpPr>
+        <p:spPr>
+          <a:xfrm>
+            <a:off x="4268169" y="367010"/>
+            <a:ext cx="3552999" cy="646331"/>
+          </a:xfrm>
+          <a:prstGeom prst="rect">
+            <a:avLst/>
+          </a:prstGeom>
+          <a:noFill/>
+        </p:spPr>
+        <p:txBody>
+          <a:bodyPr wrap="square">
+            <a:spAutoFit/>
+          </a:bodyPr>
+          <a:lstStyle/>
+          <a:p>
+            <a:r>
+              <a:rPr lang="de-DE" b="1"/>
+              <a:t>storgae-realm</a:t>
+            </a:r>
+            <a:r>
+              <a:rPr lang="de-DE"/>
+              <a:t> / db</a:t>
+            </a:r>
+          </a:p>
+          <a:p>
+            <a:endParaRPr lang="de-DE"/>
+          </a:p>
+        </p:txBody>
+      </p:sp>
+      <p:sp>
+        <p:nvSpPr>
+          <p:cNvPr id="9" name="Textfeld 8">
+            <a:extLst>
+              <a:ext uri="{FF2B5EF4-FFF2-40B4-BE49-F238E27FC236}">
+                <a16:creationId xmlns:a16="http://schemas.microsoft.com/office/drawing/2014/main" id="{F94EA407-9AED-2092-C6FC-7B7B9FA446E2}"/>
+              </a:ext>
+            </a:extLst>
+          </p:cNvPr>
+          <p:cNvSpPr txBox="1"/>
+          <p:nvPr/>
+        </p:nvSpPr>
+        <p:spPr>
+          <a:xfrm>
+            <a:off x="1316872" y="2495550"/>
+            <a:ext cx="1709571" cy="1477328"/>
+          </a:xfrm>
+          <a:prstGeom prst="rect">
+            <a:avLst/>
+          </a:prstGeom>
+          <a:noFill/>
+        </p:spPr>
+        <p:txBody>
+          <a:bodyPr wrap="none" rtlCol="0">
+            <a:spAutoFit/>
+          </a:bodyPr>
+          <a:lstStyle/>
+          <a:p>
+            <a:r>
+              <a:rPr lang="de-DE" b="1"/>
+              <a:t>principles</a:t>
+            </a:r>
+          </a:p>
+          <a:p>
+            <a:pPr lvl="1"/>
+            <a:r>
+              <a:rPr lang="de-DE"/>
+              <a:t>NRT</a:t>
+            </a:r>
+          </a:p>
+          <a:p>
+            <a:pPr lvl="1"/>
+            <a:r>
+              <a:rPr lang="de-DE"/>
+              <a:t>RP-Usage</a:t>
+            </a:r>
+          </a:p>
+          <a:p>
+            <a:pPr lvl="1"/>
+            <a:r>
+              <a:rPr lang="de-DE"/>
+              <a:t>Functional</a:t>
+            </a:r>
+          </a:p>
+          <a:p>
+            <a:pPr lvl="1"/>
+            <a:r>
+              <a:rPr lang="de-DE"/>
+              <a:t>Contracts</a:t>
+            </a:r>
+          </a:p>
+        </p:txBody>
+      </p:sp>
+      <p:sp>
+        <p:nvSpPr>
+          <p:cNvPr id="11" name="Textfeld 10">
+            <a:extLst>
+              <a:ext uri="{FF2B5EF4-FFF2-40B4-BE49-F238E27FC236}">
+                <a16:creationId xmlns:a16="http://schemas.microsoft.com/office/drawing/2014/main" id="{BD489293-44C7-2752-5AF2-8256A73E879E}"/>
+              </a:ext>
+            </a:extLst>
+          </p:cNvPr>
+          <p:cNvSpPr txBox="1"/>
+          <p:nvPr/>
+        </p:nvSpPr>
+        <p:spPr>
+          <a:xfrm>
+            <a:off x="4268343" y="1782946"/>
+            <a:ext cx="2704131" cy="369332"/>
+          </a:xfrm>
+          <a:prstGeom prst="rect">
+            <a:avLst/>
+          </a:prstGeom>
+          <a:noFill/>
+        </p:spPr>
+        <p:txBody>
+          <a:bodyPr wrap="square">
+            <a:spAutoFit/>
+          </a:bodyPr>
+          <a:lstStyle/>
+          <a:p>
+            <a:r>
+              <a:rPr lang="de-DE" b="1"/>
+              <a:t>deployment / bootsrip</a:t>
             </a:r>
           </a:p>
         </p:txBody>
@@ -5800,7 +5941,7 @@
         <p:spPr>
           <a:xfrm>
             <a:off x="2078535" y="491609"/>
-            <a:ext cx="1865511" cy="1754326"/>
+            <a:ext cx="4804585" cy="3416320"/>
           </a:xfrm>
           <a:prstGeom prst="rect">
             <a:avLst/>
@@ -5850,6 +5991,53 @@
               <a:rPr lang="de-DE"/>
               <a:t>Offene Fragen</a:t>
             </a:r>
+          </a:p>
+          <a:p>
+            <a:pPr marL="285750" indent="-285750">
+              <a:buFont typeface="Arial" panose="020B0604020202020204" pitchFamily="34" charset="0"/>
+              <a:buChar char="•"/>
+            </a:pPr>
+            <a:endParaRPr lang="de-DE"/>
+          </a:p>
+          <a:p>
+            <a:pPr marL="285750" indent="-285750">
+              <a:buFont typeface="Arial" panose="020B0604020202020204" pitchFamily="34" charset="0"/>
+              <a:buChar char="•"/>
+            </a:pPr>
+            <a:r>
+              <a:rPr lang="de-DE"/>
+              <a:t>Josyn-guide zurückbauen</a:t>
+            </a:r>
+          </a:p>
+          <a:p>
+            <a:pPr marL="285750" indent="-285750">
+              <a:buFont typeface="Arial" panose="020B0604020202020204" pitchFamily="34" charset="0"/>
+              <a:buChar char="•"/>
+            </a:pPr>
+            <a:r>
+              <a:rPr lang="de-DE"/>
+              <a:t>Gute „AI-Zitate“ einbauen</a:t>
+            </a:r>
+          </a:p>
+          <a:p>
+            <a:pPr marL="285750" indent="-285750">
+              <a:buFont typeface="Arial" panose="020B0604020202020204" pitchFamily="34" charset="0"/>
+              <a:buChar char="•"/>
+            </a:pPr>
+            <a:endParaRPr lang="de-DE"/>
+          </a:p>
+          <a:p>
+            <a:r>
+              <a:rPr lang="de-DE"/>
+              <a:t>Vorher von gitgub-ckluth =&gt; github-hävg!!!!!!!!!!</a:t>
+            </a:r>
+          </a:p>
+          <a:p>
+            <a:pPr marL="285750" indent="-285750">
+              <a:buFont typeface="Arial" panose="020B0604020202020204" pitchFamily="34" charset="0"/>
+              <a:buChar char="•"/>
+            </a:pPr>
+            <a:endParaRPr lang="de-DE"/>
           </a:p>
           <a:p>
             <a:pPr marL="285750" indent="-285750">
@@ -6008,6 +6196,9 @@
               </a:schemeClr>
             </a:solidFill>
             <a:ln>
+              <a:solidFill>
+                <a:srgbClr val="7030A0"/>
+              </a:solidFill>
               <a:prstDash val="sysDash"/>
             </a:ln>
           </p:spPr>
@@ -6065,7 +6256,11 @@
             <a:lstStyle/>
             <a:p>
               <a:r>
-                <a:rPr lang="de-DE" b="1"/>
+                <a:rPr lang="de-DE" b="1">
+                  <a:solidFill>
+                    <a:srgbClr val="7030A0"/>
+                  </a:solidFill>
+                </a:rPr>
                 <a:t>backend</a:t>
               </a:r>
             </a:p>
@@ -6118,6 +6313,14 @@
               <a:avLst/>
             </a:prstGeom>
             <a:grpFill/>
+            <a:ln>
+              <a:solidFill>
+                <a:schemeClr val="tx2">
+                  <a:lumMod val="75000"/>
+                  <a:lumOff val="25000"/>
+                </a:schemeClr>
+              </a:solidFill>
+            </a:ln>
           </p:spPr>
           <p:style>
             <a:lnRef idx="2">
@@ -6173,7 +6376,14 @@
             <a:lstStyle/>
             <a:p>
               <a:r>
-                <a:rPr lang="de-DE" b="1"/>
+                <a:rPr lang="de-DE" b="1">
+                  <a:solidFill>
+                    <a:schemeClr val="tx2">
+                      <a:lumMod val="75000"/>
+                      <a:lumOff val="25000"/>
+                    </a:schemeClr>
+                  </a:solidFill>
+                </a:rPr>
                 <a:t>job</a:t>
               </a:r>
             </a:p>
@@ -6195,9 +6405,9 @@
         <p:grpSpPr>
           <a:xfrm>
             <a:off x="4323916" y="1105230"/>
-            <a:ext cx="2507055" cy="2901871"/>
+            <a:ext cx="3185440" cy="2901871"/>
             <a:chOff x="4366189" y="2950077"/>
-            <a:chExt cx="2507055" cy="2901871"/>
+            <a:chExt cx="3185440" cy="2901871"/>
           </a:xfrm>
         </p:grpSpPr>
         <p:grpSp>
@@ -6215,9 +6425,9 @@
           <p:grpSpPr>
             <a:xfrm>
               <a:off x="4366189" y="5236651"/>
-              <a:ext cx="2507055" cy="615297"/>
+              <a:ext cx="3185440" cy="615297"/>
               <a:chOff x="4171385" y="5346379"/>
-              <a:chExt cx="1031611" cy="615297"/>
+              <a:chExt cx="1310755" cy="615297"/>
             </a:xfrm>
           </p:grpSpPr>
           <p:sp>
@@ -6289,8 +6499,8 @@
             </p:nvSpPr>
             <p:spPr>
               <a:xfrm>
-                <a:off x="4575596" y="5471494"/>
-                <a:ext cx="236433" cy="369332"/>
+                <a:off x="4358408" y="5471494"/>
+                <a:ext cx="1123732" cy="369332"/>
               </a:xfrm>
               <a:prstGeom prst="rect">
                 <a:avLst/>
@@ -6303,6 +6513,14 @@
               </a:bodyPr>
               <a:lstStyle/>
               <a:p>
+                <a:r>
+                  <a:rPr lang="de-DE" sz="1600" i="1"/>
+                  <a:t>one-to-one</a:t>
+                </a:r>
+                <a:r>
+                  <a:rPr lang="de-DE" i="1"/>
+                  <a:t> </a:t>
+                </a:r>
                 <a:r>
                   <a:rPr lang="de-DE" b="1" i="1"/>
                   <a:t>IPC</a:t>
@@ -6326,9 +6544,9 @@
           <p:grpSpPr>
             <a:xfrm>
               <a:off x="4509873" y="2950077"/>
-              <a:ext cx="2282834" cy="1933271"/>
+              <a:ext cx="2259244" cy="1933271"/>
               <a:chOff x="4452536" y="3661405"/>
-              <a:chExt cx="2282834" cy="1933271"/>
+              <a:chExt cx="2259244" cy="1933271"/>
             </a:xfrm>
           </p:grpSpPr>
           <p:sp>
@@ -6548,7 +6766,7 @@
             </p:nvSpPr>
             <p:spPr>
               <a:xfrm>
-                <a:off x="4730310" y="4362510"/>
+                <a:off x="4673154" y="4362510"/>
                 <a:ext cx="1876668" cy="523220"/>
               </a:xfrm>
               <a:prstGeom prst="rect">
@@ -6599,7 +6817,7 @@
             </p:nvSpPr>
             <p:spPr>
               <a:xfrm>
-                <a:off x="4544770" y="5002292"/>
+                <a:off x="4506666" y="5002292"/>
                 <a:ext cx="2190600" cy="553998"/>
               </a:xfrm>
               <a:prstGeom prst="rect">
@@ -6756,14 +6974,22 @@
           <a:p>
             <a:pPr algn="ctr"/>
             <a:r>
-              <a:rPr lang="de-DE" sz="1600" i="1"/>
+              <a:rPr lang="de-DE" sz="1600" i="1">
+                <a:solidFill>
+                  <a:srgbClr val="7030A0"/>
+                </a:solidFill>
+              </a:rPr>
               <a:t>Die Backend-</a:t>
             </a:r>
           </a:p>
           <a:p>
             <a:pPr algn="ctr"/>
             <a:r>
-              <a:rPr lang="de-DE" sz="1600" i="1"/>
+              <a:rPr lang="de-DE" sz="1600" i="1">
+                <a:solidFill>
+                  <a:srgbClr val="7030A0"/>
+                </a:solidFill>
+              </a:rPr>
               <a:t>Domäne</a:t>
             </a:r>
           </a:p>
@@ -6799,14 +7025,28 @@
           <a:p>
             <a:pPr algn="ctr"/>
             <a:r>
-              <a:rPr lang="de-DE" sz="1600" i="1"/>
+              <a:rPr lang="de-DE" sz="1600" i="1">
+                <a:solidFill>
+                  <a:schemeClr val="tx2">
+                    <a:lumMod val="75000"/>
+                    <a:lumOff val="25000"/>
+                  </a:schemeClr>
+                </a:solidFill>
+              </a:rPr>
               <a:t>Die Job-Dev-</a:t>
             </a:r>
           </a:p>
           <a:p>
             <a:pPr algn="ctr"/>
             <a:r>
-              <a:rPr lang="de-DE" sz="1600" i="1"/>
+              <a:rPr lang="de-DE" sz="1600" i="1">
+                <a:solidFill>
+                  <a:schemeClr val="tx2">
+                    <a:lumMod val="75000"/>
+                    <a:lumOff val="25000"/>
+                  </a:schemeClr>
+                </a:solidFill>
+              </a:rPr>
               <a:t>Domäne</a:t>
             </a:r>
           </a:p>
@@ -7184,6 +7424,11 @@
                 <a:lumOff val="90000"/>
               </a:schemeClr>
             </a:solidFill>
+            <a:ln>
+              <a:solidFill>
+                <a:srgbClr val="7030A0"/>
+              </a:solidFill>
+            </a:ln>
           </p:spPr>
           <p:style>
             <a:lnRef idx="2">
@@ -7334,6 +7579,14 @@
                 <a:lumOff val="90000"/>
               </a:schemeClr>
             </a:solidFill>
+            <a:ln>
+              <a:solidFill>
+                <a:schemeClr val="tx2">
+                  <a:lumMod val="75000"/>
+                  <a:lumOff val="25000"/>
+                </a:schemeClr>
+              </a:solidFill>
+            </a:ln>
           </p:spPr>
           <p:style>
             <a:lnRef idx="2">
@@ -7389,7 +7642,14 @@
             <a:lstStyle/>
             <a:p>
               <a:r>
-                <a:rPr lang="de-DE" b="1"/>
+                <a:rPr lang="de-DE" b="1">
+                  <a:solidFill>
+                    <a:schemeClr val="tx2">
+                      <a:lumMod val="75000"/>
+                      <a:lumOff val="25000"/>
+                    </a:schemeClr>
+                  </a:solidFill>
+                </a:rPr>
                 <a:t>job-host</a:t>
               </a:r>
             </a:p>

</xml_diff>

<commit_message>
wip: sync [2026-06-11 17:34]
</commit_message>
<xml_diff>
--- a/josyn-intro.pptx
+++ b/josyn-intro.pptx
@@ -5,19 +5,21 @@
     <p:sldMasterId id="2147483648" r:id="rId1"/>
   </p:sldMasterIdLst>
   <p:notesMasterIdLst>
-    <p:notesMasterId r:id="rId12"/>
+    <p:notesMasterId r:id="rId14"/>
   </p:notesMasterIdLst>
   <p:sldIdLst>
-    <p:sldId id="261" r:id="rId2"/>
-    <p:sldId id="259" r:id="rId3"/>
-    <p:sldId id="262" r:id="rId4"/>
-    <p:sldId id="268" r:id="rId5"/>
-    <p:sldId id="265" r:id="rId6"/>
-    <p:sldId id="266" r:id="rId7"/>
-    <p:sldId id="267" r:id="rId8"/>
-    <p:sldId id="264" r:id="rId9"/>
-    <p:sldId id="263" r:id="rId10"/>
-    <p:sldId id="260" r:id="rId11"/>
+    <p:sldId id="260" r:id="rId2"/>
+    <p:sldId id="270" r:id="rId3"/>
+    <p:sldId id="261" r:id="rId4"/>
+    <p:sldId id="259" r:id="rId5"/>
+    <p:sldId id="262" r:id="rId6"/>
+    <p:sldId id="268" r:id="rId7"/>
+    <p:sldId id="265" r:id="rId8"/>
+    <p:sldId id="266" r:id="rId9"/>
+    <p:sldId id="267" r:id="rId10"/>
+    <p:sldId id="264" r:id="rId11"/>
+    <p:sldId id="263" r:id="rId12"/>
+    <p:sldId id="269" r:id="rId13"/>
   </p:sldIdLst>
   <p:sldSz cx="12192000" cy="6858000"/>
   <p:notesSz cx="6858000" cy="9144000"/>
@@ -538,7 +540,7 @@
           <a:p>
             <a:fld id="{274F3282-AC7F-4F04-970A-9596745FD581}" type="slidenum">
               <a:rPr lang="de-DE" smtClean="0"/>
-              <a:t>2</a:t>
+              <a:t>4</a:t>
             </a:fld>
             <a:endParaRPr lang="de-DE"/>
           </a:p>
@@ -3759,66 +3761,6 @@
   <p:cSld>
     <p:spTree>
       <p:nvGrpSpPr>
-        <p:cNvPr id="1" name=""/>
-        <p:cNvGrpSpPr/>
-        <p:nvPr/>
-      </p:nvGrpSpPr>
-      <p:grpSpPr>
-        <a:xfrm>
-          <a:off x="0" y="0"/>
-          <a:ext cx="0" cy="0"/>
-          <a:chOff x="0" y="0"/>
-          <a:chExt cx="0" cy="0"/>
-        </a:xfrm>
-      </p:grpSpPr>
-      <p:pic>
-        <p:nvPicPr>
-          <p:cNvPr id="10" name="Grafik 9">
-            <a:extLst>
-              <a:ext uri="{FF2B5EF4-FFF2-40B4-BE49-F238E27FC236}">
-                <a16:creationId xmlns:a16="http://schemas.microsoft.com/office/drawing/2014/main" id="{A615FBEC-2241-E2B6-FA16-C690E728082A}"/>
-              </a:ext>
-            </a:extLst>
-          </p:cNvPr>
-          <p:cNvPicPr>
-            <a:picLocks noChangeAspect="1"/>
-          </p:cNvPicPr>
-          <p:nvPr/>
-        </p:nvPicPr>
-        <p:blipFill>
-          <a:blip r:embed="rId2"/>
-          <a:stretch>
-            <a:fillRect/>
-          </a:stretch>
-        </p:blipFill>
-        <p:spPr>
-          <a:xfrm>
-            <a:off x="2488078" y="283037"/>
-            <a:ext cx="7368244" cy="6146337"/>
-          </a:xfrm>
-          <a:prstGeom prst="rect">
-            <a:avLst/>
-          </a:prstGeom>
-        </p:spPr>
-      </p:pic>
-    </p:spTree>
-    <p:extLst>
-      <p:ext uri="{BB962C8B-B14F-4D97-AF65-F5344CB8AC3E}">
-        <p14:creationId xmlns:p14="http://schemas.microsoft.com/office/powerpoint/2010/main" val="3565579817"/>
-      </p:ext>
-    </p:extLst>
-  </p:cSld>
-  <p:clrMapOvr>
-    <a:masterClrMapping/>
-  </p:clrMapOvr>
-</p:sld>
-</file>
-
-<file path=ppt/slides/slide10.xml><?xml version="1.0" encoding="utf-8"?>
-<p:sld xmlns:a="http://schemas.openxmlformats.org/drawingml/2006/main" xmlns:r="http://schemas.openxmlformats.org/officeDocument/2006/relationships" xmlns:p="http://schemas.openxmlformats.org/presentationml/2006/main">
-  <p:cSld>
-    <p:spTree>
-      <p:nvGrpSpPr>
         <p:cNvPr id="1" name="">
           <a:extLst>
             <a:ext uri="{FF2B5EF4-FFF2-40B4-BE49-F238E27FC236}">
@@ -3839,10 +3781,1397 @@
       </p:grpSpPr>
       <p:grpSp>
         <p:nvGrpSpPr>
+          <p:cNvPr id="66" name="Gruppieren 65">
+            <a:extLst>
+              <a:ext uri="{FF2B5EF4-FFF2-40B4-BE49-F238E27FC236}">
+                <a16:creationId xmlns:a16="http://schemas.microsoft.com/office/drawing/2014/main" id="{45F580C5-8F3A-EDDB-125F-5CD169EFA36D}"/>
+              </a:ext>
+            </a:extLst>
+          </p:cNvPr>
+          <p:cNvGrpSpPr/>
+          <p:nvPr/>
+        </p:nvGrpSpPr>
+        <p:grpSpPr>
+          <a:xfrm>
+            <a:off x="1713922" y="1439437"/>
+            <a:ext cx="2992631" cy="2689384"/>
+            <a:chOff x="6606124" y="632008"/>
+            <a:chExt cx="1609958" cy="3976567"/>
+          </a:xfrm>
+          <a:solidFill>
+            <a:schemeClr val="bg1">
+              <a:lumMod val="95000"/>
+            </a:schemeClr>
+          </a:solidFill>
+        </p:grpSpPr>
+        <p:sp>
+          <p:nvSpPr>
+            <p:cNvPr id="67" name="Rechteck 66">
+              <a:extLst>
+                <a:ext uri="{FF2B5EF4-FFF2-40B4-BE49-F238E27FC236}">
+                  <a16:creationId xmlns:a16="http://schemas.microsoft.com/office/drawing/2014/main" id="{91D6CEA9-DE63-5C3E-1FC1-F87CE5390BFE}"/>
+                </a:ext>
+              </a:extLst>
+            </p:cNvPr>
+            <p:cNvSpPr/>
+            <p:nvPr/>
+          </p:nvSpPr>
+          <p:spPr>
+            <a:xfrm>
+              <a:off x="6606124" y="632008"/>
+              <a:ext cx="1609958" cy="3976567"/>
+            </a:xfrm>
+            <a:prstGeom prst="rect">
+              <a:avLst/>
+            </a:prstGeom>
+            <a:grpFill/>
+            <a:ln>
+              <a:solidFill>
+                <a:srgbClr val="7030A0"/>
+              </a:solidFill>
+            </a:ln>
+          </p:spPr>
+          <p:style>
+            <a:lnRef idx="2">
+              <a:schemeClr val="accent1">
+                <a:shade val="15000"/>
+              </a:schemeClr>
+            </a:lnRef>
+            <a:fillRef idx="1">
+              <a:schemeClr val="accent1"/>
+            </a:fillRef>
+            <a:effectRef idx="0">
+              <a:schemeClr val="accent1"/>
+            </a:effectRef>
+            <a:fontRef idx="minor">
+              <a:schemeClr val="lt1"/>
+            </a:fontRef>
+          </p:style>
+          <p:txBody>
+            <a:bodyPr rtlCol="0" anchor="ctr"/>
+            <a:lstStyle/>
+            <a:p>
+              <a:pPr algn="ctr"/>
+              <a:endParaRPr lang="de-DE"/>
+            </a:p>
+          </p:txBody>
+        </p:sp>
+        <p:sp>
+          <p:nvSpPr>
+            <p:cNvPr id="69" name="Textfeld 68">
+              <a:extLst>
+                <a:ext uri="{FF2B5EF4-FFF2-40B4-BE49-F238E27FC236}">
+                  <a16:creationId xmlns:a16="http://schemas.microsoft.com/office/drawing/2014/main" id="{06971D2B-11F1-F847-86D5-A05053D8999A}"/>
+                </a:ext>
+              </a:extLst>
+            </p:cNvPr>
+            <p:cNvSpPr txBox="1"/>
+            <p:nvPr/>
+          </p:nvSpPr>
+          <p:spPr>
+            <a:xfrm>
+              <a:off x="6607221" y="632143"/>
+              <a:ext cx="1032705" cy="546100"/>
+            </a:xfrm>
+            <a:prstGeom prst="rect">
+              <a:avLst/>
+            </a:prstGeom>
+            <a:noFill/>
+            <a:ln>
+              <a:noFill/>
+            </a:ln>
+          </p:spPr>
+          <p:txBody>
+            <a:bodyPr wrap="square" rtlCol="0">
+              <a:spAutoFit/>
+            </a:bodyPr>
+            <a:lstStyle/>
+            <a:p>
+              <a:r>
+                <a:rPr lang="de-DE" b="1">
+                  <a:solidFill>
+                    <a:srgbClr val="7030A0"/>
+                  </a:solidFill>
+                </a:rPr>
+                <a:t>Das Backend</a:t>
+              </a:r>
+            </a:p>
+          </p:txBody>
+        </p:sp>
+      </p:grpSp>
+      <p:grpSp>
+        <p:nvGrpSpPr>
+          <p:cNvPr id="9" name="Gruppieren 8">
+            <a:extLst>
+              <a:ext uri="{FF2B5EF4-FFF2-40B4-BE49-F238E27FC236}">
+                <a16:creationId xmlns:a16="http://schemas.microsoft.com/office/drawing/2014/main" id="{B20A8C9F-F57C-4D2B-2026-E1D2C374B37C}"/>
+              </a:ext>
+            </a:extLst>
+          </p:cNvPr>
+          <p:cNvGrpSpPr/>
+          <p:nvPr/>
+        </p:nvGrpSpPr>
+        <p:grpSpPr>
+          <a:xfrm>
+            <a:off x="5583614" y="1463281"/>
+            <a:ext cx="4423990" cy="2689384"/>
+            <a:chOff x="6606125" y="632008"/>
+            <a:chExt cx="1609958" cy="3976567"/>
+          </a:xfrm>
+          <a:solidFill>
+            <a:schemeClr val="bg1">
+              <a:lumMod val="95000"/>
+            </a:schemeClr>
+          </a:solidFill>
+        </p:grpSpPr>
+        <p:sp>
+          <p:nvSpPr>
+            <p:cNvPr id="10" name="Rechteck 9">
+              <a:extLst>
+                <a:ext uri="{FF2B5EF4-FFF2-40B4-BE49-F238E27FC236}">
+                  <a16:creationId xmlns:a16="http://schemas.microsoft.com/office/drawing/2014/main" id="{6921B3CE-E7A0-EC84-AE42-D587DB52C342}"/>
+                </a:ext>
+              </a:extLst>
+            </p:cNvPr>
+            <p:cNvSpPr/>
+            <p:nvPr/>
+          </p:nvSpPr>
+          <p:spPr>
+            <a:xfrm>
+              <a:off x="6606125" y="632008"/>
+              <a:ext cx="1609958" cy="3976567"/>
+            </a:xfrm>
+            <a:prstGeom prst="rect">
+              <a:avLst/>
+            </a:prstGeom>
+            <a:grpFill/>
+            <a:ln>
+              <a:solidFill>
+                <a:schemeClr val="tx2">
+                  <a:lumMod val="75000"/>
+                  <a:lumOff val="25000"/>
+                </a:schemeClr>
+              </a:solidFill>
+            </a:ln>
+          </p:spPr>
+          <p:style>
+            <a:lnRef idx="2">
+              <a:schemeClr val="accent1">
+                <a:shade val="15000"/>
+              </a:schemeClr>
+            </a:lnRef>
+            <a:fillRef idx="1">
+              <a:schemeClr val="accent1"/>
+            </a:fillRef>
+            <a:effectRef idx="0">
+              <a:schemeClr val="accent1"/>
+            </a:effectRef>
+            <a:fontRef idx="minor">
+              <a:schemeClr val="lt1"/>
+            </a:fontRef>
+          </p:style>
+          <p:txBody>
+            <a:bodyPr rtlCol="0" anchor="ctr"/>
+            <a:lstStyle/>
+            <a:p>
+              <a:pPr algn="ctr"/>
+              <a:endParaRPr lang="de-DE"/>
+            </a:p>
+          </p:txBody>
+        </p:sp>
+        <p:sp>
+          <p:nvSpPr>
+            <p:cNvPr id="11" name="Textfeld 10">
+              <a:extLst>
+                <a:ext uri="{FF2B5EF4-FFF2-40B4-BE49-F238E27FC236}">
+                  <a16:creationId xmlns:a16="http://schemas.microsoft.com/office/drawing/2014/main" id="{EC331E49-AA54-F3AD-0A2F-79D0B4B9BE38}"/>
+                </a:ext>
+              </a:extLst>
+            </p:cNvPr>
+            <p:cNvSpPr txBox="1"/>
+            <p:nvPr/>
+          </p:nvSpPr>
+          <p:spPr>
+            <a:xfrm>
+              <a:off x="6607221" y="632142"/>
+              <a:ext cx="899942" cy="659962"/>
+            </a:xfrm>
+            <a:prstGeom prst="rect">
+              <a:avLst/>
+            </a:prstGeom>
+            <a:noFill/>
+          </p:spPr>
+          <p:txBody>
+            <a:bodyPr wrap="none" rtlCol="0">
+              <a:spAutoFit/>
+            </a:bodyPr>
+            <a:lstStyle/>
+            <a:p>
+              <a:r>
+                <a:rPr lang="de-DE" b="1">
+                  <a:solidFill>
+                    <a:schemeClr val="tx2">
+                      <a:lumMod val="75000"/>
+                      <a:lumOff val="25000"/>
+                    </a:schemeClr>
+                  </a:solidFill>
+                </a:rPr>
+                <a:t>Jobhost.exe</a:t>
+              </a:r>
+            </a:p>
+          </p:txBody>
+        </p:sp>
+      </p:grpSp>
+      <p:grpSp>
+        <p:nvGrpSpPr>
+          <p:cNvPr id="15" name="Gruppieren 14">
+            <a:extLst>
+              <a:ext uri="{FF2B5EF4-FFF2-40B4-BE49-F238E27FC236}">
+                <a16:creationId xmlns:a16="http://schemas.microsoft.com/office/drawing/2014/main" id="{00681D04-726D-1F17-2FF4-63D66A1BAB7E}"/>
+              </a:ext>
+            </a:extLst>
+          </p:cNvPr>
+          <p:cNvGrpSpPr/>
+          <p:nvPr/>
+        </p:nvGrpSpPr>
+        <p:grpSpPr>
+          <a:xfrm>
+            <a:off x="8005905" y="3065442"/>
+            <a:ext cx="1823761" cy="782007"/>
+            <a:chOff x="164209" y="1507994"/>
+            <a:chExt cx="1823761" cy="782007"/>
+          </a:xfrm>
+        </p:grpSpPr>
+        <p:sp>
+          <p:nvSpPr>
+            <p:cNvPr id="16" name="Rechteck 15">
+              <a:extLst>
+                <a:ext uri="{FF2B5EF4-FFF2-40B4-BE49-F238E27FC236}">
+                  <a16:creationId xmlns:a16="http://schemas.microsoft.com/office/drawing/2014/main" id="{EE7FD0AE-ABF6-2A9B-559B-9DECBD0D518D}"/>
+                </a:ext>
+              </a:extLst>
+            </p:cNvPr>
+            <p:cNvSpPr/>
+            <p:nvPr/>
+          </p:nvSpPr>
+          <p:spPr>
+            <a:xfrm>
+              <a:off x="164209" y="1524953"/>
+              <a:ext cx="1803699" cy="765048"/>
+            </a:xfrm>
+            <a:prstGeom prst="rect">
+              <a:avLst/>
+            </a:prstGeom>
+            <a:solidFill>
+              <a:schemeClr val="tx2">
+                <a:lumMod val="10000"/>
+                <a:lumOff val="90000"/>
+              </a:schemeClr>
+            </a:solidFill>
+            <a:ln>
+              <a:solidFill>
+                <a:schemeClr val="tx2">
+                  <a:lumMod val="75000"/>
+                  <a:lumOff val="25000"/>
+                </a:schemeClr>
+              </a:solidFill>
+            </a:ln>
+          </p:spPr>
+          <p:style>
+            <a:lnRef idx="2">
+              <a:schemeClr val="accent1">
+                <a:shade val="15000"/>
+              </a:schemeClr>
+            </a:lnRef>
+            <a:fillRef idx="1">
+              <a:schemeClr val="accent1"/>
+            </a:fillRef>
+            <a:effectRef idx="0">
+              <a:schemeClr val="accent1"/>
+            </a:effectRef>
+            <a:fontRef idx="minor">
+              <a:schemeClr val="lt1"/>
+            </a:fontRef>
+          </p:style>
+          <p:txBody>
+            <a:bodyPr rtlCol="0" anchor="ctr"/>
+            <a:lstStyle/>
+            <a:p>
+              <a:pPr algn="ctr"/>
+              <a:endParaRPr lang="de-DE"/>
+            </a:p>
+          </p:txBody>
+        </p:sp>
+        <p:sp>
+          <p:nvSpPr>
+            <p:cNvPr id="17" name="Textfeld 16">
+              <a:extLst>
+                <a:ext uri="{FF2B5EF4-FFF2-40B4-BE49-F238E27FC236}">
+                  <a16:creationId xmlns:a16="http://schemas.microsoft.com/office/drawing/2014/main" id="{66E59F33-9673-BF9A-2A76-B7ED8A290DEA}"/>
+                </a:ext>
+              </a:extLst>
+            </p:cNvPr>
+            <p:cNvSpPr txBox="1"/>
+            <p:nvPr/>
+          </p:nvSpPr>
+          <p:spPr>
+            <a:xfrm>
+              <a:off x="184271" y="1507994"/>
+              <a:ext cx="1803699" cy="369332"/>
+            </a:xfrm>
+            <a:prstGeom prst="rect">
+              <a:avLst/>
+            </a:prstGeom>
+            <a:noFill/>
+          </p:spPr>
+          <p:txBody>
+            <a:bodyPr wrap="none" rtlCol="0">
+              <a:spAutoFit/>
+            </a:bodyPr>
+            <a:lstStyle/>
+            <a:p>
+              <a:r>
+                <a:rPr lang="de-DE" b="1">
+                  <a:solidFill>
+                    <a:schemeClr val="tx2">
+                      <a:lumMod val="75000"/>
+                      <a:lumOff val="25000"/>
+                    </a:schemeClr>
+                  </a:solidFill>
+                </a:rPr>
+                <a:t>job-assemblies</a:t>
+              </a:r>
+            </a:p>
+          </p:txBody>
+        </p:sp>
+      </p:grpSp>
+      <p:grpSp>
+        <p:nvGrpSpPr>
+          <p:cNvPr id="19" name="Gruppieren 18">
+            <a:extLst>
+              <a:ext uri="{FF2B5EF4-FFF2-40B4-BE49-F238E27FC236}">
+                <a16:creationId xmlns:a16="http://schemas.microsoft.com/office/drawing/2014/main" id="{41C2E713-FEED-828B-784C-F67174EC88F8}"/>
+              </a:ext>
+            </a:extLst>
+          </p:cNvPr>
+          <p:cNvGrpSpPr/>
+          <p:nvPr/>
+        </p:nvGrpSpPr>
+        <p:grpSpPr>
+          <a:xfrm>
+            <a:off x="5897322" y="1853741"/>
+            <a:ext cx="3922316" cy="708234"/>
+            <a:chOff x="164209" y="1516532"/>
+            <a:chExt cx="1803699" cy="773469"/>
+          </a:xfrm>
+        </p:grpSpPr>
+        <p:sp>
+          <p:nvSpPr>
+            <p:cNvPr id="21" name="Rechteck 20">
+              <a:extLst>
+                <a:ext uri="{FF2B5EF4-FFF2-40B4-BE49-F238E27FC236}">
+                  <a16:creationId xmlns:a16="http://schemas.microsoft.com/office/drawing/2014/main" id="{F5734D98-A5B2-DFFF-01E1-0795FEF53E54}"/>
+                </a:ext>
+              </a:extLst>
+            </p:cNvPr>
+            <p:cNvSpPr/>
+            <p:nvPr/>
+          </p:nvSpPr>
+          <p:spPr>
+            <a:xfrm>
+              <a:off x="164209" y="1524953"/>
+              <a:ext cx="1803699" cy="765048"/>
+            </a:xfrm>
+            <a:prstGeom prst="rect">
+              <a:avLst/>
+            </a:prstGeom>
+            <a:solidFill>
+              <a:schemeClr val="tx2">
+                <a:lumMod val="10000"/>
+                <a:lumOff val="90000"/>
+              </a:schemeClr>
+            </a:solidFill>
+            <a:ln>
+              <a:solidFill>
+                <a:schemeClr val="tx2">
+                  <a:lumMod val="75000"/>
+                  <a:lumOff val="25000"/>
+                </a:schemeClr>
+              </a:solidFill>
+            </a:ln>
+          </p:spPr>
+          <p:style>
+            <a:lnRef idx="2">
+              <a:schemeClr val="accent1">
+                <a:shade val="15000"/>
+              </a:schemeClr>
+            </a:lnRef>
+            <a:fillRef idx="1">
+              <a:schemeClr val="accent1"/>
+            </a:fillRef>
+            <a:effectRef idx="0">
+              <a:schemeClr val="accent1"/>
+            </a:effectRef>
+            <a:fontRef idx="minor">
+              <a:schemeClr val="lt1"/>
+            </a:fontRef>
+          </p:style>
+          <p:txBody>
+            <a:bodyPr rtlCol="0" anchor="ctr"/>
+            <a:lstStyle/>
+            <a:p>
+              <a:pPr algn="ctr"/>
+              <a:endParaRPr lang="de-DE"/>
+            </a:p>
+          </p:txBody>
+        </p:sp>
+        <p:sp>
+          <p:nvSpPr>
+            <p:cNvPr id="28" name="Textfeld 27">
+              <a:extLst>
+                <a:ext uri="{FF2B5EF4-FFF2-40B4-BE49-F238E27FC236}">
+                  <a16:creationId xmlns:a16="http://schemas.microsoft.com/office/drawing/2014/main" id="{7201EE90-CEA3-3A25-B815-CBC87BEDB594}"/>
+                </a:ext>
+              </a:extLst>
+            </p:cNvPr>
+            <p:cNvSpPr txBox="1"/>
+            <p:nvPr/>
+          </p:nvSpPr>
+          <p:spPr>
+            <a:xfrm>
+              <a:off x="198602" y="1516532"/>
+              <a:ext cx="1109599" cy="369332"/>
+            </a:xfrm>
+            <a:prstGeom prst="rect">
+              <a:avLst/>
+            </a:prstGeom>
+            <a:noFill/>
+          </p:spPr>
+          <p:txBody>
+            <a:bodyPr wrap="none" rtlCol="0">
+              <a:spAutoFit/>
+            </a:bodyPr>
+            <a:lstStyle/>
+            <a:p>
+              <a:r>
+                <a:rPr lang="de-DE" b="1">
+                  <a:solidFill>
+                    <a:schemeClr val="tx2">
+                      <a:lumMod val="75000"/>
+                      <a:lumOff val="25000"/>
+                    </a:schemeClr>
+                  </a:solidFill>
+                </a:rPr>
+                <a:t>Base-job</a:t>
+              </a:r>
+            </a:p>
+          </p:txBody>
+        </p:sp>
+      </p:grpSp>
+      <p:sp>
+        <p:nvSpPr>
+          <p:cNvPr id="52" name="Textfeld 51">
+            <a:extLst>
+              <a:ext uri="{FF2B5EF4-FFF2-40B4-BE49-F238E27FC236}">
+                <a16:creationId xmlns:a16="http://schemas.microsoft.com/office/drawing/2014/main" id="{AB395DAA-F396-28B1-E9C1-A745386E2EEB}"/>
+              </a:ext>
+            </a:extLst>
+          </p:cNvPr>
+          <p:cNvSpPr txBox="1"/>
+          <p:nvPr/>
+        </p:nvSpPr>
+        <p:spPr>
+          <a:xfrm>
+            <a:off x="5124305" y="2724919"/>
+            <a:ext cx="2472944" cy="1169551"/>
+          </a:xfrm>
+          <a:prstGeom prst="rect">
+            <a:avLst/>
+          </a:prstGeom>
+          <a:solidFill>
+            <a:srgbClr val="FF9999"/>
+          </a:solidFill>
+        </p:spPr>
+        <p:txBody>
+          <a:bodyPr wrap="square">
+            <a:spAutoFit/>
+          </a:bodyPr>
+          <a:lstStyle/>
+          <a:p>
+            <a:r>
+              <a:rPr lang="de-DE" sz="1000" b="1"/>
+              <a:t>HaevgRZ.JobSystem.SessionStore.dll</a:t>
+            </a:r>
+          </a:p>
+          <a:p>
+            <a:r>
+              <a:rPr lang="de-DE" sz="1000" b="1"/>
+              <a:t>HaevgRZ.JobSystem.Core.dll</a:t>
+            </a:r>
+          </a:p>
+          <a:p>
+            <a:r>
+              <a:rPr lang="de-DE" sz="1000" b="1"/>
+              <a:t>HaevgRZ.JobSystem.Contracts.dll</a:t>
+            </a:r>
+          </a:p>
+          <a:p>
+            <a:r>
+              <a:rPr lang="de-DE" sz="1000" b="1"/>
+              <a:t>HaevgRZ.JobSystem.Lib.Core.dll</a:t>
+            </a:r>
+          </a:p>
+          <a:p>
+            <a:r>
+              <a:rPr lang="de-DE" sz="1000" b="1"/>
+              <a:t>HaevgRZ.JobSystem.Lib.Messaging.dll</a:t>
+            </a:r>
+          </a:p>
+          <a:p>
+            <a:r>
+              <a:rPr lang="de-DE" sz="1000" b="1"/>
+              <a:t>„GlobalConfig“</a:t>
+            </a:r>
+          </a:p>
+          <a:p>
+            <a:r>
+              <a:rPr lang="de-DE" sz="1000" b="1"/>
+              <a:t>…</a:t>
+            </a:r>
+          </a:p>
+        </p:txBody>
+      </p:sp>
+      <p:sp>
+        <p:nvSpPr>
+          <p:cNvPr id="55" name="Textfeld 54">
+            <a:extLst>
+              <a:ext uri="{FF2B5EF4-FFF2-40B4-BE49-F238E27FC236}">
+                <a16:creationId xmlns:a16="http://schemas.microsoft.com/office/drawing/2014/main" id="{35A56320-1BAA-14D4-257E-BC2DD55217FB}"/>
+              </a:ext>
+            </a:extLst>
+          </p:cNvPr>
+          <p:cNvSpPr txBox="1"/>
+          <p:nvPr/>
+        </p:nvSpPr>
+        <p:spPr>
+          <a:xfrm>
+            <a:off x="7927182" y="2724919"/>
+            <a:ext cx="1905009" cy="338554"/>
+          </a:xfrm>
+          <a:prstGeom prst="rect">
+            <a:avLst/>
+          </a:prstGeom>
+          <a:noFill/>
+        </p:spPr>
+        <p:txBody>
+          <a:bodyPr wrap="none" rtlCol="0">
+            <a:spAutoFit/>
+          </a:bodyPr>
+          <a:lstStyle/>
+          <a:p>
+            <a:r>
+              <a:rPr lang="de-DE" sz="1600" b="1">
+                <a:solidFill>
+                  <a:srgbClr val="FF0000"/>
+                </a:solidFill>
+              </a:rPr>
+              <a:t>AssemblyResolve:</a:t>
+            </a:r>
+          </a:p>
+        </p:txBody>
+      </p:sp>
+      <p:grpSp>
+        <p:nvGrpSpPr>
+          <p:cNvPr id="56" name="Gruppieren 55">
+            <a:extLst>
+              <a:ext uri="{FF2B5EF4-FFF2-40B4-BE49-F238E27FC236}">
+                <a16:creationId xmlns:a16="http://schemas.microsoft.com/office/drawing/2014/main" id="{840FE24B-8ABF-C58F-FA7B-285D8FF784A4}"/>
+              </a:ext>
+            </a:extLst>
+          </p:cNvPr>
+          <p:cNvGrpSpPr/>
+          <p:nvPr/>
+        </p:nvGrpSpPr>
+        <p:grpSpPr>
+          <a:xfrm>
+            <a:off x="2898340" y="1918813"/>
+            <a:ext cx="1803699" cy="643577"/>
+            <a:chOff x="164209" y="1588453"/>
+            <a:chExt cx="1803699" cy="643577"/>
+          </a:xfrm>
+        </p:grpSpPr>
+        <p:sp>
+          <p:nvSpPr>
+            <p:cNvPr id="57" name="Rechteck 56">
+              <a:extLst>
+                <a:ext uri="{FF2B5EF4-FFF2-40B4-BE49-F238E27FC236}">
+                  <a16:creationId xmlns:a16="http://schemas.microsoft.com/office/drawing/2014/main" id="{5339CB1C-0982-812A-5B00-A1C734F2D7B9}"/>
+                </a:ext>
+              </a:extLst>
+            </p:cNvPr>
+            <p:cNvSpPr/>
+            <p:nvPr/>
+          </p:nvSpPr>
+          <p:spPr>
+            <a:xfrm>
+              <a:off x="164209" y="1588453"/>
+              <a:ext cx="1803699" cy="643577"/>
+            </a:xfrm>
+            <a:prstGeom prst="rect">
+              <a:avLst/>
+            </a:prstGeom>
+            <a:solidFill>
+              <a:schemeClr val="tx2">
+                <a:lumMod val="10000"/>
+                <a:lumOff val="90000"/>
+              </a:schemeClr>
+            </a:solidFill>
+            <a:ln>
+              <a:solidFill>
+                <a:schemeClr val="tx2">
+                  <a:lumMod val="75000"/>
+                  <a:lumOff val="25000"/>
+                </a:schemeClr>
+              </a:solidFill>
+            </a:ln>
+          </p:spPr>
+          <p:style>
+            <a:lnRef idx="2">
+              <a:schemeClr val="accent1">
+                <a:shade val="15000"/>
+              </a:schemeClr>
+            </a:lnRef>
+            <a:fillRef idx="1">
+              <a:schemeClr val="accent1"/>
+            </a:fillRef>
+            <a:effectRef idx="0">
+              <a:schemeClr val="accent1"/>
+            </a:effectRef>
+            <a:fontRef idx="minor">
+              <a:schemeClr val="lt1"/>
+            </a:fontRef>
+          </p:style>
+          <p:txBody>
+            <a:bodyPr rtlCol="0" anchor="ctr"/>
+            <a:lstStyle/>
+            <a:p>
+              <a:pPr algn="ctr"/>
+              <a:endParaRPr lang="de-DE"/>
+            </a:p>
+          </p:txBody>
+        </p:sp>
+        <p:sp>
+          <p:nvSpPr>
+            <p:cNvPr id="58" name="Textfeld 57">
+              <a:extLst>
+                <a:ext uri="{FF2B5EF4-FFF2-40B4-BE49-F238E27FC236}">
+                  <a16:creationId xmlns:a16="http://schemas.microsoft.com/office/drawing/2014/main" id="{FDA82363-6616-3120-15F7-E15ADFD3A277}"/>
+                </a:ext>
+              </a:extLst>
+            </p:cNvPr>
+            <p:cNvSpPr txBox="1"/>
+            <p:nvPr/>
+          </p:nvSpPr>
+          <p:spPr>
+            <a:xfrm>
+              <a:off x="216082" y="1606413"/>
+              <a:ext cx="1741311" cy="369332"/>
+            </a:xfrm>
+            <a:prstGeom prst="rect">
+              <a:avLst/>
+            </a:prstGeom>
+            <a:noFill/>
+          </p:spPr>
+          <p:txBody>
+            <a:bodyPr wrap="none" rtlCol="0">
+              <a:spAutoFit/>
+            </a:bodyPr>
+            <a:lstStyle/>
+            <a:p>
+              <a:r>
+                <a:rPr lang="de-DE" b="1">
+                  <a:solidFill>
+                    <a:schemeClr val="tx2">
+                      <a:lumMod val="75000"/>
+                      <a:lumOff val="25000"/>
+                    </a:schemeClr>
+                  </a:solidFill>
+                </a:rPr>
+                <a:t>SessionStarter</a:t>
+              </a:r>
+            </a:p>
+          </p:txBody>
+        </p:sp>
+      </p:grpSp>
+      <p:sp>
+        <p:nvSpPr>
+          <p:cNvPr id="60" name="Pfeil: nach rechts 59">
+            <a:extLst>
+              <a:ext uri="{FF2B5EF4-FFF2-40B4-BE49-F238E27FC236}">
+                <a16:creationId xmlns:a16="http://schemas.microsoft.com/office/drawing/2014/main" id="{3E79FB88-779C-13F8-B2BF-A117237A18A3}"/>
+              </a:ext>
+            </a:extLst>
+          </p:cNvPr>
+          <p:cNvSpPr/>
+          <p:nvPr/>
+        </p:nvSpPr>
+        <p:spPr>
+          <a:xfrm>
+            <a:off x="4723504" y="2146442"/>
+            <a:ext cx="841320" cy="234258"/>
+          </a:xfrm>
+          <a:prstGeom prst="rightArrow">
+            <a:avLst/>
+          </a:prstGeom>
+          <a:solidFill>
+            <a:schemeClr val="accent6"/>
+          </a:solidFill>
+          <a:ln>
+            <a:solidFill>
+              <a:srgbClr val="0070C0"/>
+            </a:solidFill>
+          </a:ln>
+        </p:spPr>
+        <p:style>
+          <a:lnRef idx="2">
+            <a:schemeClr val="accent1">
+              <a:shade val="15000"/>
+            </a:schemeClr>
+          </a:lnRef>
+          <a:fillRef idx="1">
+            <a:schemeClr val="accent1"/>
+          </a:fillRef>
+          <a:effectRef idx="0">
+            <a:schemeClr val="accent1"/>
+          </a:effectRef>
+          <a:fontRef idx="minor">
+            <a:schemeClr val="lt1"/>
+          </a:fontRef>
+        </p:style>
+        <p:txBody>
+          <a:bodyPr rtlCol="0" anchor="ctr"/>
+          <a:lstStyle/>
+          <a:p>
+            <a:pPr algn="ctr"/>
+            <a:endParaRPr lang="de-DE"/>
+          </a:p>
+        </p:txBody>
+      </p:sp>
+      <p:sp>
+        <p:nvSpPr>
+          <p:cNvPr id="61" name="Textfeld 60">
+            <a:extLst>
+              <a:ext uri="{FF2B5EF4-FFF2-40B4-BE49-F238E27FC236}">
+                <a16:creationId xmlns:a16="http://schemas.microsoft.com/office/drawing/2014/main" id="{62C7E6E6-A5E4-68DB-279A-D74781522F4F}"/>
+              </a:ext>
+            </a:extLst>
+          </p:cNvPr>
+          <p:cNvSpPr txBox="1"/>
+          <p:nvPr/>
+        </p:nvSpPr>
+        <p:spPr>
+          <a:xfrm>
+            <a:off x="4666437" y="1778023"/>
+            <a:ext cx="955454" cy="369332"/>
+          </a:xfrm>
+          <a:prstGeom prst="rect">
+            <a:avLst/>
+          </a:prstGeom>
+          <a:noFill/>
+        </p:spPr>
+        <p:txBody>
+          <a:bodyPr wrap="none" rtlCol="0">
+            <a:spAutoFit/>
+          </a:bodyPr>
+          <a:lstStyle/>
+          <a:p>
+            <a:r>
+              <a:rPr lang="de-DE"/>
+              <a:t>spawns</a:t>
+            </a:r>
+          </a:p>
+        </p:txBody>
+      </p:sp>
+      <p:sp>
+        <p:nvSpPr>
+          <p:cNvPr id="62" name="Textfeld 61">
+            <a:extLst>
+              <a:ext uri="{FF2B5EF4-FFF2-40B4-BE49-F238E27FC236}">
+                <a16:creationId xmlns:a16="http://schemas.microsoft.com/office/drawing/2014/main" id="{B35DD60B-AF1C-018B-BD90-0C00BBA989B8}"/>
+              </a:ext>
+            </a:extLst>
+          </p:cNvPr>
+          <p:cNvSpPr txBox="1"/>
+          <p:nvPr/>
+        </p:nvSpPr>
+        <p:spPr>
+          <a:xfrm>
+            <a:off x="1952035" y="287310"/>
+            <a:ext cx="7674922" cy="800219"/>
+          </a:xfrm>
+          <a:prstGeom prst="rect">
+            <a:avLst/>
+          </a:prstGeom>
+          <a:noFill/>
+        </p:spPr>
+        <p:txBody>
+          <a:bodyPr wrap="none" rtlCol="0">
+            <a:spAutoFit/>
+          </a:bodyPr>
+          <a:lstStyle/>
+          <a:p>
+            <a:pPr algn="ctr"/>
+            <a:r>
+              <a:rPr lang="de-DE" sz="2800" b="1"/>
+              <a:t>Das Kernproblem des alten JobSystems.</a:t>
+            </a:r>
+            <a:endParaRPr lang="de-DE" b="1"/>
+          </a:p>
+          <a:p>
+            <a:pPr algn="ctr"/>
+            <a:r>
+              <a:rPr lang="de-DE" b="1"/>
+              <a:t>Der gemeinsame </a:t>
+            </a:r>
+            <a:r>
+              <a:rPr lang="de-DE" b="1" i="1"/>
+              <a:t>Prozessraum</a:t>
+            </a:r>
+            <a:r>
+              <a:rPr lang="de-DE" b="1"/>
+              <a:t> von System und Job in der </a:t>
+            </a:r>
+            <a:r>
+              <a:rPr lang="de-DE" b="1" i="1"/>
+              <a:t>JobHost.exe</a:t>
+            </a:r>
+          </a:p>
+        </p:txBody>
+      </p:sp>
+      <p:sp>
+        <p:nvSpPr>
+          <p:cNvPr id="65" name="Textfeld 64">
+            <a:extLst>
+              <a:ext uri="{FF2B5EF4-FFF2-40B4-BE49-F238E27FC236}">
+                <a16:creationId xmlns:a16="http://schemas.microsoft.com/office/drawing/2014/main" id="{976FAEE1-0BC5-44A3-25D9-3FA8E1410855}"/>
+              </a:ext>
+            </a:extLst>
+          </p:cNvPr>
+          <p:cNvSpPr txBox="1"/>
+          <p:nvPr/>
+        </p:nvSpPr>
+        <p:spPr>
+          <a:xfrm>
+            <a:off x="1561522" y="4443472"/>
+            <a:ext cx="9553817" cy="1477328"/>
+          </a:xfrm>
+          <a:prstGeom prst="rect">
+            <a:avLst/>
+          </a:prstGeom>
+          <a:noFill/>
+        </p:spPr>
+        <p:txBody>
+          <a:bodyPr wrap="square">
+            <a:spAutoFit/>
+          </a:bodyPr>
+          <a:lstStyle/>
+          <a:p>
+            <a:r>
+              <a:rPr lang="de-DE"/>
+              <a:t>Fast alle Limitierungen und Hacks basieren direkt oder indirekt auf diesem „Ur-Fehler“</a:t>
+            </a:r>
+          </a:p>
+          <a:p>
+            <a:pPr marL="171450" indent="-171450">
+              <a:buFont typeface="Arial" panose="020B0604020202020204" pitchFamily="34" charset="0"/>
+              <a:buChar char="•"/>
+            </a:pPr>
+            <a:r>
+              <a:rPr lang="de-DE" sz="1200"/>
+              <a:t>Explizite Workflow-Adapter.exe die mit dem JobHost per CLI-Calls kommuniziert.</a:t>
+            </a:r>
+          </a:p>
+          <a:p>
+            <a:pPr marL="171450" indent="-171450">
+              <a:buFont typeface="Arial" panose="020B0604020202020204" pitchFamily="34" charset="0"/>
+              <a:buChar char="•"/>
+            </a:pPr>
+            <a:r>
+              <a:rPr lang="de-DE" sz="1200"/>
+              <a:t>Der ewige AssemblyResolver-pain-in-the-ass…</a:t>
+            </a:r>
+          </a:p>
+          <a:p>
+            <a:pPr marL="171450" indent="-171450">
+              <a:buFont typeface="Arial" panose="020B0604020202020204" pitchFamily="34" charset="0"/>
+              <a:buChar char="•"/>
+            </a:pPr>
+            <a:r>
+              <a:rPr lang="de-DE" sz="1200"/>
+              <a:t>ConfigReader-Kopie des HÄVG-Configmangers im JobSystem.</a:t>
+            </a:r>
+          </a:p>
+          <a:p>
+            <a:pPr marL="171450" indent="-171450">
+              <a:buFont typeface="Arial" panose="020B0604020202020204" pitchFamily="34" charset="0"/>
+              <a:buChar char="•"/>
+            </a:pPr>
+            <a:r>
+              <a:rPr lang="de-DE" sz="1200"/>
+              <a:t>Proprietäre ADO-Komponente; EF-Core nicht möglich.</a:t>
+            </a:r>
+          </a:p>
+          <a:p>
+            <a:pPr marL="171450" indent="-171450">
+              <a:buFont typeface="Arial" panose="020B0604020202020204" pitchFamily="34" charset="0"/>
+              <a:buChar char="•"/>
+            </a:pPr>
+            <a:r>
+              <a:rPr lang="de-DE" sz="1200"/>
+              <a:t>Eine weiter technologische Evolution und wird de facto verhindert. Nur noch interne Features oder Erweiterung durch Hacks.</a:t>
+            </a:r>
+          </a:p>
+          <a:p>
+            <a:pPr marL="171450" indent="-171450">
+              <a:buFont typeface="Arial" panose="020B0604020202020204" pitchFamily="34" charset="0"/>
+              <a:buChar char="•"/>
+            </a:pPr>
+            <a:r>
+              <a:rPr lang="de-DE" sz="1200"/>
+              <a:t>…</a:t>
+            </a:r>
+            <a:endParaRPr lang="de-DE"/>
+          </a:p>
+        </p:txBody>
+      </p:sp>
+      <p:sp>
+        <p:nvSpPr>
+          <p:cNvPr id="70" name="Pfeil: nach links 69">
+            <a:extLst>
+              <a:ext uri="{FF2B5EF4-FFF2-40B4-BE49-F238E27FC236}">
+                <a16:creationId xmlns:a16="http://schemas.microsoft.com/office/drawing/2014/main" id="{1536D43B-1E69-F7B8-4F87-A0FD5F362E85}"/>
+              </a:ext>
+            </a:extLst>
+          </p:cNvPr>
+          <p:cNvSpPr/>
+          <p:nvPr/>
+        </p:nvSpPr>
+        <p:spPr>
+          <a:xfrm>
+            <a:off x="3799699" y="2969365"/>
+            <a:ext cx="1311905" cy="707281"/>
+          </a:xfrm>
+          <a:prstGeom prst="leftArrow">
+            <a:avLst/>
+          </a:prstGeom>
+          <a:solidFill>
+            <a:srgbClr val="C00000"/>
+          </a:solidFill>
+          <a:ln>
+            <a:solidFill>
+              <a:srgbClr val="7030A0"/>
+            </a:solidFill>
+          </a:ln>
+        </p:spPr>
+        <p:style>
+          <a:lnRef idx="2">
+            <a:schemeClr val="accent1">
+              <a:shade val="15000"/>
+            </a:schemeClr>
+          </a:lnRef>
+          <a:fillRef idx="1">
+            <a:schemeClr val="accent1"/>
+          </a:fillRef>
+          <a:effectRef idx="0">
+            <a:schemeClr val="accent1"/>
+          </a:effectRef>
+          <a:fontRef idx="minor">
+            <a:schemeClr val="lt1"/>
+          </a:fontRef>
+        </p:style>
+        <p:txBody>
+          <a:bodyPr rtlCol="0" anchor="ctr"/>
+          <a:lstStyle/>
+          <a:p>
+            <a:pPr algn="ctr"/>
+            <a:endParaRPr lang="de-DE"/>
+          </a:p>
+        </p:txBody>
+      </p:sp>
+      <p:pic>
+        <p:nvPicPr>
+          <p:cNvPr id="73" name="Grafik 72">
+            <a:extLst>
+              <a:ext uri="{FF2B5EF4-FFF2-40B4-BE49-F238E27FC236}">
+                <a16:creationId xmlns:a16="http://schemas.microsoft.com/office/drawing/2014/main" id="{16156912-CE86-DB36-D615-C741938FB6F0}"/>
+              </a:ext>
+            </a:extLst>
+          </p:cNvPr>
+          <p:cNvPicPr>
+            <a:picLocks noChangeAspect="1"/>
+          </p:cNvPicPr>
+          <p:nvPr/>
+        </p:nvPicPr>
+        <p:blipFill>
+          <a:blip r:embed="rId2">
+            <a:extLst>
+              <a:ext uri="{28A0092B-C50C-407E-A947-70E740481C1C}">
+                <a14:useLocalDpi xmlns:a14="http://schemas.microsoft.com/office/drawing/2010/main" val="0"/>
+              </a:ext>
+            </a:extLst>
+          </a:blip>
+          <a:stretch>
+            <a:fillRect/>
+          </a:stretch>
+        </p:blipFill>
+        <p:spPr>
+          <a:xfrm>
+            <a:off x="1866421" y="2428990"/>
+            <a:ext cx="827913" cy="827913"/>
+          </a:xfrm>
+          <a:prstGeom prst="rect">
+            <a:avLst/>
+          </a:prstGeom>
+        </p:spPr>
+      </p:pic>
+      <p:pic>
+        <p:nvPicPr>
+          <p:cNvPr id="77" name="Grafik 76">
+            <a:extLst>
+              <a:ext uri="{FF2B5EF4-FFF2-40B4-BE49-F238E27FC236}">
+                <a16:creationId xmlns:a16="http://schemas.microsoft.com/office/drawing/2014/main" id="{FFFB93B2-C53C-4261-7D4C-71DCE8750523}"/>
+              </a:ext>
+            </a:extLst>
+          </p:cNvPr>
+          <p:cNvPicPr>
+            <a:picLocks noChangeAspect="1"/>
+          </p:cNvPicPr>
+          <p:nvPr/>
+        </p:nvPicPr>
+        <p:blipFill>
+          <a:blip r:embed="rId3">
+            <a:extLst>
+              <a:ext uri="{28A0092B-C50C-407E-A947-70E740481C1C}">
+                <a14:useLocalDpi xmlns:a14="http://schemas.microsoft.com/office/drawing/2010/main" val="0"/>
+              </a:ext>
+            </a:extLst>
+          </a:blip>
+          <a:stretch>
+            <a:fillRect/>
+          </a:stretch>
+        </p:blipFill>
+        <p:spPr>
+          <a:xfrm>
+            <a:off x="1792126" y="3208513"/>
+            <a:ext cx="882650" cy="882650"/>
+          </a:xfrm>
+          <a:prstGeom prst="rect">
+            <a:avLst/>
+          </a:prstGeom>
+        </p:spPr>
+      </p:pic>
+      <p:pic>
+        <p:nvPicPr>
+          <p:cNvPr id="75" name="Grafik 74">
+            <a:extLst>
+              <a:ext uri="{FF2B5EF4-FFF2-40B4-BE49-F238E27FC236}">
+                <a16:creationId xmlns:a16="http://schemas.microsoft.com/office/drawing/2014/main" id="{C9A9F567-C88B-8C1F-9B5C-9AF7AF1B814F}"/>
+              </a:ext>
+            </a:extLst>
+          </p:cNvPr>
+          <p:cNvPicPr>
+            <a:picLocks noChangeAspect="1"/>
+          </p:cNvPicPr>
+          <p:nvPr/>
+        </p:nvPicPr>
+        <p:blipFill>
+          <a:blip r:embed="rId4">
+            <a:extLst>
+              <a:ext uri="{28A0092B-C50C-407E-A947-70E740481C1C}">
+                <a14:useLocalDpi xmlns:a14="http://schemas.microsoft.com/office/drawing/2010/main" val="0"/>
+              </a:ext>
+            </a:extLst>
+          </a:blip>
+          <a:stretch>
+            <a:fillRect/>
+          </a:stretch>
+        </p:blipFill>
+        <p:spPr>
+          <a:xfrm>
+            <a:off x="2720198" y="2658108"/>
+            <a:ext cx="1066800" cy="1066800"/>
+          </a:xfrm>
+          <a:prstGeom prst="rect">
+            <a:avLst/>
+          </a:prstGeom>
+        </p:spPr>
+      </p:pic>
+    </p:spTree>
+    <p:extLst>
+      <p:ext uri="{BB962C8B-B14F-4D97-AF65-F5344CB8AC3E}">
+        <p14:creationId xmlns:p14="http://schemas.microsoft.com/office/powerpoint/2010/main" val="3771264090"/>
+      </p:ext>
+    </p:extLst>
+  </p:cSld>
+  <p:clrMapOvr>
+    <a:masterClrMapping/>
+  </p:clrMapOvr>
+</p:sld>
+</file>
+
+<file path=ppt/slides/slide10.xml><?xml version="1.0" encoding="utf-8"?>
+<p:sld xmlns:a="http://schemas.openxmlformats.org/drawingml/2006/main" xmlns:r="http://schemas.openxmlformats.org/officeDocument/2006/relationships" xmlns:p="http://schemas.openxmlformats.org/presentationml/2006/main">
+  <p:cSld>
+    <p:spTree>
+      <p:nvGrpSpPr>
+        <p:cNvPr id="1" name="">
+          <a:extLst>
+            <a:ext uri="{FF2B5EF4-FFF2-40B4-BE49-F238E27FC236}">
+              <a16:creationId xmlns:a16="http://schemas.microsoft.com/office/drawing/2014/main" id="{D0473CBD-2654-7327-F74E-4D7EE4DD1A0B}"/>
+            </a:ext>
+          </a:extLst>
+        </p:cNvPr>
+        <p:cNvGrpSpPr/>
+        <p:nvPr/>
+      </p:nvGrpSpPr>
+      <p:grpSpPr>
+        <a:xfrm>
+          <a:off x="0" y="0"/>
+          <a:ext cx="0" cy="0"/>
+          <a:chOff x="0" y="0"/>
+          <a:chExt cx="0" cy="0"/>
+        </a:xfrm>
+      </p:grpSpPr>
+      <p:sp>
+        <p:nvSpPr>
+          <p:cNvPr id="4" name="Textfeld 3">
+            <a:extLst>
+              <a:ext uri="{FF2B5EF4-FFF2-40B4-BE49-F238E27FC236}">
+                <a16:creationId xmlns:a16="http://schemas.microsoft.com/office/drawing/2014/main" id="{EEB7E298-9FAF-2DCD-50B2-2255FE09FCAF}"/>
+              </a:ext>
+            </a:extLst>
+          </p:cNvPr>
+          <p:cNvSpPr txBox="1"/>
+          <p:nvPr/>
+        </p:nvSpPr>
+        <p:spPr>
+          <a:xfrm>
+            <a:off x="2078535" y="491609"/>
+            <a:ext cx="4804585" cy="3416320"/>
+          </a:xfrm>
+          <a:prstGeom prst="rect">
+            <a:avLst/>
+          </a:prstGeom>
+          <a:noFill/>
+        </p:spPr>
+        <p:txBody>
+          <a:bodyPr wrap="none" rtlCol="0">
+            <a:spAutoFit/>
+          </a:bodyPr>
+          <a:lstStyle/>
+          <a:p>
+            <a:r>
+              <a:rPr lang="de-DE"/>
+              <a:t>TODO</a:t>
+            </a:r>
+          </a:p>
+          <a:p>
+            <a:endParaRPr lang="de-DE"/>
+          </a:p>
+          <a:p>
+            <a:pPr marL="285750" indent="-285750">
+              <a:buFont typeface="Arial" panose="020B0604020202020204" pitchFamily="34" charset="0"/>
+              <a:buChar char="•"/>
+            </a:pPr>
+            <a:r>
+              <a:rPr lang="de-DE"/>
+              <a:t>Backend</a:t>
+            </a:r>
+          </a:p>
+          <a:p>
+            <a:pPr marL="285750" indent="-285750">
+              <a:buFont typeface="Arial" panose="020B0604020202020204" pitchFamily="34" charset="0"/>
+              <a:buChar char="•"/>
+            </a:pPr>
+            <a:r>
+              <a:rPr lang="de-DE"/>
+              <a:t>Company-Fit</a:t>
+            </a:r>
+          </a:p>
+          <a:p>
+            <a:pPr marL="285750" indent="-285750">
+              <a:buFont typeface="Arial" panose="020B0604020202020204" pitchFamily="34" charset="0"/>
+              <a:buChar char="•"/>
+            </a:pPr>
+            <a:r>
+              <a:rPr lang="de-DE"/>
+              <a:t>Offene Fragen</a:t>
+            </a:r>
+          </a:p>
+          <a:p>
+            <a:pPr marL="285750" indent="-285750">
+              <a:buFont typeface="Arial" panose="020B0604020202020204" pitchFamily="34" charset="0"/>
+              <a:buChar char="•"/>
+            </a:pPr>
+            <a:endParaRPr lang="de-DE"/>
+          </a:p>
+          <a:p>
+            <a:pPr marL="285750" indent="-285750">
+              <a:buFont typeface="Arial" panose="020B0604020202020204" pitchFamily="34" charset="0"/>
+              <a:buChar char="•"/>
+            </a:pPr>
+            <a:r>
+              <a:rPr lang="de-DE"/>
+              <a:t>Josyn-guide zurückbauen</a:t>
+            </a:r>
+          </a:p>
+          <a:p>
+            <a:pPr marL="285750" indent="-285750">
+              <a:buFont typeface="Arial" panose="020B0604020202020204" pitchFamily="34" charset="0"/>
+              <a:buChar char="•"/>
+            </a:pPr>
+            <a:r>
+              <a:rPr lang="de-DE"/>
+              <a:t>Gute „AI-Zitate“ einbauen</a:t>
+            </a:r>
+          </a:p>
+          <a:p>
+            <a:pPr marL="285750" indent="-285750">
+              <a:buFont typeface="Arial" panose="020B0604020202020204" pitchFamily="34" charset="0"/>
+              <a:buChar char="•"/>
+            </a:pPr>
+            <a:endParaRPr lang="de-DE"/>
+          </a:p>
+          <a:p>
+            <a:r>
+              <a:rPr lang="de-DE"/>
+              <a:t>Vorher von gitgub-ckluth =&gt; github-hävg!!!!!!!!!!</a:t>
+            </a:r>
+          </a:p>
+          <a:p>
+            <a:pPr marL="285750" indent="-285750">
+              <a:buFont typeface="Arial" panose="020B0604020202020204" pitchFamily="34" charset="0"/>
+              <a:buChar char="•"/>
+            </a:pPr>
+            <a:endParaRPr lang="de-DE"/>
+          </a:p>
+          <a:p>
+            <a:pPr marL="285750" indent="-285750">
+              <a:buFont typeface="Arial" panose="020B0604020202020204" pitchFamily="34" charset="0"/>
+              <a:buChar char="•"/>
+            </a:pPr>
+            <a:endParaRPr lang="de-DE"/>
+          </a:p>
+        </p:txBody>
+      </p:sp>
+    </p:spTree>
+    <p:extLst>
+      <p:ext uri="{BB962C8B-B14F-4D97-AF65-F5344CB8AC3E}">
+        <p14:creationId xmlns:p14="http://schemas.microsoft.com/office/powerpoint/2010/main" val="2811839202"/>
+      </p:ext>
+    </p:extLst>
+  </p:cSld>
+  <p:clrMapOvr>
+    <a:masterClrMapping/>
+  </p:clrMapOvr>
+</p:sld>
+</file>
+
+<file path=ppt/slides/slide11.xml><?xml version="1.0" encoding="utf-8"?>
+<p:sld xmlns:a="http://schemas.openxmlformats.org/drawingml/2006/main" xmlns:r="http://schemas.openxmlformats.org/officeDocument/2006/relationships" xmlns:p="http://schemas.openxmlformats.org/presentationml/2006/main">
+  <p:cSld>
+    <p:spTree>
+      <p:nvGrpSpPr>
+        <p:cNvPr id="1" name="">
+          <a:extLst>
+            <a:ext uri="{FF2B5EF4-FFF2-40B4-BE49-F238E27FC236}">
+              <a16:creationId xmlns:a16="http://schemas.microsoft.com/office/drawing/2014/main" id="{A9DD6CB7-EB88-909D-C082-49E7E1D49225}"/>
+            </a:ext>
+          </a:extLst>
+        </p:cNvPr>
+        <p:cNvGrpSpPr/>
+        <p:nvPr/>
+      </p:nvGrpSpPr>
+      <p:grpSpPr>
+        <a:xfrm>
+          <a:off x="0" y="0"/>
+          <a:ext cx="0" cy="0"/>
+          <a:chOff x="0" y="0"/>
+          <a:chExt cx="0" cy="0"/>
+        </a:xfrm>
+      </p:grpSpPr>
+      <p:pic>
+        <p:nvPicPr>
+          <p:cNvPr id="4" name="Grafik 3">
+            <a:extLst>
+              <a:ext uri="{FF2B5EF4-FFF2-40B4-BE49-F238E27FC236}">
+                <a16:creationId xmlns:a16="http://schemas.microsoft.com/office/drawing/2014/main" id="{BA2A3B80-F6E1-8BA5-5B3F-A9D11EA225D9}"/>
+              </a:ext>
+            </a:extLst>
+          </p:cNvPr>
+          <p:cNvPicPr>
+            <a:picLocks noChangeAspect="1"/>
+          </p:cNvPicPr>
+          <p:nvPr/>
+        </p:nvPicPr>
+        <p:blipFill>
+          <a:blip r:embed="rId2"/>
+          <a:stretch>
+            <a:fillRect/>
+          </a:stretch>
+        </p:blipFill>
+        <p:spPr>
+          <a:xfrm>
+            <a:off x="2371205" y="1576129"/>
+            <a:ext cx="7449590" cy="3705742"/>
+          </a:xfrm>
+          <a:prstGeom prst="rect">
+            <a:avLst/>
+          </a:prstGeom>
+        </p:spPr>
+      </p:pic>
+    </p:spTree>
+    <p:extLst>
+      <p:ext uri="{BB962C8B-B14F-4D97-AF65-F5344CB8AC3E}">
+        <p14:creationId xmlns:p14="http://schemas.microsoft.com/office/powerpoint/2010/main" val="661868491"/>
+      </p:ext>
+    </p:extLst>
+  </p:cSld>
+  <p:clrMapOvr>
+    <a:masterClrMapping/>
+  </p:clrMapOvr>
+</p:sld>
+</file>
+
+<file path=ppt/slides/slide12.xml><?xml version="1.0" encoding="utf-8"?>
+<p:sld xmlns:a="http://schemas.openxmlformats.org/drawingml/2006/main" xmlns:r="http://schemas.openxmlformats.org/officeDocument/2006/relationships" xmlns:p="http://schemas.openxmlformats.org/presentationml/2006/main">
+  <p:cSld>
+    <p:spTree>
+      <p:nvGrpSpPr>
+        <p:cNvPr id="1" name="">
+          <a:extLst>
+            <a:ext uri="{FF2B5EF4-FFF2-40B4-BE49-F238E27FC236}">
+              <a16:creationId xmlns:a16="http://schemas.microsoft.com/office/drawing/2014/main" id="{EF4BCD0E-B049-B53B-B888-3DAE81785FF1}"/>
+            </a:ext>
+          </a:extLst>
+        </p:cNvPr>
+        <p:cNvGrpSpPr/>
+        <p:nvPr/>
+      </p:nvGrpSpPr>
+      <p:grpSpPr>
+        <a:xfrm>
+          <a:off x="0" y="0"/>
+          <a:ext cx="0" cy="0"/>
+          <a:chOff x="0" y="0"/>
+          <a:chExt cx="0" cy="0"/>
+        </a:xfrm>
+      </p:grpSpPr>
+      <p:grpSp>
+        <p:nvGrpSpPr>
           <p:cNvPr id="7" name="Gruppieren 6">
             <a:extLst>
               <a:ext uri="{FF2B5EF4-FFF2-40B4-BE49-F238E27FC236}">
-                <a16:creationId xmlns:a16="http://schemas.microsoft.com/office/drawing/2014/main" id="{52B1D0F5-4542-30A7-BDEF-A12AF10F9A85}"/>
+                <a16:creationId xmlns:a16="http://schemas.microsoft.com/office/drawing/2014/main" id="{1BAF3D59-551E-F0E5-9357-DDE2BAC9643E}"/>
               </a:ext>
             </a:extLst>
           </p:cNvPr>
@@ -3862,7 +5191,7 @@
             <p:cNvPr id="4" name="Rechteck 3">
               <a:extLst>
                 <a:ext uri="{FF2B5EF4-FFF2-40B4-BE49-F238E27FC236}">
-                  <a16:creationId xmlns:a16="http://schemas.microsoft.com/office/drawing/2014/main" id="{B211FAF5-BEB3-B716-4B06-4809EA3EE81D}"/>
+                  <a16:creationId xmlns:a16="http://schemas.microsoft.com/office/drawing/2014/main" id="{F399BA7C-486C-B484-16AD-094D33F59A68}"/>
                 </a:ext>
               </a:extLst>
             </p:cNvPr>
@@ -3919,7 +5248,7 @@
             <p:cNvPr id="6" name="Textfeld 5">
               <a:extLst>
                 <a:ext uri="{FF2B5EF4-FFF2-40B4-BE49-F238E27FC236}">
-                  <a16:creationId xmlns:a16="http://schemas.microsoft.com/office/drawing/2014/main" id="{2312F5F8-3043-A1F9-9484-9A73BF2B3C8B}"/>
+                  <a16:creationId xmlns:a16="http://schemas.microsoft.com/office/drawing/2014/main" id="{A37E0375-1869-E126-06F4-9223184DC40B}"/>
                 </a:ext>
               </a:extLst>
             </p:cNvPr>
@@ -3959,7 +5288,7 @@
           <p:cNvPr id="20" name="Gruppieren 19">
             <a:extLst>
               <a:ext uri="{FF2B5EF4-FFF2-40B4-BE49-F238E27FC236}">
-                <a16:creationId xmlns:a16="http://schemas.microsoft.com/office/drawing/2014/main" id="{F1EF0E68-5866-422B-0FD5-AC50BE220958}"/>
+                <a16:creationId xmlns:a16="http://schemas.microsoft.com/office/drawing/2014/main" id="{D33C9ED9-7646-38FA-583B-F8CF70453BAE}"/>
               </a:ext>
             </a:extLst>
           </p:cNvPr>
@@ -3984,7 +5313,7 @@
             <p:cNvPr id="12" name="Rechteck 11">
               <a:extLst>
                 <a:ext uri="{FF2B5EF4-FFF2-40B4-BE49-F238E27FC236}">
-                  <a16:creationId xmlns:a16="http://schemas.microsoft.com/office/drawing/2014/main" id="{8FD02BC8-269D-F720-EB7C-F7363D94B145}"/>
+                  <a16:creationId xmlns:a16="http://schemas.microsoft.com/office/drawing/2014/main" id="{31767582-C3AF-B85E-5F6D-D243A3F3A08B}"/>
                 </a:ext>
               </a:extLst>
             </p:cNvPr>
@@ -4039,7 +5368,7 @@
             <p:cNvPr id="13" name="Textfeld 12">
               <a:extLst>
                 <a:ext uri="{FF2B5EF4-FFF2-40B4-BE49-F238E27FC236}">
-                  <a16:creationId xmlns:a16="http://schemas.microsoft.com/office/drawing/2014/main" id="{46A087BE-6D83-5445-37A2-4A6F8F7313F0}"/>
+                  <a16:creationId xmlns:a16="http://schemas.microsoft.com/office/drawing/2014/main" id="{6B1C0CC8-D053-11F6-CC3E-ABF928FC1E6F}"/>
                 </a:ext>
               </a:extLst>
             </p:cNvPr>
@@ -4082,7 +5411,7 @@
           <p:cNvPr id="40" name="Gruppieren 39">
             <a:extLst>
               <a:ext uri="{FF2B5EF4-FFF2-40B4-BE49-F238E27FC236}">
-                <a16:creationId xmlns:a16="http://schemas.microsoft.com/office/drawing/2014/main" id="{C7E5871F-B7F7-9CA5-B950-E97965A52ABF}"/>
+                <a16:creationId xmlns:a16="http://schemas.microsoft.com/office/drawing/2014/main" id="{95D86320-5473-84AD-7FCE-622515606E5F}"/>
               </a:ext>
             </a:extLst>
           </p:cNvPr>
@@ -4102,7 +5431,7 @@
             <p:cNvPr id="25" name="Gruppieren 24">
               <a:extLst>
                 <a:ext uri="{FF2B5EF4-FFF2-40B4-BE49-F238E27FC236}">
-                  <a16:creationId xmlns:a16="http://schemas.microsoft.com/office/drawing/2014/main" id="{32C728BB-803C-7519-DA69-86B061BB7637}"/>
+                  <a16:creationId xmlns:a16="http://schemas.microsoft.com/office/drawing/2014/main" id="{B4331FC3-0CC5-61EB-39B4-6DCBB5747A20}"/>
                 </a:ext>
               </a:extLst>
             </p:cNvPr>
@@ -4122,7 +5451,7 @@
               <p:cNvPr id="22" name="Pfeil: nach links und rechts 21">
                 <a:extLst>
                   <a:ext uri="{FF2B5EF4-FFF2-40B4-BE49-F238E27FC236}">
-                    <a16:creationId xmlns:a16="http://schemas.microsoft.com/office/drawing/2014/main" id="{CDBCBB62-75E7-F0A7-1D4D-908B651F58DF}"/>
+                    <a16:creationId xmlns:a16="http://schemas.microsoft.com/office/drawing/2014/main" id="{73ABA095-B8C8-4312-EDBB-FE5B036E2326}"/>
                   </a:ext>
                 </a:extLst>
               </p:cNvPr>
@@ -4177,7 +5506,7 @@
               <p:cNvPr id="24" name="Textfeld 23">
                 <a:extLst>
                   <a:ext uri="{FF2B5EF4-FFF2-40B4-BE49-F238E27FC236}">
-                    <a16:creationId xmlns:a16="http://schemas.microsoft.com/office/drawing/2014/main" id="{BFBDC28A-FE8F-FB7E-BBF9-7DC6A7F43387}"/>
+                    <a16:creationId xmlns:a16="http://schemas.microsoft.com/office/drawing/2014/main" id="{8C523DA3-34E9-9038-B9C9-59B80A26A3EF}"/>
                   </a:ext>
                 </a:extLst>
               </p:cNvPr>
@@ -4221,7 +5550,7 @@
             <p:cNvPr id="39" name="Gruppieren 38">
               <a:extLst>
                 <a:ext uri="{FF2B5EF4-FFF2-40B4-BE49-F238E27FC236}">
-                  <a16:creationId xmlns:a16="http://schemas.microsoft.com/office/drawing/2014/main" id="{5C295ABA-726E-BEB9-93B2-A964EC2FB25B}"/>
+                  <a16:creationId xmlns:a16="http://schemas.microsoft.com/office/drawing/2014/main" id="{624D37AD-83CB-57BD-1A5A-14ABA35EA4F5}"/>
                 </a:ext>
               </a:extLst>
             </p:cNvPr>
@@ -4241,7 +5570,7 @@
               <p:cNvPr id="33" name="Rechteck 32">
                 <a:extLst>
                   <a:ext uri="{FF2B5EF4-FFF2-40B4-BE49-F238E27FC236}">
-                    <a16:creationId xmlns:a16="http://schemas.microsoft.com/office/drawing/2014/main" id="{83C9C3DD-E000-BB6B-66F0-25359ED0A276}"/>
+                    <a16:creationId xmlns:a16="http://schemas.microsoft.com/office/drawing/2014/main" id="{5FBD6A96-CE08-26EB-35A9-F23C6D874D2A}"/>
                   </a:ext>
                 </a:extLst>
               </p:cNvPr>
@@ -4293,7 +5622,7 @@
               <p:cNvPr id="36" name="Rechteck 35">
                 <a:extLst>
                   <a:ext uri="{FF2B5EF4-FFF2-40B4-BE49-F238E27FC236}">
-                    <a16:creationId xmlns:a16="http://schemas.microsoft.com/office/drawing/2014/main" id="{B027EAE7-778E-F0D1-CE6D-E1B5921BE5F2}"/>
+                    <a16:creationId xmlns:a16="http://schemas.microsoft.com/office/drawing/2014/main" id="{76DEB7D6-CDA6-A1D6-B8D6-C25AB3AB21DA}"/>
                   </a:ext>
                 </a:extLst>
               </p:cNvPr>
@@ -4345,7 +5674,7 @@
               <p:cNvPr id="37" name="Rechteck 36">
                 <a:extLst>
                   <a:ext uri="{FF2B5EF4-FFF2-40B4-BE49-F238E27FC236}">
-                    <a16:creationId xmlns:a16="http://schemas.microsoft.com/office/drawing/2014/main" id="{28EDDA27-D452-2E2A-7613-4820424CE402}"/>
+                    <a16:creationId xmlns:a16="http://schemas.microsoft.com/office/drawing/2014/main" id="{3DC271B0-4C44-9C3F-9A89-1677343AD282}"/>
                   </a:ext>
                 </a:extLst>
               </p:cNvPr>
@@ -4397,7 +5726,7 @@
               <p:cNvPr id="38" name="Textfeld 37">
                 <a:extLst>
                   <a:ext uri="{FF2B5EF4-FFF2-40B4-BE49-F238E27FC236}">
-                    <a16:creationId xmlns:a16="http://schemas.microsoft.com/office/drawing/2014/main" id="{9680CA55-2F20-DE97-A8A3-4EDC1C28019B}"/>
+                    <a16:creationId xmlns:a16="http://schemas.microsoft.com/office/drawing/2014/main" id="{9B6E896D-8E04-ADD6-F9DB-F0D845FDB96E}"/>
                   </a:ext>
                 </a:extLst>
               </p:cNvPr>
@@ -4444,7 +5773,7 @@
               <p:cNvPr id="27" name="Textfeld 26">
                 <a:extLst>
                   <a:ext uri="{FF2B5EF4-FFF2-40B4-BE49-F238E27FC236}">
-                    <a16:creationId xmlns:a16="http://schemas.microsoft.com/office/drawing/2014/main" id="{F265159E-B6A2-DD6C-1BEA-8939B11D054E}"/>
+                    <a16:creationId xmlns:a16="http://schemas.microsoft.com/office/drawing/2014/main" id="{0884282C-CC1A-97A5-BA07-89A3A1F586D7}"/>
                   </a:ext>
                 </a:extLst>
               </p:cNvPr>
@@ -4495,7 +5824,7 @@
               <p:cNvPr id="26" name="Textfeld 25">
                 <a:extLst>
                   <a:ext uri="{FF2B5EF4-FFF2-40B4-BE49-F238E27FC236}">
-                    <a16:creationId xmlns:a16="http://schemas.microsoft.com/office/drawing/2014/main" id="{BF5874DA-9FDF-B60F-AFFA-6A03CC9DC350}"/>
+                    <a16:creationId xmlns:a16="http://schemas.microsoft.com/office/drawing/2014/main" id="{6FBB204C-145D-A804-3817-359B9C46C1CF}"/>
                   </a:ext>
                 </a:extLst>
               </p:cNvPr>
@@ -4544,7 +5873,7 @@
           <p:cNvPr id="41" name="Rechteck 40">
             <a:extLst>
               <a:ext uri="{FF2B5EF4-FFF2-40B4-BE49-F238E27FC236}">
-                <a16:creationId xmlns:a16="http://schemas.microsoft.com/office/drawing/2014/main" id="{FF7D70AA-7401-2EF1-A496-6DABFA43A84C}"/>
+                <a16:creationId xmlns:a16="http://schemas.microsoft.com/office/drawing/2014/main" id="{F13693AA-EE15-974D-6A2D-109956D93A5E}"/>
               </a:ext>
             </a:extLst>
           </p:cNvPr>
@@ -4597,7 +5926,7 @@
           <p:cNvPr id="42" name="Textfeld 41">
             <a:extLst>
               <a:ext uri="{FF2B5EF4-FFF2-40B4-BE49-F238E27FC236}">
-                <a16:creationId xmlns:a16="http://schemas.microsoft.com/office/drawing/2014/main" id="{29C9F6E1-E731-3BD8-837C-2F293DBB0185}"/>
+                <a16:creationId xmlns:a16="http://schemas.microsoft.com/office/drawing/2014/main" id="{D37D42F0-1FBE-4A66-E270-4CBA9C02E931}"/>
               </a:ext>
             </a:extLst>
           </p:cNvPr>
@@ -4636,7 +5965,7 @@
           <p:cNvPr id="43" name="Textfeld 42">
             <a:extLst>
               <a:ext uri="{FF2B5EF4-FFF2-40B4-BE49-F238E27FC236}">
-                <a16:creationId xmlns:a16="http://schemas.microsoft.com/office/drawing/2014/main" id="{A921330F-E52A-A145-8FD5-BED746646F2F}"/>
+                <a16:creationId xmlns:a16="http://schemas.microsoft.com/office/drawing/2014/main" id="{A2A5DB11-EB10-2CA9-CB76-69B6524C2798}"/>
               </a:ext>
             </a:extLst>
           </p:cNvPr>
@@ -4687,7 +6016,7 @@
           <p:cNvPr id="44" name="Textfeld 43">
             <a:extLst>
               <a:ext uri="{FF2B5EF4-FFF2-40B4-BE49-F238E27FC236}">
-                <a16:creationId xmlns:a16="http://schemas.microsoft.com/office/drawing/2014/main" id="{3FC3E53E-063D-7A79-E069-F6886FD665FE}"/>
+                <a16:creationId xmlns:a16="http://schemas.microsoft.com/office/drawing/2014/main" id="{141E2B27-4233-536A-7D5F-18278B5DCE6C}"/>
               </a:ext>
             </a:extLst>
           </p:cNvPr>
@@ -4744,7 +6073,7 @@
           <p:cNvPr id="49" name="Gruppieren 48">
             <a:extLst>
               <a:ext uri="{FF2B5EF4-FFF2-40B4-BE49-F238E27FC236}">
-                <a16:creationId xmlns:a16="http://schemas.microsoft.com/office/drawing/2014/main" id="{C7684F1C-DD38-E1F9-9E7D-63BF50AF41B5}"/>
+                <a16:creationId xmlns:a16="http://schemas.microsoft.com/office/drawing/2014/main" id="{EE823AF3-9521-0905-838A-7344983F8593}"/>
               </a:ext>
             </a:extLst>
           </p:cNvPr>
@@ -4764,7 +6093,7 @@
             <p:cNvPr id="46" name="Rechteck 45">
               <a:extLst>
                 <a:ext uri="{FF2B5EF4-FFF2-40B4-BE49-F238E27FC236}">
-                  <a16:creationId xmlns:a16="http://schemas.microsoft.com/office/drawing/2014/main" id="{0C05F1C2-3811-9AA4-9035-C2B8F40017B3}"/>
+                  <a16:creationId xmlns:a16="http://schemas.microsoft.com/office/drawing/2014/main" id="{53931757-4D18-9E83-8E4E-02D445167FE3}"/>
                 </a:ext>
               </a:extLst>
             </p:cNvPr>
@@ -4819,7 +6148,7 @@
             <p:cNvPr id="48" name="Textfeld 47">
               <a:extLst>
                 <a:ext uri="{FF2B5EF4-FFF2-40B4-BE49-F238E27FC236}">
-                  <a16:creationId xmlns:a16="http://schemas.microsoft.com/office/drawing/2014/main" id="{AE8E6F37-E9A2-1C70-C7F9-6247B2500A1F}"/>
+                  <a16:creationId xmlns:a16="http://schemas.microsoft.com/office/drawing/2014/main" id="{4A73663D-9BD0-461E-75E5-5E38CC4C15FA}"/>
                 </a:ext>
               </a:extLst>
             </p:cNvPr>
@@ -4855,7 +6184,7 @@
           <p:cNvPr id="54" name="Textfeld 53">
             <a:extLst>
               <a:ext uri="{FF2B5EF4-FFF2-40B4-BE49-F238E27FC236}">
-                <a16:creationId xmlns:a16="http://schemas.microsoft.com/office/drawing/2014/main" id="{AA9EA5D3-621B-9C50-B056-2086FB81DB97}"/>
+                <a16:creationId xmlns:a16="http://schemas.microsoft.com/office/drawing/2014/main" id="{A90046F5-B61F-B94B-4732-BD4F05F4B529}"/>
               </a:ext>
             </a:extLst>
           </p:cNvPr>
@@ -4897,7 +6226,7 @@
           <p:cNvPr id="3" name="Rechteck: abgerundete Ecken 2">
             <a:extLst>
               <a:ext uri="{FF2B5EF4-FFF2-40B4-BE49-F238E27FC236}">
-                <a16:creationId xmlns:a16="http://schemas.microsoft.com/office/drawing/2014/main" id="{E1D95646-D94D-E609-3596-E0ECF595C118}"/>
+                <a16:creationId xmlns:a16="http://schemas.microsoft.com/office/drawing/2014/main" id="{1545B1D8-412B-4C54-6954-9A770CCB46EB}"/>
               </a:ext>
             </a:extLst>
           </p:cNvPr>
@@ -4949,7 +6278,7 @@
           <p:cNvPr id="8" name="Textfeld 7">
             <a:extLst>
               <a:ext uri="{FF2B5EF4-FFF2-40B4-BE49-F238E27FC236}">
-                <a16:creationId xmlns:a16="http://schemas.microsoft.com/office/drawing/2014/main" id="{06726E73-68A3-72B5-4F89-B169BB4AB21B}"/>
+                <a16:creationId xmlns:a16="http://schemas.microsoft.com/office/drawing/2014/main" id="{51150EFE-C115-E4E3-DF07-33F82957C6A6}"/>
               </a:ext>
             </a:extLst>
           </p:cNvPr>
@@ -4984,7 +6313,7 @@
           <p:cNvPr id="14" name="Verbinder: gewinkelt 13">
             <a:extLst>
               <a:ext uri="{FF2B5EF4-FFF2-40B4-BE49-F238E27FC236}">
-                <a16:creationId xmlns:a16="http://schemas.microsoft.com/office/drawing/2014/main" id="{5DB5EC1F-84A8-CF58-DB02-C7DD833858FF}"/>
+                <a16:creationId xmlns:a16="http://schemas.microsoft.com/office/drawing/2014/main" id="{17417DA6-BE9A-5AF2-06A0-7D809F546F62}"/>
               </a:ext>
             </a:extLst>
           </p:cNvPr>
@@ -5027,7 +6356,7 @@
           <p:cNvPr id="23" name="Verbinder: gewinkelt 22">
             <a:extLst>
               <a:ext uri="{FF2B5EF4-FFF2-40B4-BE49-F238E27FC236}">
-                <a16:creationId xmlns:a16="http://schemas.microsoft.com/office/drawing/2014/main" id="{85E569F4-D3E0-3205-7B4F-19CC77215735}"/>
+                <a16:creationId xmlns:a16="http://schemas.microsoft.com/office/drawing/2014/main" id="{E64F10DB-D51F-4117-6FC3-68EFB72C3CC0}"/>
               </a:ext>
             </a:extLst>
           </p:cNvPr>
@@ -5070,7 +6399,7 @@
           <p:cNvPr id="45" name="Gruppieren 44">
             <a:extLst>
               <a:ext uri="{FF2B5EF4-FFF2-40B4-BE49-F238E27FC236}">
-                <a16:creationId xmlns:a16="http://schemas.microsoft.com/office/drawing/2014/main" id="{F899CDE9-1718-F877-F800-B71A5F1720E0}"/>
+                <a16:creationId xmlns:a16="http://schemas.microsoft.com/office/drawing/2014/main" id="{E78E623B-CB8E-01B4-1620-3047F3603FCA}"/>
               </a:ext>
             </a:extLst>
           </p:cNvPr>
@@ -5090,7 +6419,7 @@
             <p:cNvPr id="30" name="Rechteck 29">
               <a:extLst>
                 <a:ext uri="{FF2B5EF4-FFF2-40B4-BE49-F238E27FC236}">
-                  <a16:creationId xmlns:a16="http://schemas.microsoft.com/office/drawing/2014/main" id="{461608AD-D0F2-B843-7F1B-9C6A7E9377E5}"/>
+                  <a16:creationId xmlns:a16="http://schemas.microsoft.com/office/drawing/2014/main" id="{4149715C-FDB5-2F7B-ADAC-60A402817315}"/>
                 </a:ext>
               </a:extLst>
             </p:cNvPr>
@@ -5147,7 +6476,7 @@
             <p:cNvPr id="29" name="Textfeld 28">
               <a:extLst>
                 <a:ext uri="{FF2B5EF4-FFF2-40B4-BE49-F238E27FC236}">
-                  <a16:creationId xmlns:a16="http://schemas.microsoft.com/office/drawing/2014/main" id="{B72B45D8-9BF8-3191-5D89-A1479EE47801}"/>
+                  <a16:creationId xmlns:a16="http://schemas.microsoft.com/office/drawing/2014/main" id="{D7D1E508-0130-675F-4AEF-A4680A9131C7}"/>
                 </a:ext>
               </a:extLst>
             </p:cNvPr>
@@ -5182,7 +6511,7 @@
             <p:cNvPr id="53" name="Textfeld 52">
               <a:extLst>
                 <a:ext uri="{FF2B5EF4-FFF2-40B4-BE49-F238E27FC236}">
-                  <a16:creationId xmlns:a16="http://schemas.microsoft.com/office/drawing/2014/main" id="{343AE1E2-52D3-3C0C-D38A-B7A47100DA4B}"/>
+                  <a16:creationId xmlns:a16="http://schemas.microsoft.com/office/drawing/2014/main" id="{ADE2207A-5807-A4DB-8566-62A04047F8D0}"/>
                 </a:ext>
               </a:extLst>
             </p:cNvPr>
@@ -5225,7 +6554,7 @@
           <p:cNvPr id="35" name="Gruppieren 34">
             <a:extLst>
               <a:ext uri="{FF2B5EF4-FFF2-40B4-BE49-F238E27FC236}">
-                <a16:creationId xmlns:a16="http://schemas.microsoft.com/office/drawing/2014/main" id="{484B72EE-1AF4-ED3B-2269-6EBF3EF20E5F}"/>
+                <a16:creationId xmlns:a16="http://schemas.microsoft.com/office/drawing/2014/main" id="{A24D6DA9-E6F1-C819-1CF2-7BA1B95484B9}"/>
               </a:ext>
             </a:extLst>
           </p:cNvPr>
@@ -5245,7 +6574,7 @@
             <p:cNvPr id="31" name="Rechteck 30">
               <a:extLst>
                 <a:ext uri="{FF2B5EF4-FFF2-40B4-BE49-F238E27FC236}">
-                  <a16:creationId xmlns:a16="http://schemas.microsoft.com/office/drawing/2014/main" id="{461D6F97-1702-13E9-9DCA-470F6798F5AA}"/>
+                  <a16:creationId xmlns:a16="http://schemas.microsoft.com/office/drawing/2014/main" id="{79A01BC2-F4AE-1395-95C8-3F3D592FF21E}"/>
                 </a:ext>
               </a:extLst>
             </p:cNvPr>
@@ -5305,7 +6634,7 @@
             <p:cNvPr id="32" name="Textfeld 31">
               <a:extLst>
                 <a:ext uri="{FF2B5EF4-FFF2-40B4-BE49-F238E27FC236}">
-                  <a16:creationId xmlns:a16="http://schemas.microsoft.com/office/drawing/2014/main" id="{3AE0A586-5043-D2ED-A98A-5EC4872809E4}"/>
+                  <a16:creationId xmlns:a16="http://schemas.microsoft.com/office/drawing/2014/main" id="{3F0004E6-94BC-BDE5-C21F-EF8B134297B1}"/>
                 </a:ext>
               </a:extLst>
             </p:cNvPr>
@@ -5347,7 +6676,7 @@
             <p:cNvPr id="34" name="Textfeld 33">
               <a:extLst>
                 <a:ext uri="{FF2B5EF4-FFF2-40B4-BE49-F238E27FC236}">
-                  <a16:creationId xmlns:a16="http://schemas.microsoft.com/office/drawing/2014/main" id="{A00C6A97-9C40-7549-F047-6F30FD58AA3E}"/>
+                  <a16:creationId xmlns:a16="http://schemas.microsoft.com/office/drawing/2014/main" id="{9518B670-0E28-A235-4230-C112668803C1}"/>
                 </a:ext>
               </a:extLst>
             </p:cNvPr>
@@ -5390,7 +6719,7 @@
           <p:cNvPr id="59" name="Gerade Verbindung mit Pfeil 58">
             <a:extLst>
               <a:ext uri="{FF2B5EF4-FFF2-40B4-BE49-F238E27FC236}">
-                <a16:creationId xmlns:a16="http://schemas.microsoft.com/office/drawing/2014/main" id="{7872D480-DB70-13E6-C9BA-54B48E954916}"/>
+                <a16:creationId xmlns:a16="http://schemas.microsoft.com/office/drawing/2014/main" id="{BDEBFD5A-F51B-9CE9-43D7-C7F938F12E29}"/>
               </a:ext>
             </a:extLst>
           </p:cNvPr>
@@ -5438,7 +6767,7 @@
           <p:cNvPr id="64" name="Gerade Verbindung mit Pfeil 63">
             <a:extLst>
               <a:ext uri="{FF2B5EF4-FFF2-40B4-BE49-F238E27FC236}">
-                <a16:creationId xmlns:a16="http://schemas.microsoft.com/office/drawing/2014/main" id="{4E8549EA-CA33-0A8F-869C-5FA2A73FBE7D}"/>
+                <a16:creationId xmlns:a16="http://schemas.microsoft.com/office/drawing/2014/main" id="{64C30896-5027-8C04-98A6-7683B69390F7}"/>
               </a:ext>
             </a:extLst>
           </p:cNvPr>
@@ -5486,7 +6815,7 @@
           <p:cNvPr id="68" name="Gerade Verbindung mit Pfeil 67">
             <a:extLst>
               <a:ext uri="{FF2B5EF4-FFF2-40B4-BE49-F238E27FC236}">
-                <a16:creationId xmlns:a16="http://schemas.microsoft.com/office/drawing/2014/main" id="{2CC6EBBF-D766-A9F8-D774-D75A5E49A95E}"/>
+                <a16:creationId xmlns:a16="http://schemas.microsoft.com/office/drawing/2014/main" id="{714AE6AB-4D55-011C-2F94-AD4959EE9000}"/>
               </a:ext>
             </a:extLst>
           </p:cNvPr>
@@ -5533,7 +6862,7 @@
           <p:cNvPr id="72" name="Gerade Verbindung mit Pfeil 71">
             <a:extLst>
               <a:ext uri="{FF2B5EF4-FFF2-40B4-BE49-F238E27FC236}">
-                <a16:creationId xmlns:a16="http://schemas.microsoft.com/office/drawing/2014/main" id="{06CDEC7A-9F71-5E9C-5533-F385D711B98A}"/>
+                <a16:creationId xmlns:a16="http://schemas.microsoft.com/office/drawing/2014/main" id="{C0A3AAFD-0D01-454B-CE60-1F7B4FBA677C}"/>
               </a:ext>
             </a:extLst>
           </p:cNvPr>
@@ -5580,7 +6909,7 @@
           <p:cNvPr id="100" name="Pfeil: nach oben 99">
             <a:extLst>
               <a:ext uri="{FF2B5EF4-FFF2-40B4-BE49-F238E27FC236}">
-                <a16:creationId xmlns:a16="http://schemas.microsoft.com/office/drawing/2014/main" id="{274287BF-DA51-94F7-35B1-AB7663E277AB}"/>
+                <a16:creationId xmlns:a16="http://schemas.microsoft.com/office/drawing/2014/main" id="{51B9400E-7AA8-7637-F052-3C910712658E}"/>
               </a:ext>
             </a:extLst>
           </p:cNvPr>
@@ -5637,7 +6966,7 @@
           <p:cNvPr id="101" name="Pfeil: nach oben 100">
             <a:extLst>
               <a:ext uri="{FF2B5EF4-FFF2-40B4-BE49-F238E27FC236}">
-                <a16:creationId xmlns:a16="http://schemas.microsoft.com/office/drawing/2014/main" id="{AB51E722-8560-F1DA-6936-1003079B13EC}"/>
+                <a16:creationId xmlns:a16="http://schemas.microsoft.com/office/drawing/2014/main" id="{6F7032E1-D5C5-6B5A-263E-E943BDFFF6C9}"/>
               </a:ext>
             </a:extLst>
           </p:cNvPr>
@@ -5694,7 +7023,7 @@
           <p:cNvPr id="5" name="Rechteck 4">
             <a:extLst>
               <a:ext uri="{FF2B5EF4-FFF2-40B4-BE49-F238E27FC236}">
-                <a16:creationId xmlns:a16="http://schemas.microsoft.com/office/drawing/2014/main" id="{26354980-44E7-1FC9-0A42-235E5DBF69BF}"/>
+                <a16:creationId xmlns:a16="http://schemas.microsoft.com/office/drawing/2014/main" id="{EA5C7B00-C408-E87B-AB18-BDB09D8A4281}"/>
               </a:ext>
             </a:extLst>
           </p:cNvPr>
@@ -5749,7 +7078,7 @@
           <p:cNvPr id="2" name="Textfeld 1">
             <a:extLst>
               <a:ext uri="{FF2B5EF4-FFF2-40B4-BE49-F238E27FC236}">
-                <a16:creationId xmlns:a16="http://schemas.microsoft.com/office/drawing/2014/main" id="{D35F14C2-2CB3-AF3E-413F-BAD3A7110F03}"/>
+                <a16:creationId xmlns:a16="http://schemas.microsoft.com/office/drawing/2014/main" id="{CA71FF72-8234-5756-5BF5-3D9176751508}"/>
               </a:ext>
             </a:extLst>
           </p:cNvPr>
@@ -5794,7 +7123,7 @@
     </p:spTree>
     <p:extLst>
       <p:ext uri="{BB962C8B-B14F-4D97-AF65-F5344CB8AC3E}">
-        <p14:creationId xmlns:p14="http://schemas.microsoft.com/office/powerpoint/2010/main" val="3771264090"/>
+        <p14:creationId xmlns:p14="http://schemas.microsoft.com/office/powerpoint/2010/main" val="941311319"/>
       </p:ext>
     </p:extLst>
   </p:cSld>
@@ -5805,6 +7134,1090 @@
 </file>
 
 <file path=ppt/slides/slide2.xml><?xml version="1.0" encoding="utf-8"?>
+<p:sld xmlns:a="http://schemas.openxmlformats.org/drawingml/2006/main" xmlns:r="http://schemas.openxmlformats.org/officeDocument/2006/relationships" xmlns:p="http://schemas.openxmlformats.org/presentationml/2006/main">
+  <p:cSld>
+    <p:spTree>
+      <p:nvGrpSpPr>
+        <p:cNvPr id="1" name="">
+          <a:extLst>
+            <a:ext uri="{FF2B5EF4-FFF2-40B4-BE49-F238E27FC236}">
+              <a16:creationId xmlns:a16="http://schemas.microsoft.com/office/drawing/2014/main" id="{81E50BBE-18B9-1DDD-5255-D1EE6B0E5A21}"/>
+            </a:ext>
+          </a:extLst>
+        </p:cNvPr>
+        <p:cNvGrpSpPr/>
+        <p:nvPr/>
+      </p:nvGrpSpPr>
+      <p:grpSpPr>
+        <a:xfrm>
+          <a:off x="0" y="0"/>
+          <a:ext cx="0" cy="0"/>
+          <a:chOff x="0" y="0"/>
+          <a:chExt cx="0" cy="0"/>
+        </a:xfrm>
+      </p:grpSpPr>
+      <p:grpSp>
+        <p:nvGrpSpPr>
+          <p:cNvPr id="3" name="Gruppieren 2">
+            <a:extLst>
+              <a:ext uri="{FF2B5EF4-FFF2-40B4-BE49-F238E27FC236}">
+                <a16:creationId xmlns:a16="http://schemas.microsoft.com/office/drawing/2014/main" id="{B95EA94C-38F5-591E-D9FD-26E4B0482979}"/>
+              </a:ext>
+            </a:extLst>
+          </p:cNvPr>
+          <p:cNvGrpSpPr/>
+          <p:nvPr/>
+        </p:nvGrpSpPr>
+        <p:grpSpPr>
+          <a:xfrm>
+            <a:off x="2765552" y="1204601"/>
+            <a:ext cx="6254496" cy="2351399"/>
+            <a:chOff x="2911602" y="2068201"/>
+            <a:chExt cx="6254496" cy="2351399"/>
+          </a:xfrm>
+        </p:grpSpPr>
+        <p:grpSp>
+          <p:nvGrpSpPr>
+            <p:cNvPr id="7" name="Gruppieren 6">
+              <a:extLst>
+                <a:ext uri="{FF2B5EF4-FFF2-40B4-BE49-F238E27FC236}">
+                  <a16:creationId xmlns:a16="http://schemas.microsoft.com/office/drawing/2014/main" id="{C4F543A1-F974-944C-7768-7BEE20598B94}"/>
+                </a:ext>
+              </a:extLst>
+            </p:cNvPr>
+            <p:cNvGrpSpPr/>
+            <p:nvPr/>
+          </p:nvGrpSpPr>
+          <p:grpSpPr>
+            <a:xfrm>
+              <a:off x="3105916" y="2584254"/>
+              <a:ext cx="1652773" cy="1632146"/>
+              <a:chOff x="2013970" y="586290"/>
+              <a:chExt cx="1652773" cy="3976566"/>
+            </a:xfrm>
+          </p:grpSpPr>
+          <p:sp>
+            <p:nvSpPr>
+              <p:cNvPr id="4" name="Rechteck 3">
+                <a:extLst>
+                  <a:ext uri="{FF2B5EF4-FFF2-40B4-BE49-F238E27FC236}">
+                    <a16:creationId xmlns:a16="http://schemas.microsoft.com/office/drawing/2014/main" id="{ACAEF261-0AFD-A473-0D38-5BB18A1354BE}"/>
+                  </a:ext>
+                </a:extLst>
+              </p:cNvPr>
+              <p:cNvSpPr/>
+              <p:nvPr/>
+            </p:nvSpPr>
+            <p:spPr>
+              <a:xfrm>
+                <a:off x="2031236" y="586290"/>
+                <a:ext cx="1635507" cy="3976566"/>
+              </a:xfrm>
+              <a:prstGeom prst="rect">
+                <a:avLst/>
+              </a:prstGeom>
+              <a:solidFill>
+                <a:schemeClr val="bg1">
+                  <a:lumMod val="95000"/>
+                </a:schemeClr>
+              </a:solidFill>
+              <a:ln>
+                <a:solidFill>
+                  <a:srgbClr val="7030A0"/>
+                </a:solidFill>
+                <a:prstDash val="sysDash"/>
+              </a:ln>
+            </p:spPr>
+            <p:style>
+              <a:lnRef idx="2">
+                <a:schemeClr val="accent1">
+                  <a:shade val="15000"/>
+                </a:schemeClr>
+              </a:lnRef>
+              <a:fillRef idx="1">
+                <a:schemeClr val="accent1"/>
+              </a:fillRef>
+              <a:effectRef idx="0">
+                <a:schemeClr val="accent1"/>
+              </a:effectRef>
+              <a:fontRef idx="minor">
+                <a:schemeClr val="lt1"/>
+              </a:fontRef>
+            </p:style>
+            <p:txBody>
+              <a:bodyPr rtlCol="0" anchor="ctr"/>
+              <a:lstStyle/>
+              <a:p>
+                <a:pPr algn="ctr"/>
+                <a:endParaRPr lang="de-DE"/>
+              </a:p>
+            </p:txBody>
+          </p:sp>
+          <p:sp>
+            <p:nvSpPr>
+              <p:cNvPr id="6" name="Textfeld 5">
+                <a:extLst>
+                  <a:ext uri="{FF2B5EF4-FFF2-40B4-BE49-F238E27FC236}">
+                    <a16:creationId xmlns:a16="http://schemas.microsoft.com/office/drawing/2014/main" id="{FE23814A-842D-A0C4-226C-84B90FC0854E}"/>
+                  </a:ext>
+                </a:extLst>
+              </p:cNvPr>
+              <p:cNvSpPr txBox="1"/>
+              <p:nvPr/>
+            </p:nvSpPr>
+            <p:spPr>
+              <a:xfrm>
+                <a:off x="2013970" y="594762"/>
+                <a:ext cx="1087029" cy="369332"/>
+              </a:xfrm>
+              <a:prstGeom prst="rect">
+                <a:avLst/>
+              </a:prstGeom>
+              <a:noFill/>
+            </p:spPr>
+            <p:txBody>
+              <a:bodyPr wrap="none" rtlCol="0">
+                <a:spAutoFit/>
+              </a:bodyPr>
+              <a:lstStyle/>
+              <a:p>
+                <a:r>
+                  <a:rPr lang="de-DE" b="1">
+                    <a:solidFill>
+                      <a:srgbClr val="7030A0"/>
+                    </a:solidFill>
+                  </a:rPr>
+                  <a:t>backend</a:t>
+                </a:r>
+              </a:p>
+            </p:txBody>
+          </p:sp>
+        </p:grpSp>
+        <p:grpSp>
+          <p:nvGrpSpPr>
+            <p:cNvPr id="20" name="Gruppieren 19">
+              <a:extLst>
+                <a:ext uri="{FF2B5EF4-FFF2-40B4-BE49-F238E27FC236}">
+                  <a16:creationId xmlns:a16="http://schemas.microsoft.com/office/drawing/2014/main" id="{766AAFB1-9BCF-A234-F93F-8BB0D3D6F669}"/>
+                </a:ext>
+              </a:extLst>
+            </p:cNvPr>
+            <p:cNvGrpSpPr/>
+            <p:nvPr/>
+          </p:nvGrpSpPr>
+          <p:grpSpPr>
+            <a:xfrm>
+              <a:off x="7402414" y="2590603"/>
+              <a:ext cx="1609958" cy="1625798"/>
+              <a:chOff x="6606124" y="632008"/>
+              <a:chExt cx="1609958" cy="3976567"/>
+            </a:xfrm>
+            <a:solidFill>
+              <a:schemeClr val="bg1">
+                <a:lumMod val="95000"/>
+              </a:schemeClr>
+            </a:solidFill>
+          </p:grpSpPr>
+          <p:sp>
+            <p:nvSpPr>
+              <p:cNvPr id="12" name="Rechteck 11">
+                <a:extLst>
+                  <a:ext uri="{FF2B5EF4-FFF2-40B4-BE49-F238E27FC236}">
+                    <a16:creationId xmlns:a16="http://schemas.microsoft.com/office/drawing/2014/main" id="{DFC07FED-600D-4DE7-5721-04134762009E}"/>
+                  </a:ext>
+                </a:extLst>
+              </p:cNvPr>
+              <p:cNvSpPr/>
+              <p:nvPr/>
+            </p:nvSpPr>
+            <p:spPr>
+              <a:xfrm>
+                <a:off x="6606124" y="632008"/>
+                <a:ext cx="1609958" cy="3976567"/>
+              </a:xfrm>
+              <a:prstGeom prst="rect">
+                <a:avLst/>
+              </a:prstGeom>
+              <a:grpFill/>
+              <a:ln>
+                <a:solidFill>
+                  <a:schemeClr val="tx2">
+                    <a:lumMod val="75000"/>
+                    <a:lumOff val="25000"/>
+                  </a:schemeClr>
+                </a:solidFill>
+              </a:ln>
+            </p:spPr>
+            <p:style>
+              <a:lnRef idx="2">
+                <a:schemeClr val="accent1">
+                  <a:shade val="15000"/>
+                </a:schemeClr>
+              </a:lnRef>
+              <a:fillRef idx="1">
+                <a:schemeClr val="accent1"/>
+              </a:fillRef>
+              <a:effectRef idx="0">
+                <a:schemeClr val="accent1"/>
+              </a:effectRef>
+              <a:fontRef idx="minor">
+                <a:schemeClr val="lt1"/>
+              </a:fontRef>
+            </p:style>
+            <p:txBody>
+              <a:bodyPr rtlCol="0" anchor="ctr"/>
+              <a:lstStyle/>
+              <a:p>
+                <a:pPr algn="ctr"/>
+                <a:endParaRPr lang="de-DE"/>
+              </a:p>
+            </p:txBody>
+          </p:sp>
+          <p:sp>
+            <p:nvSpPr>
+              <p:cNvPr id="13" name="Textfeld 12">
+                <a:extLst>
+                  <a:ext uri="{FF2B5EF4-FFF2-40B4-BE49-F238E27FC236}">
+                    <a16:creationId xmlns:a16="http://schemas.microsoft.com/office/drawing/2014/main" id="{050ED622-67A4-03A0-B579-8272ADDDDA00}"/>
+                  </a:ext>
+                </a:extLst>
+              </p:cNvPr>
+              <p:cNvSpPr txBox="1"/>
+              <p:nvPr/>
+            </p:nvSpPr>
+            <p:spPr>
+              <a:xfrm>
+                <a:off x="6607221" y="632142"/>
+                <a:ext cx="514885" cy="369332"/>
+              </a:xfrm>
+              <a:prstGeom prst="rect">
+                <a:avLst/>
+              </a:prstGeom>
+              <a:noFill/>
+            </p:spPr>
+            <p:txBody>
+              <a:bodyPr wrap="none" rtlCol="0">
+                <a:spAutoFit/>
+              </a:bodyPr>
+              <a:lstStyle/>
+              <a:p>
+                <a:r>
+                  <a:rPr lang="de-DE" b="1">
+                    <a:solidFill>
+                      <a:schemeClr val="tx2">
+                        <a:lumMod val="75000"/>
+                        <a:lumOff val="25000"/>
+                      </a:schemeClr>
+                    </a:solidFill>
+                  </a:rPr>
+                  <a:t>job</a:t>
+                </a:r>
+              </a:p>
+            </p:txBody>
+          </p:sp>
+        </p:grpSp>
+        <p:grpSp>
+          <p:nvGrpSpPr>
+            <p:cNvPr id="25" name="Gruppieren 24">
+              <a:extLst>
+                <a:ext uri="{FF2B5EF4-FFF2-40B4-BE49-F238E27FC236}">
+                  <a16:creationId xmlns:a16="http://schemas.microsoft.com/office/drawing/2014/main" id="{3656935A-914A-3594-2569-CFD4E2974623}"/>
+                </a:ext>
+              </a:extLst>
+            </p:cNvPr>
+            <p:cNvGrpSpPr/>
+            <p:nvPr/>
+          </p:nvGrpSpPr>
+          <p:grpSpPr>
+            <a:xfrm>
+              <a:off x="4812358" y="3182254"/>
+              <a:ext cx="3185440" cy="615297"/>
+              <a:chOff x="4171385" y="5346379"/>
+              <a:chExt cx="1310755" cy="615297"/>
+            </a:xfrm>
+          </p:grpSpPr>
+          <p:sp>
+            <p:nvSpPr>
+              <p:cNvPr id="22" name="Pfeil: nach links und rechts 21">
+                <a:extLst>
+                  <a:ext uri="{FF2B5EF4-FFF2-40B4-BE49-F238E27FC236}">
+                    <a16:creationId xmlns:a16="http://schemas.microsoft.com/office/drawing/2014/main" id="{D250BC81-0220-4A80-8B23-D6AF68702081}"/>
+                  </a:ext>
+                </a:extLst>
+              </p:cNvPr>
+              <p:cNvSpPr/>
+              <p:nvPr/>
+            </p:nvSpPr>
+            <p:spPr>
+              <a:xfrm>
+                <a:off x="4171385" y="5346379"/>
+                <a:ext cx="1031611" cy="615297"/>
+              </a:xfrm>
+              <a:prstGeom prst="leftRightArrow">
+                <a:avLst/>
+              </a:prstGeom>
+              <a:solidFill>
+                <a:schemeClr val="accent2">
+                  <a:lumMod val="20000"/>
+                  <a:lumOff val="80000"/>
+                </a:schemeClr>
+              </a:solidFill>
+              <a:ln>
+                <a:prstDash val="sysDot"/>
+              </a:ln>
+            </p:spPr>
+            <p:style>
+              <a:lnRef idx="2">
+                <a:schemeClr val="accent1">
+                  <a:shade val="15000"/>
+                </a:schemeClr>
+              </a:lnRef>
+              <a:fillRef idx="1">
+                <a:schemeClr val="accent1"/>
+              </a:fillRef>
+              <a:effectRef idx="0">
+                <a:schemeClr val="accent1"/>
+              </a:effectRef>
+              <a:fontRef idx="minor">
+                <a:schemeClr val="lt1"/>
+              </a:fontRef>
+            </p:style>
+            <p:txBody>
+              <a:bodyPr rtlCol="0" anchor="ctr"/>
+              <a:lstStyle/>
+              <a:p>
+                <a:pPr algn="ctr"/>
+                <a:endParaRPr lang="de-DE"/>
+              </a:p>
+            </p:txBody>
+          </p:sp>
+          <p:sp>
+            <p:nvSpPr>
+              <p:cNvPr id="24" name="Textfeld 23">
+                <a:extLst>
+                  <a:ext uri="{FF2B5EF4-FFF2-40B4-BE49-F238E27FC236}">
+                    <a16:creationId xmlns:a16="http://schemas.microsoft.com/office/drawing/2014/main" id="{B31D5EBB-A89F-35F1-BDFF-4FE0D37A0761}"/>
+                  </a:ext>
+                </a:extLst>
+              </p:cNvPr>
+              <p:cNvSpPr txBox="1"/>
+              <p:nvPr/>
+            </p:nvSpPr>
+            <p:spPr>
+              <a:xfrm>
+                <a:off x="4358408" y="5471494"/>
+                <a:ext cx="1123732" cy="369332"/>
+              </a:xfrm>
+              <a:prstGeom prst="rect">
+                <a:avLst/>
+              </a:prstGeom>
+              <a:noFill/>
+            </p:spPr>
+            <p:txBody>
+              <a:bodyPr wrap="square" rtlCol="0">
+                <a:spAutoFit/>
+              </a:bodyPr>
+              <a:lstStyle/>
+              <a:p>
+                <a:r>
+                  <a:rPr lang="de-DE" sz="1600" i="1"/>
+                  <a:t>one-to-one</a:t>
+                </a:r>
+                <a:r>
+                  <a:rPr lang="de-DE" i="1"/>
+                  <a:t> </a:t>
+                </a:r>
+                <a:r>
+                  <a:rPr lang="de-DE" b="1" i="1"/>
+                  <a:t>IPC</a:t>
+                </a:r>
+              </a:p>
+            </p:txBody>
+          </p:sp>
+        </p:grpSp>
+        <p:sp>
+          <p:nvSpPr>
+            <p:cNvPr id="41" name="Rechteck 40">
+              <a:extLst>
+                <a:ext uri="{FF2B5EF4-FFF2-40B4-BE49-F238E27FC236}">
+                  <a16:creationId xmlns:a16="http://schemas.microsoft.com/office/drawing/2014/main" id="{BE488C41-3E39-E95D-85D1-75AE15220CA5}"/>
+                </a:ext>
+              </a:extLst>
+            </p:cNvPr>
+            <p:cNvSpPr/>
+            <p:nvPr/>
+          </p:nvSpPr>
+          <p:spPr>
+            <a:xfrm>
+              <a:off x="2911602" y="2086489"/>
+              <a:ext cx="6254496" cy="2333111"/>
+            </a:xfrm>
+            <a:prstGeom prst="rect">
+              <a:avLst/>
+            </a:prstGeom>
+            <a:noFill/>
+            <a:ln>
+              <a:solidFill>
+                <a:srgbClr val="002060"/>
+              </a:solidFill>
+              <a:prstDash val="dash"/>
+            </a:ln>
+          </p:spPr>
+          <p:style>
+            <a:lnRef idx="2">
+              <a:schemeClr val="accent1">
+                <a:shade val="15000"/>
+              </a:schemeClr>
+            </a:lnRef>
+            <a:fillRef idx="1">
+              <a:schemeClr val="accent1"/>
+            </a:fillRef>
+            <a:effectRef idx="0">
+              <a:schemeClr val="accent1"/>
+            </a:effectRef>
+            <a:fontRef idx="minor">
+              <a:schemeClr val="lt1"/>
+            </a:fontRef>
+          </p:style>
+          <p:txBody>
+            <a:bodyPr rtlCol="0" anchor="ctr"/>
+            <a:lstStyle/>
+            <a:p>
+              <a:pPr algn="ctr"/>
+              <a:endParaRPr lang="de-DE"/>
+            </a:p>
+          </p:txBody>
+        </p:sp>
+        <p:sp>
+          <p:nvSpPr>
+            <p:cNvPr id="42" name="Textfeld 41">
+              <a:extLst>
+                <a:ext uri="{FF2B5EF4-FFF2-40B4-BE49-F238E27FC236}">
+                  <a16:creationId xmlns:a16="http://schemas.microsoft.com/office/drawing/2014/main" id="{6860F192-A780-ACF2-B447-DBCED6349946}"/>
+                </a:ext>
+              </a:extLst>
+            </p:cNvPr>
+            <p:cNvSpPr txBox="1"/>
+            <p:nvPr/>
+          </p:nvSpPr>
+          <p:spPr>
+            <a:xfrm>
+              <a:off x="2977134" y="2068201"/>
+              <a:ext cx="2244525" cy="461665"/>
+            </a:xfrm>
+            <a:prstGeom prst="rect">
+              <a:avLst/>
+            </a:prstGeom>
+            <a:noFill/>
+          </p:spPr>
+          <p:txBody>
+            <a:bodyPr wrap="none" rtlCol="0">
+              <a:spAutoFit/>
+            </a:bodyPr>
+            <a:lstStyle/>
+            <a:p>
+              <a:r>
+                <a:rPr lang="de-DE" sz="2400" b="1">
+                  <a:solidFill>
+                    <a:srgbClr val="002060"/>
+                  </a:solidFill>
+                </a:rPr>
+                <a:t>josyn-platform</a:t>
+              </a:r>
+            </a:p>
+          </p:txBody>
+        </p:sp>
+        <p:sp>
+          <p:nvSpPr>
+            <p:cNvPr id="54" name="Textfeld 53">
+              <a:extLst>
+                <a:ext uri="{FF2B5EF4-FFF2-40B4-BE49-F238E27FC236}">
+                  <a16:creationId xmlns:a16="http://schemas.microsoft.com/office/drawing/2014/main" id="{35339789-9892-8B3C-0986-3CE07F4F5B0F}"/>
+                </a:ext>
+              </a:extLst>
+            </p:cNvPr>
+            <p:cNvSpPr txBox="1"/>
+            <p:nvPr/>
+          </p:nvSpPr>
+          <p:spPr>
+            <a:xfrm>
+              <a:off x="8531784" y="3941718"/>
+              <a:ext cx="409133" cy="215444"/>
+            </a:xfrm>
+            <a:prstGeom prst="rect">
+              <a:avLst/>
+            </a:prstGeom>
+            <a:solidFill>
+              <a:srgbClr val="FFFF99"/>
+            </a:solidFill>
+            <a:ln>
+              <a:solidFill>
+                <a:schemeClr val="tx1"/>
+              </a:solidFill>
+            </a:ln>
+          </p:spPr>
+          <p:txBody>
+            <a:bodyPr wrap="none" lIns="72000" tIns="0" rIns="72000" bIns="0" rtlCol="0">
+              <a:spAutoFit/>
+            </a:bodyPr>
+            <a:lstStyle/>
+            <a:p>
+              <a:r>
+                <a:rPr lang="de-DE" sz="1400" i="1"/>
+                <a:t>exe</a:t>
+              </a:r>
+            </a:p>
+          </p:txBody>
+        </p:sp>
+        <p:grpSp>
+          <p:nvGrpSpPr>
+            <p:cNvPr id="45" name="Gruppieren 44">
+              <a:extLst>
+                <a:ext uri="{FF2B5EF4-FFF2-40B4-BE49-F238E27FC236}">
+                  <a16:creationId xmlns:a16="http://schemas.microsoft.com/office/drawing/2014/main" id="{D7D6D2AD-63E5-9095-4FC5-2C10252C76EB}"/>
+                </a:ext>
+              </a:extLst>
+            </p:cNvPr>
+            <p:cNvGrpSpPr/>
+            <p:nvPr/>
+          </p:nvGrpSpPr>
+          <p:grpSpPr>
+            <a:xfrm>
+              <a:off x="3278442" y="3049876"/>
+              <a:ext cx="1478776" cy="791538"/>
+              <a:chOff x="541429" y="351742"/>
+              <a:chExt cx="1478776" cy="791538"/>
+            </a:xfrm>
+          </p:grpSpPr>
+          <p:sp>
+            <p:nvSpPr>
+              <p:cNvPr id="30" name="Rechteck 29">
+                <a:extLst>
+                  <a:ext uri="{FF2B5EF4-FFF2-40B4-BE49-F238E27FC236}">
+                    <a16:creationId xmlns:a16="http://schemas.microsoft.com/office/drawing/2014/main" id="{2A5786B1-3FB4-0E22-8DA1-DBDDF5C888CC}"/>
+                  </a:ext>
+                </a:extLst>
+              </p:cNvPr>
+              <p:cNvSpPr/>
+              <p:nvPr/>
+            </p:nvSpPr>
+            <p:spPr>
+              <a:xfrm>
+                <a:off x="548021" y="378232"/>
+                <a:ext cx="1472184" cy="765048"/>
+              </a:xfrm>
+              <a:prstGeom prst="rect">
+                <a:avLst/>
+              </a:prstGeom>
+              <a:solidFill>
+                <a:schemeClr val="tx2">
+                  <a:lumMod val="10000"/>
+                  <a:lumOff val="90000"/>
+                </a:schemeClr>
+              </a:solidFill>
+              <a:ln>
+                <a:solidFill>
+                  <a:srgbClr val="7030A0"/>
+                </a:solidFill>
+              </a:ln>
+            </p:spPr>
+            <p:style>
+              <a:lnRef idx="2">
+                <a:schemeClr val="accent1">
+                  <a:shade val="15000"/>
+                </a:schemeClr>
+              </a:lnRef>
+              <a:fillRef idx="1">
+                <a:schemeClr val="accent1"/>
+              </a:fillRef>
+              <a:effectRef idx="0">
+                <a:schemeClr val="accent1"/>
+              </a:effectRef>
+              <a:fontRef idx="minor">
+                <a:schemeClr val="lt1"/>
+              </a:fontRef>
+            </p:style>
+            <p:txBody>
+              <a:bodyPr rtlCol="0" anchor="ctr"/>
+              <a:lstStyle/>
+              <a:p>
+                <a:pPr algn="ctr"/>
+                <a:endParaRPr lang="de-DE"/>
+              </a:p>
+            </p:txBody>
+          </p:sp>
+          <p:sp>
+            <p:nvSpPr>
+              <p:cNvPr id="29" name="Textfeld 28">
+                <a:extLst>
+                  <a:ext uri="{FF2B5EF4-FFF2-40B4-BE49-F238E27FC236}">
+                    <a16:creationId xmlns:a16="http://schemas.microsoft.com/office/drawing/2014/main" id="{3610DF32-87F5-5383-6DF3-1DE9594680FB}"/>
+                  </a:ext>
+                </a:extLst>
+              </p:cNvPr>
+              <p:cNvSpPr txBox="1"/>
+              <p:nvPr/>
+            </p:nvSpPr>
+            <p:spPr>
+              <a:xfrm>
+                <a:off x="541429" y="351742"/>
+                <a:ext cx="1247073" cy="369332"/>
+              </a:xfrm>
+              <a:prstGeom prst="rect">
+                <a:avLst/>
+              </a:prstGeom>
+              <a:noFill/>
+            </p:spPr>
+            <p:txBody>
+              <a:bodyPr wrap="none" rtlCol="0">
+                <a:spAutoFit/>
+              </a:bodyPr>
+              <a:lstStyle/>
+              <a:p>
+                <a:r>
+                  <a:rPr lang="de-DE" b="1"/>
+                  <a:t>jap-server</a:t>
+                </a:r>
+              </a:p>
+            </p:txBody>
+          </p:sp>
+          <p:sp>
+            <p:nvSpPr>
+              <p:cNvPr id="53" name="Textfeld 52">
+                <a:extLst>
+                  <a:ext uri="{FF2B5EF4-FFF2-40B4-BE49-F238E27FC236}">
+                    <a16:creationId xmlns:a16="http://schemas.microsoft.com/office/drawing/2014/main" id="{1D7ECD08-4890-EEC5-6F3A-A6FCD2CC016F}"/>
+                  </a:ext>
+                </a:extLst>
+              </p:cNvPr>
+              <p:cNvSpPr txBox="1"/>
+              <p:nvPr/>
+            </p:nvSpPr>
+            <p:spPr>
+              <a:xfrm>
+                <a:off x="1558775" y="855775"/>
+                <a:ext cx="409133" cy="215444"/>
+              </a:xfrm>
+              <a:prstGeom prst="rect">
+                <a:avLst/>
+              </a:prstGeom>
+              <a:solidFill>
+                <a:srgbClr val="FFFF99"/>
+              </a:solidFill>
+              <a:ln>
+                <a:solidFill>
+                  <a:schemeClr val="tx1"/>
+                </a:solidFill>
+              </a:ln>
+            </p:spPr>
+            <p:txBody>
+              <a:bodyPr wrap="none" lIns="72000" tIns="0" rIns="72000" bIns="0" rtlCol="0">
+                <a:spAutoFit/>
+              </a:bodyPr>
+              <a:lstStyle/>
+              <a:p>
+                <a:r>
+                  <a:rPr lang="de-DE" sz="1400" i="1"/>
+                  <a:t>exe</a:t>
+                </a:r>
+              </a:p>
+            </p:txBody>
+          </p:sp>
+        </p:grpSp>
+        <p:grpSp>
+          <p:nvGrpSpPr>
+            <p:cNvPr id="35" name="Gruppieren 34">
+              <a:extLst>
+                <a:ext uri="{FF2B5EF4-FFF2-40B4-BE49-F238E27FC236}">
+                  <a16:creationId xmlns:a16="http://schemas.microsoft.com/office/drawing/2014/main" id="{AF4BA5D2-C1EB-D6DF-7D31-767359EF3A5F}"/>
+                </a:ext>
+              </a:extLst>
+            </p:cNvPr>
+            <p:cNvGrpSpPr/>
+            <p:nvPr/>
+          </p:nvGrpSpPr>
+          <p:grpSpPr>
+            <a:xfrm>
+              <a:off x="7389405" y="3049876"/>
+              <a:ext cx="1485126" cy="791538"/>
+              <a:chOff x="482782" y="1498463"/>
+              <a:chExt cx="1485126" cy="791538"/>
+            </a:xfrm>
+          </p:grpSpPr>
+          <p:sp>
+            <p:nvSpPr>
+              <p:cNvPr id="31" name="Rechteck 30">
+                <a:extLst>
+                  <a:ext uri="{FF2B5EF4-FFF2-40B4-BE49-F238E27FC236}">
+                    <a16:creationId xmlns:a16="http://schemas.microsoft.com/office/drawing/2014/main" id="{78C8DC7B-384F-04A5-6923-880D90B4157B}"/>
+                  </a:ext>
+                </a:extLst>
+              </p:cNvPr>
+              <p:cNvSpPr/>
+              <p:nvPr/>
+            </p:nvSpPr>
+            <p:spPr>
+              <a:xfrm>
+                <a:off x="495724" y="1524953"/>
+                <a:ext cx="1472184" cy="765048"/>
+              </a:xfrm>
+              <a:prstGeom prst="rect">
+                <a:avLst/>
+              </a:prstGeom>
+              <a:solidFill>
+                <a:schemeClr val="tx2">
+                  <a:lumMod val="10000"/>
+                  <a:lumOff val="90000"/>
+                </a:schemeClr>
+              </a:solidFill>
+              <a:ln>
+                <a:solidFill>
+                  <a:schemeClr val="tx2">
+                    <a:lumMod val="75000"/>
+                    <a:lumOff val="25000"/>
+                  </a:schemeClr>
+                </a:solidFill>
+              </a:ln>
+            </p:spPr>
+            <p:style>
+              <a:lnRef idx="2">
+                <a:schemeClr val="accent1">
+                  <a:shade val="15000"/>
+                </a:schemeClr>
+              </a:lnRef>
+              <a:fillRef idx="1">
+                <a:schemeClr val="accent1"/>
+              </a:fillRef>
+              <a:effectRef idx="0">
+                <a:schemeClr val="accent1"/>
+              </a:effectRef>
+              <a:fontRef idx="minor">
+                <a:schemeClr val="lt1"/>
+              </a:fontRef>
+            </p:style>
+            <p:txBody>
+              <a:bodyPr rtlCol="0" anchor="ctr"/>
+              <a:lstStyle/>
+              <a:p>
+                <a:pPr algn="ctr"/>
+                <a:endParaRPr lang="de-DE"/>
+              </a:p>
+            </p:txBody>
+          </p:sp>
+          <p:sp>
+            <p:nvSpPr>
+              <p:cNvPr id="32" name="Textfeld 31">
+                <a:extLst>
+                  <a:ext uri="{FF2B5EF4-FFF2-40B4-BE49-F238E27FC236}">
+                    <a16:creationId xmlns:a16="http://schemas.microsoft.com/office/drawing/2014/main" id="{65513305-956F-6658-DBD8-D938D088654B}"/>
+                  </a:ext>
+                </a:extLst>
+              </p:cNvPr>
+              <p:cNvSpPr txBox="1"/>
+              <p:nvPr/>
+            </p:nvSpPr>
+            <p:spPr>
+              <a:xfrm>
+                <a:off x="482782" y="1498463"/>
+                <a:ext cx="1057982" cy="369332"/>
+              </a:xfrm>
+              <a:prstGeom prst="rect">
+                <a:avLst/>
+              </a:prstGeom>
+              <a:noFill/>
+            </p:spPr>
+            <p:txBody>
+              <a:bodyPr wrap="none" rtlCol="0">
+                <a:spAutoFit/>
+              </a:bodyPr>
+              <a:lstStyle/>
+              <a:p>
+                <a:r>
+                  <a:rPr lang="de-DE" b="1">
+                    <a:solidFill>
+                      <a:schemeClr val="tx2">
+                        <a:lumMod val="75000"/>
+                        <a:lumOff val="25000"/>
+                      </a:schemeClr>
+                    </a:solidFill>
+                  </a:rPr>
+                  <a:t>job-host</a:t>
+                </a:r>
+              </a:p>
+            </p:txBody>
+          </p:sp>
+          <p:sp>
+            <p:nvSpPr>
+              <p:cNvPr id="34" name="Textfeld 33">
+                <a:extLst>
+                  <a:ext uri="{FF2B5EF4-FFF2-40B4-BE49-F238E27FC236}">
+                    <a16:creationId xmlns:a16="http://schemas.microsoft.com/office/drawing/2014/main" id="{8E3B4212-D8F9-751B-2BDE-F0766AF188FC}"/>
+                  </a:ext>
+                </a:extLst>
+              </p:cNvPr>
+              <p:cNvSpPr txBox="1"/>
+              <p:nvPr/>
+            </p:nvSpPr>
+            <p:spPr>
+              <a:xfrm>
+                <a:off x="1332488" y="2003766"/>
+                <a:ext cx="580077" cy="215444"/>
+              </a:xfrm>
+              <a:prstGeom prst="rect">
+                <a:avLst/>
+              </a:prstGeom>
+              <a:solidFill>
+                <a:srgbClr val="FFFF99"/>
+              </a:solidFill>
+              <a:ln>
+                <a:solidFill>
+                  <a:schemeClr val="tx1"/>
+                </a:solidFill>
+              </a:ln>
+            </p:spPr>
+            <p:txBody>
+              <a:bodyPr wrap="none" lIns="72000" tIns="0" rIns="72000" bIns="0" rtlCol="0">
+                <a:spAutoFit/>
+              </a:bodyPr>
+              <a:lstStyle/>
+              <a:p>
+                <a:r>
+                  <a:rPr lang="de-DE" sz="1400" i="1"/>
+                  <a:t>nuget</a:t>
+                </a:r>
+              </a:p>
+            </p:txBody>
+          </p:sp>
+        </p:grpSp>
+      </p:grpSp>
+      <p:sp>
+        <p:nvSpPr>
+          <p:cNvPr id="2" name="Textfeld 1">
+            <a:extLst>
+              <a:ext uri="{FF2B5EF4-FFF2-40B4-BE49-F238E27FC236}">
+                <a16:creationId xmlns:a16="http://schemas.microsoft.com/office/drawing/2014/main" id="{519E1644-DBCE-0EF7-8B66-ED2E10EBBA6F}"/>
+              </a:ext>
+            </a:extLst>
+          </p:cNvPr>
+          <p:cNvSpPr txBox="1"/>
+          <p:nvPr/>
+        </p:nvSpPr>
+        <p:spPr>
+          <a:xfrm>
+            <a:off x="4776809" y="517792"/>
+            <a:ext cx="1987275" cy="523220"/>
+          </a:xfrm>
+          <a:prstGeom prst="rect">
+            <a:avLst/>
+          </a:prstGeom>
+          <a:noFill/>
+        </p:spPr>
+        <p:txBody>
+          <a:bodyPr wrap="none" rtlCol="0">
+            <a:spAutoFit/>
+          </a:bodyPr>
+          <a:lstStyle/>
+          <a:p>
+            <a:pPr algn="ctr"/>
+            <a:r>
+              <a:rPr lang="de-DE" sz="2800" b="1"/>
+              <a:t>Die Lösung</a:t>
+            </a:r>
+            <a:endParaRPr lang="de-DE" b="1"/>
+          </a:p>
+        </p:txBody>
+      </p:sp>
+      <p:sp>
+        <p:nvSpPr>
+          <p:cNvPr id="5" name="Textfeld 4">
+            <a:extLst>
+              <a:ext uri="{FF2B5EF4-FFF2-40B4-BE49-F238E27FC236}">
+                <a16:creationId xmlns:a16="http://schemas.microsoft.com/office/drawing/2014/main" id="{31B0DD6C-1959-F561-62A6-4A45090DC6D2}"/>
+              </a:ext>
+            </a:extLst>
+          </p:cNvPr>
+          <p:cNvSpPr txBox="1"/>
+          <p:nvPr/>
+        </p:nvSpPr>
+        <p:spPr>
+          <a:xfrm>
+            <a:off x="2658820" y="3613865"/>
+            <a:ext cx="6675679" cy="646331"/>
+          </a:xfrm>
+          <a:prstGeom prst="rect">
+            <a:avLst/>
+          </a:prstGeom>
+          <a:noFill/>
+        </p:spPr>
+        <p:txBody>
+          <a:bodyPr wrap="square">
+            <a:spAutoFit/>
+          </a:bodyPr>
+          <a:lstStyle/>
+          <a:p>
+            <a:pPr marL="171450" indent="-171450">
+              <a:buFont typeface="Arial" panose="020B0604020202020204" pitchFamily="34" charset="0"/>
+              <a:buChar char="•"/>
+            </a:pPr>
+            <a:r>
+              <a:rPr lang="de-DE" sz="1200"/>
+              <a:t>Trennung in zwei Prozessräume</a:t>
+            </a:r>
+          </a:p>
+          <a:p>
+            <a:pPr marL="171450" indent="-171450">
+              <a:buFont typeface="Arial" panose="020B0604020202020204" pitchFamily="34" charset="0"/>
+              <a:buChar char="•"/>
+            </a:pPr>
+            <a:r>
+              <a:rPr lang="de-DE" sz="1200"/>
+              <a:t>System.IO.Pipes (als Named-Pipes bzw. Unix-Domain-Sockets)</a:t>
+            </a:r>
+          </a:p>
+          <a:p>
+            <a:pPr marL="171450" indent="-171450">
+              <a:buFont typeface="Arial" panose="020B0604020202020204" pitchFamily="34" charset="0"/>
+              <a:buChar char="•"/>
+            </a:pPr>
+            <a:r>
+              <a:rPr lang="de-DE" sz="1200"/>
+              <a:t>Schaffung eines leichtgewichtigen one-to-one-Application-Protocols. (JAP)</a:t>
+            </a:r>
+          </a:p>
+        </p:txBody>
+      </p:sp>
+      <p:sp>
+        <p:nvSpPr>
+          <p:cNvPr id="14" name="Textfeld 13">
+            <a:extLst>
+              <a:ext uri="{FF2B5EF4-FFF2-40B4-BE49-F238E27FC236}">
+                <a16:creationId xmlns:a16="http://schemas.microsoft.com/office/drawing/2014/main" id="{7E5349DD-7736-0A81-1AC6-477997C0DE28}"/>
+              </a:ext>
+            </a:extLst>
+          </p:cNvPr>
+          <p:cNvSpPr txBox="1"/>
+          <p:nvPr/>
+        </p:nvSpPr>
+        <p:spPr>
+          <a:xfrm>
+            <a:off x="2703271" y="4573680"/>
+            <a:ext cx="7719216" cy="1200329"/>
+          </a:xfrm>
+          <a:prstGeom prst="rect">
+            <a:avLst/>
+          </a:prstGeom>
+          <a:noFill/>
+        </p:spPr>
+        <p:txBody>
+          <a:bodyPr wrap="square">
+            <a:spAutoFit/>
+          </a:bodyPr>
+          <a:lstStyle/>
+          <a:p>
+            <a:r>
+              <a:rPr lang="de-DE" sz="1800"/>
+              <a:t>Starke und nachhaltige Entkopplung - nicht nur zur Runtime im Prozessraum:</a:t>
+            </a:r>
+          </a:p>
+          <a:p>
+            <a:endParaRPr lang="de-DE" sz="1800"/>
+          </a:p>
+          <a:p>
+            <a:r>
+              <a:rPr lang="de-DE" sz="1800" b="1"/>
+              <a:t>Zwei logisch, technologisch, architekturell getrennte Domänen</a:t>
+            </a:r>
+          </a:p>
+          <a:p>
+            <a:r>
+              <a:rPr lang="de-DE" sz="1800"/>
+              <a:t>mit einer l</a:t>
+            </a:r>
+            <a:r>
+              <a:rPr lang="de-DE"/>
+              <a:t>eichtgewichtige Kopplung über das JAP-Protokoll.</a:t>
+            </a:r>
+            <a:r>
+              <a:rPr lang="de-DE" sz="1800"/>
+              <a:t> </a:t>
+            </a:r>
+          </a:p>
+        </p:txBody>
+      </p:sp>
+    </p:spTree>
+    <p:extLst>
+      <p:ext uri="{BB962C8B-B14F-4D97-AF65-F5344CB8AC3E}">
+        <p14:creationId xmlns:p14="http://schemas.microsoft.com/office/powerpoint/2010/main" val="497310861"/>
+      </p:ext>
+    </p:extLst>
+  </p:cSld>
+  <p:clrMapOvr>
+    <a:masterClrMapping/>
+  </p:clrMapOvr>
+</p:sld>
+</file>
+
+<file path=ppt/slides/slide3.xml><?xml version="1.0" encoding="utf-8"?>
+<p:sld xmlns:a="http://schemas.openxmlformats.org/drawingml/2006/main" xmlns:r="http://schemas.openxmlformats.org/officeDocument/2006/relationships" xmlns:p="http://schemas.openxmlformats.org/presentationml/2006/main">
+  <p:cSld>
+    <p:spTree>
+      <p:nvGrpSpPr>
+        <p:cNvPr id="1" name=""/>
+        <p:cNvGrpSpPr/>
+        <p:nvPr/>
+      </p:nvGrpSpPr>
+      <p:grpSpPr>
+        <a:xfrm>
+          <a:off x="0" y="0"/>
+          <a:ext cx="0" cy="0"/>
+          <a:chOff x="0" y="0"/>
+          <a:chExt cx="0" cy="0"/>
+        </a:xfrm>
+      </p:grpSpPr>
+      <p:pic>
+        <p:nvPicPr>
+          <p:cNvPr id="10" name="Grafik 9">
+            <a:extLst>
+              <a:ext uri="{FF2B5EF4-FFF2-40B4-BE49-F238E27FC236}">
+                <a16:creationId xmlns:a16="http://schemas.microsoft.com/office/drawing/2014/main" id="{A615FBEC-2241-E2B6-FA16-C690E728082A}"/>
+              </a:ext>
+            </a:extLst>
+          </p:cNvPr>
+          <p:cNvPicPr>
+            <a:picLocks noChangeAspect="1"/>
+          </p:cNvPicPr>
+          <p:nvPr/>
+        </p:nvPicPr>
+        <p:blipFill>
+          <a:blip r:embed="rId2"/>
+          <a:stretch>
+            <a:fillRect/>
+          </a:stretch>
+        </p:blipFill>
+        <p:spPr>
+          <a:xfrm>
+            <a:off x="2488078" y="283037"/>
+            <a:ext cx="7368244" cy="6146337"/>
+          </a:xfrm>
+          <a:prstGeom prst="rect">
+            <a:avLst/>
+          </a:prstGeom>
+        </p:spPr>
+      </p:pic>
+    </p:spTree>
+    <p:extLst>
+      <p:ext uri="{BB962C8B-B14F-4D97-AF65-F5344CB8AC3E}">
+        <p14:creationId xmlns:p14="http://schemas.microsoft.com/office/powerpoint/2010/main" val="3565579817"/>
+      </p:ext>
+    </p:extLst>
+  </p:cSld>
+  <p:clrMapOvr>
+    <a:masterClrMapping/>
+  </p:clrMapOvr>
+</p:sld>
+</file>
+
+<file path=ppt/slides/slide4.xml><?xml version="1.0" encoding="utf-8"?>
 <p:sld xmlns:a="http://schemas.openxmlformats.org/drawingml/2006/main" xmlns:r="http://schemas.openxmlformats.org/officeDocument/2006/relationships" xmlns:p="http://schemas.openxmlformats.org/presentationml/2006/main">
   <p:cSld>
     <p:spTree>
@@ -6822,7 +9235,7 @@
 </p:sld>
 </file>
 
-<file path=ppt/slides/slide3.xml><?xml version="1.0" encoding="utf-8"?>
+<file path=ppt/slides/slide5.xml><?xml version="1.0" encoding="utf-8"?>
 <p:sld xmlns:a="http://schemas.openxmlformats.org/drawingml/2006/main" xmlns:r="http://schemas.openxmlformats.org/officeDocument/2006/relationships" xmlns:p="http://schemas.openxmlformats.org/presentationml/2006/main">
   <p:cSld>
     <p:spTree>
@@ -6887,7 +9300,7 @@
 </p:sld>
 </file>
 
-<file path=ppt/slides/slide4.xml><?xml version="1.0" encoding="utf-8"?>
+<file path=ppt/slides/slide6.xml><?xml version="1.0" encoding="utf-8"?>
 <p:sld xmlns:a="http://schemas.openxmlformats.org/drawingml/2006/main" xmlns:r="http://schemas.openxmlformats.org/officeDocument/2006/relationships" xmlns:p="http://schemas.openxmlformats.org/presentationml/2006/main">
   <p:cSld>
     <p:spTree>
@@ -7065,485 +9478,6 @@
     <p:extLst>
       <p:ext uri="{BB962C8B-B14F-4D97-AF65-F5344CB8AC3E}">
         <p14:creationId xmlns:p14="http://schemas.microsoft.com/office/powerpoint/2010/main" val="3651167949"/>
-      </p:ext>
-    </p:extLst>
-  </p:cSld>
-  <p:clrMapOvr>
-    <a:masterClrMapping/>
-  </p:clrMapOvr>
-</p:sld>
-</file>
-
-<file path=ppt/slides/slide5.xml><?xml version="1.0" encoding="utf-8"?>
-<p:sld xmlns:a="http://schemas.openxmlformats.org/drawingml/2006/main" xmlns:r="http://schemas.openxmlformats.org/officeDocument/2006/relationships" xmlns:p="http://schemas.openxmlformats.org/presentationml/2006/main">
-  <p:cSld>
-    <p:spTree>
-      <p:nvGrpSpPr>
-        <p:cNvPr id="1" name=""/>
-        <p:cNvGrpSpPr/>
-        <p:nvPr/>
-      </p:nvGrpSpPr>
-      <p:grpSpPr>
-        <a:xfrm>
-          <a:off x="0" y="0"/>
-          <a:ext cx="0" cy="0"/>
-          <a:chOff x="0" y="0"/>
-          <a:chExt cx="0" cy="0"/>
-        </a:xfrm>
-      </p:grpSpPr>
-      <p:sp>
-        <p:nvSpPr>
-          <p:cNvPr id="5" name="Textfeld 4">
-            <a:extLst>
-              <a:ext uri="{FF2B5EF4-FFF2-40B4-BE49-F238E27FC236}">
-                <a16:creationId xmlns:a16="http://schemas.microsoft.com/office/drawing/2014/main" id="{2C80B424-DBC0-1283-17AB-A58174836B2D}"/>
-              </a:ext>
-            </a:extLst>
-          </p:cNvPr>
-          <p:cNvSpPr txBox="1"/>
-          <p:nvPr/>
-        </p:nvSpPr>
-        <p:spPr>
-          <a:xfrm>
-            <a:off x="1362075" y="1108919"/>
-            <a:ext cx="4848225" cy="4801314"/>
-          </a:xfrm>
-          <a:prstGeom prst="rect">
-            <a:avLst/>
-          </a:prstGeom>
-          <a:noFill/>
-        </p:spPr>
-        <p:txBody>
-          <a:bodyPr wrap="square">
-            <a:spAutoFit/>
-          </a:bodyPr>
-          <a:lstStyle/>
-          <a:p>
-            <a:endParaRPr lang="de-DE"/>
-          </a:p>
-          <a:p>
-            <a:r>
-              <a:rPr lang="de-DE"/>
-              <a:t>storage-realm</a:t>
-            </a:r>
-          </a:p>
-          <a:p>
-            <a:r>
-              <a:rPr lang="de-DE"/>
-              <a:t>	Db</a:t>
-            </a:r>
-          </a:p>
-          <a:p>
-            <a:r>
-              <a:rPr lang="de-DE"/>
-              <a:t>	josyn-backend-session-store</a:t>
-            </a:r>
-          </a:p>
-          <a:p>
-            <a:r>
-              <a:rPr lang="de-DE"/>
-              <a:t>	josyn-backend-config-store</a:t>
-            </a:r>
-          </a:p>
-          <a:p>
-            <a:r>
-              <a:rPr lang="de-DE"/>
-              <a:t>	josyn-backend-job-registry</a:t>
-            </a:r>
-          </a:p>
-          <a:p>
-            <a:r>
-              <a:rPr lang="de-DE"/>
-              <a:t>	josyn-backend-error-handler</a:t>
-            </a:r>
-          </a:p>
-          <a:p>
-            <a:endParaRPr lang="de-DE"/>
-          </a:p>
-          <a:p>
-            <a:r>
-              <a:rPr lang="de-DE"/>
-              <a:t>contoso</a:t>
-            </a:r>
-          </a:p>
-          <a:p>
-            <a:r>
-              <a:rPr lang="de-DE"/>
-              <a:t>	josyn-backend-adapter-contracts</a:t>
-            </a:r>
-          </a:p>
-          <a:p>
-            <a:endParaRPr lang="de-DE"/>
-          </a:p>
-          <a:p>
-            <a:r>
-              <a:rPr lang="de-DE"/>
-              <a:t>boostrap</a:t>
-            </a:r>
-          </a:p>
-          <a:p>
-            <a:r>
-              <a:rPr lang="de-DE"/>
-              <a:t>	josyn-backend-bootstrap-config</a:t>
-            </a:r>
-          </a:p>
-          <a:p>
-            <a:endParaRPr lang="de-DE"/>
-          </a:p>
-          <a:p>
-            <a:r>
-              <a:rPr lang="de-DE"/>
-              <a:t>Special-guest</a:t>
-            </a:r>
-          </a:p>
-          <a:p>
-            <a:r>
-              <a:rPr lang="de-DE"/>
-              <a:t>	josyn-backend-jap-server</a:t>
-            </a:r>
-          </a:p>
-          <a:p>
-            <a:endParaRPr lang="de-DE"/>
-          </a:p>
-        </p:txBody>
-      </p:sp>
-      <p:sp>
-        <p:nvSpPr>
-          <p:cNvPr id="6" name="Textfeld 5">
-            <a:extLst>
-              <a:ext uri="{FF2B5EF4-FFF2-40B4-BE49-F238E27FC236}">
-                <a16:creationId xmlns:a16="http://schemas.microsoft.com/office/drawing/2014/main" id="{4F4843BA-15A6-9122-3634-97B03B219E72}"/>
-              </a:ext>
-            </a:extLst>
-          </p:cNvPr>
-          <p:cNvSpPr txBox="1"/>
-          <p:nvPr/>
-        </p:nvSpPr>
-        <p:spPr>
-          <a:xfrm>
-            <a:off x="857250" y="533400"/>
-            <a:ext cx="1195392" cy="369332"/>
-          </a:xfrm>
-          <a:prstGeom prst="rect">
-            <a:avLst/>
-          </a:prstGeom>
-          <a:noFill/>
-        </p:spPr>
-        <p:txBody>
-          <a:bodyPr wrap="none" rtlCol="0">
-            <a:spAutoFit/>
-          </a:bodyPr>
-          <a:lstStyle/>
-          <a:p>
-            <a:r>
-              <a:rPr lang="de-DE"/>
-              <a:t>BACKEND</a:t>
-            </a:r>
-          </a:p>
-        </p:txBody>
-      </p:sp>
-      <p:sp>
-        <p:nvSpPr>
-          <p:cNvPr id="8" name="Textfeld 7">
-            <a:extLst>
-              <a:ext uri="{FF2B5EF4-FFF2-40B4-BE49-F238E27FC236}">
-                <a16:creationId xmlns:a16="http://schemas.microsoft.com/office/drawing/2014/main" id="{00D7F217-43D6-4BBB-A171-E90D94B87D1B}"/>
-              </a:ext>
-            </a:extLst>
-          </p:cNvPr>
-          <p:cNvSpPr txBox="1"/>
-          <p:nvPr/>
-        </p:nvSpPr>
-        <p:spPr>
-          <a:xfrm>
-            <a:off x="6591300" y="2570113"/>
-            <a:ext cx="4448175" cy="2031325"/>
-          </a:xfrm>
-          <a:prstGeom prst="rect">
-            <a:avLst/>
-          </a:prstGeom>
-          <a:noFill/>
-        </p:spPr>
-        <p:txBody>
-          <a:bodyPr wrap="square">
-            <a:spAutoFit/>
-          </a:bodyPr>
-          <a:lstStyle/>
-          <a:p>
-            <a:r>
-              <a:rPr lang="de-DE"/>
-              <a:t>3 Exen</a:t>
-            </a:r>
-          </a:p>
-          <a:p>
-            <a:r>
-              <a:rPr lang="de-DE"/>
-              <a:t>	josyn-backend-cli</a:t>
-            </a:r>
-          </a:p>
-          <a:p>
-            <a:r>
-              <a:rPr lang="de-DE"/>
-              <a:t>	josyn-backend-listener</a:t>
-            </a:r>
-          </a:p>
-          <a:p>
-            <a:r>
-              <a:rPr lang="de-DE"/>
-              <a:t>	josyn-backend-ticker</a:t>
-            </a:r>
-          </a:p>
-          <a:p>
-            <a:endParaRPr lang="de-DE"/>
-          </a:p>
-          <a:p>
-            <a:r>
-              <a:rPr lang="de-DE"/>
-              <a:t>Für die 3 Exen</a:t>
-            </a:r>
-          </a:p>
-          <a:p>
-            <a:r>
-              <a:rPr lang="de-DE"/>
-              <a:t>	josyn-backend-session-starter</a:t>
-            </a:r>
-          </a:p>
-        </p:txBody>
-      </p:sp>
-    </p:spTree>
-    <p:extLst>
-      <p:ext uri="{BB962C8B-B14F-4D97-AF65-F5344CB8AC3E}">
-        <p14:creationId xmlns:p14="http://schemas.microsoft.com/office/powerpoint/2010/main" val="3691293951"/>
-      </p:ext>
-    </p:extLst>
-  </p:cSld>
-  <p:clrMapOvr>
-    <a:masterClrMapping/>
-  </p:clrMapOvr>
-</p:sld>
-</file>
-
-<file path=ppt/slides/slide6.xml><?xml version="1.0" encoding="utf-8"?>
-<p:sld xmlns:a="http://schemas.openxmlformats.org/drawingml/2006/main" xmlns:r="http://schemas.openxmlformats.org/officeDocument/2006/relationships" xmlns:p="http://schemas.openxmlformats.org/presentationml/2006/main">
-  <p:cSld>
-    <p:spTree>
-      <p:nvGrpSpPr>
-        <p:cNvPr id="1" name=""/>
-        <p:cNvGrpSpPr/>
-        <p:nvPr/>
-      </p:nvGrpSpPr>
-      <p:grpSpPr>
-        <a:xfrm>
-          <a:off x="0" y="0"/>
-          <a:ext cx="0" cy="0"/>
-          <a:chOff x="0" y="0"/>
-          <a:chExt cx="0" cy="0"/>
-        </a:xfrm>
-      </p:grpSpPr>
-      <p:sp>
-        <p:nvSpPr>
-          <p:cNvPr id="6" name="Textfeld 5">
-            <a:extLst>
-              <a:ext uri="{FF2B5EF4-FFF2-40B4-BE49-F238E27FC236}">
-                <a16:creationId xmlns:a16="http://schemas.microsoft.com/office/drawing/2014/main" id="{1378A166-C683-26B2-2B8B-EB6C9821C42E}"/>
-              </a:ext>
-            </a:extLst>
-          </p:cNvPr>
-          <p:cNvSpPr txBox="1"/>
-          <p:nvPr/>
-        </p:nvSpPr>
-        <p:spPr>
-          <a:xfrm>
-            <a:off x="657225" y="723900"/>
-            <a:ext cx="4355744" cy="523220"/>
-          </a:xfrm>
-          <a:prstGeom prst="rect">
-            <a:avLst/>
-          </a:prstGeom>
-          <a:noFill/>
-        </p:spPr>
-        <p:txBody>
-          <a:bodyPr wrap="none" rtlCol="0">
-            <a:spAutoFit/>
-          </a:bodyPr>
-          <a:lstStyle/>
-          <a:p>
-            <a:r>
-              <a:rPr lang="de-DE" sz="2800" b="1"/>
-              <a:t>Jap-Server Dependencies</a:t>
-            </a:r>
-          </a:p>
-        </p:txBody>
-      </p:sp>
-      <p:sp>
-        <p:nvSpPr>
-          <p:cNvPr id="10" name="Textfeld 9">
-            <a:extLst>
-              <a:ext uri="{FF2B5EF4-FFF2-40B4-BE49-F238E27FC236}">
-                <a16:creationId xmlns:a16="http://schemas.microsoft.com/office/drawing/2014/main" id="{8ABCE4CD-01B1-8E57-EF8F-03E4359F6E56}"/>
-              </a:ext>
-            </a:extLst>
-          </p:cNvPr>
-          <p:cNvSpPr txBox="1"/>
-          <p:nvPr/>
-        </p:nvSpPr>
-        <p:spPr>
-          <a:xfrm>
-            <a:off x="3357562" y="1170176"/>
-            <a:ext cx="6748463" cy="3416320"/>
-          </a:xfrm>
-          <a:prstGeom prst="rect">
-            <a:avLst/>
-          </a:prstGeom>
-          <a:noFill/>
-        </p:spPr>
-        <p:txBody>
-          <a:bodyPr wrap="square">
-            <a:spAutoFit/>
-          </a:bodyPr>
-          <a:lstStyle/>
-          <a:p>
-            <a:endParaRPr lang="de-DE" sz="1200"/>
-          </a:p>
-          <a:p>
-            <a:r>
-              <a:rPr lang="de-DE" sz="1200"/>
-              <a:t>&lt;PackageReference Include="JOSYN.Foundation.JIP"             Version="1.0.0-preview01"/&gt;</a:t>
-            </a:r>
-          </a:p>
-          <a:p>
-            <a:r>
-              <a:rPr lang="de-DE" sz="1200"/>
-              <a:t>&lt;PackageReference Include="JOSYN.Foundation.PropertyBag"     Version="1.0.0-preview01"/&gt;</a:t>
-            </a:r>
-          </a:p>
-          <a:p>
-            <a:r>
-              <a:rPr lang="de-DE" sz="1200"/>
-              <a:t>&lt;PackageReference Include="JOSYN.Foundation.ResultPattern"   Version="1.0.0-preview01"/&gt;</a:t>
-            </a:r>
-          </a:p>
-          <a:p>
-            <a:endParaRPr lang="de-DE" sz="1200"/>
-          </a:p>
-          <a:p>
-            <a:r>
-              <a:rPr lang="de-DE" sz="1200"/>
-              <a:t>&lt;PackageReference Include="JOSYN.Jap.Contract"        Version="1.0.0-preview01"/&gt;</a:t>
-            </a:r>
-          </a:p>
-          <a:p>
-            <a:endParaRPr lang="de-DE" sz="1200"/>
-          </a:p>
-          <a:p>
-            <a:r>
-              <a:rPr lang="de-DE" sz="1200"/>
-              <a:t>&lt;PackageReference Include="JOSYN.Commons.Log"             Version="1.0.0-preview01"/&gt;</a:t>
-            </a:r>
-          </a:p>
-          <a:p>
-            <a:endParaRPr lang="de-DE" sz="1200"/>
-          </a:p>
-          <a:p>
-            <a:r>
-              <a:rPr lang="de-DE" sz="1200"/>
-              <a:t>----------------------------------------</a:t>
-            </a:r>
-          </a:p>
-          <a:p>
-            <a:endParaRPr lang="de-DE" sz="1200"/>
-          </a:p>
-          <a:p>
-            <a:r>
-              <a:rPr lang="de-DE" sz="1200"/>
-              <a:t>&lt;PackageReference Include="JOSYN.Backend.BootstrapConfig"      Version="1.0.0-preview01"/&gt;</a:t>
-            </a:r>
-          </a:p>
-          <a:p>
-            <a:endParaRPr lang="de-DE" sz="1200"/>
-          </a:p>
-          <a:p>
-            <a:r>
-              <a:rPr lang="de-DE" sz="1200"/>
-              <a:t>&lt;PackageReference Include="JOSYN.Backend.AdapterContracts"  Version="1.0.0-preview01"/&gt;</a:t>
-            </a:r>
-          </a:p>
-          <a:p>
-            <a:endParaRPr lang="de-DE" sz="1200"/>
-          </a:p>
-          <a:p>
-            <a:r>
-              <a:rPr lang="de-DE" sz="1200"/>
-              <a:t>&lt;PackageReference Include="JOSYN.Backend.ConfigStore"        Version="1.0.0-preview01"/&gt;</a:t>
-            </a:r>
-          </a:p>
-          <a:p>
-            <a:r>
-              <a:rPr lang="de-DE" sz="1200"/>
-              <a:t>&lt;PackageReference Include="JOSYN.Backend.ErrorHandler"       Version="1.0.0-preview01"/&gt;</a:t>
-            </a:r>
-          </a:p>
-          <a:p>
-            <a:r>
-              <a:rPr lang="de-DE" sz="1200"/>
-              <a:t>&lt;PackageReference Include="JOSYN.Backend.SessionStore"       Version="1.0.0-preview01"/&gt;</a:t>
-            </a:r>
-          </a:p>
-        </p:txBody>
-      </p:sp>
-      <p:sp>
-        <p:nvSpPr>
-          <p:cNvPr id="12" name="Textfeld 11">
-            <a:extLst>
-              <a:ext uri="{FF2B5EF4-FFF2-40B4-BE49-F238E27FC236}">
-                <a16:creationId xmlns:a16="http://schemas.microsoft.com/office/drawing/2014/main" id="{7DAB8E91-0B3C-2429-8C9C-5356A1CD3995}"/>
-              </a:ext>
-            </a:extLst>
-          </p:cNvPr>
-          <p:cNvSpPr txBox="1"/>
-          <p:nvPr/>
-        </p:nvSpPr>
-        <p:spPr>
-          <a:xfrm>
-            <a:off x="819150" y="5041493"/>
-            <a:ext cx="6096000" cy="646331"/>
-          </a:xfrm>
-          <a:prstGeom prst="rect">
-            <a:avLst/>
-          </a:prstGeom>
-          <a:noFill/>
-        </p:spPr>
-        <p:txBody>
-          <a:bodyPr wrap="square">
-            <a:spAutoFit/>
-          </a:bodyPr>
-          <a:lstStyle/>
-          <a:p>
-            <a:r>
-              <a:rPr lang="de-DE" sz="1800">
-                <a:solidFill>
-                  <a:srgbClr val="FF0000"/>
-                </a:solidFill>
-              </a:rPr>
-              <a:t>JOSYN.Jap.Shared.Contract</a:t>
-            </a:r>
-          </a:p>
-          <a:p>
-            <a:r>
-              <a:rPr lang="de-DE">
-                <a:solidFill>
-                  <a:srgbClr val="FF0000"/>
-                </a:solidFill>
-              </a:rPr>
-              <a:t>Shared im Namen ist überflüssig?</a:t>
-            </a:r>
-          </a:p>
-        </p:txBody>
-      </p:sp>
-    </p:spTree>
-    <p:extLst>
-      <p:ext uri="{BB962C8B-B14F-4D97-AF65-F5344CB8AC3E}">
-        <p14:creationId xmlns:p14="http://schemas.microsoft.com/office/powerpoint/2010/main" val="2906729512"/>
       </p:ext>
     </p:extLst>
   </p:cSld>
@@ -7572,6 +9506,485 @@
       </p:grpSpPr>
       <p:sp>
         <p:nvSpPr>
+          <p:cNvPr id="5" name="Textfeld 4">
+            <a:extLst>
+              <a:ext uri="{FF2B5EF4-FFF2-40B4-BE49-F238E27FC236}">
+                <a16:creationId xmlns:a16="http://schemas.microsoft.com/office/drawing/2014/main" id="{2C80B424-DBC0-1283-17AB-A58174836B2D}"/>
+              </a:ext>
+            </a:extLst>
+          </p:cNvPr>
+          <p:cNvSpPr txBox="1"/>
+          <p:nvPr/>
+        </p:nvSpPr>
+        <p:spPr>
+          <a:xfrm>
+            <a:off x="1362075" y="1108919"/>
+            <a:ext cx="4848225" cy="4801314"/>
+          </a:xfrm>
+          <a:prstGeom prst="rect">
+            <a:avLst/>
+          </a:prstGeom>
+          <a:noFill/>
+        </p:spPr>
+        <p:txBody>
+          <a:bodyPr wrap="square">
+            <a:spAutoFit/>
+          </a:bodyPr>
+          <a:lstStyle/>
+          <a:p>
+            <a:endParaRPr lang="de-DE"/>
+          </a:p>
+          <a:p>
+            <a:r>
+              <a:rPr lang="de-DE"/>
+              <a:t>storage-realm</a:t>
+            </a:r>
+          </a:p>
+          <a:p>
+            <a:r>
+              <a:rPr lang="de-DE"/>
+              <a:t>	Db</a:t>
+            </a:r>
+          </a:p>
+          <a:p>
+            <a:r>
+              <a:rPr lang="de-DE"/>
+              <a:t>	josyn-backend-session-store</a:t>
+            </a:r>
+          </a:p>
+          <a:p>
+            <a:r>
+              <a:rPr lang="de-DE"/>
+              <a:t>	josyn-backend-config-store</a:t>
+            </a:r>
+          </a:p>
+          <a:p>
+            <a:r>
+              <a:rPr lang="de-DE"/>
+              <a:t>	josyn-backend-job-registry</a:t>
+            </a:r>
+          </a:p>
+          <a:p>
+            <a:r>
+              <a:rPr lang="de-DE"/>
+              <a:t>	josyn-backend-error-handler</a:t>
+            </a:r>
+          </a:p>
+          <a:p>
+            <a:endParaRPr lang="de-DE"/>
+          </a:p>
+          <a:p>
+            <a:r>
+              <a:rPr lang="de-DE"/>
+              <a:t>contoso</a:t>
+            </a:r>
+          </a:p>
+          <a:p>
+            <a:r>
+              <a:rPr lang="de-DE"/>
+              <a:t>	josyn-backend-adapter-contracts</a:t>
+            </a:r>
+          </a:p>
+          <a:p>
+            <a:endParaRPr lang="de-DE"/>
+          </a:p>
+          <a:p>
+            <a:r>
+              <a:rPr lang="de-DE"/>
+              <a:t>boostrap</a:t>
+            </a:r>
+          </a:p>
+          <a:p>
+            <a:r>
+              <a:rPr lang="de-DE"/>
+              <a:t>	josyn-backend-bootstrap-config</a:t>
+            </a:r>
+          </a:p>
+          <a:p>
+            <a:endParaRPr lang="de-DE"/>
+          </a:p>
+          <a:p>
+            <a:r>
+              <a:rPr lang="de-DE"/>
+              <a:t>Special-guest</a:t>
+            </a:r>
+          </a:p>
+          <a:p>
+            <a:r>
+              <a:rPr lang="de-DE"/>
+              <a:t>	josyn-backend-jap-server</a:t>
+            </a:r>
+          </a:p>
+          <a:p>
+            <a:endParaRPr lang="de-DE"/>
+          </a:p>
+        </p:txBody>
+      </p:sp>
+      <p:sp>
+        <p:nvSpPr>
+          <p:cNvPr id="6" name="Textfeld 5">
+            <a:extLst>
+              <a:ext uri="{FF2B5EF4-FFF2-40B4-BE49-F238E27FC236}">
+                <a16:creationId xmlns:a16="http://schemas.microsoft.com/office/drawing/2014/main" id="{4F4843BA-15A6-9122-3634-97B03B219E72}"/>
+              </a:ext>
+            </a:extLst>
+          </p:cNvPr>
+          <p:cNvSpPr txBox="1"/>
+          <p:nvPr/>
+        </p:nvSpPr>
+        <p:spPr>
+          <a:xfrm>
+            <a:off x="857250" y="533400"/>
+            <a:ext cx="1195392" cy="369332"/>
+          </a:xfrm>
+          <a:prstGeom prst="rect">
+            <a:avLst/>
+          </a:prstGeom>
+          <a:noFill/>
+        </p:spPr>
+        <p:txBody>
+          <a:bodyPr wrap="none" rtlCol="0">
+            <a:spAutoFit/>
+          </a:bodyPr>
+          <a:lstStyle/>
+          <a:p>
+            <a:r>
+              <a:rPr lang="de-DE"/>
+              <a:t>BACKEND</a:t>
+            </a:r>
+          </a:p>
+        </p:txBody>
+      </p:sp>
+      <p:sp>
+        <p:nvSpPr>
+          <p:cNvPr id="8" name="Textfeld 7">
+            <a:extLst>
+              <a:ext uri="{FF2B5EF4-FFF2-40B4-BE49-F238E27FC236}">
+                <a16:creationId xmlns:a16="http://schemas.microsoft.com/office/drawing/2014/main" id="{00D7F217-43D6-4BBB-A171-E90D94B87D1B}"/>
+              </a:ext>
+            </a:extLst>
+          </p:cNvPr>
+          <p:cNvSpPr txBox="1"/>
+          <p:nvPr/>
+        </p:nvSpPr>
+        <p:spPr>
+          <a:xfrm>
+            <a:off x="6591300" y="2570113"/>
+            <a:ext cx="4448175" cy="2031325"/>
+          </a:xfrm>
+          <a:prstGeom prst="rect">
+            <a:avLst/>
+          </a:prstGeom>
+          <a:noFill/>
+        </p:spPr>
+        <p:txBody>
+          <a:bodyPr wrap="square">
+            <a:spAutoFit/>
+          </a:bodyPr>
+          <a:lstStyle/>
+          <a:p>
+            <a:r>
+              <a:rPr lang="de-DE"/>
+              <a:t>3 Exen</a:t>
+            </a:r>
+          </a:p>
+          <a:p>
+            <a:r>
+              <a:rPr lang="de-DE"/>
+              <a:t>	josyn-backend-cli</a:t>
+            </a:r>
+          </a:p>
+          <a:p>
+            <a:r>
+              <a:rPr lang="de-DE"/>
+              <a:t>	josyn-backend-listener</a:t>
+            </a:r>
+          </a:p>
+          <a:p>
+            <a:r>
+              <a:rPr lang="de-DE"/>
+              <a:t>	josyn-backend-ticker</a:t>
+            </a:r>
+          </a:p>
+          <a:p>
+            <a:endParaRPr lang="de-DE"/>
+          </a:p>
+          <a:p>
+            <a:r>
+              <a:rPr lang="de-DE"/>
+              <a:t>Für die 3 Exen</a:t>
+            </a:r>
+          </a:p>
+          <a:p>
+            <a:r>
+              <a:rPr lang="de-DE"/>
+              <a:t>	josyn-backend-session-starter</a:t>
+            </a:r>
+          </a:p>
+        </p:txBody>
+      </p:sp>
+    </p:spTree>
+    <p:extLst>
+      <p:ext uri="{BB962C8B-B14F-4D97-AF65-F5344CB8AC3E}">
+        <p14:creationId xmlns:p14="http://schemas.microsoft.com/office/powerpoint/2010/main" val="3691293951"/>
+      </p:ext>
+    </p:extLst>
+  </p:cSld>
+  <p:clrMapOvr>
+    <a:masterClrMapping/>
+  </p:clrMapOvr>
+</p:sld>
+</file>
+
+<file path=ppt/slides/slide8.xml><?xml version="1.0" encoding="utf-8"?>
+<p:sld xmlns:a="http://schemas.openxmlformats.org/drawingml/2006/main" xmlns:r="http://schemas.openxmlformats.org/officeDocument/2006/relationships" xmlns:p="http://schemas.openxmlformats.org/presentationml/2006/main">
+  <p:cSld>
+    <p:spTree>
+      <p:nvGrpSpPr>
+        <p:cNvPr id="1" name=""/>
+        <p:cNvGrpSpPr/>
+        <p:nvPr/>
+      </p:nvGrpSpPr>
+      <p:grpSpPr>
+        <a:xfrm>
+          <a:off x="0" y="0"/>
+          <a:ext cx="0" cy="0"/>
+          <a:chOff x="0" y="0"/>
+          <a:chExt cx="0" cy="0"/>
+        </a:xfrm>
+      </p:grpSpPr>
+      <p:sp>
+        <p:nvSpPr>
+          <p:cNvPr id="6" name="Textfeld 5">
+            <a:extLst>
+              <a:ext uri="{FF2B5EF4-FFF2-40B4-BE49-F238E27FC236}">
+                <a16:creationId xmlns:a16="http://schemas.microsoft.com/office/drawing/2014/main" id="{1378A166-C683-26B2-2B8B-EB6C9821C42E}"/>
+              </a:ext>
+            </a:extLst>
+          </p:cNvPr>
+          <p:cNvSpPr txBox="1"/>
+          <p:nvPr/>
+        </p:nvSpPr>
+        <p:spPr>
+          <a:xfrm>
+            <a:off x="657225" y="723900"/>
+            <a:ext cx="4355744" cy="523220"/>
+          </a:xfrm>
+          <a:prstGeom prst="rect">
+            <a:avLst/>
+          </a:prstGeom>
+          <a:noFill/>
+        </p:spPr>
+        <p:txBody>
+          <a:bodyPr wrap="none" rtlCol="0">
+            <a:spAutoFit/>
+          </a:bodyPr>
+          <a:lstStyle/>
+          <a:p>
+            <a:r>
+              <a:rPr lang="de-DE" sz="2800" b="1"/>
+              <a:t>Jap-Server Dependencies</a:t>
+            </a:r>
+          </a:p>
+        </p:txBody>
+      </p:sp>
+      <p:sp>
+        <p:nvSpPr>
+          <p:cNvPr id="10" name="Textfeld 9">
+            <a:extLst>
+              <a:ext uri="{FF2B5EF4-FFF2-40B4-BE49-F238E27FC236}">
+                <a16:creationId xmlns:a16="http://schemas.microsoft.com/office/drawing/2014/main" id="{8ABCE4CD-01B1-8E57-EF8F-03E4359F6E56}"/>
+              </a:ext>
+            </a:extLst>
+          </p:cNvPr>
+          <p:cNvSpPr txBox="1"/>
+          <p:nvPr/>
+        </p:nvSpPr>
+        <p:spPr>
+          <a:xfrm>
+            <a:off x="3357562" y="1170176"/>
+            <a:ext cx="6748463" cy="3416320"/>
+          </a:xfrm>
+          <a:prstGeom prst="rect">
+            <a:avLst/>
+          </a:prstGeom>
+          <a:noFill/>
+        </p:spPr>
+        <p:txBody>
+          <a:bodyPr wrap="square">
+            <a:spAutoFit/>
+          </a:bodyPr>
+          <a:lstStyle/>
+          <a:p>
+            <a:endParaRPr lang="de-DE" sz="1200"/>
+          </a:p>
+          <a:p>
+            <a:r>
+              <a:rPr lang="de-DE" sz="1200"/>
+              <a:t>&lt;PackageReference Include="JOSYN.Foundation.JIP"             Version="1.0.0-preview01"/&gt;</a:t>
+            </a:r>
+          </a:p>
+          <a:p>
+            <a:r>
+              <a:rPr lang="de-DE" sz="1200"/>
+              <a:t>&lt;PackageReference Include="JOSYN.Foundation.PropertyBag"     Version="1.0.0-preview01"/&gt;</a:t>
+            </a:r>
+          </a:p>
+          <a:p>
+            <a:r>
+              <a:rPr lang="de-DE" sz="1200"/>
+              <a:t>&lt;PackageReference Include="JOSYN.Foundation.ResultPattern"   Version="1.0.0-preview01"/&gt;</a:t>
+            </a:r>
+          </a:p>
+          <a:p>
+            <a:endParaRPr lang="de-DE" sz="1200"/>
+          </a:p>
+          <a:p>
+            <a:r>
+              <a:rPr lang="de-DE" sz="1200"/>
+              <a:t>&lt;PackageReference Include="JOSYN.Jap.Contract"        Version="1.0.0-preview01"/&gt;</a:t>
+            </a:r>
+          </a:p>
+          <a:p>
+            <a:endParaRPr lang="de-DE" sz="1200"/>
+          </a:p>
+          <a:p>
+            <a:r>
+              <a:rPr lang="de-DE" sz="1200"/>
+              <a:t>&lt;PackageReference Include="JOSYN.Commons.Log"             Version="1.0.0-preview01"/&gt;</a:t>
+            </a:r>
+          </a:p>
+          <a:p>
+            <a:endParaRPr lang="de-DE" sz="1200"/>
+          </a:p>
+          <a:p>
+            <a:r>
+              <a:rPr lang="de-DE" sz="1200"/>
+              <a:t>----------------------------------------</a:t>
+            </a:r>
+          </a:p>
+          <a:p>
+            <a:endParaRPr lang="de-DE" sz="1200"/>
+          </a:p>
+          <a:p>
+            <a:r>
+              <a:rPr lang="de-DE" sz="1200"/>
+              <a:t>&lt;PackageReference Include="JOSYN.Backend.BootstrapConfig"      Version="1.0.0-preview01"/&gt;</a:t>
+            </a:r>
+          </a:p>
+          <a:p>
+            <a:endParaRPr lang="de-DE" sz="1200"/>
+          </a:p>
+          <a:p>
+            <a:r>
+              <a:rPr lang="de-DE" sz="1200"/>
+              <a:t>&lt;PackageReference Include="JOSYN.Backend.AdapterContracts"  Version="1.0.0-preview01"/&gt;</a:t>
+            </a:r>
+          </a:p>
+          <a:p>
+            <a:endParaRPr lang="de-DE" sz="1200"/>
+          </a:p>
+          <a:p>
+            <a:r>
+              <a:rPr lang="de-DE" sz="1200"/>
+              <a:t>&lt;PackageReference Include="JOSYN.Backend.ConfigStore"        Version="1.0.0-preview01"/&gt;</a:t>
+            </a:r>
+          </a:p>
+          <a:p>
+            <a:r>
+              <a:rPr lang="de-DE" sz="1200"/>
+              <a:t>&lt;PackageReference Include="JOSYN.Backend.ErrorHandler"       Version="1.0.0-preview01"/&gt;</a:t>
+            </a:r>
+          </a:p>
+          <a:p>
+            <a:r>
+              <a:rPr lang="de-DE" sz="1200"/>
+              <a:t>&lt;PackageReference Include="JOSYN.Backend.SessionStore"       Version="1.0.0-preview01"/&gt;</a:t>
+            </a:r>
+          </a:p>
+        </p:txBody>
+      </p:sp>
+      <p:sp>
+        <p:nvSpPr>
+          <p:cNvPr id="12" name="Textfeld 11">
+            <a:extLst>
+              <a:ext uri="{FF2B5EF4-FFF2-40B4-BE49-F238E27FC236}">
+                <a16:creationId xmlns:a16="http://schemas.microsoft.com/office/drawing/2014/main" id="{7DAB8E91-0B3C-2429-8C9C-5356A1CD3995}"/>
+              </a:ext>
+            </a:extLst>
+          </p:cNvPr>
+          <p:cNvSpPr txBox="1"/>
+          <p:nvPr/>
+        </p:nvSpPr>
+        <p:spPr>
+          <a:xfrm>
+            <a:off x="819150" y="5041493"/>
+            <a:ext cx="6096000" cy="646331"/>
+          </a:xfrm>
+          <a:prstGeom prst="rect">
+            <a:avLst/>
+          </a:prstGeom>
+          <a:noFill/>
+        </p:spPr>
+        <p:txBody>
+          <a:bodyPr wrap="square">
+            <a:spAutoFit/>
+          </a:bodyPr>
+          <a:lstStyle/>
+          <a:p>
+            <a:r>
+              <a:rPr lang="de-DE" sz="1800">
+                <a:solidFill>
+                  <a:srgbClr val="FF0000"/>
+                </a:solidFill>
+              </a:rPr>
+              <a:t>JOSYN.Jap.Shared.Contract</a:t>
+            </a:r>
+          </a:p>
+          <a:p>
+            <a:r>
+              <a:rPr lang="de-DE">
+                <a:solidFill>
+                  <a:srgbClr val="FF0000"/>
+                </a:solidFill>
+              </a:rPr>
+              <a:t>Shared im Namen ist überflüssig?</a:t>
+            </a:r>
+          </a:p>
+        </p:txBody>
+      </p:sp>
+    </p:spTree>
+    <p:extLst>
+      <p:ext uri="{BB962C8B-B14F-4D97-AF65-F5344CB8AC3E}">
+        <p14:creationId xmlns:p14="http://schemas.microsoft.com/office/powerpoint/2010/main" val="2906729512"/>
+      </p:ext>
+    </p:extLst>
+  </p:cSld>
+  <p:clrMapOvr>
+    <a:masterClrMapping/>
+  </p:clrMapOvr>
+</p:sld>
+</file>
+
+<file path=ppt/slides/slide9.xml><?xml version="1.0" encoding="utf-8"?>
+<p:sld xmlns:a="http://schemas.openxmlformats.org/drawingml/2006/main" xmlns:r="http://schemas.openxmlformats.org/officeDocument/2006/relationships" xmlns:p="http://schemas.openxmlformats.org/presentationml/2006/main">
+  <p:cSld>
+    <p:spTree>
+      <p:nvGrpSpPr>
+        <p:cNvPr id="1" name=""/>
+        <p:cNvGrpSpPr/>
+        <p:nvPr/>
+      </p:nvGrpSpPr>
+      <p:grpSpPr>
+        <a:xfrm>
+          <a:off x="0" y="0"/>
+          <a:ext cx="0" cy="0"/>
+          <a:chOff x="0" y="0"/>
+          <a:chExt cx="0" cy="0"/>
+        </a:xfrm>
+      </p:grpSpPr>
+      <p:sp>
+        <p:nvSpPr>
           <p:cNvPr id="4" name="Textfeld 3">
             <a:extLst>
               <a:ext uri="{FF2B5EF4-FFF2-40B4-BE49-F238E27FC236}">
@@ -8072,230 +10485,6 @@
     <p:extLst>
       <p:ext uri="{BB962C8B-B14F-4D97-AF65-F5344CB8AC3E}">
         <p14:creationId xmlns:p14="http://schemas.microsoft.com/office/powerpoint/2010/main" val="2196784917"/>
-      </p:ext>
-    </p:extLst>
-  </p:cSld>
-  <p:clrMapOvr>
-    <a:masterClrMapping/>
-  </p:clrMapOvr>
-</p:sld>
-</file>
-
-<file path=ppt/slides/slide8.xml><?xml version="1.0" encoding="utf-8"?>
-<p:sld xmlns:a="http://schemas.openxmlformats.org/drawingml/2006/main" xmlns:r="http://schemas.openxmlformats.org/officeDocument/2006/relationships" xmlns:p="http://schemas.openxmlformats.org/presentationml/2006/main">
-  <p:cSld>
-    <p:spTree>
-      <p:nvGrpSpPr>
-        <p:cNvPr id="1" name="">
-          <a:extLst>
-            <a:ext uri="{FF2B5EF4-FFF2-40B4-BE49-F238E27FC236}">
-              <a16:creationId xmlns:a16="http://schemas.microsoft.com/office/drawing/2014/main" id="{D0473CBD-2654-7327-F74E-4D7EE4DD1A0B}"/>
-            </a:ext>
-          </a:extLst>
-        </p:cNvPr>
-        <p:cNvGrpSpPr/>
-        <p:nvPr/>
-      </p:nvGrpSpPr>
-      <p:grpSpPr>
-        <a:xfrm>
-          <a:off x="0" y="0"/>
-          <a:ext cx="0" cy="0"/>
-          <a:chOff x="0" y="0"/>
-          <a:chExt cx="0" cy="0"/>
-        </a:xfrm>
-      </p:grpSpPr>
-      <p:sp>
-        <p:nvSpPr>
-          <p:cNvPr id="4" name="Textfeld 3">
-            <a:extLst>
-              <a:ext uri="{FF2B5EF4-FFF2-40B4-BE49-F238E27FC236}">
-                <a16:creationId xmlns:a16="http://schemas.microsoft.com/office/drawing/2014/main" id="{EEB7E298-9FAF-2DCD-50B2-2255FE09FCAF}"/>
-              </a:ext>
-            </a:extLst>
-          </p:cNvPr>
-          <p:cNvSpPr txBox="1"/>
-          <p:nvPr/>
-        </p:nvSpPr>
-        <p:spPr>
-          <a:xfrm>
-            <a:off x="2078535" y="491609"/>
-            <a:ext cx="4804585" cy="3416320"/>
-          </a:xfrm>
-          <a:prstGeom prst="rect">
-            <a:avLst/>
-          </a:prstGeom>
-          <a:noFill/>
-        </p:spPr>
-        <p:txBody>
-          <a:bodyPr wrap="none" rtlCol="0">
-            <a:spAutoFit/>
-          </a:bodyPr>
-          <a:lstStyle/>
-          <a:p>
-            <a:r>
-              <a:rPr lang="de-DE"/>
-              <a:t>TODO</a:t>
-            </a:r>
-          </a:p>
-          <a:p>
-            <a:endParaRPr lang="de-DE"/>
-          </a:p>
-          <a:p>
-            <a:pPr marL="285750" indent="-285750">
-              <a:buFont typeface="Arial" panose="020B0604020202020204" pitchFamily="34" charset="0"/>
-              <a:buChar char="•"/>
-            </a:pPr>
-            <a:r>
-              <a:rPr lang="de-DE"/>
-              <a:t>Backend</a:t>
-            </a:r>
-          </a:p>
-          <a:p>
-            <a:pPr marL="285750" indent="-285750">
-              <a:buFont typeface="Arial" panose="020B0604020202020204" pitchFamily="34" charset="0"/>
-              <a:buChar char="•"/>
-            </a:pPr>
-            <a:r>
-              <a:rPr lang="de-DE"/>
-              <a:t>Company-Fit</a:t>
-            </a:r>
-          </a:p>
-          <a:p>
-            <a:pPr marL="285750" indent="-285750">
-              <a:buFont typeface="Arial" panose="020B0604020202020204" pitchFamily="34" charset="0"/>
-              <a:buChar char="•"/>
-            </a:pPr>
-            <a:r>
-              <a:rPr lang="de-DE"/>
-              <a:t>Offene Fragen</a:t>
-            </a:r>
-          </a:p>
-          <a:p>
-            <a:pPr marL="285750" indent="-285750">
-              <a:buFont typeface="Arial" panose="020B0604020202020204" pitchFamily="34" charset="0"/>
-              <a:buChar char="•"/>
-            </a:pPr>
-            <a:endParaRPr lang="de-DE"/>
-          </a:p>
-          <a:p>
-            <a:pPr marL="285750" indent="-285750">
-              <a:buFont typeface="Arial" panose="020B0604020202020204" pitchFamily="34" charset="0"/>
-              <a:buChar char="•"/>
-            </a:pPr>
-            <a:r>
-              <a:rPr lang="de-DE"/>
-              <a:t>Josyn-guide zurückbauen</a:t>
-            </a:r>
-          </a:p>
-          <a:p>
-            <a:pPr marL="285750" indent="-285750">
-              <a:buFont typeface="Arial" panose="020B0604020202020204" pitchFamily="34" charset="0"/>
-              <a:buChar char="•"/>
-            </a:pPr>
-            <a:r>
-              <a:rPr lang="de-DE"/>
-              <a:t>Gute „AI-Zitate“ einbauen</a:t>
-            </a:r>
-          </a:p>
-          <a:p>
-            <a:pPr marL="285750" indent="-285750">
-              <a:buFont typeface="Arial" panose="020B0604020202020204" pitchFamily="34" charset="0"/>
-              <a:buChar char="•"/>
-            </a:pPr>
-            <a:endParaRPr lang="de-DE"/>
-          </a:p>
-          <a:p>
-            <a:r>
-              <a:rPr lang="de-DE"/>
-              <a:t>Vorher von gitgub-ckluth =&gt; github-hävg!!!!!!!!!!</a:t>
-            </a:r>
-          </a:p>
-          <a:p>
-            <a:pPr marL="285750" indent="-285750">
-              <a:buFont typeface="Arial" panose="020B0604020202020204" pitchFamily="34" charset="0"/>
-              <a:buChar char="•"/>
-            </a:pPr>
-            <a:endParaRPr lang="de-DE"/>
-          </a:p>
-          <a:p>
-            <a:pPr marL="285750" indent="-285750">
-              <a:buFont typeface="Arial" panose="020B0604020202020204" pitchFamily="34" charset="0"/>
-              <a:buChar char="•"/>
-            </a:pPr>
-            <a:endParaRPr lang="de-DE"/>
-          </a:p>
-        </p:txBody>
-      </p:sp>
-    </p:spTree>
-    <p:extLst>
-      <p:ext uri="{BB962C8B-B14F-4D97-AF65-F5344CB8AC3E}">
-        <p14:creationId xmlns:p14="http://schemas.microsoft.com/office/powerpoint/2010/main" val="2811839202"/>
-      </p:ext>
-    </p:extLst>
-  </p:cSld>
-  <p:clrMapOvr>
-    <a:masterClrMapping/>
-  </p:clrMapOvr>
-</p:sld>
-</file>
-
-<file path=ppt/slides/slide9.xml><?xml version="1.0" encoding="utf-8"?>
-<p:sld xmlns:a="http://schemas.openxmlformats.org/drawingml/2006/main" xmlns:r="http://schemas.openxmlformats.org/officeDocument/2006/relationships" xmlns:p="http://schemas.openxmlformats.org/presentationml/2006/main">
-  <p:cSld>
-    <p:spTree>
-      <p:nvGrpSpPr>
-        <p:cNvPr id="1" name="">
-          <a:extLst>
-            <a:ext uri="{FF2B5EF4-FFF2-40B4-BE49-F238E27FC236}">
-              <a16:creationId xmlns:a16="http://schemas.microsoft.com/office/drawing/2014/main" id="{A9DD6CB7-EB88-909D-C082-49E7E1D49225}"/>
-            </a:ext>
-          </a:extLst>
-        </p:cNvPr>
-        <p:cNvGrpSpPr/>
-        <p:nvPr/>
-      </p:nvGrpSpPr>
-      <p:grpSpPr>
-        <a:xfrm>
-          <a:off x="0" y="0"/>
-          <a:ext cx="0" cy="0"/>
-          <a:chOff x="0" y="0"/>
-          <a:chExt cx="0" cy="0"/>
-        </a:xfrm>
-      </p:grpSpPr>
-      <p:pic>
-        <p:nvPicPr>
-          <p:cNvPr id="4" name="Grafik 3">
-            <a:extLst>
-              <a:ext uri="{FF2B5EF4-FFF2-40B4-BE49-F238E27FC236}">
-                <a16:creationId xmlns:a16="http://schemas.microsoft.com/office/drawing/2014/main" id="{BA2A3B80-F6E1-8BA5-5B3F-A9D11EA225D9}"/>
-              </a:ext>
-            </a:extLst>
-          </p:cNvPr>
-          <p:cNvPicPr>
-            <a:picLocks noChangeAspect="1"/>
-          </p:cNvPicPr>
-          <p:nvPr/>
-        </p:nvPicPr>
-        <p:blipFill>
-          <a:blip r:embed="rId2"/>
-          <a:stretch>
-            <a:fillRect/>
-          </a:stretch>
-        </p:blipFill>
-        <p:spPr>
-          <a:xfrm>
-            <a:off x="2371205" y="1576129"/>
-            <a:ext cx="7449590" cy="3705742"/>
-          </a:xfrm>
-          <a:prstGeom prst="rect">
-            <a:avLst/>
-          </a:prstGeom>
-        </p:spPr>
-      </p:pic>
-    </p:spTree>
-    <p:extLst>
-      <p:ext uri="{BB962C8B-B14F-4D97-AF65-F5344CB8AC3E}">
-        <p14:creationId xmlns:p14="http://schemas.microsoft.com/office/powerpoint/2010/main" val="661868491"/>
       </p:ext>
     </p:extLst>
   </p:cSld>

</xml_diff>

<commit_message>
wip: sync [2026-06-11 17:49]
</commit_message>
<xml_diff>
--- a/josyn-intro.pptx
+++ b/josyn-intro.pptx
@@ -5,21 +5,22 @@
     <p:sldMasterId id="2147483648" r:id="rId1"/>
   </p:sldMasterIdLst>
   <p:notesMasterIdLst>
-    <p:notesMasterId r:id="rId14"/>
+    <p:notesMasterId r:id="rId15"/>
   </p:notesMasterIdLst>
   <p:sldIdLst>
     <p:sldId id="260" r:id="rId2"/>
-    <p:sldId id="270" r:id="rId3"/>
-    <p:sldId id="261" r:id="rId4"/>
-    <p:sldId id="259" r:id="rId5"/>
-    <p:sldId id="262" r:id="rId6"/>
-    <p:sldId id="268" r:id="rId7"/>
-    <p:sldId id="265" r:id="rId8"/>
-    <p:sldId id="266" r:id="rId9"/>
-    <p:sldId id="267" r:id="rId10"/>
-    <p:sldId id="264" r:id="rId11"/>
-    <p:sldId id="263" r:id="rId12"/>
-    <p:sldId id="269" r:id="rId13"/>
+    <p:sldId id="271" r:id="rId3"/>
+    <p:sldId id="270" r:id="rId4"/>
+    <p:sldId id="261" r:id="rId5"/>
+    <p:sldId id="259" r:id="rId6"/>
+    <p:sldId id="262" r:id="rId7"/>
+    <p:sldId id="268" r:id="rId8"/>
+    <p:sldId id="265" r:id="rId9"/>
+    <p:sldId id="266" r:id="rId10"/>
+    <p:sldId id="267" r:id="rId11"/>
+    <p:sldId id="264" r:id="rId12"/>
+    <p:sldId id="263" r:id="rId13"/>
+    <p:sldId id="269" r:id="rId14"/>
   </p:sldIdLst>
   <p:sldSz cx="12192000" cy="6858000"/>
   <p:notesSz cx="6858000" cy="9144000"/>
@@ -540,7 +541,7 @@
           <a:p>
             <a:fld id="{274F3282-AC7F-4F04-970A-9596745FD581}" type="slidenum">
               <a:rPr lang="de-DE" smtClean="0"/>
-              <a:t>4</a:t>
+              <a:t>5</a:t>
             </a:fld>
             <a:endParaRPr lang="de-DE"/>
           </a:p>
@@ -4924,6 +4925,534 @@
   <p:cSld>
     <p:spTree>
       <p:nvGrpSpPr>
+        <p:cNvPr id="1" name=""/>
+        <p:cNvGrpSpPr/>
+        <p:nvPr/>
+      </p:nvGrpSpPr>
+      <p:grpSpPr>
+        <a:xfrm>
+          <a:off x="0" y="0"/>
+          <a:ext cx="0" cy="0"/>
+          <a:chOff x="0" y="0"/>
+          <a:chExt cx="0" cy="0"/>
+        </a:xfrm>
+      </p:grpSpPr>
+      <p:sp>
+        <p:nvSpPr>
+          <p:cNvPr id="4" name="Textfeld 3">
+            <a:extLst>
+              <a:ext uri="{FF2B5EF4-FFF2-40B4-BE49-F238E27FC236}">
+                <a16:creationId xmlns:a16="http://schemas.microsoft.com/office/drawing/2014/main" id="{4F5483BE-BCC0-D8A1-F472-C90B8F7469A1}"/>
+              </a:ext>
+            </a:extLst>
+          </p:cNvPr>
+          <p:cNvSpPr txBox="1"/>
+          <p:nvPr/>
+        </p:nvSpPr>
+        <p:spPr>
+          <a:xfrm>
+            <a:off x="511332" y="346026"/>
+            <a:ext cx="3532634" cy="2308324"/>
+          </a:xfrm>
+          <a:prstGeom prst="rect">
+            <a:avLst/>
+          </a:prstGeom>
+          <a:noFill/>
+        </p:spPr>
+        <p:txBody>
+          <a:bodyPr wrap="none" rtlCol="0">
+            <a:spAutoFit/>
+          </a:bodyPr>
+          <a:lstStyle/>
+          <a:p>
+            <a:r>
+              <a:rPr lang="de-DE" b="1"/>
+              <a:t>round-trip</a:t>
+            </a:r>
+          </a:p>
+          <a:p>
+            <a:endParaRPr lang="de-DE"/>
+          </a:p>
+          <a:p>
+            <a:r>
+              <a:rPr lang="de-DE"/>
+              <a:t>	live zeigen</a:t>
+            </a:r>
+          </a:p>
+          <a:p>
+            <a:endParaRPr lang="de-DE"/>
+          </a:p>
+          <a:p>
+            <a:r>
+              <a:rPr lang="de-DE"/>
+              <a:t>	a-spawns-b  diagram(s)  </a:t>
+            </a:r>
+          </a:p>
+          <a:p>
+            <a:r>
+              <a:rPr lang="de-DE"/>
+              <a:t> </a:t>
+            </a:r>
+          </a:p>
+          <a:p>
+            <a:endParaRPr lang="de-DE"/>
+          </a:p>
+          <a:p>
+            <a:endParaRPr lang="de-DE"/>
+          </a:p>
+        </p:txBody>
+      </p:sp>
+      <p:sp>
+        <p:nvSpPr>
+          <p:cNvPr id="5" name="Textfeld 4">
+            <a:extLst>
+              <a:ext uri="{FF2B5EF4-FFF2-40B4-BE49-F238E27FC236}">
+                <a16:creationId xmlns:a16="http://schemas.microsoft.com/office/drawing/2014/main" id="{0ADD3679-4C9F-5B5C-F563-34CFEFC1BB9A}"/>
+              </a:ext>
+            </a:extLst>
+          </p:cNvPr>
+          <p:cNvSpPr txBox="1"/>
+          <p:nvPr/>
+        </p:nvSpPr>
+        <p:spPr>
+          <a:xfrm>
+            <a:off x="7560174" y="367010"/>
+            <a:ext cx="4017831" cy="5909310"/>
+          </a:xfrm>
+          <a:prstGeom prst="rect">
+            <a:avLst/>
+          </a:prstGeom>
+          <a:noFill/>
+        </p:spPr>
+        <p:txBody>
+          <a:bodyPr wrap="none" rtlCol="0">
+            <a:spAutoFit/>
+          </a:bodyPr>
+          <a:lstStyle/>
+          <a:p>
+            <a:endParaRPr lang="de-DE"/>
+          </a:p>
+          <a:p>
+            <a:r>
+              <a:rPr lang="de-DE"/>
+              <a:t>-------------</a:t>
+            </a:r>
+          </a:p>
+          <a:p>
+            <a:endParaRPr lang="de-DE"/>
+          </a:p>
+          <a:p>
+            <a:r>
+              <a:rPr lang="de-DE" b="1"/>
+              <a:t>error-routing</a:t>
+            </a:r>
+          </a:p>
+          <a:p>
+            <a:endParaRPr lang="de-DE"/>
+          </a:p>
+          <a:p>
+            <a:r>
+              <a:rPr lang="de-DE"/>
+              <a:t>---------</a:t>
+            </a:r>
+          </a:p>
+          <a:p>
+            <a:endParaRPr lang="de-DE"/>
+          </a:p>
+          <a:p>
+            <a:r>
+              <a:rPr lang="de-DE" b="1"/>
+              <a:t>company-fit</a:t>
+            </a:r>
+          </a:p>
+          <a:p>
+            <a:r>
+              <a:rPr lang="de-DE"/>
+              <a:t>	contoso</a:t>
+            </a:r>
+          </a:p>
+          <a:p>
+            <a:r>
+              <a:rPr lang="de-DE"/>
+              <a:t>	Governance</a:t>
+            </a:r>
+          </a:p>
+          <a:p>
+            <a:r>
+              <a:rPr lang="de-DE"/>
+              <a:t>	hävg-dev-process</a:t>
+            </a:r>
+          </a:p>
+          <a:p>
+            <a:r>
+              <a:rPr lang="de-DE"/>
+              <a:t>	Pipeline-ready</a:t>
+            </a:r>
+          </a:p>
+          <a:p>
+            <a:r>
+              <a:rPr lang="de-DE"/>
+              <a:t>	evolution: docker/lniux</a:t>
+            </a:r>
+          </a:p>
+          <a:p>
+            <a:r>
+              <a:rPr lang="de-DE"/>
+              <a:t>	migration!</a:t>
+            </a:r>
+          </a:p>
+          <a:p>
+            <a:r>
+              <a:rPr lang="de-DE"/>
+              <a:t>	tpm-story</a:t>
+            </a:r>
+          </a:p>
+          <a:p>
+            <a:r>
+              <a:rPr lang="de-DE"/>
+              <a:t>	project?</a:t>
+            </a:r>
+          </a:p>
+          <a:p>
+            <a:r>
+              <a:rPr lang="de-DE"/>
+              <a:t>	entscheidungen</a:t>
+            </a:r>
+          </a:p>
+          <a:p>
+            <a:r>
+              <a:rPr lang="de-DE"/>
+              <a:t>	people</a:t>
+            </a:r>
+          </a:p>
+          <a:p>
+            <a:endParaRPr lang="de-DE"/>
+          </a:p>
+          <a:p>
+            <a:r>
+              <a:rPr lang="de-DE"/>
+              <a:t>josyn als domain-agnostisches system</a:t>
+            </a:r>
+          </a:p>
+          <a:p>
+            <a:r>
+              <a:rPr lang="de-DE"/>
+              <a:t>Josyn als teil der domäne</a:t>
+            </a:r>
+          </a:p>
+        </p:txBody>
+      </p:sp>
+      <p:sp>
+        <p:nvSpPr>
+          <p:cNvPr id="6" name="Textfeld 5">
+            <a:extLst>
+              <a:ext uri="{FF2B5EF4-FFF2-40B4-BE49-F238E27FC236}">
+                <a16:creationId xmlns:a16="http://schemas.microsoft.com/office/drawing/2014/main" id="{7D516507-CF40-55A8-65B1-B3768EBC5AC5}"/>
+              </a:ext>
+            </a:extLst>
+          </p:cNvPr>
+          <p:cNvSpPr txBox="1"/>
+          <p:nvPr/>
+        </p:nvSpPr>
+        <p:spPr>
+          <a:xfrm>
+            <a:off x="752475" y="4400550"/>
+            <a:ext cx="5848524" cy="923330"/>
+          </a:xfrm>
+          <a:prstGeom prst="rect">
+            <a:avLst/>
+          </a:prstGeom>
+          <a:noFill/>
+        </p:spPr>
+        <p:txBody>
+          <a:bodyPr wrap="none" rtlCol="0">
+            <a:spAutoFit/>
+          </a:bodyPr>
+          <a:lstStyle/>
+          <a:p>
+            <a:r>
+              <a:rPr lang="de-DE" b="1"/>
+              <a:t>einleitung</a:t>
+            </a:r>
+          </a:p>
+          <a:p>
+            <a:r>
+              <a:rPr lang="de-DE"/>
+              <a:t>	kurz die core-flaws des alten systems erwähnen</a:t>
+            </a:r>
+          </a:p>
+          <a:p>
+            <a:r>
+              <a:rPr lang="de-DE"/>
+              <a:t>	Ai zitieren</a:t>
+            </a:r>
+          </a:p>
+        </p:txBody>
+      </p:sp>
+      <p:sp>
+        <p:nvSpPr>
+          <p:cNvPr id="7" name="Textfeld 6">
+            <a:extLst>
+              <a:ext uri="{FF2B5EF4-FFF2-40B4-BE49-F238E27FC236}">
+                <a16:creationId xmlns:a16="http://schemas.microsoft.com/office/drawing/2014/main" id="{1D9146EC-A86F-4C5E-21C9-6FED7F4C3F1C}"/>
+              </a:ext>
+            </a:extLst>
+          </p:cNvPr>
+          <p:cNvSpPr txBox="1"/>
+          <p:nvPr/>
+        </p:nvSpPr>
+        <p:spPr>
+          <a:xfrm>
+            <a:off x="3831983" y="2754481"/>
+            <a:ext cx="3707682" cy="1477328"/>
+          </a:xfrm>
+          <a:prstGeom prst="rect">
+            <a:avLst/>
+          </a:prstGeom>
+          <a:noFill/>
+        </p:spPr>
+        <p:txBody>
+          <a:bodyPr wrap="none" rtlCol="0">
+            <a:spAutoFit/>
+          </a:bodyPr>
+          <a:lstStyle/>
+          <a:p>
+            <a:r>
+              <a:rPr lang="de-DE" b="1"/>
+              <a:t>die anderen repos</a:t>
+            </a:r>
+          </a:p>
+          <a:p>
+            <a:r>
+              <a:rPr lang="de-DE"/>
+              <a:t>	Platform / ai /sanity-check</a:t>
+            </a:r>
+          </a:p>
+          <a:p>
+            <a:r>
+              <a:rPr lang="de-DE"/>
+              <a:t>	Tooling</a:t>
+            </a:r>
+          </a:p>
+          <a:p>
+            <a:r>
+              <a:rPr lang="de-DE"/>
+              <a:t>	Playground</a:t>
+            </a:r>
+          </a:p>
+          <a:p>
+            <a:r>
+              <a:rPr lang="de-DE"/>
+              <a:t>	docs</a:t>
+            </a:r>
+          </a:p>
+        </p:txBody>
+      </p:sp>
+      <p:sp>
+        <p:nvSpPr>
+          <p:cNvPr id="8" name="Textfeld 7">
+            <a:extLst>
+              <a:ext uri="{FF2B5EF4-FFF2-40B4-BE49-F238E27FC236}">
+                <a16:creationId xmlns:a16="http://schemas.microsoft.com/office/drawing/2014/main" id="{BC52FF86-D522-2513-C318-9F6B99D33531}"/>
+              </a:ext>
+            </a:extLst>
+          </p:cNvPr>
+          <p:cNvSpPr txBox="1"/>
+          <p:nvPr/>
+        </p:nvSpPr>
+        <p:spPr>
+          <a:xfrm>
+            <a:off x="3966505" y="5664101"/>
+            <a:ext cx="2739340" cy="923330"/>
+          </a:xfrm>
+          <a:prstGeom prst="rect">
+            <a:avLst/>
+          </a:prstGeom>
+          <a:noFill/>
+        </p:spPr>
+        <p:txBody>
+          <a:bodyPr wrap="none" rtlCol="0">
+            <a:spAutoFit/>
+          </a:bodyPr>
+          <a:lstStyle/>
+          <a:p>
+            <a:r>
+              <a:rPr lang="de-DE" b="1"/>
+              <a:t>urls zur vefügung stellen</a:t>
+            </a:r>
+          </a:p>
+          <a:p>
+            <a:r>
+              <a:rPr lang="de-DE"/>
+              <a:t>	ckluth/github</a:t>
+            </a:r>
+          </a:p>
+          <a:p>
+            <a:r>
+              <a:rPr lang="de-DE"/>
+              <a:t>	</a:t>
+            </a:r>
+          </a:p>
+        </p:txBody>
+      </p:sp>
+      <p:sp>
+        <p:nvSpPr>
+          <p:cNvPr id="3" name="Textfeld 2">
+            <a:extLst>
+              <a:ext uri="{FF2B5EF4-FFF2-40B4-BE49-F238E27FC236}">
+                <a16:creationId xmlns:a16="http://schemas.microsoft.com/office/drawing/2014/main" id="{29C18F3B-60AA-F446-2720-EE185F5A41E4}"/>
+              </a:ext>
+            </a:extLst>
+          </p:cNvPr>
+          <p:cNvSpPr txBox="1"/>
+          <p:nvPr/>
+        </p:nvSpPr>
+        <p:spPr>
+          <a:xfrm>
+            <a:off x="4268169" y="367010"/>
+            <a:ext cx="3552999" cy="646331"/>
+          </a:xfrm>
+          <a:prstGeom prst="rect">
+            <a:avLst/>
+          </a:prstGeom>
+          <a:noFill/>
+        </p:spPr>
+        <p:txBody>
+          <a:bodyPr wrap="square">
+            <a:spAutoFit/>
+          </a:bodyPr>
+          <a:lstStyle/>
+          <a:p>
+            <a:r>
+              <a:rPr lang="de-DE" b="1"/>
+              <a:t>storgae-realm</a:t>
+            </a:r>
+            <a:r>
+              <a:rPr lang="de-DE"/>
+              <a:t> / db</a:t>
+            </a:r>
+          </a:p>
+          <a:p>
+            <a:endParaRPr lang="de-DE"/>
+          </a:p>
+        </p:txBody>
+      </p:sp>
+      <p:sp>
+        <p:nvSpPr>
+          <p:cNvPr id="9" name="Textfeld 8">
+            <a:extLst>
+              <a:ext uri="{FF2B5EF4-FFF2-40B4-BE49-F238E27FC236}">
+                <a16:creationId xmlns:a16="http://schemas.microsoft.com/office/drawing/2014/main" id="{F94EA407-9AED-2092-C6FC-7B7B9FA446E2}"/>
+              </a:ext>
+            </a:extLst>
+          </p:cNvPr>
+          <p:cNvSpPr txBox="1"/>
+          <p:nvPr/>
+        </p:nvSpPr>
+        <p:spPr>
+          <a:xfrm>
+            <a:off x="1316872" y="2495550"/>
+            <a:ext cx="1709571" cy="1477328"/>
+          </a:xfrm>
+          <a:prstGeom prst="rect">
+            <a:avLst/>
+          </a:prstGeom>
+          <a:noFill/>
+        </p:spPr>
+        <p:txBody>
+          <a:bodyPr wrap="none" rtlCol="0">
+            <a:spAutoFit/>
+          </a:bodyPr>
+          <a:lstStyle/>
+          <a:p>
+            <a:r>
+              <a:rPr lang="de-DE" b="1"/>
+              <a:t>principles</a:t>
+            </a:r>
+          </a:p>
+          <a:p>
+            <a:pPr lvl="1"/>
+            <a:r>
+              <a:rPr lang="de-DE"/>
+              <a:t>NRT</a:t>
+            </a:r>
+          </a:p>
+          <a:p>
+            <a:pPr lvl="1"/>
+            <a:r>
+              <a:rPr lang="de-DE"/>
+              <a:t>RP-Usage</a:t>
+            </a:r>
+          </a:p>
+          <a:p>
+            <a:pPr lvl="1"/>
+            <a:r>
+              <a:rPr lang="de-DE"/>
+              <a:t>Functional</a:t>
+            </a:r>
+          </a:p>
+          <a:p>
+            <a:pPr lvl="1"/>
+            <a:r>
+              <a:rPr lang="de-DE"/>
+              <a:t>Contracts</a:t>
+            </a:r>
+          </a:p>
+        </p:txBody>
+      </p:sp>
+      <p:sp>
+        <p:nvSpPr>
+          <p:cNvPr id="11" name="Textfeld 10">
+            <a:extLst>
+              <a:ext uri="{FF2B5EF4-FFF2-40B4-BE49-F238E27FC236}">
+                <a16:creationId xmlns:a16="http://schemas.microsoft.com/office/drawing/2014/main" id="{BD489293-44C7-2752-5AF2-8256A73E879E}"/>
+              </a:ext>
+            </a:extLst>
+          </p:cNvPr>
+          <p:cNvSpPr txBox="1"/>
+          <p:nvPr/>
+        </p:nvSpPr>
+        <p:spPr>
+          <a:xfrm>
+            <a:off x="4268343" y="1782946"/>
+            <a:ext cx="2704131" cy="369332"/>
+          </a:xfrm>
+          <a:prstGeom prst="rect">
+            <a:avLst/>
+          </a:prstGeom>
+          <a:noFill/>
+        </p:spPr>
+        <p:txBody>
+          <a:bodyPr wrap="square">
+            <a:spAutoFit/>
+          </a:bodyPr>
+          <a:lstStyle/>
+          <a:p>
+            <a:r>
+              <a:rPr lang="de-DE" b="1"/>
+              <a:t>deployment / bootsrip</a:t>
+            </a:r>
+          </a:p>
+        </p:txBody>
+      </p:sp>
+    </p:spTree>
+    <p:extLst>
+      <p:ext uri="{BB962C8B-B14F-4D97-AF65-F5344CB8AC3E}">
+        <p14:creationId xmlns:p14="http://schemas.microsoft.com/office/powerpoint/2010/main" val="2196784917"/>
+      </p:ext>
+    </p:extLst>
+  </p:cSld>
+  <p:clrMapOvr>
+    <a:masterClrMapping/>
+  </p:clrMapOvr>
+</p:sld>
+</file>
+
+<file path=ppt/slides/slide11.xml><?xml version="1.0" encoding="utf-8"?>
+<p:sld xmlns:a="http://schemas.openxmlformats.org/drawingml/2006/main" xmlns:r="http://schemas.openxmlformats.org/officeDocument/2006/relationships" xmlns:p="http://schemas.openxmlformats.org/presentationml/2006/main">
+  <p:cSld>
+    <p:spTree>
+      <p:nvGrpSpPr>
         <p:cNvPr id="1" name="">
           <a:extLst>
             <a:ext uri="{FF2B5EF4-FFF2-40B4-BE49-F238E27FC236}">
@@ -5077,7 +5606,7 @@
 </p:sld>
 </file>
 
-<file path=ppt/slides/slide11.xml><?xml version="1.0" encoding="utf-8"?>
+<file path=ppt/slides/slide12.xml><?xml version="1.0" encoding="utf-8"?>
 <p:sld xmlns:a="http://schemas.openxmlformats.org/drawingml/2006/main" xmlns:r="http://schemas.openxmlformats.org/officeDocument/2006/relationships" xmlns:p="http://schemas.openxmlformats.org/presentationml/2006/main">
   <p:cSld>
     <p:spTree>
@@ -5143,7 +5672,7 @@
 </p:sld>
 </file>
 
-<file path=ppt/slides/slide12.xml><?xml version="1.0" encoding="utf-8"?>
+<file path=ppt/slides/slide13.xml><?xml version="1.0" encoding="utf-8"?>
 <p:sld xmlns:a="http://schemas.openxmlformats.org/drawingml/2006/main" xmlns:r="http://schemas.openxmlformats.org/officeDocument/2006/relationships" xmlns:p="http://schemas.openxmlformats.org/presentationml/2006/main">
   <p:cSld>
     <p:spTree>
@@ -7134,6 +7663,208 @@
 </file>
 
 <file path=ppt/slides/slide2.xml><?xml version="1.0" encoding="utf-8"?>
+<p:sld xmlns:a="http://schemas.openxmlformats.org/drawingml/2006/main" xmlns:r="http://schemas.openxmlformats.org/officeDocument/2006/relationships" xmlns:p="http://schemas.openxmlformats.org/presentationml/2006/main">
+  <p:cSld>
+    <p:spTree>
+      <p:nvGrpSpPr>
+        <p:cNvPr id="1" name=""/>
+        <p:cNvGrpSpPr/>
+        <p:nvPr/>
+      </p:nvGrpSpPr>
+      <p:grpSpPr>
+        <a:xfrm>
+          <a:off x="0" y="0"/>
+          <a:ext cx="0" cy="0"/>
+          <a:chOff x="0" y="0"/>
+          <a:chExt cx="0" cy="0"/>
+        </a:xfrm>
+      </p:grpSpPr>
+      <p:sp>
+        <p:nvSpPr>
+          <p:cNvPr id="5" name="Textfeld 4">
+            <a:extLst>
+              <a:ext uri="{FF2B5EF4-FFF2-40B4-BE49-F238E27FC236}">
+                <a16:creationId xmlns:a16="http://schemas.microsoft.com/office/drawing/2014/main" id="{C0AA4FAB-0D79-E663-08EC-77AEA5A3925C}"/>
+              </a:ext>
+            </a:extLst>
+          </p:cNvPr>
+          <p:cNvSpPr txBox="1"/>
+          <p:nvPr/>
+        </p:nvSpPr>
+        <p:spPr>
+          <a:xfrm>
+            <a:off x="1539875" y="915402"/>
+            <a:ext cx="9480550" cy="4616648"/>
+          </a:xfrm>
+          <a:prstGeom prst="rect">
+            <a:avLst/>
+          </a:prstGeom>
+          <a:noFill/>
+        </p:spPr>
+        <p:txBody>
+          <a:bodyPr wrap="square">
+            <a:spAutoFit/>
+          </a:bodyPr>
+          <a:lstStyle/>
+          <a:p>
+            <a:r>
+              <a:rPr lang="de-DE" sz="2400" b="1"/>
+              <a:t>some more flaws…</a:t>
+            </a:r>
+          </a:p>
+          <a:p>
+            <a:endParaRPr lang="de-DE"/>
+          </a:p>
+          <a:p>
+            <a:pPr marL="285750" indent="-285750">
+              <a:buFont typeface="Arial" panose="020B0604020202020204" pitchFamily="34" charset="0"/>
+              <a:buChar char="•"/>
+            </a:pPr>
+            <a:r>
+              <a:rPr lang="de-DE"/>
+              <a:t>.Net48 / .Net10 gedoppelted Codebase</a:t>
+            </a:r>
+          </a:p>
+          <a:p>
+            <a:pPr marL="285750" indent="-285750">
+              <a:buFont typeface="Arial" panose="020B0604020202020204" pitchFamily="34" charset="0"/>
+              <a:buChar char="•"/>
+            </a:pPr>
+            <a:r>
+              <a:rPr lang="de-DE"/>
+              <a:t>.Net48 </a:t>
+            </a:r>
+            <a:r>
+              <a:rPr lang="de-DE" b="1"/>
+              <a:t>WCF-Server</a:t>
+            </a:r>
+          </a:p>
+          <a:p>
+            <a:pPr marL="285750" indent="-285750">
+              <a:buFont typeface="Arial" panose="020B0604020202020204" pitchFamily="34" charset="0"/>
+              <a:buChar char="•"/>
+            </a:pPr>
+            <a:r>
+              <a:rPr lang="de-DE"/>
+              <a:t>Codedom! nagelt auf .Net48 fest</a:t>
+            </a:r>
+          </a:p>
+          <a:p>
+            <a:pPr marL="285750" indent="-285750">
+              <a:buFont typeface="Arial" panose="020B0604020202020204" pitchFamily="34" charset="0"/>
+              <a:buChar char="•"/>
+            </a:pPr>
+            <a:r>
+              <a:rPr lang="de-DE"/>
+              <a:t>JobEntwicklung wurde mit einem </a:t>
+            </a:r>
+            <a:r>
+              <a:rPr lang="de-DE" i="1"/>
+              <a:t>Hack</a:t>
+            </a:r>
+            <a:r>
+              <a:rPr lang="de-DE"/>
+              <a:t> </a:t>
+            </a:r>
+            <a:r>
+              <a:rPr lang="de-DE" b="1"/>
+              <a:t>pipelinefähig</a:t>
+            </a:r>
+            <a:r>
+              <a:rPr lang="de-DE"/>
+              <a:t> gemacht; mit dem holistischen Gesamtsystem (fettes LINQPad-Script) ist das so nicht möglich…</a:t>
+            </a:r>
+          </a:p>
+          <a:p>
+            <a:pPr marL="285750" indent="-285750">
+              <a:buFont typeface="Arial" panose="020B0604020202020204" pitchFamily="34" charset="0"/>
+              <a:buChar char="•"/>
+            </a:pPr>
+            <a:r>
+              <a:rPr lang="de-DE"/>
+              <a:t>Hohe </a:t>
+            </a:r>
+            <a:r>
+              <a:rPr lang="de-DE" i="1"/>
+              <a:t>Expertenabhängig</a:t>
+            </a:r>
+            <a:r>
+              <a:rPr lang="de-DE"/>
+              <a:t> -&gt; nicht Nachwuchsfähig.</a:t>
+            </a:r>
+          </a:p>
+          <a:p>
+            <a:pPr marL="285750" indent="-285750">
+              <a:buFont typeface="Arial" panose="020B0604020202020204" pitchFamily="34" charset="0"/>
+              <a:buChar char="•"/>
+            </a:pPr>
+            <a:r>
+              <a:rPr lang="de-DE"/>
+              <a:t>Hoher Schulungsaufwand für Job-Entwicklung</a:t>
+            </a:r>
+          </a:p>
+          <a:p>
+            <a:pPr marL="285750" indent="-285750">
+              <a:buFont typeface="Arial" panose="020B0604020202020204" pitchFamily="34" charset="0"/>
+              <a:buChar char="•"/>
+            </a:pPr>
+            <a:r>
+              <a:rPr lang="de-DE"/>
+              <a:t>Sperrige und altmodische, in die Jahre gekommene Job-API (IBasejob)</a:t>
+            </a:r>
+          </a:p>
+          <a:p>
+            <a:pPr marL="285750" indent="-285750">
+              <a:buFont typeface="Arial" panose="020B0604020202020204" pitchFamily="34" charset="0"/>
+              <a:buChar char="•"/>
+            </a:pPr>
+            <a:r>
+              <a:rPr lang="de-DE"/>
+              <a:t>Niemals wirklich AI-fähig!</a:t>
+            </a:r>
+          </a:p>
+          <a:p>
+            <a:pPr marL="285750" indent="-285750">
+              <a:buFont typeface="Arial" panose="020B0604020202020204" pitchFamily="34" charset="0"/>
+              <a:buChar char="•"/>
+            </a:pPr>
+            <a:r>
+              <a:rPr lang="de-DE"/>
+              <a:t>…</a:t>
+            </a:r>
+          </a:p>
+          <a:p>
+            <a:pPr marL="285750" indent="-285750">
+              <a:buFont typeface="Arial" panose="020B0604020202020204" pitchFamily="34" charset="0"/>
+              <a:buChar char="•"/>
+            </a:pPr>
+            <a:endParaRPr lang="de-DE"/>
+          </a:p>
+          <a:p>
+            <a:r>
+              <a:rPr lang="de-DE" sz="3600" b="1"/>
+              <a:t>Fazit: es skaliert nicht mehr…</a:t>
+            </a:r>
+          </a:p>
+          <a:p>
+            <a:endParaRPr lang="de-DE"/>
+          </a:p>
+        </p:txBody>
+      </p:sp>
+    </p:spTree>
+    <p:extLst>
+      <p:ext uri="{BB962C8B-B14F-4D97-AF65-F5344CB8AC3E}">
+        <p14:creationId xmlns:p14="http://schemas.microsoft.com/office/powerpoint/2010/main" val="1464677924"/>
+      </p:ext>
+    </p:extLst>
+  </p:cSld>
+  <p:clrMapOvr>
+    <a:masterClrMapping/>
+  </p:clrMapOvr>
+</p:sld>
+</file>
+
+<file path=ppt/slides/slide3.xml><?xml version="1.0" encoding="utf-8"?>
 <p:sld xmlns:a="http://schemas.openxmlformats.org/drawingml/2006/main" xmlns:r="http://schemas.openxmlformats.org/officeDocument/2006/relationships" xmlns:p="http://schemas.openxmlformats.org/presentationml/2006/main">
   <p:cSld>
     <p:spTree>
@@ -8004,8 +8735,8 @@
         </p:nvSpPr>
         <p:spPr>
           <a:xfrm>
-            <a:off x="4776809" y="517792"/>
-            <a:ext cx="1987275" cy="523220"/>
+            <a:off x="3069873" y="460642"/>
+            <a:ext cx="5401159" cy="523220"/>
           </a:xfrm>
           <a:prstGeom prst="rect">
             <a:avLst/>
@@ -8021,7 +8752,7 @@
             <a:pPr algn="ctr"/>
             <a:r>
               <a:rPr lang="de-DE" sz="2800" b="1"/>
-              <a:t>Die Lösung</a:t>
+              <a:t>Die Lösung für das Kernproblem</a:t>
             </a:r>
             <a:endParaRPr lang="de-DE" b="1"/>
           </a:p>
@@ -8157,7 +8888,7 @@
 </p:sld>
 </file>
 
-<file path=ppt/slides/slide3.xml><?xml version="1.0" encoding="utf-8"?>
+<file path=ppt/slides/slide4.xml><?xml version="1.0" encoding="utf-8"?>
 <p:sld xmlns:a="http://schemas.openxmlformats.org/drawingml/2006/main" xmlns:r="http://schemas.openxmlformats.org/officeDocument/2006/relationships" xmlns:p="http://schemas.openxmlformats.org/presentationml/2006/main">
   <p:cSld>
     <p:spTree>
@@ -8217,7 +8948,7 @@
 </p:sld>
 </file>
 
-<file path=ppt/slides/slide4.xml><?xml version="1.0" encoding="utf-8"?>
+<file path=ppt/slides/slide5.xml><?xml version="1.0" encoding="utf-8"?>
 <p:sld xmlns:a="http://schemas.openxmlformats.org/drawingml/2006/main" xmlns:r="http://schemas.openxmlformats.org/officeDocument/2006/relationships" xmlns:p="http://schemas.openxmlformats.org/presentationml/2006/main">
   <p:cSld>
     <p:spTree>
@@ -9235,7 +9966,7 @@
 </p:sld>
 </file>
 
-<file path=ppt/slides/slide5.xml><?xml version="1.0" encoding="utf-8"?>
+<file path=ppt/slides/slide6.xml><?xml version="1.0" encoding="utf-8"?>
 <p:sld xmlns:a="http://schemas.openxmlformats.org/drawingml/2006/main" xmlns:r="http://schemas.openxmlformats.org/officeDocument/2006/relationships" xmlns:p="http://schemas.openxmlformats.org/presentationml/2006/main">
   <p:cSld>
     <p:spTree>
@@ -9300,7 +10031,7 @@
 </p:sld>
 </file>
 
-<file path=ppt/slides/slide6.xml><?xml version="1.0" encoding="utf-8"?>
+<file path=ppt/slides/slide7.xml><?xml version="1.0" encoding="utf-8"?>
 <p:sld xmlns:a="http://schemas.openxmlformats.org/drawingml/2006/main" xmlns:r="http://schemas.openxmlformats.org/officeDocument/2006/relationships" xmlns:p="http://schemas.openxmlformats.org/presentationml/2006/main">
   <p:cSld>
     <p:spTree>
@@ -9478,255 +10209,6 @@
     <p:extLst>
       <p:ext uri="{BB962C8B-B14F-4D97-AF65-F5344CB8AC3E}">
         <p14:creationId xmlns:p14="http://schemas.microsoft.com/office/powerpoint/2010/main" val="3651167949"/>
-      </p:ext>
-    </p:extLst>
-  </p:cSld>
-  <p:clrMapOvr>
-    <a:masterClrMapping/>
-  </p:clrMapOvr>
-</p:sld>
-</file>
-
-<file path=ppt/slides/slide7.xml><?xml version="1.0" encoding="utf-8"?>
-<p:sld xmlns:a="http://schemas.openxmlformats.org/drawingml/2006/main" xmlns:r="http://schemas.openxmlformats.org/officeDocument/2006/relationships" xmlns:p="http://schemas.openxmlformats.org/presentationml/2006/main">
-  <p:cSld>
-    <p:spTree>
-      <p:nvGrpSpPr>
-        <p:cNvPr id="1" name=""/>
-        <p:cNvGrpSpPr/>
-        <p:nvPr/>
-      </p:nvGrpSpPr>
-      <p:grpSpPr>
-        <a:xfrm>
-          <a:off x="0" y="0"/>
-          <a:ext cx="0" cy="0"/>
-          <a:chOff x="0" y="0"/>
-          <a:chExt cx="0" cy="0"/>
-        </a:xfrm>
-      </p:grpSpPr>
-      <p:sp>
-        <p:nvSpPr>
-          <p:cNvPr id="5" name="Textfeld 4">
-            <a:extLst>
-              <a:ext uri="{FF2B5EF4-FFF2-40B4-BE49-F238E27FC236}">
-                <a16:creationId xmlns:a16="http://schemas.microsoft.com/office/drawing/2014/main" id="{2C80B424-DBC0-1283-17AB-A58174836B2D}"/>
-              </a:ext>
-            </a:extLst>
-          </p:cNvPr>
-          <p:cNvSpPr txBox="1"/>
-          <p:nvPr/>
-        </p:nvSpPr>
-        <p:spPr>
-          <a:xfrm>
-            <a:off x="1362075" y="1108919"/>
-            <a:ext cx="4848225" cy="4801314"/>
-          </a:xfrm>
-          <a:prstGeom prst="rect">
-            <a:avLst/>
-          </a:prstGeom>
-          <a:noFill/>
-        </p:spPr>
-        <p:txBody>
-          <a:bodyPr wrap="square">
-            <a:spAutoFit/>
-          </a:bodyPr>
-          <a:lstStyle/>
-          <a:p>
-            <a:endParaRPr lang="de-DE"/>
-          </a:p>
-          <a:p>
-            <a:r>
-              <a:rPr lang="de-DE"/>
-              <a:t>storage-realm</a:t>
-            </a:r>
-          </a:p>
-          <a:p>
-            <a:r>
-              <a:rPr lang="de-DE"/>
-              <a:t>	Db</a:t>
-            </a:r>
-          </a:p>
-          <a:p>
-            <a:r>
-              <a:rPr lang="de-DE"/>
-              <a:t>	josyn-backend-session-store</a:t>
-            </a:r>
-          </a:p>
-          <a:p>
-            <a:r>
-              <a:rPr lang="de-DE"/>
-              <a:t>	josyn-backend-config-store</a:t>
-            </a:r>
-          </a:p>
-          <a:p>
-            <a:r>
-              <a:rPr lang="de-DE"/>
-              <a:t>	josyn-backend-job-registry</a:t>
-            </a:r>
-          </a:p>
-          <a:p>
-            <a:r>
-              <a:rPr lang="de-DE"/>
-              <a:t>	josyn-backend-error-handler</a:t>
-            </a:r>
-          </a:p>
-          <a:p>
-            <a:endParaRPr lang="de-DE"/>
-          </a:p>
-          <a:p>
-            <a:r>
-              <a:rPr lang="de-DE"/>
-              <a:t>contoso</a:t>
-            </a:r>
-          </a:p>
-          <a:p>
-            <a:r>
-              <a:rPr lang="de-DE"/>
-              <a:t>	josyn-backend-adapter-contracts</a:t>
-            </a:r>
-          </a:p>
-          <a:p>
-            <a:endParaRPr lang="de-DE"/>
-          </a:p>
-          <a:p>
-            <a:r>
-              <a:rPr lang="de-DE"/>
-              <a:t>boostrap</a:t>
-            </a:r>
-          </a:p>
-          <a:p>
-            <a:r>
-              <a:rPr lang="de-DE"/>
-              <a:t>	josyn-backend-bootstrap-config</a:t>
-            </a:r>
-          </a:p>
-          <a:p>
-            <a:endParaRPr lang="de-DE"/>
-          </a:p>
-          <a:p>
-            <a:r>
-              <a:rPr lang="de-DE"/>
-              <a:t>Special-guest</a:t>
-            </a:r>
-          </a:p>
-          <a:p>
-            <a:r>
-              <a:rPr lang="de-DE"/>
-              <a:t>	josyn-backend-jap-server</a:t>
-            </a:r>
-          </a:p>
-          <a:p>
-            <a:endParaRPr lang="de-DE"/>
-          </a:p>
-        </p:txBody>
-      </p:sp>
-      <p:sp>
-        <p:nvSpPr>
-          <p:cNvPr id="6" name="Textfeld 5">
-            <a:extLst>
-              <a:ext uri="{FF2B5EF4-FFF2-40B4-BE49-F238E27FC236}">
-                <a16:creationId xmlns:a16="http://schemas.microsoft.com/office/drawing/2014/main" id="{4F4843BA-15A6-9122-3634-97B03B219E72}"/>
-              </a:ext>
-            </a:extLst>
-          </p:cNvPr>
-          <p:cNvSpPr txBox="1"/>
-          <p:nvPr/>
-        </p:nvSpPr>
-        <p:spPr>
-          <a:xfrm>
-            <a:off x="857250" y="533400"/>
-            <a:ext cx="1195392" cy="369332"/>
-          </a:xfrm>
-          <a:prstGeom prst="rect">
-            <a:avLst/>
-          </a:prstGeom>
-          <a:noFill/>
-        </p:spPr>
-        <p:txBody>
-          <a:bodyPr wrap="none" rtlCol="0">
-            <a:spAutoFit/>
-          </a:bodyPr>
-          <a:lstStyle/>
-          <a:p>
-            <a:r>
-              <a:rPr lang="de-DE"/>
-              <a:t>BACKEND</a:t>
-            </a:r>
-          </a:p>
-        </p:txBody>
-      </p:sp>
-      <p:sp>
-        <p:nvSpPr>
-          <p:cNvPr id="8" name="Textfeld 7">
-            <a:extLst>
-              <a:ext uri="{FF2B5EF4-FFF2-40B4-BE49-F238E27FC236}">
-                <a16:creationId xmlns:a16="http://schemas.microsoft.com/office/drawing/2014/main" id="{00D7F217-43D6-4BBB-A171-E90D94B87D1B}"/>
-              </a:ext>
-            </a:extLst>
-          </p:cNvPr>
-          <p:cNvSpPr txBox="1"/>
-          <p:nvPr/>
-        </p:nvSpPr>
-        <p:spPr>
-          <a:xfrm>
-            <a:off x="6591300" y="2570113"/>
-            <a:ext cx="4448175" cy="2031325"/>
-          </a:xfrm>
-          <a:prstGeom prst="rect">
-            <a:avLst/>
-          </a:prstGeom>
-          <a:noFill/>
-        </p:spPr>
-        <p:txBody>
-          <a:bodyPr wrap="square">
-            <a:spAutoFit/>
-          </a:bodyPr>
-          <a:lstStyle/>
-          <a:p>
-            <a:r>
-              <a:rPr lang="de-DE"/>
-              <a:t>3 Exen</a:t>
-            </a:r>
-          </a:p>
-          <a:p>
-            <a:r>
-              <a:rPr lang="de-DE"/>
-              <a:t>	josyn-backend-cli</a:t>
-            </a:r>
-          </a:p>
-          <a:p>
-            <a:r>
-              <a:rPr lang="de-DE"/>
-              <a:t>	josyn-backend-listener</a:t>
-            </a:r>
-          </a:p>
-          <a:p>
-            <a:r>
-              <a:rPr lang="de-DE"/>
-              <a:t>	josyn-backend-ticker</a:t>
-            </a:r>
-          </a:p>
-          <a:p>
-            <a:endParaRPr lang="de-DE"/>
-          </a:p>
-          <a:p>
-            <a:r>
-              <a:rPr lang="de-DE"/>
-              <a:t>Für die 3 Exen</a:t>
-            </a:r>
-          </a:p>
-          <a:p>
-            <a:r>
-              <a:rPr lang="de-DE"/>
-              <a:t>	josyn-backend-session-starter</a:t>
-            </a:r>
-          </a:p>
-        </p:txBody>
-      </p:sp>
-    </p:spTree>
-    <p:extLst>
-      <p:ext uri="{BB962C8B-B14F-4D97-AF65-F5344CB8AC3E}">
-        <p14:creationId xmlns:p14="http://schemas.microsoft.com/office/powerpoint/2010/main" val="3691293951"/>
       </p:ext>
     </p:extLst>
   </p:cSld>
@@ -9755,10 +10237,10 @@
       </p:grpSpPr>
       <p:sp>
         <p:nvSpPr>
-          <p:cNvPr id="6" name="Textfeld 5">
-            <a:extLst>
-              <a:ext uri="{FF2B5EF4-FFF2-40B4-BE49-F238E27FC236}">
-                <a16:creationId xmlns:a16="http://schemas.microsoft.com/office/drawing/2014/main" id="{1378A166-C683-26B2-2B8B-EB6C9821C42E}"/>
+          <p:cNvPr id="5" name="Textfeld 4">
+            <a:extLst>
+              <a:ext uri="{FF2B5EF4-FFF2-40B4-BE49-F238E27FC236}">
+                <a16:creationId xmlns:a16="http://schemas.microsoft.com/office/drawing/2014/main" id="{2C80B424-DBC0-1283-17AB-A58174836B2D}"/>
               </a:ext>
             </a:extLst>
           </p:cNvPr>
@@ -9767,8 +10249,124 @@
         </p:nvSpPr>
         <p:spPr>
           <a:xfrm>
-            <a:off x="657225" y="723900"/>
-            <a:ext cx="4355744" cy="523220"/>
+            <a:off x="1362075" y="1108919"/>
+            <a:ext cx="4848225" cy="4801314"/>
+          </a:xfrm>
+          <a:prstGeom prst="rect">
+            <a:avLst/>
+          </a:prstGeom>
+          <a:noFill/>
+        </p:spPr>
+        <p:txBody>
+          <a:bodyPr wrap="square">
+            <a:spAutoFit/>
+          </a:bodyPr>
+          <a:lstStyle/>
+          <a:p>
+            <a:endParaRPr lang="de-DE"/>
+          </a:p>
+          <a:p>
+            <a:r>
+              <a:rPr lang="de-DE"/>
+              <a:t>storage-realm</a:t>
+            </a:r>
+          </a:p>
+          <a:p>
+            <a:r>
+              <a:rPr lang="de-DE"/>
+              <a:t>	Db</a:t>
+            </a:r>
+          </a:p>
+          <a:p>
+            <a:r>
+              <a:rPr lang="de-DE"/>
+              <a:t>	josyn-backend-session-store</a:t>
+            </a:r>
+          </a:p>
+          <a:p>
+            <a:r>
+              <a:rPr lang="de-DE"/>
+              <a:t>	josyn-backend-config-store</a:t>
+            </a:r>
+          </a:p>
+          <a:p>
+            <a:r>
+              <a:rPr lang="de-DE"/>
+              <a:t>	josyn-backend-job-registry</a:t>
+            </a:r>
+          </a:p>
+          <a:p>
+            <a:r>
+              <a:rPr lang="de-DE"/>
+              <a:t>	josyn-backend-error-handler</a:t>
+            </a:r>
+          </a:p>
+          <a:p>
+            <a:endParaRPr lang="de-DE"/>
+          </a:p>
+          <a:p>
+            <a:r>
+              <a:rPr lang="de-DE"/>
+              <a:t>contoso</a:t>
+            </a:r>
+          </a:p>
+          <a:p>
+            <a:r>
+              <a:rPr lang="de-DE"/>
+              <a:t>	josyn-backend-adapter-contracts</a:t>
+            </a:r>
+          </a:p>
+          <a:p>
+            <a:endParaRPr lang="de-DE"/>
+          </a:p>
+          <a:p>
+            <a:r>
+              <a:rPr lang="de-DE"/>
+              <a:t>boostrap</a:t>
+            </a:r>
+          </a:p>
+          <a:p>
+            <a:r>
+              <a:rPr lang="de-DE"/>
+              <a:t>	josyn-backend-bootstrap-config</a:t>
+            </a:r>
+          </a:p>
+          <a:p>
+            <a:endParaRPr lang="de-DE"/>
+          </a:p>
+          <a:p>
+            <a:r>
+              <a:rPr lang="de-DE"/>
+              <a:t>Special-guest</a:t>
+            </a:r>
+          </a:p>
+          <a:p>
+            <a:r>
+              <a:rPr lang="de-DE"/>
+              <a:t>	josyn-backend-jap-server</a:t>
+            </a:r>
+          </a:p>
+          <a:p>
+            <a:endParaRPr lang="de-DE"/>
+          </a:p>
+        </p:txBody>
+      </p:sp>
+      <p:sp>
+        <p:nvSpPr>
+          <p:cNvPr id="6" name="Textfeld 5">
+            <a:extLst>
+              <a:ext uri="{FF2B5EF4-FFF2-40B4-BE49-F238E27FC236}">
+                <a16:creationId xmlns:a16="http://schemas.microsoft.com/office/drawing/2014/main" id="{4F4843BA-15A6-9122-3634-97B03B219E72}"/>
+              </a:ext>
+            </a:extLst>
+          </p:cNvPr>
+          <p:cNvSpPr txBox="1"/>
+          <p:nvPr/>
+        </p:nvSpPr>
+        <p:spPr>
+          <a:xfrm>
+            <a:off x="857250" y="533400"/>
+            <a:ext cx="1195392" cy="369332"/>
           </a:xfrm>
           <a:prstGeom prst="rect">
             <a:avLst/>
@@ -9782,18 +10380,18 @@
           <a:lstStyle/>
           <a:p>
             <a:r>
-              <a:rPr lang="de-DE" sz="2800" b="1"/>
-              <a:t>Jap-Server Dependencies</a:t>
+              <a:rPr lang="de-DE"/>
+              <a:t>BACKEND</a:t>
             </a:r>
           </a:p>
         </p:txBody>
       </p:sp>
       <p:sp>
         <p:nvSpPr>
-          <p:cNvPr id="10" name="Textfeld 9">
-            <a:extLst>
-              <a:ext uri="{FF2B5EF4-FFF2-40B4-BE49-F238E27FC236}">
-                <a16:creationId xmlns:a16="http://schemas.microsoft.com/office/drawing/2014/main" id="{8ABCE4CD-01B1-8E57-EF8F-03E4359F6E56}"/>
+          <p:cNvPr id="8" name="Textfeld 7">
+            <a:extLst>
+              <a:ext uri="{FF2B5EF4-FFF2-40B4-BE49-F238E27FC236}">
+                <a16:creationId xmlns:a16="http://schemas.microsoft.com/office/drawing/2014/main" id="{00D7F217-43D6-4BBB-A171-E90D94B87D1B}"/>
               </a:ext>
             </a:extLst>
           </p:cNvPr>
@@ -9802,8 +10400,8 @@
         </p:nvSpPr>
         <p:spPr>
           <a:xfrm>
-            <a:off x="3357562" y="1170176"/>
-            <a:ext cx="6748463" cy="3416320"/>
+            <a:off x="6591300" y="2570113"/>
+            <a:ext cx="4448175" cy="2031325"/>
           </a:xfrm>
           <a:prstGeom prst="rect">
             <a:avLst/>
@@ -9816,139 +10414,42 @@
           </a:bodyPr>
           <a:lstStyle/>
           <a:p>
-            <a:endParaRPr lang="de-DE" sz="1200"/>
-          </a:p>
-          <a:p>
-            <a:r>
-              <a:rPr lang="de-DE" sz="1200"/>
-              <a:t>&lt;PackageReference Include="JOSYN.Foundation.JIP"             Version="1.0.0-preview01"/&gt;</a:t>
-            </a:r>
-          </a:p>
-          <a:p>
-            <a:r>
-              <a:rPr lang="de-DE" sz="1200"/>
-              <a:t>&lt;PackageReference Include="JOSYN.Foundation.PropertyBag"     Version="1.0.0-preview01"/&gt;</a:t>
-            </a:r>
-          </a:p>
-          <a:p>
-            <a:r>
-              <a:rPr lang="de-DE" sz="1200"/>
-              <a:t>&lt;PackageReference Include="JOSYN.Foundation.ResultPattern"   Version="1.0.0-preview01"/&gt;</a:t>
-            </a:r>
-          </a:p>
-          <a:p>
-            <a:endParaRPr lang="de-DE" sz="1200"/>
-          </a:p>
-          <a:p>
-            <a:r>
-              <a:rPr lang="de-DE" sz="1200"/>
-              <a:t>&lt;PackageReference Include="JOSYN.Jap.Contract"        Version="1.0.0-preview01"/&gt;</a:t>
-            </a:r>
-          </a:p>
-          <a:p>
-            <a:endParaRPr lang="de-DE" sz="1200"/>
-          </a:p>
-          <a:p>
-            <a:r>
-              <a:rPr lang="de-DE" sz="1200"/>
-              <a:t>&lt;PackageReference Include="JOSYN.Commons.Log"             Version="1.0.0-preview01"/&gt;</a:t>
-            </a:r>
-          </a:p>
-          <a:p>
-            <a:endParaRPr lang="de-DE" sz="1200"/>
-          </a:p>
-          <a:p>
-            <a:r>
-              <a:rPr lang="de-DE" sz="1200"/>
-              <a:t>----------------------------------------</a:t>
-            </a:r>
-          </a:p>
-          <a:p>
-            <a:endParaRPr lang="de-DE" sz="1200"/>
-          </a:p>
-          <a:p>
-            <a:r>
-              <a:rPr lang="de-DE" sz="1200"/>
-              <a:t>&lt;PackageReference Include="JOSYN.Backend.BootstrapConfig"      Version="1.0.0-preview01"/&gt;</a:t>
-            </a:r>
-          </a:p>
-          <a:p>
-            <a:endParaRPr lang="de-DE" sz="1200"/>
-          </a:p>
-          <a:p>
-            <a:r>
-              <a:rPr lang="de-DE" sz="1200"/>
-              <a:t>&lt;PackageReference Include="JOSYN.Backend.AdapterContracts"  Version="1.0.0-preview01"/&gt;</a:t>
-            </a:r>
-          </a:p>
-          <a:p>
-            <a:endParaRPr lang="de-DE" sz="1200"/>
-          </a:p>
-          <a:p>
-            <a:r>
-              <a:rPr lang="de-DE" sz="1200"/>
-              <a:t>&lt;PackageReference Include="JOSYN.Backend.ConfigStore"        Version="1.0.0-preview01"/&gt;</a:t>
-            </a:r>
-          </a:p>
-          <a:p>
-            <a:r>
-              <a:rPr lang="de-DE" sz="1200"/>
-              <a:t>&lt;PackageReference Include="JOSYN.Backend.ErrorHandler"       Version="1.0.0-preview01"/&gt;</a:t>
-            </a:r>
-          </a:p>
-          <a:p>
-            <a:r>
-              <a:rPr lang="de-DE" sz="1200"/>
-              <a:t>&lt;PackageReference Include="JOSYN.Backend.SessionStore"       Version="1.0.0-preview01"/&gt;</a:t>
-            </a:r>
-          </a:p>
-        </p:txBody>
-      </p:sp>
-      <p:sp>
-        <p:nvSpPr>
-          <p:cNvPr id="12" name="Textfeld 11">
-            <a:extLst>
-              <a:ext uri="{FF2B5EF4-FFF2-40B4-BE49-F238E27FC236}">
-                <a16:creationId xmlns:a16="http://schemas.microsoft.com/office/drawing/2014/main" id="{7DAB8E91-0B3C-2429-8C9C-5356A1CD3995}"/>
-              </a:ext>
-            </a:extLst>
-          </p:cNvPr>
-          <p:cNvSpPr txBox="1"/>
-          <p:nvPr/>
-        </p:nvSpPr>
-        <p:spPr>
-          <a:xfrm>
-            <a:off x="819150" y="5041493"/>
-            <a:ext cx="6096000" cy="646331"/>
-          </a:xfrm>
-          <a:prstGeom prst="rect">
-            <a:avLst/>
-          </a:prstGeom>
-          <a:noFill/>
-        </p:spPr>
-        <p:txBody>
-          <a:bodyPr wrap="square">
-            <a:spAutoFit/>
-          </a:bodyPr>
-          <a:lstStyle/>
-          <a:p>
-            <a:r>
-              <a:rPr lang="de-DE" sz="1800">
-                <a:solidFill>
-                  <a:srgbClr val="FF0000"/>
-                </a:solidFill>
-              </a:rPr>
-              <a:t>JOSYN.Jap.Shared.Contract</a:t>
-            </a:r>
-          </a:p>
-          <a:p>
-            <a:r>
-              <a:rPr lang="de-DE">
-                <a:solidFill>
-                  <a:srgbClr val="FF0000"/>
-                </a:solidFill>
-              </a:rPr>
-              <a:t>Shared im Namen ist überflüssig?</a:t>
+            <a:r>
+              <a:rPr lang="de-DE"/>
+              <a:t>3 Exen</a:t>
+            </a:r>
+          </a:p>
+          <a:p>
+            <a:r>
+              <a:rPr lang="de-DE"/>
+              <a:t>	josyn-backend-cli</a:t>
+            </a:r>
+          </a:p>
+          <a:p>
+            <a:r>
+              <a:rPr lang="de-DE"/>
+              <a:t>	josyn-backend-listener</a:t>
+            </a:r>
+          </a:p>
+          <a:p>
+            <a:r>
+              <a:rPr lang="de-DE"/>
+              <a:t>	josyn-backend-ticker</a:t>
+            </a:r>
+          </a:p>
+          <a:p>
+            <a:endParaRPr lang="de-DE"/>
+          </a:p>
+          <a:p>
+            <a:r>
+              <a:rPr lang="de-DE"/>
+              <a:t>Für die 3 Exen</a:t>
+            </a:r>
+          </a:p>
+          <a:p>
+            <a:r>
+              <a:rPr lang="de-DE"/>
+              <a:t>	josyn-backend-session-starter</a:t>
             </a:r>
           </a:p>
         </p:txBody>
@@ -9956,7 +10457,7 @@
     </p:spTree>
     <p:extLst>
       <p:ext uri="{BB962C8B-B14F-4D97-AF65-F5344CB8AC3E}">
-        <p14:creationId xmlns:p14="http://schemas.microsoft.com/office/powerpoint/2010/main" val="2906729512"/>
+        <p14:creationId xmlns:p14="http://schemas.microsoft.com/office/powerpoint/2010/main" val="3691293951"/>
       </p:ext>
     </p:extLst>
   </p:cSld>
@@ -9985,10 +10486,10 @@
       </p:grpSpPr>
       <p:sp>
         <p:nvSpPr>
-          <p:cNvPr id="4" name="Textfeld 3">
-            <a:extLst>
-              <a:ext uri="{FF2B5EF4-FFF2-40B4-BE49-F238E27FC236}">
-                <a16:creationId xmlns:a16="http://schemas.microsoft.com/office/drawing/2014/main" id="{4F5483BE-BCC0-D8A1-F472-C90B8F7469A1}"/>
+          <p:cNvPr id="6" name="Textfeld 5">
+            <a:extLst>
+              <a:ext uri="{FF2B5EF4-FFF2-40B4-BE49-F238E27FC236}">
+                <a16:creationId xmlns:a16="http://schemas.microsoft.com/office/drawing/2014/main" id="{1378A166-C683-26B2-2B8B-EB6C9821C42E}"/>
               </a:ext>
             </a:extLst>
           </p:cNvPr>
@@ -9997,8 +10498,8 @@
         </p:nvSpPr>
         <p:spPr>
           <a:xfrm>
-            <a:off x="511332" y="346026"/>
-            <a:ext cx="3532634" cy="2308324"/>
+            <a:off x="657225" y="723900"/>
+            <a:ext cx="4355744" cy="523220"/>
           </a:xfrm>
           <a:prstGeom prst="rect">
             <a:avLst/>
@@ -10012,48 +10513,18 @@
           <a:lstStyle/>
           <a:p>
             <a:r>
-              <a:rPr lang="de-DE" b="1"/>
-              <a:t>round-trip</a:t>
-            </a:r>
-          </a:p>
-          <a:p>
-            <a:endParaRPr lang="de-DE"/>
-          </a:p>
-          <a:p>
-            <a:r>
-              <a:rPr lang="de-DE"/>
-              <a:t>	live zeigen</a:t>
-            </a:r>
-          </a:p>
-          <a:p>
-            <a:endParaRPr lang="de-DE"/>
-          </a:p>
-          <a:p>
-            <a:r>
-              <a:rPr lang="de-DE"/>
-              <a:t>	a-spawns-b  diagram(s)  </a:t>
-            </a:r>
-          </a:p>
-          <a:p>
-            <a:r>
-              <a:rPr lang="de-DE"/>
-              <a:t> </a:t>
-            </a:r>
-          </a:p>
-          <a:p>
-            <a:endParaRPr lang="de-DE"/>
-          </a:p>
-          <a:p>
-            <a:endParaRPr lang="de-DE"/>
+              <a:rPr lang="de-DE" sz="2800" b="1"/>
+              <a:t>Jap-Server Dependencies</a:t>
+            </a:r>
           </a:p>
         </p:txBody>
       </p:sp>
       <p:sp>
         <p:nvSpPr>
-          <p:cNvPr id="5" name="Textfeld 4">
-            <a:extLst>
-              <a:ext uri="{FF2B5EF4-FFF2-40B4-BE49-F238E27FC236}">
-                <a16:creationId xmlns:a16="http://schemas.microsoft.com/office/drawing/2014/main" id="{0ADD3679-4C9F-5B5C-F563-34CFEFC1BB9A}"/>
+          <p:cNvPr id="10" name="Textfeld 9">
+            <a:extLst>
+              <a:ext uri="{FF2B5EF4-FFF2-40B4-BE49-F238E27FC236}">
+                <a16:creationId xmlns:a16="http://schemas.microsoft.com/office/drawing/2014/main" id="{8ABCE4CD-01B1-8E57-EF8F-03E4359F6E56}"/>
               </a:ext>
             </a:extLst>
           </p:cNvPr>
@@ -10062,301 +10533,8 @@
         </p:nvSpPr>
         <p:spPr>
           <a:xfrm>
-            <a:off x="7560174" y="367010"/>
-            <a:ext cx="4017831" cy="5909310"/>
-          </a:xfrm>
-          <a:prstGeom prst="rect">
-            <a:avLst/>
-          </a:prstGeom>
-          <a:noFill/>
-        </p:spPr>
-        <p:txBody>
-          <a:bodyPr wrap="none" rtlCol="0">
-            <a:spAutoFit/>
-          </a:bodyPr>
-          <a:lstStyle/>
-          <a:p>
-            <a:endParaRPr lang="de-DE"/>
-          </a:p>
-          <a:p>
-            <a:r>
-              <a:rPr lang="de-DE"/>
-              <a:t>-------------</a:t>
-            </a:r>
-          </a:p>
-          <a:p>
-            <a:endParaRPr lang="de-DE"/>
-          </a:p>
-          <a:p>
-            <a:r>
-              <a:rPr lang="de-DE" b="1"/>
-              <a:t>error-routing</a:t>
-            </a:r>
-          </a:p>
-          <a:p>
-            <a:endParaRPr lang="de-DE"/>
-          </a:p>
-          <a:p>
-            <a:r>
-              <a:rPr lang="de-DE"/>
-              <a:t>---------</a:t>
-            </a:r>
-          </a:p>
-          <a:p>
-            <a:endParaRPr lang="de-DE"/>
-          </a:p>
-          <a:p>
-            <a:r>
-              <a:rPr lang="de-DE" b="1"/>
-              <a:t>company-fit</a:t>
-            </a:r>
-          </a:p>
-          <a:p>
-            <a:r>
-              <a:rPr lang="de-DE"/>
-              <a:t>	contoso</a:t>
-            </a:r>
-          </a:p>
-          <a:p>
-            <a:r>
-              <a:rPr lang="de-DE"/>
-              <a:t>	Governance</a:t>
-            </a:r>
-          </a:p>
-          <a:p>
-            <a:r>
-              <a:rPr lang="de-DE"/>
-              <a:t>	hävg-dev-process</a:t>
-            </a:r>
-          </a:p>
-          <a:p>
-            <a:r>
-              <a:rPr lang="de-DE"/>
-              <a:t>	Pipeline-ready</a:t>
-            </a:r>
-          </a:p>
-          <a:p>
-            <a:r>
-              <a:rPr lang="de-DE"/>
-              <a:t>	evolution: docker/lniux</a:t>
-            </a:r>
-          </a:p>
-          <a:p>
-            <a:r>
-              <a:rPr lang="de-DE"/>
-              <a:t>	migration!</a:t>
-            </a:r>
-          </a:p>
-          <a:p>
-            <a:r>
-              <a:rPr lang="de-DE"/>
-              <a:t>	tpm-story</a:t>
-            </a:r>
-          </a:p>
-          <a:p>
-            <a:r>
-              <a:rPr lang="de-DE"/>
-              <a:t>	project?</a:t>
-            </a:r>
-          </a:p>
-          <a:p>
-            <a:r>
-              <a:rPr lang="de-DE"/>
-              <a:t>	entscheidungen</a:t>
-            </a:r>
-          </a:p>
-          <a:p>
-            <a:r>
-              <a:rPr lang="de-DE"/>
-              <a:t>	people</a:t>
-            </a:r>
-          </a:p>
-          <a:p>
-            <a:endParaRPr lang="de-DE"/>
-          </a:p>
-          <a:p>
-            <a:r>
-              <a:rPr lang="de-DE"/>
-              <a:t>josyn als domain-agnostisches system</a:t>
-            </a:r>
-          </a:p>
-          <a:p>
-            <a:r>
-              <a:rPr lang="de-DE"/>
-              <a:t>Josyn als teil der domäne</a:t>
-            </a:r>
-          </a:p>
-        </p:txBody>
-      </p:sp>
-      <p:sp>
-        <p:nvSpPr>
-          <p:cNvPr id="6" name="Textfeld 5">
-            <a:extLst>
-              <a:ext uri="{FF2B5EF4-FFF2-40B4-BE49-F238E27FC236}">
-                <a16:creationId xmlns:a16="http://schemas.microsoft.com/office/drawing/2014/main" id="{7D516507-CF40-55A8-65B1-B3768EBC5AC5}"/>
-              </a:ext>
-            </a:extLst>
-          </p:cNvPr>
-          <p:cNvSpPr txBox="1"/>
-          <p:nvPr/>
-        </p:nvSpPr>
-        <p:spPr>
-          <a:xfrm>
-            <a:off x="752475" y="4400550"/>
-            <a:ext cx="5848524" cy="923330"/>
-          </a:xfrm>
-          <a:prstGeom prst="rect">
-            <a:avLst/>
-          </a:prstGeom>
-          <a:noFill/>
-        </p:spPr>
-        <p:txBody>
-          <a:bodyPr wrap="none" rtlCol="0">
-            <a:spAutoFit/>
-          </a:bodyPr>
-          <a:lstStyle/>
-          <a:p>
-            <a:r>
-              <a:rPr lang="de-DE" b="1"/>
-              <a:t>einleitung</a:t>
-            </a:r>
-          </a:p>
-          <a:p>
-            <a:r>
-              <a:rPr lang="de-DE"/>
-              <a:t>	kurz die core-flaws des alten systems erwähnen</a:t>
-            </a:r>
-          </a:p>
-          <a:p>
-            <a:r>
-              <a:rPr lang="de-DE"/>
-              <a:t>	Ai zitieren</a:t>
-            </a:r>
-          </a:p>
-        </p:txBody>
-      </p:sp>
-      <p:sp>
-        <p:nvSpPr>
-          <p:cNvPr id="7" name="Textfeld 6">
-            <a:extLst>
-              <a:ext uri="{FF2B5EF4-FFF2-40B4-BE49-F238E27FC236}">
-                <a16:creationId xmlns:a16="http://schemas.microsoft.com/office/drawing/2014/main" id="{1D9146EC-A86F-4C5E-21C9-6FED7F4C3F1C}"/>
-              </a:ext>
-            </a:extLst>
-          </p:cNvPr>
-          <p:cNvSpPr txBox="1"/>
-          <p:nvPr/>
-        </p:nvSpPr>
-        <p:spPr>
-          <a:xfrm>
-            <a:off x="3831983" y="2754481"/>
-            <a:ext cx="3707682" cy="1477328"/>
-          </a:xfrm>
-          <a:prstGeom prst="rect">
-            <a:avLst/>
-          </a:prstGeom>
-          <a:noFill/>
-        </p:spPr>
-        <p:txBody>
-          <a:bodyPr wrap="none" rtlCol="0">
-            <a:spAutoFit/>
-          </a:bodyPr>
-          <a:lstStyle/>
-          <a:p>
-            <a:r>
-              <a:rPr lang="de-DE" b="1"/>
-              <a:t>die anderen repos</a:t>
-            </a:r>
-          </a:p>
-          <a:p>
-            <a:r>
-              <a:rPr lang="de-DE"/>
-              <a:t>	Platform / ai /sanity-check</a:t>
-            </a:r>
-          </a:p>
-          <a:p>
-            <a:r>
-              <a:rPr lang="de-DE"/>
-              <a:t>	Tooling</a:t>
-            </a:r>
-          </a:p>
-          <a:p>
-            <a:r>
-              <a:rPr lang="de-DE"/>
-              <a:t>	Playground</a:t>
-            </a:r>
-          </a:p>
-          <a:p>
-            <a:r>
-              <a:rPr lang="de-DE"/>
-              <a:t>	docs</a:t>
-            </a:r>
-          </a:p>
-        </p:txBody>
-      </p:sp>
-      <p:sp>
-        <p:nvSpPr>
-          <p:cNvPr id="8" name="Textfeld 7">
-            <a:extLst>
-              <a:ext uri="{FF2B5EF4-FFF2-40B4-BE49-F238E27FC236}">
-                <a16:creationId xmlns:a16="http://schemas.microsoft.com/office/drawing/2014/main" id="{BC52FF86-D522-2513-C318-9F6B99D33531}"/>
-              </a:ext>
-            </a:extLst>
-          </p:cNvPr>
-          <p:cNvSpPr txBox="1"/>
-          <p:nvPr/>
-        </p:nvSpPr>
-        <p:spPr>
-          <a:xfrm>
-            <a:off x="3966505" y="5664101"/>
-            <a:ext cx="2739340" cy="923330"/>
-          </a:xfrm>
-          <a:prstGeom prst="rect">
-            <a:avLst/>
-          </a:prstGeom>
-          <a:noFill/>
-        </p:spPr>
-        <p:txBody>
-          <a:bodyPr wrap="none" rtlCol="0">
-            <a:spAutoFit/>
-          </a:bodyPr>
-          <a:lstStyle/>
-          <a:p>
-            <a:r>
-              <a:rPr lang="de-DE" b="1"/>
-              <a:t>urls zur vefügung stellen</a:t>
-            </a:r>
-          </a:p>
-          <a:p>
-            <a:r>
-              <a:rPr lang="de-DE"/>
-              <a:t>	ckluth/github</a:t>
-            </a:r>
-          </a:p>
-          <a:p>
-            <a:r>
-              <a:rPr lang="de-DE"/>
-              <a:t>	</a:t>
-            </a:r>
-          </a:p>
-        </p:txBody>
-      </p:sp>
-      <p:sp>
-        <p:nvSpPr>
-          <p:cNvPr id="3" name="Textfeld 2">
-            <a:extLst>
-              <a:ext uri="{FF2B5EF4-FFF2-40B4-BE49-F238E27FC236}">
-                <a16:creationId xmlns:a16="http://schemas.microsoft.com/office/drawing/2014/main" id="{29C18F3B-60AA-F446-2720-EE185F5A41E4}"/>
-              </a:ext>
-            </a:extLst>
-          </p:cNvPr>
-          <p:cNvSpPr txBox="1"/>
-          <p:nvPr/>
-        </p:nvSpPr>
-        <p:spPr>
-          <a:xfrm>
-            <a:off x="4268169" y="367010"/>
-            <a:ext cx="3552999" cy="646331"/>
+            <a:off x="3357562" y="1170176"/>
+            <a:ext cx="6748463" cy="3416320"/>
           </a:xfrm>
           <a:prstGeom prst="rect">
             <a:avLst/>
@@ -10369,26 +10547,100 @@
           </a:bodyPr>
           <a:lstStyle/>
           <a:p>
-            <a:r>
-              <a:rPr lang="de-DE" b="1"/>
-              <a:t>storgae-realm</a:t>
-            </a:r>
-            <a:r>
-              <a:rPr lang="de-DE"/>
-              <a:t> / db</a:t>
-            </a:r>
-          </a:p>
-          <a:p>
-            <a:endParaRPr lang="de-DE"/>
+            <a:endParaRPr lang="de-DE" sz="1200"/>
+          </a:p>
+          <a:p>
+            <a:r>
+              <a:rPr lang="de-DE" sz="1200"/>
+              <a:t>&lt;PackageReference Include="JOSYN.Foundation.JIP"             Version="1.0.0-preview01"/&gt;</a:t>
+            </a:r>
+          </a:p>
+          <a:p>
+            <a:r>
+              <a:rPr lang="de-DE" sz="1200"/>
+              <a:t>&lt;PackageReference Include="JOSYN.Foundation.PropertyBag"     Version="1.0.0-preview01"/&gt;</a:t>
+            </a:r>
+          </a:p>
+          <a:p>
+            <a:r>
+              <a:rPr lang="de-DE" sz="1200"/>
+              <a:t>&lt;PackageReference Include="JOSYN.Foundation.ResultPattern"   Version="1.0.0-preview01"/&gt;</a:t>
+            </a:r>
+          </a:p>
+          <a:p>
+            <a:endParaRPr lang="de-DE" sz="1200"/>
+          </a:p>
+          <a:p>
+            <a:r>
+              <a:rPr lang="de-DE" sz="1200"/>
+              <a:t>&lt;PackageReference Include="JOSYN.Jap.Contract"        Version="1.0.0-preview01"/&gt;</a:t>
+            </a:r>
+          </a:p>
+          <a:p>
+            <a:endParaRPr lang="de-DE" sz="1200"/>
+          </a:p>
+          <a:p>
+            <a:r>
+              <a:rPr lang="de-DE" sz="1200"/>
+              <a:t>&lt;PackageReference Include="JOSYN.Commons.Log"             Version="1.0.0-preview01"/&gt;</a:t>
+            </a:r>
+          </a:p>
+          <a:p>
+            <a:endParaRPr lang="de-DE" sz="1200"/>
+          </a:p>
+          <a:p>
+            <a:r>
+              <a:rPr lang="de-DE" sz="1200"/>
+              <a:t>----------------------------------------</a:t>
+            </a:r>
+          </a:p>
+          <a:p>
+            <a:endParaRPr lang="de-DE" sz="1200"/>
+          </a:p>
+          <a:p>
+            <a:r>
+              <a:rPr lang="de-DE" sz="1200"/>
+              <a:t>&lt;PackageReference Include="JOSYN.Backend.BootstrapConfig"      Version="1.0.0-preview01"/&gt;</a:t>
+            </a:r>
+          </a:p>
+          <a:p>
+            <a:endParaRPr lang="de-DE" sz="1200"/>
+          </a:p>
+          <a:p>
+            <a:r>
+              <a:rPr lang="de-DE" sz="1200"/>
+              <a:t>&lt;PackageReference Include="JOSYN.Backend.AdapterContracts"  Version="1.0.0-preview01"/&gt;</a:t>
+            </a:r>
+          </a:p>
+          <a:p>
+            <a:endParaRPr lang="de-DE" sz="1200"/>
+          </a:p>
+          <a:p>
+            <a:r>
+              <a:rPr lang="de-DE" sz="1200"/>
+              <a:t>&lt;PackageReference Include="JOSYN.Backend.ConfigStore"        Version="1.0.0-preview01"/&gt;</a:t>
+            </a:r>
+          </a:p>
+          <a:p>
+            <a:r>
+              <a:rPr lang="de-DE" sz="1200"/>
+              <a:t>&lt;PackageReference Include="JOSYN.Backend.ErrorHandler"       Version="1.0.0-preview01"/&gt;</a:t>
+            </a:r>
+          </a:p>
+          <a:p>
+            <a:r>
+              <a:rPr lang="de-DE" sz="1200"/>
+              <a:t>&lt;PackageReference Include="JOSYN.Backend.SessionStore"       Version="1.0.0-preview01"/&gt;</a:t>
+            </a:r>
           </a:p>
         </p:txBody>
       </p:sp>
       <p:sp>
         <p:nvSpPr>
-          <p:cNvPr id="9" name="Textfeld 8">
-            <a:extLst>
-              <a:ext uri="{FF2B5EF4-FFF2-40B4-BE49-F238E27FC236}">
-                <a16:creationId xmlns:a16="http://schemas.microsoft.com/office/drawing/2014/main" id="{F94EA407-9AED-2092-C6FC-7B7B9FA446E2}"/>
+          <p:cNvPr id="12" name="Textfeld 11">
+            <a:extLst>
+              <a:ext uri="{FF2B5EF4-FFF2-40B4-BE49-F238E27FC236}">
+                <a16:creationId xmlns:a16="http://schemas.microsoft.com/office/drawing/2014/main" id="{7DAB8E91-0B3C-2429-8C9C-5356A1CD3995}"/>
               </a:ext>
             </a:extLst>
           </p:cNvPr>
@@ -10397,71 +10649,8 @@
         </p:nvSpPr>
         <p:spPr>
           <a:xfrm>
-            <a:off x="1316872" y="2495550"/>
-            <a:ext cx="1709571" cy="1477328"/>
-          </a:xfrm>
-          <a:prstGeom prst="rect">
-            <a:avLst/>
-          </a:prstGeom>
-          <a:noFill/>
-        </p:spPr>
-        <p:txBody>
-          <a:bodyPr wrap="none" rtlCol="0">
-            <a:spAutoFit/>
-          </a:bodyPr>
-          <a:lstStyle/>
-          <a:p>
-            <a:r>
-              <a:rPr lang="de-DE" b="1"/>
-              <a:t>principles</a:t>
-            </a:r>
-          </a:p>
-          <a:p>
-            <a:pPr lvl="1"/>
-            <a:r>
-              <a:rPr lang="de-DE"/>
-              <a:t>NRT</a:t>
-            </a:r>
-          </a:p>
-          <a:p>
-            <a:pPr lvl="1"/>
-            <a:r>
-              <a:rPr lang="de-DE"/>
-              <a:t>RP-Usage</a:t>
-            </a:r>
-          </a:p>
-          <a:p>
-            <a:pPr lvl="1"/>
-            <a:r>
-              <a:rPr lang="de-DE"/>
-              <a:t>Functional</a:t>
-            </a:r>
-          </a:p>
-          <a:p>
-            <a:pPr lvl="1"/>
-            <a:r>
-              <a:rPr lang="de-DE"/>
-              <a:t>Contracts</a:t>
-            </a:r>
-          </a:p>
-        </p:txBody>
-      </p:sp>
-      <p:sp>
-        <p:nvSpPr>
-          <p:cNvPr id="11" name="Textfeld 10">
-            <a:extLst>
-              <a:ext uri="{FF2B5EF4-FFF2-40B4-BE49-F238E27FC236}">
-                <a16:creationId xmlns:a16="http://schemas.microsoft.com/office/drawing/2014/main" id="{BD489293-44C7-2752-5AF2-8256A73E879E}"/>
-              </a:ext>
-            </a:extLst>
-          </p:cNvPr>
-          <p:cNvSpPr txBox="1"/>
-          <p:nvPr/>
-        </p:nvSpPr>
-        <p:spPr>
-          <a:xfrm>
-            <a:off x="4268343" y="1782946"/>
-            <a:ext cx="2704131" cy="369332"/>
+            <a:off x="819150" y="5041493"/>
+            <a:ext cx="6096000" cy="646331"/>
           </a:xfrm>
           <a:prstGeom prst="rect">
             <a:avLst/>
@@ -10475,8 +10664,22 @@
           <a:lstStyle/>
           <a:p>
             <a:r>
-              <a:rPr lang="de-DE" b="1"/>
-              <a:t>deployment / bootsrip</a:t>
+              <a:rPr lang="de-DE" sz="1800">
+                <a:solidFill>
+                  <a:srgbClr val="FF0000"/>
+                </a:solidFill>
+              </a:rPr>
+              <a:t>JOSYN.Jap.Shared.Contract</a:t>
+            </a:r>
+          </a:p>
+          <a:p>
+            <a:r>
+              <a:rPr lang="de-DE">
+                <a:solidFill>
+                  <a:srgbClr val="FF0000"/>
+                </a:solidFill>
+              </a:rPr>
+              <a:t>Shared im Namen ist überflüssig?</a:t>
             </a:r>
           </a:p>
         </p:txBody>
@@ -10484,7 +10687,7 @@
     </p:spTree>
     <p:extLst>
       <p:ext uri="{BB962C8B-B14F-4D97-AF65-F5344CB8AC3E}">
-        <p14:creationId xmlns:p14="http://schemas.microsoft.com/office/powerpoint/2010/main" val="2196784917"/>
+        <p14:creationId xmlns:p14="http://schemas.microsoft.com/office/powerpoint/2010/main" val="2906729512"/>
       </p:ext>
     </p:extLst>
   </p:cSld>

</xml_diff>

<commit_message>
wip: sync [2026-06-13 17:16]
</commit_message>
<xml_diff>
--- a/josyn-intro.pptx
+++ b/josyn-intro.pptx
@@ -3802,15 +3802,27 @@
           <a:p>
             <a:pPr algn="ctr"/>
             <a:r>
-              <a:rPr lang="de-DE" sz="4400" i="1"/>
+              <a:rPr lang="de-DE" sz="4400" i="1">
+                <a:solidFill>
+                  <a:srgbClr val="00B050"/>
+                </a:solidFill>
+              </a:rPr>
               <a:t>Nach </a:t>
             </a:r>
             <a:r>
-              <a:rPr lang="de-DE" sz="4400" b="1" i="1"/>
+              <a:rPr lang="de-DE" sz="4400" b="1" i="1">
+                <a:solidFill>
+                  <a:srgbClr val="00B050"/>
+                </a:solidFill>
+              </a:rPr>
               <a:t>10</a:t>
             </a:r>
             <a:r>
-              <a:rPr lang="de-DE" sz="4400" i="1"/>
+              <a:rPr lang="de-DE" sz="4400" i="1">
+                <a:solidFill>
+                  <a:srgbClr val="00B050"/>
+                </a:solidFill>
+              </a:rPr>
               <a:t> erfolgreichen Jahren </a:t>
             </a:r>
           </a:p>
@@ -3827,27 +3839,43 @@
           </a:p>
           <a:p>
             <a:pPr algn="ctr"/>
-            <a:endParaRPr lang="de-DE" sz="4400" b="1"/>
+            <a:endParaRPr lang="de-DE" sz="1400" i="1"/>
           </a:p>
           <a:p>
             <a:pPr algn="ctr"/>
             <a:r>
-              <a:rPr lang="de-DE" sz="4400"/>
+              <a:rPr lang="de-DE" sz="4400" i="1"/>
               <a:t>Noch fit für die Zukunft?</a:t>
             </a:r>
           </a:p>
           <a:p>
             <a:pPr algn="ctr"/>
-            <a:r>
-              <a:rPr lang="de-DE" sz="4400"/>
-              <a:t>Zeit für die Rente?</a:t>
-            </a:r>
+            <a:endParaRPr lang="de-DE" i="1"/>
           </a:p>
           <a:p>
             <a:pPr algn="ctr"/>
             <a:r>
+              <a:rPr lang="de-DE" sz="4400">
+                <a:solidFill>
+                  <a:srgbClr val="FF0000"/>
+                </a:solidFill>
+              </a:rPr>
+              <a:t>Zeit für die Rente?...</a:t>
+            </a:r>
+          </a:p>
+          <a:p>
+            <a:pPr algn="ctr"/>
+            <a:endParaRPr lang="de-DE" sz="1200">
+              <a:solidFill>
+                <a:srgbClr val="FF0000"/>
+              </a:solidFill>
+            </a:endParaRPr>
+          </a:p>
+          <a:p>
+            <a:pPr algn="ctr"/>
+            <a:r>
               <a:rPr lang="de-DE" sz="4400" b="1" i="1"/>
-              <a:t>Was kommt danach?</a:t>
+              <a:t>=&gt; …was käme danach?</a:t>
             </a:r>
           </a:p>
           <a:p>
@@ -3866,6 +3894,183 @@
   <p:clrMapOvr>
     <a:masterClrMapping/>
   </p:clrMapOvr>
+  <p:timing>
+    <p:tnLst>
+      <p:par>
+        <p:cTn id="1" dur="indefinite" restart="never" nodeType="tmRoot">
+          <p:childTnLst>
+            <p:seq concurrent="1" nextAc="seek">
+              <p:cTn id="2" dur="indefinite" nodeType="mainSeq">
+                <p:childTnLst>
+                  <p:par>
+                    <p:cTn id="3" fill="hold">
+                      <p:stCondLst>
+                        <p:cond delay="indefinite"/>
+                      </p:stCondLst>
+                      <p:childTnLst>
+                        <p:par>
+                          <p:cTn id="4" fill="hold">
+                            <p:stCondLst>
+                              <p:cond delay="0"/>
+                            </p:stCondLst>
+                            <p:childTnLst>
+                              <p:par>
+                                <p:cTn id="5" presetID="1" presetClass="entr" presetSubtype="0" fill="hold" nodeType="clickEffect">
+                                  <p:stCondLst>
+                                    <p:cond delay="0"/>
+                                  </p:stCondLst>
+                                  <p:childTnLst>
+                                    <p:set>
+                                      <p:cBhvr>
+                                        <p:cTn id="6" dur="1" fill="hold">
+                                          <p:stCondLst>
+                                            <p:cond delay="0"/>
+                                          </p:stCondLst>
+                                        </p:cTn>
+                                        <p:tgtEl>
+                                          <p:spTgt spid="4">
+                                            <p:txEl>
+                                              <p:pRg st="3" end="3"/>
+                                            </p:txEl>
+                                          </p:spTgt>
+                                        </p:tgtEl>
+                                        <p:attrNameLst>
+                                          <p:attrName>style.visibility</p:attrName>
+                                        </p:attrNameLst>
+                                      </p:cBhvr>
+                                      <p:to>
+                                        <p:strVal val="visible"/>
+                                      </p:to>
+                                    </p:set>
+                                  </p:childTnLst>
+                                </p:cTn>
+                              </p:par>
+                            </p:childTnLst>
+                          </p:cTn>
+                        </p:par>
+                      </p:childTnLst>
+                    </p:cTn>
+                  </p:par>
+                  <p:par>
+                    <p:cTn id="7" fill="hold">
+                      <p:stCondLst>
+                        <p:cond delay="indefinite"/>
+                      </p:stCondLst>
+                      <p:childTnLst>
+                        <p:par>
+                          <p:cTn id="8" fill="hold">
+                            <p:stCondLst>
+                              <p:cond delay="0"/>
+                            </p:stCondLst>
+                            <p:childTnLst>
+                              <p:par>
+                                <p:cTn id="9" presetID="1" presetClass="entr" presetSubtype="0" fill="hold" nodeType="clickEffect">
+                                  <p:stCondLst>
+                                    <p:cond delay="0"/>
+                                  </p:stCondLst>
+                                  <p:childTnLst>
+                                    <p:set>
+                                      <p:cBhvr>
+                                        <p:cTn id="10" dur="1" fill="hold">
+                                          <p:stCondLst>
+                                            <p:cond delay="0"/>
+                                          </p:stCondLst>
+                                        </p:cTn>
+                                        <p:tgtEl>
+                                          <p:spTgt spid="4">
+                                            <p:txEl>
+                                              <p:pRg st="5" end="5"/>
+                                            </p:txEl>
+                                          </p:spTgt>
+                                        </p:tgtEl>
+                                        <p:attrNameLst>
+                                          <p:attrName>style.visibility</p:attrName>
+                                        </p:attrNameLst>
+                                      </p:cBhvr>
+                                      <p:to>
+                                        <p:strVal val="visible"/>
+                                      </p:to>
+                                    </p:set>
+                                  </p:childTnLst>
+                                </p:cTn>
+                              </p:par>
+                            </p:childTnLst>
+                          </p:cTn>
+                        </p:par>
+                      </p:childTnLst>
+                    </p:cTn>
+                  </p:par>
+                  <p:par>
+                    <p:cTn id="11" fill="hold">
+                      <p:stCondLst>
+                        <p:cond delay="indefinite"/>
+                      </p:stCondLst>
+                      <p:childTnLst>
+                        <p:par>
+                          <p:cTn id="12" fill="hold">
+                            <p:stCondLst>
+                              <p:cond delay="0"/>
+                            </p:stCondLst>
+                            <p:childTnLst>
+                              <p:par>
+                                <p:cTn id="13" presetID="1" presetClass="entr" presetSubtype="0" fill="hold" nodeType="clickEffect">
+                                  <p:stCondLst>
+                                    <p:cond delay="0"/>
+                                  </p:stCondLst>
+                                  <p:childTnLst>
+                                    <p:set>
+                                      <p:cBhvr>
+                                        <p:cTn id="14" dur="1" fill="hold">
+                                          <p:stCondLst>
+                                            <p:cond delay="0"/>
+                                          </p:stCondLst>
+                                        </p:cTn>
+                                        <p:tgtEl>
+                                          <p:spTgt spid="4">
+                                            <p:txEl>
+                                              <p:pRg st="7" end="7"/>
+                                            </p:txEl>
+                                          </p:spTgt>
+                                        </p:tgtEl>
+                                        <p:attrNameLst>
+                                          <p:attrName>style.visibility</p:attrName>
+                                        </p:attrNameLst>
+                                      </p:cBhvr>
+                                      <p:to>
+                                        <p:strVal val="visible"/>
+                                      </p:to>
+                                    </p:set>
+                                  </p:childTnLst>
+                                </p:cTn>
+                              </p:par>
+                            </p:childTnLst>
+                          </p:cTn>
+                        </p:par>
+                      </p:childTnLst>
+                    </p:cTn>
+                  </p:par>
+                </p:childTnLst>
+              </p:cTn>
+              <p:prevCondLst>
+                <p:cond evt="onPrev" delay="0">
+                  <p:tgtEl>
+                    <p:sldTgt/>
+                  </p:tgtEl>
+                </p:cond>
+              </p:prevCondLst>
+              <p:nextCondLst>
+                <p:cond evt="onNext" delay="0">
+                  <p:tgtEl>
+                    <p:sldTgt/>
+                  </p:tgtEl>
+                </p:cond>
+              </p:nextCondLst>
+            </p:seq>
+          </p:childTnLst>
+        </p:cTn>
+      </p:par>
+    </p:tnLst>
+  </p:timing>
 </p:sld>
 </file>
 
@@ -7167,8 +7372,16 @@
               <a:buChar char="•"/>
             </a:pPr>
             <a:r>
+              <a:rPr lang="de-DE">
+                <a:solidFill>
+                  <a:srgbClr val="FF0000"/>
+                </a:solidFill>
+              </a:rPr>
+              <a:t>Zukunft? </a:t>
+            </a:r>
+            <a:r>
               <a:rPr lang="de-DE"/>
-              <a:t>Zukunft? Docker? Linux? =&gt; no way…</a:t>
+              <a:t>Docker? Linux? =&gt; no way…</a:t>
             </a:r>
           </a:p>
           <a:p>
@@ -7217,8 +7430,8 @@
         </p:nvSpPr>
         <p:spPr>
           <a:xfrm>
-            <a:off x="941191" y="260230"/>
-            <a:ext cx="10309617" cy="461665"/>
+            <a:off x="769741" y="260230"/>
+            <a:ext cx="10621306" cy="461665"/>
           </a:xfrm>
           <a:prstGeom prst="rect">
             <a:avLst/>
@@ -7233,7 +7446,19 @@
           <a:p>
             <a:r>
               <a:rPr lang="de-DE" sz="2400" b="1"/>
-              <a:t>Die Diagnosen-Liste ist lang</a:t>
+              <a:t>Die „</a:t>
+            </a:r>
+            <a:r>
+              <a:rPr lang="de-DE" sz="2400" b="1" i="1">
+                <a:solidFill>
+                  <a:srgbClr val="002060"/>
+                </a:solidFill>
+              </a:rPr>
+              <a:t>Diagnosen-Liste“</a:t>
+            </a:r>
+            <a:r>
+              <a:rPr lang="de-DE" sz="2400" b="1"/>
+              <a:t> ist lang</a:t>
             </a:r>
             <a:r>
               <a:rPr lang="de-DE" sz="2400"/>
@@ -7252,6 +7477,802 @@
   <p:clrMapOvr>
     <a:masterClrMapping/>
   </p:clrMapOvr>
+  <p:timing>
+    <p:tnLst>
+      <p:par>
+        <p:cTn id="1" dur="indefinite" restart="never" nodeType="tmRoot">
+          <p:childTnLst>
+            <p:seq concurrent="1" nextAc="seek">
+              <p:cTn id="2" dur="indefinite" nodeType="mainSeq">
+                <p:childTnLst>
+                  <p:par>
+                    <p:cTn id="3" fill="hold">
+                      <p:stCondLst>
+                        <p:cond delay="indefinite"/>
+                      </p:stCondLst>
+                      <p:childTnLst>
+                        <p:par>
+                          <p:cTn id="4" fill="hold">
+                            <p:stCondLst>
+                              <p:cond delay="0"/>
+                            </p:stCondLst>
+                            <p:childTnLst>
+                              <p:par>
+                                <p:cTn id="5" presetID="1" presetClass="entr" presetSubtype="0" fill="hold" nodeType="clickEffect">
+                                  <p:stCondLst>
+                                    <p:cond delay="0"/>
+                                  </p:stCondLst>
+                                  <p:childTnLst>
+                                    <p:set>
+                                      <p:cBhvr>
+                                        <p:cTn id="6" dur="1" fill="hold">
+                                          <p:stCondLst>
+                                            <p:cond delay="0"/>
+                                          </p:stCondLst>
+                                        </p:cTn>
+                                        <p:tgtEl>
+                                          <p:spTgt spid="5">
+                                            <p:txEl>
+                                              <p:pRg st="0" end="0"/>
+                                            </p:txEl>
+                                          </p:spTgt>
+                                        </p:tgtEl>
+                                        <p:attrNameLst>
+                                          <p:attrName>style.visibility</p:attrName>
+                                        </p:attrNameLst>
+                                      </p:cBhvr>
+                                      <p:to>
+                                        <p:strVal val="visible"/>
+                                      </p:to>
+                                    </p:set>
+                                  </p:childTnLst>
+                                </p:cTn>
+                              </p:par>
+                              <p:par>
+                                <p:cTn id="7" presetID="1" presetClass="entr" presetSubtype="0" fill="hold" nodeType="withEffect">
+                                  <p:stCondLst>
+                                    <p:cond delay="0"/>
+                                  </p:stCondLst>
+                                  <p:childTnLst>
+                                    <p:set>
+                                      <p:cBhvr>
+                                        <p:cTn id="8" dur="1" fill="hold">
+                                          <p:stCondLst>
+                                            <p:cond delay="0"/>
+                                          </p:stCondLst>
+                                        </p:cTn>
+                                        <p:tgtEl>
+                                          <p:spTgt spid="5">
+                                            <p:txEl>
+                                              <p:pRg st="2" end="2"/>
+                                            </p:txEl>
+                                          </p:spTgt>
+                                        </p:tgtEl>
+                                        <p:attrNameLst>
+                                          <p:attrName>style.visibility</p:attrName>
+                                        </p:attrNameLst>
+                                      </p:cBhvr>
+                                      <p:to>
+                                        <p:strVal val="visible"/>
+                                      </p:to>
+                                    </p:set>
+                                  </p:childTnLst>
+                                </p:cTn>
+                              </p:par>
+                            </p:childTnLst>
+                          </p:cTn>
+                        </p:par>
+                      </p:childTnLst>
+                    </p:cTn>
+                  </p:par>
+                  <p:par>
+                    <p:cTn id="9" fill="hold">
+                      <p:stCondLst>
+                        <p:cond delay="indefinite"/>
+                      </p:stCondLst>
+                      <p:childTnLst>
+                        <p:par>
+                          <p:cTn id="10" fill="hold">
+                            <p:stCondLst>
+                              <p:cond delay="0"/>
+                            </p:stCondLst>
+                            <p:childTnLst>
+                              <p:par>
+                                <p:cTn id="11" presetID="1" presetClass="entr" presetSubtype="0" fill="hold" nodeType="clickEffect">
+                                  <p:stCondLst>
+                                    <p:cond delay="0"/>
+                                  </p:stCondLst>
+                                  <p:childTnLst>
+                                    <p:set>
+                                      <p:cBhvr>
+                                        <p:cTn id="12" dur="1" fill="hold">
+                                          <p:stCondLst>
+                                            <p:cond delay="0"/>
+                                          </p:stCondLst>
+                                        </p:cTn>
+                                        <p:tgtEl>
+                                          <p:spTgt spid="5">
+                                            <p:txEl>
+                                              <p:pRg st="3" end="3"/>
+                                            </p:txEl>
+                                          </p:spTgt>
+                                        </p:tgtEl>
+                                        <p:attrNameLst>
+                                          <p:attrName>style.visibility</p:attrName>
+                                        </p:attrNameLst>
+                                      </p:cBhvr>
+                                      <p:to>
+                                        <p:strVal val="visible"/>
+                                      </p:to>
+                                    </p:set>
+                                  </p:childTnLst>
+                                </p:cTn>
+                              </p:par>
+                            </p:childTnLst>
+                          </p:cTn>
+                        </p:par>
+                      </p:childTnLst>
+                    </p:cTn>
+                  </p:par>
+                  <p:par>
+                    <p:cTn id="13" fill="hold">
+                      <p:stCondLst>
+                        <p:cond delay="indefinite"/>
+                      </p:stCondLst>
+                      <p:childTnLst>
+                        <p:par>
+                          <p:cTn id="14" fill="hold">
+                            <p:stCondLst>
+                              <p:cond delay="0"/>
+                            </p:stCondLst>
+                            <p:childTnLst>
+                              <p:par>
+                                <p:cTn id="15" presetID="1" presetClass="entr" presetSubtype="0" fill="hold" nodeType="clickEffect">
+                                  <p:stCondLst>
+                                    <p:cond delay="0"/>
+                                  </p:stCondLst>
+                                  <p:childTnLst>
+                                    <p:set>
+                                      <p:cBhvr>
+                                        <p:cTn id="16" dur="1" fill="hold">
+                                          <p:stCondLst>
+                                            <p:cond delay="0"/>
+                                          </p:stCondLst>
+                                        </p:cTn>
+                                        <p:tgtEl>
+                                          <p:spTgt spid="5">
+                                            <p:txEl>
+                                              <p:pRg st="4" end="4"/>
+                                            </p:txEl>
+                                          </p:spTgt>
+                                        </p:tgtEl>
+                                        <p:attrNameLst>
+                                          <p:attrName>style.visibility</p:attrName>
+                                        </p:attrNameLst>
+                                      </p:cBhvr>
+                                      <p:to>
+                                        <p:strVal val="visible"/>
+                                      </p:to>
+                                    </p:set>
+                                  </p:childTnLst>
+                                </p:cTn>
+                              </p:par>
+                            </p:childTnLst>
+                          </p:cTn>
+                        </p:par>
+                      </p:childTnLst>
+                    </p:cTn>
+                  </p:par>
+                  <p:par>
+                    <p:cTn id="17" fill="hold">
+                      <p:stCondLst>
+                        <p:cond delay="indefinite"/>
+                      </p:stCondLst>
+                      <p:childTnLst>
+                        <p:par>
+                          <p:cTn id="18" fill="hold">
+                            <p:stCondLst>
+                              <p:cond delay="0"/>
+                            </p:stCondLst>
+                            <p:childTnLst>
+                              <p:par>
+                                <p:cTn id="19" presetID="1" presetClass="entr" presetSubtype="0" fill="hold" nodeType="clickEffect">
+                                  <p:stCondLst>
+                                    <p:cond delay="0"/>
+                                  </p:stCondLst>
+                                  <p:childTnLst>
+                                    <p:set>
+                                      <p:cBhvr>
+                                        <p:cTn id="20" dur="1" fill="hold">
+                                          <p:stCondLst>
+                                            <p:cond delay="0"/>
+                                          </p:stCondLst>
+                                        </p:cTn>
+                                        <p:tgtEl>
+                                          <p:spTgt spid="5">
+                                            <p:txEl>
+                                              <p:pRg st="5" end="5"/>
+                                            </p:txEl>
+                                          </p:spTgt>
+                                        </p:tgtEl>
+                                        <p:attrNameLst>
+                                          <p:attrName>style.visibility</p:attrName>
+                                        </p:attrNameLst>
+                                      </p:cBhvr>
+                                      <p:to>
+                                        <p:strVal val="visible"/>
+                                      </p:to>
+                                    </p:set>
+                                  </p:childTnLst>
+                                </p:cTn>
+                              </p:par>
+                            </p:childTnLst>
+                          </p:cTn>
+                        </p:par>
+                      </p:childTnLst>
+                    </p:cTn>
+                  </p:par>
+                  <p:par>
+                    <p:cTn id="21" fill="hold">
+                      <p:stCondLst>
+                        <p:cond delay="indefinite"/>
+                      </p:stCondLst>
+                      <p:childTnLst>
+                        <p:par>
+                          <p:cTn id="22" fill="hold">
+                            <p:stCondLst>
+                              <p:cond delay="0"/>
+                            </p:stCondLst>
+                            <p:childTnLst>
+                              <p:par>
+                                <p:cTn id="23" presetID="1" presetClass="entr" presetSubtype="0" fill="hold" nodeType="clickEffect">
+                                  <p:stCondLst>
+                                    <p:cond delay="0"/>
+                                  </p:stCondLst>
+                                  <p:childTnLst>
+                                    <p:set>
+                                      <p:cBhvr>
+                                        <p:cTn id="24" dur="1" fill="hold">
+                                          <p:stCondLst>
+                                            <p:cond delay="0"/>
+                                          </p:stCondLst>
+                                        </p:cTn>
+                                        <p:tgtEl>
+                                          <p:spTgt spid="5">
+                                            <p:txEl>
+                                              <p:pRg st="6" end="6"/>
+                                            </p:txEl>
+                                          </p:spTgt>
+                                        </p:tgtEl>
+                                        <p:attrNameLst>
+                                          <p:attrName>style.visibility</p:attrName>
+                                        </p:attrNameLst>
+                                      </p:cBhvr>
+                                      <p:to>
+                                        <p:strVal val="visible"/>
+                                      </p:to>
+                                    </p:set>
+                                  </p:childTnLst>
+                                </p:cTn>
+                              </p:par>
+                            </p:childTnLst>
+                          </p:cTn>
+                        </p:par>
+                      </p:childTnLst>
+                    </p:cTn>
+                  </p:par>
+                  <p:par>
+                    <p:cTn id="25" fill="hold">
+                      <p:stCondLst>
+                        <p:cond delay="indefinite"/>
+                      </p:stCondLst>
+                      <p:childTnLst>
+                        <p:par>
+                          <p:cTn id="26" fill="hold">
+                            <p:stCondLst>
+                              <p:cond delay="0"/>
+                            </p:stCondLst>
+                            <p:childTnLst>
+                              <p:par>
+                                <p:cTn id="27" presetID="1" presetClass="entr" presetSubtype="0" fill="hold" nodeType="clickEffect">
+                                  <p:stCondLst>
+                                    <p:cond delay="0"/>
+                                  </p:stCondLst>
+                                  <p:childTnLst>
+                                    <p:set>
+                                      <p:cBhvr>
+                                        <p:cTn id="28" dur="1" fill="hold">
+                                          <p:stCondLst>
+                                            <p:cond delay="0"/>
+                                          </p:stCondLst>
+                                        </p:cTn>
+                                        <p:tgtEl>
+                                          <p:spTgt spid="5">
+                                            <p:txEl>
+                                              <p:pRg st="7" end="7"/>
+                                            </p:txEl>
+                                          </p:spTgt>
+                                        </p:tgtEl>
+                                        <p:attrNameLst>
+                                          <p:attrName>style.visibility</p:attrName>
+                                        </p:attrNameLst>
+                                      </p:cBhvr>
+                                      <p:to>
+                                        <p:strVal val="visible"/>
+                                      </p:to>
+                                    </p:set>
+                                  </p:childTnLst>
+                                </p:cTn>
+                              </p:par>
+                            </p:childTnLst>
+                          </p:cTn>
+                        </p:par>
+                      </p:childTnLst>
+                    </p:cTn>
+                  </p:par>
+                  <p:par>
+                    <p:cTn id="29" fill="hold">
+                      <p:stCondLst>
+                        <p:cond delay="indefinite"/>
+                      </p:stCondLst>
+                      <p:childTnLst>
+                        <p:par>
+                          <p:cTn id="30" fill="hold">
+                            <p:stCondLst>
+                              <p:cond delay="0"/>
+                            </p:stCondLst>
+                            <p:childTnLst>
+                              <p:par>
+                                <p:cTn id="31" presetID="1" presetClass="entr" presetSubtype="0" fill="hold" nodeType="clickEffect">
+                                  <p:stCondLst>
+                                    <p:cond delay="0"/>
+                                  </p:stCondLst>
+                                  <p:childTnLst>
+                                    <p:set>
+                                      <p:cBhvr>
+                                        <p:cTn id="32" dur="1" fill="hold">
+                                          <p:stCondLst>
+                                            <p:cond delay="0"/>
+                                          </p:stCondLst>
+                                        </p:cTn>
+                                        <p:tgtEl>
+                                          <p:spTgt spid="5">
+                                            <p:txEl>
+                                              <p:pRg st="8" end="8"/>
+                                            </p:txEl>
+                                          </p:spTgt>
+                                        </p:tgtEl>
+                                        <p:attrNameLst>
+                                          <p:attrName>style.visibility</p:attrName>
+                                        </p:attrNameLst>
+                                      </p:cBhvr>
+                                      <p:to>
+                                        <p:strVal val="visible"/>
+                                      </p:to>
+                                    </p:set>
+                                  </p:childTnLst>
+                                </p:cTn>
+                              </p:par>
+                            </p:childTnLst>
+                          </p:cTn>
+                        </p:par>
+                      </p:childTnLst>
+                    </p:cTn>
+                  </p:par>
+                  <p:par>
+                    <p:cTn id="33" fill="hold">
+                      <p:stCondLst>
+                        <p:cond delay="indefinite"/>
+                      </p:stCondLst>
+                      <p:childTnLst>
+                        <p:par>
+                          <p:cTn id="34" fill="hold">
+                            <p:stCondLst>
+                              <p:cond delay="0"/>
+                            </p:stCondLst>
+                            <p:childTnLst>
+                              <p:par>
+                                <p:cTn id="35" presetID="1" presetClass="entr" presetSubtype="0" fill="hold" nodeType="clickEffect">
+                                  <p:stCondLst>
+                                    <p:cond delay="0"/>
+                                  </p:stCondLst>
+                                  <p:childTnLst>
+                                    <p:set>
+                                      <p:cBhvr>
+                                        <p:cTn id="36" dur="1" fill="hold">
+                                          <p:stCondLst>
+                                            <p:cond delay="0"/>
+                                          </p:stCondLst>
+                                        </p:cTn>
+                                        <p:tgtEl>
+                                          <p:spTgt spid="5">
+                                            <p:txEl>
+                                              <p:pRg st="9" end="9"/>
+                                            </p:txEl>
+                                          </p:spTgt>
+                                        </p:tgtEl>
+                                        <p:attrNameLst>
+                                          <p:attrName>style.visibility</p:attrName>
+                                        </p:attrNameLst>
+                                      </p:cBhvr>
+                                      <p:to>
+                                        <p:strVal val="visible"/>
+                                      </p:to>
+                                    </p:set>
+                                  </p:childTnLst>
+                                </p:cTn>
+                              </p:par>
+                            </p:childTnLst>
+                          </p:cTn>
+                        </p:par>
+                      </p:childTnLst>
+                    </p:cTn>
+                  </p:par>
+                  <p:par>
+                    <p:cTn id="37" fill="hold">
+                      <p:stCondLst>
+                        <p:cond delay="indefinite"/>
+                      </p:stCondLst>
+                      <p:childTnLst>
+                        <p:par>
+                          <p:cTn id="38" fill="hold">
+                            <p:stCondLst>
+                              <p:cond delay="0"/>
+                            </p:stCondLst>
+                            <p:childTnLst>
+                              <p:par>
+                                <p:cTn id="39" presetID="1" presetClass="entr" presetSubtype="0" fill="hold" nodeType="clickEffect">
+                                  <p:stCondLst>
+                                    <p:cond delay="0"/>
+                                  </p:stCondLst>
+                                  <p:childTnLst>
+                                    <p:set>
+                                      <p:cBhvr>
+                                        <p:cTn id="40" dur="1" fill="hold">
+                                          <p:stCondLst>
+                                            <p:cond delay="0"/>
+                                          </p:stCondLst>
+                                        </p:cTn>
+                                        <p:tgtEl>
+                                          <p:spTgt spid="5">
+                                            <p:txEl>
+                                              <p:pRg st="10" end="10"/>
+                                            </p:txEl>
+                                          </p:spTgt>
+                                        </p:tgtEl>
+                                        <p:attrNameLst>
+                                          <p:attrName>style.visibility</p:attrName>
+                                        </p:attrNameLst>
+                                      </p:cBhvr>
+                                      <p:to>
+                                        <p:strVal val="visible"/>
+                                      </p:to>
+                                    </p:set>
+                                  </p:childTnLst>
+                                </p:cTn>
+                              </p:par>
+                            </p:childTnLst>
+                          </p:cTn>
+                        </p:par>
+                      </p:childTnLst>
+                    </p:cTn>
+                  </p:par>
+                  <p:par>
+                    <p:cTn id="41" fill="hold">
+                      <p:stCondLst>
+                        <p:cond delay="indefinite"/>
+                      </p:stCondLst>
+                      <p:childTnLst>
+                        <p:par>
+                          <p:cTn id="42" fill="hold">
+                            <p:stCondLst>
+                              <p:cond delay="0"/>
+                            </p:stCondLst>
+                            <p:childTnLst>
+                              <p:par>
+                                <p:cTn id="43" presetID="1" presetClass="entr" presetSubtype="0" fill="hold" nodeType="clickEffect">
+                                  <p:stCondLst>
+                                    <p:cond delay="0"/>
+                                  </p:stCondLst>
+                                  <p:childTnLst>
+                                    <p:set>
+                                      <p:cBhvr>
+                                        <p:cTn id="44" dur="1" fill="hold">
+                                          <p:stCondLst>
+                                            <p:cond delay="0"/>
+                                          </p:stCondLst>
+                                        </p:cTn>
+                                        <p:tgtEl>
+                                          <p:spTgt spid="5">
+                                            <p:txEl>
+                                              <p:pRg st="11" end="11"/>
+                                            </p:txEl>
+                                          </p:spTgt>
+                                        </p:tgtEl>
+                                        <p:attrNameLst>
+                                          <p:attrName>style.visibility</p:attrName>
+                                        </p:attrNameLst>
+                                      </p:cBhvr>
+                                      <p:to>
+                                        <p:strVal val="visible"/>
+                                      </p:to>
+                                    </p:set>
+                                  </p:childTnLst>
+                                </p:cTn>
+                              </p:par>
+                            </p:childTnLst>
+                          </p:cTn>
+                        </p:par>
+                      </p:childTnLst>
+                    </p:cTn>
+                  </p:par>
+                  <p:par>
+                    <p:cTn id="45" fill="hold">
+                      <p:stCondLst>
+                        <p:cond delay="indefinite"/>
+                      </p:stCondLst>
+                      <p:childTnLst>
+                        <p:par>
+                          <p:cTn id="46" fill="hold">
+                            <p:stCondLst>
+                              <p:cond delay="0"/>
+                            </p:stCondLst>
+                            <p:childTnLst>
+                              <p:par>
+                                <p:cTn id="47" presetID="1" presetClass="entr" presetSubtype="0" fill="hold" nodeType="clickEffect">
+                                  <p:stCondLst>
+                                    <p:cond delay="0"/>
+                                  </p:stCondLst>
+                                  <p:childTnLst>
+                                    <p:set>
+                                      <p:cBhvr>
+                                        <p:cTn id="48" dur="1" fill="hold">
+                                          <p:stCondLst>
+                                            <p:cond delay="0"/>
+                                          </p:stCondLst>
+                                        </p:cTn>
+                                        <p:tgtEl>
+                                          <p:spTgt spid="5">
+                                            <p:txEl>
+                                              <p:pRg st="12" end="12"/>
+                                            </p:txEl>
+                                          </p:spTgt>
+                                        </p:tgtEl>
+                                        <p:attrNameLst>
+                                          <p:attrName>style.visibility</p:attrName>
+                                        </p:attrNameLst>
+                                      </p:cBhvr>
+                                      <p:to>
+                                        <p:strVal val="visible"/>
+                                      </p:to>
+                                    </p:set>
+                                  </p:childTnLst>
+                                </p:cTn>
+                              </p:par>
+                            </p:childTnLst>
+                          </p:cTn>
+                        </p:par>
+                      </p:childTnLst>
+                    </p:cTn>
+                  </p:par>
+                  <p:par>
+                    <p:cTn id="49" fill="hold">
+                      <p:stCondLst>
+                        <p:cond delay="indefinite"/>
+                      </p:stCondLst>
+                      <p:childTnLst>
+                        <p:par>
+                          <p:cTn id="50" fill="hold">
+                            <p:stCondLst>
+                              <p:cond delay="0"/>
+                            </p:stCondLst>
+                            <p:childTnLst>
+                              <p:par>
+                                <p:cTn id="51" presetID="1" presetClass="entr" presetSubtype="0" fill="hold" nodeType="clickEffect">
+                                  <p:stCondLst>
+                                    <p:cond delay="0"/>
+                                  </p:stCondLst>
+                                  <p:childTnLst>
+                                    <p:set>
+                                      <p:cBhvr>
+                                        <p:cTn id="52" dur="1" fill="hold">
+                                          <p:stCondLst>
+                                            <p:cond delay="0"/>
+                                          </p:stCondLst>
+                                        </p:cTn>
+                                        <p:tgtEl>
+                                          <p:spTgt spid="5">
+                                            <p:txEl>
+                                              <p:pRg st="13" end="13"/>
+                                            </p:txEl>
+                                          </p:spTgt>
+                                        </p:tgtEl>
+                                        <p:attrNameLst>
+                                          <p:attrName>style.visibility</p:attrName>
+                                        </p:attrNameLst>
+                                      </p:cBhvr>
+                                      <p:to>
+                                        <p:strVal val="visible"/>
+                                      </p:to>
+                                    </p:set>
+                                  </p:childTnLst>
+                                </p:cTn>
+                              </p:par>
+                            </p:childTnLst>
+                          </p:cTn>
+                        </p:par>
+                      </p:childTnLst>
+                    </p:cTn>
+                  </p:par>
+                  <p:par>
+                    <p:cTn id="53" fill="hold">
+                      <p:stCondLst>
+                        <p:cond delay="indefinite"/>
+                      </p:stCondLst>
+                      <p:childTnLst>
+                        <p:par>
+                          <p:cTn id="54" fill="hold">
+                            <p:stCondLst>
+                              <p:cond delay="0"/>
+                            </p:stCondLst>
+                            <p:childTnLst>
+                              <p:par>
+                                <p:cTn id="55" presetID="1" presetClass="entr" presetSubtype="0" fill="hold" nodeType="clickEffect">
+                                  <p:stCondLst>
+                                    <p:cond delay="0"/>
+                                  </p:stCondLst>
+                                  <p:childTnLst>
+                                    <p:set>
+                                      <p:cBhvr>
+                                        <p:cTn id="56" dur="1" fill="hold">
+                                          <p:stCondLst>
+                                            <p:cond delay="0"/>
+                                          </p:stCondLst>
+                                        </p:cTn>
+                                        <p:tgtEl>
+                                          <p:spTgt spid="5">
+                                            <p:txEl>
+                                              <p:pRg st="14" end="14"/>
+                                            </p:txEl>
+                                          </p:spTgt>
+                                        </p:tgtEl>
+                                        <p:attrNameLst>
+                                          <p:attrName>style.visibility</p:attrName>
+                                        </p:attrNameLst>
+                                      </p:cBhvr>
+                                      <p:to>
+                                        <p:strVal val="visible"/>
+                                      </p:to>
+                                    </p:set>
+                                  </p:childTnLst>
+                                </p:cTn>
+                              </p:par>
+                            </p:childTnLst>
+                          </p:cTn>
+                        </p:par>
+                      </p:childTnLst>
+                    </p:cTn>
+                  </p:par>
+                  <p:par>
+                    <p:cTn id="57" fill="hold">
+                      <p:stCondLst>
+                        <p:cond delay="indefinite"/>
+                      </p:stCondLst>
+                      <p:childTnLst>
+                        <p:par>
+                          <p:cTn id="58" fill="hold">
+                            <p:stCondLst>
+                              <p:cond delay="0"/>
+                            </p:stCondLst>
+                            <p:childTnLst>
+                              <p:par>
+                                <p:cTn id="59" presetID="1" presetClass="entr" presetSubtype="0" fill="hold" nodeType="clickEffect">
+                                  <p:stCondLst>
+                                    <p:cond delay="0"/>
+                                  </p:stCondLst>
+                                  <p:childTnLst>
+                                    <p:set>
+                                      <p:cBhvr>
+                                        <p:cTn id="60" dur="1" fill="hold">
+                                          <p:stCondLst>
+                                            <p:cond delay="0"/>
+                                          </p:stCondLst>
+                                        </p:cTn>
+                                        <p:tgtEl>
+                                          <p:spTgt spid="5">
+                                            <p:txEl>
+                                              <p:pRg st="15" end="15"/>
+                                            </p:txEl>
+                                          </p:spTgt>
+                                        </p:tgtEl>
+                                        <p:attrNameLst>
+                                          <p:attrName>style.visibility</p:attrName>
+                                        </p:attrNameLst>
+                                      </p:cBhvr>
+                                      <p:to>
+                                        <p:strVal val="visible"/>
+                                      </p:to>
+                                    </p:set>
+                                  </p:childTnLst>
+                                </p:cTn>
+                              </p:par>
+                            </p:childTnLst>
+                          </p:cTn>
+                        </p:par>
+                      </p:childTnLst>
+                    </p:cTn>
+                  </p:par>
+                  <p:par>
+                    <p:cTn id="61" fill="hold">
+                      <p:stCondLst>
+                        <p:cond delay="indefinite"/>
+                      </p:stCondLst>
+                      <p:childTnLst>
+                        <p:par>
+                          <p:cTn id="62" fill="hold">
+                            <p:stCondLst>
+                              <p:cond delay="0"/>
+                            </p:stCondLst>
+                            <p:childTnLst>
+                              <p:par>
+                                <p:cTn id="63" presetID="1" presetClass="entr" presetSubtype="0" fill="hold" nodeType="clickEffect">
+                                  <p:stCondLst>
+                                    <p:cond delay="0"/>
+                                  </p:stCondLst>
+                                  <p:childTnLst>
+                                    <p:set>
+                                      <p:cBhvr>
+                                        <p:cTn id="64" dur="1" fill="hold">
+                                          <p:stCondLst>
+                                            <p:cond delay="0"/>
+                                          </p:stCondLst>
+                                        </p:cTn>
+                                        <p:tgtEl>
+                                          <p:spTgt spid="5">
+                                            <p:txEl>
+                                              <p:pRg st="16" end="16"/>
+                                            </p:txEl>
+                                          </p:spTgt>
+                                        </p:tgtEl>
+                                        <p:attrNameLst>
+                                          <p:attrName>style.visibility</p:attrName>
+                                        </p:attrNameLst>
+                                      </p:cBhvr>
+                                      <p:to>
+                                        <p:strVal val="visible"/>
+                                      </p:to>
+                                    </p:set>
+                                  </p:childTnLst>
+                                </p:cTn>
+                              </p:par>
+                            </p:childTnLst>
+                          </p:cTn>
+                        </p:par>
+                      </p:childTnLst>
+                    </p:cTn>
+                  </p:par>
+                </p:childTnLst>
+              </p:cTn>
+              <p:prevCondLst>
+                <p:cond evt="onPrev" delay="0">
+                  <p:tgtEl>
+                    <p:sldTgt/>
+                  </p:tgtEl>
+                </p:cond>
+              </p:prevCondLst>
+              <p:nextCondLst>
+                <p:cond evt="onNext" delay="0">
+                  <p:tgtEl>
+                    <p:sldTgt/>
+                  </p:tgtEl>
+                </p:cond>
+              </p:nextCondLst>
+            </p:seq>
+          </p:childTnLst>
+        </p:cTn>
+      </p:par>
+    </p:tnLst>
+  </p:timing>
 </p:sld>
 </file>
 
@@ -7499,6 +8520,232 @@
   <p:clrMapOvr>
     <a:masterClrMapping/>
   </p:clrMapOvr>
+  <p:timing>
+    <p:tnLst>
+      <p:par>
+        <p:cTn id="1" dur="indefinite" restart="never" nodeType="tmRoot">
+          <p:childTnLst>
+            <p:seq concurrent="1" nextAc="seek">
+              <p:cTn id="2" dur="indefinite" nodeType="mainSeq">
+                <p:childTnLst>
+                  <p:par>
+                    <p:cTn id="3" fill="hold">
+                      <p:stCondLst>
+                        <p:cond delay="indefinite"/>
+                      </p:stCondLst>
+                      <p:childTnLst>
+                        <p:par>
+                          <p:cTn id="4" fill="hold">
+                            <p:stCondLst>
+                              <p:cond delay="0"/>
+                            </p:stCondLst>
+                            <p:childTnLst>
+                              <p:par>
+                                <p:cTn id="5" presetID="1" presetClass="entr" presetSubtype="0" fill="hold" nodeType="clickEffect">
+                                  <p:stCondLst>
+                                    <p:cond delay="0"/>
+                                  </p:stCondLst>
+                                  <p:childTnLst>
+                                    <p:set>
+                                      <p:cBhvr>
+                                        <p:cTn id="6" dur="1" fill="hold">
+                                          <p:stCondLst>
+                                            <p:cond delay="0"/>
+                                          </p:stCondLst>
+                                        </p:cTn>
+                                        <p:tgtEl>
+                                          <p:spTgt spid="5">
+                                            <p:txEl>
+                                              <p:pRg st="2" end="2"/>
+                                            </p:txEl>
+                                          </p:spTgt>
+                                        </p:tgtEl>
+                                        <p:attrNameLst>
+                                          <p:attrName>style.visibility</p:attrName>
+                                        </p:attrNameLst>
+                                      </p:cBhvr>
+                                      <p:to>
+                                        <p:strVal val="visible"/>
+                                      </p:to>
+                                    </p:set>
+                                  </p:childTnLst>
+                                </p:cTn>
+                              </p:par>
+                            </p:childTnLst>
+                          </p:cTn>
+                        </p:par>
+                      </p:childTnLst>
+                    </p:cTn>
+                  </p:par>
+                  <p:par>
+                    <p:cTn id="7" fill="hold">
+                      <p:stCondLst>
+                        <p:cond delay="indefinite"/>
+                      </p:stCondLst>
+                      <p:childTnLst>
+                        <p:par>
+                          <p:cTn id="8" fill="hold">
+                            <p:stCondLst>
+                              <p:cond delay="0"/>
+                            </p:stCondLst>
+                            <p:childTnLst>
+                              <p:par>
+                                <p:cTn id="9" presetID="1" presetClass="entr" presetSubtype="0" fill="hold" nodeType="clickEffect">
+                                  <p:stCondLst>
+                                    <p:cond delay="0"/>
+                                  </p:stCondLst>
+                                  <p:childTnLst>
+                                    <p:set>
+                                      <p:cBhvr>
+                                        <p:cTn id="10" dur="1" fill="hold">
+                                          <p:stCondLst>
+                                            <p:cond delay="0"/>
+                                          </p:stCondLst>
+                                        </p:cTn>
+                                        <p:tgtEl>
+                                          <p:spTgt spid="5">
+                                            <p:txEl>
+                                              <p:pRg st="4" end="4"/>
+                                            </p:txEl>
+                                          </p:spTgt>
+                                        </p:tgtEl>
+                                        <p:attrNameLst>
+                                          <p:attrName>style.visibility</p:attrName>
+                                        </p:attrNameLst>
+                                      </p:cBhvr>
+                                      <p:to>
+                                        <p:strVal val="visible"/>
+                                      </p:to>
+                                    </p:set>
+                                  </p:childTnLst>
+                                </p:cTn>
+                              </p:par>
+                            </p:childTnLst>
+                          </p:cTn>
+                        </p:par>
+                      </p:childTnLst>
+                    </p:cTn>
+                  </p:par>
+                  <p:par>
+                    <p:cTn id="11" fill="hold">
+                      <p:stCondLst>
+                        <p:cond delay="indefinite"/>
+                      </p:stCondLst>
+                      <p:childTnLst>
+                        <p:par>
+                          <p:cTn id="12" fill="hold">
+                            <p:stCondLst>
+                              <p:cond delay="0"/>
+                            </p:stCondLst>
+                            <p:childTnLst>
+                              <p:par>
+                                <p:cTn id="13" presetID="1" presetClass="entr" presetSubtype="0" fill="hold" nodeType="clickEffect">
+                                  <p:stCondLst>
+                                    <p:cond delay="0"/>
+                                  </p:stCondLst>
+                                  <p:childTnLst>
+                                    <p:set>
+                                      <p:cBhvr>
+                                        <p:cTn id="14" dur="1" fill="hold">
+                                          <p:stCondLst>
+                                            <p:cond delay="0"/>
+                                          </p:stCondLst>
+                                        </p:cTn>
+                                        <p:tgtEl>
+                                          <p:spTgt spid="5">
+                                            <p:txEl>
+                                              <p:pRg st="6" end="6"/>
+                                            </p:txEl>
+                                          </p:spTgt>
+                                        </p:tgtEl>
+                                        <p:attrNameLst>
+                                          <p:attrName>style.visibility</p:attrName>
+                                        </p:attrNameLst>
+                                      </p:cBhvr>
+                                      <p:to>
+                                        <p:strVal val="visible"/>
+                                      </p:to>
+                                    </p:set>
+                                  </p:childTnLst>
+                                </p:cTn>
+                              </p:par>
+                            </p:childTnLst>
+                          </p:cTn>
+                        </p:par>
+                      </p:childTnLst>
+                    </p:cTn>
+                  </p:par>
+                  <p:par>
+                    <p:cTn id="15" fill="hold">
+                      <p:stCondLst>
+                        <p:cond delay="indefinite"/>
+                      </p:stCondLst>
+                      <p:childTnLst>
+                        <p:par>
+                          <p:cTn id="16" fill="hold">
+                            <p:stCondLst>
+                              <p:cond delay="0"/>
+                            </p:stCondLst>
+                            <p:childTnLst>
+                              <p:par>
+                                <p:cTn id="17" presetID="1" presetClass="entr" presetSubtype="0" fill="hold" nodeType="clickEffect">
+                                  <p:stCondLst>
+                                    <p:cond delay="0"/>
+                                  </p:stCondLst>
+                                  <p:childTnLst>
+                                    <p:set>
+                                      <p:cBhvr>
+                                        <p:cTn id="18" dur="1" fill="hold">
+                                          <p:stCondLst>
+                                            <p:cond delay="0"/>
+                                          </p:stCondLst>
+                                        </p:cTn>
+                                        <p:tgtEl>
+                                          <p:spTgt spid="5">
+                                            <p:txEl>
+                                              <p:pRg st="8" end="8"/>
+                                            </p:txEl>
+                                          </p:spTgt>
+                                        </p:tgtEl>
+                                        <p:attrNameLst>
+                                          <p:attrName>style.visibility</p:attrName>
+                                        </p:attrNameLst>
+                                      </p:cBhvr>
+                                      <p:to>
+                                        <p:strVal val="visible"/>
+                                      </p:to>
+                                    </p:set>
+                                  </p:childTnLst>
+                                </p:cTn>
+                              </p:par>
+                            </p:childTnLst>
+                          </p:cTn>
+                        </p:par>
+                      </p:childTnLst>
+                    </p:cTn>
+                  </p:par>
+                </p:childTnLst>
+              </p:cTn>
+              <p:prevCondLst>
+                <p:cond evt="onPrev" delay="0">
+                  <p:tgtEl>
+                    <p:sldTgt/>
+                  </p:tgtEl>
+                </p:cond>
+              </p:prevCondLst>
+              <p:nextCondLst>
+                <p:cond evt="onNext" delay="0">
+                  <p:tgtEl>
+                    <p:sldTgt/>
+                  </p:tgtEl>
+                </p:cond>
+              </p:nextCondLst>
+            </p:seq>
+          </p:childTnLst>
+        </p:cTn>
+      </p:par>
+    </p:tnLst>
+  </p:timing>
 </p:sld>
 </file>
 
@@ -8508,7 +9755,15 @@
             </a:pPr>
             <a:r>
               <a:rPr lang="de-DE" sz="1200"/>
-              <a:t>Bsp.: Explizite Workflow-Adapter.exe die mit dem JobHost per CLI-Calls kommuniziert.</a:t>
+              <a:t>Bsp.: Explizite Workflow-Adapter.exe, die mit dem JobHost per </a:t>
+            </a:r>
+            <a:r>
+              <a:rPr lang="de-DE" sz="1200" i="1"/>
+              <a:t>CLI-Calls</a:t>
+            </a:r>
+            <a:r>
+              <a:rPr lang="de-DE" sz="1200"/>
+              <a:t> kommuniziert.</a:t>
             </a:r>
           </a:p>
           <a:p>
@@ -8751,6 +10006,276 @@
   <p:clrMapOvr>
     <a:masterClrMapping/>
   </p:clrMapOvr>
+  <p:timing>
+    <p:tnLst>
+      <p:par>
+        <p:cTn id="1" dur="indefinite" restart="never" nodeType="tmRoot">
+          <p:childTnLst>
+            <p:seq concurrent="1" nextAc="seek">
+              <p:cTn id="2" dur="indefinite" nodeType="mainSeq">
+                <p:childTnLst>
+                  <p:par>
+                    <p:cTn id="3" fill="hold">
+                      <p:stCondLst>
+                        <p:cond delay="indefinite"/>
+                      </p:stCondLst>
+                      <p:childTnLst>
+                        <p:par>
+                          <p:cTn id="4" fill="hold">
+                            <p:stCondLst>
+                              <p:cond delay="0"/>
+                            </p:stCondLst>
+                            <p:childTnLst>
+                              <p:par>
+                                <p:cTn id="5" presetID="1" presetClass="entr" presetSubtype="0" fill="hold" nodeType="clickEffect">
+                                  <p:stCondLst>
+                                    <p:cond delay="0"/>
+                                  </p:stCondLst>
+                                  <p:childTnLst>
+                                    <p:set>
+                                      <p:cBhvr>
+                                        <p:cTn id="6" dur="1" fill="hold">
+                                          <p:stCondLst>
+                                            <p:cond delay="0"/>
+                                          </p:stCondLst>
+                                        </p:cTn>
+                                        <p:tgtEl>
+                                          <p:spTgt spid="65">
+                                            <p:txEl>
+                                              <p:pRg st="0" end="0"/>
+                                            </p:txEl>
+                                          </p:spTgt>
+                                        </p:tgtEl>
+                                        <p:attrNameLst>
+                                          <p:attrName>style.visibility</p:attrName>
+                                        </p:attrNameLst>
+                                      </p:cBhvr>
+                                      <p:to>
+                                        <p:strVal val="visible"/>
+                                      </p:to>
+                                    </p:set>
+                                  </p:childTnLst>
+                                </p:cTn>
+                              </p:par>
+                              <p:par>
+                                <p:cTn id="7" presetID="1" presetClass="entr" presetSubtype="0" fill="hold" nodeType="withEffect">
+                                  <p:stCondLst>
+                                    <p:cond delay="0"/>
+                                  </p:stCondLst>
+                                  <p:childTnLst>
+                                    <p:set>
+                                      <p:cBhvr>
+                                        <p:cTn id="8" dur="1" fill="hold">
+                                          <p:stCondLst>
+                                            <p:cond delay="0"/>
+                                          </p:stCondLst>
+                                        </p:cTn>
+                                        <p:tgtEl>
+                                          <p:spTgt spid="65">
+                                            <p:txEl>
+                                              <p:pRg st="1" end="1"/>
+                                            </p:txEl>
+                                          </p:spTgt>
+                                        </p:tgtEl>
+                                        <p:attrNameLst>
+                                          <p:attrName>style.visibility</p:attrName>
+                                        </p:attrNameLst>
+                                      </p:cBhvr>
+                                      <p:to>
+                                        <p:strVal val="visible"/>
+                                      </p:to>
+                                    </p:set>
+                                  </p:childTnLst>
+                                </p:cTn>
+                              </p:par>
+                            </p:childTnLst>
+                          </p:cTn>
+                        </p:par>
+                      </p:childTnLst>
+                    </p:cTn>
+                  </p:par>
+                  <p:par>
+                    <p:cTn id="9" fill="hold">
+                      <p:stCondLst>
+                        <p:cond delay="indefinite"/>
+                      </p:stCondLst>
+                      <p:childTnLst>
+                        <p:par>
+                          <p:cTn id="10" fill="hold">
+                            <p:stCondLst>
+                              <p:cond delay="0"/>
+                            </p:stCondLst>
+                            <p:childTnLst>
+                              <p:par>
+                                <p:cTn id="11" presetID="1" presetClass="entr" presetSubtype="0" fill="hold" nodeType="clickEffect">
+                                  <p:stCondLst>
+                                    <p:cond delay="0"/>
+                                  </p:stCondLst>
+                                  <p:childTnLst>
+                                    <p:set>
+                                      <p:cBhvr>
+                                        <p:cTn id="12" dur="1" fill="hold">
+                                          <p:stCondLst>
+                                            <p:cond delay="0"/>
+                                          </p:stCondLst>
+                                        </p:cTn>
+                                        <p:tgtEl>
+                                          <p:spTgt spid="65">
+                                            <p:txEl>
+                                              <p:pRg st="2" end="2"/>
+                                            </p:txEl>
+                                          </p:spTgt>
+                                        </p:tgtEl>
+                                        <p:attrNameLst>
+                                          <p:attrName>style.visibility</p:attrName>
+                                        </p:attrNameLst>
+                                      </p:cBhvr>
+                                      <p:to>
+                                        <p:strVal val="visible"/>
+                                      </p:to>
+                                    </p:set>
+                                  </p:childTnLst>
+                                </p:cTn>
+                              </p:par>
+                              <p:par>
+                                <p:cTn id="13" presetID="1" presetClass="entr" presetSubtype="0" fill="hold" nodeType="withEffect">
+                                  <p:stCondLst>
+                                    <p:cond delay="0"/>
+                                  </p:stCondLst>
+                                  <p:childTnLst>
+                                    <p:set>
+                                      <p:cBhvr>
+                                        <p:cTn id="14" dur="1" fill="hold">
+                                          <p:stCondLst>
+                                            <p:cond delay="0"/>
+                                          </p:stCondLst>
+                                        </p:cTn>
+                                        <p:tgtEl>
+                                          <p:spTgt spid="65">
+                                            <p:txEl>
+                                              <p:pRg st="3" end="3"/>
+                                            </p:txEl>
+                                          </p:spTgt>
+                                        </p:tgtEl>
+                                        <p:attrNameLst>
+                                          <p:attrName>style.visibility</p:attrName>
+                                        </p:attrNameLst>
+                                      </p:cBhvr>
+                                      <p:to>
+                                        <p:strVal val="visible"/>
+                                      </p:to>
+                                    </p:set>
+                                  </p:childTnLst>
+                                </p:cTn>
+                              </p:par>
+                              <p:par>
+                                <p:cTn id="15" presetID="1" presetClass="entr" presetSubtype="0" fill="hold" nodeType="withEffect">
+                                  <p:stCondLst>
+                                    <p:cond delay="0"/>
+                                  </p:stCondLst>
+                                  <p:childTnLst>
+                                    <p:set>
+                                      <p:cBhvr>
+                                        <p:cTn id="16" dur="1" fill="hold">
+                                          <p:stCondLst>
+                                            <p:cond delay="0"/>
+                                          </p:stCondLst>
+                                        </p:cTn>
+                                        <p:tgtEl>
+                                          <p:spTgt spid="65">
+                                            <p:txEl>
+                                              <p:pRg st="4" end="4"/>
+                                            </p:txEl>
+                                          </p:spTgt>
+                                        </p:tgtEl>
+                                        <p:attrNameLst>
+                                          <p:attrName>style.visibility</p:attrName>
+                                        </p:attrNameLst>
+                                      </p:cBhvr>
+                                      <p:to>
+                                        <p:strVal val="visible"/>
+                                      </p:to>
+                                    </p:set>
+                                  </p:childTnLst>
+                                </p:cTn>
+                              </p:par>
+                            </p:childTnLst>
+                          </p:cTn>
+                        </p:par>
+                      </p:childTnLst>
+                    </p:cTn>
+                  </p:par>
+                  <p:par>
+                    <p:cTn id="17" fill="hold">
+                      <p:stCondLst>
+                        <p:cond delay="indefinite"/>
+                      </p:stCondLst>
+                      <p:childTnLst>
+                        <p:par>
+                          <p:cTn id="18" fill="hold">
+                            <p:stCondLst>
+                              <p:cond delay="0"/>
+                            </p:stCondLst>
+                            <p:childTnLst>
+                              <p:par>
+                                <p:cTn id="19" presetID="1" presetClass="entr" presetSubtype="0" fill="hold" nodeType="clickEffect">
+                                  <p:stCondLst>
+                                    <p:cond delay="0"/>
+                                  </p:stCondLst>
+                                  <p:childTnLst>
+                                    <p:set>
+                                      <p:cBhvr>
+                                        <p:cTn id="20" dur="1" fill="hold">
+                                          <p:stCondLst>
+                                            <p:cond delay="0"/>
+                                          </p:stCondLst>
+                                        </p:cTn>
+                                        <p:tgtEl>
+                                          <p:spTgt spid="65">
+                                            <p:txEl>
+                                              <p:pRg st="5" end="5"/>
+                                            </p:txEl>
+                                          </p:spTgt>
+                                        </p:tgtEl>
+                                        <p:attrNameLst>
+                                          <p:attrName>style.visibility</p:attrName>
+                                        </p:attrNameLst>
+                                      </p:cBhvr>
+                                      <p:to>
+                                        <p:strVal val="visible"/>
+                                      </p:to>
+                                    </p:set>
+                                  </p:childTnLst>
+                                </p:cTn>
+                              </p:par>
+                            </p:childTnLst>
+                          </p:cTn>
+                        </p:par>
+                      </p:childTnLst>
+                    </p:cTn>
+                  </p:par>
+                </p:childTnLst>
+              </p:cTn>
+              <p:prevCondLst>
+                <p:cond evt="onPrev" delay="0">
+                  <p:tgtEl>
+                    <p:sldTgt/>
+                  </p:tgtEl>
+                </p:cond>
+              </p:prevCondLst>
+              <p:nextCondLst>
+                <p:cond evt="onNext" delay="0">
+                  <p:tgtEl>
+                    <p:sldTgt/>
+                  </p:tgtEl>
+                </p:cond>
+              </p:nextCondLst>
+            </p:seq>
+          </p:childTnLst>
+        </p:cTn>
+      </p:par>
+    </p:tnLst>
+  </p:timing>
 </p:sld>
 </file>
 
@@ -8786,7 +10311,7 @@
         <p:spPr>
           <a:xfrm>
             <a:off x="787667" y="170347"/>
-            <a:ext cx="10616666" cy="6309420"/>
+            <a:ext cx="10616666" cy="6247864"/>
           </a:xfrm>
           <a:prstGeom prst="rect">
             <a:avLst/>
@@ -8850,7 +10375,7 @@
                   <a:srgbClr val="00B050"/>
                 </a:solidFill>
               </a:rPr>
-              <a:t>josyn</a:t>
+              <a:t>josyn?</a:t>
             </a:r>
             <a:endParaRPr lang="de-DE" sz="2400">
               <a:solidFill>
@@ -8860,7 +10385,7 @@
           </a:p>
           <a:p>
             <a:pPr algn="ctr"/>
-            <a:endParaRPr lang="de-DE" sz="2400"/>
+            <a:endParaRPr lang="de-DE" sz="1200"/>
           </a:p>
           <a:p>
             <a:pPr algn="ctr"/>
@@ -8886,13 +10411,32 @@
             </a:r>
             <a:r>
               <a:rPr lang="de-DE" sz="2400"/>
-              <a:t>- ein undenkbarer Aufwand! </a:t>
+              <a:t>- ein undenkbarer </a:t>
+            </a:r>
+            <a:r>
+              <a:rPr lang="de-DE" sz="2400" b="1">
+                <a:solidFill>
+                  <a:srgbClr val="FF0000"/>
+                </a:solidFill>
+              </a:rPr>
+              <a:t>Aufwand! </a:t>
             </a:r>
           </a:p>
           <a:p>
             <a:pPr algn="ctr"/>
             <a:r>
-              <a:rPr lang="de-DE" sz="2400"/>
+              <a:rPr lang="de-DE" sz="2400" b="1">
+                <a:solidFill>
+                  <a:srgbClr val="FF0000"/>
+                </a:solidFill>
+              </a:rPr>
+              <a:t>Nicht machbar! Viel zu teuer!</a:t>
+            </a:r>
+          </a:p>
+          <a:p>
+            <a:pPr algn="ctr"/>
+            <a:r>
+              <a:rPr lang="de-DE" sz="1600"/>
               <a:t>(Lass uns lieber den Legacy-Opa so lange pflegen, beatmen und mit weiteren Prothesen ausrüsten, bis es ein Problem anderer Leute ist…)</a:t>
             </a:r>
           </a:p>
@@ -8967,6 +10511,521 @@
   <p:clrMapOvr>
     <a:masterClrMapping/>
   </p:clrMapOvr>
+  <p:timing>
+    <p:tnLst>
+      <p:par>
+        <p:cTn id="1" dur="indefinite" restart="never" nodeType="tmRoot">
+          <p:childTnLst>
+            <p:seq concurrent="1" nextAc="seek">
+              <p:cTn id="2" dur="indefinite" nodeType="mainSeq">
+                <p:childTnLst>
+                  <p:par>
+                    <p:cTn id="3" fill="hold">
+                      <p:stCondLst>
+                        <p:cond delay="indefinite"/>
+                      </p:stCondLst>
+                      <p:childTnLst>
+                        <p:par>
+                          <p:cTn id="4" fill="hold">
+                            <p:stCondLst>
+                              <p:cond delay="0"/>
+                            </p:stCondLst>
+                            <p:childTnLst>
+                              <p:par>
+                                <p:cTn id="5" presetID="1" presetClass="entr" presetSubtype="0" fill="hold" nodeType="clickEffect">
+                                  <p:stCondLst>
+                                    <p:cond delay="0"/>
+                                  </p:stCondLst>
+                                  <p:childTnLst>
+                                    <p:set>
+                                      <p:cBhvr>
+                                        <p:cTn id="6" dur="1" fill="hold">
+                                          <p:stCondLst>
+                                            <p:cond delay="0"/>
+                                          </p:stCondLst>
+                                        </p:cTn>
+                                        <p:tgtEl>
+                                          <p:spTgt spid="4">
+                                            <p:txEl>
+                                              <p:pRg st="3" end="3"/>
+                                            </p:txEl>
+                                          </p:spTgt>
+                                        </p:tgtEl>
+                                        <p:attrNameLst>
+                                          <p:attrName>style.visibility</p:attrName>
+                                        </p:attrNameLst>
+                                      </p:cBhvr>
+                                      <p:to>
+                                        <p:strVal val="visible"/>
+                                      </p:to>
+                                    </p:set>
+                                  </p:childTnLst>
+                                </p:cTn>
+                              </p:par>
+                              <p:par>
+                                <p:cTn id="7" presetID="1" presetClass="entr" presetSubtype="0" fill="hold" nodeType="withEffect">
+                                  <p:stCondLst>
+                                    <p:cond delay="0"/>
+                                  </p:stCondLst>
+                                  <p:childTnLst>
+                                    <p:set>
+                                      <p:cBhvr>
+                                        <p:cTn id="8" dur="1" fill="hold">
+                                          <p:stCondLst>
+                                            <p:cond delay="0"/>
+                                          </p:stCondLst>
+                                        </p:cTn>
+                                        <p:tgtEl>
+                                          <p:spTgt spid="4">
+                                            <p:txEl>
+                                              <p:pRg st="4" end="4"/>
+                                            </p:txEl>
+                                          </p:spTgt>
+                                        </p:tgtEl>
+                                        <p:attrNameLst>
+                                          <p:attrName>style.visibility</p:attrName>
+                                        </p:attrNameLst>
+                                      </p:cBhvr>
+                                      <p:to>
+                                        <p:strVal val="visible"/>
+                                      </p:to>
+                                    </p:set>
+                                  </p:childTnLst>
+                                </p:cTn>
+                              </p:par>
+                              <p:par>
+                                <p:cTn id="9" presetID="1" presetClass="entr" presetSubtype="0" fill="hold" nodeType="withEffect">
+                                  <p:stCondLst>
+                                    <p:cond delay="0"/>
+                                  </p:stCondLst>
+                                  <p:childTnLst>
+                                    <p:set>
+                                      <p:cBhvr>
+                                        <p:cTn id="10" dur="1" fill="hold">
+                                          <p:stCondLst>
+                                            <p:cond delay="0"/>
+                                          </p:stCondLst>
+                                        </p:cTn>
+                                        <p:tgtEl>
+                                          <p:spTgt spid="4">
+                                            <p:txEl>
+                                              <p:pRg st="5" end="5"/>
+                                            </p:txEl>
+                                          </p:spTgt>
+                                        </p:tgtEl>
+                                        <p:attrNameLst>
+                                          <p:attrName>style.visibility</p:attrName>
+                                        </p:attrNameLst>
+                                      </p:cBhvr>
+                                      <p:to>
+                                        <p:strVal val="visible"/>
+                                      </p:to>
+                                    </p:set>
+                                  </p:childTnLst>
+                                </p:cTn>
+                              </p:par>
+                            </p:childTnLst>
+                          </p:cTn>
+                        </p:par>
+                      </p:childTnLst>
+                    </p:cTn>
+                  </p:par>
+                  <p:par>
+                    <p:cTn id="11" fill="hold">
+                      <p:stCondLst>
+                        <p:cond delay="indefinite"/>
+                      </p:stCondLst>
+                      <p:childTnLst>
+                        <p:par>
+                          <p:cTn id="12" fill="hold">
+                            <p:stCondLst>
+                              <p:cond delay="0"/>
+                            </p:stCondLst>
+                            <p:childTnLst>
+                              <p:par>
+                                <p:cTn id="13" presetID="1" presetClass="entr" presetSubtype="0" fill="hold" nodeType="clickEffect">
+                                  <p:stCondLst>
+                                    <p:cond delay="0"/>
+                                  </p:stCondLst>
+                                  <p:childTnLst>
+                                    <p:set>
+                                      <p:cBhvr>
+                                        <p:cTn id="14" dur="1" fill="hold">
+                                          <p:stCondLst>
+                                            <p:cond delay="0"/>
+                                          </p:stCondLst>
+                                        </p:cTn>
+                                        <p:tgtEl>
+                                          <p:spTgt spid="4">
+                                            <p:txEl>
+                                              <p:pRg st="7" end="7"/>
+                                            </p:txEl>
+                                          </p:spTgt>
+                                        </p:tgtEl>
+                                        <p:attrNameLst>
+                                          <p:attrName>style.visibility</p:attrName>
+                                        </p:attrNameLst>
+                                      </p:cBhvr>
+                                      <p:to>
+                                        <p:strVal val="visible"/>
+                                      </p:to>
+                                    </p:set>
+                                  </p:childTnLst>
+                                </p:cTn>
+                              </p:par>
+                            </p:childTnLst>
+                          </p:cTn>
+                        </p:par>
+                      </p:childTnLst>
+                    </p:cTn>
+                  </p:par>
+                  <p:par>
+                    <p:cTn id="15" fill="hold">
+                      <p:stCondLst>
+                        <p:cond delay="indefinite"/>
+                      </p:stCondLst>
+                      <p:childTnLst>
+                        <p:par>
+                          <p:cTn id="16" fill="hold">
+                            <p:stCondLst>
+                              <p:cond delay="0"/>
+                            </p:stCondLst>
+                            <p:childTnLst>
+                              <p:par>
+                                <p:cTn id="17" presetID="1" presetClass="entr" presetSubtype="0" fill="hold" nodeType="clickEffect">
+                                  <p:stCondLst>
+                                    <p:cond delay="0"/>
+                                  </p:stCondLst>
+                                  <p:childTnLst>
+                                    <p:set>
+                                      <p:cBhvr>
+                                        <p:cTn id="18" dur="1" fill="hold">
+                                          <p:stCondLst>
+                                            <p:cond delay="0"/>
+                                          </p:stCondLst>
+                                        </p:cTn>
+                                        <p:tgtEl>
+                                          <p:spTgt spid="4">
+                                            <p:txEl>
+                                              <p:pRg st="8" end="8"/>
+                                            </p:txEl>
+                                          </p:spTgt>
+                                        </p:tgtEl>
+                                        <p:attrNameLst>
+                                          <p:attrName>style.visibility</p:attrName>
+                                        </p:attrNameLst>
+                                      </p:cBhvr>
+                                      <p:to>
+                                        <p:strVal val="visible"/>
+                                      </p:to>
+                                    </p:set>
+                                  </p:childTnLst>
+                                </p:cTn>
+                              </p:par>
+                              <p:par>
+                                <p:cTn id="19" presetID="1" presetClass="entr" presetSubtype="0" fill="hold" nodeType="withEffect">
+                                  <p:stCondLst>
+                                    <p:cond delay="0"/>
+                                  </p:stCondLst>
+                                  <p:childTnLst>
+                                    <p:set>
+                                      <p:cBhvr>
+                                        <p:cTn id="20" dur="1" fill="hold">
+                                          <p:stCondLst>
+                                            <p:cond delay="0"/>
+                                          </p:stCondLst>
+                                        </p:cTn>
+                                        <p:tgtEl>
+                                          <p:spTgt spid="4">
+                                            <p:txEl>
+                                              <p:pRg st="9" end="9"/>
+                                            </p:txEl>
+                                          </p:spTgt>
+                                        </p:tgtEl>
+                                        <p:attrNameLst>
+                                          <p:attrName>style.visibility</p:attrName>
+                                        </p:attrNameLst>
+                                      </p:cBhvr>
+                                      <p:to>
+                                        <p:strVal val="visible"/>
+                                      </p:to>
+                                    </p:set>
+                                  </p:childTnLst>
+                                </p:cTn>
+                              </p:par>
+                            </p:childTnLst>
+                          </p:cTn>
+                        </p:par>
+                      </p:childTnLst>
+                    </p:cTn>
+                  </p:par>
+                  <p:par>
+                    <p:cTn id="21" fill="hold">
+                      <p:stCondLst>
+                        <p:cond delay="indefinite"/>
+                      </p:stCondLst>
+                      <p:childTnLst>
+                        <p:par>
+                          <p:cTn id="22" fill="hold">
+                            <p:stCondLst>
+                              <p:cond delay="0"/>
+                            </p:stCondLst>
+                            <p:childTnLst>
+                              <p:par>
+                                <p:cTn id="23" presetID="1" presetClass="entr" presetSubtype="0" fill="hold" nodeType="clickEffect">
+                                  <p:stCondLst>
+                                    <p:cond delay="0"/>
+                                  </p:stCondLst>
+                                  <p:childTnLst>
+                                    <p:set>
+                                      <p:cBhvr>
+                                        <p:cTn id="24" dur="1" fill="hold">
+                                          <p:stCondLst>
+                                            <p:cond delay="0"/>
+                                          </p:stCondLst>
+                                        </p:cTn>
+                                        <p:tgtEl>
+                                          <p:spTgt spid="4">
+                                            <p:txEl>
+                                              <p:pRg st="11" end="11"/>
+                                            </p:txEl>
+                                          </p:spTgt>
+                                        </p:tgtEl>
+                                        <p:attrNameLst>
+                                          <p:attrName>style.visibility</p:attrName>
+                                        </p:attrNameLst>
+                                      </p:cBhvr>
+                                      <p:to>
+                                        <p:strVal val="visible"/>
+                                      </p:to>
+                                    </p:set>
+                                  </p:childTnLst>
+                                </p:cTn>
+                              </p:par>
+                            </p:childTnLst>
+                          </p:cTn>
+                        </p:par>
+                      </p:childTnLst>
+                    </p:cTn>
+                  </p:par>
+                  <p:par>
+                    <p:cTn id="25" fill="hold">
+                      <p:stCondLst>
+                        <p:cond delay="indefinite"/>
+                      </p:stCondLst>
+                      <p:childTnLst>
+                        <p:par>
+                          <p:cTn id="26" fill="hold">
+                            <p:stCondLst>
+                              <p:cond delay="0"/>
+                            </p:stCondLst>
+                            <p:childTnLst>
+                              <p:par>
+                                <p:cTn id="27" presetID="1" presetClass="entr" presetSubtype="0" fill="hold" nodeType="clickEffect">
+                                  <p:stCondLst>
+                                    <p:cond delay="0"/>
+                                  </p:stCondLst>
+                                  <p:childTnLst>
+                                    <p:set>
+                                      <p:cBhvr>
+                                        <p:cTn id="28" dur="1" fill="hold">
+                                          <p:stCondLst>
+                                            <p:cond delay="0"/>
+                                          </p:stCondLst>
+                                        </p:cTn>
+                                        <p:tgtEl>
+                                          <p:spTgt spid="4">
+                                            <p:txEl>
+                                              <p:pRg st="12" end="12"/>
+                                            </p:txEl>
+                                          </p:spTgt>
+                                        </p:tgtEl>
+                                        <p:attrNameLst>
+                                          <p:attrName>style.visibility</p:attrName>
+                                        </p:attrNameLst>
+                                      </p:cBhvr>
+                                      <p:to>
+                                        <p:strVal val="visible"/>
+                                      </p:to>
+                                    </p:set>
+                                  </p:childTnLst>
+                                </p:cTn>
+                              </p:par>
+                            </p:childTnLst>
+                          </p:cTn>
+                        </p:par>
+                      </p:childTnLst>
+                    </p:cTn>
+                  </p:par>
+                  <p:par>
+                    <p:cTn id="29" fill="hold">
+                      <p:stCondLst>
+                        <p:cond delay="indefinite"/>
+                      </p:stCondLst>
+                      <p:childTnLst>
+                        <p:par>
+                          <p:cTn id="30" fill="hold">
+                            <p:stCondLst>
+                              <p:cond delay="0"/>
+                            </p:stCondLst>
+                            <p:childTnLst>
+                              <p:par>
+                                <p:cTn id="31" presetID="1" presetClass="entr" presetSubtype="0" fill="hold" nodeType="clickEffect">
+                                  <p:stCondLst>
+                                    <p:cond delay="0"/>
+                                  </p:stCondLst>
+                                  <p:childTnLst>
+                                    <p:set>
+                                      <p:cBhvr>
+                                        <p:cTn id="32" dur="1" fill="hold">
+                                          <p:stCondLst>
+                                            <p:cond delay="0"/>
+                                          </p:stCondLst>
+                                        </p:cTn>
+                                        <p:tgtEl>
+                                          <p:spTgt spid="4">
+                                            <p:txEl>
+                                              <p:pRg st="13" end="13"/>
+                                            </p:txEl>
+                                          </p:spTgt>
+                                        </p:tgtEl>
+                                        <p:attrNameLst>
+                                          <p:attrName>style.visibility</p:attrName>
+                                        </p:attrNameLst>
+                                      </p:cBhvr>
+                                      <p:to>
+                                        <p:strVal val="visible"/>
+                                      </p:to>
+                                    </p:set>
+                                  </p:childTnLst>
+                                </p:cTn>
+                              </p:par>
+                            </p:childTnLst>
+                          </p:cTn>
+                        </p:par>
+                      </p:childTnLst>
+                    </p:cTn>
+                  </p:par>
+                  <p:par>
+                    <p:cTn id="33" fill="hold">
+                      <p:stCondLst>
+                        <p:cond delay="indefinite"/>
+                      </p:stCondLst>
+                      <p:childTnLst>
+                        <p:par>
+                          <p:cTn id="34" fill="hold">
+                            <p:stCondLst>
+                              <p:cond delay="0"/>
+                            </p:stCondLst>
+                            <p:childTnLst>
+                              <p:par>
+                                <p:cTn id="35" presetID="1" presetClass="entr" presetSubtype="0" fill="hold" nodeType="clickEffect">
+                                  <p:stCondLst>
+                                    <p:cond delay="0"/>
+                                  </p:stCondLst>
+                                  <p:childTnLst>
+                                    <p:set>
+                                      <p:cBhvr>
+                                        <p:cTn id="36" dur="1" fill="hold">
+                                          <p:stCondLst>
+                                            <p:cond delay="0"/>
+                                          </p:stCondLst>
+                                        </p:cTn>
+                                        <p:tgtEl>
+                                          <p:spTgt spid="4">
+                                            <p:txEl>
+                                              <p:pRg st="14" end="14"/>
+                                            </p:txEl>
+                                          </p:spTgt>
+                                        </p:tgtEl>
+                                        <p:attrNameLst>
+                                          <p:attrName>style.visibility</p:attrName>
+                                        </p:attrNameLst>
+                                      </p:cBhvr>
+                                      <p:to>
+                                        <p:strVal val="visible"/>
+                                      </p:to>
+                                    </p:set>
+                                  </p:childTnLst>
+                                </p:cTn>
+                              </p:par>
+                            </p:childTnLst>
+                          </p:cTn>
+                        </p:par>
+                      </p:childTnLst>
+                    </p:cTn>
+                  </p:par>
+                  <p:par>
+                    <p:cTn id="37" fill="hold">
+                      <p:stCondLst>
+                        <p:cond delay="indefinite"/>
+                      </p:stCondLst>
+                      <p:childTnLst>
+                        <p:par>
+                          <p:cTn id="38" fill="hold">
+                            <p:stCondLst>
+                              <p:cond delay="0"/>
+                            </p:stCondLst>
+                            <p:childTnLst>
+                              <p:par>
+                                <p:cTn id="39" presetID="1" presetClass="entr" presetSubtype="0" fill="hold" nodeType="clickEffect">
+                                  <p:stCondLst>
+                                    <p:cond delay="0"/>
+                                  </p:stCondLst>
+                                  <p:childTnLst>
+                                    <p:set>
+                                      <p:cBhvr>
+                                        <p:cTn id="40" dur="1" fill="hold">
+                                          <p:stCondLst>
+                                            <p:cond delay="0"/>
+                                          </p:stCondLst>
+                                        </p:cTn>
+                                        <p:tgtEl>
+                                          <p:spTgt spid="4">
+                                            <p:txEl>
+                                              <p:pRg st="15" end="15"/>
+                                            </p:txEl>
+                                          </p:spTgt>
+                                        </p:tgtEl>
+                                        <p:attrNameLst>
+                                          <p:attrName>style.visibility</p:attrName>
+                                        </p:attrNameLst>
+                                      </p:cBhvr>
+                                      <p:to>
+                                        <p:strVal val="visible"/>
+                                      </p:to>
+                                    </p:set>
+                                  </p:childTnLst>
+                                </p:cTn>
+                              </p:par>
+                            </p:childTnLst>
+                          </p:cTn>
+                        </p:par>
+                      </p:childTnLst>
+                    </p:cTn>
+                  </p:par>
+                </p:childTnLst>
+              </p:cTn>
+              <p:prevCondLst>
+                <p:cond evt="onPrev" delay="0">
+                  <p:tgtEl>
+                    <p:sldTgt/>
+                  </p:tgtEl>
+                </p:cond>
+              </p:prevCondLst>
+              <p:nextCondLst>
+                <p:cond evt="onNext" delay="0">
+                  <p:tgtEl>
+                    <p:sldTgt/>
+                  </p:tgtEl>
+                </p:cond>
+              </p:nextCondLst>
+            </p:seq>
+          </p:childTnLst>
+        </p:cTn>
+      </p:par>
+    </p:tnLst>
+  </p:timing>
 </p:sld>
 </file>
 
@@ -9025,7 +11084,7 @@
                   <a:srgbClr val="002060"/>
                 </a:solidFill>
               </a:rPr>
-              <a:t>Ziel 1 dieser Besprechung: </a:t>
+              <a:t>Ziel 1. dieser Besprechung: </a:t>
             </a:r>
             <a:endParaRPr lang="de-DE" sz="3200" b="1"/>
           </a:p>
@@ -9069,7 +11128,23 @@
                   <a:srgbClr val="002060"/>
                 </a:solidFill>
               </a:rPr>
-              <a:t>Ziel 2 (falls TPM-Initiative):</a:t>
+              <a:t>Ziel 2. (</a:t>
+            </a:r>
+            <a:r>
+              <a:rPr lang="de-DE" sz="3200" b="1" i="1">
+                <a:solidFill>
+                  <a:srgbClr val="002060"/>
+                </a:solidFill>
+              </a:rPr>
+              <a:t>falls</a:t>
+            </a:r>
+            <a:r>
+              <a:rPr lang="de-DE" sz="3200" b="1">
+                <a:solidFill>
+                  <a:srgbClr val="002060"/>
+                </a:solidFill>
+              </a:rPr>
+              <a:t> TPM-Initiative):</a:t>
             </a:r>
             <a:endParaRPr lang="de-DE" sz="3200" b="1"/>
           </a:p>
@@ -9105,7 +11180,27 @@
           <a:p>
             <a:r>
               <a:rPr lang="de-DE" sz="3200" b="1" i="1"/>
-              <a:t>Pflegestation oder TPM-Initiative?</a:t>
+              <a:t>Pflegestation </a:t>
+            </a:r>
+            <a:r>
+              <a:rPr lang="de-DE" sz="3200"/>
+              <a:t>oder</a:t>
+            </a:r>
+            <a:r>
+              <a:rPr lang="de-DE" sz="3200" b="1" i="1"/>
+              <a:t> </a:t>
+            </a:r>
+            <a:r>
+              <a:rPr lang="de-DE" sz="3200" b="1" i="1">
+                <a:solidFill>
+                  <a:srgbClr val="0070C0"/>
+                </a:solidFill>
+              </a:rPr>
+              <a:t>TPM-Initiative</a:t>
+            </a:r>
+            <a:r>
+              <a:rPr lang="de-DE" sz="3200" b="1" i="1"/>
+              <a:t>?</a:t>
             </a:r>
           </a:p>
         </p:txBody>
@@ -9139,17 +11234,29 @@
           <a:lstStyle/>
           <a:p>
             <a:r>
-              <a:rPr lang="de-DE" sz="3200" b="1" i="1"/>
-              <a:t>Wie, Wer, Was…. </a:t>
-            </a:r>
-          </a:p>
-          <a:p>
-            <a:r>
-              <a:rPr lang="de-DE" sz="2000" b="1"/>
-              <a:t>=&gt; Hausaufgaben für den Owner dieses Termins, oder andere Leute…</a:t>
-            </a:r>
-            <a:r>
-              <a:rPr lang="de-DE" sz="3200" b="1"/>
+              <a:rPr lang="de-DE" sz="3200" b="1" i="1">
+                <a:solidFill>
+                  <a:srgbClr val="0070C0"/>
+                </a:solidFill>
+              </a:rPr>
+              <a:t>Setup TPM-Initiative</a:t>
+            </a:r>
+            <a:r>
+              <a:rPr lang="de-DE" sz="3200" i="1">
+                <a:solidFill>
+                  <a:srgbClr val="0070C0"/>
+                </a:solidFill>
+              </a:rPr>
+              <a:t>: Wie, Wer, Was…. </a:t>
+            </a:r>
+          </a:p>
+          <a:p>
+            <a:r>
+              <a:rPr lang="de-DE" sz="2000"/>
+              <a:t>=&gt; Hausaufgaben! - für den Owner dieses Termins, oder andere Leute…</a:t>
+            </a:r>
+            <a:r>
+              <a:rPr lang="de-DE" sz="3200"/>
               <a:t> </a:t>
             </a:r>
           </a:p>
@@ -9165,6 +11272,151 @@
   <p:clrMapOvr>
     <a:masterClrMapping/>
   </p:clrMapOvr>
+  <p:timing>
+    <p:tnLst>
+      <p:par>
+        <p:cTn id="1" dur="indefinite" restart="never" nodeType="tmRoot">
+          <p:childTnLst>
+            <p:seq concurrent="1" nextAc="seek">
+              <p:cTn id="2" dur="indefinite" nodeType="mainSeq">
+                <p:childTnLst>
+                  <p:par>
+                    <p:cTn id="3" fill="hold">
+                      <p:stCondLst>
+                        <p:cond delay="indefinite"/>
+                      </p:stCondLst>
+                      <p:childTnLst>
+                        <p:par>
+                          <p:cTn id="4" fill="hold">
+                            <p:stCondLst>
+                              <p:cond delay="0"/>
+                            </p:stCondLst>
+                            <p:childTnLst>
+                              <p:par>
+                                <p:cTn id="5" presetID="1" presetClass="entr" presetSubtype="0" fill="hold" grpId="0" nodeType="clickEffect">
+                                  <p:stCondLst>
+                                    <p:cond delay="0"/>
+                                  </p:stCondLst>
+                                  <p:childTnLst>
+                                    <p:set>
+                                      <p:cBhvr>
+                                        <p:cTn id="6" dur="1" fill="hold">
+                                          <p:stCondLst>
+                                            <p:cond delay="0"/>
+                                          </p:stCondLst>
+                                        </p:cTn>
+                                        <p:tgtEl>
+                                          <p:spTgt spid="10">
+                                            <p:txEl>
+                                              <p:pRg st="0" end="0"/>
+                                            </p:txEl>
+                                          </p:spTgt>
+                                        </p:tgtEl>
+                                        <p:attrNameLst>
+                                          <p:attrName>style.visibility</p:attrName>
+                                        </p:attrNameLst>
+                                      </p:cBhvr>
+                                      <p:to>
+                                        <p:strVal val="visible"/>
+                                      </p:to>
+                                    </p:set>
+                                  </p:childTnLst>
+                                </p:cTn>
+                              </p:par>
+                              <p:par>
+                                <p:cTn id="7" presetID="1" presetClass="entr" presetSubtype="0" fill="hold" grpId="0" nodeType="withEffect">
+                                  <p:stCondLst>
+                                    <p:cond delay="0"/>
+                                  </p:stCondLst>
+                                  <p:childTnLst>
+                                    <p:set>
+                                      <p:cBhvr>
+                                        <p:cTn id="8" dur="1" fill="hold">
+                                          <p:stCondLst>
+                                            <p:cond delay="0"/>
+                                          </p:stCondLst>
+                                        </p:cTn>
+                                        <p:tgtEl>
+                                          <p:spTgt spid="14">
+                                            <p:txEl>
+                                              <p:pRg st="0" end="0"/>
+                                            </p:txEl>
+                                          </p:spTgt>
+                                        </p:tgtEl>
+                                        <p:attrNameLst>
+                                          <p:attrName>style.visibility</p:attrName>
+                                        </p:attrNameLst>
+                                      </p:cBhvr>
+                                      <p:to>
+                                        <p:strVal val="visible"/>
+                                      </p:to>
+                                    </p:set>
+                                  </p:childTnLst>
+                                </p:cTn>
+                              </p:par>
+                              <p:par>
+                                <p:cTn id="9" presetID="1" presetClass="entr" presetSubtype="0" fill="hold" grpId="0" nodeType="withEffect">
+                                  <p:stCondLst>
+                                    <p:cond delay="0"/>
+                                  </p:stCondLst>
+                                  <p:childTnLst>
+                                    <p:set>
+                                      <p:cBhvr>
+                                        <p:cTn id="10" dur="1" fill="hold">
+                                          <p:stCondLst>
+                                            <p:cond delay="0"/>
+                                          </p:stCondLst>
+                                        </p:cTn>
+                                        <p:tgtEl>
+                                          <p:spTgt spid="14">
+                                            <p:txEl>
+                                              <p:pRg st="1" end="1"/>
+                                            </p:txEl>
+                                          </p:spTgt>
+                                        </p:tgtEl>
+                                        <p:attrNameLst>
+                                          <p:attrName>style.visibility</p:attrName>
+                                        </p:attrNameLst>
+                                      </p:cBhvr>
+                                      <p:to>
+                                        <p:strVal val="visible"/>
+                                      </p:to>
+                                    </p:set>
+                                  </p:childTnLst>
+                                </p:cTn>
+                              </p:par>
+                            </p:childTnLst>
+                          </p:cTn>
+                        </p:par>
+                      </p:childTnLst>
+                    </p:cTn>
+                  </p:par>
+                </p:childTnLst>
+              </p:cTn>
+              <p:prevCondLst>
+                <p:cond evt="onPrev" delay="0">
+                  <p:tgtEl>
+                    <p:sldTgt/>
+                  </p:tgtEl>
+                </p:cond>
+              </p:prevCondLst>
+              <p:nextCondLst>
+                <p:cond evt="onNext" delay="0">
+                  <p:tgtEl>
+                    <p:sldTgt/>
+                  </p:tgtEl>
+                </p:cond>
+              </p:nextCondLst>
+            </p:seq>
+          </p:childTnLst>
+        </p:cTn>
+      </p:par>
+    </p:tnLst>
+    <p:bldLst>
+      <p:bldP spid="10" grpId="0" build="allAtOnce"/>
+      <p:bldP spid="14" grpId="0" build="allAtOnce"/>
+    </p:bldLst>
+  </p:timing>
 </p:sld>
 </file>
 
@@ -9185,813 +11437,6 @@
           <a:chExt cx="0" cy="0"/>
         </a:xfrm>
       </p:grpSpPr>
-      <p:cxnSp>
-        <p:nvCxnSpPr>
-          <p:cNvPr id="6" name="Gerader Verbinder 5">
-            <a:extLst>
-              <a:ext uri="{FF2B5EF4-FFF2-40B4-BE49-F238E27FC236}">
-                <a16:creationId xmlns:a16="http://schemas.microsoft.com/office/drawing/2014/main" id="{4F1D6A53-778D-D4CA-DF28-B32614F2BC67}"/>
-              </a:ext>
-            </a:extLst>
-          </p:cNvPr>
-          <p:cNvCxnSpPr>
-            <a:cxnSpLocks/>
-          </p:cNvCxnSpPr>
-          <p:nvPr/>
-        </p:nvCxnSpPr>
-        <p:spPr>
-          <a:xfrm>
-            <a:off x="7102757" y="1426819"/>
-            <a:ext cx="34835" cy="4038599"/>
-          </a:xfrm>
-          <a:prstGeom prst="line">
-            <a:avLst/>
-          </a:prstGeom>
-          <a:ln w="28575">
-            <a:prstDash val="sysDash"/>
-          </a:ln>
-        </p:spPr>
-        <p:style>
-          <a:lnRef idx="2">
-            <a:schemeClr val="accent1"/>
-          </a:lnRef>
-          <a:fillRef idx="0">
-            <a:schemeClr val="accent1"/>
-          </a:fillRef>
-          <a:effectRef idx="1">
-            <a:schemeClr val="accent1"/>
-          </a:effectRef>
-          <a:fontRef idx="minor">
-            <a:schemeClr val="tx1"/>
-          </a:fontRef>
-        </p:style>
-      </p:cxnSp>
-      <p:sp>
-        <p:nvSpPr>
-          <p:cNvPr id="7" name="Textfeld 6">
-            <a:extLst>
-              <a:ext uri="{FF2B5EF4-FFF2-40B4-BE49-F238E27FC236}">
-                <a16:creationId xmlns:a16="http://schemas.microsoft.com/office/drawing/2014/main" id="{7BD7EA1E-C351-FA16-597F-C8904AEE55E8}"/>
-              </a:ext>
-            </a:extLst>
-          </p:cNvPr>
-          <p:cNvSpPr txBox="1"/>
-          <p:nvPr/>
-        </p:nvSpPr>
-        <p:spPr>
-          <a:xfrm>
-            <a:off x="7328885" y="1160517"/>
-            <a:ext cx="3508525" cy="461665"/>
-          </a:xfrm>
-          <a:prstGeom prst="rect">
-            <a:avLst/>
-          </a:prstGeom>
-          <a:noFill/>
-        </p:spPr>
-        <p:txBody>
-          <a:bodyPr wrap="none" rtlCol="0">
-            <a:spAutoFit/>
-          </a:bodyPr>
-          <a:lstStyle/>
-          <a:p>
-            <a:r>
-              <a:rPr lang="de-DE" sz="2400" b="1">
-                <a:solidFill>
-                  <a:srgbClr val="002060"/>
-                </a:solidFill>
-              </a:rPr>
-              <a:t>„CKL-Domain“ </a:t>
-            </a:r>
-            <a:r>
-              <a:rPr lang="de-DE" sz="2400">
-                <a:solidFill>
-                  <a:srgbClr val="002060"/>
-                </a:solidFill>
-              </a:rPr>
-              <a:t>(GitHub)</a:t>
-            </a:r>
-          </a:p>
-        </p:txBody>
-      </p:sp>
-      <p:sp>
-        <p:nvSpPr>
-          <p:cNvPr id="8" name="Textfeld 7">
-            <a:extLst>
-              <a:ext uri="{FF2B5EF4-FFF2-40B4-BE49-F238E27FC236}">
-                <a16:creationId xmlns:a16="http://schemas.microsoft.com/office/drawing/2014/main" id="{F48A6FD9-47FD-C5EB-4F97-78E97694F368}"/>
-              </a:ext>
-            </a:extLst>
-          </p:cNvPr>
-          <p:cNvSpPr txBox="1"/>
-          <p:nvPr/>
-        </p:nvSpPr>
-        <p:spPr>
-          <a:xfrm>
-            <a:off x="1341628" y="1119007"/>
-            <a:ext cx="2193357" cy="461665"/>
-          </a:xfrm>
-          <a:prstGeom prst="rect">
-            <a:avLst/>
-          </a:prstGeom>
-          <a:noFill/>
-        </p:spPr>
-        <p:txBody>
-          <a:bodyPr wrap="none" rtlCol="0">
-            <a:spAutoFit/>
-          </a:bodyPr>
-          <a:lstStyle/>
-          <a:p>
-            <a:r>
-              <a:rPr lang="de-DE" sz="2400" b="1">
-                <a:solidFill>
-                  <a:srgbClr val="002060"/>
-                </a:solidFill>
-              </a:rPr>
-              <a:t>HÄVG-Domain</a:t>
-            </a:r>
-          </a:p>
-        </p:txBody>
-      </p:sp>
-      <p:sp>
-        <p:nvSpPr>
-          <p:cNvPr id="9" name="Textfeld 8">
-            <a:extLst>
-              <a:ext uri="{FF2B5EF4-FFF2-40B4-BE49-F238E27FC236}">
-                <a16:creationId xmlns:a16="http://schemas.microsoft.com/office/drawing/2014/main" id="{9D900BFE-C88A-3A8A-B9AB-D4E4F9F8A368}"/>
-              </a:ext>
-            </a:extLst>
-          </p:cNvPr>
-          <p:cNvSpPr txBox="1"/>
-          <p:nvPr/>
-        </p:nvSpPr>
-        <p:spPr>
-          <a:xfrm>
-            <a:off x="4331617" y="1091885"/>
-            <a:ext cx="2287036" cy="461665"/>
-          </a:xfrm>
-          <a:prstGeom prst="rect">
-            <a:avLst/>
-          </a:prstGeom>
-          <a:noFill/>
-        </p:spPr>
-        <p:txBody>
-          <a:bodyPr wrap="none" rtlCol="0">
-            <a:spAutoFit/>
-          </a:bodyPr>
-          <a:lstStyle/>
-          <a:p>
-            <a:r>
-              <a:rPr lang="de-DE" sz="2400" b="1">
-                <a:solidFill>
-                  <a:srgbClr val="002060"/>
-                </a:solidFill>
-              </a:rPr>
-              <a:t>„Staging-Area“</a:t>
-            </a:r>
-          </a:p>
-        </p:txBody>
-      </p:sp>
-      <p:sp>
-        <p:nvSpPr>
-          <p:cNvPr id="15" name="Pfeil: nach links 14">
-            <a:extLst>
-              <a:ext uri="{FF2B5EF4-FFF2-40B4-BE49-F238E27FC236}">
-                <a16:creationId xmlns:a16="http://schemas.microsoft.com/office/drawing/2014/main" id="{2C0A912A-2832-E5FD-10A4-D85EAC1FA583}"/>
-              </a:ext>
-            </a:extLst>
-          </p:cNvPr>
-          <p:cNvSpPr/>
-          <p:nvPr/>
-        </p:nvSpPr>
-        <p:spPr>
-          <a:xfrm>
-            <a:off x="6504181" y="3292980"/>
-            <a:ext cx="1131789" cy="392399"/>
-          </a:xfrm>
-          <a:prstGeom prst="leftArrow">
-            <a:avLst/>
-          </a:prstGeom>
-          <a:solidFill>
-            <a:schemeClr val="tx2">
-              <a:lumMod val="50000"/>
-              <a:lumOff val="50000"/>
-            </a:schemeClr>
-          </a:solidFill>
-        </p:spPr>
-        <p:style>
-          <a:lnRef idx="2">
-            <a:schemeClr val="accent1">
-              <a:shade val="15000"/>
-            </a:schemeClr>
-          </a:lnRef>
-          <a:fillRef idx="1">
-            <a:schemeClr val="accent1"/>
-          </a:fillRef>
-          <a:effectRef idx="0">
-            <a:schemeClr val="accent1"/>
-          </a:effectRef>
-          <a:fontRef idx="minor">
-            <a:schemeClr val="lt1"/>
-          </a:fontRef>
-        </p:style>
-        <p:txBody>
-          <a:bodyPr rtlCol="0" anchor="ctr"/>
-          <a:lstStyle/>
-          <a:p>
-            <a:pPr algn="ctr"/>
-            <a:endParaRPr lang="de-DE"/>
-          </a:p>
-        </p:txBody>
-      </p:sp>
-      <p:sp>
-        <p:nvSpPr>
-          <p:cNvPr id="19" name="Ellipse 18">
-            <a:extLst>
-              <a:ext uri="{FF2B5EF4-FFF2-40B4-BE49-F238E27FC236}">
-                <a16:creationId xmlns:a16="http://schemas.microsoft.com/office/drawing/2014/main" id="{39258206-4131-12A3-660F-17B889C6B58A}"/>
-              </a:ext>
-            </a:extLst>
-          </p:cNvPr>
-          <p:cNvSpPr/>
-          <p:nvPr/>
-        </p:nvSpPr>
-        <p:spPr>
-          <a:xfrm>
-            <a:off x="4652324" y="3114618"/>
-            <a:ext cx="1507308" cy="742950"/>
-          </a:xfrm>
-          <a:prstGeom prst="ellipse">
-            <a:avLst/>
-          </a:prstGeom>
-          <a:solidFill>
-            <a:schemeClr val="tx2">
-              <a:lumMod val="50000"/>
-              <a:lumOff val="50000"/>
-            </a:schemeClr>
-          </a:solidFill>
-        </p:spPr>
-        <p:style>
-          <a:lnRef idx="2">
-            <a:schemeClr val="accent1">
-              <a:shade val="15000"/>
-            </a:schemeClr>
-          </a:lnRef>
-          <a:fillRef idx="1">
-            <a:schemeClr val="accent1"/>
-          </a:fillRef>
-          <a:effectRef idx="0">
-            <a:schemeClr val="accent1"/>
-          </a:effectRef>
-          <a:fontRef idx="minor">
-            <a:schemeClr val="lt1"/>
-          </a:fontRef>
-        </p:style>
-        <p:txBody>
-          <a:bodyPr rtlCol="0" anchor="ctr"/>
-          <a:lstStyle/>
-          <a:p>
-            <a:pPr algn="ctr"/>
-            <a:r>
-              <a:rPr lang="de-DE" sz="1600" b="1"/>
-              <a:t>Proposal</a:t>
-            </a:r>
-          </a:p>
-        </p:txBody>
-      </p:sp>
-      <p:sp>
-        <p:nvSpPr>
-          <p:cNvPr id="20" name="Ellipse 19">
-            <a:extLst>
-              <a:ext uri="{FF2B5EF4-FFF2-40B4-BE49-F238E27FC236}">
-                <a16:creationId xmlns:a16="http://schemas.microsoft.com/office/drawing/2014/main" id="{71B297BD-EB29-7936-AFE6-4B0B3CCC06CA}"/>
-              </a:ext>
-            </a:extLst>
-          </p:cNvPr>
-          <p:cNvSpPr/>
-          <p:nvPr/>
-        </p:nvSpPr>
-        <p:spPr>
-          <a:xfrm>
-            <a:off x="4666906" y="4144686"/>
-            <a:ext cx="1507308" cy="742950"/>
-          </a:xfrm>
-          <a:prstGeom prst="ellipse">
-            <a:avLst/>
-          </a:prstGeom>
-          <a:solidFill>
-            <a:schemeClr val="tx2">
-              <a:lumMod val="50000"/>
-              <a:lumOff val="50000"/>
-            </a:schemeClr>
-          </a:solidFill>
-        </p:spPr>
-        <p:style>
-          <a:lnRef idx="2">
-            <a:schemeClr val="accent1">
-              <a:shade val="15000"/>
-            </a:schemeClr>
-          </a:lnRef>
-          <a:fillRef idx="1">
-            <a:schemeClr val="accent1"/>
-          </a:fillRef>
-          <a:effectRef idx="0">
-            <a:schemeClr val="accent1"/>
-          </a:effectRef>
-          <a:fontRef idx="minor">
-            <a:schemeClr val="lt1"/>
-          </a:fontRef>
-        </p:style>
-        <p:txBody>
-          <a:bodyPr rtlCol="0" anchor="ctr"/>
-          <a:lstStyle/>
-          <a:p>
-            <a:pPr algn="ctr"/>
-            <a:r>
-              <a:rPr lang="de-DE" sz="1600" b="1"/>
-              <a:t>Proposal</a:t>
-            </a:r>
-          </a:p>
-        </p:txBody>
-      </p:sp>
-      <p:sp>
-        <p:nvSpPr>
-          <p:cNvPr id="21" name="Ellipse 20">
-            <a:extLst>
-              <a:ext uri="{FF2B5EF4-FFF2-40B4-BE49-F238E27FC236}">
-                <a16:creationId xmlns:a16="http://schemas.microsoft.com/office/drawing/2014/main" id="{90575A8D-8C72-B615-A545-E12FE53533E5}"/>
-              </a:ext>
-            </a:extLst>
-          </p:cNvPr>
-          <p:cNvSpPr/>
-          <p:nvPr/>
-        </p:nvSpPr>
-        <p:spPr>
-          <a:xfrm>
-            <a:off x="4652324" y="2070503"/>
-            <a:ext cx="1507308" cy="742950"/>
-          </a:xfrm>
-          <a:prstGeom prst="ellipse">
-            <a:avLst/>
-          </a:prstGeom>
-          <a:solidFill>
-            <a:schemeClr val="tx2">
-              <a:lumMod val="50000"/>
-              <a:lumOff val="50000"/>
-            </a:schemeClr>
-          </a:solidFill>
-        </p:spPr>
-        <p:style>
-          <a:lnRef idx="2">
-            <a:schemeClr val="accent1">
-              <a:shade val="15000"/>
-            </a:schemeClr>
-          </a:lnRef>
-          <a:fillRef idx="1">
-            <a:schemeClr val="accent1"/>
-          </a:fillRef>
-          <a:effectRef idx="0">
-            <a:schemeClr val="accent1"/>
-          </a:effectRef>
-          <a:fontRef idx="minor">
-            <a:schemeClr val="lt1"/>
-          </a:fontRef>
-        </p:style>
-        <p:txBody>
-          <a:bodyPr rtlCol="0" anchor="ctr"/>
-          <a:lstStyle/>
-          <a:p>
-            <a:pPr algn="ctr"/>
-            <a:r>
-              <a:rPr lang="de-DE" sz="1600" b="1"/>
-              <a:t>Proposal</a:t>
-            </a:r>
-          </a:p>
-        </p:txBody>
-      </p:sp>
-      <p:sp>
-        <p:nvSpPr>
-          <p:cNvPr id="22" name="Ellipse 21">
-            <a:extLst>
-              <a:ext uri="{FF2B5EF4-FFF2-40B4-BE49-F238E27FC236}">
-                <a16:creationId xmlns:a16="http://schemas.microsoft.com/office/drawing/2014/main" id="{2063DA56-F4AD-AC48-CCFA-10F491C2F167}"/>
-              </a:ext>
-            </a:extLst>
-          </p:cNvPr>
-          <p:cNvSpPr/>
-          <p:nvPr/>
-        </p:nvSpPr>
-        <p:spPr>
-          <a:xfrm>
-            <a:off x="1534315" y="1943669"/>
-            <a:ext cx="1507308" cy="742950"/>
-          </a:xfrm>
-          <a:prstGeom prst="ellipse">
-            <a:avLst/>
-          </a:prstGeom>
-          <a:solidFill>
-            <a:srgbClr val="00B050"/>
-          </a:solidFill>
-        </p:spPr>
-        <p:style>
-          <a:lnRef idx="2">
-            <a:schemeClr val="accent1">
-              <a:shade val="15000"/>
-            </a:schemeClr>
-          </a:lnRef>
-          <a:fillRef idx="1">
-            <a:schemeClr val="accent1"/>
-          </a:fillRef>
-          <a:effectRef idx="0">
-            <a:schemeClr val="accent1"/>
-          </a:effectRef>
-          <a:fontRef idx="minor">
-            <a:schemeClr val="lt1"/>
-          </a:fontRef>
-        </p:style>
-        <p:txBody>
-          <a:bodyPr rtlCol="0" anchor="ctr"/>
-          <a:lstStyle/>
-          <a:p>
-            <a:pPr algn="ctr"/>
-            <a:r>
-              <a:rPr lang="de-DE" sz="1600" b="1"/>
-              <a:t>Decision</a:t>
-            </a:r>
-          </a:p>
-        </p:txBody>
-      </p:sp>
-      <p:sp>
-        <p:nvSpPr>
-          <p:cNvPr id="23" name="Ellipse 22">
-            <a:extLst>
-              <a:ext uri="{FF2B5EF4-FFF2-40B4-BE49-F238E27FC236}">
-                <a16:creationId xmlns:a16="http://schemas.microsoft.com/office/drawing/2014/main" id="{6BCAFD35-9659-BAB9-4F1B-2ACD5A03309D}"/>
-              </a:ext>
-            </a:extLst>
-          </p:cNvPr>
-          <p:cNvSpPr/>
-          <p:nvPr/>
-        </p:nvSpPr>
-        <p:spPr>
-          <a:xfrm>
-            <a:off x="1534315" y="3093694"/>
-            <a:ext cx="1507308" cy="742950"/>
-          </a:xfrm>
-          <a:prstGeom prst="ellipse">
-            <a:avLst/>
-          </a:prstGeom>
-          <a:solidFill>
-            <a:srgbClr val="00B050"/>
-          </a:solidFill>
-        </p:spPr>
-        <p:style>
-          <a:lnRef idx="2">
-            <a:schemeClr val="accent1">
-              <a:shade val="15000"/>
-            </a:schemeClr>
-          </a:lnRef>
-          <a:fillRef idx="1">
-            <a:schemeClr val="accent1"/>
-          </a:fillRef>
-          <a:effectRef idx="0">
-            <a:schemeClr val="accent1"/>
-          </a:effectRef>
-          <a:fontRef idx="minor">
-            <a:schemeClr val="lt1"/>
-          </a:fontRef>
-        </p:style>
-        <p:txBody>
-          <a:bodyPr rtlCol="0" anchor="ctr"/>
-          <a:lstStyle/>
-          <a:p>
-            <a:pPr algn="ctr"/>
-            <a:r>
-              <a:rPr lang="de-DE" sz="1600" b="1"/>
-              <a:t>Decision</a:t>
-            </a:r>
-          </a:p>
-        </p:txBody>
-      </p:sp>
-      <p:sp>
-        <p:nvSpPr>
-          <p:cNvPr id="24" name="Ellipse 23">
-            <a:extLst>
-              <a:ext uri="{FF2B5EF4-FFF2-40B4-BE49-F238E27FC236}">
-                <a16:creationId xmlns:a16="http://schemas.microsoft.com/office/drawing/2014/main" id="{57C1F23F-BCC7-4F6C-01C3-846DEC0EFEC0}"/>
-              </a:ext>
-            </a:extLst>
-          </p:cNvPr>
-          <p:cNvSpPr/>
-          <p:nvPr/>
-        </p:nvSpPr>
-        <p:spPr>
-          <a:xfrm>
-            <a:off x="1514132" y="4208119"/>
-            <a:ext cx="1507308" cy="742950"/>
-          </a:xfrm>
-          <a:prstGeom prst="ellipse">
-            <a:avLst/>
-          </a:prstGeom>
-          <a:solidFill>
-            <a:srgbClr val="00B050"/>
-          </a:solidFill>
-        </p:spPr>
-        <p:style>
-          <a:lnRef idx="2">
-            <a:schemeClr val="accent1">
-              <a:shade val="15000"/>
-            </a:schemeClr>
-          </a:lnRef>
-          <a:fillRef idx="1">
-            <a:schemeClr val="accent1"/>
-          </a:fillRef>
-          <a:effectRef idx="0">
-            <a:schemeClr val="accent1"/>
-          </a:effectRef>
-          <a:fontRef idx="minor">
-            <a:schemeClr val="lt1"/>
-          </a:fontRef>
-        </p:style>
-        <p:txBody>
-          <a:bodyPr rtlCol="0" anchor="ctr"/>
-          <a:lstStyle/>
-          <a:p>
-            <a:pPr algn="ctr"/>
-            <a:r>
-              <a:rPr lang="de-DE" sz="1600" b="1"/>
-              <a:t>Decision</a:t>
-            </a:r>
-          </a:p>
-        </p:txBody>
-      </p:sp>
-      <p:sp>
-        <p:nvSpPr>
-          <p:cNvPr id="25" name="Pfeil: nach oben 24">
-            <a:extLst>
-              <a:ext uri="{FF2B5EF4-FFF2-40B4-BE49-F238E27FC236}">
-                <a16:creationId xmlns:a16="http://schemas.microsoft.com/office/drawing/2014/main" id="{CB618802-2A98-C1E1-C645-F0980876EF22}"/>
-              </a:ext>
-            </a:extLst>
-          </p:cNvPr>
-          <p:cNvSpPr/>
-          <p:nvPr/>
-        </p:nvSpPr>
-        <p:spPr>
-          <a:xfrm>
-            <a:off x="8771563" y="1707299"/>
-            <a:ext cx="1886122" cy="3674326"/>
-          </a:xfrm>
-          <a:prstGeom prst="upArrow">
-            <a:avLst/>
-          </a:prstGeom>
-          <a:solidFill>
-            <a:schemeClr val="accent6">
-              <a:lumMod val="40000"/>
-              <a:lumOff val="60000"/>
-            </a:schemeClr>
-          </a:solidFill>
-        </p:spPr>
-        <p:style>
-          <a:lnRef idx="2">
-            <a:schemeClr val="accent1">
-              <a:shade val="15000"/>
-            </a:schemeClr>
-          </a:lnRef>
-          <a:fillRef idx="1">
-            <a:schemeClr val="accent1"/>
-          </a:fillRef>
-          <a:effectRef idx="0">
-            <a:schemeClr val="accent1"/>
-          </a:effectRef>
-          <a:fontRef idx="minor">
-            <a:schemeClr val="lt1"/>
-          </a:fontRef>
-        </p:style>
-        <p:txBody>
-          <a:bodyPr rtlCol="0" anchor="ctr"/>
-          <a:lstStyle/>
-          <a:p>
-            <a:pPr algn="ctr"/>
-            <a:endParaRPr lang="de-DE"/>
-          </a:p>
-        </p:txBody>
-      </p:sp>
-      <p:pic>
-        <p:nvPicPr>
-          <p:cNvPr id="29" name="Grafik 28">
-            <a:extLst>
-              <a:ext uri="{FF2B5EF4-FFF2-40B4-BE49-F238E27FC236}">
-                <a16:creationId xmlns:a16="http://schemas.microsoft.com/office/drawing/2014/main" id="{FD624151-C93A-C1A6-942A-96A2AF69FF0B}"/>
-              </a:ext>
-            </a:extLst>
-          </p:cNvPr>
-          <p:cNvPicPr>
-            <a:picLocks noChangeAspect="1"/>
-          </p:cNvPicPr>
-          <p:nvPr/>
-        </p:nvPicPr>
-        <p:blipFill>
-          <a:blip r:embed="rId2">
-            <a:extLst>
-              <a:ext uri="{28A0092B-C50C-407E-A947-70E740481C1C}">
-                <a14:useLocalDpi xmlns:a14="http://schemas.microsoft.com/office/drawing/2010/main" val="0"/>
-              </a:ext>
-            </a:extLst>
-          </a:blip>
-          <a:stretch>
-            <a:fillRect/>
-          </a:stretch>
-        </p:blipFill>
-        <p:spPr>
-          <a:xfrm>
-            <a:off x="5000521" y="5829802"/>
-            <a:ext cx="953091" cy="953091"/>
-          </a:xfrm>
-          <a:prstGeom prst="rect">
-            <a:avLst/>
-          </a:prstGeom>
-        </p:spPr>
-      </p:pic>
-      <p:cxnSp>
-        <p:nvCxnSpPr>
-          <p:cNvPr id="33" name="Gerader Verbinder 32">
-            <a:extLst>
-              <a:ext uri="{FF2B5EF4-FFF2-40B4-BE49-F238E27FC236}">
-                <a16:creationId xmlns:a16="http://schemas.microsoft.com/office/drawing/2014/main" id="{2D9EE726-1AF9-8340-FED4-B3EFF74430DA}"/>
-              </a:ext>
-            </a:extLst>
-          </p:cNvPr>
-          <p:cNvCxnSpPr>
-            <a:cxnSpLocks/>
-          </p:cNvCxnSpPr>
-          <p:nvPr/>
-        </p:nvCxnSpPr>
-        <p:spPr>
-          <a:xfrm>
-            <a:off x="3838575" y="1426819"/>
-            <a:ext cx="18730" cy="4038599"/>
-          </a:xfrm>
-          <a:prstGeom prst="line">
-            <a:avLst/>
-          </a:prstGeom>
-          <a:ln w="76200">
-            <a:solidFill>
-              <a:srgbClr val="FF0000"/>
-            </a:solidFill>
-          </a:ln>
-        </p:spPr>
-        <p:style>
-          <a:lnRef idx="2">
-            <a:schemeClr val="accent1"/>
-          </a:lnRef>
-          <a:fillRef idx="0">
-            <a:schemeClr val="accent1"/>
-          </a:fillRef>
-          <a:effectRef idx="1">
-            <a:schemeClr val="accent1"/>
-          </a:effectRef>
-          <a:fontRef idx="minor">
-            <a:schemeClr val="tx1"/>
-          </a:fontRef>
-        </p:style>
-      </p:cxnSp>
-      <p:sp>
-        <p:nvSpPr>
-          <p:cNvPr id="36" name="Rechteck 35">
-            <a:extLst>
-              <a:ext uri="{FF2B5EF4-FFF2-40B4-BE49-F238E27FC236}">
-                <a16:creationId xmlns:a16="http://schemas.microsoft.com/office/drawing/2014/main" id="{952CADCB-1CB0-F1CA-741C-CB151AC44414}"/>
-              </a:ext>
-            </a:extLst>
-          </p:cNvPr>
-          <p:cNvSpPr/>
-          <p:nvPr/>
-        </p:nvSpPr>
-        <p:spPr>
-          <a:xfrm>
-            <a:off x="3429296" y="2686619"/>
-            <a:ext cx="888973" cy="1590105"/>
-          </a:xfrm>
-          <a:prstGeom prst="rect">
-            <a:avLst/>
-          </a:prstGeom>
-          <a:solidFill>
-            <a:schemeClr val="bg1"/>
-          </a:solidFill>
-          <a:ln>
-            <a:noFill/>
-          </a:ln>
-        </p:spPr>
-        <p:style>
-          <a:lnRef idx="2">
-            <a:schemeClr val="accent1">
-              <a:shade val="15000"/>
-            </a:schemeClr>
-          </a:lnRef>
-          <a:fillRef idx="1">
-            <a:schemeClr val="accent1"/>
-          </a:fillRef>
-          <a:effectRef idx="0">
-            <a:schemeClr val="accent1"/>
-          </a:effectRef>
-          <a:fontRef idx="minor">
-            <a:schemeClr val="lt1"/>
-          </a:fontRef>
-        </p:style>
-        <p:txBody>
-          <a:bodyPr rtlCol="0" anchor="ctr"/>
-          <a:lstStyle/>
-          <a:p>
-            <a:pPr algn="ctr"/>
-            <a:endParaRPr lang="de-DE"/>
-          </a:p>
-        </p:txBody>
-      </p:sp>
-      <p:sp>
-        <p:nvSpPr>
-          <p:cNvPr id="27" name="Pfeil: nach links 26">
-            <a:extLst>
-              <a:ext uri="{FF2B5EF4-FFF2-40B4-BE49-F238E27FC236}">
-                <a16:creationId xmlns:a16="http://schemas.microsoft.com/office/drawing/2014/main" id="{D78CB09B-750F-9588-B243-6B065C35AC72}"/>
-              </a:ext>
-            </a:extLst>
-          </p:cNvPr>
-          <p:cNvSpPr/>
-          <p:nvPr/>
-        </p:nvSpPr>
-        <p:spPr>
-          <a:xfrm>
-            <a:off x="3221126" y="3202294"/>
-            <a:ext cx="1131789" cy="392399"/>
-          </a:xfrm>
-          <a:prstGeom prst="leftArrow">
-            <a:avLst/>
-          </a:prstGeom>
-          <a:solidFill>
-            <a:schemeClr val="accent6"/>
-          </a:solidFill>
-        </p:spPr>
-        <p:style>
-          <a:lnRef idx="2">
-            <a:schemeClr val="accent1">
-              <a:shade val="15000"/>
-            </a:schemeClr>
-          </a:lnRef>
-          <a:fillRef idx="1">
-            <a:schemeClr val="accent1"/>
-          </a:fillRef>
-          <a:effectRef idx="0">
-            <a:schemeClr val="accent1"/>
-          </a:effectRef>
-          <a:fontRef idx="minor">
-            <a:schemeClr val="lt1"/>
-          </a:fontRef>
-        </p:style>
-        <p:txBody>
-          <a:bodyPr rtlCol="0" anchor="ctr"/>
-          <a:lstStyle/>
-          <a:p>
-            <a:pPr algn="ctr"/>
-            <a:endParaRPr lang="de-DE"/>
-          </a:p>
-        </p:txBody>
-      </p:sp>
-      <p:pic>
-        <p:nvPicPr>
-          <p:cNvPr id="37" name="Grafik 36">
-            <a:extLst>
-              <a:ext uri="{FF2B5EF4-FFF2-40B4-BE49-F238E27FC236}">
-                <a16:creationId xmlns:a16="http://schemas.microsoft.com/office/drawing/2014/main" id="{B265D967-E0F6-75E0-AD93-28D8EEA4501F}"/>
-              </a:ext>
-            </a:extLst>
-          </p:cNvPr>
-          <p:cNvPicPr>
-            <a:picLocks noChangeAspect="1"/>
-          </p:cNvPicPr>
-          <p:nvPr/>
-        </p:nvPicPr>
-        <p:blipFill>
-          <a:blip r:embed="rId3">
-            <a:extLst>
-              <a:ext uri="{28A0092B-C50C-407E-A947-70E740481C1C}">
-                <a14:useLocalDpi xmlns:a14="http://schemas.microsoft.com/office/drawing/2010/main" val="0"/>
-              </a:ext>
-            </a:extLst>
-          </a:blip>
-          <a:stretch>
-            <a:fillRect/>
-          </a:stretch>
-        </p:blipFill>
-        <p:spPr>
-          <a:xfrm>
-            <a:off x="3584382" y="2614658"/>
-            <a:ext cx="660908" cy="660908"/>
-          </a:xfrm>
-          <a:prstGeom prst="rect">
-            <a:avLst/>
-          </a:prstGeom>
-        </p:spPr>
-      </p:pic>
       <p:sp>
         <p:nvSpPr>
           <p:cNvPr id="38" name="Textfeld 37">
@@ -10006,8 +11451,8 @@
         </p:nvSpPr>
         <p:spPr>
           <a:xfrm>
-            <a:off x="118167" y="60504"/>
-            <a:ext cx="6851427" cy="830997"/>
+            <a:off x="146742" y="90250"/>
+            <a:ext cx="11749983" cy="769441"/>
           </a:xfrm>
           <a:prstGeom prst="rect">
             <a:avLst/>
@@ -10015,7 +11460,7 @@
           <a:noFill/>
         </p:spPr>
         <p:txBody>
-          <a:bodyPr wrap="none" rtlCol="0">
+          <a:bodyPr wrap="square" rtlCol="0">
             <a:spAutoFit/>
           </a:bodyPr>
           <a:lstStyle/>
@@ -10030,314 +11475,1150 @@
                   <a:srgbClr val="0070C0"/>
                 </a:solidFill>
               </a:rPr>
-              <a:t>effizienteten</a:t>
+              <a:t>effizienten</a:t>
             </a:r>
             <a:r>
               <a:rPr lang="de-DE" sz="2400" b="1"/>
-              <a:t> Arbeitsmodus</a:t>
-            </a:r>
-          </a:p>
-          <a:p>
+              <a:t> Arbeitsmodus der </a:t>
+            </a:r>
+            <a:r>
+              <a:rPr lang="de-DE" sz="2400" b="1">
+                <a:solidFill>
+                  <a:srgbClr val="0070C0"/>
+                </a:solidFill>
+              </a:rPr>
+              <a:t>TPM-Initiative</a:t>
+            </a:r>
             <a:r>
               <a:rPr lang="de-DE" sz="2400" b="1"/>
-              <a:t>für die ersten Milestones… </a:t>
-            </a:r>
-            <a:r>
-              <a:rPr lang="de-DE" sz="2400"/>
-              <a:t>(„logisches Modell“)</a:t>
+              <a:t>.</a:t>
+            </a:r>
+          </a:p>
+          <a:p>
+            <a:r>
+              <a:rPr lang="de-DE" sz="2000"/>
+              <a:t>Für die ersten Milestones - bis zu einem expliziten Moduswechsel   („logisches Modell“)</a:t>
             </a:r>
           </a:p>
         </p:txBody>
       </p:sp>
-      <p:pic>
-        <p:nvPicPr>
-          <p:cNvPr id="40" name="Grafik 39">
+      <p:grpSp>
+        <p:nvGrpSpPr>
+          <p:cNvPr id="2" name="Gruppieren 1">
             <a:extLst>
               <a:ext uri="{FF2B5EF4-FFF2-40B4-BE49-F238E27FC236}">
-                <a16:creationId xmlns:a16="http://schemas.microsoft.com/office/drawing/2014/main" id="{606A1F1B-FF16-5FB9-1B7C-71990D18D2B6}"/>
+                <a16:creationId xmlns:a16="http://schemas.microsoft.com/office/drawing/2014/main" id="{B8308D9D-8D26-57BC-0AFC-5EBF5E9F152D}"/>
               </a:ext>
             </a:extLst>
           </p:cNvPr>
-          <p:cNvPicPr>
-            <a:picLocks noChangeAspect="1"/>
-          </p:cNvPicPr>
+          <p:cNvGrpSpPr/>
           <p:nvPr/>
-        </p:nvPicPr>
-        <p:blipFill>
-          <a:blip r:embed="rId4">
-            <a:extLst>
-              <a:ext uri="{28A0092B-C50C-407E-A947-70E740481C1C}">
-                <a14:useLocalDpi xmlns:a14="http://schemas.microsoft.com/office/drawing/2010/main" val="0"/>
-              </a:ext>
-            </a:extLst>
-          </a:blip>
-          <a:stretch>
-            <a:fillRect/>
-          </a:stretch>
-        </p:blipFill>
-        <p:spPr>
-          <a:xfrm flipH="1">
-            <a:off x="3477288" y="3339313"/>
-            <a:ext cx="742950" cy="742950"/>
+        </p:nvGrpSpPr>
+        <p:grpSpPr>
+          <a:xfrm>
+            <a:off x="1341628" y="1091885"/>
+            <a:ext cx="9495782" cy="5691008"/>
+            <a:chOff x="1341628" y="1091885"/>
+            <a:chExt cx="9495782" cy="5691008"/>
           </a:xfrm>
-          <a:prstGeom prst="rect">
-            <a:avLst/>
-          </a:prstGeom>
-        </p:spPr>
-      </p:pic>
-      <p:pic>
-        <p:nvPicPr>
-          <p:cNvPr id="42" name="Grafik 41">
-            <a:extLst>
-              <a:ext uri="{FF2B5EF4-FFF2-40B4-BE49-F238E27FC236}">
-                <a16:creationId xmlns:a16="http://schemas.microsoft.com/office/drawing/2014/main" id="{5774CF2A-F904-6D24-37CE-0FFA71458000}"/>
-              </a:ext>
-            </a:extLst>
-          </p:cNvPr>
-          <p:cNvPicPr>
-            <a:picLocks noChangeAspect="1"/>
-          </p:cNvPicPr>
-          <p:nvPr/>
-        </p:nvPicPr>
-        <p:blipFill>
-          <a:blip r:embed="rId5">
-            <a:extLst>
-              <a:ext uri="{28A0092B-C50C-407E-A947-70E740481C1C}">
-                <a14:useLocalDpi xmlns:a14="http://schemas.microsoft.com/office/drawing/2010/main" val="0"/>
-              </a:ext>
-            </a:extLst>
-          </a:blip>
-          <a:stretch>
-            <a:fillRect/>
-          </a:stretch>
-        </p:blipFill>
-        <p:spPr>
-          <a:xfrm rot="18854049">
-            <a:off x="9034888" y="2988045"/>
-            <a:ext cx="1455857" cy="1455857"/>
-          </a:xfrm>
-          <a:prstGeom prst="rect">
-            <a:avLst/>
-          </a:prstGeom>
-        </p:spPr>
-      </p:pic>
-      <p:cxnSp>
-        <p:nvCxnSpPr>
-          <p:cNvPr id="46" name="Gerader Verbinder 45">
-            <a:extLst>
-              <a:ext uri="{FF2B5EF4-FFF2-40B4-BE49-F238E27FC236}">
-                <a16:creationId xmlns:a16="http://schemas.microsoft.com/office/drawing/2014/main" id="{76BD3CD9-1AA6-01F6-ECFD-1B3E54261B80}"/>
-              </a:ext>
-            </a:extLst>
-          </p:cNvPr>
-          <p:cNvCxnSpPr>
-            <a:cxnSpLocks/>
-          </p:cNvCxnSpPr>
-          <p:nvPr/>
-        </p:nvCxnSpPr>
-        <p:spPr>
-          <a:xfrm>
-            <a:off x="4373581" y="5465418"/>
-            <a:ext cx="2245072" cy="0"/>
-          </a:xfrm>
-          <a:prstGeom prst="line">
-            <a:avLst/>
-          </a:prstGeom>
-          <a:ln w="28575">
-            <a:prstDash val="sysDash"/>
-          </a:ln>
-        </p:spPr>
-        <p:style>
-          <a:lnRef idx="2">
-            <a:schemeClr val="accent1"/>
-          </a:lnRef>
-          <a:fillRef idx="0">
-            <a:schemeClr val="accent1"/>
-          </a:fillRef>
-          <a:effectRef idx="1">
-            <a:schemeClr val="accent1"/>
-          </a:effectRef>
-          <a:fontRef idx="minor">
-            <a:schemeClr val="tx1"/>
-          </a:fontRef>
-        </p:style>
-      </p:cxnSp>
-      <p:sp>
-        <p:nvSpPr>
-          <p:cNvPr id="30" name="Pfeil: nach links 29">
-            <a:extLst>
-              <a:ext uri="{FF2B5EF4-FFF2-40B4-BE49-F238E27FC236}">
-                <a16:creationId xmlns:a16="http://schemas.microsoft.com/office/drawing/2014/main" id="{23F6AB9C-6C3F-7896-F149-587F6EA65541}"/>
-              </a:ext>
-            </a:extLst>
-          </p:cNvPr>
-          <p:cNvSpPr/>
-          <p:nvPr/>
-        </p:nvSpPr>
-        <p:spPr>
-          <a:xfrm rot="16200000">
-            <a:off x="5070455" y="5233551"/>
-            <a:ext cx="742952" cy="392399"/>
-          </a:xfrm>
-          <a:prstGeom prst="leftArrow">
-            <a:avLst/>
-          </a:prstGeom>
-          <a:solidFill>
-            <a:srgbClr val="FF0000"/>
-          </a:solidFill>
-        </p:spPr>
-        <p:style>
-          <a:lnRef idx="2">
-            <a:schemeClr val="accent1">
-              <a:shade val="15000"/>
-            </a:schemeClr>
-          </a:lnRef>
-          <a:fillRef idx="1">
-            <a:schemeClr val="accent1"/>
-          </a:fillRef>
-          <a:effectRef idx="0">
-            <a:schemeClr val="accent1"/>
-          </a:effectRef>
-          <a:fontRef idx="minor">
-            <a:schemeClr val="lt1"/>
-          </a:fontRef>
-        </p:style>
-        <p:txBody>
-          <a:bodyPr rtlCol="0" anchor="ctr"/>
-          <a:lstStyle/>
-          <a:p>
-            <a:pPr algn="ctr"/>
-            <a:endParaRPr lang="de-DE"/>
-          </a:p>
-        </p:txBody>
-      </p:sp>
-      <p:sp>
-        <p:nvSpPr>
-          <p:cNvPr id="53" name="Ellipse 52">
-            <a:extLst>
-              <a:ext uri="{FF2B5EF4-FFF2-40B4-BE49-F238E27FC236}">
-                <a16:creationId xmlns:a16="http://schemas.microsoft.com/office/drawing/2014/main" id="{4CE273E4-DACC-18FE-B1F2-F22205DF295C}"/>
-              </a:ext>
-            </a:extLst>
-          </p:cNvPr>
-          <p:cNvSpPr/>
-          <p:nvPr/>
-        </p:nvSpPr>
-        <p:spPr>
-          <a:xfrm>
-            <a:off x="7793318" y="3074643"/>
-            <a:ext cx="1240011" cy="742950"/>
-          </a:xfrm>
-          <a:prstGeom prst="ellipse">
-            <a:avLst/>
-          </a:prstGeom>
-          <a:solidFill>
-            <a:schemeClr val="tx2">
-              <a:lumMod val="50000"/>
-              <a:lumOff val="50000"/>
-            </a:schemeClr>
-          </a:solidFill>
-        </p:spPr>
-        <p:style>
-          <a:lnRef idx="2">
-            <a:schemeClr val="accent1">
-              <a:shade val="15000"/>
-            </a:schemeClr>
-          </a:lnRef>
-          <a:fillRef idx="1">
-            <a:schemeClr val="accent1"/>
-          </a:fillRef>
-          <a:effectRef idx="0">
-            <a:schemeClr val="accent1"/>
-          </a:effectRef>
-          <a:fontRef idx="minor">
-            <a:schemeClr val="lt1"/>
-          </a:fontRef>
-        </p:style>
-        <p:txBody>
-          <a:bodyPr rtlCol="0" anchor="ctr"/>
-          <a:lstStyle/>
-          <a:p>
-            <a:pPr algn="ctr"/>
-            <a:r>
-              <a:rPr lang="de-DE" sz="1600" b="1"/>
-              <a:t>Raw</a:t>
-            </a:r>
-          </a:p>
-        </p:txBody>
-      </p:sp>
-      <p:pic>
-        <p:nvPicPr>
-          <p:cNvPr id="54" name="Grafik 53">
-            <a:extLst>
-              <a:ext uri="{FF2B5EF4-FFF2-40B4-BE49-F238E27FC236}">
-                <a16:creationId xmlns:a16="http://schemas.microsoft.com/office/drawing/2014/main" id="{F4B67388-3290-E097-0F90-89890F15656E}"/>
-              </a:ext>
-            </a:extLst>
-          </p:cNvPr>
-          <p:cNvPicPr>
-            <a:picLocks noChangeAspect="1"/>
-          </p:cNvPicPr>
-          <p:nvPr/>
-        </p:nvPicPr>
-        <p:blipFill>
-          <a:blip r:embed="rId4">
-            <a:extLst>
-              <a:ext uri="{28A0092B-C50C-407E-A947-70E740481C1C}">
-                <a14:useLocalDpi xmlns:a14="http://schemas.microsoft.com/office/drawing/2010/main" val="0"/>
-              </a:ext>
-            </a:extLst>
-          </a:blip>
-          <a:stretch>
-            <a:fillRect/>
-          </a:stretch>
-        </p:blipFill>
-        <p:spPr>
-          <a:xfrm flipH="1">
-            <a:off x="4507654" y="4866655"/>
-            <a:ext cx="742950" cy="742950"/>
-          </a:xfrm>
-          <a:prstGeom prst="rect">
-            <a:avLst/>
-          </a:prstGeom>
-        </p:spPr>
-      </p:pic>
-      <p:pic>
-        <p:nvPicPr>
-          <p:cNvPr id="55" name="Grafik 54">
-            <a:extLst>
-              <a:ext uri="{FF2B5EF4-FFF2-40B4-BE49-F238E27FC236}">
-                <a16:creationId xmlns:a16="http://schemas.microsoft.com/office/drawing/2014/main" id="{BB923A5B-0DCC-6EC9-543A-79CED09BB240}"/>
-              </a:ext>
-            </a:extLst>
-          </p:cNvPr>
-          <p:cNvPicPr>
-            <a:picLocks noChangeAspect="1"/>
-          </p:cNvPicPr>
-          <p:nvPr/>
-        </p:nvPicPr>
-        <p:blipFill>
-          <a:blip r:embed="rId4">
-            <a:extLst>
-              <a:ext uri="{28A0092B-C50C-407E-A947-70E740481C1C}">
-                <a14:useLocalDpi xmlns:a14="http://schemas.microsoft.com/office/drawing/2010/main" val="0"/>
-              </a:ext>
-            </a:extLst>
-          </a:blip>
-          <a:stretch>
-            <a:fillRect/>
-          </a:stretch>
-        </p:blipFill>
-        <p:spPr>
-          <a:xfrm flipH="1">
-            <a:off x="3508192" y="3662543"/>
-            <a:ext cx="742950" cy="742950"/>
-          </a:xfrm>
-          <a:prstGeom prst="rect">
-            <a:avLst/>
-          </a:prstGeom>
-        </p:spPr>
-      </p:pic>
+        </p:grpSpPr>
+        <p:cxnSp>
+          <p:nvCxnSpPr>
+            <p:cNvPr id="6" name="Gerader Verbinder 5">
+              <a:extLst>
+                <a:ext uri="{FF2B5EF4-FFF2-40B4-BE49-F238E27FC236}">
+                  <a16:creationId xmlns:a16="http://schemas.microsoft.com/office/drawing/2014/main" id="{4F1D6A53-778D-D4CA-DF28-B32614F2BC67}"/>
+                </a:ext>
+              </a:extLst>
+            </p:cNvPr>
+            <p:cNvCxnSpPr>
+              <a:cxnSpLocks/>
+            </p:cNvCxnSpPr>
+            <p:nvPr/>
+          </p:nvCxnSpPr>
+          <p:spPr>
+            <a:xfrm>
+              <a:off x="7102757" y="1426819"/>
+              <a:ext cx="34835" cy="4038599"/>
+            </a:xfrm>
+            <a:prstGeom prst="line">
+              <a:avLst/>
+            </a:prstGeom>
+            <a:ln w="28575">
+              <a:prstDash val="sysDash"/>
+            </a:ln>
+          </p:spPr>
+          <p:style>
+            <a:lnRef idx="2">
+              <a:schemeClr val="accent1"/>
+            </a:lnRef>
+            <a:fillRef idx="0">
+              <a:schemeClr val="accent1"/>
+            </a:fillRef>
+            <a:effectRef idx="1">
+              <a:schemeClr val="accent1"/>
+            </a:effectRef>
+            <a:fontRef idx="minor">
+              <a:schemeClr val="tx1"/>
+            </a:fontRef>
+          </p:style>
+        </p:cxnSp>
+        <p:sp>
+          <p:nvSpPr>
+            <p:cNvPr id="7" name="Textfeld 6">
+              <a:extLst>
+                <a:ext uri="{FF2B5EF4-FFF2-40B4-BE49-F238E27FC236}">
+                  <a16:creationId xmlns:a16="http://schemas.microsoft.com/office/drawing/2014/main" id="{7BD7EA1E-C351-FA16-597F-C8904AEE55E8}"/>
+                </a:ext>
+              </a:extLst>
+            </p:cNvPr>
+            <p:cNvSpPr txBox="1"/>
+            <p:nvPr/>
+          </p:nvSpPr>
+          <p:spPr>
+            <a:xfrm>
+              <a:off x="7328885" y="1160517"/>
+              <a:ext cx="3508525" cy="461665"/>
+            </a:xfrm>
+            <a:prstGeom prst="rect">
+              <a:avLst/>
+            </a:prstGeom>
+            <a:noFill/>
+          </p:spPr>
+          <p:txBody>
+            <a:bodyPr wrap="none" rtlCol="0">
+              <a:spAutoFit/>
+            </a:bodyPr>
+            <a:lstStyle/>
+            <a:p>
+              <a:r>
+                <a:rPr lang="de-DE" sz="2400" b="1">
+                  <a:solidFill>
+                    <a:srgbClr val="002060"/>
+                  </a:solidFill>
+                </a:rPr>
+                <a:t>„CKL-Domain“ </a:t>
+              </a:r>
+              <a:r>
+                <a:rPr lang="de-DE" sz="2400">
+                  <a:solidFill>
+                    <a:srgbClr val="002060"/>
+                  </a:solidFill>
+                </a:rPr>
+                <a:t>(GitHub)</a:t>
+              </a:r>
+            </a:p>
+          </p:txBody>
+        </p:sp>
+        <p:sp>
+          <p:nvSpPr>
+            <p:cNvPr id="8" name="Textfeld 7">
+              <a:extLst>
+                <a:ext uri="{FF2B5EF4-FFF2-40B4-BE49-F238E27FC236}">
+                  <a16:creationId xmlns:a16="http://schemas.microsoft.com/office/drawing/2014/main" id="{F48A6FD9-47FD-C5EB-4F97-78E97694F368}"/>
+                </a:ext>
+              </a:extLst>
+            </p:cNvPr>
+            <p:cNvSpPr txBox="1"/>
+            <p:nvPr/>
+          </p:nvSpPr>
+          <p:spPr>
+            <a:xfrm>
+              <a:off x="1341628" y="1119007"/>
+              <a:ext cx="2193357" cy="461665"/>
+            </a:xfrm>
+            <a:prstGeom prst="rect">
+              <a:avLst/>
+            </a:prstGeom>
+            <a:noFill/>
+          </p:spPr>
+          <p:txBody>
+            <a:bodyPr wrap="none" rtlCol="0">
+              <a:spAutoFit/>
+            </a:bodyPr>
+            <a:lstStyle/>
+            <a:p>
+              <a:r>
+                <a:rPr lang="de-DE" sz="2400" b="1">
+                  <a:solidFill>
+                    <a:srgbClr val="002060"/>
+                  </a:solidFill>
+                </a:rPr>
+                <a:t>HÄVG-Domain</a:t>
+              </a:r>
+            </a:p>
+          </p:txBody>
+        </p:sp>
+        <p:sp>
+          <p:nvSpPr>
+            <p:cNvPr id="9" name="Textfeld 8">
+              <a:extLst>
+                <a:ext uri="{FF2B5EF4-FFF2-40B4-BE49-F238E27FC236}">
+                  <a16:creationId xmlns:a16="http://schemas.microsoft.com/office/drawing/2014/main" id="{9D900BFE-C88A-3A8A-B9AB-D4E4F9F8A368}"/>
+                </a:ext>
+              </a:extLst>
+            </p:cNvPr>
+            <p:cNvSpPr txBox="1"/>
+            <p:nvPr/>
+          </p:nvSpPr>
+          <p:spPr>
+            <a:xfrm>
+              <a:off x="4331617" y="1091885"/>
+              <a:ext cx="2287036" cy="461665"/>
+            </a:xfrm>
+            <a:prstGeom prst="rect">
+              <a:avLst/>
+            </a:prstGeom>
+            <a:noFill/>
+          </p:spPr>
+          <p:txBody>
+            <a:bodyPr wrap="none" rtlCol="0">
+              <a:spAutoFit/>
+            </a:bodyPr>
+            <a:lstStyle/>
+            <a:p>
+              <a:r>
+                <a:rPr lang="de-DE" sz="2400" b="1">
+                  <a:solidFill>
+                    <a:srgbClr val="002060"/>
+                  </a:solidFill>
+                </a:rPr>
+                <a:t>„Staging-Area“</a:t>
+              </a:r>
+            </a:p>
+          </p:txBody>
+        </p:sp>
+        <p:sp>
+          <p:nvSpPr>
+            <p:cNvPr id="15" name="Pfeil: nach links 14">
+              <a:extLst>
+                <a:ext uri="{FF2B5EF4-FFF2-40B4-BE49-F238E27FC236}">
+                  <a16:creationId xmlns:a16="http://schemas.microsoft.com/office/drawing/2014/main" id="{2C0A912A-2832-E5FD-10A4-D85EAC1FA583}"/>
+                </a:ext>
+              </a:extLst>
+            </p:cNvPr>
+            <p:cNvSpPr/>
+            <p:nvPr/>
+          </p:nvSpPr>
+          <p:spPr>
+            <a:xfrm>
+              <a:off x="6504181" y="3292980"/>
+              <a:ext cx="1131789" cy="392399"/>
+            </a:xfrm>
+            <a:prstGeom prst="leftArrow">
+              <a:avLst/>
+            </a:prstGeom>
+            <a:solidFill>
+              <a:schemeClr val="tx2">
+                <a:lumMod val="50000"/>
+                <a:lumOff val="50000"/>
+              </a:schemeClr>
+            </a:solidFill>
+          </p:spPr>
+          <p:style>
+            <a:lnRef idx="2">
+              <a:schemeClr val="accent1">
+                <a:shade val="15000"/>
+              </a:schemeClr>
+            </a:lnRef>
+            <a:fillRef idx="1">
+              <a:schemeClr val="accent1"/>
+            </a:fillRef>
+            <a:effectRef idx="0">
+              <a:schemeClr val="accent1"/>
+            </a:effectRef>
+            <a:fontRef idx="minor">
+              <a:schemeClr val="lt1"/>
+            </a:fontRef>
+          </p:style>
+          <p:txBody>
+            <a:bodyPr rtlCol="0" anchor="ctr"/>
+            <a:lstStyle/>
+            <a:p>
+              <a:pPr algn="ctr"/>
+              <a:endParaRPr lang="de-DE"/>
+            </a:p>
+          </p:txBody>
+        </p:sp>
+        <p:sp>
+          <p:nvSpPr>
+            <p:cNvPr id="19" name="Ellipse 18">
+              <a:extLst>
+                <a:ext uri="{FF2B5EF4-FFF2-40B4-BE49-F238E27FC236}">
+                  <a16:creationId xmlns:a16="http://schemas.microsoft.com/office/drawing/2014/main" id="{39258206-4131-12A3-660F-17B889C6B58A}"/>
+                </a:ext>
+              </a:extLst>
+            </p:cNvPr>
+            <p:cNvSpPr/>
+            <p:nvPr/>
+          </p:nvSpPr>
+          <p:spPr>
+            <a:xfrm>
+              <a:off x="4652324" y="3114618"/>
+              <a:ext cx="1507308" cy="742950"/>
+            </a:xfrm>
+            <a:prstGeom prst="ellipse">
+              <a:avLst/>
+            </a:prstGeom>
+            <a:solidFill>
+              <a:schemeClr val="tx2">
+                <a:lumMod val="50000"/>
+                <a:lumOff val="50000"/>
+              </a:schemeClr>
+            </a:solidFill>
+          </p:spPr>
+          <p:style>
+            <a:lnRef idx="2">
+              <a:schemeClr val="accent1">
+                <a:shade val="15000"/>
+              </a:schemeClr>
+            </a:lnRef>
+            <a:fillRef idx="1">
+              <a:schemeClr val="accent1"/>
+            </a:fillRef>
+            <a:effectRef idx="0">
+              <a:schemeClr val="accent1"/>
+            </a:effectRef>
+            <a:fontRef idx="minor">
+              <a:schemeClr val="lt1"/>
+            </a:fontRef>
+          </p:style>
+          <p:txBody>
+            <a:bodyPr rtlCol="0" anchor="ctr"/>
+            <a:lstStyle/>
+            <a:p>
+              <a:pPr algn="ctr"/>
+              <a:r>
+                <a:rPr lang="de-DE" sz="1600" b="1"/>
+                <a:t>Proposal</a:t>
+              </a:r>
+            </a:p>
+          </p:txBody>
+        </p:sp>
+        <p:sp>
+          <p:nvSpPr>
+            <p:cNvPr id="20" name="Ellipse 19">
+              <a:extLst>
+                <a:ext uri="{FF2B5EF4-FFF2-40B4-BE49-F238E27FC236}">
+                  <a16:creationId xmlns:a16="http://schemas.microsoft.com/office/drawing/2014/main" id="{71B297BD-EB29-7936-AFE6-4B0B3CCC06CA}"/>
+                </a:ext>
+              </a:extLst>
+            </p:cNvPr>
+            <p:cNvSpPr/>
+            <p:nvPr/>
+          </p:nvSpPr>
+          <p:spPr>
+            <a:xfrm>
+              <a:off x="4666906" y="4144686"/>
+              <a:ext cx="1507308" cy="742950"/>
+            </a:xfrm>
+            <a:prstGeom prst="ellipse">
+              <a:avLst/>
+            </a:prstGeom>
+            <a:solidFill>
+              <a:schemeClr val="tx2">
+                <a:lumMod val="50000"/>
+                <a:lumOff val="50000"/>
+              </a:schemeClr>
+            </a:solidFill>
+          </p:spPr>
+          <p:style>
+            <a:lnRef idx="2">
+              <a:schemeClr val="accent1">
+                <a:shade val="15000"/>
+              </a:schemeClr>
+            </a:lnRef>
+            <a:fillRef idx="1">
+              <a:schemeClr val="accent1"/>
+            </a:fillRef>
+            <a:effectRef idx="0">
+              <a:schemeClr val="accent1"/>
+            </a:effectRef>
+            <a:fontRef idx="minor">
+              <a:schemeClr val="lt1"/>
+            </a:fontRef>
+          </p:style>
+          <p:txBody>
+            <a:bodyPr rtlCol="0" anchor="ctr"/>
+            <a:lstStyle/>
+            <a:p>
+              <a:pPr algn="ctr"/>
+              <a:r>
+                <a:rPr lang="de-DE" sz="1600" b="1"/>
+                <a:t>Proposal</a:t>
+              </a:r>
+            </a:p>
+          </p:txBody>
+        </p:sp>
+        <p:sp>
+          <p:nvSpPr>
+            <p:cNvPr id="21" name="Ellipse 20">
+              <a:extLst>
+                <a:ext uri="{FF2B5EF4-FFF2-40B4-BE49-F238E27FC236}">
+                  <a16:creationId xmlns:a16="http://schemas.microsoft.com/office/drawing/2014/main" id="{90575A8D-8C72-B615-A545-E12FE53533E5}"/>
+                </a:ext>
+              </a:extLst>
+            </p:cNvPr>
+            <p:cNvSpPr/>
+            <p:nvPr/>
+          </p:nvSpPr>
+          <p:spPr>
+            <a:xfrm>
+              <a:off x="4652324" y="2070503"/>
+              <a:ext cx="1507308" cy="742950"/>
+            </a:xfrm>
+            <a:prstGeom prst="ellipse">
+              <a:avLst/>
+            </a:prstGeom>
+            <a:solidFill>
+              <a:schemeClr val="tx2">
+                <a:lumMod val="50000"/>
+                <a:lumOff val="50000"/>
+              </a:schemeClr>
+            </a:solidFill>
+          </p:spPr>
+          <p:style>
+            <a:lnRef idx="2">
+              <a:schemeClr val="accent1">
+                <a:shade val="15000"/>
+              </a:schemeClr>
+            </a:lnRef>
+            <a:fillRef idx="1">
+              <a:schemeClr val="accent1"/>
+            </a:fillRef>
+            <a:effectRef idx="0">
+              <a:schemeClr val="accent1"/>
+            </a:effectRef>
+            <a:fontRef idx="minor">
+              <a:schemeClr val="lt1"/>
+            </a:fontRef>
+          </p:style>
+          <p:txBody>
+            <a:bodyPr rtlCol="0" anchor="ctr"/>
+            <a:lstStyle/>
+            <a:p>
+              <a:pPr algn="ctr"/>
+              <a:r>
+                <a:rPr lang="de-DE" sz="1600" b="1"/>
+                <a:t>Proposal</a:t>
+              </a:r>
+            </a:p>
+          </p:txBody>
+        </p:sp>
+        <p:sp>
+          <p:nvSpPr>
+            <p:cNvPr id="22" name="Ellipse 21">
+              <a:extLst>
+                <a:ext uri="{FF2B5EF4-FFF2-40B4-BE49-F238E27FC236}">
+                  <a16:creationId xmlns:a16="http://schemas.microsoft.com/office/drawing/2014/main" id="{2063DA56-F4AD-AC48-CCFA-10F491C2F167}"/>
+                </a:ext>
+              </a:extLst>
+            </p:cNvPr>
+            <p:cNvSpPr/>
+            <p:nvPr/>
+          </p:nvSpPr>
+          <p:spPr>
+            <a:xfrm>
+              <a:off x="1534315" y="1943669"/>
+              <a:ext cx="1507308" cy="742950"/>
+            </a:xfrm>
+            <a:prstGeom prst="ellipse">
+              <a:avLst/>
+            </a:prstGeom>
+            <a:solidFill>
+              <a:srgbClr val="00B050"/>
+            </a:solidFill>
+          </p:spPr>
+          <p:style>
+            <a:lnRef idx="2">
+              <a:schemeClr val="accent1">
+                <a:shade val="15000"/>
+              </a:schemeClr>
+            </a:lnRef>
+            <a:fillRef idx="1">
+              <a:schemeClr val="accent1"/>
+            </a:fillRef>
+            <a:effectRef idx="0">
+              <a:schemeClr val="accent1"/>
+            </a:effectRef>
+            <a:fontRef idx="minor">
+              <a:schemeClr val="lt1"/>
+            </a:fontRef>
+          </p:style>
+          <p:txBody>
+            <a:bodyPr rtlCol="0" anchor="ctr"/>
+            <a:lstStyle/>
+            <a:p>
+              <a:pPr algn="ctr"/>
+              <a:r>
+                <a:rPr lang="de-DE" sz="1600" b="1"/>
+                <a:t>Decision</a:t>
+              </a:r>
+            </a:p>
+          </p:txBody>
+        </p:sp>
+        <p:sp>
+          <p:nvSpPr>
+            <p:cNvPr id="23" name="Ellipse 22">
+              <a:extLst>
+                <a:ext uri="{FF2B5EF4-FFF2-40B4-BE49-F238E27FC236}">
+                  <a16:creationId xmlns:a16="http://schemas.microsoft.com/office/drawing/2014/main" id="{6BCAFD35-9659-BAB9-4F1B-2ACD5A03309D}"/>
+                </a:ext>
+              </a:extLst>
+            </p:cNvPr>
+            <p:cNvSpPr/>
+            <p:nvPr/>
+          </p:nvSpPr>
+          <p:spPr>
+            <a:xfrm>
+              <a:off x="1534315" y="3093694"/>
+              <a:ext cx="1507308" cy="742950"/>
+            </a:xfrm>
+            <a:prstGeom prst="ellipse">
+              <a:avLst/>
+            </a:prstGeom>
+            <a:solidFill>
+              <a:srgbClr val="00B050"/>
+            </a:solidFill>
+          </p:spPr>
+          <p:style>
+            <a:lnRef idx="2">
+              <a:schemeClr val="accent1">
+                <a:shade val="15000"/>
+              </a:schemeClr>
+            </a:lnRef>
+            <a:fillRef idx="1">
+              <a:schemeClr val="accent1"/>
+            </a:fillRef>
+            <a:effectRef idx="0">
+              <a:schemeClr val="accent1"/>
+            </a:effectRef>
+            <a:fontRef idx="minor">
+              <a:schemeClr val="lt1"/>
+            </a:fontRef>
+          </p:style>
+          <p:txBody>
+            <a:bodyPr rtlCol="0" anchor="ctr"/>
+            <a:lstStyle/>
+            <a:p>
+              <a:pPr algn="ctr"/>
+              <a:r>
+                <a:rPr lang="de-DE" sz="1600" b="1"/>
+                <a:t>Decision</a:t>
+              </a:r>
+            </a:p>
+          </p:txBody>
+        </p:sp>
+        <p:sp>
+          <p:nvSpPr>
+            <p:cNvPr id="24" name="Ellipse 23">
+              <a:extLst>
+                <a:ext uri="{FF2B5EF4-FFF2-40B4-BE49-F238E27FC236}">
+                  <a16:creationId xmlns:a16="http://schemas.microsoft.com/office/drawing/2014/main" id="{57C1F23F-BCC7-4F6C-01C3-846DEC0EFEC0}"/>
+                </a:ext>
+              </a:extLst>
+            </p:cNvPr>
+            <p:cNvSpPr/>
+            <p:nvPr/>
+          </p:nvSpPr>
+          <p:spPr>
+            <a:xfrm>
+              <a:off x="1514132" y="4208119"/>
+              <a:ext cx="1507308" cy="742950"/>
+            </a:xfrm>
+            <a:prstGeom prst="ellipse">
+              <a:avLst/>
+            </a:prstGeom>
+            <a:solidFill>
+              <a:srgbClr val="00B050"/>
+            </a:solidFill>
+          </p:spPr>
+          <p:style>
+            <a:lnRef idx="2">
+              <a:schemeClr val="accent1">
+                <a:shade val="15000"/>
+              </a:schemeClr>
+            </a:lnRef>
+            <a:fillRef idx="1">
+              <a:schemeClr val="accent1"/>
+            </a:fillRef>
+            <a:effectRef idx="0">
+              <a:schemeClr val="accent1"/>
+            </a:effectRef>
+            <a:fontRef idx="minor">
+              <a:schemeClr val="lt1"/>
+            </a:fontRef>
+          </p:style>
+          <p:txBody>
+            <a:bodyPr rtlCol="0" anchor="ctr"/>
+            <a:lstStyle/>
+            <a:p>
+              <a:pPr algn="ctr"/>
+              <a:r>
+                <a:rPr lang="de-DE" sz="1600" b="1"/>
+                <a:t>Decision</a:t>
+              </a:r>
+            </a:p>
+          </p:txBody>
+        </p:sp>
+        <p:sp>
+          <p:nvSpPr>
+            <p:cNvPr id="25" name="Pfeil: nach oben 24">
+              <a:extLst>
+                <a:ext uri="{FF2B5EF4-FFF2-40B4-BE49-F238E27FC236}">
+                  <a16:creationId xmlns:a16="http://schemas.microsoft.com/office/drawing/2014/main" id="{CB618802-2A98-C1E1-C645-F0980876EF22}"/>
+                </a:ext>
+              </a:extLst>
+            </p:cNvPr>
+            <p:cNvSpPr/>
+            <p:nvPr/>
+          </p:nvSpPr>
+          <p:spPr>
+            <a:xfrm>
+              <a:off x="8771563" y="1707299"/>
+              <a:ext cx="1886122" cy="3674326"/>
+            </a:xfrm>
+            <a:prstGeom prst="upArrow">
+              <a:avLst/>
+            </a:prstGeom>
+            <a:solidFill>
+              <a:schemeClr val="accent6">
+                <a:lumMod val="40000"/>
+                <a:lumOff val="60000"/>
+              </a:schemeClr>
+            </a:solidFill>
+          </p:spPr>
+          <p:style>
+            <a:lnRef idx="2">
+              <a:schemeClr val="accent1">
+                <a:shade val="15000"/>
+              </a:schemeClr>
+            </a:lnRef>
+            <a:fillRef idx="1">
+              <a:schemeClr val="accent1"/>
+            </a:fillRef>
+            <a:effectRef idx="0">
+              <a:schemeClr val="accent1"/>
+            </a:effectRef>
+            <a:fontRef idx="minor">
+              <a:schemeClr val="lt1"/>
+            </a:fontRef>
+          </p:style>
+          <p:txBody>
+            <a:bodyPr rtlCol="0" anchor="ctr"/>
+            <a:lstStyle/>
+            <a:p>
+              <a:pPr algn="ctr"/>
+              <a:endParaRPr lang="de-DE"/>
+            </a:p>
+          </p:txBody>
+        </p:sp>
+        <p:pic>
+          <p:nvPicPr>
+            <p:cNvPr id="29" name="Grafik 28">
+              <a:extLst>
+                <a:ext uri="{FF2B5EF4-FFF2-40B4-BE49-F238E27FC236}">
+                  <a16:creationId xmlns:a16="http://schemas.microsoft.com/office/drawing/2014/main" id="{FD624151-C93A-C1A6-942A-96A2AF69FF0B}"/>
+                </a:ext>
+              </a:extLst>
+            </p:cNvPr>
+            <p:cNvPicPr>
+              <a:picLocks noChangeAspect="1"/>
+            </p:cNvPicPr>
+            <p:nvPr/>
+          </p:nvPicPr>
+          <p:blipFill>
+            <a:blip r:embed="rId2">
+              <a:extLst>
+                <a:ext uri="{28A0092B-C50C-407E-A947-70E740481C1C}">
+                  <a14:useLocalDpi xmlns:a14="http://schemas.microsoft.com/office/drawing/2010/main" val="0"/>
+                </a:ext>
+              </a:extLst>
+            </a:blip>
+            <a:stretch>
+              <a:fillRect/>
+            </a:stretch>
+          </p:blipFill>
+          <p:spPr>
+            <a:xfrm>
+              <a:off x="5000521" y="5829802"/>
+              <a:ext cx="953091" cy="953091"/>
+            </a:xfrm>
+            <a:prstGeom prst="rect">
+              <a:avLst/>
+            </a:prstGeom>
+          </p:spPr>
+        </p:pic>
+        <p:cxnSp>
+          <p:nvCxnSpPr>
+            <p:cNvPr id="33" name="Gerader Verbinder 32">
+              <a:extLst>
+                <a:ext uri="{FF2B5EF4-FFF2-40B4-BE49-F238E27FC236}">
+                  <a16:creationId xmlns:a16="http://schemas.microsoft.com/office/drawing/2014/main" id="{2D9EE726-1AF9-8340-FED4-B3EFF74430DA}"/>
+                </a:ext>
+              </a:extLst>
+            </p:cNvPr>
+            <p:cNvCxnSpPr>
+              <a:cxnSpLocks/>
+            </p:cNvCxnSpPr>
+            <p:nvPr/>
+          </p:nvCxnSpPr>
+          <p:spPr>
+            <a:xfrm>
+              <a:off x="3838575" y="1426819"/>
+              <a:ext cx="18730" cy="4038599"/>
+            </a:xfrm>
+            <a:prstGeom prst="line">
+              <a:avLst/>
+            </a:prstGeom>
+            <a:ln w="76200">
+              <a:solidFill>
+                <a:srgbClr val="FF0000"/>
+              </a:solidFill>
+            </a:ln>
+          </p:spPr>
+          <p:style>
+            <a:lnRef idx="2">
+              <a:schemeClr val="accent1"/>
+            </a:lnRef>
+            <a:fillRef idx="0">
+              <a:schemeClr val="accent1"/>
+            </a:fillRef>
+            <a:effectRef idx="1">
+              <a:schemeClr val="accent1"/>
+            </a:effectRef>
+            <a:fontRef idx="minor">
+              <a:schemeClr val="tx1"/>
+            </a:fontRef>
+          </p:style>
+        </p:cxnSp>
+        <p:sp>
+          <p:nvSpPr>
+            <p:cNvPr id="36" name="Rechteck 35">
+              <a:extLst>
+                <a:ext uri="{FF2B5EF4-FFF2-40B4-BE49-F238E27FC236}">
+                  <a16:creationId xmlns:a16="http://schemas.microsoft.com/office/drawing/2014/main" id="{952CADCB-1CB0-F1CA-741C-CB151AC44414}"/>
+                </a:ext>
+              </a:extLst>
+            </p:cNvPr>
+            <p:cNvSpPr/>
+            <p:nvPr/>
+          </p:nvSpPr>
+          <p:spPr>
+            <a:xfrm>
+              <a:off x="3429296" y="2686619"/>
+              <a:ext cx="888973" cy="1590105"/>
+            </a:xfrm>
+            <a:prstGeom prst="rect">
+              <a:avLst/>
+            </a:prstGeom>
+            <a:solidFill>
+              <a:schemeClr val="bg1"/>
+            </a:solidFill>
+            <a:ln>
+              <a:noFill/>
+            </a:ln>
+          </p:spPr>
+          <p:style>
+            <a:lnRef idx="2">
+              <a:schemeClr val="accent1">
+                <a:shade val="15000"/>
+              </a:schemeClr>
+            </a:lnRef>
+            <a:fillRef idx="1">
+              <a:schemeClr val="accent1"/>
+            </a:fillRef>
+            <a:effectRef idx="0">
+              <a:schemeClr val="accent1"/>
+            </a:effectRef>
+            <a:fontRef idx="minor">
+              <a:schemeClr val="lt1"/>
+            </a:fontRef>
+          </p:style>
+          <p:txBody>
+            <a:bodyPr rtlCol="0" anchor="ctr"/>
+            <a:lstStyle/>
+            <a:p>
+              <a:pPr algn="ctr"/>
+              <a:endParaRPr lang="de-DE"/>
+            </a:p>
+          </p:txBody>
+        </p:sp>
+        <p:sp>
+          <p:nvSpPr>
+            <p:cNvPr id="27" name="Pfeil: nach links 26">
+              <a:extLst>
+                <a:ext uri="{FF2B5EF4-FFF2-40B4-BE49-F238E27FC236}">
+                  <a16:creationId xmlns:a16="http://schemas.microsoft.com/office/drawing/2014/main" id="{D78CB09B-750F-9588-B243-6B065C35AC72}"/>
+                </a:ext>
+              </a:extLst>
+            </p:cNvPr>
+            <p:cNvSpPr/>
+            <p:nvPr/>
+          </p:nvSpPr>
+          <p:spPr>
+            <a:xfrm>
+              <a:off x="3221126" y="3202294"/>
+              <a:ext cx="1131789" cy="392399"/>
+            </a:xfrm>
+            <a:prstGeom prst="leftArrow">
+              <a:avLst/>
+            </a:prstGeom>
+            <a:solidFill>
+              <a:schemeClr val="accent6"/>
+            </a:solidFill>
+          </p:spPr>
+          <p:style>
+            <a:lnRef idx="2">
+              <a:schemeClr val="accent1">
+                <a:shade val="15000"/>
+              </a:schemeClr>
+            </a:lnRef>
+            <a:fillRef idx="1">
+              <a:schemeClr val="accent1"/>
+            </a:fillRef>
+            <a:effectRef idx="0">
+              <a:schemeClr val="accent1"/>
+            </a:effectRef>
+            <a:fontRef idx="minor">
+              <a:schemeClr val="lt1"/>
+            </a:fontRef>
+          </p:style>
+          <p:txBody>
+            <a:bodyPr rtlCol="0" anchor="ctr"/>
+            <a:lstStyle/>
+            <a:p>
+              <a:pPr algn="ctr"/>
+              <a:endParaRPr lang="de-DE"/>
+            </a:p>
+          </p:txBody>
+        </p:sp>
+        <p:pic>
+          <p:nvPicPr>
+            <p:cNvPr id="37" name="Grafik 36">
+              <a:extLst>
+                <a:ext uri="{FF2B5EF4-FFF2-40B4-BE49-F238E27FC236}">
+                  <a16:creationId xmlns:a16="http://schemas.microsoft.com/office/drawing/2014/main" id="{B265D967-E0F6-75E0-AD93-28D8EEA4501F}"/>
+                </a:ext>
+              </a:extLst>
+            </p:cNvPr>
+            <p:cNvPicPr>
+              <a:picLocks noChangeAspect="1"/>
+            </p:cNvPicPr>
+            <p:nvPr/>
+          </p:nvPicPr>
+          <p:blipFill>
+            <a:blip r:embed="rId3">
+              <a:extLst>
+                <a:ext uri="{28A0092B-C50C-407E-A947-70E740481C1C}">
+                  <a14:useLocalDpi xmlns:a14="http://schemas.microsoft.com/office/drawing/2010/main" val="0"/>
+                </a:ext>
+              </a:extLst>
+            </a:blip>
+            <a:stretch>
+              <a:fillRect/>
+            </a:stretch>
+          </p:blipFill>
+          <p:spPr>
+            <a:xfrm>
+              <a:off x="3584382" y="2614658"/>
+              <a:ext cx="660908" cy="660908"/>
+            </a:xfrm>
+            <a:prstGeom prst="rect">
+              <a:avLst/>
+            </a:prstGeom>
+          </p:spPr>
+        </p:pic>
+        <p:pic>
+          <p:nvPicPr>
+            <p:cNvPr id="40" name="Grafik 39">
+              <a:extLst>
+                <a:ext uri="{FF2B5EF4-FFF2-40B4-BE49-F238E27FC236}">
+                  <a16:creationId xmlns:a16="http://schemas.microsoft.com/office/drawing/2014/main" id="{606A1F1B-FF16-5FB9-1B7C-71990D18D2B6}"/>
+                </a:ext>
+              </a:extLst>
+            </p:cNvPr>
+            <p:cNvPicPr>
+              <a:picLocks noChangeAspect="1"/>
+            </p:cNvPicPr>
+            <p:nvPr/>
+          </p:nvPicPr>
+          <p:blipFill>
+            <a:blip r:embed="rId4">
+              <a:extLst>
+                <a:ext uri="{28A0092B-C50C-407E-A947-70E740481C1C}">
+                  <a14:useLocalDpi xmlns:a14="http://schemas.microsoft.com/office/drawing/2010/main" val="0"/>
+                </a:ext>
+              </a:extLst>
+            </a:blip>
+            <a:stretch>
+              <a:fillRect/>
+            </a:stretch>
+          </p:blipFill>
+          <p:spPr>
+            <a:xfrm flipH="1">
+              <a:off x="3477288" y="3339313"/>
+              <a:ext cx="742950" cy="742950"/>
+            </a:xfrm>
+            <a:prstGeom prst="rect">
+              <a:avLst/>
+            </a:prstGeom>
+          </p:spPr>
+        </p:pic>
+        <p:pic>
+          <p:nvPicPr>
+            <p:cNvPr id="42" name="Grafik 41">
+              <a:extLst>
+                <a:ext uri="{FF2B5EF4-FFF2-40B4-BE49-F238E27FC236}">
+                  <a16:creationId xmlns:a16="http://schemas.microsoft.com/office/drawing/2014/main" id="{5774CF2A-F904-6D24-37CE-0FFA71458000}"/>
+                </a:ext>
+              </a:extLst>
+            </p:cNvPr>
+            <p:cNvPicPr>
+              <a:picLocks noChangeAspect="1"/>
+            </p:cNvPicPr>
+            <p:nvPr/>
+          </p:nvPicPr>
+          <p:blipFill>
+            <a:blip r:embed="rId5">
+              <a:extLst>
+                <a:ext uri="{28A0092B-C50C-407E-A947-70E740481C1C}">
+                  <a14:useLocalDpi xmlns:a14="http://schemas.microsoft.com/office/drawing/2010/main" val="0"/>
+                </a:ext>
+              </a:extLst>
+            </a:blip>
+            <a:stretch>
+              <a:fillRect/>
+            </a:stretch>
+          </p:blipFill>
+          <p:spPr>
+            <a:xfrm rot="18854049">
+              <a:off x="9044413" y="2988045"/>
+              <a:ext cx="1455857" cy="1455857"/>
+            </a:xfrm>
+            <a:prstGeom prst="rect">
+              <a:avLst/>
+            </a:prstGeom>
+          </p:spPr>
+        </p:pic>
+        <p:cxnSp>
+          <p:nvCxnSpPr>
+            <p:cNvPr id="46" name="Gerader Verbinder 45">
+              <a:extLst>
+                <a:ext uri="{FF2B5EF4-FFF2-40B4-BE49-F238E27FC236}">
+                  <a16:creationId xmlns:a16="http://schemas.microsoft.com/office/drawing/2014/main" id="{76BD3CD9-1AA6-01F6-ECFD-1B3E54261B80}"/>
+                </a:ext>
+              </a:extLst>
+            </p:cNvPr>
+            <p:cNvCxnSpPr>
+              <a:cxnSpLocks/>
+            </p:cNvCxnSpPr>
+            <p:nvPr/>
+          </p:nvCxnSpPr>
+          <p:spPr>
+            <a:xfrm>
+              <a:off x="4373581" y="5465418"/>
+              <a:ext cx="2245072" cy="0"/>
+            </a:xfrm>
+            <a:prstGeom prst="line">
+              <a:avLst/>
+            </a:prstGeom>
+            <a:ln w="28575">
+              <a:prstDash val="sysDash"/>
+            </a:ln>
+          </p:spPr>
+          <p:style>
+            <a:lnRef idx="2">
+              <a:schemeClr val="accent1"/>
+            </a:lnRef>
+            <a:fillRef idx="0">
+              <a:schemeClr val="accent1"/>
+            </a:fillRef>
+            <a:effectRef idx="1">
+              <a:schemeClr val="accent1"/>
+            </a:effectRef>
+            <a:fontRef idx="minor">
+              <a:schemeClr val="tx1"/>
+            </a:fontRef>
+          </p:style>
+        </p:cxnSp>
+        <p:sp>
+          <p:nvSpPr>
+            <p:cNvPr id="30" name="Pfeil: nach links 29">
+              <a:extLst>
+                <a:ext uri="{FF2B5EF4-FFF2-40B4-BE49-F238E27FC236}">
+                  <a16:creationId xmlns:a16="http://schemas.microsoft.com/office/drawing/2014/main" id="{23F6AB9C-6C3F-7896-F149-587F6EA65541}"/>
+                </a:ext>
+              </a:extLst>
+            </p:cNvPr>
+            <p:cNvSpPr/>
+            <p:nvPr/>
+          </p:nvSpPr>
+          <p:spPr>
+            <a:xfrm rot="16200000">
+              <a:off x="5070455" y="5233551"/>
+              <a:ext cx="742952" cy="392399"/>
+            </a:xfrm>
+            <a:prstGeom prst="leftArrow">
+              <a:avLst/>
+            </a:prstGeom>
+            <a:solidFill>
+              <a:srgbClr val="FF0000"/>
+            </a:solidFill>
+          </p:spPr>
+          <p:style>
+            <a:lnRef idx="2">
+              <a:schemeClr val="accent1">
+                <a:shade val="15000"/>
+              </a:schemeClr>
+            </a:lnRef>
+            <a:fillRef idx="1">
+              <a:schemeClr val="accent1"/>
+            </a:fillRef>
+            <a:effectRef idx="0">
+              <a:schemeClr val="accent1"/>
+            </a:effectRef>
+            <a:fontRef idx="minor">
+              <a:schemeClr val="lt1"/>
+            </a:fontRef>
+          </p:style>
+          <p:txBody>
+            <a:bodyPr rtlCol="0" anchor="ctr"/>
+            <a:lstStyle/>
+            <a:p>
+              <a:pPr algn="ctr"/>
+              <a:endParaRPr lang="de-DE"/>
+            </a:p>
+          </p:txBody>
+        </p:sp>
+        <p:sp>
+          <p:nvSpPr>
+            <p:cNvPr id="53" name="Ellipse 52">
+              <a:extLst>
+                <a:ext uri="{FF2B5EF4-FFF2-40B4-BE49-F238E27FC236}">
+                  <a16:creationId xmlns:a16="http://schemas.microsoft.com/office/drawing/2014/main" id="{4CE273E4-DACC-18FE-B1F2-F22205DF295C}"/>
+                </a:ext>
+              </a:extLst>
+            </p:cNvPr>
+            <p:cNvSpPr/>
+            <p:nvPr/>
+          </p:nvSpPr>
+          <p:spPr>
+            <a:xfrm>
+              <a:off x="7793318" y="3074643"/>
+              <a:ext cx="1240011" cy="742950"/>
+            </a:xfrm>
+            <a:prstGeom prst="ellipse">
+              <a:avLst/>
+            </a:prstGeom>
+            <a:solidFill>
+              <a:schemeClr val="tx2">
+                <a:lumMod val="50000"/>
+                <a:lumOff val="50000"/>
+              </a:schemeClr>
+            </a:solidFill>
+          </p:spPr>
+          <p:style>
+            <a:lnRef idx="2">
+              <a:schemeClr val="accent1">
+                <a:shade val="15000"/>
+              </a:schemeClr>
+            </a:lnRef>
+            <a:fillRef idx="1">
+              <a:schemeClr val="accent1"/>
+            </a:fillRef>
+            <a:effectRef idx="0">
+              <a:schemeClr val="accent1"/>
+            </a:effectRef>
+            <a:fontRef idx="minor">
+              <a:schemeClr val="lt1"/>
+            </a:fontRef>
+          </p:style>
+          <p:txBody>
+            <a:bodyPr rtlCol="0" anchor="ctr"/>
+            <a:lstStyle/>
+            <a:p>
+              <a:pPr algn="ctr"/>
+              <a:r>
+                <a:rPr lang="de-DE" sz="1600" b="1"/>
+                <a:t>Raw</a:t>
+              </a:r>
+            </a:p>
+          </p:txBody>
+        </p:sp>
+        <p:pic>
+          <p:nvPicPr>
+            <p:cNvPr id="54" name="Grafik 53">
+              <a:extLst>
+                <a:ext uri="{FF2B5EF4-FFF2-40B4-BE49-F238E27FC236}">
+                  <a16:creationId xmlns:a16="http://schemas.microsoft.com/office/drawing/2014/main" id="{F4B67388-3290-E097-0F90-89890F15656E}"/>
+                </a:ext>
+              </a:extLst>
+            </p:cNvPr>
+            <p:cNvPicPr>
+              <a:picLocks noChangeAspect="1"/>
+            </p:cNvPicPr>
+            <p:nvPr/>
+          </p:nvPicPr>
+          <p:blipFill>
+            <a:blip r:embed="rId4">
+              <a:extLst>
+                <a:ext uri="{28A0092B-C50C-407E-A947-70E740481C1C}">
+                  <a14:useLocalDpi xmlns:a14="http://schemas.microsoft.com/office/drawing/2010/main" val="0"/>
+                </a:ext>
+              </a:extLst>
+            </a:blip>
+            <a:stretch>
+              <a:fillRect/>
+            </a:stretch>
+          </p:blipFill>
+          <p:spPr>
+            <a:xfrm flipH="1">
+              <a:off x="4507654" y="4866655"/>
+              <a:ext cx="742950" cy="742950"/>
+            </a:xfrm>
+            <a:prstGeom prst="rect">
+              <a:avLst/>
+            </a:prstGeom>
+          </p:spPr>
+        </p:pic>
+        <p:pic>
+          <p:nvPicPr>
+            <p:cNvPr id="55" name="Grafik 54">
+              <a:extLst>
+                <a:ext uri="{FF2B5EF4-FFF2-40B4-BE49-F238E27FC236}">
+                  <a16:creationId xmlns:a16="http://schemas.microsoft.com/office/drawing/2014/main" id="{BB923A5B-0DCC-6EC9-543A-79CED09BB240}"/>
+                </a:ext>
+              </a:extLst>
+            </p:cNvPr>
+            <p:cNvPicPr>
+              <a:picLocks noChangeAspect="1"/>
+            </p:cNvPicPr>
+            <p:nvPr/>
+          </p:nvPicPr>
+          <p:blipFill>
+            <a:blip r:embed="rId4">
+              <a:extLst>
+                <a:ext uri="{28A0092B-C50C-407E-A947-70E740481C1C}">
+                  <a14:useLocalDpi xmlns:a14="http://schemas.microsoft.com/office/drawing/2010/main" val="0"/>
+                </a:ext>
+              </a:extLst>
+            </a:blip>
+            <a:stretch>
+              <a:fillRect/>
+            </a:stretch>
+          </p:blipFill>
+          <p:spPr>
+            <a:xfrm flipH="1">
+              <a:off x="3508192" y="3662543"/>
+              <a:ext cx="742950" cy="742950"/>
+            </a:xfrm>
+            <a:prstGeom prst="rect">
+              <a:avLst/>
+            </a:prstGeom>
+          </p:spPr>
+        </p:pic>
+      </p:grpSp>
     </p:spTree>
     <p:extLst>
       <p:ext uri="{BB962C8B-B14F-4D97-AF65-F5344CB8AC3E}">
@@ -10348,6 +12629,81 @@
   <p:clrMapOvr>
     <a:masterClrMapping/>
   </p:clrMapOvr>
+  <p:timing>
+    <p:tnLst>
+      <p:par>
+        <p:cTn id="1" dur="indefinite" restart="never" nodeType="tmRoot">
+          <p:childTnLst>
+            <p:seq concurrent="1" nextAc="seek">
+              <p:cTn id="2" dur="indefinite" nodeType="mainSeq">
+                <p:childTnLst>
+                  <p:par>
+                    <p:cTn id="3" fill="hold">
+                      <p:stCondLst>
+                        <p:cond delay="indefinite"/>
+                      </p:stCondLst>
+                      <p:childTnLst>
+                        <p:par>
+                          <p:cTn id="4" fill="hold">
+                            <p:stCondLst>
+                              <p:cond delay="0"/>
+                            </p:stCondLst>
+                            <p:childTnLst>
+                              <p:par>
+                                <p:cTn id="5" presetID="1" presetClass="entr" presetSubtype="0" fill="hold" nodeType="clickEffect">
+                                  <p:stCondLst>
+                                    <p:cond delay="0"/>
+                                  </p:stCondLst>
+                                  <p:childTnLst>
+                                    <p:set>
+                                      <p:cBhvr>
+                                        <p:cTn id="6" dur="1" fill="hold">
+                                          <p:stCondLst>
+                                            <p:cond delay="0"/>
+                                          </p:stCondLst>
+                                        </p:cTn>
+                                        <p:tgtEl>
+                                          <p:spTgt spid="2"/>
+                                        </p:tgtEl>
+                                        <p:attrNameLst>
+                                          <p:attrName>style.visibility</p:attrName>
+                                        </p:attrNameLst>
+                                      </p:cBhvr>
+                                      <p:to>
+                                        <p:strVal val="visible"/>
+                                      </p:to>
+                                    </p:set>
+                                  </p:childTnLst>
+                                </p:cTn>
+                              </p:par>
+                            </p:childTnLst>
+                          </p:cTn>
+                        </p:par>
+                      </p:childTnLst>
+                    </p:cTn>
+                  </p:par>
+                </p:childTnLst>
+              </p:cTn>
+              <p:prevCondLst>
+                <p:cond evt="onPrev" delay="0">
+                  <p:tgtEl>
+                    <p:sldTgt/>
+                  </p:tgtEl>
+                </p:cond>
+              </p:prevCondLst>
+              <p:nextCondLst>
+                <p:cond evt="onNext" delay="0">
+                  <p:tgtEl>
+                    <p:sldTgt/>
+                  </p:tgtEl>
+                </p:cond>
+              </p:nextCondLst>
+            </p:seq>
+          </p:childTnLst>
+        </p:cTn>
+      </p:par>
+    </p:tnLst>
+  </p:timing>
 </p:sld>
 </file>
 

</xml_diff>

<commit_message>
wip: sync [2026-06-21 00:31]
</commit_message>
<xml_diff>
--- a/josyn-intro.pptx
+++ b/josyn-intro.pptx
@@ -5,7 +5,7 @@
     <p:sldMasterId id="2147483648" r:id="rId1"/>
   </p:sldMasterIdLst>
   <p:notesMasterIdLst>
-    <p:notesMasterId r:id="rId11"/>
+    <p:notesMasterId r:id="rId12"/>
   </p:notesMasterIdLst>
   <p:sldIdLst>
     <p:sldId id="273" r:id="rId2"/>
@@ -17,6 +17,7 @@
     <p:sldId id="276" r:id="rId8"/>
     <p:sldId id="270" r:id="rId9"/>
     <p:sldId id="269" r:id="rId10"/>
+    <p:sldId id="277" r:id="rId11"/>
   </p:sldIdLst>
   <p:sldSz cx="12192000" cy="6858000"/>
   <p:notesSz cx="6858000" cy="9144000"/>
@@ -547,6 +548,198 @@
     <p:extLst>
       <p:ext uri="{BB962C8B-B14F-4D97-AF65-F5344CB8AC3E}">
         <p14:creationId xmlns:p14="http://schemas.microsoft.com/office/powerpoint/2010/main" val="3832260560"/>
+      </p:ext>
+    </p:extLst>
+  </p:cSld>
+  <p:clrMapOvr>
+    <a:masterClrMapping/>
+  </p:clrMapOvr>
+</p:notes>
+</file>
+
+<file path=ppt/notesSlides/notesSlide2.xml><?xml version="1.0" encoding="utf-8"?>
+<p:notes xmlns:a="http://schemas.openxmlformats.org/drawingml/2006/main" xmlns:r="http://schemas.openxmlformats.org/officeDocument/2006/relationships" xmlns:p="http://schemas.openxmlformats.org/presentationml/2006/main">
+  <p:cSld>
+    <p:spTree>
+      <p:nvGrpSpPr>
+        <p:cNvPr id="1" name=""/>
+        <p:cNvGrpSpPr/>
+        <p:nvPr/>
+      </p:nvGrpSpPr>
+      <p:grpSpPr>
+        <a:xfrm>
+          <a:off x="0" y="0"/>
+          <a:ext cx="0" cy="0"/>
+          <a:chOff x="0" y="0"/>
+          <a:chExt cx="0" cy="0"/>
+        </a:xfrm>
+      </p:grpSpPr>
+      <p:sp>
+        <p:nvSpPr>
+          <p:cNvPr id="2" name="Folienbildplatzhalter 1"/>
+          <p:cNvSpPr>
+            <a:spLocks noGrp="1" noRot="1" noChangeAspect="1"/>
+          </p:cNvSpPr>
+          <p:nvPr>
+            <p:ph type="sldImg"/>
+          </p:nvPr>
+        </p:nvSpPr>
+        <p:spPr/>
+      </p:sp>
+      <p:sp>
+        <p:nvSpPr>
+          <p:cNvPr id="3" name="Notizenplatzhalter 2"/>
+          <p:cNvSpPr>
+            <a:spLocks noGrp="1"/>
+          </p:cNvSpPr>
+          <p:nvPr>
+            <p:ph type="body" idx="1"/>
+          </p:nvPr>
+        </p:nvSpPr>
+        <p:spPr/>
+        <p:txBody>
+          <a:bodyPr/>
+          <a:lstStyle/>
+          <a:p>
+            <a:endParaRPr lang="de-DE"/>
+          </a:p>
+        </p:txBody>
+      </p:sp>
+      <p:sp>
+        <p:nvSpPr>
+          <p:cNvPr id="4" name="Foliennummernplatzhalter 3"/>
+          <p:cNvSpPr>
+            <a:spLocks noGrp="1"/>
+          </p:cNvSpPr>
+          <p:nvPr>
+            <p:ph type="sldNum" sz="quarter" idx="5"/>
+          </p:nvPr>
+        </p:nvSpPr>
+        <p:spPr/>
+        <p:txBody>
+          <a:bodyPr/>
+          <a:lstStyle/>
+          <a:p>
+            <a:fld id="{274F3282-AC7F-4F04-970A-9596745FD581}" type="slidenum">
+              <a:rPr lang="de-DE" smtClean="0"/>
+              <a:t>9</a:t>
+            </a:fld>
+            <a:endParaRPr lang="de-DE"/>
+          </a:p>
+        </p:txBody>
+      </p:sp>
+    </p:spTree>
+    <p:extLst>
+      <p:ext uri="{BB962C8B-B14F-4D97-AF65-F5344CB8AC3E}">
+        <p14:creationId xmlns:p14="http://schemas.microsoft.com/office/powerpoint/2010/main" val="2458213995"/>
+      </p:ext>
+    </p:extLst>
+  </p:cSld>
+  <p:clrMapOvr>
+    <a:masterClrMapping/>
+  </p:clrMapOvr>
+</p:notes>
+</file>
+
+<file path=ppt/notesSlides/notesSlide3.xml><?xml version="1.0" encoding="utf-8"?>
+<p:notes xmlns:a="http://schemas.openxmlformats.org/drawingml/2006/main" xmlns:r="http://schemas.openxmlformats.org/officeDocument/2006/relationships" xmlns:p="http://schemas.openxmlformats.org/presentationml/2006/main">
+  <p:cSld>
+    <p:spTree>
+      <p:nvGrpSpPr>
+        <p:cNvPr id="1" name="">
+          <a:extLst>
+            <a:ext uri="{FF2B5EF4-FFF2-40B4-BE49-F238E27FC236}">
+              <a16:creationId xmlns:a16="http://schemas.microsoft.com/office/drawing/2014/main" id="{FA129D7C-19A8-F8B9-9B82-D782E1A3FB80}"/>
+            </a:ext>
+          </a:extLst>
+        </p:cNvPr>
+        <p:cNvGrpSpPr/>
+        <p:nvPr/>
+      </p:nvGrpSpPr>
+      <p:grpSpPr>
+        <a:xfrm>
+          <a:off x="0" y="0"/>
+          <a:ext cx="0" cy="0"/>
+          <a:chOff x="0" y="0"/>
+          <a:chExt cx="0" cy="0"/>
+        </a:xfrm>
+      </p:grpSpPr>
+      <p:sp>
+        <p:nvSpPr>
+          <p:cNvPr id="2" name="Folienbildplatzhalter 1">
+            <a:extLst>
+              <a:ext uri="{FF2B5EF4-FFF2-40B4-BE49-F238E27FC236}">
+                <a16:creationId xmlns:a16="http://schemas.microsoft.com/office/drawing/2014/main" id="{3E1C1C68-C6E4-A750-7F54-AC26A8A23A1F}"/>
+              </a:ext>
+            </a:extLst>
+          </p:cNvPr>
+          <p:cNvSpPr>
+            <a:spLocks noGrp="1" noRot="1" noChangeAspect="1"/>
+          </p:cNvSpPr>
+          <p:nvPr>
+            <p:ph type="sldImg"/>
+          </p:nvPr>
+        </p:nvSpPr>
+        <p:spPr/>
+      </p:sp>
+      <p:sp>
+        <p:nvSpPr>
+          <p:cNvPr id="3" name="Notizenplatzhalter 2">
+            <a:extLst>
+              <a:ext uri="{FF2B5EF4-FFF2-40B4-BE49-F238E27FC236}">
+                <a16:creationId xmlns:a16="http://schemas.microsoft.com/office/drawing/2014/main" id="{3F592884-356A-4F7F-C37A-7000A8D8D681}"/>
+              </a:ext>
+            </a:extLst>
+          </p:cNvPr>
+          <p:cNvSpPr>
+            <a:spLocks noGrp="1"/>
+          </p:cNvSpPr>
+          <p:nvPr>
+            <p:ph type="body" idx="1"/>
+          </p:nvPr>
+        </p:nvSpPr>
+        <p:spPr/>
+        <p:txBody>
+          <a:bodyPr/>
+          <a:lstStyle/>
+          <a:p>
+            <a:endParaRPr lang="de-DE"/>
+          </a:p>
+        </p:txBody>
+      </p:sp>
+      <p:sp>
+        <p:nvSpPr>
+          <p:cNvPr id="4" name="Foliennummernplatzhalter 3">
+            <a:extLst>
+              <a:ext uri="{FF2B5EF4-FFF2-40B4-BE49-F238E27FC236}">
+                <a16:creationId xmlns:a16="http://schemas.microsoft.com/office/drawing/2014/main" id="{72199996-2A3F-6F5D-5B5A-F5FAFC13CC9C}"/>
+              </a:ext>
+            </a:extLst>
+          </p:cNvPr>
+          <p:cNvSpPr>
+            <a:spLocks noGrp="1"/>
+          </p:cNvSpPr>
+          <p:nvPr>
+            <p:ph type="sldNum" sz="quarter" idx="5"/>
+          </p:nvPr>
+        </p:nvSpPr>
+        <p:spPr/>
+        <p:txBody>
+          <a:bodyPr/>
+          <a:lstStyle/>
+          <a:p>
+            <a:fld id="{274F3282-AC7F-4F04-970A-9596745FD581}" type="slidenum">
+              <a:rPr lang="de-DE" smtClean="0"/>
+              <a:t>10</a:t>
+            </a:fld>
+            <a:endParaRPr lang="de-DE"/>
+          </a:p>
+        </p:txBody>
+      </p:sp>
+    </p:spTree>
+    <p:extLst>
+      <p:ext uri="{BB962C8B-B14F-4D97-AF65-F5344CB8AC3E}">
+        <p14:creationId xmlns:p14="http://schemas.microsoft.com/office/powerpoint/2010/main" val="218226788"/>
       </p:ext>
     </p:extLst>
   </p:cSld>
@@ -4069,6 +4262,2343 @@
       </p:par>
     </p:tnLst>
   </p:timing>
+</p:sld>
+</file>
+
+<file path=ppt/slides/slide10.xml><?xml version="1.0" encoding="utf-8"?>
+<p:sld xmlns:a="http://schemas.openxmlformats.org/drawingml/2006/main" xmlns:r="http://schemas.openxmlformats.org/officeDocument/2006/relationships" xmlns:p="http://schemas.openxmlformats.org/presentationml/2006/main">
+  <p:cSld>
+    <p:spTree>
+      <p:nvGrpSpPr>
+        <p:cNvPr id="1" name="">
+          <a:extLst>
+            <a:ext uri="{FF2B5EF4-FFF2-40B4-BE49-F238E27FC236}">
+              <a16:creationId xmlns:a16="http://schemas.microsoft.com/office/drawing/2014/main" id="{CF079B1E-EC5E-7DBE-C605-51B9B0786F4E}"/>
+            </a:ext>
+          </a:extLst>
+        </p:cNvPr>
+        <p:cNvGrpSpPr/>
+        <p:nvPr/>
+      </p:nvGrpSpPr>
+      <p:grpSpPr>
+        <a:xfrm>
+          <a:off x="0" y="0"/>
+          <a:ext cx="0" cy="0"/>
+          <a:chOff x="0" y="0"/>
+          <a:chExt cx="0" cy="0"/>
+        </a:xfrm>
+      </p:grpSpPr>
+      <p:sp>
+        <p:nvSpPr>
+          <p:cNvPr id="42" name="Textfeld 41">
+            <a:extLst>
+              <a:ext uri="{FF2B5EF4-FFF2-40B4-BE49-F238E27FC236}">
+                <a16:creationId xmlns:a16="http://schemas.microsoft.com/office/drawing/2014/main" id="{50C5CCA2-97C4-F1BE-3F7D-E940CEC2760C}"/>
+              </a:ext>
+            </a:extLst>
+          </p:cNvPr>
+          <p:cNvSpPr txBox="1"/>
+          <p:nvPr/>
+        </p:nvSpPr>
+        <p:spPr>
+          <a:xfrm>
+            <a:off x="518868" y="181599"/>
+            <a:ext cx="7712048" cy="461665"/>
+          </a:xfrm>
+          <a:prstGeom prst="rect">
+            <a:avLst/>
+          </a:prstGeom>
+          <a:noFill/>
+        </p:spPr>
+        <p:txBody>
+          <a:bodyPr wrap="none" rtlCol="0">
+            <a:spAutoFit/>
+          </a:bodyPr>
+          <a:lstStyle/>
+          <a:p>
+            <a:r>
+              <a:rPr lang="de-DE" sz="2400" b="1">
+                <a:solidFill>
+                  <a:srgbClr val="002060"/>
+                </a:solidFill>
+              </a:rPr>
+              <a:t>josyn-platform </a:t>
+            </a:r>
+            <a:r>
+              <a:rPr lang="de-DE" sz="2400">
+                <a:solidFill>
+                  <a:srgbClr val="002060"/>
+                </a:solidFill>
+              </a:rPr>
+              <a:t>(PoC/Proposal) | paramount perspective</a:t>
+            </a:r>
+          </a:p>
+        </p:txBody>
+      </p:sp>
+      <p:grpSp>
+        <p:nvGrpSpPr>
+          <p:cNvPr id="75" name="Gruppieren 74">
+            <a:extLst>
+              <a:ext uri="{FF2B5EF4-FFF2-40B4-BE49-F238E27FC236}">
+                <a16:creationId xmlns:a16="http://schemas.microsoft.com/office/drawing/2014/main" id="{6DD36379-05F6-3345-4AD2-DB2E75B70F7E}"/>
+              </a:ext>
+            </a:extLst>
+          </p:cNvPr>
+          <p:cNvGrpSpPr/>
+          <p:nvPr/>
+        </p:nvGrpSpPr>
+        <p:grpSpPr>
+          <a:xfrm>
+            <a:off x="876459" y="3796470"/>
+            <a:ext cx="3276600" cy="2328105"/>
+            <a:chOff x="4429125" y="1110420"/>
+            <a:chExt cx="3276600" cy="2328105"/>
+          </a:xfrm>
+        </p:grpSpPr>
+        <p:sp>
+          <p:nvSpPr>
+            <p:cNvPr id="41" name="Rechteck 40">
+              <a:extLst>
+                <a:ext uri="{FF2B5EF4-FFF2-40B4-BE49-F238E27FC236}">
+                  <a16:creationId xmlns:a16="http://schemas.microsoft.com/office/drawing/2014/main" id="{4CB9E22E-A679-3625-A2E9-80C148B99629}"/>
+                </a:ext>
+              </a:extLst>
+            </p:cNvPr>
+            <p:cNvSpPr/>
+            <p:nvPr/>
+          </p:nvSpPr>
+          <p:spPr>
+            <a:xfrm>
+              <a:off x="4429125" y="1323975"/>
+              <a:ext cx="3276600" cy="2114550"/>
+            </a:xfrm>
+            <a:prstGeom prst="rect">
+              <a:avLst/>
+            </a:prstGeom>
+            <a:noFill/>
+            <a:ln>
+              <a:solidFill>
+                <a:srgbClr val="002060"/>
+              </a:solidFill>
+              <a:prstDash val="dash"/>
+            </a:ln>
+          </p:spPr>
+          <p:style>
+            <a:lnRef idx="2">
+              <a:schemeClr val="accent1">
+                <a:shade val="15000"/>
+              </a:schemeClr>
+            </a:lnRef>
+            <a:fillRef idx="1">
+              <a:schemeClr val="accent1"/>
+            </a:fillRef>
+            <a:effectRef idx="0">
+              <a:schemeClr val="accent1"/>
+            </a:effectRef>
+            <a:fontRef idx="minor">
+              <a:schemeClr val="lt1"/>
+            </a:fontRef>
+          </p:style>
+          <p:txBody>
+            <a:bodyPr rtlCol="0" anchor="ctr"/>
+            <a:lstStyle/>
+            <a:p>
+              <a:pPr algn="ctr"/>
+              <a:endParaRPr lang="de-DE"/>
+            </a:p>
+          </p:txBody>
+        </p:sp>
+        <p:grpSp>
+          <p:nvGrpSpPr>
+            <p:cNvPr id="60" name="Gruppieren 59">
+              <a:extLst>
+                <a:ext uri="{FF2B5EF4-FFF2-40B4-BE49-F238E27FC236}">
+                  <a16:creationId xmlns:a16="http://schemas.microsoft.com/office/drawing/2014/main" id="{C76509CC-5BDF-2B15-D4B2-376C29E338EA}"/>
+                </a:ext>
+              </a:extLst>
+            </p:cNvPr>
+            <p:cNvGrpSpPr/>
+            <p:nvPr/>
+          </p:nvGrpSpPr>
+          <p:grpSpPr>
+            <a:xfrm>
+              <a:off x="4568656" y="1536242"/>
+              <a:ext cx="1013326" cy="1702258"/>
+              <a:chOff x="1820150" y="924493"/>
+              <a:chExt cx="1013326" cy="1681581"/>
+            </a:xfrm>
+          </p:grpSpPr>
+          <p:sp>
+            <p:nvSpPr>
+              <p:cNvPr id="58" name="Rechteck 57">
+                <a:extLst>
+                  <a:ext uri="{FF2B5EF4-FFF2-40B4-BE49-F238E27FC236}">
+                    <a16:creationId xmlns:a16="http://schemas.microsoft.com/office/drawing/2014/main" id="{3E8347AF-8829-7A63-DC62-5C9AB8121017}"/>
+                  </a:ext>
+                </a:extLst>
+              </p:cNvPr>
+              <p:cNvSpPr/>
+              <p:nvPr/>
+            </p:nvSpPr>
+            <p:spPr>
+              <a:xfrm>
+                <a:off x="1820150" y="924493"/>
+                <a:ext cx="1013326" cy="1681581"/>
+              </a:xfrm>
+              <a:prstGeom prst="rect">
+                <a:avLst/>
+              </a:prstGeom>
+              <a:solidFill>
+                <a:schemeClr val="bg1">
+                  <a:lumMod val="95000"/>
+                </a:schemeClr>
+              </a:solidFill>
+              <a:ln>
+                <a:solidFill>
+                  <a:schemeClr val="tx2">
+                    <a:lumMod val="25000"/>
+                    <a:lumOff val="75000"/>
+                  </a:schemeClr>
+                </a:solidFill>
+              </a:ln>
+            </p:spPr>
+            <p:style>
+              <a:lnRef idx="2">
+                <a:schemeClr val="accent1">
+                  <a:shade val="15000"/>
+                </a:schemeClr>
+              </a:lnRef>
+              <a:fillRef idx="1">
+                <a:schemeClr val="accent1"/>
+              </a:fillRef>
+              <a:effectRef idx="0">
+                <a:schemeClr val="accent1"/>
+              </a:effectRef>
+              <a:fontRef idx="minor">
+                <a:schemeClr val="lt1"/>
+              </a:fontRef>
+            </p:style>
+            <p:txBody>
+              <a:bodyPr rtlCol="0" anchor="ctr"/>
+              <a:lstStyle/>
+              <a:p>
+                <a:pPr algn="ctr"/>
+                <a:endParaRPr lang="de-DE"/>
+              </a:p>
+            </p:txBody>
+          </p:sp>
+          <p:pic>
+            <p:nvPicPr>
+              <p:cNvPr id="28" name="Grafik 27">
+                <a:extLst>
+                  <a:ext uri="{FF2B5EF4-FFF2-40B4-BE49-F238E27FC236}">
+                    <a16:creationId xmlns:a16="http://schemas.microsoft.com/office/drawing/2014/main" id="{16202F63-A2FB-3668-081C-369352E55957}"/>
+                  </a:ext>
+                </a:extLst>
+              </p:cNvPr>
+              <p:cNvPicPr>
+                <a:picLocks noChangeAspect="1"/>
+              </p:cNvPicPr>
+              <p:nvPr/>
+            </p:nvPicPr>
+            <p:blipFill>
+              <a:blip r:embed="rId3">
+                <a:extLst>
+                  <a:ext uri="{28A0092B-C50C-407E-A947-70E740481C1C}">
+                    <a14:useLocalDpi xmlns:a14="http://schemas.microsoft.com/office/drawing/2010/main" val="0"/>
+                  </a:ext>
+                </a:extLst>
+              </a:blip>
+              <a:stretch>
+                <a:fillRect/>
+              </a:stretch>
+            </p:blipFill>
+            <p:spPr>
+              <a:xfrm>
+                <a:off x="1978263" y="1330212"/>
+                <a:ext cx="855213" cy="855212"/>
+              </a:xfrm>
+              <a:prstGeom prst="rect">
+                <a:avLst/>
+              </a:prstGeom>
+            </p:spPr>
+          </p:pic>
+        </p:grpSp>
+        <p:sp>
+          <p:nvSpPr>
+            <p:cNvPr id="50" name="Textfeld 49">
+              <a:extLst>
+                <a:ext uri="{FF2B5EF4-FFF2-40B4-BE49-F238E27FC236}">
+                  <a16:creationId xmlns:a16="http://schemas.microsoft.com/office/drawing/2014/main" id="{B0D9FBAA-BCE2-2FF0-FFAB-6060B1DFB1BA}"/>
+                </a:ext>
+              </a:extLst>
+            </p:cNvPr>
+            <p:cNvSpPr txBox="1"/>
+            <p:nvPr/>
+          </p:nvSpPr>
+          <p:spPr>
+            <a:xfrm>
+              <a:off x="4568656" y="1110420"/>
+              <a:ext cx="696587" cy="369332"/>
+            </a:xfrm>
+            <a:prstGeom prst="rect">
+              <a:avLst/>
+            </a:prstGeom>
+            <a:solidFill>
+              <a:schemeClr val="bg1"/>
+            </a:solidFill>
+          </p:spPr>
+          <p:txBody>
+            <a:bodyPr wrap="square" rtlCol="0">
+              <a:spAutoFit/>
+            </a:bodyPr>
+            <a:lstStyle/>
+            <a:p>
+              <a:r>
+                <a:rPr lang="de-DE" b="1">
+                  <a:solidFill>
+                    <a:srgbClr val="002060"/>
+                  </a:solidFill>
+                </a:rPr>
+                <a:t>prod</a:t>
+              </a:r>
+              <a:endParaRPr lang="de-DE">
+                <a:solidFill>
+                  <a:srgbClr val="002060"/>
+                </a:solidFill>
+              </a:endParaRPr>
+            </a:p>
+          </p:txBody>
+        </p:sp>
+        <p:sp>
+          <p:nvSpPr>
+            <p:cNvPr id="65" name="Rechteck 64">
+              <a:extLst>
+                <a:ext uri="{FF2B5EF4-FFF2-40B4-BE49-F238E27FC236}">
+                  <a16:creationId xmlns:a16="http://schemas.microsoft.com/office/drawing/2014/main" id="{E8653C20-8972-EC34-25A6-B089321287B6}"/>
+                </a:ext>
+              </a:extLst>
+            </p:cNvPr>
+            <p:cNvSpPr/>
+            <p:nvPr/>
+          </p:nvSpPr>
+          <p:spPr>
+            <a:xfrm>
+              <a:off x="5716443" y="1536242"/>
+              <a:ext cx="1827357" cy="529654"/>
+            </a:xfrm>
+            <a:prstGeom prst="rect">
+              <a:avLst/>
+            </a:prstGeom>
+            <a:noFill/>
+            <a:ln>
+              <a:solidFill>
+                <a:srgbClr val="002060"/>
+              </a:solidFill>
+              <a:prstDash val="dash"/>
+            </a:ln>
+          </p:spPr>
+          <p:style>
+            <a:lnRef idx="2">
+              <a:schemeClr val="accent1">
+                <a:shade val="15000"/>
+              </a:schemeClr>
+            </a:lnRef>
+            <a:fillRef idx="1">
+              <a:schemeClr val="accent1"/>
+            </a:fillRef>
+            <a:effectRef idx="0">
+              <a:schemeClr val="accent1"/>
+            </a:effectRef>
+            <a:fontRef idx="minor">
+              <a:schemeClr val="lt1"/>
+            </a:fontRef>
+          </p:style>
+          <p:txBody>
+            <a:bodyPr rtlCol="0" anchor="ctr"/>
+            <a:lstStyle/>
+            <a:p>
+              <a:pPr algn="ctr"/>
+              <a:endParaRPr lang="de-DE"/>
+            </a:p>
+          </p:txBody>
+        </p:sp>
+        <p:sp>
+          <p:nvSpPr>
+            <p:cNvPr id="66" name="Rechteck 65">
+              <a:extLst>
+                <a:ext uri="{FF2B5EF4-FFF2-40B4-BE49-F238E27FC236}">
+                  <a16:creationId xmlns:a16="http://schemas.microsoft.com/office/drawing/2014/main" id="{1AED45E9-3916-3984-E674-F11578A47931}"/>
+                </a:ext>
+              </a:extLst>
+            </p:cNvPr>
+            <p:cNvSpPr/>
+            <p:nvPr/>
+          </p:nvSpPr>
+          <p:spPr>
+            <a:xfrm>
+              <a:off x="5716443" y="2139035"/>
+              <a:ext cx="1827357" cy="529654"/>
+            </a:xfrm>
+            <a:prstGeom prst="rect">
+              <a:avLst/>
+            </a:prstGeom>
+            <a:noFill/>
+            <a:ln>
+              <a:solidFill>
+                <a:srgbClr val="002060"/>
+              </a:solidFill>
+              <a:prstDash val="dash"/>
+            </a:ln>
+          </p:spPr>
+          <p:style>
+            <a:lnRef idx="2">
+              <a:schemeClr val="accent1">
+                <a:shade val="15000"/>
+              </a:schemeClr>
+            </a:lnRef>
+            <a:fillRef idx="1">
+              <a:schemeClr val="accent1"/>
+            </a:fillRef>
+            <a:effectRef idx="0">
+              <a:schemeClr val="accent1"/>
+            </a:effectRef>
+            <a:fontRef idx="minor">
+              <a:schemeClr val="lt1"/>
+            </a:fontRef>
+          </p:style>
+          <p:txBody>
+            <a:bodyPr rtlCol="0" anchor="ctr"/>
+            <a:lstStyle/>
+            <a:p>
+              <a:pPr algn="ctr"/>
+              <a:endParaRPr lang="de-DE"/>
+            </a:p>
+          </p:txBody>
+        </p:sp>
+        <p:sp>
+          <p:nvSpPr>
+            <p:cNvPr id="69" name="Rechteck 68">
+              <a:extLst>
+                <a:ext uri="{FF2B5EF4-FFF2-40B4-BE49-F238E27FC236}">
+                  <a16:creationId xmlns:a16="http://schemas.microsoft.com/office/drawing/2014/main" id="{9B6DEE85-7BC1-53D6-9ACA-E05E1290F534}"/>
+                </a:ext>
+              </a:extLst>
+            </p:cNvPr>
+            <p:cNvSpPr/>
+            <p:nvPr/>
+          </p:nvSpPr>
+          <p:spPr>
+            <a:xfrm>
+              <a:off x="5716442" y="2735364"/>
+              <a:ext cx="1827357" cy="529654"/>
+            </a:xfrm>
+            <a:prstGeom prst="rect">
+              <a:avLst/>
+            </a:prstGeom>
+            <a:noFill/>
+            <a:ln>
+              <a:solidFill>
+                <a:srgbClr val="002060"/>
+              </a:solidFill>
+              <a:prstDash val="dash"/>
+            </a:ln>
+          </p:spPr>
+          <p:style>
+            <a:lnRef idx="2">
+              <a:schemeClr val="accent1">
+                <a:shade val="15000"/>
+              </a:schemeClr>
+            </a:lnRef>
+            <a:fillRef idx="1">
+              <a:schemeClr val="accent1"/>
+            </a:fillRef>
+            <a:effectRef idx="0">
+              <a:schemeClr val="accent1"/>
+            </a:effectRef>
+            <a:fontRef idx="minor">
+              <a:schemeClr val="lt1"/>
+            </a:fontRef>
+          </p:style>
+          <p:txBody>
+            <a:bodyPr rtlCol="0" anchor="ctr"/>
+            <a:lstStyle/>
+            <a:p>
+              <a:pPr algn="ctr"/>
+              <a:endParaRPr lang="de-DE"/>
+            </a:p>
+          </p:txBody>
+        </p:sp>
+        <p:sp>
+          <p:nvSpPr>
+            <p:cNvPr id="71" name="Textfeld 70">
+              <a:extLst>
+                <a:ext uri="{FF2B5EF4-FFF2-40B4-BE49-F238E27FC236}">
+                  <a16:creationId xmlns:a16="http://schemas.microsoft.com/office/drawing/2014/main" id="{3557DB5F-8A73-70C4-46AD-A6915AF162EB}"/>
+                </a:ext>
+              </a:extLst>
+            </p:cNvPr>
+            <p:cNvSpPr txBox="1"/>
+            <p:nvPr/>
+          </p:nvSpPr>
+          <p:spPr>
+            <a:xfrm>
+              <a:off x="5850900" y="1624215"/>
+              <a:ext cx="1558440" cy="369332"/>
+            </a:xfrm>
+            <a:prstGeom prst="rect">
+              <a:avLst/>
+            </a:prstGeom>
+            <a:noFill/>
+          </p:spPr>
+          <p:txBody>
+            <a:bodyPr wrap="none" rtlCol="0">
+              <a:spAutoFit/>
+            </a:bodyPr>
+            <a:lstStyle/>
+            <a:p>
+              <a:r>
+                <a:rPr lang="de-DE"/>
+                <a:t>machine p-01</a:t>
+              </a:r>
+            </a:p>
+          </p:txBody>
+        </p:sp>
+        <p:sp>
+          <p:nvSpPr>
+            <p:cNvPr id="73" name="Textfeld 72">
+              <a:extLst>
+                <a:ext uri="{FF2B5EF4-FFF2-40B4-BE49-F238E27FC236}">
+                  <a16:creationId xmlns:a16="http://schemas.microsoft.com/office/drawing/2014/main" id="{7916C6AF-5735-AD9B-5D3B-E6F4198E60C6}"/>
+                </a:ext>
+              </a:extLst>
+            </p:cNvPr>
+            <p:cNvSpPr txBox="1"/>
+            <p:nvPr/>
+          </p:nvSpPr>
+          <p:spPr>
+            <a:xfrm>
+              <a:off x="5850900" y="2230354"/>
+              <a:ext cx="1558440" cy="369332"/>
+            </a:xfrm>
+            <a:prstGeom prst="rect">
+              <a:avLst/>
+            </a:prstGeom>
+            <a:noFill/>
+          </p:spPr>
+          <p:txBody>
+            <a:bodyPr wrap="none" rtlCol="0">
+              <a:spAutoFit/>
+            </a:bodyPr>
+            <a:lstStyle/>
+            <a:p>
+              <a:r>
+                <a:rPr lang="de-DE"/>
+                <a:t>machine p-02</a:t>
+              </a:r>
+            </a:p>
+          </p:txBody>
+        </p:sp>
+        <p:sp>
+          <p:nvSpPr>
+            <p:cNvPr id="74" name="Textfeld 73">
+              <a:extLst>
+                <a:ext uri="{FF2B5EF4-FFF2-40B4-BE49-F238E27FC236}">
+                  <a16:creationId xmlns:a16="http://schemas.microsoft.com/office/drawing/2014/main" id="{F6FEFC5E-B681-FA39-B677-FA10127052A3}"/>
+                </a:ext>
+              </a:extLst>
+            </p:cNvPr>
+            <p:cNvSpPr txBox="1"/>
+            <p:nvPr/>
+          </p:nvSpPr>
+          <p:spPr>
+            <a:xfrm>
+              <a:off x="5850900" y="2801973"/>
+              <a:ext cx="1635384" cy="369332"/>
+            </a:xfrm>
+            <a:prstGeom prst="rect">
+              <a:avLst/>
+            </a:prstGeom>
+            <a:noFill/>
+          </p:spPr>
+          <p:txBody>
+            <a:bodyPr wrap="none" rtlCol="0">
+              <a:spAutoFit/>
+            </a:bodyPr>
+            <a:lstStyle/>
+            <a:p>
+              <a:r>
+                <a:rPr lang="de-DE"/>
+                <a:t>machine p-n…</a:t>
+              </a:r>
+            </a:p>
+          </p:txBody>
+        </p:sp>
+      </p:grpSp>
+      <p:grpSp>
+        <p:nvGrpSpPr>
+          <p:cNvPr id="76" name="Gruppieren 75">
+            <a:extLst>
+              <a:ext uri="{FF2B5EF4-FFF2-40B4-BE49-F238E27FC236}">
+                <a16:creationId xmlns:a16="http://schemas.microsoft.com/office/drawing/2014/main" id="{EE4963FB-A264-E120-0B48-FD97B4F6733F}"/>
+              </a:ext>
+            </a:extLst>
+          </p:cNvPr>
+          <p:cNvGrpSpPr/>
+          <p:nvPr/>
+        </p:nvGrpSpPr>
+        <p:grpSpPr>
+          <a:xfrm>
+            <a:off x="4411341" y="3796470"/>
+            <a:ext cx="3276600" cy="2328105"/>
+            <a:chOff x="4429125" y="1110420"/>
+            <a:chExt cx="3276600" cy="2328105"/>
+          </a:xfrm>
+        </p:grpSpPr>
+        <p:sp>
+          <p:nvSpPr>
+            <p:cNvPr id="77" name="Rechteck 76">
+              <a:extLst>
+                <a:ext uri="{FF2B5EF4-FFF2-40B4-BE49-F238E27FC236}">
+                  <a16:creationId xmlns:a16="http://schemas.microsoft.com/office/drawing/2014/main" id="{42E0F9F9-AB2E-BBB9-42C3-0FDB5AD82563}"/>
+                </a:ext>
+              </a:extLst>
+            </p:cNvPr>
+            <p:cNvSpPr/>
+            <p:nvPr/>
+          </p:nvSpPr>
+          <p:spPr>
+            <a:xfrm>
+              <a:off x="4429125" y="1323975"/>
+              <a:ext cx="3276600" cy="2114550"/>
+            </a:xfrm>
+            <a:prstGeom prst="rect">
+              <a:avLst/>
+            </a:prstGeom>
+            <a:noFill/>
+            <a:ln>
+              <a:solidFill>
+                <a:srgbClr val="002060"/>
+              </a:solidFill>
+              <a:prstDash val="dash"/>
+            </a:ln>
+          </p:spPr>
+          <p:style>
+            <a:lnRef idx="2">
+              <a:schemeClr val="accent1">
+                <a:shade val="15000"/>
+              </a:schemeClr>
+            </a:lnRef>
+            <a:fillRef idx="1">
+              <a:schemeClr val="accent1"/>
+            </a:fillRef>
+            <a:effectRef idx="0">
+              <a:schemeClr val="accent1"/>
+            </a:effectRef>
+            <a:fontRef idx="minor">
+              <a:schemeClr val="lt1"/>
+            </a:fontRef>
+          </p:style>
+          <p:txBody>
+            <a:bodyPr rtlCol="0" anchor="ctr"/>
+            <a:lstStyle/>
+            <a:p>
+              <a:pPr algn="ctr"/>
+              <a:endParaRPr lang="de-DE"/>
+            </a:p>
+          </p:txBody>
+        </p:sp>
+        <p:grpSp>
+          <p:nvGrpSpPr>
+            <p:cNvPr id="78" name="Gruppieren 77">
+              <a:extLst>
+                <a:ext uri="{FF2B5EF4-FFF2-40B4-BE49-F238E27FC236}">
+                  <a16:creationId xmlns:a16="http://schemas.microsoft.com/office/drawing/2014/main" id="{2C4302CE-B741-4526-8E63-153F56D6BC45}"/>
+                </a:ext>
+              </a:extLst>
+            </p:cNvPr>
+            <p:cNvGrpSpPr/>
+            <p:nvPr/>
+          </p:nvGrpSpPr>
+          <p:grpSpPr>
+            <a:xfrm>
+              <a:off x="4568656" y="1536242"/>
+              <a:ext cx="1013326" cy="1702258"/>
+              <a:chOff x="1820150" y="924493"/>
+              <a:chExt cx="1013326" cy="1681581"/>
+            </a:xfrm>
+          </p:grpSpPr>
+          <p:sp>
+            <p:nvSpPr>
+              <p:cNvPr id="86" name="Rechteck 85">
+                <a:extLst>
+                  <a:ext uri="{FF2B5EF4-FFF2-40B4-BE49-F238E27FC236}">
+                    <a16:creationId xmlns:a16="http://schemas.microsoft.com/office/drawing/2014/main" id="{CDF4E0B1-2D28-F2BB-6C23-A9D4F09D89B1}"/>
+                  </a:ext>
+                </a:extLst>
+              </p:cNvPr>
+              <p:cNvSpPr/>
+              <p:nvPr/>
+            </p:nvSpPr>
+            <p:spPr>
+              <a:xfrm>
+                <a:off x="1820150" y="924493"/>
+                <a:ext cx="1013326" cy="1681581"/>
+              </a:xfrm>
+              <a:prstGeom prst="rect">
+                <a:avLst/>
+              </a:prstGeom>
+              <a:solidFill>
+                <a:schemeClr val="bg1">
+                  <a:lumMod val="95000"/>
+                </a:schemeClr>
+              </a:solidFill>
+              <a:ln>
+                <a:solidFill>
+                  <a:schemeClr val="tx2">
+                    <a:lumMod val="25000"/>
+                    <a:lumOff val="75000"/>
+                  </a:schemeClr>
+                </a:solidFill>
+              </a:ln>
+            </p:spPr>
+            <p:style>
+              <a:lnRef idx="2">
+                <a:schemeClr val="accent1">
+                  <a:shade val="15000"/>
+                </a:schemeClr>
+              </a:lnRef>
+              <a:fillRef idx="1">
+                <a:schemeClr val="accent1"/>
+              </a:fillRef>
+              <a:effectRef idx="0">
+                <a:schemeClr val="accent1"/>
+              </a:effectRef>
+              <a:fontRef idx="minor">
+                <a:schemeClr val="lt1"/>
+              </a:fontRef>
+            </p:style>
+            <p:txBody>
+              <a:bodyPr rtlCol="0" anchor="ctr"/>
+              <a:lstStyle/>
+              <a:p>
+                <a:pPr algn="ctr"/>
+                <a:endParaRPr lang="de-DE"/>
+              </a:p>
+            </p:txBody>
+          </p:sp>
+          <p:pic>
+            <p:nvPicPr>
+              <p:cNvPr id="87" name="Grafik 86">
+                <a:extLst>
+                  <a:ext uri="{FF2B5EF4-FFF2-40B4-BE49-F238E27FC236}">
+                    <a16:creationId xmlns:a16="http://schemas.microsoft.com/office/drawing/2014/main" id="{E11E8A44-0E0B-1FFC-8DD7-1EF39AF065A3}"/>
+                  </a:ext>
+                </a:extLst>
+              </p:cNvPr>
+              <p:cNvPicPr>
+                <a:picLocks noChangeAspect="1"/>
+              </p:cNvPicPr>
+              <p:nvPr/>
+            </p:nvPicPr>
+            <p:blipFill>
+              <a:blip r:embed="rId3">
+                <a:extLst>
+                  <a:ext uri="{28A0092B-C50C-407E-A947-70E740481C1C}">
+                    <a14:useLocalDpi xmlns:a14="http://schemas.microsoft.com/office/drawing/2010/main" val="0"/>
+                  </a:ext>
+                </a:extLst>
+              </a:blip>
+              <a:stretch>
+                <a:fillRect/>
+              </a:stretch>
+            </p:blipFill>
+            <p:spPr>
+              <a:xfrm>
+                <a:off x="1978263" y="1330212"/>
+                <a:ext cx="855213" cy="855212"/>
+              </a:xfrm>
+              <a:prstGeom prst="rect">
+                <a:avLst/>
+              </a:prstGeom>
+            </p:spPr>
+          </p:pic>
+        </p:grpSp>
+        <p:sp>
+          <p:nvSpPr>
+            <p:cNvPr id="79" name="Textfeld 78">
+              <a:extLst>
+                <a:ext uri="{FF2B5EF4-FFF2-40B4-BE49-F238E27FC236}">
+                  <a16:creationId xmlns:a16="http://schemas.microsoft.com/office/drawing/2014/main" id="{376A21D2-038F-AEED-87CD-16482ACCEA85}"/>
+                </a:ext>
+              </a:extLst>
+            </p:cNvPr>
+            <p:cNvSpPr txBox="1"/>
+            <p:nvPr/>
+          </p:nvSpPr>
+          <p:spPr>
+            <a:xfrm>
+              <a:off x="4568656" y="1110420"/>
+              <a:ext cx="544845" cy="369332"/>
+            </a:xfrm>
+            <a:prstGeom prst="rect">
+              <a:avLst/>
+            </a:prstGeom>
+            <a:solidFill>
+              <a:schemeClr val="bg1"/>
+            </a:solidFill>
+          </p:spPr>
+          <p:txBody>
+            <a:bodyPr wrap="square" rtlCol="0">
+              <a:spAutoFit/>
+            </a:bodyPr>
+            <a:lstStyle/>
+            <a:p>
+              <a:r>
+                <a:rPr lang="de-DE" b="1">
+                  <a:solidFill>
+                    <a:srgbClr val="002060"/>
+                  </a:solidFill>
+                </a:rPr>
+                <a:t>int</a:t>
+              </a:r>
+              <a:endParaRPr lang="de-DE">
+                <a:solidFill>
+                  <a:srgbClr val="002060"/>
+                </a:solidFill>
+              </a:endParaRPr>
+            </a:p>
+          </p:txBody>
+        </p:sp>
+        <p:sp>
+          <p:nvSpPr>
+            <p:cNvPr id="80" name="Rechteck 79">
+              <a:extLst>
+                <a:ext uri="{FF2B5EF4-FFF2-40B4-BE49-F238E27FC236}">
+                  <a16:creationId xmlns:a16="http://schemas.microsoft.com/office/drawing/2014/main" id="{903E0E31-6D1C-14CB-10A4-98A52811B2EF}"/>
+                </a:ext>
+              </a:extLst>
+            </p:cNvPr>
+            <p:cNvSpPr/>
+            <p:nvPr/>
+          </p:nvSpPr>
+          <p:spPr>
+            <a:xfrm>
+              <a:off x="5716443" y="1536242"/>
+              <a:ext cx="1827357" cy="529654"/>
+            </a:xfrm>
+            <a:prstGeom prst="rect">
+              <a:avLst/>
+            </a:prstGeom>
+            <a:noFill/>
+            <a:ln>
+              <a:solidFill>
+                <a:srgbClr val="002060"/>
+              </a:solidFill>
+              <a:prstDash val="dash"/>
+            </a:ln>
+          </p:spPr>
+          <p:style>
+            <a:lnRef idx="2">
+              <a:schemeClr val="accent1">
+                <a:shade val="15000"/>
+              </a:schemeClr>
+            </a:lnRef>
+            <a:fillRef idx="1">
+              <a:schemeClr val="accent1"/>
+            </a:fillRef>
+            <a:effectRef idx="0">
+              <a:schemeClr val="accent1"/>
+            </a:effectRef>
+            <a:fontRef idx="minor">
+              <a:schemeClr val="lt1"/>
+            </a:fontRef>
+          </p:style>
+          <p:txBody>
+            <a:bodyPr rtlCol="0" anchor="ctr"/>
+            <a:lstStyle/>
+            <a:p>
+              <a:pPr algn="ctr"/>
+              <a:endParaRPr lang="de-DE"/>
+            </a:p>
+          </p:txBody>
+        </p:sp>
+        <p:sp>
+          <p:nvSpPr>
+            <p:cNvPr id="81" name="Rechteck 80">
+              <a:extLst>
+                <a:ext uri="{FF2B5EF4-FFF2-40B4-BE49-F238E27FC236}">
+                  <a16:creationId xmlns:a16="http://schemas.microsoft.com/office/drawing/2014/main" id="{9E63DD4D-A10D-DEC7-D199-A4578F8CACCB}"/>
+                </a:ext>
+              </a:extLst>
+            </p:cNvPr>
+            <p:cNvSpPr/>
+            <p:nvPr/>
+          </p:nvSpPr>
+          <p:spPr>
+            <a:xfrm>
+              <a:off x="5716443" y="2139035"/>
+              <a:ext cx="1827357" cy="529654"/>
+            </a:xfrm>
+            <a:prstGeom prst="rect">
+              <a:avLst/>
+            </a:prstGeom>
+            <a:noFill/>
+            <a:ln>
+              <a:solidFill>
+                <a:srgbClr val="002060"/>
+              </a:solidFill>
+              <a:prstDash val="dash"/>
+            </a:ln>
+          </p:spPr>
+          <p:style>
+            <a:lnRef idx="2">
+              <a:schemeClr val="accent1">
+                <a:shade val="15000"/>
+              </a:schemeClr>
+            </a:lnRef>
+            <a:fillRef idx="1">
+              <a:schemeClr val="accent1"/>
+            </a:fillRef>
+            <a:effectRef idx="0">
+              <a:schemeClr val="accent1"/>
+            </a:effectRef>
+            <a:fontRef idx="minor">
+              <a:schemeClr val="lt1"/>
+            </a:fontRef>
+          </p:style>
+          <p:txBody>
+            <a:bodyPr rtlCol="0" anchor="ctr"/>
+            <a:lstStyle/>
+            <a:p>
+              <a:pPr algn="ctr"/>
+              <a:endParaRPr lang="de-DE"/>
+            </a:p>
+          </p:txBody>
+        </p:sp>
+        <p:sp>
+          <p:nvSpPr>
+            <p:cNvPr id="82" name="Rechteck 81">
+              <a:extLst>
+                <a:ext uri="{FF2B5EF4-FFF2-40B4-BE49-F238E27FC236}">
+                  <a16:creationId xmlns:a16="http://schemas.microsoft.com/office/drawing/2014/main" id="{6D74EE23-41B8-60FE-F242-FFF287168719}"/>
+                </a:ext>
+              </a:extLst>
+            </p:cNvPr>
+            <p:cNvSpPr/>
+            <p:nvPr/>
+          </p:nvSpPr>
+          <p:spPr>
+            <a:xfrm>
+              <a:off x="5716442" y="2735364"/>
+              <a:ext cx="1827357" cy="529654"/>
+            </a:xfrm>
+            <a:prstGeom prst="rect">
+              <a:avLst/>
+            </a:prstGeom>
+            <a:noFill/>
+            <a:ln>
+              <a:solidFill>
+                <a:srgbClr val="002060"/>
+              </a:solidFill>
+              <a:prstDash val="dash"/>
+            </a:ln>
+          </p:spPr>
+          <p:style>
+            <a:lnRef idx="2">
+              <a:schemeClr val="accent1">
+                <a:shade val="15000"/>
+              </a:schemeClr>
+            </a:lnRef>
+            <a:fillRef idx="1">
+              <a:schemeClr val="accent1"/>
+            </a:fillRef>
+            <a:effectRef idx="0">
+              <a:schemeClr val="accent1"/>
+            </a:effectRef>
+            <a:fontRef idx="minor">
+              <a:schemeClr val="lt1"/>
+            </a:fontRef>
+          </p:style>
+          <p:txBody>
+            <a:bodyPr rtlCol="0" anchor="ctr"/>
+            <a:lstStyle/>
+            <a:p>
+              <a:pPr algn="ctr"/>
+              <a:endParaRPr lang="de-DE"/>
+            </a:p>
+          </p:txBody>
+        </p:sp>
+        <p:sp>
+          <p:nvSpPr>
+            <p:cNvPr id="83" name="Textfeld 82">
+              <a:extLst>
+                <a:ext uri="{FF2B5EF4-FFF2-40B4-BE49-F238E27FC236}">
+                  <a16:creationId xmlns:a16="http://schemas.microsoft.com/office/drawing/2014/main" id="{054ED0B3-6854-2677-853F-42A117DE03C3}"/>
+                </a:ext>
+              </a:extLst>
+            </p:cNvPr>
+            <p:cNvSpPr txBox="1"/>
+            <p:nvPr/>
+          </p:nvSpPr>
+          <p:spPr>
+            <a:xfrm>
+              <a:off x="5850900" y="1624215"/>
+              <a:ext cx="1483098" cy="369332"/>
+            </a:xfrm>
+            <a:prstGeom prst="rect">
+              <a:avLst/>
+            </a:prstGeom>
+            <a:noFill/>
+          </p:spPr>
+          <p:txBody>
+            <a:bodyPr wrap="none" rtlCol="0">
+              <a:spAutoFit/>
+            </a:bodyPr>
+            <a:lstStyle/>
+            <a:p>
+              <a:r>
+                <a:rPr lang="de-DE"/>
+                <a:t>machine i-01</a:t>
+              </a:r>
+            </a:p>
+          </p:txBody>
+        </p:sp>
+        <p:sp>
+          <p:nvSpPr>
+            <p:cNvPr id="84" name="Textfeld 83">
+              <a:extLst>
+                <a:ext uri="{FF2B5EF4-FFF2-40B4-BE49-F238E27FC236}">
+                  <a16:creationId xmlns:a16="http://schemas.microsoft.com/office/drawing/2014/main" id="{B1A741D4-10F8-B2BB-3E86-7CDDEC7DF6D5}"/>
+                </a:ext>
+              </a:extLst>
+            </p:cNvPr>
+            <p:cNvSpPr txBox="1"/>
+            <p:nvPr/>
+          </p:nvSpPr>
+          <p:spPr>
+            <a:xfrm>
+              <a:off x="5850900" y="2230354"/>
+              <a:ext cx="1483098" cy="369332"/>
+            </a:xfrm>
+            <a:prstGeom prst="rect">
+              <a:avLst/>
+            </a:prstGeom>
+            <a:noFill/>
+          </p:spPr>
+          <p:txBody>
+            <a:bodyPr wrap="none" rtlCol="0">
+              <a:spAutoFit/>
+            </a:bodyPr>
+            <a:lstStyle/>
+            <a:p>
+              <a:r>
+                <a:rPr lang="de-DE"/>
+                <a:t>machine i-02</a:t>
+              </a:r>
+            </a:p>
+          </p:txBody>
+        </p:sp>
+        <p:sp>
+          <p:nvSpPr>
+            <p:cNvPr id="85" name="Textfeld 84">
+              <a:extLst>
+                <a:ext uri="{FF2B5EF4-FFF2-40B4-BE49-F238E27FC236}">
+                  <a16:creationId xmlns:a16="http://schemas.microsoft.com/office/drawing/2014/main" id="{F44DE05C-5E2E-FE5D-2571-E3B5D5FA9728}"/>
+                </a:ext>
+              </a:extLst>
+            </p:cNvPr>
+            <p:cNvSpPr txBox="1"/>
+            <p:nvPr/>
+          </p:nvSpPr>
+          <p:spPr>
+            <a:xfrm>
+              <a:off x="5850900" y="2801973"/>
+              <a:ext cx="1560042" cy="369332"/>
+            </a:xfrm>
+            <a:prstGeom prst="rect">
+              <a:avLst/>
+            </a:prstGeom>
+            <a:noFill/>
+          </p:spPr>
+          <p:txBody>
+            <a:bodyPr wrap="none" rtlCol="0">
+              <a:spAutoFit/>
+            </a:bodyPr>
+            <a:lstStyle/>
+            <a:p>
+              <a:r>
+                <a:rPr lang="de-DE"/>
+                <a:t>machine i-n…</a:t>
+              </a:r>
+            </a:p>
+          </p:txBody>
+        </p:sp>
+      </p:grpSp>
+      <p:grpSp>
+        <p:nvGrpSpPr>
+          <p:cNvPr id="88" name="Gruppieren 87">
+            <a:extLst>
+              <a:ext uri="{FF2B5EF4-FFF2-40B4-BE49-F238E27FC236}">
+                <a16:creationId xmlns:a16="http://schemas.microsoft.com/office/drawing/2014/main" id="{F2C764CF-ED26-F5B0-866D-E42804B1FBEE}"/>
+              </a:ext>
+            </a:extLst>
+          </p:cNvPr>
+          <p:cNvGrpSpPr/>
+          <p:nvPr/>
+        </p:nvGrpSpPr>
+        <p:grpSpPr>
+          <a:xfrm>
+            <a:off x="7974798" y="3796470"/>
+            <a:ext cx="3276600" cy="2328105"/>
+            <a:chOff x="4429125" y="1110420"/>
+            <a:chExt cx="3276600" cy="2328105"/>
+          </a:xfrm>
+        </p:grpSpPr>
+        <p:sp>
+          <p:nvSpPr>
+            <p:cNvPr id="89" name="Rechteck 88">
+              <a:extLst>
+                <a:ext uri="{FF2B5EF4-FFF2-40B4-BE49-F238E27FC236}">
+                  <a16:creationId xmlns:a16="http://schemas.microsoft.com/office/drawing/2014/main" id="{5C4AAD48-7E7D-D14C-9309-279D0FB96342}"/>
+                </a:ext>
+              </a:extLst>
+            </p:cNvPr>
+            <p:cNvSpPr/>
+            <p:nvPr/>
+          </p:nvSpPr>
+          <p:spPr>
+            <a:xfrm>
+              <a:off x="4429125" y="1323975"/>
+              <a:ext cx="3276600" cy="2114550"/>
+            </a:xfrm>
+            <a:prstGeom prst="rect">
+              <a:avLst/>
+            </a:prstGeom>
+            <a:noFill/>
+            <a:ln>
+              <a:solidFill>
+                <a:srgbClr val="002060"/>
+              </a:solidFill>
+              <a:prstDash val="dash"/>
+            </a:ln>
+          </p:spPr>
+          <p:style>
+            <a:lnRef idx="2">
+              <a:schemeClr val="accent1">
+                <a:shade val="15000"/>
+              </a:schemeClr>
+            </a:lnRef>
+            <a:fillRef idx="1">
+              <a:schemeClr val="accent1"/>
+            </a:fillRef>
+            <a:effectRef idx="0">
+              <a:schemeClr val="accent1"/>
+            </a:effectRef>
+            <a:fontRef idx="minor">
+              <a:schemeClr val="lt1"/>
+            </a:fontRef>
+          </p:style>
+          <p:txBody>
+            <a:bodyPr rtlCol="0" anchor="ctr"/>
+            <a:lstStyle/>
+            <a:p>
+              <a:pPr algn="ctr"/>
+              <a:endParaRPr lang="de-DE"/>
+            </a:p>
+          </p:txBody>
+        </p:sp>
+        <p:grpSp>
+          <p:nvGrpSpPr>
+            <p:cNvPr id="90" name="Gruppieren 89">
+              <a:extLst>
+                <a:ext uri="{FF2B5EF4-FFF2-40B4-BE49-F238E27FC236}">
+                  <a16:creationId xmlns:a16="http://schemas.microsoft.com/office/drawing/2014/main" id="{E34142B9-CD46-8E11-6609-60F55464A347}"/>
+                </a:ext>
+              </a:extLst>
+            </p:cNvPr>
+            <p:cNvGrpSpPr/>
+            <p:nvPr/>
+          </p:nvGrpSpPr>
+          <p:grpSpPr>
+            <a:xfrm>
+              <a:off x="4568656" y="1536242"/>
+              <a:ext cx="1013326" cy="1702258"/>
+              <a:chOff x="1820150" y="924493"/>
+              <a:chExt cx="1013326" cy="1681581"/>
+            </a:xfrm>
+          </p:grpSpPr>
+          <p:sp>
+            <p:nvSpPr>
+              <p:cNvPr id="98" name="Rechteck 97">
+                <a:extLst>
+                  <a:ext uri="{FF2B5EF4-FFF2-40B4-BE49-F238E27FC236}">
+                    <a16:creationId xmlns:a16="http://schemas.microsoft.com/office/drawing/2014/main" id="{B6C7D4EA-0E05-2D0D-4018-7B4F42898C0F}"/>
+                  </a:ext>
+                </a:extLst>
+              </p:cNvPr>
+              <p:cNvSpPr/>
+              <p:nvPr/>
+            </p:nvSpPr>
+            <p:spPr>
+              <a:xfrm>
+                <a:off x="1820150" y="924493"/>
+                <a:ext cx="1013326" cy="1681581"/>
+              </a:xfrm>
+              <a:prstGeom prst="rect">
+                <a:avLst/>
+              </a:prstGeom>
+              <a:solidFill>
+                <a:schemeClr val="bg1">
+                  <a:lumMod val="95000"/>
+                </a:schemeClr>
+              </a:solidFill>
+              <a:ln>
+                <a:solidFill>
+                  <a:schemeClr val="tx2">
+                    <a:lumMod val="25000"/>
+                    <a:lumOff val="75000"/>
+                  </a:schemeClr>
+                </a:solidFill>
+              </a:ln>
+            </p:spPr>
+            <p:style>
+              <a:lnRef idx="2">
+                <a:schemeClr val="accent1">
+                  <a:shade val="15000"/>
+                </a:schemeClr>
+              </a:lnRef>
+              <a:fillRef idx="1">
+                <a:schemeClr val="accent1"/>
+              </a:fillRef>
+              <a:effectRef idx="0">
+                <a:schemeClr val="accent1"/>
+              </a:effectRef>
+              <a:fontRef idx="minor">
+                <a:schemeClr val="lt1"/>
+              </a:fontRef>
+            </p:style>
+            <p:txBody>
+              <a:bodyPr rtlCol="0" anchor="ctr"/>
+              <a:lstStyle/>
+              <a:p>
+                <a:pPr algn="ctr"/>
+                <a:endParaRPr lang="de-DE"/>
+              </a:p>
+            </p:txBody>
+          </p:sp>
+          <p:pic>
+            <p:nvPicPr>
+              <p:cNvPr id="99" name="Grafik 98">
+                <a:extLst>
+                  <a:ext uri="{FF2B5EF4-FFF2-40B4-BE49-F238E27FC236}">
+                    <a16:creationId xmlns:a16="http://schemas.microsoft.com/office/drawing/2014/main" id="{EA56D6D8-0873-0FF5-0493-01D608F0DB66}"/>
+                  </a:ext>
+                </a:extLst>
+              </p:cNvPr>
+              <p:cNvPicPr>
+                <a:picLocks noChangeAspect="1"/>
+              </p:cNvPicPr>
+              <p:nvPr/>
+            </p:nvPicPr>
+            <p:blipFill>
+              <a:blip r:embed="rId3">
+                <a:extLst>
+                  <a:ext uri="{28A0092B-C50C-407E-A947-70E740481C1C}">
+                    <a14:useLocalDpi xmlns:a14="http://schemas.microsoft.com/office/drawing/2010/main" val="0"/>
+                  </a:ext>
+                </a:extLst>
+              </a:blip>
+              <a:stretch>
+                <a:fillRect/>
+              </a:stretch>
+            </p:blipFill>
+            <p:spPr>
+              <a:xfrm>
+                <a:off x="1978263" y="1330212"/>
+                <a:ext cx="855213" cy="855212"/>
+              </a:xfrm>
+              <a:prstGeom prst="rect">
+                <a:avLst/>
+              </a:prstGeom>
+            </p:spPr>
+          </p:pic>
+        </p:grpSp>
+        <p:sp>
+          <p:nvSpPr>
+            <p:cNvPr id="91" name="Textfeld 90">
+              <a:extLst>
+                <a:ext uri="{FF2B5EF4-FFF2-40B4-BE49-F238E27FC236}">
+                  <a16:creationId xmlns:a16="http://schemas.microsoft.com/office/drawing/2014/main" id="{107567DF-9219-EAF1-13E4-F84B16FA045C}"/>
+                </a:ext>
+              </a:extLst>
+            </p:cNvPr>
+            <p:cNvSpPr txBox="1"/>
+            <p:nvPr/>
+          </p:nvSpPr>
+          <p:spPr>
+            <a:xfrm>
+              <a:off x="4568658" y="1110420"/>
+              <a:ext cx="638986" cy="369332"/>
+            </a:xfrm>
+            <a:prstGeom prst="rect">
+              <a:avLst/>
+            </a:prstGeom>
+            <a:solidFill>
+              <a:schemeClr val="bg1"/>
+            </a:solidFill>
+          </p:spPr>
+          <p:txBody>
+            <a:bodyPr wrap="square" rtlCol="0">
+              <a:spAutoFit/>
+            </a:bodyPr>
+            <a:lstStyle/>
+            <a:p>
+              <a:r>
+                <a:rPr lang="de-DE" b="1">
+                  <a:solidFill>
+                    <a:srgbClr val="002060"/>
+                  </a:solidFill>
+                </a:rPr>
+                <a:t>dev</a:t>
+              </a:r>
+              <a:endParaRPr lang="de-DE">
+                <a:solidFill>
+                  <a:srgbClr val="002060"/>
+                </a:solidFill>
+              </a:endParaRPr>
+            </a:p>
+          </p:txBody>
+        </p:sp>
+        <p:sp>
+          <p:nvSpPr>
+            <p:cNvPr id="92" name="Rechteck 91">
+              <a:extLst>
+                <a:ext uri="{FF2B5EF4-FFF2-40B4-BE49-F238E27FC236}">
+                  <a16:creationId xmlns:a16="http://schemas.microsoft.com/office/drawing/2014/main" id="{2CCA74BF-3293-AECA-C971-1243362D1AE7}"/>
+                </a:ext>
+              </a:extLst>
+            </p:cNvPr>
+            <p:cNvSpPr/>
+            <p:nvPr/>
+          </p:nvSpPr>
+          <p:spPr>
+            <a:xfrm>
+              <a:off x="5716443" y="1536242"/>
+              <a:ext cx="1827357" cy="529654"/>
+            </a:xfrm>
+            <a:prstGeom prst="rect">
+              <a:avLst/>
+            </a:prstGeom>
+            <a:noFill/>
+            <a:ln>
+              <a:solidFill>
+                <a:srgbClr val="002060"/>
+              </a:solidFill>
+              <a:prstDash val="dash"/>
+            </a:ln>
+          </p:spPr>
+          <p:style>
+            <a:lnRef idx="2">
+              <a:schemeClr val="accent1">
+                <a:shade val="15000"/>
+              </a:schemeClr>
+            </a:lnRef>
+            <a:fillRef idx="1">
+              <a:schemeClr val="accent1"/>
+            </a:fillRef>
+            <a:effectRef idx="0">
+              <a:schemeClr val="accent1"/>
+            </a:effectRef>
+            <a:fontRef idx="minor">
+              <a:schemeClr val="lt1"/>
+            </a:fontRef>
+          </p:style>
+          <p:txBody>
+            <a:bodyPr rtlCol="0" anchor="ctr"/>
+            <a:lstStyle/>
+            <a:p>
+              <a:pPr algn="ctr"/>
+              <a:endParaRPr lang="de-DE"/>
+            </a:p>
+          </p:txBody>
+        </p:sp>
+        <p:sp>
+          <p:nvSpPr>
+            <p:cNvPr id="93" name="Rechteck 92">
+              <a:extLst>
+                <a:ext uri="{FF2B5EF4-FFF2-40B4-BE49-F238E27FC236}">
+                  <a16:creationId xmlns:a16="http://schemas.microsoft.com/office/drawing/2014/main" id="{166D5F45-6124-CC15-B12A-EEFD35172EAE}"/>
+                </a:ext>
+              </a:extLst>
+            </p:cNvPr>
+            <p:cNvSpPr/>
+            <p:nvPr/>
+          </p:nvSpPr>
+          <p:spPr>
+            <a:xfrm>
+              <a:off x="5716443" y="2139035"/>
+              <a:ext cx="1827357" cy="529654"/>
+            </a:xfrm>
+            <a:prstGeom prst="rect">
+              <a:avLst/>
+            </a:prstGeom>
+            <a:noFill/>
+            <a:ln>
+              <a:solidFill>
+                <a:srgbClr val="002060"/>
+              </a:solidFill>
+              <a:prstDash val="dash"/>
+            </a:ln>
+          </p:spPr>
+          <p:style>
+            <a:lnRef idx="2">
+              <a:schemeClr val="accent1">
+                <a:shade val="15000"/>
+              </a:schemeClr>
+            </a:lnRef>
+            <a:fillRef idx="1">
+              <a:schemeClr val="accent1"/>
+            </a:fillRef>
+            <a:effectRef idx="0">
+              <a:schemeClr val="accent1"/>
+            </a:effectRef>
+            <a:fontRef idx="minor">
+              <a:schemeClr val="lt1"/>
+            </a:fontRef>
+          </p:style>
+          <p:txBody>
+            <a:bodyPr rtlCol="0" anchor="ctr"/>
+            <a:lstStyle/>
+            <a:p>
+              <a:pPr algn="ctr"/>
+              <a:endParaRPr lang="de-DE"/>
+            </a:p>
+          </p:txBody>
+        </p:sp>
+        <p:sp>
+          <p:nvSpPr>
+            <p:cNvPr id="94" name="Rechteck 93">
+              <a:extLst>
+                <a:ext uri="{FF2B5EF4-FFF2-40B4-BE49-F238E27FC236}">
+                  <a16:creationId xmlns:a16="http://schemas.microsoft.com/office/drawing/2014/main" id="{5F366AA7-423F-E0CE-7DF0-8AF2DC627312}"/>
+                </a:ext>
+              </a:extLst>
+            </p:cNvPr>
+            <p:cNvSpPr/>
+            <p:nvPr/>
+          </p:nvSpPr>
+          <p:spPr>
+            <a:xfrm>
+              <a:off x="5716442" y="2735364"/>
+              <a:ext cx="1827357" cy="529654"/>
+            </a:xfrm>
+            <a:prstGeom prst="rect">
+              <a:avLst/>
+            </a:prstGeom>
+            <a:noFill/>
+            <a:ln>
+              <a:solidFill>
+                <a:srgbClr val="002060"/>
+              </a:solidFill>
+              <a:prstDash val="dash"/>
+            </a:ln>
+          </p:spPr>
+          <p:style>
+            <a:lnRef idx="2">
+              <a:schemeClr val="accent1">
+                <a:shade val="15000"/>
+              </a:schemeClr>
+            </a:lnRef>
+            <a:fillRef idx="1">
+              <a:schemeClr val="accent1"/>
+            </a:fillRef>
+            <a:effectRef idx="0">
+              <a:schemeClr val="accent1"/>
+            </a:effectRef>
+            <a:fontRef idx="minor">
+              <a:schemeClr val="lt1"/>
+            </a:fontRef>
+          </p:style>
+          <p:txBody>
+            <a:bodyPr rtlCol="0" anchor="ctr"/>
+            <a:lstStyle/>
+            <a:p>
+              <a:pPr algn="ctr"/>
+              <a:endParaRPr lang="de-DE"/>
+            </a:p>
+          </p:txBody>
+        </p:sp>
+        <p:sp>
+          <p:nvSpPr>
+            <p:cNvPr id="95" name="Textfeld 94">
+              <a:extLst>
+                <a:ext uri="{FF2B5EF4-FFF2-40B4-BE49-F238E27FC236}">
+                  <a16:creationId xmlns:a16="http://schemas.microsoft.com/office/drawing/2014/main" id="{074E4030-D716-B2B4-5A74-15FC4412210C}"/>
+                </a:ext>
+              </a:extLst>
+            </p:cNvPr>
+            <p:cNvSpPr txBox="1"/>
+            <p:nvPr/>
+          </p:nvSpPr>
+          <p:spPr>
+            <a:xfrm>
+              <a:off x="5850900" y="1624215"/>
+              <a:ext cx="1558440" cy="369332"/>
+            </a:xfrm>
+            <a:prstGeom prst="rect">
+              <a:avLst/>
+            </a:prstGeom>
+            <a:noFill/>
+          </p:spPr>
+          <p:txBody>
+            <a:bodyPr wrap="none" rtlCol="0">
+              <a:spAutoFit/>
+            </a:bodyPr>
+            <a:lstStyle/>
+            <a:p>
+              <a:r>
+                <a:rPr lang="de-DE"/>
+                <a:t>machine d-01</a:t>
+              </a:r>
+            </a:p>
+          </p:txBody>
+        </p:sp>
+        <p:sp>
+          <p:nvSpPr>
+            <p:cNvPr id="96" name="Textfeld 95">
+              <a:extLst>
+                <a:ext uri="{FF2B5EF4-FFF2-40B4-BE49-F238E27FC236}">
+                  <a16:creationId xmlns:a16="http://schemas.microsoft.com/office/drawing/2014/main" id="{8A15E1CF-E576-C90E-6B8F-7524A7D5F13D}"/>
+                </a:ext>
+              </a:extLst>
+            </p:cNvPr>
+            <p:cNvSpPr txBox="1"/>
+            <p:nvPr/>
+          </p:nvSpPr>
+          <p:spPr>
+            <a:xfrm>
+              <a:off x="5850900" y="2230354"/>
+              <a:ext cx="1558440" cy="369332"/>
+            </a:xfrm>
+            <a:prstGeom prst="rect">
+              <a:avLst/>
+            </a:prstGeom>
+            <a:noFill/>
+          </p:spPr>
+          <p:txBody>
+            <a:bodyPr wrap="none" rtlCol="0">
+              <a:spAutoFit/>
+            </a:bodyPr>
+            <a:lstStyle/>
+            <a:p>
+              <a:r>
+                <a:rPr lang="de-DE"/>
+                <a:t>machine d-02</a:t>
+              </a:r>
+            </a:p>
+          </p:txBody>
+        </p:sp>
+        <p:sp>
+          <p:nvSpPr>
+            <p:cNvPr id="97" name="Textfeld 96">
+              <a:extLst>
+                <a:ext uri="{FF2B5EF4-FFF2-40B4-BE49-F238E27FC236}">
+                  <a16:creationId xmlns:a16="http://schemas.microsoft.com/office/drawing/2014/main" id="{31D3AC5B-EE0A-220D-2953-47545DE25B9E}"/>
+                </a:ext>
+              </a:extLst>
+            </p:cNvPr>
+            <p:cNvSpPr txBox="1"/>
+            <p:nvPr/>
+          </p:nvSpPr>
+          <p:spPr>
+            <a:xfrm>
+              <a:off x="5850900" y="2801973"/>
+              <a:ext cx="1635384" cy="369332"/>
+            </a:xfrm>
+            <a:prstGeom prst="rect">
+              <a:avLst/>
+            </a:prstGeom>
+            <a:noFill/>
+          </p:spPr>
+          <p:txBody>
+            <a:bodyPr wrap="none" rtlCol="0">
+              <a:spAutoFit/>
+            </a:bodyPr>
+            <a:lstStyle/>
+            <a:p>
+              <a:r>
+                <a:rPr lang="de-DE"/>
+                <a:t>machine d-n…</a:t>
+              </a:r>
+            </a:p>
+          </p:txBody>
+        </p:sp>
+      </p:grpSp>
+      <p:sp>
+        <p:nvSpPr>
+          <p:cNvPr id="103" name="Rechteck 102">
+            <a:extLst>
+              <a:ext uri="{FF2B5EF4-FFF2-40B4-BE49-F238E27FC236}">
+                <a16:creationId xmlns:a16="http://schemas.microsoft.com/office/drawing/2014/main" id="{BE8B31F0-3D7C-21FA-8743-F5C87A925FD5}"/>
+              </a:ext>
+            </a:extLst>
+          </p:cNvPr>
+          <p:cNvSpPr/>
+          <p:nvPr/>
+        </p:nvSpPr>
+        <p:spPr>
+          <a:xfrm>
+            <a:off x="714533" y="1125781"/>
+            <a:ext cx="9295418" cy="1459455"/>
+          </a:xfrm>
+          <a:prstGeom prst="rect">
+            <a:avLst/>
+          </a:prstGeom>
+          <a:noFill/>
+          <a:ln>
+            <a:solidFill>
+              <a:srgbClr val="002060"/>
+            </a:solidFill>
+            <a:prstDash val="dash"/>
+          </a:ln>
+        </p:spPr>
+        <p:style>
+          <a:lnRef idx="2">
+            <a:schemeClr val="accent1">
+              <a:shade val="15000"/>
+            </a:schemeClr>
+          </a:lnRef>
+          <a:fillRef idx="1">
+            <a:schemeClr val="accent1"/>
+          </a:fillRef>
+          <a:effectRef idx="0">
+            <a:schemeClr val="accent1"/>
+          </a:effectRef>
+          <a:fontRef idx="minor">
+            <a:schemeClr val="lt1"/>
+          </a:fontRef>
+        </p:style>
+        <p:txBody>
+          <a:bodyPr rtlCol="0" anchor="ctr"/>
+          <a:lstStyle/>
+          <a:p>
+            <a:pPr algn="ctr"/>
+            <a:endParaRPr lang="de-DE"/>
+          </a:p>
+        </p:txBody>
+      </p:sp>
+      <p:grpSp>
+        <p:nvGrpSpPr>
+          <p:cNvPr id="104" name="Gruppieren 103">
+            <a:extLst>
+              <a:ext uri="{FF2B5EF4-FFF2-40B4-BE49-F238E27FC236}">
+                <a16:creationId xmlns:a16="http://schemas.microsoft.com/office/drawing/2014/main" id="{AD91A5B5-C8A6-2FB6-DF17-EBFA34D56DBE}"/>
+              </a:ext>
+            </a:extLst>
+          </p:cNvPr>
+          <p:cNvGrpSpPr/>
+          <p:nvPr/>
+        </p:nvGrpSpPr>
+        <p:grpSpPr>
+          <a:xfrm>
+            <a:off x="898218" y="1412926"/>
+            <a:ext cx="1667177" cy="920997"/>
+            <a:chOff x="1820149" y="924492"/>
+            <a:chExt cx="1667177" cy="916340"/>
+          </a:xfrm>
+        </p:grpSpPr>
+        <p:sp>
+          <p:nvSpPr>
+            <p:cNvPr id="112" name="Rechteck 111">
+              <a:extLst>
+                <a:ext uri="{FF2B5EF4-FFF2-40B4-BE49-F238E27FC236}">
+                  <a16:creationId xmlns:a16="http://schemas.microsoft.com/office/drawing/2014/main" id="{973E445A-04D0-A221-AE3A-B7D0411F1F69}"/>
+                </a:ext>
+              </a:extLst>
+            </p:cNvPr>
+            <p:cNvSpPr/>
+            <p:nvPr/>
+          </p:nvSpPr>
+          <p:spPr>
+            <a:xfrm>
+              <a:off x="1820149" y="924492"/>
+              <a:ext cx="1667177" cy="916340"/>
+            </a:xfrm>
+            <a:prstGeom prst="rect">
+              <a:avLst/>
+            </a:prstGeom>
+            <a:solidFill>
+              <a:schemeClr val="bg1">
+                <a:lumMod val="95000"/>
+              </a:schemeClr>
+            </a:solidFill>
+            <a:ln>
+              <a:solidFill>
+                <a:schemeClr val="tx2">
+                  <a:lumMod val="25000"/>
+                  <a:lumOff val="75000"/>
+                </a:schemeClr>
+              </a:solidFill>
+            </a:ln>
+          </p:spPr>
+          <p:style>
+            <a:lnRef idx="2">
+              <a:schemeClr val="accent1">
+                <a:shade val="15000"/>
+              </a:schemeClr>
+            </a:lnRef>
+            <a:fillRef idx="1">
+              <a:schemeClr val="accent1"/>
+            </a:fillRef>
+            <a:effectRef idx="0">
+              <a:schemeClr val="accent1"/>
+            </a:effectRef>
+            <a:fontRef idx="minor">
+              <a:schemeClr val="lt1"/>
+            </a:fontRef>
+          </p:style>
+          <p:txBody>
+            <a:bodyPr rtlCol="0" anchor="ctr"/>
+            <a:lstStyle/>
+            <a:p>
+              <a:pPr algn="ctr"/>
+              <a:endParaRPr lang="de-DE"/>
+            </a:p>
+          </p:txBody>
+        </p:sp>
+        <p:pic>
+          <p:nvPicPr>
+            <p:cNvPr id="113" name="Grafik 112">
+              <a:extLst>
+                <a:ext uri="{FF2B5EF4-FFF2-40B4-BE49-F238E27FC236}">
+                  <a16:creationId xmlns:a16="http://schemas.microsoft.com/office/drawing/2014/main" id="{B0524F46-216B-FE18-3C60-28CAE59FFDA0}"/>
+                </a:ext>
+              </a:extLst>
+            </p:cNvPr>
+            <p:cNvPicPr>
+              <a:picLocks noChangeAspect="1"/>
+            </p:cNvPicPr>
+            <p:nvPr/>
+          </p:nvPicPr>
+          <p:blipFill>
+            <a:blip r:embed="rId3">
+              <a:extLst>
+                <a:ext uri="{28A0092B-C50C-407E-A947-70E740481C1C}">
+                  <a14:useLocalDpi xmlns:a14="http://schemas.microsoft.com/office/drawing/2010/main" val="0"/>
+                </a:ext>
+              </a:extLst>
+            </a:blip>
+            <a:stretch>
+              <a:fillRect/>
+            </a:stretch>
+          </p:blipFill>
+          <p:spPr>
+            <a:xfrm>
+              <a:off x="2405651" y="982919"/>
+              <a:ext cx="551073" cy="551072"/>
+            </a:xfrm>
+            <a:prstGeom prst="rect">
+              <a:avLst/>
+            </a:prstGeom>
+          </p:spPr>
+        </p:pic>
+      </p:grpSp>
+      <p:sp>
+        <p:nvSpPr>
+          <p:cNvPr id="105" name="Textfeld 104">
+            <a:extLst>
+              <a:ext uri="{FF2B5EF4-FFF2-40B4-BE49-F238E27FC236}">
+                <a16:creationId xmlns:a16="http://schemas.microsoft.com/office/drawing/2014/main" id="{D875A9FF-14FA-BD5C-9F79-534F63A0589A}"/>
+              </a:ext>
+            </a:extLst>
+          </p:cNvPr>
+          <p:cNvSpPr txBox="1"/>
+          <p:nvPr/>
+        </p:nvSpPr>
+        <p:spPr>
+          <a:xfrm>
+            <a:off x="980746" y="928673"/>
+            <a:ext cx="1013326" cy="369332"/>
+          </a:xfrm>
+          <a:prstGeom prst="rect">
+            <a:avLst/>
+          </a:prstGeom>
+          <a:solidFill>
+            <a:schemeClr val="bg1"/>
+          </a:solidFill>
+        </p:spPr>
+        <p:txBody>
+          <a:bodyPr wrap="square" rtlCol="0">
+            <a:spAutoFit/>
+          </a:bodyPr>
+          <a:lstStyle/>
+          <a:p>
+            <a:r>
+              <a:rPr lang="de-DE" b="1">
+                <a:solidFill>
+                  <a:srgbClr val="0070C0"/>
+                </a:solidFill>
+              </a:rPr>
+              <a:t>surface</a:t>
+            </a:r>
+            <a:endParaRPr lang="de-DE">
+              <a:solidFill>
+                <a:srgbClr val="0070C0"/>
+              </a:solidFill>
+            </a:endParaRPr>
+          </a:p>
+        </p:txBody>
+      </p:sp>
+      <p:sp>
+        <p:nvSpPr>
+          <p:cNvPr id="117" name="Textfeld 116">
+            <a:extLst>
+              <a:ext uri="{FF2B5EF4-FFF2-40B4-BE49-F238E27FC236}">
+                <a16:creationId xmlns:a16="http://schemas.microsoft.com/office/drawing/2014/main" id="{9C8ED44E-D5BC-9858-56C6-E0AF260DCC80}"/>
+              </a:ext>
+            </a:extLst>
+          </p:cNvPr>
+          <p:cNvSpPr txBox="1"/>
+          <p:nvPr/>
+        </p:nvSpPr>
+        <p:spPr>
+          <a:xfrm>
+            <a:off x="4184435" y="2900539"/>
+            <a:ext cx="1425518" cy="338554"/>
+          </a:xfrm>
+          <a:prstGeom prst="rect">
+            <a:avLst/>
+          </a:prstGeom>
+          <a:noFill/>
+        </p:spPr>
+        <p:txBody>
+          <a:bodyPr wrap="none" rtlCol="0">
+            <a:spAutoFit/>
+          </a:bodyPr>
+          <a:lstStyle/>
+          <a:p>
+            <a:r>
+              <a:rPr lang="de-DE" sz="1600" b="1"/>
+              <a:t>RESTful HTTP</a:t>
+            </a:r>
+          </a:p>
+        </p:txBody>
+      </p:sp>
+      <p:sp>
+        <p:nvSpPr>
+          <p:cNvPr id="118" name="Rechteck 117">
+            <a:extLst>
+              <a:ext uri="{FF2B5EF4-FFF2-40B4-BE49-F238E27FC236}">
+                <a16:creationId xmlns:a16="http://schemas.microsoft.com/office/drawing/2014/main" id="{4F8E0CC6-2221-A78D-B7C6-9962D37800BE}"/>
+              </a:ext>
+            </a:extLst>
+          </p:cNvPr>
+          <p:cNvSpPr/>
+          <p:nvPr/>
+        </p:nvSpPr>
+        <p:spPr>
+          <a:xfrm>
+            <a:off x="714533" y="3651849"/>
+            <a:ext cx="10724834" cy="2644176"/>
+          </a:xfrm>
+          <a:prstGeom prst="rect">
+            <a:avLst/>
+          </a:prstGeom>
+          <a:noFill/>
+          <a:ln>
+            <a:solidFill>
+              <a:srgbClr val="002060"/>
+            </a:solidFill>
+            <a:prstDash val="dash"/>
+          </a:ln>
+        </p:spPr>
+        <p:style>
+          <a:lnRef idx="2">
+            <a:schemeClr val="accent1">
+              <a:shade val="15000"/>
+            </a:schemeClr>
+          </a:lnRef>
+          <a:fillRef idx="1">
+            <a:schemeClr val="accent1"/>
+          </a:fillRef>
+          <a:effectRef idx="0">
+            <a:schemeClr val="accent1"/>
+          </a:effectRef>
+          <a:fontRef idx="minor">
+            <a:schemeClr val="lt1"/>
+          </a:fontRef>
+        </p:style>
+        <p:txBody>
+          <a:bodyPr rtlCol="0" anchor="ctr"/>
+          <a:lstStyle/>
+          <a:p>
+            <a:pPr algn="ctr"/>
+            <a:endParaRPr lang="de-DE"/>
+          </a:p>
+        </p:txBody>
+      </p:sp>
+      <p:sp>
+        <p:nvSpPr>
+          <p:cNvPr id="122" name="Textfeld 121">
+            <a:extLst>
+              <a:ext uri="{FF2B5EF4-FFF2-40B4-BE49-F238E27FC236}">
+                <a16:creationId xmlns:a16="http://schemas.microsoft.com/office/drawing/2014/main" id="{38E01999-D87B-8334-4BC3-CF8F63EF3330}"/>
+              </a:ext>
+            </a:extLst>
+          </p:cNvPr>
+          <p:cNvSpPr txBox="1"/>
+          <p:nvPr/>
+        </p:nvSpPr>
+        <p:spPr>
+          <a:xfrm>
+            <a:off x="965755" y="3435339"/>
+            <a:ext cx="1682195" cy="369332"/>
+          </a:xfrm>
+          <a:prstGeom prst="rect">
+            <a:avLst/>
+          </a:prstGeom>
+          <a:solidFill>
+            <a:schemeClr val="bg1"/>
+          </a:solidFill>
+        </p:spPr>
+        <p:txBody>
+          <a:bodyPr wrap="square" rtlCol="0">
+            <a:spAutoFit/>
+          </a:bodyPr>
+          <a:lstStyle/>
+          <a:p>
+            <a:r>
+              <a:rPr lang="de-DE" b="1">
+                <a:solidFill>
+                  <a:srgbClr val="002060"/>
+                </a:solidFill>
+              </a:rPr>
+              <a:t>headless area</a:t>
+            </a:r>
+            <a:endParaRPr lang="de-DE">
+              <a:solidFill>
+                <a:srgbClr val="002060"/>
+              </a:solidFill>
+            </a:endParaRPr>
+          </a:p>
+        </p:txBody>
+      </p:sp>
+      <p:sp>
+        <p:nvSpPr>
+          <p:cNvPr id="124" name="Textfeld 123">
+            <a:extLst>
+              <a:ext uri="{FF2B5EF4-FFF2-40B4-BE49-F238E27FC236}">
+                <a16:creationId xmlns:a16="http://schemas.microsoft.com/office/drawing/2014/main" id="{4B7E8AA5-E7D8-99DE-40C2-701B6D8B773D}"/>
+              </a:ext>
+            </a:extLst>
+          </p:cNvPr>
+          <p:cNvSpPr txBox="1"/>
+          <p:nvPr/>
+        </p:nvSpPr>
+        <p:spPr>
+          <a:xfrm>
+            <a:off x="3768942" y="1719823"/>
+            <a:ext cx="4561398" cy="738664"/>
+          </a:xfrm>
+          <a:prstGeom prst="rect">
+            <a:avLst/>
+          </a:prstGeom>
+          <a:noFill/>
+        </p:spPr>
+        <p:txBody>
+          <a:bodyPr wrap="square">
+            <a:spAutoFit/>
+          </a:bodyPr>
+          <a:lstStyle/>
+          <a:p>
+            <a:pPr marL="285750" indent="-285750">
+              <a:buFont typeface="Arial" panose="020B0604020202020204" pitchFamily="34" charset="0"/>
+              <a:buChar char="•"/>
+            </a:pPr>
+            <a:r>
+              <a:rPr lang="de-DE" sz="1400">
+                <a:solidFill>
+                  <a:srgbClr val="002060"/>
+                </a:solidFill>
+              </a:rPr>
+              <a:t>superseeds the former „RemoteControl“…</a:t>
+            </a:r>
+          </a:p>
+          <a:p>
+            <a:pPr marL="285750" indent="-285750">
+              <a:buFont typeface="Arial" panose="020B0604020202020204" pitchFamily="34" charset="0"/>
+              <a:buChar char="•"/>
+            </a:pPr>
+            <a:r>
+              <a:rPr lang="de-DE" sz="1400">
+                <a:solidFill>
+                  <a:srgbClr val="002060"/>
+                </a:solidFill>
+              </a:rPr>
+              <a:t>suspends all RDP needs…</a:t>
+            </a:r>
+          </a:p>
+          <a:p>
+            <a:pPr marL="285750" indent="-285750">
+              <a:buFont typeface="Arial" panose="020B0604020202020204" pitchFamily="34" charset="0"/>
+              <a:buChar char="•"/>
+            </a:pPr>
+            <a:r>
+              <a:rPr lang="de-DE" sz="1400">
+                <a:solidFill>
+                  <a:srgbClr val="002060"/>
+                </a:solidFill>
+              </a:rPr>
+              <a:t>maybe a blazor-app </a:t>
+            </a:r>
+            <a:r>
+              <a:rPr lang="de-DE" sz="1400" i="1">
+                <a:solidFill>
+                  <a:srgbClr val="002060"/>
+                </a:solidFill>
+              </a:rPr>
+              <a:t>and</a:t>
+            </a:r>
+            <a:r>
+              <a:rPr lang="de-DE" sz="1400">
+                <a:solidFill>
+                  <a:srgbClr val="002060"/>
+                </a:solidFill>
+              </a:rPr>
+              <a:t> a set of maintainer-scripts…</a:t>
+            </a:r>
+          </a:p>
+        </p:txBody>
+      </p:sp>
+      <p:sp>
+        <p:nvSpPr>
+          <p:cNvPr id="126" name="Textfeld 125">
+            <a:extLst>
+              <a:ext uri="{FF2B5EF4-FFF2-40B4-BE49-F238E27FC236}">
+                <a16:creationId xmlns:a16="http://schemas.microsoft.com/office/drawing/2014/main" id="{C1592DBC-F813-61B3-2D7D-B7D57EFF4E51}"/>
+              </a:ext>
+            </a:extLst>
+          </p:cNvPr>
+          <p:cNvSpPr txBox="1"/>
+          <p:nvPr/>
+        </p:nvSpPr>
+        <p:spPr>
+          <a:xfrm>
+            <a:off x="2873871" y="1319713"/>
+            <a:ext cx="7136080" cy="400110"/>
+          </a:xfrm>
+          <a:prstGeom prst="rect">
+            <a:avLst/>
+          </a:prstGeom>
+          <a:noFill/>
+        </p:spPr>
+        <p:txBody>
+          <a:bodyPr wrap="square">
+            <a:spAutoFit/>
+          </a:bodyPr>
+          <a:lstStyle/>
+          <a:p>
+            <a:pPr algn="l">
+              <a:spcAft>
+                <a:spcPts val="1200"/>
+              </a:spcAft>
+              <a:buNone/>
+            </a:pPr>
+            <a:r>
+              <a:rPr lang="de-DE" sz="2000" b="1" i="0">
+                <a:solidFill>
+                  <a:srgbClr val="0070C0"/>
+                </a:solidFill>
+                <a:effectLst/>
+                <a:latin typeface="-apple-system"/>
+              </a:rPr>
+              <a:t>josyn-surface</a:t>
+            </a:r>
+            <a:r>
+              <a:rPr lang="de-DE" sz="2000" b="1" i="0">
+                <a:effectLst/>
+                <a:latin typeface="-apple-system"/>
+              </a:rPr>
+              <a:t>: </a:t>
+            </a:r>
+            <a:r>
+              <a:rPr lang="de-DE" sz="2000" i="1">
+                <a:effectLst/>
+                <a:latin typeface="-apple-system"/>
+              </a:rPr>
+              <a:t>the human window into a headless platform</a:t>
+            </a:r>
+          </a:p>
+        </p:txBody>
+      </p:sp>
+      <p:sp>
+        <p:nvSpPr>
+          <p:cNvPr id="127" name="Textfeld 126">
+            <a:extLst>
+              <a:ext uri="{FF2B5EF4-FFF2-40B4-BE49-F238E27FC236}">
+                <a16:creationId xmlns:a16="http://schemas.microsoft.com/office/drawing/2014/main" id="{28D79F58-3D43-8A57-D710-417F5DE2D833}"/>
+              </a:ext>
+            </a:extLst>
+          </p:cNvPr>
+          <p:cNvSpPr txBox="1"/>
+          <p:nvPr/>
+        </p:nvSpPr>
+        <p:spPr>
+          <a:xfrm>
+            <a:off x="933609" y="1984443"/>
+            <a:ext cx="1587807" cy="276999"/>
+          </a:xfrm>
+          <a:prstGeom prst="rect">
+            <a:avLst/>
+          </a:prstGeom>
+          <a:noFill/>
+        </p:spPr>
+        <p:txBody>
+          <a:bodyPr wrap="none" rtlCol="0">
+            <a:spAutoFit/>
+          </a:bodyPr>
+          <a:lstStyle/>
+          <a:p>
+            <a:r>
+              <a:rPr lang="de-DE" sz="1200"/>
+              <a:t>machine/env-registry</a:t>
+            </a:r>
+          </a:p>
+        </p:txBody>
+      </p:sp>
+      <p:sp>
+        <p:nvSpPr>
+          <p:cNvPr id="128" name="Rechteck 127">
+            <a:extLst>
+              <a:ext uri="{FF2B5EF4-FFF2-40B4-BE49-F238E27FC236}">
+                <a16:creationId xmlns:a16="http://schemas.microsoft.com/office/drawing/2014/main" id="{A2A13414-5EA5-9E8F-58E0-22A473AF6641}"/>
+              </a:ext>
+            </a:extLst>
+          </p:cNvPr>
+          <p:cNvSpPr/>
+          <p:nvPr/>
+        </p:nvSpPr>
+        <p:spPr>
+          <a:xfrm>
+            <a:off x="10191230" y="1125781"/>
+            <a:ext cx="1319401" cy="1459455"/>
+          </a:xfrm>
+          <a:prstGeom prst="rect">
+            <a:avLst/>
+          </a:prstGeom>
+          <a:noFill/>
+          <a:ln>
+            <a:solidFill>
+              <a:srgbClr val="002060"/>
+            </a:solidFill>
+            <a:prstDash val="dash"/>
+          </a:ln>
+        </p:spPr>
+        <p:style>
+          <a:lnRef idx="2">
+            <a:schemeClr val="accent1">
+              <a:shade val="15000"/>
+            </a:schemeClr>
+          </a:lnRef>
+          <a:fillRef idx="1">
+            <a:schemeClr val="accent1"/>
+          </a:fillRef>
+          <a:effectRef idx="0">
+            <a:schemeClr val="accent1"/>
+          </a:effectRef>
+          <a:fontRef idx="minor">
+            <a:schemeClr val="lt1"/>
+          </a:fontRef>
+        </p:style>
+        <p:txBody>
+          <a:bodyPr rtlCol="0" anchor="ctr"/>
+          <a:lstStyle/>
+          <a:p>
+            <a:pPr algn="ctr"/>
+            <a:endParaRPr lang="de-DE"/>
+          </a:p>
+        </p:txBody>
+      </p:sp>
+      <p:sp>
+        <p:nvSpPr>
+          <p:cNvPr id="130" name="Textfeld 129">
+            <a:extLst>
+              <a:ext uri="{FF2B5EF4-FFF2-40B4-BE49-F238E27FC236}">
+                <a16:creationId xmlns:a16="http://schemas.microsoft.com/office/drawing/2014/main" id="{3CBCB20F-B13E-0255-8062-7C6EF7C749D1}"/>
+              </a:ext>
+            </a:extLst>
+          </p:cNvPr>
+          <p:cNvSpPr txBox="1"/>
+          <p:nvPr/>
+        </p:nvSpPr>
+        <p:spPr>
+          <a:xfrm>
+            <a:off x="10247597" y="925032"/>
+            <a:ext cx="1182246" cy="369332"/>
+          </a:xfrm>
+          <a:prstGeom prst="rect">
+            <a:avLst/>
+          </a:prstGeom>
+          <a:solidFill>
+            <a:schemeClr val="bg1"/>
+          </a:solidFill>
+        </p:spPr>
+        <p:txBody>
+          <a:bodyPr wrap="square" rtlCol="0">
+            <a:spAutoFit/>
+          </a:bodyPr>
+          <a:lstStyle/>
+          <a:p>
+            <a:r>
+              <a:rPr lang="de-DE" b="1"/>
+              <a:t>pipelines</a:t>
+            </a:r>
+            <a:endParaRPr lang="de-DE"/>
+          </a:p>
+        </p:txBody>
+      </p:sp>
+      <p:pic>
+        <p:nvPicPr>
+          <p:cNvPr id="131" name="Grafik 130" descr="Azure DevOps Logo and symbol, meaning, history, PNG, brand">
+            <a:extLst>
+              <a:ext uri="{FF2B5EF4-FFF2-40B4-BE49-F238E27FC236}">
+                <a16:creationId xmlns:a16="http://schemas.microsoft.com/office/drawing/2014/main" id="{6A3BD91A-5219-9F3A-7CE3-7A309B56DD96}"/>
+              </a:ext>
+            </a:extLst>
+          </p:cNvPr>
+          <p:cNvPicPr>
+            <a:picLocks noChangeAspect="1"/>
+          </p:cNvPicPr>
+          <p:nvPr/>
+        </p:nvPicPr>
+        <p:blipFill>
+          <a:blip r:embed="rId4"/>
+          <a:stretch>
+            <a:fillRect/>
+          </a:stretch>
+        </p:blipFill>
+        <p:spPr>
+          <a:xfrm>
+            <a:off x="9955971" y="1399099"/>
+            <a:ext cx="1661909" cy="934824"/>
+          </a:xfrm>
+          <a:prstGeom prst="rect">
+            <a:avLst/>
+          </a:prstGeom>
+        </p:spPr>
+      </p:pic>
+      <p:sp>
+        <p:nvSpPr>
+          <p:cNvPr id="132" name="Pfeil: nach unten 131">
+            <a:extLst>
+              <a:ext uri="{FF2B5EF4-FFF2-40B4-BE49-F238E27FC236}">
+                <a16:creationId xmlns:a16="http://schemas.microsoft.com/office/drawing/2014/main" id="{576641C9-365D-77E9-963D-35AA37547D38}"/>
+              </a:ext>
+            </a:extLst>
+          </p:cNvPr>
+          <p:cNvSpPr/>
+          <p:nvPr/>
+        </p:nvSpPr>
+        <p:spPr>
+          <a:xfrm>
+            <a:off x="10557511" y="2746216"/>
+            <a:ext cx="531961" cy="736070"/>
+          </a:xfrm>
+          <a:prstGeom prst="downArrow">
+            <a:avLst/>
+          </a:prstGeom>
+          <a:solidFill>
+            <a:schemeClr val="tx2">
+              <a:lumMod val="25000"/>
+              <a:lumOff val="75000"/>
+            </a:schemeClr>
+          </a:solidFill>
+        </p:spPr>
+        <p:style>
+          <a:lnRef idx="2">
+            <a:schemeClr val="accent1">
+              <a:shade val="15000"/>
+            </a:schemeClr>
+          </a:lnRef>
+          <a:fillRef idx="1">
+            <a:schemeClr val="accent1"/>
+          </a:fillRef>
+          <a:effectRef idx="0">
+            <a:schemeClr val="accent1"/>
+          </a:effectRef>
+          <a:fontRef idx="minor">
+            <a:schemeClr val="lt1"/>
+          </a:fontRef>
+        </p:style>
+        <p:txBody>
+          <a:bodyPr rtlCol="0" anchor="ctr"/>
+          <a:lstStyle/>
+          <a:p>
+            <a:pPr algn="ctr"/>
+            <a:endParaRPr lang="de-DE"/>
+          </a:p>
+        </p:txBody>
+      </p:sp>
+      <p:sp>
+        <p:nvSpPr>
+          <p:cNvPr id="133" name="Pfeil: nach unten 132">
+            <a:extLst>
+              <a:ext uri="{FF2B5EF4-FFF2-40B4-BE49-F238E27FC236}">
+                <a16:creationId xmlns:a16="http://schemas.microsoft.com/office/drawing/2014/main" id="{B478007D-BFBB-FD6C-CE99-C85C9F7EF518}"/>
+              </a:ext>
+            </a:extLst>
+          </p:cNvPr>
+          <p:cNvSpPr/>
+          <p:nvPr/>
+        </p:nvSpPr>
+        <p:spPr>
+          <a:xfrm>
+            <a:off x="5556886" y="2738769"/>
+            <a:ext cx="531961" cy="733992"/>
+          </a:xfrm>
+          <a:prstGeom prst="downArrow">
+            <a:avLst/>
+          </a:prstGeom>
+          <a:solidFill>
+            <a:srgbClr val="FFE07D"/>
+          </a:solidFill>
+        </p:spPr>
+        <p:style>
+          <a:lnRef idx="2">
+            <a:schemeClr val="accent1">
+              <a:shade val="15000"/>
+            </a:schemeClr>
+          </a:lnRef>
+          <a:fillRef idx="1">
+            <a:schemeClr val="accent1"/>
+          </a:fillRef>
+          <a:effectRef idx="0">
+            <a:schemeClr val="accent1"/>
+          </a:effectRef>
+          <a:fontRef idx="minor">
+            <a:schemeClr val="lt1"/>
+          </a:fontRef>
+        </p:style>
+        <p:txBody>
+          <a:bodyPr rtlCol="0" anchor="ctr"/>
+          <a:lstStyle/>
+          <a:p>
+            <a:pPr algn="ctr"/>
+            <a:endParaRPr lang="de-DE"/>
+          </a:p>
+        </p:txBody>
+      </p:sp>
+    </p:spTree>
+    <p:extLst>
+      <p:ext uri="{BB962C8B-B14F-4D97-AF65-F5344CB8AC3E}">
+        <p14:creationId xmlns:p14="http://schemas.microsoft.com/office/powerpoint/2010/main" val="291207422"/>
+      </p:ext>
+    </p:extLst>
+  </p:cSld>
+  <p:clrMapOvr>
+    <a:masterClrMapping/>
+  </p:clrMapOvr>
 </p:sld>
 </file>
 
@@ -8835,7 +11365,7 @@
             <p:spPr>
               <a:xfrm>
                 <a:off x="4963072" y="1012888"/>
-                <a:ext cx="2287036" cy="461665"/>
+                <a:ext cx="2262735" cy="461665"/>
               </a:xfrm>
               <a:prstGeom prst="rect">
                 <a:avLst/>
@@ -8854,7 +11384,7 @@
                       <a:srgbClr val="002060"/>
                     </a:solidFill>
                   </a:rPr>
-                  <a:t>„Staging-Area“</a:t>
+                  <a:t>„Staging-Pipe“</a:t>
                 </a:r>
               </a:p>
             </p:txBody>
@@ -9864,10 +12394,10 @@
         </p:nvGrpSpPr>
         <p:grpSpPr>
           <a:xfrm>
-            <a:off x="2765552" y="1204601"/>
-            <a:ext cx="6254496" cy="2351399"/>
-            <a:chOff x="2911602" y="2068201"/>
-            <a:chExt cx="6254496" cy="2351399"/>
+            <a:off x="2754884" y="1204601"/>
+            <a:ext cx="6265164" cy="2351399"/>
+            <a:chOff x="2900934" y="2068201"/>
+            <a:chExt cx="6265164" cy="2351399"/>
           </a:xfrm>
         </p:grpSpPr>
         <p:grpSp>
@@ -10296,8 +12826,8 @@
           </p:nvSpPr>
           <p:spPr>
             <a:xfrm>
-              <a:off x="2977134" y="2068201"/>
-              <a:ext cx="2244525" cy="461665"/>
+              <a:off x="2900934" y="2068201"/>
+              <a:ext cx="6137514" cy="338554"/>
             </a:xfrm>
             <a:prstGeom prst="rect">
               <a:avLst/>
@@ -10311,12 +12841,12 @@
             <a:lstStyle/>
             <a:p>
               <a:r>
-                <a:rPr lang="de-DE" sz="2400" b="1">
+                <a:rPr lang="de-DE" sz="1600" b="1">
                   <a:solidFill>
                     <a:srgbClr val="002060"/>
                   </a:solidFill>
                 </a:rPr>
-                <a:t>josyn-platform</a:t>
+                <a:t>one logical job-session-process in two separate process-spaces</a:t>
               </a:r>
             </a:p>
           </p:txBody>
@@ -10781,8 +13311,8 @@
         </p:nvSpPr>
         <p:spPr>
           <a:xfrm>
-            <a:off x="2658820" y="3613865"/>
-            <a:ext cx="6675679" cy="707886"/>
+            <a:off x="2658820" y="3671015"/>
+            <a:ext cx="8418755" cy="830997"/>
           </a:xfrm>
           <a:prstGeom prst="rect">
             <a:avLst/>
@@ -10800,7 +13330,7 @@
               <a:buChar char="•"/>
             </a:pPr>
             <a:r>
-              <a:rPr lang="de-DE" sz="1200"/>
+              <a:rPr lang="de-DE" sz="1600"/>
               <a:t>Trennung in zwei Prozessräume</a:t>
             </a:r>
           </a:p>
@@ -10810,7 +13340,7 @@
               <a:buChar char="•"/>
             </a:pPr>
             <a:r>
-              <a:rPr lang="de-DE" sz="1200"/>
+              <a:rPr lang="de-DE" sz="1600"/>
               <a:t>System.IO.Pipes (als Named-Pipes bzw. Unix-Domain-Sockets)</a:t>
             </a:r>
           </a:p>
@@ -10820,20 +13350,16 @@
               <a:buChar char="•"/>
             </a:pPr>
             <a:r>
-              <a:rPr lang="de-DE" sz="1200" b="1"/>
+              <a:rPr lang="de-DE" sz="1600" b="1"/>
               <a:t>Schaffung eines leichtgewichtigen </a:t>
             </a:r>
             <a:r>
-              <a:rPr lang="de-DE" sz="1200" b="1" i="1"/>
+              <a:rPr lang="de-DE" sz="1600" b="1" i="1"/>
               <a:t>one-to-one-IPC-Application-Protocols</a:t>
             </a:r>
             <a:r>
-              <a:rPr lang="de-DE" sz="1200" b="1"/>
-              <a:t>. </a:t>
-            </a:r>
-            <a:r>
               <a:rPr lang="de-DE" sz="1600" b="1"/>
-              <a:t>(JAP)</a:t>
+              <a:t>. (JAP)</a:t>
             </a:r>
           </a:p>
         </p:txBody>
@@ -10988,10 +13514,10 @@
         </p:nvGrpSpPr>
         <p:grpSpPr>
           <a:xfrm>
-            <a:off x="3237857" y="1206558"/>
-            <a:ext cx="1948506" cy="3976566"/>
-            <a:chOff x="2013970" y="586290"/>
-            <a:chExt cx="1652773" cy="3976566"/>
+            <a:off x="2719853" y="1349688"/>
+            <a:ext cx="3321647" cy="3976566"/>
+            <a:chOff x="849237" y="586290"/>
+            <a:chExt cx="2817507" cy="3976566"/>
           </a:xfrm>
         </p:grpSpPr>
         <p:sp>
@@ -11008,8 +13534,8 @@
           </p:nvSpPr>
           <p:spPr>
             <a:xfrm>
-              <a:off x="2031236" y="586290"/>
-              <a:ext cx="1635507" cy="3976566"/>
+              <a:off x="849237" y="586290"/>
+              <a:ext cx="2817507" cy="3976566"/>
             </a:xfrm>
             <a:prstGeom prst="rect">
               <a:avLst/>
@@ -11065,7 +13591,7 @@
           </p:nvSpPr>
           <p:spPr>
             <a:xfrm>
-              <a:off x="2013970" y="594762"/>
+              <a:off x="890940" y="594762"/>
               <a:ext cx="1087029" cy="369332"/>
             </a:xfrm>
             <a:prstGeom prst="rect">
@@ -11105,7 +13631,7 @@
         </p:nvGrpSpPr>
         <p:grpSpPr>
           <a:xfrm>
-            <a:off x="8449212" y="1206556"/>
+            <a:off x="9296937" y="1358956"/>
             <a:ext cx="1609958" cy="3976567"/>
             <a:chOff x="6606124" y="632008"/>
             <a:chExt cx="1609958" cy="3976567"/>
@@ -11228,10 +13754,10 @@
         </p:nvGrpSpPr>
         <p:grpSpPr>
           <a:xfrm>
-            <a:off x="5859156" y="1213434"/>
-            <a:ext cx="2507055" cy="2901871"/>
-            <a:chOff x="4366189" y="2950077"/>
-            <a:chExt cx="2507055" cy="2901871"/>
+            <a:off x="6706881" y="1330649"/>
+            <a:ext cx="2507055" cy="2937056"/>
+            <a:chOff x="4366189" y="2914892"/>
+            <a:chExt cx="2507055" cy="2937056"/>
           </a:xfrm>
         </p:grpSpPr>
         <p:grpSp>
@@ -11367,10 +13893,10 @@
           </p:nvGrpSpPr>
           <p:grpSpPr>
             <a:xfrm>
-              <a:off x="4509873" y="2950077"/>
-              <a:ext cx="2259244" cy="1933271"/>
-              <a:chOff x="4452536" y="3661405"/>
-              <a:chExt cx="2259244" cy="1933271"/>
+              <a:off x="4509873" y="2914892"/>
+              <a:ext cx="2257200" cy="1968456"/>
+              <a:chOff x="4452536" y="3626220"/>
+              <a:chExt cx="2257200" cy="1968456"/>
             </a:xfrm>
           </p:grpSpPr>
           <p:sp>
@@ -11387,112 +13913,8 @@
             </p:nvSpPr>
             <p:spPr>
               <a:xfrm>
-                <a:off x="4452536" y="4950286"/>
-                <a:ext cx="2257200" cy="644390"/>
-              </a:xfrm>
-              <a:prstGeom prst="rect">
-                <a:avLst/>
-              </a:prstGeom>
-              <a:solidFill>
-                <a:schemeClr val="accent2">
-                  <a:lumMod val="20000"/>
-                  <a:lumOff val="80000"/>
-                </a:schemeClr>
-              </a:solidFill>
-            </p:spPr>
-            <p:style>
-              <a:lnRef idx="2">
-                <a:schemeClr val="accent1">
-                  <a:shade val="15000"/>
-                </a:schemeClr>
-              </a:lnRef>
-              <a:fillRef idx="1">
-                <a:schemeClr val="accent1"/>
-              </a:fillRef>
-              <a:effectRef idx="0">
-                <a:schemeClr val="accent1"/>
-              </a:effectRef>
-              <a:fontRef idx="minor">
-                <a:schemeClr val="lt1"/>
-              </a:fontRef>
-            </p:style>
-            <p:txBody>
-              <a:bodyPr rtlCol="0" anchor="ctr"/>
-              <a:lstStyle/>
-              <a:p>
-                <a:pPr algn="ctr"/>
-                <a:endParaRPr lang="de-DE"/>
-              </a:p>
-            </p:txBody>
-          </p:sp>
-          <p:sp>
-            <p:nvSpPr>
-              <p:cNvPr id="36" name="Rechteck 35">
-                <a:extLst>
-                  <a:ext uri="{FF2B5EF4-FFF2-40B4-BE49-F238E27FC236}">
-                    <a16:creationId xmlns:a16="http://schemas.microsoft.com/office/drawing/2014/main" id="{76DEB7D6-CDA6-A1D6-B8D6-C25AB3AB21DA}"/>
-                  </a:ext>
-                </a:extLst>
-              </p:cNvPr>
-              <p:cNvSpPr/>
-              <p:nvPr/>
-            </p:nvSpPr>
-            <p:spPr>
-              <a:xfrm>
-                <a:off x="4454099" y="4306086"/>
-                <a:ext cx="2257200" cy="644390"/>
-              </a:xfrm>
-              <a:prstGeom prst="rect">
-                <a:avLst/>
-              </a:prstGeom>
-              <a:solidFill>
-                <a:schemeClr val="accent2">
-                  <a:lumMod val="20000"/>
-                  <a:lumOff val="80000"/>
-                </a:schemeClr>
-              </a:solidFill>
-            </p:spPr>
-            <p:style>
-              <a:lnRef idx="2">
-                <a:schemeClr val="accent1">
-                  <a:shade val="15000"/>
-                </a:schemeClr>
-              </a:lnRef>
-              <a:fillRef idx="1">
-                <a:schemeClr val="accent1"/>
-              </a:fillRef>
-              <a:effectRef idx="0">
-                <a:schemeClr val="accent1"/>
-              </a:effectRef>
-              <a:fontRef idx="minor">
-                <a:schemeClr val="lt1"/>
-              </a:fontRef>
-            </p:style>
-            <p:txBody>
-              <a:bodyPr rtlCol="0" anchor="ctr"/>
-              <a:lstStyle/>
-              <a:p>
-                <a:pPr algn="ctr"/>
-                <a:endParaRPr lang="de-DE"/>
-              </a:p>
-            </p:txBody>
-          </p:sp>
-          <p:sp>
-            <p:nvSpPr>
-              <p:cNvPr id="37" name="Rechteck 36">
-                <a:extLst>
-                  <a:ext uri="{FF2B5EF4-FFF2-40B4-BE49-F238E27FC236}">
-                    <a16:creationId xmlns:a16="http://schemas.microsoft.com/office/drawing/2014/main" id="{3DC271B0-4C44-9C3F-9A89-1677343AD282}"/>
-                  </a:ext>
-                </a:extLst>
-              </p:cNvPr>
-              <p:cNvSpPr/>
-              <p:nvPr/>
-            </p:nvSpPr>
-            <p:spPr>
-              <a:xfrm>
-                <a:off x="4454098" y="3661405"/>
-                <a:ext cx="2257682" cy="644390"/>
+                <a:off x="4452536" y="3626220"/>
+                <a:ext cx="2257200" cy="1968456"/>
               </a:xfrm>
               <a:prstGeom prst="rect">
                 <a:avLst/>
@@ -11543,8 +13965,8 @@
             </p:nvSpPr>
             <p:spPr>
               <a:xfrm>
-                <a:off x="4602889" y="3716107"/>
-                <a:ext cx="2055050" cy="492443"/>
+                <a:off x="4674644" y="3716107"/>
+                <a:ext cx="1911549" cy="492443"/>
               </a:xfrm>
               <a:prstGeom prst="rect">
                 <a:avLst/>
@@ -11571,7 +13993,7 @@
                 <a:pPr algn="ctr"/>
                 <a:r>
                   <a:rPr lang="de-DE" sz="1200"/>
-                  <a:t>(Serialisierungs-Konvention)</a:t>
+                  <a:t>(Serialization-Convention)</a:t>
                 </a:r>
               </a:p>
             </p:txBody>
@@ -11690,8 +14112,8 @@
         </p:nvSpPr>
         <p:spPr>
           <a:xfrm>
-            <a:off x="1643998" y="684155"/>
-            <a:ext cx="8570213" cy="5175227"/>
+            <a:off x="716936" y="866775"/>
+            <a:ext cx="10672677" cy="5534025"/>
           </a:xfrm>
           <a:prstGeom prst="rect">
             <a:avLst/>
@@ -11743,8 +14165,8 @@
         </p:nvSpPr>
         <p:spPr>
           <a:xfrm>
-            <a:off x="1655382" y="684155"/>
-            <a:ext cx="3056799" cy="461665"/>
+            <a:off x="252326" y="153024"/>
+            <a:ext cx="9923807" cy="461665"/>
           </a:xfrm>
           <a:prstGeom prst="rect">
             <a:avLst/>
@@ -11771,7 +14193,7 @@
                   <a:srgbClr val="002060"/>
                 </a:solidFill>
               </a:rPr>
-              <a:t>(PoC)</a:t>
+              <a:t>(PoC/Proposal) | environment-bound machine perspective</a:t>
             </a:r>
           </a:p>
         </p:txBody>
@@ -11790,8 +14212,8 @@
         </p:nvSpPr>
         <p:spPr>
           <a:xfrm>
-            <a:off x="3633713" y="1480498"/>
-            <a:ext cx="1220719" cy="523220"/>
+            <a:off x="3728070" y="1632898"/>
+            <a:ext cx="1241557" cy="523220"/>
           </a:xfrm>
           <a:prstGeom prst="rect">
             <a:avLst/>
@@ -11811,7 +14233,7 @@
                   <a:srgbClr val="7030A0"/>
                 </a:solidFill>
               </a:rPr>
-              <a:t>Die Backend-</a:t>
+              <a:t>The Backend-</a:t>
             </a:r>
           </a:p>
           <a:p>
@@ -11822,7 +14244,7 @@
                   <a:srgbClr val="7030A0"/>
                 </a:solidFill>
               </a:rPr>
-              <a:t>Domäne</a:t>
+              <a:t>Domain</a:t>
             </a:r>
           </a:p>
         </p:txBody>
@@ -11841,8 +14263,8 @@
         </p:nvSpPr>
         <p:spPr>
           <a:xfrm>
-            <a:off x="8670093" y="1455665"/>
-            <a:ext cx="1162305" cy="523220"/>
+            <a:off x="9470530" y="1608065"/>
+            <a:ext cx="1256883" cy="523220"/>
           </a:xfrm>
           <a:prstGeom prst="rect">
             <a:avLst/>
@@ -11865,7 +14287,7 @@
                   </a:schemeClr>
                 </a:solidFill>
               </a:rPr>
-              <a:t>Die Job-Dev-</a:t>
+              <a:t>The Job-Dev‘s</a:t>
             </a:r>
           </a:p>
           <a:p>
@@ -11879,7 +14301,7 @@
                   </a:schemeClr>
                 </a:solidFill>
               </a:rPr>
-              <a:t>Domäne</a:t>
+              <a:t>World</a:t>
             </a:r>
           </a:p>
         </p:txBody>
@@ -11898,7 +14320,7 @@
         </p:nvGrpSpPr>
         <p:grpSpPr>
           <a:xfrm>
-            <a:off x="6313665" y="4374667"/>
+            <a:off x="7161390" y="4527067"/>
             <a:ext cx="1615269" cy="495116"/>
             <a:chOff x="5359908" y="5411908"/>
             <a:chExt cx="1615269" cy="495116"/>
@@ -11997,48 +14419,6 @@
       </p:grpSp>
       <p:sp>
         <p:nvSpPr>
-          <p:cNvPr id="54" name="Textfeld 53">
-            <a:extLst>
-              <a:ext uri="{FF2B5EF4-FFF2-40B4-BE49-F238E27FC236}">
-                <a16:creationId xmlns:a16="http://schemas.microsoft.com/office/drawing/2014/main" id="{A90046F5-B61F-B94B-4732-BD4F05F4B529}"/>
-              </a:ext>
-            </a:extLst>
-          </p:cNvPr>
-          <p:cNvSpPr txBox="1"/>
-          <p:nvPr/>
-        </p:nvSpPr>
-        <p:spPr>
-          <a:xfrm>
-            <a:off x="9578582" y="4875422"/>
-            <a:ext cx="409133" cy="215444"/>
-          </a:xfrm>
-          <a:prstGeom prst="rect">
-            <a:avLst/>
-          </a:prstGeom>
-          <a:solidFill>
-            <a:srgbClr val="FFFF99"/>
-          </a:solidFill>
-          <a:ln>
-            <a:solidFill>
-              <a:schemeClr val="tx1"/>
-            </a:solidFill>
-          </a:ln>
-        </p:spPr>
-        <p:txBody>
-          <a:bodyPr wrap="none" lIns="72000" tIns="0" rIns="72000" bIns="0" rtlCol="0">
-            <a:spAutoFit/>
-          </a:bodyPr>
-          <a:lstStyle/>
-          <a:p>
-            <a:r>
-              <a:rPr lang="de-DE" sz="1400" i="1"/>
-              <a:t>exe</a:t>
-            </a:r>
-          </a:p>
-        </p:txBody>
-      </p:sp>
-      <p:sp>
-        <p:nvSpPr>
           <p:cNvPr id="3" name="Rechteck: abgerundete Ecken 2">
             <a:extLst>
               <a:ext uri="{FF2B5EF4-FFF2-40B4-BE49-F238E27FC236}">
@@ -12051,7 +14431,7 @@
         </p:nvSpPr>
         <p:spPr>
           <a:xfrm>
-            <a:off x="6217885" y="5315687"/>
+            <a:off x="7065610" y="5468087"/>
             <a:ext cx="1810819" cy="362640"/>
           </a:xfrm>
           <a:prstGeom prst="roundRect">
@@ -12103,7 +14483,7 @@
         </p:nvSpPr>
         <p:spPr>
           <a:xfrm>
-            <a:off x="6644233" y="5345120"/>
+            <a:off x="7491958" y="5497520"/>
             <a:ext cx="971741" cy="307777"/>
           </a:xfrm>
           <a:prstGeom prst="rect">
@@ -12142,8 +14522,8 @@
         </p:nvCxnSpPr>
         <p:spPr>
           <a:xfrm rot="16200000" flipH="1">
-            <a:off x="5063145" y="4342266"/>
-            <a:ext cx="313883" cy="1995597"/>
+            <a:off x="5561567" y="4145363"/>
+            <a:ext cx="323153" cy="2684933"/>
           </a:xfrm>
           <a:prstGeom prst="bentConnector2">
             <a:avLst/>
@@ -12185,7 +14565,7 @@
         </p:nvCxnSpPr>
         <p:spPr>
           <a:xfrm rot="5400000">
-            <a:off x="8484506" y="4727322"/>
+            <a:off x="9332231" y="4879722"/>
             <a:ext cx="313884" cy="1225487"/>
           </a:xfrm>
           <a:prstGeom prst="bentConnector2">
@@ -12224,10 +14604,10 @@
         </p:nvGrpSpPr>
         <p:grpSpPr>
           <a:xfrm>
-            <a:off x="8436203" y="3367630"/>
-            <a:ext cx="1485126" cy="832330"/>
+            <a:off x="9283928" y="3456530"/>
+            <a:ext cx="1494650" cy="832330"/>
             <a:chOff x="482782" y="1498463"/>
-            <a:chExt cx="1485126" cy="832330"/>
+            <a:chExt cx="1494650" cy="832330"/>
           </a:xfrm>
         </p:grpSpPr>
         <p:sp>
@@ -12244,7 +14624,7 @@
           </p:nvSpPr>
           <p:spPr>
             <a:xfrm>
-              <a:off x="495724" y="1524952"/>
+              <a:off x="505248" y="1524952"/>
               <a:ext cx="1472184" cy="805841"/>
             </a:xfrm>
             <a:prstGeom prst="rect">
@@ -12256,7 +14636,7 @@
                 <a:lumOff val="90000"/>
               </a:schemeClr>
             </a:solidFill>
-            <a:ln>
+            <a:ln w="38100">
               <a:solidFill>
                 <a:schemeClr val="tx2">
                   <a:lumMod val="75000"/>
@@ -12406,7 +14786,7 @@
         </p:nvCxnSpPr>
         <p:spPr>
           <a:xfrm flipH="1" flipV="1">
-            <a:off x="7118644" y="4869783"/>
+            <a:off x="7966369" y="5022183"/>
             <a:ext cx="4651" cy="445904"/>
           </a:xfrm>
           <a:prstGeom prst="straightConnector1">
@@ -12454,7 +14834,7 @@
         </p:nvCxnSpPr>
         <p:spPr>
           <a:xfrm>
-            <a:off x="7112684" y="3961481"/>
+            <a:off x="7960409" y="4113881"/>
             <a:ext cx="5960" cy="413186"/>
           </a:xfrm>
           <a:prstGeom prst="straightConnector1">
@@ -12501,7 +14881,7 @@
         </p:nvCxnSpPr>
         <p:spPr>
           <a:xfrm>
-            <a:off x="5186363" y="4622225"/>
+            <a:off x="6034088" y="4774625"/>
             <a:ext cx="1127302" cy="0"/>
           </a:xfrm>
           <a:prstGeom prst="straightConnector1">
@@ -12548,7 +14928,7 @@
         </p:nvCxnSpPr>
         <p:spPr>
           <a:xfrm flipH="1">
-            <a:off x="7923623" y="4622225"/>
+            <a:off x="8771348" y="4774625"/>
             <a:ext cx="525522" cy="0"/>
           </a:xfrm>
           <a:prstGeom prst="straightConnector1">
@@ -12592,7 +14972,7 @@
         </p:nvSpPr>
         <p:spPr>
           <a:xfrm>
-            <a:off x="7002218" y="3217407"/>
+            <a:off x="7849943" y="3369807"/>
             <a:ext cx="203200" cy="350142"/>
           </a:xfrm>
           <a:prstGeom prst="upArrow">
@@ -12649,7 +15029,7 @@
         </p:nvSpPr>
         <p:spPr>
           <a:xfrm>
-            <a:off x="6058028" y="1258609"/>
+            <a:off x="6905753" y="1411009"/>
             <a:ext cx="103159" cy="1821394"/>
           </a:xfrm>
           <a:prstGeom prst="upArrow">
@@ -12706,7 +15086,7 @@
         </p:nvSpPr>
         <p:spPr>
           <a:xfrm rot="16200000">
-            <a:off x="5453071" y="2079798"/>
+            <a:off x="6303761" y="2232505"/>
             <a:ext cx="1320610" cy="194284"/>
           </a:xfrm>
           <a:prstGeom prst="rect">
@@ -12761,7 +15141,7 @@
         </p:nvSpPr>
         <p:spPr>
           <a:xfrm rot="16200000">
-            <a:off x="5443871" y="2082953"/>
+            <a:off x="6294765" y="2229003"/>
             <a:ext cx="1320609" cy="184666"/>
           </a:xfrm>
           <a:prstGeom prst="rect">
@@ -12808,10 +15188,10 @@
         </p:nvGrpSpPr>
         <p:grpSpPr>
           <a:xfrm>
-            <a:off x="3373300" y="2008590"/>
-            <a:ext cx="1652773" cy="1476633"/>
-            <a:chOff x="2013970" y="586290"/>
-            <a:chExt cx="1652773" cy="3976566"/>
+            <a:off x="3542966" y="2160990"/>
+            <a:ext cx="2263355" cy="1476633"/>
+            <a:chOff x="1335911" y="586290"/>
+            <a:chExt cx="2263355" cy="3976566"/>
           </a:xfrm>
         </p:grpSpPr>
         <p:sp>
@@ -12828,7 +15208,7 @@
           </p:nvSpPr>
           <p:spPr>
             <a:xfrm>
-              <a:off x="2031236" y="586290"/>
+              <a:off x="1335911" y="586290"/>
               <a:ext cx="1635507" cy="3976566"/>
             </a:xfrm>
             <a:prstGeom prst="rect">
@@ -12885,8 +15265,8 @@
           </p:nvSpPr>
           <p:spPr>
             <a:xfrm>
-              <a:off x="2013970" y="594762"/>
-              <a:ext cx="1518621" cy="3895553"/>
+              <a:off x="1457219" y="594762"/>
+              <a:ext cx="2142047" cy="3895553"/>
             </a:xfrm>
             <a:prstGeom prst="rect">
               <a:avLst/>
@@ -12898,7 +15278,7 @@
             </a:ln>
           </p:spPr>
           <p:txBody>
-            <a:bodyPr wrap="none" rtlCol="0">
+            <a:bodyPr wrap="square" rtlCol="0">
               <a:spAutoFit/>
             </a:bodyPr>
             <a:lstStyle/>
@@ -13013,7 +15393,7 @@
         </p:nvGrpSpPr>
         <p:grpSpPr>
           <a:xfrm>
-            <a:off x="4033140" y="3367629"/>
+            <a:off x="4880865" y="3456529"/>
             <a:ext cx="1770877" cy="873927"/>
             <a:chOff x="249329" y="351742"/>
             <a:chExt cx="1770877" cy="791538"/>
@@ -13174,7 +15554,7 @@
         </p:nvSpPr>
         <p:spPr>
           <a:xfrm>
-            <a:off x="8524131" y="2091140"/>
+            <a:off x="9371856" y="2084790"/>
             <a:ext cx="1512658" cy="1200329"/>
           </a:xfrm>
           <a:prstGeom prst="rect">
@@ -13313,10 +15693,10 @@
         </p:nvGrpSpPr>
         <p:grpSpPr>
           <a:xfrm>
-            <a:off x="1776650" y="3936264"/>
-            <a:ext cx="1950038" cy="1147585"/>
-            <a:chOff x="-151820" y="5031901"/>
-            <a:chExt cx="1950038" cy="3090441"/>
+            <a:off x="2816688" y="4031514"/>
+            <a:ext cx="1886832" cy="1147585"/>
+            <a:chOff x="40493" y="5031901"/>
+            <a:chExt cx="1886832" cy="3090441"/>
           </a:xfrm>
         </p:grpSpPr>
         <p:sp>
@@ -13333,16 +15713,14 @@
           </p:nvSpPr>
           <p:spPr>
             <a:xfrm>
-              <a:off x="-151820" y="5146372"/>
-              <a:ext cx="1923190" cy="2975970"/>
+              <a:off x="57730" y="5146372"/>
+              <a:ext cx="1782923" cy="2975970"/>
             </a:xfrm>
             <a:prstGeom prst="rect">
               <a:avLst/>
             </a:prstGeom>
             <a:solidFill>
-              <a:schemeClr val="bg1">
-                <a:lumMod val="95000"/>
-              </a:schemeClr>
+              <a:schemeClr val="bg2"/>
             </a:solidFill>
             <a:ln w="3175">
               <a:solidFill>
@@ -13390,8 +15768,8 @@
           </p:nvSpPr>
           <p:spPr>
             <a:xfrm>
-              <a:off x="-129933" y="5031901"/>
-              <a:ext cx="1928151" cy="2900943"/>
+              <a:off x="40493" y="5031901"/>
+              <a:ext cx="1886832" cy="2900943"/>
             </a:xfrm>
             <a:prstGeom prst="rect">
               <a:avLst/>
@@ -13409,12 +15787,20 @@
             <a:lstStyle/>
             <a:p>
               <a:r>
+                <a:rPr lang="de-DE" sz="1600" b="1" i="1">
+                  <a:solidFill>
+                    <a:srgbClr val="7030A0"/>
+                  </a:solidFill>
+                </a:rPr>
+                <a:t>contoso</a:t>
+              </a:r>
+              <a:r>
                 <a:rPr lang="de-DE" sz="1600" b="1">
                   <a:solidFill>
                     <a:srgbClr val="7030A0"/>
                   </a:solidFill>
                 </a:rPr>
-                <a:t>contoso-adapters</a:t>
+                <a:t>-adapters</a:t>
               </a:r>
             </a:p>
             <a:p>
@@ -13490,7 +15876,7 @@
         </p:nvSpPr>
         <p:spPr>
           <a:xfrm>
-            <a:off x="3736281" y="4290884"/>
+            <a:off x="4650681" y="4443284"/>
             <a:ext cx="1127098" cy="604667"/>
           </a:xfrm>
           <a:prstGeom prst="leftUpArrow">
@@ -13549,7 +15935,7 @@
         </p:nvSpPr>
         <p:spPr>
           <a:xfrm>
-            <a:off x="3725516" y="4604378"/>
+            <a:off x="4639916" y="4756778"/>
             <a:ext cx="1122849" cy="261610"/>
           </a:xfrm>
           <a:prstGeom prst="rect">
@@ -13588,10 +15974,10 @@
         </p:nvGrpSpPr>
         <p:grpSpPr>
           <a:xfrm>
-            <a:off x="1785222" y="1219767"/>
-            <a:ext cx="1361481" cy="2643905"/>
+            <a:off x="954291" y="1145982"/>
+            <a:ext cx="1361481" cy="5026217"/>
             <a:chOff x="1813797" y="924492"/>
-            <a:chExt cx="1361481" cy="2643905"/>
+            <a:chExt cx="1361481" cy="4965164"/>
           </a:xfrm>
         </p:grpSpPr>
         <p:sp>
@@ -13609,7 +15995,7 @@
           <p:spPr>
             <a:xfrm>
               <a:off x="1813797" y="924492"/>
-              <a:ext cx="1361481" cy="2643057"/>
+              <a:ext cx="1361481" cy="4965164"/>
             </a:xfrm>
             <a:prstGeom prst="rect">
               <a:avLst/>
@@ -13668,7 +16054,7 @@
             <p:nvPr/>
           </p:nvPicPr>
           <p:blipFill>
-            <a:blip r:embed="rId2">
+            <a:blip r:embed="rId3">
               <a:extLst>
                 <a:ext uri="{28A0092B-C50C-407E-A947-70E740481C1C}">
                   <a14:useLocalDpi xmlns:a14="http://schemas.microsoft.com/office/drawing/2010/main" val="0"/>
@@ -13681,7 +16067,7 @@
           </p:blipFill>
           <p:spPr>
             <a:xfrm>
-              <a:off x="2046947" y="1514357"/>
+              <a:off x="2003448" y="1601482"/>
               <a:ext cx="1056380" cy="1056380"/>
             </a:xfrm>
             <a:prstGeom prst="rect">
@@ -13752,7 +16138,7 @@
           </p:nvSpPr>
           <p:spPr>
             <a:xfrm>
-              <a:off x="1813797" y="2552734"/>
+              <a:off x="1823626" y="2790706"/>
               <a:ext cx="1351652" cy="1015663"/>
             </a:xfrm>
             <a:prstGeom prst="rect">
@@ -13852,8 +16238,8 @@
         </p:nvSpPr>
         <p:spPr>
           <a:xfrm rot="5400000">
-            <a:off x="3611221" y="3404401"/>
-            <a:ext cx="350107" cy="524050"/>
+            <a:off x="4440128" y="3575620"/>
+            <a:ext cx="387743" cy="524050"/>
           </a:xfrm>
           <a:prstGeom prst="bentUpArrow">
             <a:avLst>
@@ -13913,8 +16299,8 @@
         </p:nvSpPr>
         <p:spPr>
           <a:xfrm>
-            <a:off x="3465021" y="3631064"/>
-            <a:ext cx="579005" cy="215444"/>
+            <a:off x="4310365" y="3804893"/>
+            <a:ext cx="601447" cy="215444"/>
           </a:xfrm>
           <a:prstGeom prst="rect">
             <a:avLst/>
@@ -13928,12 +16314,594 @@
           <a:lstStyle/>
           <a:p>
             <a:r>
-              <a:rPr lang="de-DE" sz="800"/>
+              <a:rPr lang="de-DE" sz="800" b="1"/>
               <a:t>launcher</a:t>
             </a:r>
           </a:p>
         </p:txBody>
       </p:sp>
+      <p:sp>
+        <p:nvSpPr>
+          <p:cNvPr id="9" name="Rechteck 8">
+            <a:extLst>
+              <a:ext uri="{FF2B5EF4-FFF2-40B4-BE49-F238E27FC236}">
+                <a16:creationId xmlns:a16="http://schemas.microsoft.com/office/drawing/2014/main" id="{CC17422F-E89D-D549-F4A0-F4E416CC6D74}"/>
+              </a:ext>
+            </a:extLst>
+          </p:cNvPr>
+          <p:cNvSpPr/>
+          <p:nvPr/>
+        </p:nvSpPr>
+        <p:spPr>
+          <a:xfrm>
+            <a:off x="2511951" y="1128292"/>
+            <a:ext cx="8677227" cy="5018662"/>
+          </a:xfrm>
+          <a:prstGeom prst="rect">
+            <a:avLst/>
+          </a:prstGeom>
+          <a:noFill/>
+          <a:ln>
+            <a:solidFill>
+              <a:srgbClr val="002060"/>
+            </a:solidFill>
+            <a:prstDash val="dash"/>
+          </a:ln>
+        </p:spPr>
+        <p:style>
+          <a:lnRef idx="2">
+            <a:schemeClr val="accent1">
+              <a:shade val="15000"/>
+            </a:schemeClr>
+          </a:lnRef>
+          <a:fillRef idx="1">
+            <a:schemeClr val="accent1"/>
+          </a:fillRef>
+          <a:effectRef idx="0">
+            <a:schemeClr val="accent1"/>
+          </a:effectRef>
+          <a:fontRef idx="minor">
+            <a:schemeClr val="lt1"/>
+          </a:fontRef>
+        </p:style>
+        <p:txBody>
+          <a:bodyPr rtlCol="0" anchor="ctr"/>
+          <a:lstStyle/>
+          <a:p>
+            <a:pPr algn="ctr"/>
+            <a:endParaRPr lang="de-DE"/>
+          </a:p>
+        </p:txBody>
+      </p:sp>
+      <p:sp>
+        <p:nvSpPr>
+          <p:cNvPr id="21" name="Textfeld 20">
+            <a:extLst>
+              <a:ext uri="{FF2B5EF4-FFF2-40B4-BE49-F238E27FC236}">
+                <a16:creationId xmlns:a16="http://schemas.microsoft.com/office/drawing/2014/main" id="{E47F840B-F118-2E9E-85D6-4D4400DA71D1}"/>
+              </a:ext>
+            </a:extLst>
+          </p:cNvPr>
+          <p:cNvSpPr txBox="1"/>
+          <p:nvPr/>
+        </p:nvSpPr>
+        <p:spPr>
+          <a:xfrm>
+            <a:off x="2624375" y="961317"/>
+            <a:ext cx="2834430" cy="369332"/>
+          </a:xfrm>
+          <a:prstGeom prst="rect">
+            <a:avLst/>
+          </a:prstGeom>
+          <a:solidFill>
+            <a:schemeClr val="bg1"/>
+          </a:solidFill>
+        </p:spPr>
+        <p:txBody>
+          <a:bodyPr wrap="none" rtlCol="0">
+            <a:spAutoFit/>
+          </a:bodyPr>
+          <a:lstStyle/>
+          <a:p>
+            <a:r>
+              <a:rPr lang="de-DE" b="1">
+                <a:solidFill>
+                  <a:srgbClr val="002060"/>
+                </a:solidFill>
+              </a:rPr>
+              <a:t>headless machine </a:t>
+            </a:r>
+            <a:r>
+              <a:rPr lang="de-DE">
+                <a:solidFill>
+                  <a:srgbClr val="002060"/>
+                </a:solidFill>
+              </a:rPr>
+              <a:t>- 1 of n</a:t>
+            </a:r>
+          </a:p>
+        </p:txBody>
+      </p:sp>
+      <p:sp>
+        <p:nvSpPr>
+          <p:cNvPr id="50" name="Textfeld 49">
+            <a:extLst>
+              <a:ext uri="{FF2B5EF4-FFF2-40B4-BE49-F238E27FC236}">
+                <a16:creationId xmlns:a16="http://schemas.microsoft.com/office/drawing/2014/main" id="{5F8CB247-06B3-C14B-5535-7AEDC74D4CC1}"/>
+              </a:ext>
+            </a:extLst>
+          </p:cNvPr>
+          <p:cNvSpPr txBox="1"/>
+          <p:nvPr/>
+        </p:nvSpPr>
+        <p:spPr>
+          <a:xfrm>
+            <a:off x="903613" y="666962"/>
+            <a:ext cx="1930312" cy="369332"/>
+          </a:xfrm>
+          <a:prstGeom prst="rect">
+            <a:avLst/>
+          </a:prstGeom>
+          <a:solidFill>
+            <a:schemeClr val="bg1"/>
+          </a:solidFill>
+        </p:spPr>
+        <p:txBody>
+          <a:bodyPr wrap="square" rtlCol="0">
+            <a:spAutoFit/>
+          </a:bodyPr>
+          <a:lstStyle/>
+          <a:p>
+            <a:r>
+              <a:rPr lang="de-DE" b="1">
+                <a:solidFill>
+                  <a:srgbClr val="002060"/>
+                </a:solidFill>
+              </a:rPr>
+              <a:t>env </a:t>
+            </a:r>
+            <a:r>
+              <a:rPr lang="de-DE">
+                <a:solidFill>
+                  <a:srgbClr val="002060"/>
+                </a:solidFill>
+              </a:rPr>
+              <a:t>(prod|int|dev)</a:t>
+            </a:r>
+          </a:p>
+        </p:txBody>
+      </p:sp>
+      <p:cxnSp>
+        <p:nvCxnSpPr>
+          <p:cNvPr id="62" name="Gerader Verbinder 61">
+            <a:extLst>
+              <a:ext uri="{FF2B5EF4-FFF2-40B4-BE49-F238E27FC236}">
+                <a16:creationId xmlns:a16="http://schemas.microsoft.com/office/drawing/2014/main" id="{F3E8D9B7-B951-5849-DABA-58CA6079B6F6}"/>
+              </a:ext>
+            </a:extLst>
+          </p:cNvPr>
+          <p:cNvCxnSpPr/>
+          <p:nvPr/>
+        </p:nvCxnSpPr>
+        <p:spPr>
+          <a:xfrm>
+            <a:off x="7099300" y="1990725"/>
+            <a:ext cx="1884922" cy="0"/>
+          </a:xfrm>
+          <a:prstGeom prst="line">
+            <a:avLst/>
+          </a:prstGeom>
+        </p:spPr>
+        <p:style>
+          <a:lnRef idx="2">
+            <a:schemeClr val="accent1"/>
+          </a:lnRef>
+          <a:fillRef idx="0">
+            <a:schemeClr val="accent1"/>
+          </a:fillRef>
+          <a:effectRef idx="1">
+            <a:schemeClr val="accent1"/>
+          </a:effectRef>
+          <a:fontRef idx="minor">
+            <a:schemeClr val="tx1"/>
+          </a:fontRef>
+        </p:style>
+      </p:cxnSp>
+      <p:cxnSp>
+        <p:nvCxnSpPr>
+          <p:cNvPr id="63" name="Gerader Verbinder 62">
+            <a:extLst>
+              <a:ext uri="{FF2B5EF4-FFF2-40B4-BE49-F238E27FC236}">
+                <a16:creationId xmlns:a16="http://schemas.microsoft.com/office/drawing/2014/main" id="{16D4DDBC-FB00-FE45-D54F-D986C5ED361B}"/>
+              </a:ext>
+            </a:extLst>
+          </p:cNvPr>
+          <p:cNvCxnSpPr/>
+          <p:nvPr/>
+        </p:nvCxnSpPr>
+        <p:spPr>
+          <a:xfrm>
+            <a:off x="7099300" y="2697196"/>
+            <a:ext cx="1884922" cy="0"/>
+          </a:xfrm>
+          <a:prstGeom prst="line">
+            <a:avLst/>
+          </a:prstGeom>
+        </p:spPr>
+        <p:style>
+          <a:lnRef idx="2">
+            <a:schemeClr val="accent1"/>
+          </a:lnRef>
+          <a:fillRef idx="0">
+            <a:schemeClr val="accent1"/>
+          </a:fillRef>
+          <a:effectRef idx="1">
+            <a:schemeClr val="accent1"/>
+          </a:effectRef>
+          <a:fontRef idx="minor">
+            <a:schemeClr val="tx1"/>
+          </a:fontRef>
+        </p:style>
+      </p:cxnSp>
+      <p:pic>
+        <p:nvPicPr>
+          <p:cNvPr id="71" name="Grafik 70">
+            <a:extLst>
+              <a:ext uri="{FF2B5EF4-FFF2-40B4-BE49-F238E27FC236}">
+                <a16:creationId xmlns:a16="http://schemas.microsoft.com/office/drawing/2014/main" id="{2153665A-8E4E-D8DA-B6EB-46A77D170425}"/>
+              </a:ext>
+            </a:extLst>
+          </p:cNvPr>
+          <p:cNvPicPr>
+            <a:picLocks noChangeAspect="1"/>
+          </p:cNvPicPr>
+          <p:nvPr/>
+        </p:nvPicPr>
+        <p:blipFill>
+          <a:blip r:embed="rId4"/>
+          <a:stretch>
+            <a:fillRect/>
+          </a:stretch>
+        </p:blipFill>
+        <p:spPr>
+          <a:xfrm>
+            <a:off x="4081702" y="4365389"/>
+            <a:ext cx="366234" cy="357021"/>
+          </a:xfrm>
+          <a:prstGeom prst="rect">
+            <a:avLst/>
+          </a:prstGeom>
+        </p:spPr>
+      </p:pic>
+      <p:grpSp>
+        <p:nvGrpSpPr>
+          <p:cNvPr id="81" name="Gruppieren 80">
+            <a:extLst>
+              <a:ext uri="{FF2B5EF4-FFF2-40B4-BE49-F238E27FC236}">
+                <a16:creationId xmlns:a16="http://schemas.microsoft.com/office/drawing/2014/main" id="{D34BB2CC-52FF-2FC4-2833-09C955FCDA30}"/>
+              </a:ext>
+            </a:extLst>
+          </p:cNvPr>
+          <p:cNvGrpSpPr/>
+          <p:nvPr/>
+        </p:nvGrpSpPr>
+        <p:grpSpPr>
+          <a:xfrm>
+            <a:off x="2806073" y="3816509"/>
+            <a:ext cx="1487539" cy="276999"/>
+            <a:chOff x="3181943" y="5397086"/>
+            <a:chExt cx="1203134" cy="276999"/>
+          </a:xfrm>
+        </p:grpSpPr>
+        <p:sp>
+          <p:nvSpPr>
+            <p:cNvPr id="76" name="Rechteck 75">
+              <a:extLst>
+                <a:ext uri="{FF2B5EF4-FFF2-40B4-BE49-F238E27FC236}">
+                  <a16:creationId xmlns:a16="http://schemas.microsoft.com/office/drawing/2014/main" id="{3B70D8F2-CDC7-7055-B487-470EA1D42C29}"/>
+                </a:ext>
+              </a:extLst>
+            </p:cNvPr>
+            <p:cNvSpPr/>
+            <p:nvPr/>
+          </p:nvSpPr>
+          <p:spPr>
+            <a:xfrm>
+              <a:off x="3204380" y="5398271"/>
+              <a:ext cx="1141782" cy="258866"/>
+            </a:xfrm>
+            <a:prstGeom prst="rect">
+              <a:avLst/>
+            </a:prstGeom>
+            <a:solidFill>
+              <a:schemeClr val="bg2"/>
+            </a:solidFill>
+            <a:ln w="3175">
+              <a:solidFill>
+                <a:srgbClr val="7030A0"/>
+              </a:solidFill>
+              <a:prstDash val="solid"/>
+            </a:ln>
+          </p:spPr>
+          <p:style>
+            <a:lnRef idx="2">
+              <a:schemeClr val="accent1">
+                <a:shade val="15000"/>
+              </a:schemeClr>
+            </a:lnRef>
+            <a:fillRef idx="1">
+              <a:schemeClr val="accent1"/>
+            </a:fillRef>
+            <a:effectRef idx="0">
+              <a:schemeClr val="accent1"/>
+            </a:effectRef>
+            <a:fontRef idx="minor">
+              <a:schemeClr val="lt1"/>
+            </a:fontRef>
+          </p:style>
+          <p:txBody>
+            <a:bodyPr rtlCol="0" anchor="ctr"/>
+            <a:lstStyle/>
+            <a:p>
+              <a:pPr algn="ctr"/>
+              <a:endParaRPr lang="de-DE"/>
+            </a:p>
+          </p:txBody>
+        </p:sp>
+        <p:sp>
+          <p:nvSpPr>
+            <p:cNvPr id="80" name="Textfeld 79">
+              <a:extLst>
+                <a:ext uri="{FF2B5EF4-FFF2-40B4-BE49-F238E27FC236}">
+                  <a16:creationId xmlns:a16="http://schemas.microsoft.com/office/drawing/2014/main" id="{61F57061-C48D-2C51-506A-F3D57C41CB51}"/>
+                </a:ext>
+              </a:extLst>
+            </p:cNvPr>
+            <p:cNvSpPr txBox="1"/>
+            <p:nvPr/>
+          </p:nvSpPr>
+          <p:spPr>
+            <a:xfrm>
+              <a:off x="3181943" y="5397086"/>
+              <a:ext cx="1203134" cy="276999"/>
+            </a:xfrm>
+            <a:prstGeom prst="rect">
+              <a:avLst/>
+            </a:prstGeom>
+            <a:noFill/>
+            <a:ln w="3175">
+              <a:noFill/>
+              <a:prstDash val="solid"/>
+            </a:ln>
+          </p:spPr>
+          <p:txBody>
+            <a:bodyPr wrap="square" rtlCol="0">
+              <a:spAutoFit/>
+            </a:bodyPr>
+            <a:lstStyle/>
+            <a:p>
+              <a:r>
+                <a:rPr lang="de-DE" sz="1200" b="1" i="1">
+                  <a:solidFill>
+                    <a:srgbClr val="7030A0"/>
+                  </a:solidFill>
+                </a:rPr>
+                <a:t>contoso</a:t>
+              </a:r>
+              <a:r>
+                <a:rPr lang="de-DE" sz="1200" b="1">
+                  <a:solidFill>
+                    <a:srgbClr val="7030A0"/>
+                  </a:solidFill>
+                </a:rPr>
+                <a:t>-contracts</a:t>
+              </a:r>
+            </a:p>
+          </p:txBody>
+        </p:sp>
+      </p:grpSp>
+      <p:sp>
+        <p:nvSpPr>
+          <p:cNvPr id="54" name="Textfeld 53">
+            <a:extLst>
+              <a:ext uri="{FF2B5EF4-FFF2-40B4-BE49-F238E27FC236}">
+                <a16:creationId xmlns:a16="http://schemas.microsoft.com/office/drawing/2014/main" id="{A90046F5-B61F-B94B-4732-BD4F05F4B529}"/>
+              </a:ext>
+            </a:extLst>
+          </p:cNvPr>
+          <p:cNvSpPr txBox="1"/>
+          <p:nvPr/>
+        </p:nvSpPr>
+        <p:spPr>
+          <a:xfrm>
+            <a:off x="10426307" y="5027822"/>
+            <a:ext cx="409133" cy="215444"/>
+          </a:xfrm>
+          <a:prstGeom prst="rect">
+            <a:avLst/>
+          </a:prstGeom>
+          <a:solidFill>
+            <a:srgbClr val="FFFF99"/>
+          </a:solidFill>
+          <a:ln>
+            <a:solidFill>
+              <a:schemeClr val="tx1"/>
+            </a:solidFill>
+          </a:ln>
+        </p:spPr>
+        <p:txBody>
+          <a:bodyPr wrap="none" lIns="72000" tIns="0" rIns="72000" bIns="0" rtlCol="0">
+            <a:spAutoFit/>
+          </a:bodyPr>
+          <a:lstStyle/>
+          <a:p>
+            <a:r>
+              <a:rPr lang="de-DE" sz="1400" i="1"/>
+              <a:t>exe</a:t>
+            </a:r>
+          </a:p>
+        </p:txBody>
+      </p:sp>
+      <p:grpSp>
+        <p:nvGrpSpPr>
+          <p:cNvPr id="75" name="Gruppieren 74">
+            <a:extLst>
+              <a:ext uri="{FF2B5EF4-FFF2-40B4-BE49-F238E27FC236}">
+                <a16:creationId xmlns:a16="http://schemas.microsoft.com/office/drawing/2014/main" id="{74F62C5C-0D4A-4406-2FD1-660DB0F20D83}"/>
+              </a:ext>
+            </a:extLst>
+          </p:cNvPr>
+          <p:cNvGrpSpPr/>
+          <p:nvPr/>
+        </p:nvGrpSpPr>
+        <p:grpSpPr>
+          <a:xfrm>
+            <a:off x="9425094" y="4369662"/>
+            <a:ext cx="1364910" cy="584775"/>
+            <a:chOff x="9425094" y="4382362"/>
+            <a:chExt cx="1364910" cy="584775"/>
+          </a:xfrm>
+        </p:grpSpPr>
+        <p:sp>
+          <p:nvSpPr>
+            <p:cNvPr id="69" name="Rechteck 68">
+              <a:extLst>
+                <a:ext uri="{FF2B5EF4-FFF2-40B4-BE49-F238E27FC236}">
+                  <a16:creationId xmlns:a16="http://schemas.microsoft.com/office/drawing/2014/main" id="{BF9D75D2-70BD-FE79-8A4B-45C5AB2987E1}"/>
+                </a:ext>
+              </a:extLst>
+            </p:cNvPr>
+            <p:cNvSpPr/>
+            <p:nvPr/>
+          </p:nvSpPr>
+          <p:spPr>
+            <a:xfrm>
+              <a:off x="9425094" y="4404515"/>
+              <a:ext cx="1364910" cy="546290"/>
+            </a:xfrm>
+            <a:prstGeom prst="rect">
+              <a:avLst/>
+            </a:prstGeom>
+            <a:solidFill>
+              <a:schemeClr val="accent3">
+                <a:lumMod val="40000"/>
+                <a:lumOff val="60000"/>
+              </a:schemeClr>
+            </a:solidFill>
+            <a:ln>
+              <a:solidFill>
+                <a:schemeClr val="accent6"/>
+              </a:solidFill>
+              <a:prstDash val="sysDash"/>
+            </a:ln>
+          </p:spPr>
+          <p:style>
+            <a:lnRef idx="2">
+              <a:schemeClr val="accent1">
+                <a:shade val="15000"/>
+              </a:schemeClr>
+            </a:lnRef>
+            <a:fillRef idx="1">
+              <a:schemeClr val="accent1"/>
+            </a:fillRef>
+            <a:effectRef idx="0">
+              <a:schemeClr val="accent1"/>
+            </a:effectRef>
+            <a:fontRef idx="minor">
+              <a:schemeClr val="lt1"/>
+            </a:fontRef>
+          </p:style>
+          <p:txBody>
+            <a:bodyPr rtlCol="0" anchor="ctr"/>
+            <a:lstStyle/>
+            <a:p>
+              <a:pPr algn="ctr"/>
+              <a:endParaRPr lang="de-DE"/>
+            </a:p>
+          </p:txBody>
+        </p:sp>
+        <p:pic>
+          <p:nvPicPr>
+            <p:cNvPr id="73" name="Grafik 72">
+              <a:extLst>
+                <a:ext uri="{FF2B5EF4-FFF2-40B4-BE49-F238E27FC236}">
+                  <a16:creationId xmlns:a16="http://schemas.microsoft.com/office/drawing/2014/main" id="{08D5A4D1-A73D-BD30-0B6E-173C2C5E1781}"/>
+                </a:ext>
+              </a:extLst>
+            </p:cNvPr>
+            <p:cNvPicPr>
+              <a:picLocks noChangeAspect="1"/>
+            </p:cNvPicPr>
+            <p:nvPr/>
+          </p:nvPicPr>
+          <p:blipFill>
+            <a:blip r:embed="rId4"/>
+            <a:stretch>
+              <a:fillRect/>
+            </a:stretch>
+          </p:blipFill>
+          <p:spPr>
+            <a:xfrm>
+              <a:off x="9509756" y="4498313"/>
+              <a:ext cx="366234" cy="357021"/>
+            </a:xfrm>
+            <a:prstGeom prst="rect">
+              <a:avLst/>
+            </a:prstGeom>
+          </p:spPr>
+        </p:pic>
+        <p:sp>
+          <p:nvSpPr>
+            <p:cNvPr id="74" name="Textfeld 73">
+              <a:extLst>
+                <a:ext uri="{FF2B5EF4-FFF2-40B4-BE49-F238E27FC236}">
+                  <a16:creationId xmlns:a16="http://schemas.microsoft.com/office/drawing/2014/main" id="{5EEF4584-4569-91C5-5871-432896611578}"/>
+                </a:ext>
+              </a:extLst>
+            </p:cNvPr>
+            <p:cNvSpPr txBox="1"/>
+            <p:nvPr/>
+          </p:nvSpPr>
+          <p:spPr>
+            <a:xfrm>
+              <a:off x="9833386" y="4382362"/>
+              <a:ext cx="945067" cy="584775"/>
+            </a:xfrm>
+            <a:prstGeom prst="rect">
+              <a:avLst/>
+            </a:prstGeom>
+            <a:noFill/>
+          </p:spPr>
+          <p:txBody>
+            <a:bodyPr wrap="none" rtlCol="0">
+              <a:spAutoFit/>
+            </a:bodyPr>
+            <a:lstStyle/>
+            <a:p>
+              <a:pPr algn="ctr"/>
+              <a:r>
+                <a:rPr lang="de-DE" sz="1600" b="1">
+                  <a:solidFill>
+                    <a:srgbClr val="0070C0"/>
+                  </a:solidFill>
+                </a:rPr>
+                <a:t>contoso</a:t>
+              </a:r>
+            </a:p>
+            <a:p>
+              <a:pPr algn="ctr"/>
+              <a:r>
+                <a:rPr lang="de-DE" sz="1600" b="1">
+                  <a:solidFill>
+                    <a:srgbClr val="0070C0"/>
+                  </a:solidFill>
+                </a:rPr>
+                <a:t>world!</a:t>
+              </a:r>
+            </a:p>
+          </p:txBody>
+        </p:sp>
+      </p:grpSp>
     </p:spTree>
     <p:extLst>
       <p:ext uri="{BB962C8B-B14F-4D97-AF65-F5344CB8AC3E}">

</xml_diff>

<commit_message>
wip: sync [2026-06-21 22:45]
</commit_message>
<xml_diff>
--- a/josyn-intro.pptx
+++ b/josyn-intro.pptx
@@ -14926,7 +14926,19 @@
           <a:p>
             <a:r>
               <a:rPr lang="de-DE" sz="2400" b="1"/>
-              <a:t>Vorschlag für einen effizienten Arbeitsmodus der </a:t>
+              <a:t>Vorschlag für einen effizienten </a:t>
+            </a:r>
+            <a:r>
+              <a:rPr lang="de-DE" sz="2400" b="1">
+                <a:solidFill>
+                  <a:srgbClr val="0070C0"/>
+                </a:solidFill>
+              </a:rPr>
+              <a:t>Arbeitsmodus</a:t>
+            </a:r>
+            <a:r>
+              <a:rPr lang="de-DE" sz="2400" b="1"/>
+              <a:t> der </a:t>
             </a:r>
             <a:r>
               <a:rPr lang="de-DE" sz="2400" b="1">
@@ -14944,7 +14956,15 @@
           <a:p>
             <a:r>
               <a:rPr lang="de-DE" sz="2000"/>
-              <a:t>Für die ersten Milestones - bis zu einem </a:t>
+              <a:t>Für die </a:t>
+            </a:r>
+            <a:r>
+              <a:rPr lang="de-DE" sz="2000" i="1"/>
+              <a:t>ersten Milestones</a:t>
+            </a:r>
+            <a:r>
+              <a:rPr lang="de-DE" sz="2000"/>
+              <a:t> - bis zu einem </a:t>
             </a:r>
             <a:r>
               <a:rPr lang="de-DE" sz="2000" i="1"/>
@@ -14952,7 +14972,7 @@
             </a:r>
             <a:r>
               <a:rPr lang="de-DE" sz="2000"/>
-              <a:t> - (ein „</a:t>
+              <a:t> - „</a:t>
             </a:r>
             <a:r>
               <a:rPr lang="de-DE" sz="2000">
@@ -14976,17 +14996,17 @@
             </a:r>
             <a:r>
               <a:rPr lang="de-DE" sz="2000"/>
-              <a:t>“)</a:t>
+              <a:t>“</a:t>
             </a:r>
           </a:p>
         </p:txBody>
       </p:sp>
       <p:grpSp>
         <p:nvGrpSpPr>
-          <p:cNvPr id="11" name="Gruppieren 10">
+          <p:cNvPr id="32" name="Gruppieren 31">
             <a:extLst>
               <a:ext uri="{FF2B5EF4-FFF2-40B4-BE49-F238E27FC236}">
-                <a16:creationId xmlns:a16="http://schemas.microsoft.com/office/drawing/2014/main" id="{F9DF1980-87A5-DF9B-4C35-F25E1B10BBE9}"/>
+                <a16:creationId xmlns:a16="http://schemas.microsoft.com/office/drawing/2014/main" id="{A74BB45E-3158-1249-3703-8DC8394305B5}"/>
               </a:ext>
             </a:extLst>
           </p:cNvPr>
@@ -14995,253 +15015,1474 @@
         </p:nvGrpSpPr>
         <p:grpSpPr>
           <a:xfrm>
-            <a:off x="410130" y="965799"/>
-            <a:ext cx="10681992" cy="5738097"/>
-            <a:chOff x="410130" y="965799"/>
-            <a:chExt cx="10681992" cy="5738097"/>
+            <a:off x="750351" y="1051524"/>
+            <a:ext cx="10958734" cy="5647506"/>
+            <a:chOff x="750351" y="1051524"/>
+            <a:chExt cx="10958734" cy="5647506"/>
           </a:xfrm>
         </p:grpSpPr>
-        <p:graphicFrame>
-          <p:nvGraphicFramePr>
-            <p:cNvPr id="2" name="Objekt 1">
+        <p:grpSp>
+          <p:nvGrpSpPr>
+            <p:cNvPr id="25" name="Gruppieren 24">
               <a:extLst>
                 <a:ext uri="{FF2B5EF4-FFF2-40B4-BE49-F238E27FC236}">
-                  <a16:creationId xmlns:a16="http://schemas.microsoft.com/office/drawing/2014/main" id="{D5ECA142-B412-E0D5-06F1-656EF56CD978}"/>
+                  <a16:creationId xmlns:a16="http://schemas.microsoft.com/office/drawing/2014/main" id="{8C7CC583-04A8-1711-7267-440E9B8274EE}"/>
                 </a:ext>
               </a:extLst>
             </p:cNvPr>
-            <p:cNvGraphicFramePr>
-              <a:graphicFrameLocks noChangeAspect="1"/>
-            </p:cNvGraphicFramePr>
-            <p:nvPr>
-              <p:extLst>
-                <p:ext uri="{D42A27DB-BD31-4B8C-83A1-F6EECF244321}">
-                  <p14:modId xmlns:p14="http://schemas.microsoft.com/office/powerpoint/2010/main" val="4032221289"/>
-                </p:ext>
-              </p:extLst>
-            </p:nvPr>
-          </p:nvGraphicFramePr>
-          <p:xfrm>
-            <a:off x="3268342" y="965799"/>
-            <a:ext cx="1009391" cy="490762"/>
-          </p:xfrm>
-          <a:graphic>
-            <a:graphicData uri="http://schemas.openxmlformats.org/presentationml/2006/ole">
-              <mc:AlternateContent xmlns:mc="http://schemas.openxmlformats.org/markup-compatibility/2006">
-                <mc:Choice xmlns:v="urn:schemas-microsoft-com:vml" Requires="v">
-                  <p:oleObj name="Image" r:id="rId3" imgW="10638619" imgH="5172693" progId="Photoshop.Image.7">
-                    <p:embed/>
-                  </p:oleObj>
-                </mc:Choice>
-                <mc:Fallback>
-                  <p:oleObj name="Image" r:id="rId3" imgW="10638619" imgH="5172693" progId="Photoshop.Image.7">
-                    <p:embed/>
-                    <p:pic>
-                      <p:nvPicPr>
-                        <p:cNvPr id="0" name=""/>
-                        <p:cNvPicPr/>
-                        <p:nvPr/>
-                      </p:nvPicPr>
-                      <p:blipFill>
-                        <a:blip r:embed="rId4"/>
-                        <a:stretch>
-                          <a:fillRect/>
-                        </a:stretch>
-                      </p:blipFill>
-                      <p:spPr>
-                        <a:xfrm>
-                          <a:off x="3268342" y="965799"/>
-                          <a:ext cx="1009391" cy="490762"/>
-                        </a:xfrm>
-                        <a:prstGeom prst="rect">
-                          <a:avLst/>
-                        </a:prstGeom>
-                      </p:spPr>
-                    </p:pic>
-                  </p:oleObj>
-                </mc:Fallback>
-              </mc:AlternateContent>
-            </a:graphicData>
-          </a:graphic>
-        </p:graphicFrame>
-        <p:cxnSp>
-          <p:nvCxnSpPr>
-            <p:cNvPr id="6" name="Gerader Verbinder 5">
+            <p:cNvGrpSpPr/>
+            <p:nvPr/>
+          </p:nvGrpSpPr>
+          <p:grpSpPr>
+            <a:xfrm>
+              <a:off x="750351" y="1051524"/>
+              <a:ext cx="10958734" cy="5647506"/>
+              <a:chOff x="750351" y="1051524"/>
+              <a:chExt cx="10958734" cy="5647506"/>
+            </a:xfrm>
+          </p:grpSpPr>
+          <p:grpSp>
+            <p:nvGrpSpPr>
+              <p:cNvPr id="18" name="Gruppieren 17">
+                <a:extLst>
+                  <a:ext uri="{FF2B5EF4-FFF2-40B4-BE49-F238E27FC236}">
+                    <a16:creationId xmlns:a16="http://schemas.microsoft.com/office/drawing/2014/main" id="{829AD25F-9114-B332-4496-32AA66FB9099}"/>
+                  </a:ext>
+                </a:extLst>
+              </p:cNvPr>
+              <p:cNvGrpSpPr/>
+              <p:nvPr/>
+            </p:nvGrpSpPr>
+            <p:grpSpPr>
+              <a:xfrm>
+                <a:off x="750351" y="1051524"/>
+                <a:ext cx="10437021" cy="5647506"/>
+                <a:chOff x="750351" y="1051524"/>
+                <a:chExt cx="10437021" cy="5647506"/>
+              </a:xfrm>
+            </p:grpSpPr>
+            <p:grpSp>
+              <p:nvGrpSpPr>
+                <p:cNvPr id="11" name="Gruppieren 10">
+                  <a:extLst>
+                    <a:ext uri="{FF2B5EF4-FFF2-40B4-BE49-F238E27FC236}">
+                      <a16:creationId xmlns:a16="http://schemas.microsoft.com/office/drawing/2014/main" id="{F9DF1980-87A5-DF9B-4C35-F25E1B10BBE9}"/>
+                    </a:ext>
+                  </a:extLst>
+                </p:cNvPr>
+                <p:cNvGrpSpPr/>
+                <p:nvPr/>
+              </p:nvGrpSpPr>
+              <p:grpSpPr>
+                <a:xfrm>
+                  <a:off x="750351" y="1051524"/>
+                  <a:ext cx="10437021" cy="5647506"/>
+                  <a:chOff x="655101" y="965799"/>
+                  <a:chExt cx="10437021" cy="5647506"/>
+                </a:xfrm>
+              </p:grpSpPr>
+              <p:graphicFrame>
+                <p:nvGraphicFramePr>
+                  <p:cNvPr id="2" name="Objekt 1">
+                    <a:extLst>
+                      <a:ext uri="{FF2B5EF4-FFF2-40B4-BE49-F238E27FC236}">
+                        <a16:creationId xmlns:a16="http://schemas.microsoft.com/office/drawing/2014/main" id="{D5ECA142-B412-E0D5-06F1-656EF56CD978}"/>
+                      </a:ext>
+                    </a:extLst>
+                  </p:cNvPr>
+                  <p:cNvGraphicFramePr>
+                    <a:graphicFrameLocks noChangeAspect="1"/>
+                  </p:cNvGraphicFramePr>
+                  <p:nvPr>
+                    <p:extLst>
+                      <p:ext uri="{D42A27DB-BD31-4B8C-83A1-F6EECF244321}">
+                        <p14:modId xmlns:p14="http://schemas.microsoft.com/office/powerpoint/2010/main" val="4032221289"/>
+                      </p:ext>
+                    </p:extLst>
+                  </p:nvPr>
+                </p:nvGraphicFramePr>
+                <p:xfrm>
+                  <a:off x="3268342" y="965799"/>
+                  <a:ext cx="1009391" cy="490762"/>
+                </p:xfrm>
+                <a:graphic>
+                  <a:graphicData uri="http://schemas.openxmlformats.org/presentationml/2006/ole">
+                    <mc:AlternateContent xmlns:mc="http://schemas.openxmlformats.org/markup-compatibility/2006">
+                      <mc:Choice xmlns:v="urn:schemas-microsoft-com:vml" Requires="v">
+                        <p:oleObj name="Image" r:id="rId3" imgW="10638619" imgH="5172693" progId="Photoshop.Image.7">
+                          <p:embed/>
+                        </p:oleObj>
+                      </mc:Choice>
+                      <mc:Fallback>
+                        <p:oleObj name="Image" r:id="rId3" imgW="10638619" imgH="5172693" progId="Photoshop.Image.7">
+                          <p:embed/>
+                          <p:pic>
+                            <p:nvPicPr>
+                              <p:cNvPr id="0" name=""/>
+                              <p:cNvPicPr/>
+                              <p:nvPr/>
+                            </p:nvPicPr>
+                            <p:blipFill>
+                              <a:blip r:embed="rId4"/>
+                              <a:stretch>
+                                <a:fillRect/>
+                              </a:stretch>
+                            </p:blipFill>
+                            <p:spPr>
+                              <a:xfrm>
+                                <a:off x="3268342" y="965799"/>
+                                <a:ext cx="1009391" cy="490762"/>
+                              </a:xfrm>
+                              <a:prstGeom prst="rect">
+                                <a:avLst/>
+                              </a:prstGeom>
+                            </p:spPr>
+                          </p:pic>
+                        </p:oleObj>
+                      </mc:Fallback>
+                    </mc:AlternateContent>
+                  </a:graphicData>
+                </a:graphic>
+              </p:graphicFrame>
+              <p:cxnSp>
+                <p:nvCxnSpPr>
+                  <p:cNvPr id="6" name="Gerader Verbinder 5">
+                    <a:extLst>
+                      <a:ext uri="{FF2B5EF4-FFF2-40B4-BE49-F238E27FC236}">
+                        <a16:creationId xmlns:a16="http://schemas.microsoft.com/office/drawing/2014/main" id="{4F1D6A53-778D-D4CA-DF28-B32614F2BC67}"/>
+                      </a:ext>
+                    </a:extLst>
+                  </p:cNvPr>
+                  <p:cNvCxnSpPr>
+                    <a:cxnSpLocks/>
+                  </p:cNvCxnSpPr>
+                  <p:nvPr/>
+                </p:nvCxnSpPr>
+                <p:spPr>
+                  <a:xfrm>
+                    <a:off x="4427643" y="1378047"/>
+                    <a:ext cx="34835" cy="4038599"/>
+                  </a:xfrm>
+                  <a:prstGeom prst="line">
+                    <a:avLst/>
+                  </a:prstGeom>
+                  <a:ln w="28575">
+                    <a:prstDash val="sysDash"/>
+                  </a:ln>
+                </p:spPr>
+                <p:style>
+                  <a:lnRef idx="2">
+                    <a:schemeClr val="accent1"/>
+                  </a:lnRef>
+                  <a:fillRef idx="0">
+                    <a:schemeClr val="accent1"/>
+                  </a:fillRef>
+                  <a:effectRef idx="1">
+                    <a:schemeClr val="accent1"/>
+                  </a:effectRef>
+                  <a:fontRef idx="minor">
+                    <a:schemeClr val="tx1"/>
+                  </a:fontRef>
+                </p:style>
+              </p:cxnSp>
+              <p:sp>
+                <p:nvSpPr>
+                  <p:cNvPr id="7" name="Textfeld 6">
+                    <a:extLst>
+                      <a:ext uri="{FF2B5EF4-FFF2-40B4-BE49-F238E27FC236}">
+                        <a16:creationId xmlns:a16="http://schemas.microsoft.com/office/drawing/2014/main" id="{7BD7EA1E-C351-FA16-597F-C8904AEE55E8}"/>
+                      </a:ext>
+                    </a:extLst>
+                  </p:cNvPr>
+                  <p:cNvSpPr txBox="1"/>
+                  <p:nvPr/>
+                </p:nvSpPr>
+                <p:spPr>
+                  <a:xfrm>
+                    <a:off x="655101" y="996619"/>
+                    <a:ext cx="2774734" cy="707886"/>
+                  </a:xfrm>
+                  <a:prstGeom prst="rect">
+                    <a:avLst/>
+                  </a:prstGeom>
+                  <a:noFill/>
+                </p:spPr>
+                <p:txBody>
+                  <a:bodyPr wrap="none" rtlCol="0">
+                    <a:spAutoFit/>
+                  </a:bodyPr>
+                  <a:lstStyle/>
+                  <a:p>
+                    <a:pPr algn="ctr"/>
+                    <a:r>
+                      <a:rPr lang="de-DE" sz="2400" b="1">
+                        <a:solidFill>
+                          <a:srgbClr val="002060"/>
+                        </a:solidFill>
+                      </a:rPr>
+                      <a:t>„speedboat-lane“ </a:t>
+                    </a:r>
+                  </a:p>
+                  <a:p>
+                    <a:pPr algn="ctr"/>
+                    <a:r>
+                      <a:rPr lang="de-DE" sz="1600">
+                        <a:solidFill>
+                          <a:srgbClr val="002060"/>
+                        </a:solidFill>
+                      </a:rPr>
+                      <a:t>(ckluth/haevg - GitHub)</a:t>
+                    </a:r>
+                  </a:p>
+                </p:txBody>
+              </p:sp>
+              <p:sp>
+                <p:nvSpPr>
+                  <p:cNvPr id="8" name="Textfeld 7">
+                    <a:extLst>
+                      <a:ext uri="{FF2B5EF4-FFF2-40B4-BE49-F238E27FC236}">
+                        <a16:creationId xmlns:a16="http://schemas.microsoft.com/office/drawing/2014/main" id="{F48A6FD9-47FD-C5EB-4F97-78E97694F368}"/>
+                      </a:ext>
+                    </a:extLst>
+                  </p:cNvPr>
+                  <p:cNvSpPr txBox="1"/>
+                  <p:nvPr/>
+                </p:nvSpPr>
+                <p:spPr>
+                  <a:xfrm>
+                    <a:off x="8143751" y="1012888"/>
+                    <a:ext cx="2948371" cy="461665"/>
+                  </a:xfrm>
+                  <a:prstGeom prst="rect">
+                    <a:avLst/>
+                  </a:prstGeom>
+                  <a:noFill/>
+                </p:spPr>
+                <p:txBody>
+                  <a:bodyPr wrap="none" rtlCol="0">
+                    <a:spAutoFit/>
+                  </a:bodyPr>
+                  <a:lstStyle/>
+                  <a:p>
+                    <a:r>
+                      <a:rPr lang="de-DE" sz="2400" b="1">
+                        <a:solidFill>
+                          <a:schemeClr val="accent6">
+                            <a:lumMod val="50000"/>
+                          </a:schemeClr>
+                        </a:solidFill>
+                      </a:rPr>
+                      <a:t>HÄVG-SWE-Domain</a:t>
+                    </a:r>
+                  </a:p>
+                </p:txBody>
+              </p:sp>
+              <p:sp>
+                <p:nvSpPr>
+                  <p:cNvPr id="9" name="Textfeld 8">
+                    <a:extLst>
+                      <a:ext uri="{FF2B5EF4-FFF2-40B4-BE49-F238E27FC236}">
+                        <a16:creationId xmlns:a16="http://schemas.microsoft.com/office/drawing/2014/main" id="{9D900BFE-C88A-3A8A-B9AB-D4E4F9F8A368}"/>
+                      </a:ext>
+                    </a:extLst>
+                  </p:cNvPr>
+                  <p:cNvSpPr txBox="1"/>
+                  <p:nvPr/>
+                </p:nvSpPr>
+                <p:spPr>
+                  <a:xfrm>
+                    <a:off x="4550946" y="1010586"/>
+                    <a:ext cx="2227918" cy="707886"/>
+                  </a:xfrm>
+                  <a:prstGeom prst="rect">
+                    <a:avLst/>
+                  </a:prstGeom>
+                  <a:noFill/>
+                </p:spPr>
+                <p:txBody>
+                  <a:bodyPr wrap="none" rtlCol="0">
+                    <a:spAutoFit/>
+                  </a:bodyPr>
+                  <a:lstStyle/>
+                  <a:p>
+                    <a:r>
+                      <a:rPr lang="de-DE" sz="2400" b="1">
+                        <a:solidFill>
+                          <a:srgbClr val="0070C0"/>
+                        </a:solidFill>
+                      </a:rPr>
+                      <a:t>„staging-pipe“</a:t>
+                    </a:r>
+                  </a:p>
+                  <a:p>
+                    <a:pPr algn="ctr"/>
+                    <a:r>
+                      <a:rPr lang="de-DE" sz="1600">
+                        <a:solidFill>
+                          <a:srgbClr val="0070C0"/>
+                        </a:solidFill>
+                      </a:rPr>
+                      <a:t>decision-gate</a:t>
+                    </a:r>
+                  </a:p>
+                </p:txBody>
+              </p:sp>
+              <p:sp>
+                <p:nvSpPr>
+                  <p:cNvPr id="19" name="Ellipse 18">
+                    <a:extLst>
+                      <a:ext uri="{FF2B5EF4-FFF2-40B4-BE49-F238E27FC236}">
+                        <a16:creationId xmlns:a16="http://schemas.microsoft.com/office/drawing/2014/main" id="{39258206-4131-12A3-660F-17B889C6B58A}"/>
+                      </a:ext>
+                    </a:extLst>
+                  </p:cNvPr>
+                  <p:cNvSpPr/>
+                  <p:nvPr/>
+                </p:nvSpPr>
+                <p:spPr>
+                  <a:xfrm>
+                    <a:off x="5319732" y="2952238"/>
+                    <a:ext cx="1507308" cy="742950"/>
+                  </a:xfrm>
+                  <a:prstGeom prst="ellipse">
+                    <a:avLst/>
+                  </a:prstGeom>
+                  <a:solidFill>
+                    <a:schemeClr val="tx2">
+                      <a:lumMod val="50000"/>
+                      <a:lumOff val="50000"/>
+                    </a:schemeClr>
+                  </a:solidFill>
+                </p:spPr>
+                <p:style>
+                  <a:lnRef idx="2">
+                    <a:schemeClr val="accent1">
+                      <a:shade val="15000"/>
+                    </a:schemeClr>
+                  </a:lnRef>
+                  <a:fillRef idx="1">
+                    <a:schemeClr val="accent1"/>
+                  </a:fillRef>
+                  <a:effectRef idx="0">
+                    <a:schemeClr val="accent1"/>
+                  </a:effectRef>
+                  <a:fontRef idx="minor">
+                    <a:schemeClr val="lt1"/>
+                  </a:fontRef>
+                </p:style>
+                <p:txBody>
+                  <a:bodyPr rtlCol="0" anchor="ctr"/>
+                  <a:lstStyle/>
+                  <a:p>
+                    <a:pPr algn="ctr"/>
+                    <a:r>
+                      <a:rPr lang="de-DE" sz="1600" b="1"/>
+                      <a:t>Proposal</a:t>
+                    </a:r>
+                  </a:p>
+                </p:txBody>
+              </p:sp>
+              <p:sp>
+                <p:nvSpPr>
+                  <p:cNvPr id="20" name="Ellipse 19">
+                    <a:extLst>
+                      <a:ext uri="{FF2B5EF4-FFF2-40B4-BE49-F238E27FC236}">
+                        <a16:creationId xmlns:a16="http://schemas.microsoft.com/office/drawing/2014/main" id="{71B297BD-EB29-7936-AFE6-4B0B3CCC06CA}"/>
+                      </a:ext>
+                    </a:extLst>
+                  </p:cNvPr>
+                  <p:cNvSpPr/>
+                  <p:nvPr/>
+                </p:nvSpPr>
+                <p:spPr>
+                  <a:xfrm>
+                    <a:off x="5319732" y="3981208"/>
+                    <a:ext cx="1507308" cy="742950"/>
+                  </a:xfrm>
+                  <a:prstGeom prst="ellipse">
+                    <a:avLst/>
+                  </a:prstGeom>
+                  <a:solidFill>
+                    <a:schemeClr val="tx2">
+                      <a:lumMod val="50000"/>
+                      <a:lumOff val="50000"/>
+                    </a:schemeClr>
+                  </a:solidFill>
+                </p:spPr>
+                <p:style>
+                  <a:lnRef idx="2">
+                    <a:schemeClr val="accent1">
+                      <a:shade val="15000"/>
+                    </a:schemeClr>
+                  </a:lnRef>
+                  <a:fillRef idx="1">
+                    <a:schemeClr val="accent1"/>
+                  </a:fillRef>
+                  <a:effectRef idx="0">
+                    <a:schemeClr val="accent1"/>
+                  </a:effectRef>
+                  <a:fontRef idx="minor">
+                    <a:schemeClr val="lt1"/>
+                  </a:fontRef>
+                </p:style>
+                <p:txBody>
+                  <a:bodyPr rtlCol="0" anchor="ctr"/>
+                  <a:lstStyle/>
+                  <a:p>
+                    <a:pPr algn="ctr"/>
+                    <a:r>
+                      <a:rPr lang="de-DE" sz="1600" b="1"/>
+                      <a:t>Proposal</a:t>
+                    </a:r>
+                  </a:p>
+                </p:txBody>
+              </p:sp>
+              <p:sp>
+                <p:nvSpPr>
+                  <p:cNvPr id="21" name="Ellipse 20">
+                    <a:extLst>
+                      <a:ext uri="{FF2B5EF4-FFF2-40B4-BE49-F238E27FC236}">
+                        <a16:creationId xmlns:a16="http://schemas.microsoft.com/office/drawing/2014/main" id="{90575A8D-8C72-B615-A545-E12FE53533E5}"/>
+                      </a:ext>
+                    </a:extLst>
+                  </p:cNvPr>
+                  <p:cNvSpPr/>
+                  <p:nvPr/>
+                </p:nvSpPr>
+                <p:spPr>
+                  <a:xfrm>
+                    <a:off x="5328141" y="1952624"/>
+                    <a:ext cx="1507308" cy="742950"/>
+                  </a:xfrm>
+                  <a:prstGeom prst="ellipse">
+                    <a:avLst/>
+                  </a:prstGeom>
+                  <a:solidFill>
+                    <a:schemeClr val="tx2">
+                      <a:lumMod val="50000"/>
+                      <a:lumOff val="50000"/>
+                    </a:schemeClr>
+                  </a:solidFill>
+                </p:spPr>
+                <p:style>
+                  <a:lnRef idx="2">
+                    <a:schemeClr val="accent1">
+                      <a:shade val="15000"/>
+                    </a:schemeClr>
+                  </a:lnRef>
+                  <a:fillRef idx="1">
+                    <a:schemeClr val="accent1"/>
+                  </a:fillRef>
+                  <a:effectRef idx="0">
+                    <a:schemeClr val="accent1"/>
+                  </a:effectRef>
+                  <a:fontRef idx="minor">
+                    <a:schemeClr val="lt1"/>
+                  </a:fontRef>
+                </p:style>
+                <p:txBody>
+                  <a:bodyPr rtlCol="0" anchor="ctr"/>
+                  <a:lstStyle/>
+                  <a:p>
+                    <a:pPr algn="ctr"/>
+                    <a:r>
+                      <a:rPr lang="de-DE" sz="1600" b="1"/>
+                      <a:t>Proposal</a:t>
+                    </a:r>
+                  </a:p>
+                </p:txBody>
+              </p:sp>
+              <p:sp>
+                <p:nvSpPr>
+                  <p:cNvPr id="22" name="Ellipse 21">
+                    <a:extLst>
+                      <a:ext uri="{FF2B5EF4-FFF2-40B4-BE49-F238E27FC236}">
+                        <a16:creationId xmlns:a16="http://schemas.microsoft.com/office/drawing/2014/main" id="{2063DA56-F4AD-AC48-CCFA-10F491C2F167}"/>
+                      </a:ext>
+                    </a:extLst>
+                  </p:cNvPr>
+                  <p:cNvSpPr/>
+                  <p:nvPr/>
+                </p:nvSpPr>
+                <p:spPr>
+                  <a:xfrm>
+                    <a:off x="8825679" y="1991506"/>
+                    <a:ext cx="1507308" cy="742950"/>
+                  </a:xfrm>
+                  <a:prstGeom prst="ellipse">
+                    <a:avLst/>
+                  </a:prstGeom>
+                  <a:solidFill>
+                    <a:srgbClr val="00B050"/>
+                  </a:solidFill>
+                </p:spPr>
+                <p:style>
+                  <a:lnRef idx="2">
+                    <a:schemeClr val="accent1">
+                      <a:shade val="15000"/>
+                    </a:schemeClr>
+                  </a:lnRef>
+                  <a:fillRef idx="1">
+                    <a:schemeClr val="accent1"/>
+                  </a:fillRef>
+                  <a:effectRef idx="0">
+                    <a:schemeClr val="accent1"/>
+                  </a:effectRef>
+                  <a:fontRef idx="minor">
+                    <a:schemeClr val="lt1"/>
+                  </a:fontRef>
+                </p:style>
+                <p:txBody>
+                  <a:bodyPr rtlCol="0" anchor="ctr"/>
+                  <a:lstStyle/>
+                  <a:p>
+                    <a:pPr algn="ctr"/>
+                    <a:r>
+                      <a:rPr lang="de-DE" sz="1600" b="1"/>
+                      <a:t>Decision</a:t>
+                    </a:r>
+                  </a:p>
+                </p:txBody>
+              </p:sp>
+              <p:sp>
+                <p:nvSpPr>
+                  <p:cNvPr id="23" name="Ellipse 22">
+                    <a:extLst>
+                      <a:ext uri="{FF2B5EF4-FFF2-40B4-BE49-F238E27FC236}">
+                        <a16:creationId xmlns:a16="http://schemas.microsoft.com/office/drawing/2014/main" id="{6BCAFD35-9659-BAB9-4F1B-2ACD5A03309D}"/>
+                      </a:ext>
+                    </a:extLst>
+                  </p:cNvPr>
+                  <p:cNvSpPr/>
+                  <p:nvPr/>
+                </p:nvSpPr>
+                <p:spPr>
+                  <a:xfrm>
+                    <a:off x="8831531" y="2952238"/>
+                    <a:ext cx="1507308" cy="742950"/>
+                  </a:xfrm>
+                  <a:prstGeom prst="ellipse">
+                    <a:avLst/>
+                  </a:prstGeom>
+                  <a:solidFill>
+                    <a:srgbClr val="00B050"/>
+                  </a:solidFill>
+                </p:spPr>
+                <p:style>
+                  <a:lnRef idx="2">
+                    <a:schemeClr val="accent1">
+                      <a:shade val="15000"/>
+                    </a:schemeClr>
+                  </a:lnRef>
+                  <a:fillRef idx="1">
+                    <a:schemeClr val="accent1"/>
+                  </a:fillRef>
+                  <a:effectRef idx="0">
+                    <a:schemeClr val="accent1"/>
+                  </a:effectRef>
+                  <a:fontRef idx="minor">
+                    <a:schemeClr val="lt1"/>
+                  </a:fontRef>
+                </p:style>
+                <p:txBody>
+                  <a:bodyPr rtlCol="0" anchor="ctr"/>
+                  <a:lstStyle/>
+                  <a:p>
+                    <a:pPr algn="ctr"/>
+                    <a:r>
+                      <a:rPr lang="de-DE" sz="1600" b="1"/>
+                      <a:t>Decision</a:t>
+                    </a:r>
+                  </a:p>
+                </p:txBody>
+              </p:sp>
+              <p:sp>
+                <p:nvSpPr>
+                  <p:cNvPr id="24" name="Ellipse 23">
+                    <a:extLst>
+                      <a:ext uri="{FF2B5EF4-FFF2-40B4-BE49-F238E27FC236}">
+                        <a16:creationId xmlns:a16="http://schemas.microsoft.com/office/drawing/2014/main" id="{57C1F23F-BCC7-4F6C-01C3-846DEC0EFEC0}"/>
+                      </a:ext>
+                    </a:extLst>
+                  </p:cNvPr>
+                  <p:cNvSpPr/>
+                  <p:nvPr/>
+                </p:nvSpPr>
+                <p:spPr>
+                  <a:xfrm>
+                    <a:off x="8831531" y="3973704"/>
+                    <a:ext cx="1507308" cy="742950"/>
+                  </a:xfrm>
+                  <a:prstGeom prst="ellipse">
+                    <a:avLst/>
+                  </a:prstGeom>
+                  <a:solidFill>
+                    <a:srgbClr val="00B050"/>
+                  </a:solidFill>
+                </p:spPr>
+                <p:style>
+                  <a:lnRef idx="2">
+                    <a:schemeClr val="accent1">
+                      <a:shade val="15000"/>
+                    </a:schemeClr>
+                  </a:lnRef>
+                  <a:fillRef idx="1">
+                    <a:schemeClr val="accent1"/>
+                  </a:fillRef>
+                  <a:effectRef idx="0">
+                    <a:schemeClr val="accent1"/>
+                  </a:effectRef>
+                  <a:fontRef idx="minor">
+                    <a:schemeClr val="lt1"/>
+                  </a:fontRef>
+                </p:style>
+                <p:txBody>
+                  <a:bodyPr rtlCol="0" anchor="ctr"/>
+                  <a:lstStyle/>
+                  <a:p>
+                    <a:pPr algn="ctr"/>
+                    <a:r>
+                      <a:rPr lang="de-DE" sz="1600" b="1"/>
+                      <a:t>Decision</a:t>
+                    </a:r>
+                  </a:p>
+                </p:txBody>
+              </p:sp>
+              <p:pic>
+                <p:nvPicPr>
+                  <p:cNvPr id="29" name="Grafik 28">
+                    <a:extLst>
+                      <a:ext uri="{FF2B5EF4-FFF2-40B4-BE49-F238E27FC236}">
+                        <a16:creationId xmlns:a16="http://schemas.microsoft.com/office/drawing/2014/main" id="{FD624151-C93A-C1A6-942A-96A2AF69FF0B}"/>
+                      </a:ext>
+                    </a:extLst>
+                  </p:cNvPr>
+                  <p:cNvPicPr>
+                    <a:picLocks noChangeAspect="1"/>
+                  </p:cNvPicPr>
+                  <p:nvPr/>
+                </p:nvPicPr>
+                <p:blipFill>
+                  <a:blip r:embed="rId5">
+                    <a:extLst>
+                      <a:ext uri="{28A0092B-C50C-407E-A947-70E740481C1C}">
+                        <a14:useLocalDpi xmlns:a14="http://schemas.microsoft.com/office/drawing/2010/main" val="0"/>
+                      </a:ext>
+                    </a:extLst>
+                  </a:blip>
+                  <a:stretch>
+                    <a:fillRect/>
+                  </a:stretch>
+                </p:blipFill>
+                <p:spPr>
+                  <a:xfrm>
+                    <a:off x="5703403" y="5828111"/>
+                    <a:ext cx="785194" cy="785194"/>
+                  </a:xfrm>
+                  <a:prstGeom prst="rect">
+                    <a:avLst/>
+                  </a:prstGeom>
+                </p:spPr>
+              </p:pic>
+              <p:cxnSp>
+                <p:nvCxnSpPr>
+                  <p:cNvPr id="33" name="Gerader Verbinder 32">
+                    <a:extLst>
+                      <a:ext uri="{FF2B5EF4-FFF2-40B4-BE49-F238E27FC236}">
+                        <a16:creationId xmlns:a16="http://schemas.microsoft.com/office/drawing/2014/main" id="{2D9EE726-1AF9-8340-FED4-B3EFF74430DA}"/>
+                      </a:ext>
+                    </a:extLst>
+                  </p:cNvPr>
+                  <p:cNvCxnSpPr>
+                    <a:cxnSpLocks/>
+                  </p:cNvCxnSpPr>
+                  <p:nvPr/>
+                </p:nvCxnSpPr>
+                <p:spPr>
+                  <a:xfrm>
+                    <a:off x="7870828" y="1330703"/>
+                    <a:ext cx="18730" cy="4038599"/>
+                  </a:xfrm>
+                  <a:prstGeom prst="line">
+                    <a:avLst/>
+                  </a:prstGeom>
+                  <a:ln w="76200">
+                    <a:solidFill>
+                      <a:srgbClr val="FF0000"/>
+                    </a:solidFill>
+                  </a:ln>
+                </p:spPr>
+                <p:style>
+                  <a:lnRef idx="2">
+                    <a:schemeClr val="accent1"/>
+                  </a:lnRef>
+                  <a:fillRef idx="0">
+                    <a:schemeClr val="accent1"/>
+                  </a:fillRef>
+                  <a:effectRef idx="1">
+                    <a:schemeClr val="accent1"/>
+                  </a:effectRef>
+                  <a:fontRef idx="minor">
+                    <a:schemeClr val="tx1"/>
+                  </a:fontRef>
+                </p:style>
+              </p:cxnSp>
+              <p:sp>
+                <p:nvSpPr>
+                  <p:cNvPr id="36" name="Rechteck 35">
+                    <a:extLst>
+                      <a:ext uri="{FF2B5EF4-FFF2-40B4-BE49-F238E27FC236}">
+                        <a16:creationId xmlns:a16="http://schemas.microsoft.com/office/drawing/2014/main" id="{952CADCB-1CB0-F1CA-741C-CB151AC44414}"/>
+                      </a:ext>
+                    </a:extLst>
+                  </p:cNvPr>
+                  <p:cNvSpPr/>
+                  <p:nvPr/>
+                </p:nvSpPr>
+                <p:spPr>
+                  <a:xfrm>
+                    <a:off x="7461549" y="2590503"/>
+                    <a:ext cx="888973" cy="1590105"/>
+                  </a:xfrm>
+                  <a:prstGeom prst="rect">
+                    <a:avLst/>
+                  </a:prstGeom>
+                  <a:solidFill>
+                    <a:schemeClr val="bg1"/>
+                  </a:solidFill>
+                  <a:ln>
+                    <a:noFill/>
+                  </a:ln>
+                </p:spPr>
+                <p:style>
+                  <a:lnRef idx="2">
+                    <a:schemeClr val="accent1">
+                      <a:shade val="15000"/>
+                    </a:schemeClr>
+                  </a:lnRef>
+                  <a:fillRef idx="1">
+                    <a:schemeClr val="accent1"/>
+                  </a:fillRef>
+                  <a:effectRef idx="0">
+                    <a:schemeClr val="accent1"/>
+                  </a:effectRef>
+                  <a:fontRef idx="minor">
+                    <a:schemeClr val="lt1"/>
+                  </a:fontRef>
+                </p:style>
+                <p:txBody>
+                  <a:bodyPr rtlCol="0" anchor="ctr"/>
+                  <a:lstStyle/>
+                  <a:p>
+                    <a:pPr algn="ctr"/>
+                    <a:endParaRPr lang="de-DE"/>
+                  </a:p>
+                </p:txBody>
+              </p:sp>
+              <p:sp>
+                <p:nvSpPr>
+                  <p:cNvPr id="27" name="Pfeil: nach links 26">
+                    <a:extLst>
+                      <a:ext uri="{FF2B5EF4-FFF2-40B4-BE49-F238E27FC236}">
+                        <a16:creationId xmlns:a16="http://schemas.microsoft.com/office/drawing/2014/main" id="{D78CB09B-750F-9588-B243-6B065C35AC72}"/>
+                      </a:ext>
+                    </a:extLst>
+                  </p:cNvPr>
+                  <p:cNvSpPr/>
+                  <p:nvPr/>
+                </p:nvSpPr>
+                <p:spPr>
+                  <a:xfrm rot="10800000">
+                    <a:off x="7396254" y="3115703"/>
+                    <a:ext cx="1131789" cy="392399"/>
+                  </a:xfrm>
+                  <a:prstGeom prst="leftArrow">
+                    <a:avLst/>
+                  </a:prstGeom>
+                  <a:solidFill>
+                    <a:schemeClr val="accent6"/>
+                  </a:solidFill>
+                </p:spPr>
+                <p:style>
+                  <a:lnRef idx="2">
+                    <a:schemeClr val="accent1">
+                      <a:shade val="15000"/>
+                    </a:schemeClr>
+                  </a:lnRef>
+                  <a:fillRef idx="1">
+                    <a:schemeClr val="accent1"/>
+                  </a:fillRef>
+                  <a:effectRef idx="0">
+                    <a:schemeClr val="accent1"/>
+                  </a:effectRef>
+                  <a:fontRef idx="minor">
+                    <a:schemeClr val="lt1"/>
+                  </a:fontRef>
+                </p:style>
+                <p:txBody>
+                  <a:bodyPr rtlCol="0" anchor="ctr"/>
+                  <a:lstStyle/>
+                  <a:p>
+                    <a:pPr algn="ctr"/>
+                    <a:endParaRPr lang="de-DE"/>
+                  </a:p>
+                </p:txBody>
+              </p:sp>
+              <p:pic>
+                <p:nvPicPr>
+                  <p:cNvPr id="37" name="Grafik 36">
+                    <a:extLst>
+                      <a:ext uri="{FF2B5EF4-FFF2-40B4-BE49-F238E27FC236}">
+                        <a16:creationId xmlns:a16="http://schemas.microsoft.com/office/drawing/2014/main" id="{B265D967-E0F6-75E0-AD93-28D8EEA4501F}"/>
+                      </a:ext>
+                    </a:extLst>
+                  </p:cNvPr>
+                  <p:cNvPicPr>
+                    <a:picLocks noChangeAspect="1"/>
+                  </p:cNvPicPr>
+                  <p:nvPr/>
+                </p:nvPicPr>
+                <p:blipFill>
+                  <a:blip r:embed="rId6">
+                    <a:extLst>
+                      <a:ext uri="{28A0092B-C50C-407E-A947-70E740481C1C}">
+                        <a14:useLocalDpi xmlns:a14="http://schemas.microsoft.com/office/drawing/2010/main" val="0"/>
+                      </a:ext>
+                    </a:extLst>
+                  </a:blip>
+                  <a:stretch>
+                    <a:fillRect/>
+                  </a:stretch>
+                </p:blipFill>
+                <p:spPr>
+                  <a:xfrm>
+                    <a:off x="7616635" y="2470917"/>
+                    <a:ext cx="660908" cy="660908"/>
+                  </a:xfrm>
+                  <a:prstGeom prst="rect">
+                    <a:avLst/>
+                  </a:prstGeom>
+                </p:spPr>
+              </p:pic>
+              <p:pic>
+                <p:nvPicPr>
+                  <p:cNvPr id="40" name="Grafik 39">
+                    <a:extLst>
+                      <a:ext uri="{FF2B5EF4-FFF2-40B4-BE49-F238E27FC236}">
+                        <a16:creationId xmlns:a16="http://schemas.microsoft.com/office/drawing/2014/main" id="{606A1F1B-FF16-5FB9-1B7C-71990D18D2B6}"/>
+                      </a:ext>
+                    </a:extLst>
+                  </p:cNvPr>
+                  <p:cNvPicPr>
+                    <a:picLocks noChangeAspect="1"/>
+                  </p:cNvPicPr>
+                  <p:nvPr/>
+                </p:nvPicPr>
+                <p:blipFill>
+                  <a:blip r:embed="rId7">
+                    <a:extLst>
+                      <a:ext uri="{28A0092B-C50C-407E-A947-70E740481C1C}">
+                        <a14:useLocalDpi xmlns:a14="http://schemas.microsoft.com/office/drawing/2010/main" val="0"/>
+                      </a:ext>
+                    </a:extLst>
+                  </a:blip>
+                  <a:stretch>
+                    <a:fillRect/>
+                  </a:stretch>
+                </p:blipFill>
+                <p:spPr>
+                  <a:xfrm flipH="1">
+                    <a:off x="7509541" y="3243197"/>
+                    <a:ext cx="742950" cy="742950"/>
+                  </a:xfrm>
+                  <a:prstGeom prst="rect">
+                    <a:avLst/>
+                  </a:prstGeom>
+                </p:spPr>
+              </p:pic>
+              <p:cxnSp>
+                <p:nvCxnSpPr>
+                  <p:cNvPr id="46" name="Gerader Verbinder 45">
+                    <a:extLst>
+                      <a:ext uri="{FF2B5EF4-FFF2-40B4-BE49-F238E27FC236}">
+                        <a16:creationId xmlns:a16="http://schemas.microsoft.com/office/drawing/2014/main" id="{76BD3CD9-1AA6-01F6-ECFD-1B3E54261B80}"/>
+                      </a:ext>
+                    </a:extLst>
+                  </p:cNvPr>
+                  <p:cNvCxnSpPr>
+                    <a:cxnSpLocks/>
+                  </p:cNvCxnSpPr>
+                  <p:nvPr/>
+                </p:nvCxnSpPr>
+                <p:spPr>
+                  <a:xfrm>
+                    <a:off x="5005036" y="5434046"/>
+                    <a:ext cx="2245072" cy="0"/>
+                  </a:xfrm>
+                  <a:prstGeom prst="line">
+                    <a:avLst/>
+                  </a:prstGeom>
+                  <a:ln w="28575">
+                    <a:prstDash val="sysDash"/>
+                  </a:ln>
+                </p:spPr>
+                <p:style>
+                  <a:lnRef idx="2">
+                    <a:schemeClr val="accent1"/>
+                  </a:lnRef>
+                  <a:fillRef idx="0">
+                    <a:schemeClr val="accent1"/>
+                  </a:fillRef>
+                  <a:effectRef idx="1">
+                    <a:schemeClr val="accent1"/>
+                  </a:effectRef>
+                  <a:fontRef idx="minor">
+                    <a:schemeClr val="tx1"/>
+                  </a:fontRef>
+                </p:style>
+              </p:cxnSp>
+              <p:sp>
+                <p:nvSpPr>
+                  <p:cNvPr id="30" name="Pfeil: nach links 29">
+                    <a:extLst>
+                      <a:ext uri="{FF2B5EF4-FFF2-40B4-BE49-F238E27FC236}">
+                        <a16:creationId xmlns:a16="http://schemas.microsoft.com/office/drawing/2014/main" id="{23F6AB9C-6C3F-7896-F149-587F6EA65541}"/>
+                      </a:ext>
+                    </a:extLst>
+                  </p:cNvPr>
+                  <p:cNvSpPr/>
+                  <p:nvPr/>
+                </p:nvSpPr>
+                <p:spPr>
+                  <a:xfrm rot="16200000">
+                    <a:off x="5701910" y="5183129"/>
+                    <a:ext cx="742952" cy="392399"/>
+                  </a:xfrm>
+                  <a:prstGeom prst="leftArrow">
+                    <a:avLst/>
+                  </a:prstGeom>
+                  <a:solidFill>
+                    <a:srgbClr val="FF0000"/>
+                  </a:solidFill>
+                </p:spPr>
+                <p:style>
+                  <a:lnRef idx="2">
+                    <a:schemeClr val="accent1">
+                      <a:shade val="15000"/>
+                    </a:schemeClr>
+                  </a:lnRef>
+                  <a:fillRef idx="1">
+                    <a:schemeClr val="accent1"/>
+                  </a:fillRef>
+                  <a:effectRef idx="0">
+                    <a:schemeClr val="accent1"/>
+                  </a:effectRef>
+                  <a:fontRef idx="minor">
+                    <a:schemeClr val="lt1"/>
+                  </a:fontRef>
+                </p:style>
+                <p:txBody>
+                  <a:bodyPr rtlCol="0" anchor="ctr"/>
+                  <a:lstStyle/>
+                  <a:p>
+                    <a:pPr algn="ctr"/>
+                    <a:endParaRPr lang="de-DE"/>
+                  </a:p>
+                </p:txBody>
+              </p:sp>
+              <p:sp>
+                <p:nvSpPr>
+                  <p:cNvPr id="53" name="Ellipse 52">
+                    <a:extLst>
+                      <a:ext uri="{FF2B5EF4-FFF2-40B4-BE49-F238E27FC236}">
+                        <a16:creationId xmlns:a16="http://schemas.microsoft.com/office/drawing/2014/main" id="{4CE273E4-DACC-18FE-B1F2-F22205DF295C}"/>
+                      </a:ext>
+                    </a:extLst>
+                  </p:cNvPr>
+                  <p:cNvSpPr/>
+                  <p:nvPr/>
+                </p:nvSpPr>
+                <p:spPr>
+                  <a:xfrm>
+                    <a:off x="2221449" y="1991506"/>
+                    <a:ext cx="1431518" cy="742950"/>
+                  </a:xfrm>
+                  <a:prstGeom prst="ellipse">
+                    <a:avLst/>
+                  </a:prstGeom>
+                  <a:solidFill>
+                    <a:schemeClr val="accent2">
+                      <a:lumMod val="20000"/>
+                      <a:lumOff val="80000"/>
+                    </a:schemeClr>
+                  </a:solidFill>
+                </p:spPr>
+                <p:style>
+                  <a:lnRef idx="2">
+                    <a:schemeClr val="accent1">
+                      <a:shade val="15000"/>
+                    </a:schemeClr>
+                  </a:lnRef>
+                  <a:fillRef idx="1">
+                    <a:schemeClr val="accent1"/>
+                  </a:fillRef>
+                  <a:effectRef idx="0">
+                    <a:schemeClr val="accent1"/>
+                  </a:effectRef>
+                  <a:fontRef idx="minor">
+                    <a:schemeClr val="lt1"/>
+                  </a:fontRef>
+                </p:style>
+                <p:txBody>
+                  <a:bodyPr rtlCol="0" anchor="ctr"/>
+                  <a:lstStyle/>
+                  <a:p>
+                    <a:pPr algn="ctr"/>
+                    <a:r>
+                      <a:rPr lang="de-DE" sz="1600" b="1">
+                        <a:solidFill>
+                          <a:schemeClr val="tx1"/>
+                        </a:solidFill>
+                      </a:rPr>
+                      <a:t>Raw</a:t>
+                    </a:r>
+                  </a:p>
+                </p:txBody>
+              </p:sp>
+              <p:pic>
+                <p:nvPicPr>
+                  <p:cNvPr id="54" name="Grafik 53">
+                    <a:extLst>
+                      <a:ext uri="{FF2B5EF4-FFF2-40B4-BE49-F238E27FC236}">
+                        <a16:creationId xmlns:a16="http://schemas.microsoft.com/office/drawing/2014/main" id="{F4B67388-3290-E097-0F90-89890F15656E}"/>
+                      </a:ext>
+                    </a:extLst>
+                  </p:cNvPr>
+                  <p:cNvPicPr>
+                    <a:picLocks noChangeAspect="1"/>
+                  </p:cNvPicPr>
+                  <p:nvPr/>
+                </p:nvPicPr>
+                <p:blipFill>
+                  <a:blip r:embed="rId7">
+                    <a:extLst>
+                      <a:ext uri="{28A0092B-C50C-407E-A947-70E740481C1C}">
+                        <a14:useLocalDpi xmlns:a14="http://schemas.microsoft.com/office/drawing/2010/main" val="0"/>
+                      </a:ext>
+                    </a:extLst>
+                  </a:blip>
+                  <a:stretch>
+                    <a:fillRect/>
+                  </a:stretch>
+                </p:blipFill>
+                <p:spPr>
+                  <a:xfrm flipH="1">
+                    <a:off x="5072434" y="4749558"/>
+                    <a:ext cx="742950" cy="742950"/>
+                  </a:xfrm>
+                  <a:prstGeom prst="rect">
+                    <a:avLst/>
+                  </a:prstGeom>
+                </p:spPr>
+              </p:pic>
+              <p:pic>
+                <p:nvPicPr>
+                  <p:cNvPr id="55" name="Grafik 54">
+                    <a:extLst>
+                      <a:ext uri="{FF2B5EF4-FFF2-40B4-BE49-F238E27FC236}">
+                        <a16:creationId xmlns:a16="http://schemas.microsoft.com/office/drawing/2014/main" id="{BB923A5B-0DCC-6EC9-543A-79CED09BB240}"/>
+                      </a:ext>
+                    </a:extLst>
+                  </p:cNvPr>
+                  <p:cNvPicPr>
+                    <a:picLocks noChangeAspect="1"/>
+                  </p:cNvPicPr>
+                  <p:nvPr/>
+                </p:nvPicPr>
+                <p:blipFill>
+                  <a:blip r:embed="rId7">
+                    <a:extLst>
+                      <a:ext uri="{28A0092B-C50C-407E-A947-70E740481C1C}">
+                        <a14:useLocalDpi xmlns:a14="http://schemas.microsoft.com/office/drawing/2010/main" val="0"/>
+                      </a:ext>
+                    </a:extLst>
+                  </a:blip>
+                  <a:stretch>
+                    <a:fillRect/>
+                  </a:stretch>
+                </p:blipFill>
+                <p:spPr>
+                  <a:xfrm flipH="1">
+                    <a:off x="7540445" y="3566427"/>
+                    <a:ext cx="742950" cy="742950"/>
+                  </a:xfrm>
+                  <a:prstGeom prst="rect">
+                    <a:avLst/>
+                  </a:prstGeom>
+                </p:spPr>
+              </p:pic>
+              <p:pic>
+                <p:nvPicPr>
+                  <p:cNvPr id="5" name="Grafik 4">
+                    <a:extLst>
+                      <a:ext uri="{FF2B5EF4-FFF2-40B4-BE49-F238E27FC236}">
+                        <a16:creationId xmlns:a16="http://schemas.microsoft.com/office/drawing/2014/main" id="{5A5D133E-2F3E-D728-61FD-48C7E29F3614}"/>
+                      </a:ext>
+                    </a:extLst>
+                  </p:cNvPr>
+                  <p:cNvPicPr>
+                    <a:picLocks noChangeAspect="1"/>
+                  </p:cNvPicPr>
+                  <p:nvPr/>
+                </p:nvPicPr>
+                <p:blipFill>
+                  <a:blip r:embed="rId8">
+                    <a:extLst>
+                      <a:ext uri="{28A0092B-C50C-407E-A947-70E740481C1C}">
+                        <a14:useLocalDpi xmlns:a14="http://schemas.microsoft.com/office/drawing/2010/main" val="0"/>
+                      </a:ext>
+                    </a:extLst>
+                  </a:blip>
+                  <a:stretch>
+                    <a:fillRect/>
+                  </a:stretch>
+                </p:blipFill>
+                <p:spPr>
+                  <a:xfrm rot="18757477">
+                    <a:off x="762628" y="2653669"/>
+                    <a:ext cx="1570399" cy="1570399"/>
+                  </a:xfrm>
+                  <a:prstGeom prst="rect">
+                    <a:avLst/>
+                  </a:prstGeom>
+                </p:spPr>
+              </p:pic>
+              <p:sp>
+                <p:nvSpPr>
+                  <p:cNvPr id="4" name="Rechteck 3">
+                    <a:extLst>
+                      <a:ext uri="{FF2B5EF4-FFF2-40B4-BE49-F238E27FC236}">
+                        <a16:creationId xmlns:a16="http://schemas.microsoft.com/office/drawing/2014/main" id="{FF5D6EF1-60CC-73F2-4B3E-569488FA4AC9}"/>
+                      </a:ext>
+                    </a:extLst>
+                  </p:cNvPr>
+                  <p:cNvSpPr/>
+                  <p:nvPr/>
+                </p:nvSpPr>
+                <p:spPr>
+                  <a:xfrm>
+                    <a:off x="3994770" y="2734456"/>
+                    <a:ext cx="888973" cy="1251691"/>
+                  </a:xfrm>
+                  <a:prstGeom prst="rect">
+                    <a:avLst/>
+                  </a:prstGeom>
+                  <a:solidFill>
+                    <a:schemeClr val="bg1"/>
+                  </a:solidFill>
+                  <a:ln>
+                    <a:noFill/>
+                  </a:ln>
+                </p:spPr>
+                <p:style>
+                  <a:lnRef idx="2">
+                    <a:schemeClr val="accent1">
+                      <a:shade val="15000"/>
+                    </a:schemeClr>
+                  </a:lnRef>
+                  <a:fillRef idx="1">
+                    <a:schemeClr val="accent1"/>
+                  </a:fillRef>
+                  <a:effectRef idx="0">
+                    <a:schemeClr val="accent1"/>
+                  </a:effectRef>
+                  <a:fontRef idx="minor">
+                    <a:schemeClr val="lt1"/>
+                  </a:fontRef>
+                </p:style>
+                <p:txBody>
+                  <a:bodyPr rtlCol="0" anchor="ctr"/>
+                  <a:lstStyle/>
+                  <a:p>
+                    <a:pPr algn="ctr"/>
+                    <a:endParaRPr lang="de-DE"/>
+                  </a:p>
+                </p:txBody>
+              </p:sp>
+              <p:sp>
+                <p:nvSpPr>
+                  <p:cNvPr id="15" name="Pfeil: nach links 14">
+                    <a:extLst>
+                      <a:ext uri="{FF2B5EF4-FFF2-40B4-BE49-F238E27FC236}">
+                        <a16:creationId xmlns:a16="http://schemas.microsoft.com/office/drawing/2014/main" id="{2C0A912A-2832-E5FD-10A4-D85EAC1FA583}"/>
+                      </a:ext>
+                    </a:extLst>
+                  </p:cNvPr>
+                  <p:cNvSpPr/>
+                  <p:nvPr/>
+                </p:nvSpPr>
+                <p:spPr>
+                  <a:xfrm rot="10800000">
+                    <a:off x="3880936" y="2973069"/>
+                    <a:ext cx="1233011" cy="645208"/>
+                  </a:xfrm>
+                  <a:prstGeom prst="leftArrow">
+                    <a:avLst/>
+                  </a:prstGeom>
+                  <a:solidFill>
+                    <a:schemeClr val="tx2">
+                      <a:lumMod val="50000"/>
+                      <a:lumOff val="50000"/>
+                    </a:schemeClr>
+                  </a:solidFill>
+                </p:spPr>
+                <p:style>
+                  <a:lnRef idx="2">
+                    <a:schemeClr val="accent1">
+                      <a:shade val="15000"/>
+                    </a:schemeClr>
+                  </a:lnRef>
+                  <a:fillRef idx="1">
+                    <a:schemeClr val="accent1"/>
+                  </a:fillRef>
+                  <a:effectRef idx="0">
+                    <a:schemeClr val="accent1"/>
+                  </a:effectRef>
+                  <a:fontRef idx="minor">
+                    <a:schemeClr val="lt1"/>
+                  </a:fontRef>
+                </p:style>
+                <p:txBody>
+                  <a:bodyPr rtlCol="0" anchor="ctr"/>
+                  <a:lstStyle/>
+                  <a:p>
+                    <a:pPr algn="ctr"/>
+                    <a:endParaRPr lang="de-DE"/>
+                  </a:p>
+                </p:txBody>
+              </p:sp>
+              <p:sp>
+                <p:nvSpPr>
+                  <p:cNvPr id="12" name="Ellipse 11">
+                    <a:extLst>
+                      <a:ext uri="{FF2B5EF4-FFF2-40B4-BE49-F238E27FC236}">
+                        <a16:creationId xmlns:a16="http://schemas.microsoft.com/office/drawing/2014/main" id="{320B11DB-31BD-BD2C-7129-58C150BA617B}"/>
+                      </a:ext>
+                    </a:extLst>
+                  </p:cNvPr>
+                  <p:cNvSpPr/>
+                  <p:nvPr/>
+                </p:nvSpPr>
+                <p:spPr>
+                  <a:xfrm>
+                    <a:off x="2221449" y="2957686"/>
+                    <a:ext cx="1431518" cy="742950"/>
+                  </a:xfrm>
+                  <a:prstGeom prst="ellipse">
+                    <a:avLst/>
+                  </a:prstGeom>
+                  <a:solidFill>
+                    <a:schemeClr val="accent2">
+                      <a:lumMod val="20000"/>
+                      <a:lumOff val="80000"/>
+                    </a:schemeClr>
+                  </a:solidFill>
+                </p:spPr>
+                <p:style>
+                  <a:lnRef idx="2">
+                    <a:schemeClr val="accent1">
+                      <a:shade val="15000"/>
+                    </a:schemeClr>
+                  </a:lnRef>
+                  <a:fillRef idx="1">
+                    <a:schemeClr val="accent1"/>
+                  </a:fillRef>
+                  <a:effectRef idx="0">
+                    <a:schemeClr val="accent1"/>
+                  </a:effectRef>
+                  <a:fontRef idx="minor">
+                    <a:schemeClr val="lt1"/>
+                  </a:fontRef>
+                </p:style>
+                <p:txBody>
+                  <a:bodyPr rtlCol="0" anchor="ctr"/>
+                  <a:lstStyle/>
+                  <a:p>
+                    <a:pPr algn="ctr"/>
+                    <a:r>
+                      <a:rPr lang="de-DE" sz="1600" b="1">
+                        <a:solidFill>
+                          <a:schemeClr val="tx1"/>
+                        </a:solidFill>
+                      </a:rPr>
+                      <a:t>Raw</a:t>
+                    </a:r>
+                  </a:p>
+                </p:txBody>
+              </p:sp>
+              <p:sp>
+                <p:nvSpPr>
+                  <p:cNvPr id="13" name="Ellipse 12">
+                    <a:extLst>
+                      <a:ext uri="{FF2B5EF4-FFF2-40B4-BE49-F238E27FC236}">
+                        <a16:creationId xmlns:a16="http://schemas.microsoft.com/office/drawing/2014/main" id="{CE83A1D4-37AA-E853-263C-980B360DA9B4}"/>
+                      </a:ext>
+                    </a:extLst>
+                  </p:cNvPr>
+                  <p:cNvSpPr/>
+                  <p:nvPr/>
+                </p:nvSpPr>
+                <p:spPr>
+                  <a:xfrm>
+                    <a:off x="2212349" y="3957330"/>
+                    <a:ext cx="1431518" cy="742950"/>
+                  </a:xfrm>
+                  <a:prstGeom prst="ellipse">
+                    <a:avLst/>
+                  </a:prstGeom>
+                  <a:solidFill>
+                    <a:schemeClr val="accent2">
+                      <a:lumMod val="20000"/>
+                      <a:lumOff val="80000"/>
+                    </a:schemeClr>
+                  </a:solidFill>
+                </p:spPr>
+                <p:style>
+                  <a:lnRef idx="2">
+                    <a:schemeClr val="accent1">
+                      <a:shade val="15000"/>
+                    </a:schemeClr>
+                  </a:lnRef>
+                  <a:fillRef idx="1">
+                    <a:schemeClr val="accent1"/>
+                  </a:fillRef>
+                  <a:effectRef idx="0">
+                    <a:schemeClr val="accent1"/>
+                  </a:effectRef>
+                  <a:fontRef idx="minor">
+                    <a:schemeClr val="lt1"/>
+                  </a:fontRef>
+                </p:style>
+                <p:txBody>
+                  <a:bodyPr rtlCol="0" anchor="ctr"/>
+                  <a:lstStyle/>
+                  <a:p>
+                    <a:pPr algn="ctr"/>
+                    <a:r>
+                      <a:rPr lang="de-DE" sz="1600" b="1">
+                        <a:solidFill>
+                          <a:schemeClr val="tx1"/>
+                        </a:solidFill>
+                      </a:rPr>
+                      <a:t>Raw</a:t>
+                    </a:r>
+                  </a:p>
+                </p:txBody>
+              </p:sp>
+            </p:grpSp>
+            <p:sp>
+              <p:nvSpPr>
+                <p:cNvPr id="14" name="Textfeld 13">
+                  <a:extLst>
+                    <a:ext uri="{FF2B5EF4-FFF2-40B4-BE49-F238E27FC236}">
+                      <a16:creationId xmlns:a16="http://schemas.microsoft.com/office/drawing/2014/main" id="{7FF19F27-BFA8-C546-958A-1424C53CCFDB}"/>
+                    </a:ext>
+                  </a:extLst>
+                </p:cNvPr>
+                <p:cNvSpPr txBox="1"/>
+                <p:nvPr/>
+              </p:nvSpPr>
+              <p:spPr>
+                <a:xfrm>
+                  <a:off x="3719527" y="3617084"/>
+                  <a:ext cx="1613711" cy="338554"/>
+                </a:xfrm>
+                <a:prstGeom prst="rect">
+                  <a:avLst/>
+                </a:prstGeom>
+                <a:noFill/>
+              </p:spPr>
+              <p:txBody>
+                <a:bodyPr wrap="none" rtlCol="0">
+                  <a:spAutoFit/>
+                </a:bodyPr>
+                <a:lstStyle/>
+                <a:p>
+                  <a:r>
+                    <a:rPr lang="de-DE" sz="1600"/>
+                    <a:t>„content pump“</a:t>
+                  </a:r>
+                </a:p>
+              </p:txBody>
+            </p:sp>
+            <p:pic>
+              <p:nvPicPr>
+                <p:cNvPr id="16" name="Grafik 15" descr="Türsteher - Kostenlose menschen-Icons">
+                  <a:extLst>
+                    <a:ext uri="{FF2B5EF4-FFF2-40B4-BE49-F238E27FC236}">
+                      <a16:creationId xmlns:a16="http://schemas.microsoft.com/office/drawing/2014/main" id="{A0E9892C-BB23-A46C-35AE-DBE5BE714778}"/>
+                    </a:ext>
+                  </a:extLst>
+                </p:cNvPr>
+                <p:cNvPicPr>
+                  <a:picLocks noChangeAspect="1"/>
+                </p:cNvPicPr>
+                <p:nvPr/>
+              </p:nvPicPr>
+              <p:blipFill>
+                <a:blip r:embed="rId9"/>
+                <a:stretch>
+                  <a:fillRect/>
+                </a:stretch>
+              </p:blipFill>
+              <p:spPr>
+                <a:xfrm>
+                  <a:off x="6947847" y="1055811"/>
+                  <a:ext cx="769441" cy="769441"/>
+                </a:xfrm>
+                <a:prstGeom prst="rect">
+                  <a:avLst/>
+                </a:prstGeom>
+              </p:spPr>
+            </p:pic>
+          </p:grpSp>
+          <p:pic>
+            <p:nvPicPr>
+              <p:cNvPr id="17" name="Grafik 16">
+                <a:extLst>
+                  <a:ext uri="{FF2B5EF4-FFF2-40B4-BE49-F238E27FC236}">
+                    <a16:creationId xmlns:a16="http://schemas.microsoft.com/office/drawing/2014/main" id="{81747E49-5DF4-CEE4-6843-CC98AD34FBB9}"/>
+                  </a:ext>
+                </a:extLst>
+              </p:cNvPr>
+              <p:cNvPicPr>
+                <a:picLocks noChangeAspect="1"/>
+              </p:cNvPicPr>
+              <p:nvPr/>
+            </p:nvPicPr>
+            <p:blipFill>
+              <a:blip r:embed="rId10"/>
+              <a:stretch>
+                <a:fillRect/>
+              </a:stretch>
+            </p:blipFill>
+            <p:spPr>
+              <a:xfrm>
+                <a:off x="11187372" y="1075150"/>
+                <a:ext cx="521713" cy="508589"/>
+              </a:xfrm>
+              <a:prstGeom prst="rect">
+                <a:avLst/>
+              </a:prstGeom>
+            </p:spPr>
+          </p:pic>
+        </p:grpSp>
+        <p:sp>
+          <p:nvSpPr>
+            <p:cNvPr id="26" name="Parallelogramm 25">
               <a:extLst>
                 <a:ext uri="{FF2B5EF4-FFF2-40B4-BE49-F238E27FC236}">
-                  <a16:creationId xmlns:a16="http://schemas.microsoft.com/office/drawing/2014/main" id="{4F1D6A53-778D-D4CA-DF28-B32614F2BC67}"/>
-                </a:ext>
-              </a:extLst>
-            </p:cNvPr>
-            <p:cNvCxnSpPr>
-              <a:cxnSpLocks/>
-            </p:cNvCxnSpPr>
-            <p:nvPr/>
-          </p:nvCxnSpPr>
-          <p:spPr>
-            <a:xfrm>
-              <a:off x="4427643" y="1378047"/>
-              <a:ext cx="34835" cy="4038599"/>
-            </a:xfrm>
-            <a:prstGeom prst="line">
-              <a:avLst/>
-            </a:prstGeom>
-            <a:ln w="28575">
-              <a:prstDash val="sysDash"/>
-            </a:ln>
-          </p:spPr>
-          <p:style>
-            <a:lnRef idx="2">
-              <a:schemeClr val="accent1"/>
-            </a:lnRef>
-            <a:fillRef idx="0">
-              <a:schemeClr val="accent1"/>
-            </a:fillRef>
-            <a:effectRef idx="1">
-              <a:schemeClr val="accent1"/>
-            </a:effectRef>
-            <a:fontRef idx="minor">
-              <a:schemeClr val="tx1"/>
-            </a:fontRef>
-          </p:style>
-        </p:cxnSp>
-        <p:sp>
-          <p:nvSpPr>
-            <p:cNvPr id="7" name="Textfeld 6">
-              <a:extLst>
-                <a:ext uri="{FF2B5EF4-FFF2-40B4-BE49-F238E27FC236}">
-                  <a16:creationId xmlns:a16="http://schemas.microsoft.com/office/drawing/2014/main" id="{7BD7EA1E-C351-FA16-597F-C8904AEE55E8}"/>
-                </a:ext>
-              </a:extLst>
-            </p:cNvPr>
-            <p:cNvSpPr txBox="1"/>
-            <p:nvPr/>
-          </p:nvSpPr>
-          <p:spPr>
-            <a:xfrm>
-              <a:off x="410130" y="996619"/>
-              <a:ext cx="3264676" cy="830997"/>
-            </a:xfrm>
-            <a:prstGeom prst="rect">
-              <a:avLst/>
-            </a:prstGeom>
-            <a:noFill/>
-          </p:spPr>
-          <p:txBody>
-            <a:bodyPr wrap="none" rtlCol="0">
-              <a:spAutoFit/>
-            </a:bodyPr>
-            <a:lstStyle/>
-            <a:p>
-              <a:pPr algn="ctr"/>
-              <a:r>
-                <a:rPr lang="de-DE" sz="2400" b="1">
-                  <a:solidFill>
-                    <a:srgbClr val="002060"/>
-                  </a:solidFill>
-                </a:rPr>
-                <a:t>„speedboat-lane“ </a:t>
-              </a:r>
-            </a:p>
-            <a:p>
-              <a:pPr algn="ctr"/>
-              <a:r>
-                <a:rPr lang="de-DE" sz="2400">
-                  <a:solidFill>
-                    <a:srgbClr val="002060"/>
-                  </a:solidFill>
-                </a:rPr>
-                <a:t>(ckluth/haevg - GitHub)</a:t>
-              </a:r>
-            </a:p>
-          </p:txBody>
-        </p:sp>
-        <p:sp>
-          <p:nvSpPr>
-            <p:cNvPr id="8" name="Textfeld 7">
-              <a:extLst>
-                <a:ext uri="{FF2B5EF4-FFF2-40B4-BE49-F238E27FC236}">
-                  <a16:creationId xmlns:a16="http://schemas.microsoft.com/office/drawing/2014/main" id="{F48A6FD9-47FD-C5EB-4F97-78E97694F368}"/>
-                </a:ext>
-              </a:extLst>
-            </p:cNvPr>
-            <p:cNvSpPr txBox="1"/>
-            <p:nvPr/>
-          </p:nvSpPr>
-          <p:spPr>
-            <a:xfrm>
-              <a:off x="8143751" y="1012888"/>
-              <a:ext cx="2948371" cy="461665"/>
-            </a:xfrm>
-            <a:prstGeom prst="rect">
-              <a:avLst/>
-            </a:prstGeom>
-            <a:noFill/>
-          </p:spPr>
-          <p:txBody>
-            <a:bodyPr wrap="none" rtlCol="0">
-              <a:spAutoFit/>
-            </a:bodyPr>
-            <a:lstStyle/>
-            <a:p>
-              <a:r>
-                <a:rPr lang="de-DE" sz="2400" b="1">
-                  <a:solidFill>
-                    <a:schemeClr val="accent6">
-                      <a:lumMod val="50000"/>
-                    </a:schemeClr>
-                  </a:solidFill>
-                </a:rPr>
-                <a:t>HÄVG-SWE-Domain</a:t>
-              </a:r>
-            </a:p>
-          </p:txBody>
-        </p:sp>
-        <p:sp>
-          <p:nvSpPr>
-            <p:cNvPr id="9" name="Textfeld 8">
-              <a:extLst>
-                <a:ext uri="{FF2B5EF4-FFF2-40B4-BE49-F238E27FC236}">
-                  <a16:creationId xmlns:a16="http://schemas.microsoft.com/office/drawing/2014/main" id="{9D900BFE-C88A-3A8A-B9AB-D4E4F9F8A368}"/>
-                </a:ext>
-              </a:extLst>
-            </p:cNvPr>
-            <p:cNvSpPr txBox="1"/>
-            <p:nvPr/>
-          </p:nvSpPr>
-          <p:spPr>
-            <a:xfrm>
-              <a:off x="4963072" y="1012888"/>
-              <a:ext cx="2227918" cy="461665"/>
-            </a:xfrm>
-            <a:prstGeom prst="rect">
-              <a:avLst/>
-            </a:prstGeom>
-            <a:noFill/>
-          </p:spPr>
-          <p:txBody>
-            <a:bodyPr wrap="none" rtlCol="0">
-              <a:spAutoFit/>
-            </a:bodyPr>
-            <a:lstStyle/>
-            <a:p>
-              <a:r>
-                <a:rPr lang="de-DE" sz="2400" b="1">
-                  <a:solidFill>
-                    <a:srgbClr val="0070C0"/>
-                  </a:solidFill>
-                </a:rPr>
-                <a:t>„staging-pipe“</a:t>
-              </a:r>
-            </a:p>
-          </p:txBody>
-        </p:sp>
-        <p:sp>
-          <p:nvSpPr>
-            <p:cNvPr id="19" name="Ellipse 18">
-              <a:extLst>
-                <a:ext uri="{FF2B5EF4-FFF2-40B4-BE49-F238E27FC236}">
-                  <a16:creationId xmlns:a16="http://schemas.microsoft.com/office/drawing/2014/main" id="{39258206-4131-12A3-660F-17B889C6B58A}"/>
+                  <a16:creationId xmlns:a16="http://schemas.microsoft.com/office/drawing/2014/main" id="{254F0ACF-941E-D493-7F91-719AA052FE63}"/>
                 </a:ext>
               </a:extLst>
             </p:cNvPr>
@@ -15250,414 +16491,19 @@
           </p:nvSpPr>
           <p:spPr>
             <a:xfrm>
-              <a:off x="5283779" y="3035621"/>
-              <a:ext cx="1507308" cy="742950"/>
+              <a:off x="3986969" y="3233773"/>
+              <a:ext cx="395757" cy="303348"/>
             </a:xfrm>
-            <a:prstGeom prst="ellipse">
-              <a:avLst/>
+            <a:prstGeom prst="parallelogram">
+              <a:avLst>
+                <a:gd name="adj" fmla="val 82983"/>
+              </a:avLst>
             </a:prstGeom>
             <a:solidFill>
-              <a:schemeClr val="tx2">
-                <a:lumMod val="50000"/>
-                <a:lumOff val="50000"/>
+              <a:schemeClr val="accent2">
+                <a:lumMod val="20000"/>
+                <a:lumOff val="80000"/>
               </a:schemeClr>
-            </a:solidFill>
-          </p:spPr>
-          <p:style>
-            <a:lnRef idx="2">
-              <a:schemeClr val="accent1">
-                <a:shade val="15000"/>
-              </a:schemeClr>
-            </a:lnRef>
-            <a:fillRef idx="1">
-              <a:schemeClr val="accent1"/>
-            </a:fillRef>
-            <a:effectRef idx="0">
-              <a:schemeClr val="accent1"/>
-            </a:effectRef>
-            <a:fontRef idx="minor">
-              <a:schemeClr val="lt1"/>
-            </a:fontRef>
-          </p:style>
-          <p:txBody>
-            <a:bodyPr rtlCol="0" anchor="ctr"/>
-            <a:lstStyle/>
-            <a:p>
-              <a:pPr algn="ctr"/>
-              <a:r>
-                <a:rPr lang="de-DE" sz="1600" b="1"/>
-                <a:t>Proposal</a:t>
-              </a:r>
-            </a:p>
-          </p:txBody>
-        </p:sp>
-        <p:sp>
-          <p:nvSpPr>
-            <p:cNvPr id="20" name="Ellipse 19">
-              <a:extLst>
-                <a:ext uri="{FF2B5EF4-FFF2-40B4-BE49-F238E27FC236}">
-                  <a16:creationId xmlns:a16="http://schemas.microsoft.com/office/drawing/2014/main" id="{71B297BD-EB29-7936-AFE6-4B0B3CCC06CA}"/>
-                </a:ext>
-              </a:extLst>
-            </p:cNvPr>
-            <p:cNvSpPr/>
-            <p:nvPr/>
-          </p:nvSpPr>
-          <p:spPr>
-            <a:xfrm>
-              <a:off x="5298361" y="4065689"/>
-              <a:ext cx="1507308" cy="742950"/>
-            </a:xfrm>
-            <a:prstGeom prst="ellipse">
-              <a:avLst/>
-            </a:prstGeom>
-            <a:solidFill>
-              <a:schemeClr val="tx2">
-                <a:lumMod val="50000"/>
-                <a:lumOff val="50000"/>
-              </a:schemeClr>
-            </a:solidFill>
-          </p:spPr>
-          <p:style>
-            <a:lnRef idx="2">
-              <a:schemeClr val="accent1">
-                <a:shade val="15000"/>
-              </a:schemeClr>
-            </a:lnRef>
-            <a:fillRef idx="1">
-              <a:schemeClr val="accent1"/>
-            </a:fillRef>
-            <a:effectRef idx="0">
-              <a:schemeClr val="accent1"/>
-            </a:effectRef>
-            <a:fontRef idx="minor">
-              <a:schemeClr val="lt1"/>
-            </a:fontRef>
-          </p:style>
-          <p:txBody>
-            <a:bodyPr rtlCol="0" anchor="ctr"/>
-            <a:lstStyle/>
-            <a:p>
-              <a:pPr algn="ctr"/>
-              <a:r>
-                <a:rPr lang="de-DE" sz="1600" b="1"/>
-                <a:t>Proposal</a:t>
-              </a:r>
-            </a:p>
-          </p:txBody>
-        </p:sp>
-        <p:sp>
-          <p:nvSpPr>
-            <p:cNvPr id="21" name="Ellipse 20">
-              <a:extLst>
-                <a:ext uri="{FF2B5EF4-FFF2-40B4-BE49-F238E27FC236}">
-                  <a16:creationId xmlns:a16="http://schemas.microsoft.com/office/drawing/2014/main" id="{90575A8D-8C72-B615-A545-E12FE53533E5}"/>
-                </a:ext>
-              </a:extLst>
-            </p:cNvPr>
-            <p:cNvSpPr/>
-            <p:nvPr/>
-          </p:nvSpPr>
-          <p:spPr>
-            <a:xfrm>
-              <a:off x="5283779" y="1991506"/>
-              <a:ext cx="1507308" cy="742950"/>
-            </a:xfrm>
-            <a:prstGeom prst="ellipse">
-              <a:avLst/>
-            </a:prstGeom>
-            <a:solidFill>
-              <a:schemeClr val="tx2">
-                <a:lumMod val="50000"/>
-                <a:lumOff val="50000"/>
-              </a:schemeClr>
-            </a:solidFill>
-          </p:spPr>
-          <p:style>
-            <a:lnRef idx="2">
-              <a:schemeClr val="accent1">
-                <a:shade val="15000"/>
-              </a:schemeClr>
-            </a:lnRef>
-            <a:fillRef idx="1">
-              <a:schemeClr val="accent1"/>
-            </a:fillRef>
-            <a:effectRef idx="0">
-              <a:schemeClr val="accent1"/>
-            </a:effectRef>
-            <a:fontRef idx="minor">
-              <a:schemeClr val="lt1"/>
-            </a:fontRef>
-          </p:style>
-          <p:txBody>
-            <a:bodyPr rtlCol="0" anchor="ctr"/>
-            <a:lstStyle/>
-            <a:p>
-              <a:pPr algn="ctr"/>
-              <a:r>
-                <a:rPr lang="de-DE" sz="1600" b="1"/>
-                <a:t>Proposal</a:t>
-              </a:r>
-            </a:p>
-          </p:txBody>
-        </p:sp>
-        <p:sp>
-          <p:nvSpPr>
-            <p:cNvPr id="22" name="Ellipse 21">
-              <a:extLst>
-                <a:ext uri="{FF2B5EF4-FFF2-40B4-BE49-F238E27FC236}">
-                  <a16:creationId xmlns:a16="http://schemas.microsoft.com/office/drawing/2014/main" id="{2063DA56-F4AD-AC48-CCFA-10F491C2F167}"/>
-                </a:ext>
-              </a:extLst>
-            </p:cNvPr>
-            <p:cNvSpPr/>
-            <p:nvPr/>
-          </p:nvSpPr>
-          <p:spPr>
-            <a:xfrm>
-              <a:off x="8806465" y="1912429"/>
-              <a:ext cx="1507308" cy="742950"/>
-            </a:xfrm>
-            <a:prstGeom prst="ellipse">
-              <a:avLst/>
-            </a:prstGeom>
-            <a:solidFill>
-              <a:srgbClr val="00B050"/>
-            </a:solidFill>
-          </p:spPr>
-          <p:style>
-            <a:lnRef idx="2">
-              <a:schemeClr val="accent1">
-                <a:shade val="15000"/>
-              </a:schemeClr>
-            </a:lnRef>
-            <a:fillRef idx="1">
-              <a:schemeClr val="accent1"/>
-            </a:fillRef>
-            <a:effectRef idx="0">
-              <a:schemeClr val="accent1"/>
-            </a:effectRef>
-            <a:fontRef idx="minor">
-              <a:schemeClr val="lt1"/>
-            </a:fontRef>
-          </p:style>
-          <p:txBody>
-            <a:bodyPr rtlCol="0" anchor="ctr"/>
-            <a:lstStyle/>
-            <a:p>
-              <a:pPr algn="ctr"/>
-              <a:r>
-                <a:rPr lang="de-DE" sz="1600" b="1"/>
-                <a:t>Decision</a:t>
-              </a:r>
-            </a:p>
-          </p:txBody>
-        </p:sp>
-        <p:sp>
-          <p:nvSpPr>
-            <p:cNvPr id="23" name="Ellipse 22">
-              <a:extLst>
-                <a:ext uri="{FF2B5EF4-FFF2-40B4-BE49-F238E27FC236}">
-                  <a16:creationId xmlns:a16="http://schemas.microsoft.com/office/drawing/2014/main" id="{6BCAFD35-9659-BAB9-4F1B-2ACD5A03309D}"/>
-                </a:ext>
-              </a:extLst>
-            </p:cNvPr>
-            <p:cNvSpPr/>
-            <p:nvPr/>
-          </p:nvSpPr>
-          <p:spPr>
-            <a:xfrm>
-              <a:off x="8806465" y="3062454"/>
-              <a:ext cx="1507308" cy="742950"/>
-            </a:xfrm>
-            <a:prstGeom prst="ellipse">
-              <a:avLst/>
-            </a:prstGeom>
-            <a:solidFill>
-              <a:srgbClr val="00B050"/>
-            </a:solidFill>
-          </p:spPr>
-          <p:style>
-            <a:lnRef idx="2">
-              <a:schemeClr val="accent1">
-                <a:shade val="15000"/>
-              </a:schemeClr>
-            </a:lnRef>
-            <a:fillRef idx="1">
-              <a:schemeClr val="accent1"/>
-            </a:fillRef>
-            <a:effectRef idx="0">
-              <a:schemeClr val="accent1"/>
-            </a:effectRef>
-            <a:fontRef idx="minor">
-              <a:schemeClr val="lt1"/>
-            </a:fontRef>
-          </p:style>
-          <p:txBody>
-            <a:bodyPr rtlCol="0" anchor="ctr"/>
-            <a:lstStyle/>
-            <a:p>
-              <a:pPr algn="ctr"/>
-              <a:r>
-                <a:rPr lang="de-DE" sz="1600" b="1"/>
-                <a:t>Decision</a:t>
-              </a:r>
-            </a:p>
-          </p:txBody>
-        </p:sp>
-        <p:sp>
-          <p:nvSpPr>
-            <p:cNvPr id="24" name="Ellipse 23">
-              <a:extLst>
-                <a:ext uri="{FF2B5EF4-FFF2-40B4-BE49-F238E27FC236}">
-                  <a16:creationId xmlns:a16="http://schemas.microsoft.com/office/drawing/2014/main" id="{57C1F23F-BCC7-4F6C-01C3-846DEC0EFEC0}"/>
-                </a:ext>
-              </a:extLst>
-            </p:cNvPr>
-            <p:cNvSpPr/>
-            <p:nvPr/>
-          </p:nvSpPr>
-          <p:spPr>
-            <a:xfrm>
-              <a:off x="8786282" y="4176879"/>
-              <a:ext cx="1507308" cy="742950"/>
-            </a:xfrm>
-            <a:prstGeom prst="ellipse">
-              <a:avLst/>
-            </a:prstGeom>
-            <a:solidFill>
-              <a:srgbClr val="00B050"/>
-            </a:solidFill>
-          </p:spPr>
-          <p:style>
-            <a:lnRef idx="2">
-              <a:schemeClr val="accent1">
-                <a:shade val="15000"/>
-              </a:schemeClr>
-            </a:lnRef>
-            <a:fillRef idx="1">
-              <a:schemeClr val="accent1"/>
-            </a:fillRef>
-            <a:effectRef idx="0">
-              <a:schemeClr val="accent1"/>
-            </a:effectRef>
-            <a:fontRef idx="minor">
-              <a:schemeClr val="lt1"/>
-            </a:fontRef>
-          </p:style>
-          <p:txBody>
-            <a:bodyPr rtlCol="0" anchor="ctr"/>
-            <a:lstStyle/>
-            <a:p>
-              <a:pPr algn="ctr"/>
-              <a:r>
-                <a:rPr lang="de-DE" sz="1600" b="1"/>
-                <a:t>Decision</a:t>
-              </a:r>
-            </a:p>
-          </p:txBody>
-        </p:sp>
-        <p:pic>
-          <p:nvPicPr>
-            <p:cNvPr id="29" name="Grafik 28">
-              <a:extLst>
-                <a:ext uri="{FF2B5EF4-FFF2-40B4-BE49-F238E27FC236}">
-                  <a16:creationId xmlns:a16="http://schemas.microsoft.com/office/drawing/2014/main" id="{FD624151-C93A-C1A6-942A-96A2AF69FF0B}"/>
-                </a:ext>
-              </a:extLst>
-            </p:cNvPr>
-            <p:cNvPicPr>
-              <a:picLocks noChangeAspect="1"/>
-            </p:cNvPicPr>
-            <p:nvPr/>
-          </p:nvPicPr>
-          <p:blipFill>
-            <a:blip r:embed="rId5">
-              <a:extLst>
-                <a:ext uri="{28A0092B-C50C-407E-A947-70E740481C1C}">
-                  <a14:useLocalDpi xmlns:a14="http://schemas.microsoft.com/office/drawing/2010/main" val="0"/>
-                </a:ext>
-              </a:extLst>
-            </a:blip>
-            <a:stretch>
-              <a:fillRect/>
-            </a:stretch>
-          </p:blipFill>
-          <p:spPr>
-            <a:xfrm>
-              <a:off x="5631976" y="5750805"/>
-              <a:ext cx="953091" cy="953091"/>
-            </a:xfrm>
-            <a:prstGeom prst="rect">
-              <a:avLst/>
-            </a:prstGeom>
-          </p:spPr>
-        </p:pic>
-        <p:cxnSp>
-          <p:nvCxnSpPr>
-            <p:cNvPr id="33" name="Gerader Verbinder 32">
-              <a:extLst>
-                <a:ext uri="{FF2B5EF4-FFF2-40B4-BE49-F238E27FC236}">
-                  <a16:creationId xmlns:a16="http://schemas.microsoft.com/office/drawing/2014/main" id="{2D9EE726-1AF9-8340-FED4-B3EFF74430DA}"/>
-                </a:ext>
-              </a:extLst>
-            </p:cNvPr>
-            <p:cNvCxnSpPr>
-              <a:cxnSpLocks/>
-            </p:cNvCxnSpPr>
-            <p:nvPr/>
-          </p:nvCxnSpPr>
-          <p:spPr>
-            <a:xfrm>
-              <a:off x="7870828" y="1330703"/>
-              <a:ext cx="18730" cy="4038599"/>
-            </a:xfrm>
-            <a:prstGeom prst="line">
-              <a:avLst/>
-            </a:prstGeom>
-            <a:ln w="76200">
-              <a:solidFill>
-                <a:srgbClr val="FF0000"/>
-              </a:solidFill>
-            </a:ln>
-          </p:spPr>
-          <p:style>
-            <a:lnRef idx="2">
-              <a:schemeClr val="accent1"/>
-            </a:lnRef>
-            <a:fillRef idx="0">
-              <a:schemeClr val="accent1"/>
-            </a:fillRef>
-            <a:effectRef idx="1">
-              <a:schemeClr val="accent1"/>
-            </a:effectRef>
-            <a:fontRef idx="minor">
-              <a:schemeClr val="tx1"/>
-            </a:fontRef>
-          </p:style>
-        </p:cxnSp>
-        <p:sp>
-          <p:nvSpPr>
-            <p:cNvPr id="36" name="Rechteck 35">
-              <a:extLst>
-                <a:ext uri="{FF2B5EF4-FFF2-40B4-BE49-F238E27FC236}">
-                  <a16:creationId xmlns:a16="http://schemas.microsoft.com/office/drawing/2014/main" id="{952CADCB-1CB0-F1CA-741C-CB151AC44414}"/>
-                </a:ext>
-              </a:extLst>
-            </p:cNvPr>
-            <p:cNvSpPr/>
-            <p:nvPr/>
-          </p:nvSpPr>
-          <p:spPr>
-            <a:xfrm>
-              <a:off x="7461549" y="2590503"/>
-              <a:ext cx="888973" cy="1590105"/>
-            </a:xfrm>
-            <a:prstGeom prst="rect">
-              <a:avLst/>
-            </a:prstGeom>
-            <a:solidFill>
-              <a:schemeClr val="bg1"/>
             </a:solidFill>
             <a:ln>
               <a:noFill/>
@@ -15690,221 +16536,10 @@
         </p:sp>
         <p:sp>
           <p:nvSpPr>
-            <p:cNvPr id="27" name="Pfeil: nach links 26">
+            <p:cNvPr id="28" name="Parallelogramm 27">
               <a:extLst>
                 <a:ext uri="{FF2B5EF4-FFF2-40B4-BE49-F238E27FC236}">
-                  <a16:creationId xmlns:a16="http://schemas.microsoft.com/office/drawing/2014/main" id="{D78CB09B-750F-9588-B243-6B065C35AC72}"/>
-                </a:ext>
-              </a:extLst>
-            </p:cNvPr>
-            <p:cNvSpPr/>
-            <p:nvPr/>
-          </p:nvSpPr>
-          <p:spPr>
-            <a:xfrm rot="10800000">
-              <a:off x="7396254" y="3106178"/>
-              <a:ext cx="1131789" cy="392399"/>
-            </a:xfrm>
-            <a:prstGeom prst="leftArrow">
-              <a:avLst/>
-            </a:prstGeom>
-            <a:solidFill>
-              <a:schemeClr val="accent6"/>
-            </a:solidFill>
-          </p:spPr>
-          <p:style>
-            <a:lnRef idx="2">
-              <a:schemeClr val="accent1">
-                <a:shade val="15000"/>
-              </a:schemeClr>
-            </a:lnRef>
-            <a:fillRef idx="1">
-              <a:schemeClr val="accent1"/>
-            </a:fillRef>
-            <a:effectRef idx="0">
-              <a:schemeClr val="accent1"/>
-            </a:effectRef>
-            <a:fontRef idx="minor">
-              <a:schemeClr val="lt1"/>
-            </a:fontRef>
-          </p:style>
-          <p:txBody>
-            <a:bodyPr rtlCol="0" anchor="ctr"/>
-            <a:lstStyle/>
-            <a:p>
-              <a:pPr algn="ctr"/>
-              <a:endParaRPr lang="de-DE"/>
-            </a:p>
-          </p:txBody>
-        </p:sp>
-        <p:pic>
-          <p:nvPicPr>
-            <p:cNvPr id="37" name="Grafik 36">
-              <a:extLst>
-                <a:ext uri="{FF2B5EF4-FFF2-40B4-BE49-F238E27FC236}">
-                  <a16:creationId xmlns:a16="http://schemas.microsoft.com/office/drawing/2014/main" id="{B265D967-E0F6-75E0-AD93-28D8EEA4501F}"/>
-                </a:ext>
-              </a:extLst>
-            </p:cNvPr>
-            <p:cNvPicPr>
-              <a:picLocks noChangeAspect="1"/>
-            </p:cNvPicPr>
-            <p:nvPr/>
-          </p:nvPicPr>
-          <p:blipFill>
-            <a:blip r:embed="rId6">
-              <a:extLst>
-                <a:ext uri="{28A0092B-C50C-407E-A947-70E740481C1C}">
-                  <a14:useLocalDpi xmlns:a14="http://schemas.microsoft.com/office/drawing/2010/main" val="0"/>
-                </a:ext>
-              </a:extLst>
-            </a:blip>
-            <a:stretch>
-              <a:fillRect/>
-            </a:stretch>
-          </p:blipFill>
-          <p:spPr>
-            <a:xfrm>
-              <a:off x="7616635" y="2518542"/>
-              <a:ext cx="660908" cy="660908"/>
-            </a:xfrm>
-            <a:prstGeom prst="rect">
-              <a:avLst/>
-            </a:prstGeom>
-          </p:spPr>
-        </p:pic>
-        <p:pic>
-          <p:nvPicPr>
-            <p:cNvPr id="40" name="Grafik 39">
-              <a:extLst>
-                <a:ext uri="{FF2B5EF4-FFF2-40B4-BE49-F238E27FC236}">
-                  <a16:creationId xmlns:a16="http://schemas.microsoft.com/office/drawing/2014/main" id="{606A1F1B-FF16-5FB9-1B7C-71990D18D2B6}"/>
-                </a:ext>
-              </a:extLst>
-            </p:cNvPr>
-            <p:cNvPicPr>
-              <a:picLocks noChangeAspect="1"/>
-            </p:cNvPicPr>
-            <p:nvPr/>
-          </p:nvPicPr>
-          <p:blipFill>
-            <a:blip r:embed="rId7">
-              <a:extLst>
-                <a:ext uri="{28A0092B-C50C-407E-A947-70E740481C1C}">
-                  <a14:useLocalDpi xmlns:a14="http://schemas.microsoft.com/office/drawing/2010/main" val="0"/>
-                </a:ext>
-              </a:extLst>
-            </a:blip>
-            <a:stretch>
-              <a:fillRect/>
-            </a:stretch>
-          </p:blipFill>
-          <p:spPr>
-            <a:xfrm flipH="1">
-              <a:off x="7509541" y="3243197"/>
-              <a:ext cx="742950" cy="742950"/>
-            </a:xfrm>
-            <a:prstGeom prst="rect">
-              <a:avLst/>
-            </a:prstGeom>
-          </p:spPr>
-        </p:pic>
-        <p:cxnSp>
-          <p:nvCxnSpPr>
-            <p:cNvPr id="46" name="Gerader Verbinder 45">
-              <a:extLst>
-                <a:ext uri="{FF2B5EF4-FFF2-40B4-BE49-F238E27FC236}">
-                  <a16:creationId xmlns:a16="http://schemas.microsoft.com/office/drawing/2014/main" id="{76BD3CD9-1AA6-01F6-ECFD-1B3E54261B80}"/>
-                </a:ext>
-              </a:extLst>
-            </p:cNvPr>
-            <p:cNvCxnSpPr>
-              <a:cxnSpLocks/>
-            </p:cNvCxnSpPr>
-            <p:nvPr/>
-          </p:nvCxnSpPr>
-          <p:spPr>
-            <a:xfrm>
-              <a:off x="5005036" y="5386421"/>
-              <a:ext cx="2245072" cy="0"/>
-            </a:xfrm>
-            <a:prstGeom prst="line">
-              <a:avLst/>
-            </a:prstGeom>
-            <a:ln w="28575">
-              <a:prstDash val="sysDash"/>
-            </a:ln>
-          </p:spPr>
-          <p:style>
-            <a:lnRef idx="2">
-              <a:schemeClr val="accent1"/>
-            </a:lnRef>
-            <a:fillRef idx="0">
-              <a:schemeClr val="accent1"/>
-            </a:fillRef>
-            <a:effectRef idx="1">
-              <a:schemeClr val="accent1"/>
-            </a:effectRef>
-            <a:fontRef idx="minor">
-              <a:schemeClr val="tx1"/>
-            </a:fontRef>
-          </p:style>
-        </p:cxnSp>
-        <p:sp>
-          <p:nvSpPr>
-            <p:cNvPr id="30" name="Pfeil: nach links 29">
-              <a:extLst>
-                <a:ext uri="{FF2B5EF4-FFF2-40B4-BE49-F238E27FC236}">
-                  <a16:creationId xmlns:a16="http://schemas.microsoft.com/office/drawing/2014/main" id="{23F6AB9C-6C3F-7896-F149-587F6EA65541}"/>
-                </a:ext>
-              </a:extLst>
-            </p:cNvPr>
-            <p:cNvSpPr/>
-            <p:nvPr/>
-          </p:nvSpPr>
-          <p:spPr>
-            <a:xfrm rot="16200000">
-              <a:off x="5701910" y="5135504"/>
-              <a:ext cx="742952" cy="392399"/>
-            </a:xfrm>
-            <a:prstGeom prst="leftArrow">
-              <a:avLst/>
-            </a:prstGeom>
-            <a:solidFill>
-              <a:srgbClr val="FF0000"/>
-            </a:solidFill>
-          </p:spPr>
-          <p:style>
-            <a:lnRef idx="2">
-              <a:schemeClr val="accent1">
-                <a:shade val="15000"/>
-              </a:schemeClr>
-            </a:lnRef>
-            <a:fillRef idx="1">
-              <a:schemeClr val="accent1"/>
-            </a:fillRef>
-            <a:effectRef idx="0">
-              <a:schemeClr val="accent1"/>
-            </a:effectRef>
-            <a:fontRef idx="minor">
-              <a:schemeClr val="lt1"/>
-            </a:fontRef>
-          </p:style>
-          <p:txBody>
-            <a:bodyPr rtlCol="0" anchor="ctr"/>
-            <a:lstStyle/>
-            <a:p>
-              <a:pPr algn="ctr"/>
-              <a:endParaRPr lang="de-DE"/>
-            </a:p>
-          </p:txBody>
-        </p:sp>
-        <p:sp>
-          <p:nvSpPr>
-            <p:cNvPr id="53" name="Ellipse 52">
-              <a:extLst>
-                <a:ext uri="{FF2B5EF4-FFF2-40B4-BE49-F238E27FC236}">
-                  <a16:creationId xmlns:a16="http://schemas.microsoft.com/office/drawing/2014/main" id="{4CE273E4-DACC-18FE-B1F2-F22205DF295C}"/>
+                  <a16:creationId xmlns:a16="http://schemas.microsoft.com/office/drawing/2014/main" id="{361AE975-8A63-E643-94C0-A5D03257DDDF}"/>
                 </a:ext>
               </a:extLst>
             </p:cNvPr>
@@ -15913,177 +16548,19 @@
           </p:nvSpPr>
           <p:spPr>
             <a:xfrm>
-              <a:off x="2280797" y="2988826"/>
-              <a:ext cx="1240011" cy="742950"/>
+              <a:off x="4186998" y="3229002"/>
+              <a:ext cx="395757" cy="303348"/>
             </a:xfrm>
-            <a:prstGeom prst="ellipse">
-              <a:avLst/>
+            <a:prstGeom prst="parallelogram">
+              <a:avLst>
+                <a:gd name="adj" fmla="val 82983"/>
+              </a:avLst>
             </a:prstGeom>
             <a:solidFill>
-              <a:schemeClr val="tx2">
-                <a:lumMod val="50000"/>
-                <a:lumOff val="50000"/>
+              <a:schemeClr val="accent2">
+                <a:lumMod val="20000"/>
+                <a:lumOff val="80000"/>
               </a:schemeClr>
-            </a:solidFill>
-          </p:spPr>
-          <p:style>
-            <a:lnRef idx="2">
-              <a:schemeClr val="accent1">
-                <a:shade val="15000"/>
-              </a:schemeClr>
-            </a:lnRef>
-            <a:fillRef idx="1">
-              <a:schemeClr val="accent1"/>
-            </a:fillRef>
-            <a:effectRef idx="0">
-              <a:schemeClr val="accent1"/>
-            </a:effectRef>
-            <a:fontRef idx="minor">
-              <a:schemeClr val="lt1"/>
-            </a:fontRef>
-          </p:style>
-          <p:txBody>
-            <a:bodyPr rtlCol="0" anchor="ctr"/>
-            <a:lstStyle/>
-            <a:p>
-              <a:pPr algn="ctr"/>
-              <a:r>
-                <a:rPr lang="de-DE" sz="1600" b="1"/>
-                <a:t>Raw</a:t>
-              </a:r>
-            </a:p>
-          </p:txBody>
-        </p:sp>
-        <p:pic>
-          <p:nvPicPr>
-            <p:cNvPr id="54" name="Grafik 53">
-              <a:extLst>
-                <a:ext uri="{FF2B5EF4-FFF2-40B4-BE49-F238E27FC236}">
-                  <a16:creationId xmlns:a16="http://schemas.microsoft.com/office/drawing/2014/main" id="{F4B67388-3290-E097-0F90-89890F15656E}"/>
-                </a:ext>
-              </a:extLst>
-            </p:cNvPr>
-            <p:cNvPicPr>
-              <a:picLocks noChangeAspect="1"/>
-            </p:cNvPicPr>
-            <p:nvPr/>
-          </p:nvPicPr>
-          <p:blipFill>
-            <a:blip r:embed="rId7">
-              <a:extLst>
-                <a:ext uri="{28A0092B-C50C-407E-A947-70E740481C1C}">
-                  <a14:useLocalDpi xmlns:a14="http://schemas.microsoft.com/office/drawing/2010/main" val="0"/>
-                </a:ext>
-              </a:extLst>
-            </a:blip>
-            <a:stretch>
-              <a:fillRect/>
-            </a:stretch>
-          </p:blipFill>
-          <p:spPr>
-            <a:xfrm flipH="1">
-              <a:off x="5139109" y="4787658"/>
-              <a:ext cx="742950" cy="742950"/>
-            </a:xfrm>
-            <a:prstGeom prst="rect">
-              <a:avLst/>
-            </a:prstGeom>
-          </p:spPr>
-        </p:pic>
-        <p:pic>
-          <p:nvPicPr>
-            <p:cNvPr id="55" name="Grafik 54">
-              <a:extLst>
-                <a:ext uri="{FF2B5EF4-FFF2-40B4-BE49-F238E27FC236}">
-                  <a16:creationId xmlns:a16="http://schemas.microsoft.com/office/drawing/2014/main" id="{BB923A5B-0DCC-6EC9-543A-79CED09BB240}"/>
-                </a:ext>
-              </a:extLst>
-            </p:cNvPr>
-            <p:cNvPicPr>
-              <a:picLocks noChangeAspect="1"/>
-            </p:cNvPicPr>
-            <p:nvPr/>
-          </p:nvPicPr>
-          <p:blipFill>
-            <a:blip r:embed="rId7">
-              <a:extLst>
-                <a:ext uri="{28A0092B-C50C-407E-A947-70E740481C1C}">
-                  <a14:useLocalDpi xmlns:a14="http://schemas.microsoft.com/office/drawing/2010/main" val="0"/>
-                </a:ext>
-              </a:extLst>
-            </a:blip>
-            <a:stretch>
-              <a:fillRect/>
-            </a:stretch>
-          </p:blipFill>
-          <p:spPr>
-            <a:xfrm flipH="1">
-              <a:off x="7540445" y="3566427"/>
-              <a:ext cx="742950" cy="742950"/>
-            </a:xfrm>
-            <a:prstGeom prst="rect">
-              <a:avLst/>
-            </a:prstGeom>
-          </p:spPr>
-        </p:pic>
-        <p:pic>
-          <p:nvPicPr>
-            <p:cNvPr id="5" name="Grafik 4">
-              <a:extLst>
-                <a:ext uri="{FF2B5EF4-FFF2-40B4-BE49-F238E27FC236}">
-                  <a16:creationId xmlns:a16="http://schemas.microsoft.com/office/drawing/2014/main" id="{5A5D133E-2F3E-D728-61FD-48C7E29F3614}"/>
-                </a:ext>
-              </a:extLst>
-            </p:cNvPr>
-            <p:cNvPicPr>
-              <a:picLocks noChangeAspect="1"/>
-            </p:cNvPicPr>
-            <p:nvPr/>
-          </p:nvPicPr>
-          <p:blipFill>
-            <a:blip r:embed="rId8">
-              <a:extLst>
-                <a:ext uri="{28A0092B-C50C-407E-A947-70E740481C1C}">
-                  <a14:useLocalDpi xmlns:a14="http://schemas.microsoft.com/office/drawing/2010/main" val="0"/>
-                </a:ext>
-              </a:extLst>
-            </a:blip>
-            <a:stretch>
-              <a:fillRect/>
-            </a:stretch>
-          </p:blipFill>
-          <p:spPr>
-            <a:xfrm rot="18757477">
-              <a:off x="946418" y="2829472"/>
-              <a:ext cx="1570399" cy="1570399"/>
-            </a:xfrm>
-            <a:prstGeom prst="rect">
-              <a:avLst/>
-            </a:prstGeom>
-          </p:spPr>
-        </p:pic>
-        <p:sp>
-          <p:nvSpPr>
-            <p:cNvPr id="4" name="Rechteck 3">
-              <a:extLst>
-                <a:ext uri="{FF2B5EF4-FFF2-40B4-BE49-F238E27FC236}">
-                  <a16:creationId xmlns:a16="http://schemas.microsoft.com/office/drawing/2014/main" id="{FF5D6EF1-60CC-73F2-4B3E-569488FA4AC9}"/>
-                </a:ext>
-              </a:extLst>
-            </p:cNvPr>
-            <p:cNvSpPr/>
-            <p:nvPr/>
-          </p:nvSpPr>
-          <p:spPr>
-            <a:xfrm>
-              <a:off x="3994770" y="2734456"/>
-              <a:ext cx="888973" cy="1251691"/>
-            </a:xfrm>
-            <a:prstGeom prst="rect">
-              <a:avLst/>
-            </a:prstGeom>
-            <a:solidFill>
-              <a:schemeClr val="bg1"/>
             </a:solidFill>
             <a:ln>
               <a:noFill/>
@@ -16116,10 +16593,10 @@
         </p:sp>
         <p:sp>
           <p:nvSpPr>
-            <p:cNvPr id="15" name="Pfeil: nach links 14">
+            <p:cNvPr id="31" name="Parallelogramm 30">
               <a:extLst>
                 <a:ext uri="{FF2B5EF4-FFF2-40B4-BE49-F238E27FC236}">
-                  <a16:creationId xmlns:a16="http://schemas.microsoft.com/office/drawing/2014/main" id="{2C0A912A-2832-E5FD-10A4-D85EAC1FA583}"/>
+                  <a16:creationId xmlns:a16="http://schemas.microsoft.com/office/drawing/2014/main" id="{2C024125-6091-9DE9-858C-8DC0E02D8177}"/>
                 </a:ext>
               </a:extLst>
             </p:cNvPr>
@@ -16127,19 +16604,24 @@
             <p:nvPr/>
           </p:nvSpPr>
           <p:spPr>
-            <a:xfrm rot="10800000">
-              <a:off x="3920844" y="3189355"/>
-              <a:ext cx="1131789" cy="392399"/>
+            <a:xfrm>
+              <a:off x="4387027" y="3224231"/>
+              <a:ext cx="395757" cy="303348"/>
             </a:xfrm>
-            <a:prstGeom prst="leftArrow">
-              <a:avLst/>
+            <a:prstGeom prst="parallelogram">
+              <a:avLst>
+                <a:gd name="adj" fmla="val 82983"/>
+              </a:avLst>
             </a:prstGeom>
             <a:solidFill>
-              <a:schemeClr val="tx2">
-                <a:lumMod val="50000"/>
-                <a:lumOff val="50000"/>
+              <a:schemeClr val="accent2">
+                <a:lumMod val="20000"/>
+                <a:lumOff val="80000"/>
               </a:schemeClr>
             </a:solidFill>
+            <a:ln>
+              <a:noFill/>
+            </a:ln>
           </p:spPr>
           <p:style>
             <a:lnRef idx="2">
@@ -16211,7 +16693,7 @@
                                           </p:stCondLst>
                                         </p:cTn>
                                         <p:tgtEl>
-                                          <p:spTgt spid="11"/>
+                                          <p:spTgt spid="32"/>
                                         </p:tgtEl>
                                         <p:attrNameLst>
                                           <p:attrName>style.visibility</p:attrName>

</xml_diff>

<commit_message>
wip: sync [2026-06-21 22:50]
</commit_message>
<xml_diff>
--- a/josyn-intro.pptx
+++ b/josyn-intro.pptx
@@ -15015,10 +15015,10 @@
         </p:nvGrpSpPr>
         <p:grpSpPr>
           <a:xfrm>
-            <a:off x="750351" y="1051524"/>
-            <a:ext cx="10958734" cy="5647506"/>
-            <a:chOff x="750351" y="1051524"/>
-            <a:chExt cx="10958734" cy="5647506"/>
+            <a:off x="750351" y="1055811"/>
+            <a:ext cx="10958734" cy="5643219"/>
+            <a:chOff x="750351" y="1055811"/>
+            <a:chExt cx="10958734" cy="5643219"/>
           </a:xfrm>
         </p:grpSpPr>
         <p:grpSp>
@@ -15035,10 +15035,10 @@
           </p:nvGrpSpPr>
           <p:grpSpPr>
             <a:xfrm>
-              <a:off x="750351" y="1051524"/>
-              <a:ext cx="10958734" cy="5647506"/>
-              <a:chOff x="750351" y="1051524"/>
-              <a:chExt cx="10958734" cy="5647506"/>
+              <a:off x="750351" y="1055811"/>
+              <a:ext cx="10958734" cy="5643219"/>
+              <a:chOff x="750351" y="1055811"/>
+              <a:chExt cx="10958734" cy="5643219"/>
             </a:xfrm>
           </p:grpSpPr>
           <p:grpSp>
@@ -15055,10 +15055,10 @@
             </p:nvGrpSpPr>
             <p:grpSpPr>
               <a:xfrm>
-                <a:off x="750351" y="1051524"/>
-                <a:ext cx="10437021" cy="5647506"/>
-                <a:chOff x="750351" y="1051524"/>
-                <a:chExt cx="10437021" cy="5647506"/>
+                <a:off x="750351" y="1055811"/>
+                <a:ext cx="10437021" cy="5643219"/>
+                <a:chOff x="750351" y="1055811"/>
+                <a:chExt cx="10437021" cy="5643219"/>
               </a:xfrm>
             </p:grpSpPr>
             <p:grpSp>
@@ -15075,10 +15075,10 @@
               </p:nvGrpSpPr>
               <p:grpSpPr>
                 <a:xfrm>
-                  <a:off x="750351" y="1051524"/>
-                  <a:ext cx="10437021" cy="5647506"/>
-                  <a:chOff x="655101" y="965799"/>
-                  <a:chExt cx="10437021" cy="5647506"/>
+                  <a:off x="750351" y="1082344"/>
+                  <a:ext cx="10437021" cy="5616686"/>
+                  <a:chOff x="655101" y="996619"/>
+                  <a:chExt cx="10437021" cy="5616686"/>
                 </a:xfrm>
               </p:grpSpPr>
               <p:graphicFrame>
@@ -15096,13 +15096,13 @@
                   <p:nvPr>
                     <p:extLst>
                       <p:ext uri="{D42A27DB-BD31-4B8C-83A1-F6EECF244321}">
-                        <p14:modId xmlns:p14="http://schemas.microsoft.com/office/powerpoint/2010/main" val="4032221289"/>
+                        <p14:modId xmlns:p14="http://schemas.microsoft.com/office/powerpoint/2010/main" val="1700902092"/>
                       </p:ext>
                     </p:extLst>
                   </p:nvPr>
                 </p:nvGraphicFramePr>
                 <p:xfrm>
-                  <a:off x="3268342" y="965799"/>
+                  <a:off x="3268342" y="1099149"/>
                   <a:ext cx="1009391" cy="490762"/>
                 </p:xfrm>
                 <a:graphic>
@@ -15130,7 +15130,7 @@
                             </p:blipFill>
                             <p:spPr>
                               <a:xfrm>
-                                <a:off x="3268342" y="965799"/>
+                                <a:off x="3268342" y="1099149"/>
                                 <a:ext cx="1009391" cy="490762"/>
                               </a:xfrm>
                               <a:prstGeom prst="rect">

</xml_diff>

<commit_message>
wip: sync [2026-06-22 11:28]
</commit_message>
<xml_diff>
--- a/josyn-intro.pptx
+++ b/josyn-intro.pptx
@@ -207,7 +207,7 @@
           <a:p>
             <a:fld id="{8E5D503C-CB4E-47D2-854F-034286D1EDEF}" type="datetimeFigureOut">
               <a:rPr lang="de-DE" smtClean="0"/>
-              <a:t>21.06.2026</a:t>
+              <a:t>22.06.2026</a:t>
             </a:fld>
             <a:endParaRPr lang="de-DE"/>
           </a:p>
@@ -897,7 +897,7 @@
           <a:p>
             <a:fld id="{6670F5CD-5655-45E5-8E7F-D706B3048717}" type="datetimeFigureOut">
               <a:rPr lang="de-DE" smtClean="0"/>
-              <a:t>21.06.2026</a:t>
+              <a:t>22.06.2026</a:t>
             </a:fld>
             <a:endParaRPr lang="de-DE"/>
           </a:p>
@@ -1095,7 +1095,7 @@
           <a:p>
             <a:fld id="{6670F5CD-5655-45E5-8E7F-D706B3048717}" type="datetimeFigureOut">
               <a:rPr lang="de-DE" smtClean="0"/>
-              <a:t>21.06.2026</a:t>
+              <a:t>22.06.2026</a:t>
             </a:fld>
             <a:endParaRPr lang="de-DE"/>
           </a:p>
@@ -1303,7 +1303,7 @@
           <a:p>
             <a:fld id="{6670F5CD-5655-45E5-8E7F-D706B3048717}" type="datetimeFigureOut">
               <a:rPr lang="de-DE" smtClean="0"/>
-              <a:t>21.06.2026</a:t>
+              <a:t>22.06.2026</a:t>
             </a:fld>
             <a:endParaRPr lang="de-DE"/>
           </a:p>
@@ -1501,7 +1501,7 @@
           <a:p>
             <a:fld id="{6670F5CD-5655-45E5-8E7F-D706B3048717}" type="datetimeFigureOut">
               <a:rPr lang="de-DE" smtClean="0"/>
-              <a:t>21.06.2026</a:t>
+              <a:t>22.06.2026</a:t>
             </a:fld>
             <a:endParaRPr lang="de-DE"/>
           </a:p>
@@ -1776,7 +1776,7 @@
           <a:p>
             <a:fld id="{6670F5CD-5655-45E5-8E7F-D706B3048717}" type="datetimeFigureOut">
               <a:rPr lang="de-DE" smtClean="0"/>
-              <a:t>21.06.2026</a:t>
+              <a:t>22.06.2026</a:t>
             </a:fld>
             <a:endParaRPr lang="de-DE"/>
           </a:p>
@@ -2041,7 +2041,7 @@
           <a:p>
             <a:fld id="{6670F5CD-5655-45E5-8E7F-D706B3048717}" type="datetimeFigureOut">
               <a:rPr lang="de-DE" smtClean="0"/>
-              <a:t>21.06.2026</a:t>
+              <a:t>22.06.2026</a:t>
             </a:fld>
             <a:endParaRPr lang="de-DE"/>
           </a:p>
@@ -2453,7 +2453,7 @@
           <a:p>
             <a:fld id="{6670F5CD-5655-45E5-8E7F-D706B3048717}" type="datetimeFigureOut">
               <a:rPr lang="de-DE" smtClean="0"/>
-              <a:t>21.06.2026</a:t>
+              <a:t>22.06.2026</a:t>
             </a:fld>
             <a:endParaRPr lang="de-DE"/>
           </a:p>
@@ -2594,7 +2594,7 @@
           <a:p>
             <a:fld id="{6670F5CD-5655-45E5-8E7F-D706B3048717}" type="datetimeFigureOut">
               <a:rPr lang="de-DE" smtClean="0"/>
-              <a:t>21.06.2026</a:t>
+              <a:t>22.06.2026</a:t>
             </a:fld>
             <a:endParaRPr lang="de-DE"/>
           </a:p>
@@ -2707,7 +2707,7 @@
           <a:p>
             <a:fld id="{6670F5CD-5655-45E5-8E7F-D706B3048717}" type="datetimeFigureOut">
               <a:rPr lang="de-DE" smtClean="0"/>
-              <a:t>21.06.2026</a:t>
+              <a:t>22.06.2026</a:t>
             </a:fld>
             <a:endParaRPr lang="de-DE"/>
           </a:p>
@@ -3018,7 +3018,7 @@
           <a:p>
             <a:fld id="{6670F5CD-5655-45E5-8E7F-D706B3048717}" type="datetimeFigureOut">
               <a:rPr lang="de-DE" smtClean="0"/>
-              <a:t>21.06.2026</a:t>
+              <a:t>22.06.2026</a:t>
             </a:fld>
             <a:endParaRPr lang="de-DE"/>
           </a:p>
@@ -3306,7 +3306,7 @@
           <a:p>
             <a:fld id="{6670F5CD-5655-45E5-8E7F-D706B3048717}" type="datetimeFigureOut">
               <a:rPr lang="de-DE" smtClean="0"/>
-              <a:t>21.06.2026</a:t>
+              <a:t>22.06.2026</a:t>
             </a:fld>
             <a:endParaRPr lang="de-DE"/>
           </a:p>
@@ -3547,7 +3547,7 @@
           <a:p>
             <a:fld id="{6670F5CD-5655-45E5-8E7F-D706B3048717}" type="datetimeFigureOut">
               <a:rPr lang="de-DE" smtClean="0"/>
-              <a:t>21.06.2026</a:t>
+              <a:t>22.06.2026</a:t>
             </a:fld>
             <a:endParaRPr lang="de-DE"/>
           </a:p>
@@ -4324,7 +4324,7 @@
           <p:spPr>
             <a:xfrm>
               <a:off x="2148700" y="1048781"/>
-              <a:ext cx="9295418" cy="1459455"/>
+              <a:ext cx="9295418" cy="1530573"/>
             </a:xfrm>
             <a:prstGeom prst="rect">
               <a:avLst/>
@@ -4538,7 +4538,7 @@
           </p:nvSpPr>
           <p:spPr>
             <a:xfrm>
-              <a:off x="4862127" y="2673067"/>
+              <a:off x="4862127" y="2812767"/>
               <a:ext cx="787395" cy="400110"/>
             </a:xfrm>
             <a:prstGeom prst="rect">
@@ -4574,8 +4574,8 @@
           </p:nvSpPr>
           <p:spPr>
             <a:xfrm>
-              <a:off x="4204343" y="1614489"/>
-              <a:ext cx="7051045" cy="738664"/>
+              <a:off x="4185293" y="1443039"/>
+              <a:ext cx="3860157" cy="954107"/>
             </a:xfrm>
             <a:prstGeom prst="rect">
               <a:avLst/>
@@ -4693,7 +4693,7 @@
           </p:nvSpPr>
           <p:spPr>
             <a:xfrm>
-              <a:off x="4173288" y="1242713"/>
+              <a:off x="4163395" y="1077617"/>
               <a:ext cx="7136080" cy="400110"/>
             </a:xfrm>
             <a:prstGeom prst="rect">
@@ -4790,7 +4790,7 @@
           <p:spPr>
             <a:xfrm>
               <a:off x="719671" y="1048781"/>
-              <a:ext cx="1319401" cy="1459455"/>
+              <a:ext cx="1319401" cy="1525257"/>
             </a:xfrm>
             <a:prstGeom prst="rect">
               <a:avLst/>
@@ -4918,7 +4918,7 @@
           </p:nvSpPr>
           <p:spPr>
             <a:xfrm>
-              <a:off x="5556886" y="2662269"/>
+              <a:off x="5556886" y="2694019"/>
               <a:ext cx="531961" cy="733992"/>
             </a:xfrm>
             <a:prstGeom prst="downArrow">
@@ -6716,7 +6716,7 @@
           </p:nvSpPr>
           <p:spPr>
             <a:xfrm>
-              <a:off x="6003931" y="2701618"/>
+              <a:off x="6003931" y="2822268"/>
               <a:ext cx="2409890" cy="338554"/>
             </a:xfrm>
             <a:prstGeom prst="rect">
@@ -6857,7 +6857,7 @@
           </p:nvSpPr>
           <p:spPr>
             <a:xfrm>
-              <a:off x="1124452" y="2669716"/>
+              <a:off x="1124452" y="2701466"/>
               <a:ext cx="531961" cy="736070"/>
             </a:xfrm>
             <a:prstGeom prst="downArrow">
@@ -6893,6 +6893,248 @@
           </p:txBody>
         </p:sp>
       </p:grpSp>
+      <p:sp>
+        <p:nvSpPr>
+          <p:cNvPr id="10" name="Textfeld 9">
+            <a:extLst>
+              <a:ext uri="{FF2B5EF4-FFF2-40B4-BE49-F238E27FC236}">
+                <a16:creationId xmlns:a16="http://schemas.microsoft.com/office/drawing/2014/main" id="{33DD06CC-8D36-A15C-E080-328933C07164}"/>
+              </a:ext>
+            </a:extLst>
+          </p:cNvPr>
+          <p:cNvSpPr txBox="1"/>
+          <p:nvPr/>
+        </p:nvSpPr>
+        <p:spPr>
+          <a:xfrm>
+            <a:off x="8179824" y="1299275"/>
+            <a:ext cx="1221392" cy="1107996"/>
+          </a:xfrm>
+          <a:prstGeom prst="rect">
+            <a:avLst/>
+          </a:prstGeom>
+          <a:noFill/>
+        </p:spPr>
+        <p:txBody>
+          <a:bodyPr wrap="square">
+            <a:spAutoFit/>
+          </a:bodyPr>
+          <a:lstStyle/>
+          <a:p>
+            <a:r>
+              <a:rPr lang="de-DE" sz="1100" b="1">
+                <a:solidFill>
+                  <a:srgbClr val="002060"/>
+                </a:solidFill>
+              </a:rPr>
+              <a:t>queries</a:t>
+            </a:r>
+          </a:p>
+          <a:p>
+            <a:pPr marL="171450" indent="-171450">
+              <a:buFont typeface="Arial" panose="020B0604020202020204" pitchFamily="34" charset="0"/>
+              <a:buChar char="•"/>
+            </a:pPr>
+            <a:r>
+              <a:rPr lang="de-DE" sz="1100">
+                <a:solidFill>
+                  <a:srgbClr val="002060"/>
+                </a:solidFill>
+              </a:rPr>
+              <a:t>session-list</a:t>
+            </a:r>
+          </a:p>
+          <a:p>
+            <a:pPr marL="171450" indent="-171450">
+              <a:buFont typeface="Arial" panose="020B0604020202020204" pitchFamily="34" charset="0"/>
+              <a:buChar char="•"/>
+            </a:pPr>
+            <a:r>
+              <a:rPr lang="de-DE" sz="1100">
+                <a:solidFill>
+                  <a:srgbClr val="002060"/>
+                </a:solidFill>
+              </a:rPr>
+              <a:t>diagnosis</a:t>
+            </a:r>
+          </a:p>
+          <a:p>
+            <a:pPr marL="171450" indent="-171450">
+              <a:buFont typeface="Arial" panose="020B0604020202020204" pitchFamily="34" charset="0"/>
+              <a:buChar char="•"/>
+            </a:pPr>
+            <a:r>
+              <a:rPr lang="de-DE" sz="1100">
+                <a:solidFill>
+                  <a:srgbClr val="002060"/>
+                </a:solidFill>
+              </a:rPr>
+              <a:t>inventory</a:t>
+            </a:r>
+          </a:p>
+          <a:p>
+            <a:pPr marL="171450" indent="-171450">
+              <a:buFont typeface="Arial" panose="020B0604020202020204" pitchFamily="34" charset="0"/>
+              <a:buChar char="•"/>
+            </a:pPr>
+            <a:r>
+              <a:rPr lang="de-DE" sz="1100">
+                <a:solidFill>
+                  <a:srgbClr val="002060"/>
+                </a:solidFill>
+              </a:rPr>
+              <a:t>statistics</a:t>
+            </a:r>
+          </a:p>
+          <a:p>
+            <a:pPr marL="171450" indent="-171450">
+              <a:buFont typeface="Arial" panose="020B0604020202020204" pitchFamily="34" charset="0"/>
+              <a:buChar char="•"/>
+            </a:pPr>
+            <a:r>
+              <a:rPr lang="de-DE" sz="1100">
+                <a:solidFill>
+                  <a:srgbClr val="002060"/>
+                </a:solidFill>
+              </a:rPr>
+              <a:t>…</a:t>
+            </a:r>
+          </a:p>
+        </p:txBody>
+      </p:sp>
+      <p:sp>
+        <p:nvSpPr>
+          <p:cNvPr id="12" name="Textfeld 11">
+            <a:extLst>
+              <a:ext uri="{FF2B5EF4-FFF2-40B4-BE49-F238E27FC236}">
+                <a16:creationId xmlns:a16="http://schemas.microsoft.com/office/drawing/2014/main" id="{6572E98E-222F-4360-E0D5-E07CB5EDAEBD}"/>
+              </a:ext>
+            </a:extLst>
+          </p:cNvPr>
+          <p:cNvSpPr txBox="1"/>
+          <p:nvPr/>
+        </p:nvSpPr>
+        <p:spPr>
+          <a:xfrm>
+            <a:off x="9213040" y="1304386"/>
+            <a:ext cx="2220810" cy="938719"/>
+          </a:xfrm>
+          <a:prstGeom prst="rect">
+            <a:avLst/>
+          </a:prstGeom>
+          <a:noFill/>
+        </p:spPr>
+        <p:txBody>
+          <a:bodyPr wrap="square">
+            <a:spAutoFit/>
+          </a:bodyPr>
+          <a:lstStyle/>
+          <a:p>
+            <a:r>
+              <a:rPr lang="de-DE" sz="1100" b="1">
+                <a:solidFill>
+                  <a:srgbClr val="002060"/>
+                </a:solidFill>
+              </a:rPr>
+              <a:t>commands</a:t>
+            </a:r>
+          </a:p>
+          <a:p>
+            <a:pPr marL="171450" indent="-171450">
+              <a:buFont typeface="Arial" panose="020B0604020202020204" pitchFamily="34" charset="0"/>
+              <a:buChar char="•"/>
+            </a:pPr>
+            <a:r>
+              <a:rPr lang="de-DE" sz="1100">
+                <a:solidFill>
+                  <a:srgbClr val="002060"/>
+                </a:solidFill>
+              </a:rPr>
+              <a:t>start, cancel, kill a job-session</a:t>
+            </a:r>
+          </a:p>
+          <a:p>
+            <a:pPr marL="171450" indent="-171450">
+              <a:buFont typeface="Arial" panose="020B0604020202020204" pitchFamily="34" charset="0"/>
+              <a:buChar char="•"/>
+            </a:pPr>
+            <a:r>
+              <a:rPr lang="de-DE" sz="1100">
+                <a:solidFill>
+                  <a:srgbClr val="002060"/>
+                </a:solidFill>
+              </a:rPr>
+              <a:t>edit job-scheduling</a:t>
+            </a:r>
+          </a:p>
+          <a:p>
+            <a:pPr marL="171450" indent="-171450">
+              <a:buFont typeface="Arial" panose="020B0604020202020204" pitchFamily="34" charset="0"/>
+              <a:buChar char="•"/>
+            </a:pPr>
+            <a:r>
+              <a:rPr lang="de-DE" sz="1100">
+                <a:solidFill>
+                  <a:srgbClr val="002060"/>
+                </a:solidFill>
+              </a:rPr>
+              <a:t>edit job-arguments</a:t>
+            </a:r>
+          </a:p>
+          <a:p>
+            <a:pPr marL="171450" indent="-171450">
+              <a:buFont typeface="Arial" panose="020B0604020202020204" pitchFamily="34" charset="0"/>
+              <a:buChar char="•"/>
+            </a:pPr>
+            <a:r>
+              <a:rPr lang="de-DE" sz="1100">
+                <a:solidFill>
+                  <a:srgbClr val="002060"/>
+                </a:solidFill>
+              </a:rPr>
+              <a:t>…</a:t>
+            </a:r>
+          </a:p>
+        </p:txBody>
+      </p:sp>
+      <p:cxnSp>
+        <p:nvCxnSpPr>
+          <p:cNvPr id="14" name="Gerader Verbinder 13">
+            <a:extLst>
+              <a:ext uri="{FF2B5EF4-FFF2-40B4-BE49-F238E27FC236}">
+                <a16:creationId xmlns:a16="http://schemas.microsoft.com/office/drawing/2014/main" id="{73E8F32E-22C9-F060-E845-4D8EB56BEF1F}"/>
+              </a:ext>
+            </a:extLst>
+          </p:cNvPr>
+          <p:cNvCxnSpPr>
+            <a:cxnSpLocks/>
+          </p:cNvCxnSpPr>
+          <p:nvPr/>
+        </p:nvCxnSpPr>
+        <p:spPr>
+          <a:xfrm>
+            <a:off x="8096250" y="1382477"/>
+            <a:ext cx="0" cy="919419"/>
+          </a:xfrm>
+          <a:prstGeom prst="line">
+            <a:avLst/>
+          </a:prstGeom>
+        </p:spPr>
+        <p:style>
+          <a:lnRef idx="2">
+            <a:schemeClr val="accent1"/>
+          </a:lnRef>
+          <a:fillRef idx="0">
+            <a:schemeClr val="accent1"/>
+          </a:fillRef>
+          <a:effectRef idx="1">
+            <a:schemeClr val="accent1"/>
+          </a:effectRef>
+          <a:fontRef idx="minor">
+            <a:schemeClr val="tx1"/>
+          </a:fontRef>
+        </p:style>
+      </p:cxnSp>
     </p:spTree>
     <p:extLst>
       <p:ext uri="{BB962C8B-B14F-4D97-AF65-F5344CB8AC3E}">

</xml_diff>

<commit_message>
wip: sync [2026-06-22 16:38]
</commit_message>
<xml_diff>
--- a/josyn-intro.pptx
+++ b/josyn-intro.pptx
@@ -7302,7 +7302,7 @@
         </p:nvGrpSpPr>
         <p:grpSpPr>
           <a:xfrm>
-            <a:off x="9296937" y="1358956"/>
+            <a:off x="9296937" y="1339906"/>
             <a:ext cx="1609958" cy="3976567"/>
             <a:chOff x="6606124" y="632008"/>
             <a:chExt cx="1609958" cy="3976567"/>
@@ -7425,7 +7425,7 @@
         </p:nvGrpSpPr>
         <p:grpSpPr>
           <a:xfrm>
-            <a:off x="6706881" y="1330649"/>
+            <a:off x="6706881" y="1336999"/>
             <a:ext cx="2507055" cy="2937056"/>
             <a:chOff x="4366189" y="2914892"/>
             <a:chExt cx="2507055" cy="2937056"/>
@@ -8236,8 +8236,8 @@
         </p:nvCxnSpPr>
         <p:spPr>
           <a:xfrm rot="5400000">
-            <a:off x="9332231" y="4879722"/>
-            <a:ext cx="313884" cy="1225487"/>
+            <a:off x="9322706" y="4870197"/>
+            <a:ext cx="332934" cy="1225487"/>
           </a:xfrm>
           <a:prstGeom prst="bentConnector2">
             <a:avLst/>
@@ -8505,8 +8505,8 @@
         </p:nvCxnSpPr>
         <p:spPr>
           <a:xfrm>
-            <a:off x="7960409" y="4113881"/>
-            <a:ext cx="5960" cy="413186"/>
+            <a:off x="7960409" y="4120231"/>
+            <a:ext cx="5960" cy="406836"/>
           </a:xfrm>
           <a:prstGeom prst="straightConnector1">
             <a:avLst/>

</xml_diff>

<commit_message>
wip: sync [2026-06-22 21:38]
</commit_message>
<xml_diff>
--- a/josyn-intro.pptx
+++ b/josyn-intro.pptx
@@ -6809,7 +6809,7 @@
           <p:spPr>
             <a:xfrm>
               <a:off x="728418" y="400674"/>
-              <a:ext cx="8764772" cy="461665"/>
+              <a:ext cx="8229689" cy="461665"/>
             </a:xfrm>
             <a:prstGeom prst="rect">
               <a:avLst/>
@@ -6838,7 +6838,7 @@
                     <a:srgbClr val="002060"/>
                   </a:solidFill>
                 </a:rPr>
-                <a:t>(„Vision“/PoC/Proposal) | paramount perspective</a:t>
+                <a:t>(„Vision“/Proposal) | paramount perspective</a:t>
               </a:r>
             </a:p>
           </p:txBody>
@@ -7837,7 +7837,7 @@
         <p:spPr>
           <a:xfrm>
             <a:off x="252326" y="153024"/>
-            <a:ext cx="9923807" cy="461665"/>
+            <a:ext cx="9753311" cy="461665"/>
           </a:xfrm>
           <a:prstGeom prst="rect">
             <a:avLst/>
@@ -7864,7 +7864,7 @@
                   <a:srgbClr val="002060"/>
                 </a:solidFill>
               </a:rPr>
-              <a:t>(PoC/Proposal) | environment-bound machine perspective</a:t>
+              <a:t>(working PoC) | environment-bound machine perspective</a:t>
             </a:r>
           </a:p>
         </p:txBody>
@@ -14056,8 +14056,20 @@
           <a:p>
             <a:pPr algn="ctr"/>
             <a:r>
+              <a:rPr lang="de-DE" sz="2400" b="1" strike="sngStrike"/>
+              <a:t>Projekt</a:t>
+            </a:r>
+            <a:r>
               <a:rPr lang="de-DE" sz="2400" b="1"/>
-              <a:t>Projekt für ein </a:t>
+              <a:t> – eine </a:t>
+            </a:r>
+            <a:r>
+              <a:rPr lang="de-DE" sz="2400" b="1" i="1"/>
+              <a:t>Initiative</a:t>
+            </a:r>
+            <a:r>
+              <a:rPr lang="de-DE" sz="2400" b="1"/>
+              <a:t> - für ein </a:t>
             </a:r>
             <a:r>
               <a:rPr lang="de-DE" sz="2400" b="1" i="1"/>
@@ -14865,8 +14877,8 @@
         </p:nvSpPr>
         <p:spPr>
           <a:xfrm>
-            <a:off x="2150640" y="1707447"/>
-            <a:ext cx="7788888" cy="584775"/>
+            <a:off x="2150639" y="1716972"/>
+            <a:ext cx="9460335" cy="954107"/>
           </a:xfrm>
           <a:prstGeom prst="rect">
             <a:avLst/>
@@ -14880,28 +14892,22 @@
           <a:lstStyle/>
           <a:p>
             <a:r>
-              <a:rPr lang="de-DE" sz="3200" b="1" i="1"/>
-              <a:t>Pflegestation </a:t>
-            </a:r>
-            <a:r>
-              <a:rPr lang="de-DE" sz="3200"/>
-              <a:t>oder</a:t>
-            </a:r>
-            <a:r>
-              <a:rPr lang="de-DE" sz="3200" b="1" i="1"/>
-              <a:t> </a:t>
-            </a:r>
-            <a:r>
               <a:rPr lang="de-DE" sz="3200" b="1" i="1">
                 <a:solidFill>
                   <a:srgbClr val="0070C0"/>
                 </a:solidFill>
               </a:rPr>
-              <a:t>TPM-Initiative</a:t>
-            </a:r>
-            <a:r>
-              <a:rPr lang="de-DE" sz="3200" b="1" i="1"/>
-              <a:t>?</a:t>
+              <a:t>TPM-Initiative? </a:t>
+            </a:r>
+            <a:r>
+              <a:rPr lang="de-DE" sz="2400" i="1"/>
+              <a:t>(oder reicht eine gute „Pflegestation“?)</a:t>
+            </a:r>
+          </a:p>
+          <a:p>
+            <a:r>
+              <a:rPr lang="de-DE" sz="2400" i="1"/>
+              <a:t>ja! | nein! | ja, aber nur wenn…</a:t>
             </a:r>
           </a:p>
         </p:txBody>
@@ -14921,7 +14927,7 @@
         <p:spPr>
           <a:xfrm>
             <a:off x="2150640" y="3855643"/>
-            <a:ext cx="8566128" cy="1077218"/>
+            <a:ext cx="8566128" cy="1692771"/>
           </a:xfrm>
           <a:prstGeom prst="rect">
             <a:avLst/>
@@ -14953,8 +14959,26 @@
           </a:p>
           <a:p>
             <a:r>
+              <a:rPr lang="de-DE" sz="2000" i="1">
+                <a:solidFill>
+                  <a:srgbClr val="0070C0"/>
+                </a:solidFill>
+              </a:rPr>
+              <a:t>Constraints / Rules / Rahmenbedingungen / People / Methodik / Risiken / Kommunikation / Evaluation / Kosten / Time-Line / Exit-Strategie / …</a:t>
+            </a:r>
+          </a:p>
+          <a:p>
+            <a:r>
               <a:rPr lang="de-DE" sz="2000"/>
-              <a:t>=&gt; Hausaufgaben! - für den Owner dieses Termins, oder andere Leute…</a:t>
+              <a:t>=&gt;</a:t>
+            </a:r>
+            <a:r>
+              <a:rPr lang="de-DE" sz="2000" b="1"/>
+              <a:t> Hausaufgaben!</a:t>
+            </a:r>
+            <a:r>
+              <a:rPr lang="de-DE" sz="2000"/>
+              <a:t> - für den Owner dieses Termins, oder andere Leute…</a:t>
             </a:r>
             <a:r>
               <a:rPr lang="de-DE" sz="3200"/>
@@ -15086,6 +15110,37 @@
                                   </p:childTnLst>
                                 </p:cTn>
                               </p:par>
+                              <p:par>
+                                <p:cTn id="11" presetID="1" presetClass="entr" presetSubtype="0" fill="hold" grpId="0" nodeType="withEffect">
+                                  <p:stCondLst>
+                                    <p:cond delay="0"/>
+                                  </p:stCondLst>
+                                  <p:childTnLst>
+                                    <p:set>
+                                      <p:cBhvr>
+                                        <p:cTn id="12" dur="1" fill="hold">
+                                          <p:stCondLst>
+                                            <p:cond delay="0"/>
+                                          </p:stCondLst>
+                                        </p:cTn>
+                                        <p:tgtEl>
+                                          <p:spTgt spid="14">
+                                            <p:txEl>
+                                              <p:pRg st="2" end="2"/>
+                                            </p:txEl>
+                                          </p:spTgt>
+                                        </p:tgtEl>
+                                        <p:attrNameLst>
+                                          <p:attrName>style.visibility</p:attrName>
+                                        </p:attrNameLst>
+                                      </p:cBhvr>
+                                      <p:to>
+                                        <p:strVal val="visible"/>
+                                      </p:to>
+                                    </p:set>
+                                  </p:childTnLst>
+                                </p:cTn>
+                              </p:par>
                             </p:childTnLst>
                           </p:cTn>
                         </p:par>
@@ -15153,7 +15208,7 @@
         <p:spPr>
           <a:xfrm>
             <a:off x="146742" y="90250"/>
-            <a:ext cx="11749983" cy="769441"/>
+            <a:ext cx="12110118" cy="707886"/>
           </a:xfrm>
           <a:prstGeom prst="rect">
             <a:avLst/>
@@ -15167,11 +15222,11 @@
           <a:lstStyle/>
           <a:p>
             <a:r>
-              <a:rPr lang="de-DE" sz="2400" b="1"/>
+              <a:rPr lang="de-DE" sz="2000" b="1"/>
               <a:t>Vorschlag für einen effizienten </a:t>
             </a:r>
             <a:r>
-              <a:rPr lang="de-DE" sz="2400" b="1">
+              <a:rPr lang="de-DE" sz="2000" b="1">
                 <a:solidFill>
                   <a:srgbClr val="0070C0"/>
                 </a:solidFill>
@@ -15179,11 +15234,11 @@
               <a:t>Arbeitsmodus</a:t>
             </a:r>
             <a:r>
-              <a:rPr lang="de-DE" sz="2400" b="1"/>
-              <a:t> der </a:t>
-            </a:r>
-            <a:r>
-              <a:rPr lang="de-DE" sz="2400" b="1">
+              <a:rPr lang="de-DE" sz="2000" b="1"/>
+              <a:t> einer potentiellen </a:t>
+            </a:r>
+            <a:r>
+              <a:rPr lang="de-DE" sz="2000" b="1">
                 <a:solidFill>
                   <a:srgbClr val="0070C0"/>
                 </a:solidFill>
@@ -15191,14 +15246,27 @@
               <a:t>TPM-Initiative</a:t>
             </a:r>
             <a:r>
-              <a:rPr lang="de-DE" sz="2400" b="1"/>
-              <a:t>.</a:t>
-            </a:r>
-          </a:p>
-          <a:p>
+              <a:rPr lang="de-DE" sz="2000" b="1"/>
+              <a:t>. </a:t>
+            </a:r>
             <a:r>
               <a:rPr lang="de-DE" sz="2000"/>
-              <a:t>Für die </a:t>
+              <a:t>(ein „logisches </a:t>
+            </a:r>
+            <a:r>
+              <a:rPr lang="de-DE" sz="2000" b="1"/>
+              <a:t>Modell</a:t>
+            </a:r>
+            <a:r>
+              <a:rPr lang="de-DE" sz="2000"/>
+              <a:t>“)</a:t>
+            </a:r>
+            <a:endParaRPr lang="de-DE" sz="2000" b="1"/>
+          </a:p>
+          <a:p>
+            <a:r>
+              <a:rPr lang="de-DE" sz="2000"/>
+              <a:t>Cave!: nur für die </a:t>
             </a:r>
             <a:r>
               <a:rPr lang="de-DE" sz="2000" i="1"/>
@@ -15210,35 +15278,11 @@
             </a:r>
             <a:r>
               <a:rPr lang="de-DE" sz="2000" i="1"/>
-              <a:t>expliziten Moduswechsel</a:t>
+              <a:t>expliziten Moduswechsel!</a:t>
             </a:r>
             <a:r>
               <a:rPr lang="de-DE" sz="2000"/>
-              <a:t> - „</a:t>
-            </a:r>
-            <a:r>
-              <a:rPr lang="de-DE" sz="2000">
-                <a:solidFill>
-                  <a:srgbClr val="7030A0"/>
-                </a:solidFill>
-              </a:rPr>
-              <a:t>logisches</a:t>
-            </a:r>
-            <a:r>
-              <a:rPr lang="de-DE" sz="2000"/>
-              <a:t> </a:t>
-            </a:r>
-            <a:r>
-              <a:rPr lang="de-DE" sz="2000" b="1">
-                <a:solidFill>
-                  <a:srgbClr val="7030A0"/>
-                </a:solidFill>
-              </a:rPr>
-              <a:t>Modell</a:t>
-            </a:r>
-            <a:r>
-              <a:rPr lang="de-DE" sz="2000"/>
-              <a:t>“</a:t>
+              <a:t>  </a:t>
             </a:r>
           </a:p>
         </p:txBody>

</xml_diff>

<commit_message>
wip: sync [2026-06-23 20:08]
</commit_message>
<xml_diff>
--- a/josyn-intro.pptx
+++ b/josyn-intro.pptx
@@ -207,7 +207,7 @@
           <a:p>
             <a:fld id="{8E5D503C-CB4E-47D2-854F-034286D1EDEF}" type="datetimeFigureOut">
               <a:rPr lang="de-DE" smtClean="0"/>
-              <a:t>22.06.2026</a:t>
+              <a:t>23.06.2026</a:t>
             </a:fld>
             <a:endParaRPr lang="de-DE"/>
           </a:p>
@@ -897,7 +897,7 @@
           <a:p>
             <a:fld id="{6670F5CD-5655-45E5-8E7F-D706B3048717}" type="datetimeFigureOut">
               <a:rPr lang="de-DE" smtClean="0"/>
-              <a:t>22.06.2026</a:t>
+              <a:t>23.06.2026</a:t>
             </a:fld>
             <a:endParaRPr lang="de-DE"/>
           </a:p>
@@ -1095,7 +1095,7 @@
           <a:p>
             <a:fld id="{6670F5CD-5655-45E5-8E7F-D706B3048717}" type="datetimeFigureOut">
               <a:rPr lang="de-DE" smtClean="0"/>
-              <a:t>22.06.2026</a:t>
+              <a:t>23.06.2026</a:t>
             </a:fld>
             <a:endParaRPr lang="de-DE"/>
           </a:p>
@@ -1303,7 +1303,7 @@
           <a:p>
             <a:fld id="{6670F5CD-5655-45E5-8E7F-D706B3048717}" type="datetimeFigureOut">
               <a:rPr lang="de-DE" smtClean="0"/>
-              <a:t>22.06.2026</a:t>
+              <a:t>23.06.2026</a:t>
             </a:fld>
             <a:endParaRPr lang="de-DE"/>
           </a:p>
@@ -1501,7 +1501,7 @@
           <a:p>
             <a:fld id="{6670F5CD-5655-45E5-8E7F-D706B3048717}" type="datetimeFigureOut">
               <a:rPr lang="de-DE" smtClean="0"/>
-              <a:t>22.06.2026</a:t>
+              <a:t>23.06.2026</a:t>
             </a:fld>
             <a:endParaRPr lang="de-DE"/>
           </a:p>
@@ -1776,7 +1776,7 @@
           <a:p>
             <a:fld id="{6670F5CD-5655-45E5-8E7F-D706B3048717}" type="datetimeFigureOut">
               <a:rPr lang="de-DE" smtClean="0"/>
-              <a:t>22.06.2026</a:t>
+              <a:t>23.06.2026</a:t>
             </a:fld>
             <a:endParaRPr lang="de-DE"/>
           </a:p>
@@ -2041,7 +2041,7 @@
           <a:p>
             <a:fld id="{6670F5CD-5655-45E5-8E7F-D706B3048717}" type="datetimeFigureOut">
               <a:rPr lang="de-DE" smtClean="0"/>
-              <a:t>22.06.2026</a:t>
+              <a:t>23.06.2026</a:t>
             </a:fld>
             <a:endParaRPr lang="de-DE"/>
           </a:p>
@@ -2453,7 +2453,7 @@
           <a:p>
             <a:fld id="{6670F5CD-5655-45E5-8E7F-D706B3048717}" type="datetimeFigureOut">
               <a:rPr lang="de-DE" smtClean="0"/>
-              <a:t>22.06.2026</a:t>
+              <a:t>23.06.2026</a:t>
             </a:fld>
             <a:endParaRPr lang="de-DE"/>
           </a:p>
@@ -2594,7 +2594,7 @@
           <a:p>
             <a:fld id="{6670F5CD-5655-45E5-8E7F-D706B3048717}" type="datetimeFigureOut">
               <a:rPr lang="de-DE" smtClean="0"/>
-              <a:t>22.06.2026</a:t>
+              <a:t>23.06.2026</a:t>
             </a:fld>
             <a:endParaRPr lang="de-DE"/>
           </a:p>
@@ -2707,7 +2707,7 @@
           <a:p>
             <a:fld id="{6670F5CD-5655-45E5-8E7F-D706B3048717}" type="datetimeFigureOut">
               <a:rPr lang="de-DE" smtClean="0"/>
-              <a:t>22.06.2026</a:t>
+              <a:t>23.06.2026</a:t>
             </a:fld>
             <a:endParaRPr lang="de-DE"/>
           </a:p>
@@ -3018,7 +3018,7 @@
           <a:p>
             <a:fld id="{6670F5CD-5655-45E5-8E7F-D706B3048717}" type="datetimeFigureOut">
               <a:rPr lang="de-DE" smtClean="0"/>
-              <a:t>22.06.2026</a:t>
+              <a:t>23.06.2026</a:t>
             </a:fld>
             <a:endParaRPr lang="de-DE"/>
           </a:p>
@@ -3306,7 +3306,7 @@
           <a:p>
             <a:fld id="{6670F5CD-5655-45E5-8E7F-D706B3048717}" type="datetimeFigureOut">
               <a:rPr lang="de-DE" smtClean="0"/>
-              <a:t>22.06.2026</a:t>
+              <a:t>23.06.2026</a:t>
             </a:fld>
             <a:endParaRPr lang="de-DE"/>
           </a:p>
@@ -3547,7 +3547,7 @@
           <a:p>
             <a:fld id="{6670F5CD-5655-45E5-8E7F-D706B3048717}" type="datetimeFigureOut">
               <a:rPr lang="de-DE" smtClean="0"/>
-              <a:t>22.06.2026</a:t>
+              <a:t>23.06.2026</a:t>
             </a:fld>
             <a:endParaRPr lang="de-DE"/>
           </a:p>
@@ -10618,7 +10618,7 @@
         <p:spPr>
           <a:xfrm>
             <a:off x="1421765" y="721895"/>
-            <a:ext cx="10071100" cy="6124754"/>
+            <a:ext cx="10265410" cy="6001643"/>
           </a:xfrm>
           <a:prstGeom prst="rect">
             <a:avLst/>
@@ -10751,7 +10751,7 @@
               <a:t>Das Scheduling =&gt; als ewiges Provisorium als XML auf den einzelnen Servern -&gt; </a:t>
             </a:r>
             <a:r>
-              <a:rPr lang="de-DE">
+              <a:rPr lang="de-DE" b="1">
                 <a:solidFill>
                   <a:srgbClr val="FF0000"/>
                 </a:solidFill>
@@ -10903,7 +10903,7 @@
               <a:t>Immerhin sehr viel, immer wieder mühsam nachgezogene, </a:t>
             </a:r>
             <a:r>
-              <a:rPr lang="de-DE">
+              <a:rPr lang="de-DE" b="1">
                 <a:solidFill>
                   <a:srgbClr val="FF0000"/>
                 </a:solidFill>
@@ -12015,7 +12015,19 @@
             </a:r>
             <a:r>
               <a:rPr lang="de-DE"/>
-              <a:t> um komplizierte Patches und Ergänzungen erweitert (</a:t>
+              <a:t> um komplizierte </a:t>
+            </a:r>
+            <a:r>
+              <a:rPr lang="de-DE">
+                <a:solidFill>
+                  <a:srgbClr val="FF0000"/>
+                </a:solidFill>
+              </a:rPr>
+              <a:t>Patches</a:t>
+            </a:r>
+            <a:r>
+              <a:rPr lang="de-DE"/>
+              <a:t> und Ergänzungen erweitert (</a:t>
             </a:r>
             <a:r>
               <a:rPr lang="de-DE" i="1"/>
@@ -12031,7 +12043,19 @@
             </a:r>
             <a:r>
               <a:rPr lang="de-DE"/>
-              <a:t>), die z.B. das anfänglich nicht adressierte „Concurrency-Problem“ betreffen. Aus „Pending“ wurde „Preparing goes to Pending“; abgesichert mit einem „Turnstile“: kaum dokumentiert, nicht durch Contracts oder Tests abgesichert; nur notdürftig durch Code-Kommentare eklärt:  das versteht die zukünftige Generation von Maintainern nicht mehr: wir haben hier </a:t>
+              <a:t>), die z.B. das anfänglich nicht adressierte „Concurrency-Problem“ betreffen. Aus „Pending“ wurde „Preparing goes to Pending“; abgesichert mit einem „Turnstile“: kaum dokumentiert, nicht durch Contracts oder Tests abgesichert; nur notdürftig durch Code-Kommentare eklärt:  </a:t>
+            </a:r>
+            <a:r>
+              <a:rPr lang="de-DE">
+                <a:solidFill>
+                  <a:srgbClr val="FF0000"/>
+                </a:solidFill>
+              </a:rPr>
+              <a:t>das versteht die zukünftige Generation von Maintainern nicht mehr</a:t>
+            </a:r>
+            <a:r>
+              <a:rPr lang="de-DE"/>
+              <a:t>: wir haben hier </a:t>
             </a:r>
             <a:r>
               <a:rPr lang="de-DE" b="1">
@@ -12121,7 +12145,15 @@
             </a:r>
             <a:r>
               <a:rPr lang="de-DE" sz="2000"/>
-              <a:t>: das System ist z.B. nicht fit, eine zukünftige, härtere </a:t>
+              <a:t>: das System ist - </a:t>
+            </a:r>
+            <a:r>
+              <a:rPr lang="de-DE" sz="2000" i="1"/>
+              <a:t>z.Bsp.</a:t>
+            </a:r>
+            <a:r>
+              <a:rPr lang="de-DE" sz="2000"/>
+              <a:t> - nicht fit, eine zukünftige, härtere </a:t>
             </a:r>
             <a:r>
               <a:rPr lang="de-DE" sz="2000" b="1"/>
@@ -12145,7 +12177,7 @@
             </a:r>
             <a:r>
               <a:rPr lang="de-DE" sz="2000"/>
-              <a:t> sind kaum machbar.  Schärfere Anforderungen wären nur durch „stunts“, „nervige handarbeit“ und „dont-ask-dont-tell“-Kompromisse mühsam mitzugehen… </a:t>
+              <a:t> sind kaum machbar.  (Schärfere Anforderungen wären nur durch „hacks“, „nervige handarbeit“ und „dont-ask-dont-tell“-Kompromisse mühsam mitzugehen…) </a:t>
             </a:r>
           </a:p>
           <a:p>
@@ -12437,819 +12469,6 @@
           <a:chExt cx="0" cy="0"/>
         </a:xfrm>
       </p:grpSpPr>
-      <p:grpSp>
-        <p:nvGrpSpPr>
-          <p:cNvPr id="66" name="Gruppieren 65">
-            <a:extLst>
-              <a:ext uri="{FF2B5EF4-FFF2-40B4-BE49-F238E27FC236}">
-                <a16:creationId xmlns:a16="http://schemas.microsoft.com/office/drawing/2014/main" id="{45F580C5-8F3A-EDDB-125F-5CD169EFA36D}"/>
-              </a:ext>
-            </a:extLst>
-          </p:cNvPr>
-          <p:cNvGrpSpPr/>
-          <p:nvPr/>
-        </p:nvGrpSpPr>
-        <p:grpSpPr>
-          <a:xfrm>
-            <a:off x="1713922" y="1439437"/>
-            <a:ext cx="2992631" cy="2689384"/>
-            <a:chOff x="6606124" y="632008"/>
-            <a:chExt cx="1609958" cy="3976567"/>
-          </a:xfrm>
-          <a:solidFill>
-            <a:schemeClr val="bg1">
-              <a:lumMod val="95000"/>
-            </a:schemeClr>
-          </a:solidFill>
-        </p:grpSpPr>
-        <p:sp>
-          <p:nvSpPr>
-            <p:cNvPr id="67" name="Rechteck 66">
-              <a:extLst>
-                <a:ext uri="{FF2B5EF4-FFF2-40B4-BE49-F238E27FC236}">
-                  <a16:creationId xmlns:a16="http://schemas.microsoft.com/office/drawing/2014/main" id="{91D6CEA9-DE63-5C3E-1FC1-F87CE5390BFE}"/>
-                </a:ext>
-              </a:extLst>
-            </p:cNvPr>
-            <p:cNvSpPr/>
-            <p:nvPr/>
-          </p:nvSpPr>
-          <p:spPr>
-            <a:xfrm>
-              <a:off x="6606124" y="632008"/>
-              <a:ext cx="1609958" cy="3976567"/>
-            </a:xfrm>
-            <a:prstGeom prst="rect">
-              <a:avLst/>
-            </a:prstGeom>
-            <a:grpFill/>
-            <a:ln>
-              <a:solidFill>
-                <a:srgbClr val="7030A0"/>
-              </a:solidFill>
-            </a:ln>
-          </p:spPr>
-          <p:style>
-            <a:lnRef idx="2">
-              <a:schemeClr val="accent1">
-                <a:shade val="15000"/>
-              </a:schemeClr>
-            </a:lnRef>
-            <a:fillRef idx="1">
-              <a:schemeClr val="accent1"/>
-            </a:fillRef>
-            <a:effectRef idx="0">
-              <a:schemeClr val="accent1"/>
-            </a:effectRef>
-            <a:fontRef idx="minor">
-              <a:schemeClr val="lt1"/>
-            </a:fontRef>
-          </p:style>
-          <p:txBody>
-            <a:bodyPr rtlCol="0" anchor="ctr"/>
-            <a:lstStyle/>
-            <a:p>
-              <a:pPr algn="ctr"/>
-              <a:endParaRPr lang="de-DE"/>
-            </a:p>
-          </p:txBody>
-        </p:sp>
-        <p:sp>
-          <p:nvSpPr>
-            <p:cNvPr id="69" name="Textfeld 68">
-              <a:extLst>
-                <a:ext uri="{FF2B5EF4-FFF2-40B4-BE49-F238E27FC236}">
-                  <a16:creationId xmlns:a16="http://schemas.microsoft.com/office/drawing/2014/main" id="{06971D2B-11F1-F847-86D5-A05053D8999A}"/>
-                </a:ext>
-              </a:extLst>
-            </p:cNvPr>
-            <p:cNvSpPr txBox="1"/>
-            <p:nvPr/>
-          </p:nvSpPr>
-          <p:spPr>
-            <a:xfrm>
-              <a:off x="6607221" y="632143"/>
-              <a:ext cx="1032705" cy="546100"/>
-            </a:xfrm>
-            <a:prstGeom prst="rect">
-              <a:avLst/>
-            </a:prstGeom>
-            <a:noFill/>
-            <a:ln>
-              <a:noFill/>
-            </a:ln>
-          </p:spPr>
-          <p:txBody>
-            <a:bodyPr wrap="square" rtlCol="0">
-              <a:spAutoFit/>
-            </a:bodyPr>
-            <a:lstStyle/>
-            <a:p>
-              <a:r>
-                <a:rPr lang="de-DE" b="1">
-                  <a:solidFill>
-                    <a:srgbClr val="7030A0"/>
-                  </a:solidFill>
-                </a:rPr>
-                <a:t>Das Backend</a:t>
-              </a:r>
-            </a:p>
-          </p:txBody>
-        </p:sp>
-      </p:grpSp>
-      <p:grpSp>
-        <p:nvGrpSpPr>
-          <p:cNvPr id="9" name="Gruppieren 8">
-            <a:extLst>
-              <a:ext uri="{FF2B5EF4-FFF2-40B4-BE49-F238E27FC236}">
-                <a16:creationId xmlns:a16="http://schemas.microsoft.com/office/drawing/2014/main" id="{B20A8C9F-F57C-4D2B-2026-E1D2C374B37C}"/>
-              </a:ext>
-            </a:extLst>
-          </p:cNvPr>
-          <p:cNvGrpSpPr/>
-          <p:nvPr/>
-        </p:nvGrpSpPr>
-        <p:grpSpPr>
-          <a:xfrm>
-            <a:off x="5583614" y="1463281"/>
-            <a:ext cx="4423990" cy="2689384"/>
-            <a:chOff x="6606125" y="632008"/>
-            <a:chExt cx="1609958" cy="3976567"/>
-          </a:xfrm>
-          <a:solidFill>
-            <a:schemeClr val="bg1">
-              <a:lumMod val="95000"/>
-            </a:schemeClr>
-          </a:solidFill>
-        </p:grpSpPr>
-        <p:sp>
-          <p:nvSpPr>
-            <p:cNvPr id="10" name="Rechteck 9">
-              <a:extLst>
-                <a:ext uri="{FF2B5EF4-FFF2-40B4-BE49-F238E27FC236}">
-                  <a16:creationId xmlns:a16="http://schemas.microsoft.com/office/drawing/2014/main" id="{6921B3CE-E7A0-EC84-AE42-D587DB52C342}"/>
-                </a:ext>
-              </a:extLst>
-            </p:cNvPr>
-            <p:cNvSpPr/>
-            <p:nvPr/>
-          </p:nvSpPr>
-          <p:spPr>
-            <a:xfrm>
-              <a:off x="6606125" y="632008"/>
-              <a:ext cx="1609958" cy="3976567"/>
-            </a:xfrm>
-            <a:prstGeom prst="rect">
-              <a:avLst/>
-            </a:prstGeom>
-            <a:grpFill/>
-            <a:ln>
-              <a:solidFill>
-                <a:schemeClr val="tx2">
-                  <a:lumMod val="75000"/>
-                  <a:lumOff val="25000"/>
-                </a:schemeClr>
-              </a:solidFill>
-            </a:ln>
-          </p:spPr>
-          <p:style>
-            <a:lnRef idx="2">
-              <a:schemeClr val="accent1">
-                <a:shade val="15000"/>
-              </a:schemeClr>
-            </a:lnRef>
-            <a:fillRef idx="1">
-              <a:schemeClr val="accent1"/>
-            </a:fillRef>
-            <a:effectRef idx="0">
-              <a:schemeClr val="accent1"/>
-            </a:effectRef>
-            <a:fontRef idx="minor">
-              <a:schemeClr val="lt1"/>
-            </a:fontRef>
-          </p:style>
-          <p:txBody>
-            <a:bodyPr rtlCol="0" anchor="ctr"/>
-            <a:lstStyle/>
-            <a:p>
-              <a:pPr algn="ctr"/>
-              <a:endParaRPr lang="de-DE"/>
-            </a:p>
-          </p:txBody>
-        </p:sp>
-        <p:sp>
-          <p:nvSpPr>
-            <p:cNvPr id="11" name="Textfeld 10">
-              <a:extLst>
-                <a:ext uri="{FF2B5EF4-FFF2-40B4-BE49-F238E27FC236}">
-                  <a16:creationId xmlns:a16="http://schemas.microsoft.com/office/drawing/2014/main" id="{EC331E49-AA54-F3AD-0A2F-79D0B4B9BE38}"/>
-                </a:ext>
-              </a:extLst>
-            </p:cNvPr>
-            <p:cNvSpPr txBox="1"/>
-            <p:nvPr/>
-          </p:nvSpPr>
-          <p:spPr>
-            <a:xfrm>
-              <a:off x="6607221" y="632142"/>
-              <a:ext cx="899942" cy="659962"/>
-            </a:xfrm>
-            <a:prstGeom prst="rect">
-              <a:avLst/>
-            </a:prstGeom>
-            <a:noFill/>
-          </p:spPr>
-          <p:txBody>
-            <a:bodyPr wrap="none" rtlCol="0">
-              <a:spAutoFit/>
-            </a:bodyPr>
-            <a:lstStyle/>
-            <a:p>
-              <a:r>
-                <a:rPr lang="de-DE" b="1">
-                  <a:solidFill>
-                    <a:schemeClr val="tx2">
-                      <a:lumMod val="75000"/>
-                      <a:lumOff val="25000"/>
-                    </a:schemeClr>
-                  </a:solidFill>
-                </a:rPr>
-                <a:t>Jobhost.exe</a:t>
-              </a:r>
-            </a:p>
-          </p:txBody>
-        </p:sp>
-      </p:grpSp>
-      <p:grpSp>
-        <p:nvGrpSpPr>
-          <p:cNvPr id="15" name="Gruppieren 14">
-            <a:extLst>
-              <a:ext uri="{FF2B5EF4-FFF2-40B4-BE49-F238E27FC236}">
-                <a16:creationId xmlns:a16="http://schemas.microsoft.com/office/drawing/2014/main" id="{00681D04-726D-1F17-2FF4-63D66A1BAB7E}"/>
-              </a:ext>
-            </a:extLst>
-          </p:cNvPr>
-          <p:cNvGrpSpPr/>
-          <p:nvPr/>
-        </p:nvGrpSpPr>
-        <p:grpSpPr>
-          <a:xfrm>
-            <a:off x="8005905" y="3082401"/>
-            <a:ext cx="1822489" cy="765048"/>
-            <a:chOff x="164209" y="1524953"/>
-            <a:chExt cx="1822489" cy="765048"/>
-          </a:xfrm>
-        </p:grpSpPr>
-        <p:sp>
-          <p:nvSpPr>
-            <p:cNvPr id="16" name="Rechteck 15">
-              <a:extLst>
-                <a:ext uri="{FF2B5EF4-FFF2-40B4-BE49-F238E27FC236}">
-                  <a16:creationId xmlns:a16="http://schemas.microsoft.com/office/drawing/2014/main" id="{EE7FD0AE-ABF6-2A9B-559B-9DECBD0D518D}"/>
-                </a:ext>
-              </a:extLst>
-            </p:cNvPr>
-            <p:cNvSpPr/>
-            <p:nvPr/>
-          </p:nvSpPr>
-          <p:spPr>
-            <a:xfrm>
-              <a:off x="164209" y="1524953"/>
-              <a:ext cx="1803699" cy="765048"/>
-            </a:xfrm>
-            <a:prstGeom prst="rect">
-              <a:avLst/>
-            </a:prstGeom>
-            <a:solidFill>
-              <a:schemeClr val="tx2">
-                <a:lumMod val="10000"/>
-                <a:lumOff val="90000"/>
-              </a:schemeClr>
-            </a:solidFill>
-            <a:ln>
-              <a:solidFill>
-                <a:schemeClr val="tx2">
-                  <a:lumMod val="75000"/>
-                  <a:lumOff val="25000"/>
-                </a:schemeClr>
-              </a:solidFill>
-            </a:ln>
-          </p:spPr>
-          <p:style>
-            <a:lnRef idx="2">
-              <a:schemeClr val="accent1">
-                <a:shade val="15000"/>
-              </a:schemeClr>
-            </a:lnRef>
-            <a:fillRef idx="1">
-              <a:schemeClr val="accent1"/>
-            </a:fillRef>
-            <a:effectRef idx="0">
-              <a:schemeClr val="accent1"/>
-            </a:effectRef>
-            <a:fontRef idx="minor">
-              <a:schemeClr val="lt1"/>
-            </a:fontRef>
-          </p:style>
-          <p:txBody>
-            <a:bodyPr rtlCol="0" anchor="ctr"/>
-            <a:lstStyle/>
-            <a:p>
-              <a:pPr algn="ctr"/>
-              <a:endParaRPr lang="de-DE"/>
-            </a:p>
-          </p:txBody>
-        </p:sp>
-        <p:sp>
-          <p:nvSpPr>
-            <p:cNvPr id="17" name="Textfeld 16">
-              <a:extLst>
-                <a:ext uri="{FF2B5EF4-FFF2-40B4-BE49-F238E27FC236}">
-                  <a16:creationId xmlns:a16="http://schemas.microsoft.com/office/drawing/2014/main" id="{66E59F33-9673-BF9A-2A76-B7ED8A290DEA}"/>
-                </a:ext>
-              </a:extLst>
-            </p:cNvPr>
-            <p:cNvSpPr txBox="1"/>
-            <p:nvPr/>
-          </p:nvSpPr>
-          <p:spPr>
-            <a:xfrm>
-              <a:off x="182999" y="1686886"/>
-              <a:ext cx="1803699" cy="369332"/>
-            </a:xfrm>
-            <a:prstGeom prst="rect">
-              <a:avLst/>
-            </a:prstGeom>
-            <a:noFill/>
-          </p:spPr>
-          <p:txBody>
-            <a:bodyPr wrap="none" rtlCol="0">
-              <a:spAutoFit/>
-            </a:bodyPr>
-            <a:lstStyle/>
-            <a:p>
-              <a:r>
-                <a:rPr lang="de-DE" b="1">
-                  <a:solidFill>
-                    <a:schemeClr val="tx2">
-                      <a:lumMod val="75000"/>
-                      <a:lumOff val="25000"/>
-                    </a:schemeClr>
-                  </a:solidFill>
-                </a:rPr>
-                <a:t>job-assemblies</a:t>
-              </a:r>
-            </a:p>
-          </p:txBody>
-        </p:sp>
-      </p:grpSp>
-      <p:grpSp>
-        <p:nvGrpSpPr>
-          <p:cNvPr id="19" name="Gruppieren 18">
-            <a:extLst>
-              <a:ext uri="{FF2B5EF4-FFF2-40B4-BE49-F238E27FC236}">
-                <a16:creationId xmlns:a16="http://schemas.microsoft.com/office/drawing/2014/main" id="{41C2E713-FEED-828B-784C-F67174EC88F8}"/>
-              </a:ext>
-            </a:extLst>
-          </p:cNvPr>
-          <p:cNvGrpSpPr/>
-          <p:nvPr/>
-        </p:nvGrpSpPr>
-        <p:grpSpPr>
-          <a:xfrm>
-            <a:off x="5897322" y="1853741"/>
-            <a:ext cx="3922316" cy="708234"/>
-            <a:chOff x="164209" y="1516532"/>
-            <a:chExt cx="1803699" cy="773469"/>
-          </a:xfrm>
-        </p:grpSpPr>
-        <p:sp>
-          <p:nvSpPr>
-            <p:cNvPr id="21" name="Rechteck 20">
-              <a:extLst>
-                <a:ext uri="{FF2B5EF4-FFF2-40B4-BE49-F238E27FC236}">
-                  <a16:creationId xmlns:a16="http://schemas.microsoft.com/office/drawing/2014/main" id="{F5734D98-A5B2-DFFF-01E1-0795FEF53E54}"/>
-                </a:ext>
-              </a:extLst>
-            </p:cNvPr>
-            <p:cNvSpPr/>
-            <p:nvPr/>
-          </p:nvSpPr>
-          <p:spPr>
-            <a:xfrm>
-              <a:off x="164209" y="1524953"/>
-              <a:ext cx="1803699" cy="765048"/>
-            </a:xfrm>
-            <a:prstGeom prst="rect">
-              <a:avLst/>
-            </a:prstGeom>
-            <a:solidFill>
-              <a:schemeClr val="tx2">
-                <a:lumMod val="10000"/>
-                <a:lumOff val="90000"/>
-              </a:schemeClr>
-            </a:solidFill>
-            <a:ln>
-              <a:solidFill>
-                <a:schemeClr val="tx2">
-                  <a:lumMod val="75000"/>
-                  <a:lumOff val="25000"/>
-                </a:schemeClr>
-              </a:solidFill>
-            </a:ln>
-          </p:spPr>
-          <p:style>
-            <a:lnRef idx="2">
-              <a:schemeClr val="accent1">
-                <a:shade val="15000"/>
-              </a:schemeClr>
-            </a:lnRef>
-            <a:fillRef idx="1">
-              <a:schemeClr val="accent1"/>
-            </a:fillRef>
-            <a:effectRef idx="0">
-              <a:schemeClr val="accent1"/>
-            </a:effectRef>
-            <a:fontRef idx="minor">
-              <a:schemeClr val="lt1"/>
-            </a:fontRef>
-          </p:style>
-          <p:txBody>
-            <a:bodyPr rtlCol="0" anchor="ctr"/>
-            <a:lstStyle/>
-            <a:p>
-              <a:pPr algn="ctr"/>
-              <a:endParaRPr lang="de-DE"/>
-            </a:p>
-          </p:txBody>
-        </p:sp>
-        <p:sp>
-          <p:nvSpPr>
-            <p:cNvPr id="28" name="Textfeld 27">
-              <a:extLst>
-                <a:ext uri="{FF2B5EF4-FFF2-40B4-BE49-F238E27FC236}">
-                  <a16:creationId xmlns:a16="http://schemas.microsoft.com/office/drawing/2014/main" id="{7201EE90-CEA3-3A25-B815-CBC87BEDB594}"/>
-                </a:ext>
-              </a:extLst>
-            </p:cNvPr>
-            <p:cNvSpPr txBox="1"/>
-            <p:nvPr/>
-          </p:nvSpPr>
-          <p:spPr>
-            <a:xfrm>
-              <a:off x="198602" y="1516532"/>
-              <a:ext cx="1109599" cy="369332"/>
-            </a:xfrm>
-            <a:prstGeom prst="rect">
-              <a:avLst/>
-            </a:prstGeom>
-            <a:noFill/>
-          </p:spPr>
-          <p:txBody>
-            <a:bodyPr wrap="none" rtlCol="0">
-              <a:spAutoFit/>
-            </a:bodyPr>
-            <a:lstStyle/>
-            <a:p>
-              <a:r>
-                <a:rPr lang="de-DE" b="1">
-                  <a:solidFill>
-                    <a:schemeClr val="tx2">
-                      <a:lumMod val="75000"/>
-                      <a:lumOff val="25000"/>
-                    </a:schemeClr>
-                  </a:solidFill>
-                </a:rPr>
-                <a:t>Base-job</a:t>
-              </a:r>
-            </a:p>
-          </p:txBody>
-        </p:sp>
-      </p:grpSp>
-      <p:sp>
-        <p:nvSpPr>
-          <p:cNvPr id="52" name="Textfeld 51">
-            <a:extLst>
-              <a:ext uri="{FF2B5EF4-FFF2-40B4-BE49-F238E27FC236}">
-                <a16:creationId xmlns:a16="http://schemas.microsoft.com/office/drawing/2014/main" id="{AB395DAA-F396-28B1-E9C1-A745386E2EEB}"/>
-              </a:ext>
-            </a:extLst>
-          </p:cNvPr>
-          <p:cNvSpPr txBox="1"/>
-          <p:nvPr/>
-        </p:nvSpPr>
-        <p:spPr>
-          <a:xfrm>
-            <a:off x="5124305" y="2724919"/>
-            <a:ext cx="2472944" cy="1169551"/>
-          </a:xfrm>
-          <a:prstGeom prst="rect">
-            <a:avLst/>
-          </a:prstGeom>
-          <a:solidFill>
-            <a:srgbClr val="FF9999"/>
-          </a:solidFill>
-        </p:spPr>
-        <p:txBody>
-          <a:bodyPr wrap="square">
-            <a:spAutoFit/>
-          </a:bodyPr>
-          <a:lstStyle/>
-          <a:p>
-            <a:r>
-              <a:rPr lang="de-DE" sz="1000" b="1"/>
-              <a:t>HaevgRZ.JobSystem.SessionStore.dll</a:t>
-            </a:r>
-          </a:p>
-          <a:p>
-            <a:r>
-              <a:rPr lang="de-DE" sz="1000" b="1"/>
-              <a:t>HaevgRZ.JobSystem.Core.dll</a:t>
-            </a:r>
-          </a:p>
-          <a:p>
-            <a:r>
-              <a:rPr lang="de-DE" sz="1000" b="1"/>
-              <a:t>HaevgRZ.JobSystem.Contracts.dll</a:t>
-            </a:r>
-          </a:p>
-          <a:p>
-            <a:r>
-              <a:rPr lang="de-DE" sz="1000" b="1"/>
-              <a:t>HaevgRZ.JobSystem.Lib.Core.dll</a:t>
-            </a:r>
-          </a:p>
-          <a:p>
-            <a:r>
-              <a:rPr lang="de-DE" sz="1000" b="1"/>
-              <a:t>HaevgRZ.JobSystem.Lib.Messaging.dll</a:t>
-            </a:r>
-          </a:p>
-          <a:p>
-            <a:r>
-              <a:rPr lang="de-DE" sz="1000" b="1"/>
-              <a:t>„GlobalConfig“</a:t>
-            </a:r>
-          </a:p>
-          <a:p>
-            <a:r>
-              <a:rPr lang="de-DE" sz="1000" b="1"/>
-              <a:t>…</a:t>
-            </a:r>
-          </a:p>
-        </p:txBody>
-      </p:sp>
-      <p:sp>
-        <p:nvSpPr>
-          <p:cNvPr id="55" name="Textfeld 54">
-            <a:extLst>
-              <a:ext uri="{FF2B5EF4-FFF2-40B4-BE49-F238E27FC236}">
-                <a16:creationId xmlns:a16="http://schemas.microsoft.com/office/drawing/2014/main" id="{35A56320-1BAA-14D4-257E-BC2DD55217FB}"/>
-              </a:ext>
-            </a:extLst>
-          </p:cNvPr>
-          <p:cNvSpPr txBox="1"/>
-          <p:nvPr/>
-        </p:nvSpPr>
-        <p:spPr>
-          <a:xfrm>
-            <a:off x="7927182" y="2724919"/>
-            <a:ext cx="1905009" cy="338554"/>
-          </a:xfrm>
-          <a:prstGeom prst="rect">
-            <a:avLst/>
-          </a:prstGeom>
-          <a:noFill/>
-        </p:spPr>
-        <p:txBody>
-          <a:bodyPr wrap="none" rtlCol="0">
-            <a:spAutoFit/>
-          </a:bodyPr>
-          <a:lstStyle/>
-          <a:p>
-            <a:r>
-              <a:rPr lang="de-DE" sz="1600" b="1">
-                <a:solidFill>
-                  <a:srgbClr val="FF0000"/>
-                </a:solidFill>
-              </a:rPr>
-              <a:t>AssemblyResolve:</a:t>
-            </a:r>
-          </a:p>
-        </p:txBody>
-      </p:sp>
-      <p:grpSp>
-        <p:nvGrpSpPr>
-          <p:cNvPr id="56" name="Gruppieren 55">
-            <a:extLst>
-              <a:ext uri="{FF2B5EF4-FFF2-40B4-BE49-F238E27FC236}">
-                <a16:creationId xmlns:a16="http://schemas.microsoft.com/office/drawing/2014/main" id="{840FE24B-8ABF-C58F-FA7B-285D8FF784A4}"/>
-              </a:ext>
-            </a:extLst>
-          </p:cNvPr>
-          <p:cNvGrpSpPr/>
-          <p:nvPr/>
-        </p:nvGrpSpPr>
-        <p:grpSpPr>
-          <a:xfrm>
-            <a:off x="2898340" y="1918813"/>
-            <a:ext cx="1803699" cy="643577"/>
-            <a:chOff x="164209" y="1588453"/>
-            <a:chExt cx="1803699" cy="643577"/>
-          </a:xfrm>
-        </p:grpSpPr>
-        <p:sp>
-          <p:nvSpPr>
-            <p:cNvPr id="57" name="Rechteck 56">
-              <a:extLst>
-                <a:ext uri="{FF2B5EF4-FFF2-40B4-BE49-F238E27FC236}">
-                  <a16:creationId xmlns:a16="http://schemas.microsoft.com/office/drawing/2014/main" id="{5339CB1C-0982-812A-5B00-A1C734F2D7B9}"/>
-                </a:ext>
-              </a:extLst>
-            </p:cNvPr>
-            <p:cNvSpPr/>
-            <p:nvPr/>
-          </p:nvSpPr>
-          <p:spPr>
-            <a:xfrm>
-              <a:off x="164209" y="1588453"/>
-              <a:ext cx="1803699" cy="643577"/>
-            </a:xfrm>
-            <a:prstGeom prst="rect">
-              <a:avLst/>
-            </a:prstGeom>
-            <a:solidFill>
-              <a:schemeClr val="tx2">
-                <a:lumMod val="10000"/>
-                <a:lumOff val="90000"/>
-              </a:schemeClr>
-            </a:solidFill>
-            <a:ln>
-              <a:solidFill>
-                <a:schemeClr val="tx2">
-                  <a:lumMod val="75000"/>
-                  <a:lumOff val="25000"/>
-                </a:schemeClr>
-              </a:solidFill>
-            </a:ln>
-          </p:spPr>
-          <p:style>
-            <a:lnRef idx="2">
-              <a:schemeClr val="accent1">
-                <a:shade val="15000"/>
-              </a:schemeClr>
-            </a:lnRef>
-            <a:fillRef idx="1">
-              <a:schemeClr val="accent1"/>
-            </a:fillRef>
-            <a:effectRef idx="0">
-              <a:schemeClr val="accent1"/>
-            </a:effectRef>
-            <a:fontRef idx="minor">
-              <a:schemeClr val="lt1"/>
-            </a:fontRef>
-          </p:style>
-          <p:txBody>
-            <a:bodyPr rtlCol="0" anchor="ctr"/>
-            <a:lstStyle/>
-            <a:p>
-              <a:pPr algn="ctr"/>
-              <a:endParaRPr lang="de-DE"/>
-            </a:p>
-          </p:txBody>
-        </p:sp>
-        <p:sp>
-          <p:nvSpPr>
-            <p:cNvPr id="58" name="Textfeld 57">
-              <a:extLst>
-                <a:ext uri="{FF2B5EF4-FFF2-40B4-BE49-F238E27FC236}">
-                  <a16:creationId xmlns:a16="http://schemas.microsoft.com/office/drawing/2014/main" id="{FDA82363-6616-3120-15F7-E15ADFD3A277}"/>
-                </a:ext>
-              </a:extLst>
-            </p:cNvPr>
-            <p:cNvSpPr txBox="1"/>
-            <p:nvPr/>
-          </p:nvSpPr>
-          <p:spPr>
-            <a:xfrm>
-              <a:off x="216082" y="1606413"/>
-              <a:ext cx="1741311" cy="369332"/>
-            </a:xfrm>
-            <a:prstGeom prst="rect">
-              <a:avLst/>
-            </a:prstGeom>
-            <a:noFill/>
-          </p:spPr>
-          <p:txBody>
-            <a:bodyPr wrap="none" rtlCol="0">
-              <a:spAutoFit/>
-            </a:bodyPr>
-            <a:lstStyle/>
-            <a:p>
-              <a:r>
-                <a:rPr lang="de-DE" b="1">
-                  <a:solidFill>
-                    <a:schemeClr val="tx2">
-                      <a:lumMod val="75000"/>
-                      <a:lumOff val="25000"/>
-                    </a:schemeClr>
-                  </a:solidFill>
-                </a:rPr>
-                <a:t>SessionStarter</a:t>
-              </a:r>
-            </a:p>
-          </p:txBody>
-        </p:sp>
-      </p:grpSp>
-      <p:sp>
-        <p:nvSpPr>
-          <p:cNvPr id="60" name="Pfeil: nach rechts 59">
-            <a:extLst>
-              <a:ext uri="{FF2B5EF4-FFF2-40B4-BE49-F238E27FC236}">
-                <a16:creationId xmlns:a16="http://schemas.microsoft.com/office/drawing/2014/main" id="{3E79FB88-779C-13F8-B2BF-A117237A18A3}"/>
-              </a:ext>
-            </a:extLst>
-          </p:cNvPr>
-          <p:cNvSpPr/>
-          <p:nvPr/>
-        </p:nvSpPr>
-        <p:spPr>
-          <a:xfrm>
-            <a:off x="4723504" y="2146442"/>
-            <a:ext cx="841320" cy="234258"/>
-          </a:xfrm>
-          <a:prstGeom prst="rightArrow">
-            <a:avLst/>
-          </a:prstGeom>
-          <a:solidFill>
-            <a:schemeClr val="accent6"/>
-          </a:solidFill>
-          <a:ln>
-            <a:solidFill>
-              <a:srgbClr val="0070C0"/>
-            </a:solidFill>
-          </a:ln>
-        </p:spPr>
-        <p:style>
-          <a:lnRef idx="2">
-            <a:schemeClr val="accent1">
-              <a:shade val="15000"/>
-            </a:schemeClr>
-          </a:lnRef>
-          <a:fillRef idx="1">
-            <a:schemeClr val="accent1"/>
-          </a:fillRef>
-          <a:effectRef idx="0">
-            <a:schemeClr val="accent1"/>
-          </a:effectRef>
-          <a:fontRef idx="minor">
-            <a:schemeClr val="lt1"/>
-          </a:fontRef>
-        </p:style>
-        <p:txBody>
-          <a:bodyPr rtlCol="0" anchor="ctr"/>
-          <a:lstStyle/>
-          <a:p>
-            <a:pPr algn="ctr"/>
-            <a:endParaRPr lang="de-DE"/>
-          </a:p>
-        </p:txBody>
-      </p:sp>
-      <p:sp>
-        <p:nvSpPr>
-          <p:cNvPr id="61" name="Textfeld 60">
-            <a:extLst>
-              <a:ext uri="{FF2B5EF4-FFF2-40B4-BE49-F238E27FC236}">
-                <a16:creationId xmlns:a16="http://schemas.microsoft.com/office/drawing/2014/main" id="{62C7E6E6-A5E4-68DB-279A-D74781522F4F}"/>
-              </a:ext>
-            </a:extLst>
-          </p:cNvPr>
-          <p:cNvSpPr txBox="1"/>
-          <p:nvPr/>
-        </p:nvSpPr>
-        <p:spPr>
-          <a:xfrm>
-            <a:off x="4666437" y="1778023"/>
-            <a:ext cx="955454" cy="369332"/>
-          </a:xfrm>
-          <a:prstGeom prst="rect">
-            <a:avLst/>
-          </a:prstGeom>
-          <a:noFill/>
-        </p:spPr>
-        <p:txBody>
-          <a:bodyPr wrap="none" rtlCol="0">
-            <a:spAutoFit/>
-          </a:bodyPr>
-          <a:lstStyle/>
-          <a:p>
-            <a:r>
-              <a:rPr lang="de-DE"/>
-              <a:t>spawns</a:t>
-            </a:r>
-          </a:p>
-        </p:txBody>
-      </p:sp>
       <p:sp>
         <p:nvSpPr>
           <p:cNvPr id="62" name="Textfeld 61">
@@ -13264,8 +12483,8 @@
         </p:nvSpPr>
         <p:spPr>
           <a:xfrm>
-            <a:off x="1476358" y="238438"/>
-            <a:ext cx="8703280" cy="800219"/>
+            <a:off x="1476367" y="238438"/>
+            <a:ext cx="8703280" cy="1354217"/>
           </a:xfrm>
           <a:prstGeom prst="rect">
             <a:avLst/>
@@ -13337,11 +12556,49 @@
             </a:r>
             <a:r>
               <a:rPr lang="de-DE" b="1"/>
-              <a:t>von System und Job in der </a:t>
+              <a:t>von </a:t>
+            </a:r>
+            <a:r>
+              <a:rPr lang="de-DE" b="1" i="1"/>
+              <a:t>System</a:t>
+            </a:r>
+            <a:r>
+              <a:rPr lang="de-DE" b="1"/>
+              <a:t> und </a:t>
+            </a:r>
+            <a:r>
+              <a:rPr lang="de-DE" b="1" i="1"/>
+              <a:t>Job</a:t>
+            </a:r>
+            <a:r>
+              <a:rPr lang="de-DE" b="1"/>
+              <a:t> in der </a:t>
             </a:r>
             <a:r>
               <a:rPr lang="de-DE" b="1" i="1"/>
               <a:t>JobHost.exe</a:t>
+            </a:r>
+          </a:p>
+          <a:p>
+            <a:pPr algn="ctr"/>
+            <a:r>
+              <a:rPr lang="de-DE" i="1">
+                <a:solidFill>
+                  <a:srgbClr val="00B050"/>
+                </a:solidFill>
+              </a:rPr>
+              <a:t>(prinzipiell ein sehr cooles „decoupling and isolation-concept“: </a:t>
+            </a:r>
+          </a:p>
+          <a:p>
+            <a:pPr algn="ctr"/>
+            <a:r>
+              <a:rPr lang="de-DE" i="1">
+                <a:solidFill>
+                  <a:srgbClr val="00B050"/>
+                </a:solidFill>
+              </a:rPr>
+              <a:t>session-starter fires -&gt; continuation in a fresh, isolated process-space!...)</a:t>
             </a:r>
           </a:p>
         </p:txBody>
@@ -13360,7 +12617,7 @@
         </p:nvSpPr>
         <p:spPr>
           <a:xfrm>
-            <a:off x="1561522" y="4443472"/>
+            <a:off x="1476367" y="4931115"/>
             <a:ext cx="9553817" cy="1723549"/>
           </a:xfrm>
           <a:prstGeom prst="rect">
@@ -13465,238 +12722,1215 @@
       </p:sp>
       <p:sp>
         <p:nvSpPr>
-          <p:cNvPr id="70" name="Pfeil: nach links 69">
+          <p:cNvPr id="5" name="Textfeld 4">
             <a:extLst>
               <a:ext uri="{FF2B5EF4-FFF2-40B4-BE49-F238E27FC236}">
-                <a16:creationId xmlns:a16="http://schemas.microsoft.com/office/drawing/2014/main" id="{1536D43B-1E69-F7B8-4F87-A0FD5F362E85}"/>
+                <a16:creationId xmlns:a16="http://schemas.microsoft.com/office/drawing/2014/main" id="{DCB02146-A086-858D-2DD5-1A4C53E506CF}"/>
               </a:ext>
             </a:extLst>
           </p:cNvPr>
-          <p:cNvSpPr/>
+          <p:cNvSpPr txBox="1"/>
           <p:nvPr/>
         </p:nvSpPr>
         <p:spPr>
           <a:xfrm>
-            <a:off x="3799699" y="2969365"/>
-            <a:ext cx="1311905" cy="707281"/>
-          </a:xfrm>
-          <a:prstGeom prst="leftArrow">
-            <a:avLst/>
-          </a:prstGeom>
-          <a:solidFill>
-            <a:srgbClr val="C00000"/>
-          </a:solidFill>
-          <a:ln>
-            <a:solidFill>
-              <a:srgbClr val="7030A0"/>
-            </a:solidFill>
-          </a:ln>
-        </p:spPr>
-        <p:style>
-          <a:lnRef idx="2">
-            <a:schemeClr val="accent1">
-              <a:shade val="15000"/>
-            </a:schemeClr>
-          </a:lnRef>
-          <a:fillRef idx="1">
-            <a:schemeClr val="accent1"/>
-          </a:fillRef>
-          <a:effectRef idx="0">
-            <a:schemeClr val="accent1"/>
-          </a:effectRef>
-          <a:fontRef idx="minor">
-            <a:schemeClr val="lt1"/>
-          </a:fontRef>
-        </p:style>
-        <p:txBody>
-          <a:bodyPr rtlCol="0" anchor="ctr"/>
-          <a:lstStyle/>
-          <a:p>
-            <a:pPr algn="ctr"/>
-            <a:endParaRPr lang="de-DE"/>
-          </a:p>
-        </p:txBody>
-      </p:sp>
-      <p:pic>
-        <p:nvPicPr>
-          <p:cNvPr id="73" name="Grafik 72">
-            <a:extLst>
-              <a:ext uri="{FF2B5EF4-FFF2-40B4-BE49-F238E27FC236}">
-                <a16:creationId xmlns:a16="http://schemas.microsoft.com/office/drawing/2014/main" id="{16156912-CE86-DB36-D615-C741938FB6F0}"/>
-              </a:ext>
-            </a:extLst>
-          </p:cNvPr>
-          <p:cNvPicPr>
-            <a:picLocks noChangeAspect="1"/>
-          </p:cNvPicPr>
-          <p:nvPr/>
-        </p:nvPicPr>
-        <p:blipFill>
-          <a:blip r:embed="rId2">
-            <a:extLst>
-              <a:ext uri="{28A0092B-C50C-407E-A947-70E740481C1C}">
-                <a14:useLocalDpi xmlns:a14="http://schemas.microsoft.com/office/drawing/2010/main" val="0"/>
-              </a:ext>
-            </a:extLst>
-          </a:blip>
-          <a:stretch>
-            <a:fillRect/>
-          </a:stretch>
-        </p:blipFill>
-        <p:spPr>
-          <a:xfrm>
-            <a:off x="1866421" y="2428990"/>
-            <a:ext cx="827913" cy="827913"/>
+            <a:off x="729595" y="1563009"/>
+            <a:ext cx="10732810" cy="369332"/>
           </a:xfrm>
           <a:prstGeom prst="rect">
             <a:avLst/>
           </a:prstGeom>
+          <a:noFill/>
         </p:spPr>
-      </p:pic>
-      <p:pic>
-        <p:nvPicPr>
-          <p:cNvPr id="77" name="Grafik 76">
+        <p:txBody>
+          <a:bodyPr wrap="none" rtlCol="0">
+            <a:spAutoFit/>
+          </a:bodyPr>
+          <a:lstStyle/>
+          <a:p>
+            <a:r>
+              <a:rPr lang="de-DE">
+                <a:solidFill>
+                  <a:schemeClr val="tx1">
+                    <a:lumMod val="50000"/>
+                    <a:lumOff val="50000"/>
+                  </a:schemeClr>
+                </a:solidFill>
+              </a:rPr>
+              <a:t>…and then i‘m gonna spoil it all, by designing </a:t>
+            </a:r>
+            <a:r>
+              <a:rPr lang="de-DE" i="1">
+                <a:solidFill>
+                  <a:schemeClr val="tx1">
+                    <a:lumMod val="50000"/>
+                    <a:lumOff val="50000"/>
+                  </a:schemeClr>
+                </a:solidFill>
+              </a:rPr>
+              <a:t>something stupid</a:t>
+            </a:r>
+            <a:r>
+              <a:rPr lang="de-DE">
+                <a:solidFill>
+                  <a:schemeClr val="tx1">
+                    <a:lumMod val="50000"/>
+                    <a:lumOff val="50000"/>
+                  </a:schemeClr>
+                </a:solidFill>
+              </a:rPr>
+              <a:t> like </a:t>
+            </a:r>
+            <a:r>
+              <a:rPr lang="de-DE" i="1">
+                <a:solidFill>
+                  <a:schemeClr val="tx1">
+                    <a:lumMod val="50000"/>
+                    <a:lumOff val="50000"/>
+                  </a:schemeClr>
+                </a:solidFill>
+              </a:rPr>
+              <a:t>„a shared runtime-dependency room“</a:t>
+            </a:r>
+            <a:r>
+              <a:rPr lang="de-DE">
+                <a:solidFill>
+                  <a:schemeClr val="tx1">
+                    <a:lumMod val="50000"/>
+                    <a:lumOff val="50000"/>
+                  </a:schemeClr>
+                </a:solidFill>
+              </a:rPr>
+              <a:t>… </a:t>
+            </a:r>
+          </a:p>
+        </p:txBody>
+      </p:sp>
+      <p:grpSp>
+        <p:nvGrpSpPr>
+          <p:cNvPr id="8" name="Gruppieren 7">
             <a:extLst>
               <a:ext uri="{FF2B5EF4-FFF2-40B4-BE49-F238E27FC236}">
-                <a16:creationId xmlns:a16="http://schemas.microsoft.com/office/drawing/2014/main" id="{FFFB93B2-C53C-4261-7D4C-71DCE8750523}"/>
+                <a16:creationId xmlns:a16="http://schemas.microsoft.com/office/drawing/2014/main" id="{476108D6-F08B-AD38-2AD1-D94537F47EA2}"/>
               </a:ext>
             </a:extLst>
           </p:cNvPr>
-          <p:cNvPicPr>
-            <a:picLocks noChangeAspect="1"/>
-          </p:cNvPicPr>
+          <p:cNvGrpSpPr/>
           <p:nvPr/>
-        </p:nvPicPr>
-        <p:blipFill>
-          <a:blip r:embed="rId3">
-            <a:extLst>
-              <a:ext uri="{28A0092B-C50C-407E-A947-70E740481C1C}">
-                <a14:useLocalDpi xmlns:a14="http://schemas.microsoft.com/office/drawing/2010/main" val="0"/>
-              </a:ext>
-            </a:extLst>
-          </a:blip>
-          <a:stretch>
-            <a:fillRect/>
-          </a:stretch>
-        </p:blipFill>
-        <p:spPr>
+        </p:nvGrpSpPr>
+        <p:grpSpPr>
           <a:xfrm>
-            <a:off x="1792126" y="3208513"/>
-            <a:ext cx="882650" cy="882650"/>
+            <a:off x="1771072" y="2072386"/>
+            <a:ext cx="8303713" cy="2713228"/>
+            <a:chOff x="1771072" y="2072386"/>
+            <a:chExt cx="8303713" cy="2713228"/>
           </a:xfrm>
-          <a:prstGeom prst="rect">
-            <a:avLst/>
-          </a:prstGeom>
-        </p:spPr>
-      </p:pic>
-      <p:pic>
-        <p:nvPicPr>
-          <p:cNvPr id="75" name="Grafik 74">
-            <a:extLst>
-              <a:ext uri="{FF2B5EF4-FFF2-40B4-BE49-F238E27FC236}">
-                <a16:creationId xmlns:a16="http://schemas.microsoft.com/office/drawing/2014/main" id="{C9A9F567-C88B-8C1F-9B5C-9AF7AF1B814F}"/>
-              </a:ext>
-            </a:extLst>
-          </p:cNvPr>
-          <p:cNvPicPr>
-            <a:picLocks noChangeAspect="1"/>
-          </p:cNvPicPr>
-          <p:nvPr/>
-        </p:nvPicPr>
-        <p:blipFill>
-          <a:blip r:embed="rId4">
-            <a:extLst>
-              <a:ext uri="{28A0092B-C50C-407E-A947-70E740481C1C}">
-                <a14:useLocalDpi xmlns:a14="http://schemas.microsoft.com/office/drawing/2010/main" val="0"/>
-              </a:ext>
-            </a:extLst>
-          </a:blip>
-          <a:stretch>
-            <a:fillRect/>
-          </a:stretch>
-        </p:blipFill>
-        <p:spPr>
-          <a:xfrm>
-            <a:off x="2720198" y="2658108"/>
-            <a:ext cx="1066800" cy="1066800"/>
-          </a:xfrm>
-          <a:prstGeom prst="rect">
-            <a:avLst/>
-          </a:prstGeom>
-        </p:spPr>
-      </p:pic>
-      <p:pic>
-        <p:nvPicPr>
-          <p:cNvPr id="3" name="Grafik 2">
-            <a:extLst>
-              <a:ext uri="{FF2B5EF4-FFF2-40B4-BE49-F238E27FC236}">
-                <a16:creationId xmlns:a16="http://schemas.microsoft.com/office/drawing/2014/main" id="{6A00C80A-8D50-378A-0B7B-84DC8F866922}"/>
-              </a:ext>
-            </a:extLst>
-          </p:cNvPr>
-          <p:cNvPicPr>
-            <a:picLocks noChangeAspect="1"/>
-          </p:cNvPicPr>
-          <p:nvPr/>
-        </p:nvPicPr>
-        <p:blipFill>
-          <a:blip r:embed="rId5">
-            <a:extLst>
-              <a:ext uri="{28A0092B-C50C-407E-A947-70E740481C1C}">
-                <a14:useLocalDpi xmlns:a14="http://schemas.microsoft.com/office/drawing/2010/main" val="0"/>
-              </a:ext>
-            </a:extLst>
-          </a:blip>
-          <a:stretch>
-            <a:fillRect/>
-          </a:stretch>
-        </p:blipFill>
-        <p:spPr>
-          <a:xfrm>
-            <a:off x="9560435" y="2842946"/>
-            <a:ext cx="457200" cy="457200"/>
-          </a:xfrm>
-          <a:prstGeom prst="rect">
-            <a:avLst/>
-          </a:prstGeom>
-        </p:spPr>
-      </p:pic>
-      <p:pic>
-        <p:nvPicPr>
-          <p:cNvPr id="2" name="Grafik 1">
-            <a:extLst>
-              <a:ext uri="{FF2B5EF4-FFF2-40B4-BE49-F238E27FC236}">
-                <a16:creationId xmlns:a16="http://schemas.microsoft.com/office/drawing/2014/main" id="{D73ECB46-C9A9-DAF5-D3DE-40D24C072FC7}"/>
-              </a:ext>
-            </a:extLst>
-          </p:cNvPr>
-          <p:cNvPicPr>
-            <a:picLocks noChangeAspect="1"/>
-          </p:cNvPicPr>
-          <p:nvPr/>
-        </p:nvPicPr>
-        <p:blipFill>
-          <a:blip r:embed="rId5">
-            <a:extLst>
-              <a:ext uri="{28A0092B-C50C-407E-A947-70E740481C1C}">
-                <a14:useLocalDpi xmlns:a14="http://schemas.microsoft.com/office/drawing/2010/main" val="0"/>
-              </a:ext>
-            </a:extLst>
-          </a:blip>
-          <a:stretch>
-            <a:fillRect/>
-          </a:stretch>
-        </p:blipFill>
-        <p:spPr>
-          <a:xfrm>
-            <a:off x="4216569" y="2886721"/>
-            <a:ext cx="842786" cy="842786"/>
-          </a:xfrm>
-          <a:prstGeom prst="rect">
-            <a:avLst/>
-          </a:prstGeom>
-        </p:spPr>
-      </p:pic>
+        </p:grpSpPr>
+        <p:grpSp>
+          <p:nvGrpSpPr>
+            <p:cNvPr id="4" name="Gruppieren 3">
+              <a:extLst>
+                <a:ext uri="{FF2B5EF4-FFF2-40B4-BE49-F238E27FC236}">
+                  <a16:creationId xmlns:a16="http://schemas.microsoft.com/office/drawing/2014/main" id="{54B98630-6773-7B36-E819-EF331F0DEE60}"/>
+                </a:ext>
+              </a:extLst>
+            </p:cNvPr>
+            <p:cNvGrpSpPr/>
+            <p:nvPr/>
+          </p:nvGrpSpPr>
+          <p:grpSpPr>
+            <a:xfrm>
+              <a:off x="1771072" y="2072386"/>
+              <a:ext cx="8303713" cy="2713228"/>
+              <a:chOff x="1713922" y="1439437"/>
+              <a:chExt cx="8303713" cy="2713228"/>
+            </a:xfrm>
+          </p:grpSpPr>
+          <p:grpSp>
+            <p:nvGrpSpPr>
+              <p:cNvPr id="66" name="Gruppieren 65">
+                <a:extLst>
+                  <a:ext uri="{FF2B5EF4-FFF2-40B4-BE49-F238E27FC236}">
+                    <a16:creationId xmlns:a16="http://schemas.microsoft.com/office/drawing/2014/main" id="{45F580C5-8F3A-EDDB-125F-5CD169EFA36D}"/>
+                  </a:ext>
+                </a:extLst>
+              </p:cNvPr>
+              <p:cNvGrpSpPr/>
+              <p:nvPr/>
+            </p:nvGrpSpPr>
+            <p:grpSpPr>
+              <a:xfrm>
+                <a:off x="1713922" y="1439437"/>
+                <a:ext cx="2992631" cy="2689384"/>
+                <a:chOff x="6606124" y="632008"/>
+                <a:chExt cx="1609958" cy="3976567"/>
+              </a:xfrm>
+              <a:solidFill>
+                <a:schemeClr val="bg1">
+                  <a:lumMod val="95000"/>
+                </a:schemeClr>
+              </a:solidFill>
+            </p:grpSpPr>
+            <p:sp>
+              <p:nvSpPr>
+                <p:cNvPr id="67" name="Rechteck 66">
+                  <a:extLst>
+                    <a:ext uri="{FF2B5EF4-FFF2-40B4-BE49-F238E27FC236}">
+                      <a16:creationId xmlns:a16="http://schemas.microsoft.com/office/drawing/2014/main" id="{91D6CEA9-DE63-5C3E-1FC1-F87CE5390BFE}"/>
+                    </a:ext>
+                  </a:extLst>
+                </p:cNvPr>
+                <p:cNvSpPr/>
+                <p:nvPr/>
+              </p:nvSpPr>
+              <p:spPr>
+                <a:xfrm>
+                  <a:off x="6606124" y="632008"/>
+                  <a:ext cx="1609958" cy="3976567"/>
+                </a:xfrm>
+                <a:prstGeom prst="rect">
+                  <a:avLst/>
+                </a:prstGeom>
+                <a:grpFill/>
+                <a:ln>
+                  <a:solidFill>
+                    <a:srgbClr val="7030A0"/>
+                  </a:solidFill>
+                </a:ln>
+              </p:spPr>
+              <p:style>
+                <a:lnRef idx="2">
+                  <a:schemeClr val="accent1">
+                    <a:shade val="15000"/>
+                  </a:schemeClr>
+                </a:lnRef>
+                <a:fillRef idx="1">
+                  <a:schemeClr val="accent1"/>
+                </a:fillRef>
+                <a:effectRef idx="0">
+                  <a:schemeClr val="accent1"/>
+                </a:effectRef>
+                <a:fontRef idx="minor">
+                  <a:schemeClr val="lt1"/>
+                </a:fontRef>
+              </p:style>
+              <p:txBody>
+                <a:bodyPr rtlCol="0" anchor="ctr"/>
+                <a:lstStyle/>
+                <a:p>
+                  <a:pPr algn="ctr"/>
+                  <a:endParaRPr lang="de-DE"/>
+                </a:p>
+              </p:txBody>
+            </p:sp>
+            <p:sp>
+              <p:nvSpPr>
+                <p:cNvPr id="69" name="Textfeld 68">
+                  <a:extLst>
+                    <a:ext uri="{FF2B5EF4-FFF2-40B4-BE49-F238E27FC236}">
+                      <a16:creationId xmlns:a16="http://schemas.microsoft.com/office/drawing/2014/main" id="{06971D2B-11F1-F847-86D5-A05053D8999A}"/>
+                    </a:ext>
+                  </a:extLst>
+                </p:cNvPr>
+                <p:cNvSpPr txBox="1"/>
+                <p:nvPr/>
+              </p:nvSpPr>
+              <p:spPr>
+                <a:xfrm>
+                  <a:off x="6607221" y="632143"/>
+                  <a:ext cx="1032705" cy="546100"/>
+                </a:xfrm>
+                <a:prstGeom prst="rect">
+                  <a:avLst/>
+                </a:prstGeom>
+                <a:noFill/>
+                <a:ln>
+                  <a:noFill/>
+                </a:ln>
+              </p:spPr>
+              <p:txBody>
+                <a:bodyPr wrap="square" rtlCol="0">
+                  <a:spAutoFit/>
+                </a:bodyPr>
+                <a:lstStyle/>
+                <a:p>
+                  <a:r>
+                    <a:rPr lang="de-DE" b="1">
+                      <a:solidFill>
+                        <a:srgbClr val="7030A0"/>
+                      </a:solidFill>
+                    </a:rPr>
+                    <a:t>Das Backend</a:t>
+                  </a:r>
+                </a:p>
+              </p:txBody>
+            </p:sp>
+          </p:grpSp>
+          <p:grpSp>
+            <p:nvGrpSpPr>
+              <p:cNvPr id="9" name="Gruppieren 8">
+                <a:extLst>
+                  <a:ext uri="{FF2B5EF4-FFF2-40B4-BE49-F238E27FC236}">
+                    <a16:creationId xmlns:a16="http://schemas.microsoft.com/office/drawing/2014/main" id="{B20A8C9F-F57C-4D2B-2026-E1D2C374B37C}"/>
+                  </a:ext>
+                </a:extLst>
+              </p:cNvPr>
+              <p:cNvGrpSpPr/>
+              <p:nvPr/>
+            </p:nvGrpSpPr>
+            <p:grpSpPr>
+              <a:xfrm>
+                <a:off x="5583614" y="1463281"/>
+                <a:ext cx="4423990" cy="2689384"/>
+                <a:chOff x="6606125" y="632008"/>
+                <a:chExt cx="1609958" cy="3976567"/>
+              </a:xfrm>
+              <a:solidFill>
+                <a:schemeClr val="bg1">
+                  <a:lumMod val="95000"/>
+                </a:schemeClr>
+              </a:solidFill>
+            </p:grpSpPr>
+            <p:sp>
+              <p:nvSpPr>
+                <p:cNvPr id="10" name="Rechteck 9">
+                  <a:extLst>
+                    <a:ext uri="{FF2B5EF4-FFF2-40B4-BE49-F238E27FC236}">
+                      <a16:creationId xmlns:a16="http://schemas.microsoft.com/office/drawing/2014/main" id="{6921B3CE-E7A0-EC84-AE42-D587DB52C342}"/>
+                    </a:ext>
+                  </a:extLst>
+                </p:cNvPr>
+                <p:cNvSpPr/>
+                <p:nvPr/>
+              </p:nvSpPr>
+              <p:spPr>
+                <a:xfrm>
+                  <a:off x="6606125" y="632008"/>
+                  <a:ext cx="1609958" cy="3976567"/>
+                </a:xfrm>
+                <a:prstGeom prst="rect">
+                  <a:avLst/>
+                </a:prstGeom>
+                <a:grpFill/>
+                <a:ln>
+                  <a:solidFill>
+                    <a:schemeClr val="tx2">
+                      <a:lumMod val="75000"/>
+                      <a:lumOff val="25000"/>
+                    </a:schemeClr>
+                  </a:solidFill>
+                </a:ln>
+              </p:spPr>
+              <p:style>
+                <a:lnRef idx="2">
+                  <a:schemeClr val="accent1">
+                    <a:shade val="15000"/>
+                  </a:schemeClr>
+                </a:lnRef>
+                <a:fillRef idx="1">
+                  <a:schemeClr val="accent1"/>
+                </a:fillRef>
+                <a:effectRef idx="0">
+                  <a:schemeClr val="accent1"/>
+                </a:effectRef>
+                <a:fontRef idx="minor">
+                  <a:schemeClr val="lt1"/>
+                </a:fontRef>
+              </p:style>
+              <p:txBody>
+                <a:bodyPr rtlCol="0" anchor="ctr"/>
+                <a:lstStyle/>
+                <a:p>
+                  <a:pPr algn="ctr"/>
+                  <a:endParaRPr lang="de-DE"/>
+                </a:p>
+              </p:txBody>
+            </p:sp>
+            <p:sp>
+              <p:nvSpPr>
+                <p:cNvPr id="11" name="Textfeld 10">
+                  <a:extLst>
+                    <a:ext uri="{FF2B5EF4-FFF2-40B4-BE49-F238E27FC236}">
+                      <a16:creationId xmlns:a16="http://schemas.microsoft.com/office/drawing/2014/main" id="{EC331E49-AA54-F3AD-0A2F-79D0B4B9BE38}"/>
+                    </a:ext>
+                  </a:extLst>
+                </p:cNvPr>
+                <p:cNvSpPr txBox="1"/>
+                <p:nvPr/>
+              </p:nvSpPr>
+              <p:spPr>
+                <a:xfrm>
+                  <a:off x="6607221" y="632142"/>
+                  <a:ext cx="899942" cy="659962"/>
+                </a:xfrm>
+                <a:prstGeom prst="rect">
+                  <a:avLst/>
+                </a:prstGeom>
+                <a:noFill/>
+              </p:spPr>
+              <p:txBody>
+                <a:bodyPr wrap="none" rtlCol="0">
+                  <a:spAutoFit/>
+                </a:bodyPr>
+                <a:lstStyle/>
+                <a:p>
+                  <a:r>
+                    <a:rPr lang="de-DE" b="1">
+                      <a:solidFill>
+                        <a:schemeClr val="tx2">
+                          <a:lumMod val="75000"/>
+                          <a:lumOff val="25000"/>
+                        </a:schemeClr>
+                      </a:solidFill>
+                    </a:rPr>
+                    <a:t>Jobhost.exe</a:t>
+                  </a:r>
+                </a:p>
+              </p:txBody>
+            </p:sp>
+          </p:grpSp>
+          <p:grpSp>
+            <p:nvGrpSpPr>
+              <p:cNvPr id="15" name="Gruppieren 14">
+                <a:extLst>
+                  <a:ext uri="{FF2B5EF4-FFF2-40B4-BE49-F238E27FC236}">
+                    <a16:creationId xmlns:a16="http://schemas.microsoft.com/office/drawing/2014/main" id="{00681D04-726D-1F17-2FF4-63D66A1BAB7E}"/>
+                  </a:ext>
+                </a:extLst>
+              </p:cNvPr>
+              <p:cNvGrpSpPr/>
+              <p:nvPr/>
+            </p:nvGrpSpPr>
+            <p:grpSpPr>
+              <a:xfrm>
+                <a:off x="8005905" y="3082401"/>
+                <a:ext cx="1822489" cy="765048"/>
+                <a:chOff x="164209" y="1524953"/>
+                <a:chExt cx="1822489" cy="765048"/>
+              </a:xfrm>
+            </p:grpSpPr>
+            <p:sp>
+              <p:nvSpPr>
+                <p:cNvPr id="16" name="Rechteck 15">
+                  <a:extLst>
+                    <a:ext uri="{FF2B5EF4-FFF2-40B4-BE49-F238E27FC236}">
+                      <a16:creationId xmlns:a16="http://schemas.microsoft.com/office/drawing/2014/main" id="{EE7FD0AE-ABF6-2A9B-559B-9DECBD0D518D}"/>
+                    </a:ext>
+                  </a:extLst>
+                </p:cNvPr>
+                <p:cNvSpPr/>
+                <p:nvPr/>
+              </p:nvSpPr>
+              <p:spPr>
+                <a:xfrm>
+                  <a:off x="164209" y="1524953"/>
+                  <a:ext cx="1803699" cy="765048"/>
+                </a:xfrm>
+                <a:prstGeom prst="rect">
+                  <a:avLst/>
+                </a:prstGeom>
+                <a:solidFill>
+                  <a:schemeClr val="tx2">
+                    <a:lumMod val="10000"/>
+                    <a:lumOff val="90000"/>
+                  </a:schemeClr>
+                </a:solidFill>
+                <a:ln>
+                  <a:solidFill>
+                    <a:schemeClr val="tx2">
+                      <a:lumMod val="75000"/>
+                      <a:lumOff val="25000"/>
+                    </a:schemeClr>
+                  </a:solidFill>
+                </a:ln>
+              </p:spPr>
+              <p:style>
+                <a:lnRef idx="2">
+                  <a:schemeClr val="accent1">
+                    <a:shade val="15000"/>
+                  </a:schemeClr>
+                </a:lnRef>
+                <a:fillRef idx="1">
+                  <a:schemeClr val="accent1"/>
+                </a:fillRef>
+                <a:effectRef idx="0">
+                  <a:schemeClr val="accent1"/>
+                </a:effectRef>
+                <a:fontRef idx="minor">
+                  <a:schemeClr val="lt1"/>
+                </a:fontRef>
+              </p:style>
+              <p:txBody>
+                <a:bodyPr rtlCol="0" anchor="ctr"/>
+                <a:lstStyle/>
+                <a:p>
+                  <a:pPr algn="ctr"/>
+                  <a:endParaRPr lang="de-DE"/>
+                </a:p>
+              </p:txBody>
+            </p:sp>
+            <p:sp>
+              <p:nvSpPr>
+                <p:cNvPr id="17" name="Textfeld 16">
+                  <a:extLst>
+                    <a:ext uri="{FF2B5EF4-FFF2-40B4-BE49-F238E27FC236}">
+                      <a16:creationId xmlns:a16="http://schemas.microsoft.com/office/drawing/2014/main" id="{66E59F33-9673-BF9A-2A76-B7ED8A290DEA}"/>
+                    </a:ext>
+                  </a:extLst>
+                </p:cNvPr>
+                <p:cNvSpPr txBox="1"/>
+                <p:nvPr/>
+              </p:nvSpPr>
+              <p:spPr>
+                <a:xfrm>
+                  <a:off x="182999" y="1686886"/>
+                  <a:ext cx="1803699" cy="369332"/>
+                </a:xfrm>
+                <a:prstGeom prst="rect">
+                  <a:avLst/>
+                </a:prstGeom>
+                <a:noFill/>
+              </p:spPr>
+              <p:txBody>
+                <a:bodyPr wrap="none" rtlCol="0">
+                  <a:spAutoFit/>
+                </a:bodyPr>
+                <a:lstStyle/>
+                <a:p>
+                  <a:r>
+                    <a:rPr lang="de-DE" b="1">
+                      <a:solidFill>
+                        <a:schemeClr val="tx2">
+                          <a:lumMod val="75000"/>
+                          <a:lumOff val="25000"/>
+                        </a:schemeClr>
+                      </a:solidFill>
+                    </a:rPr>
+                    <a:t>job-assemblies</a:t>
+                  </a:r>
+                </a:p>
+              </p:txBody>
+            </p:sp>
+          </p:grpSp>
+          <p:grpSp>
+            <p:nvGrpSpPr>
+              <p:cNvPr id="19" name="Gruppieren 18">
+                <a:extLst>
+                  <a:ext uri="{FF2B5EF4-FFF2-40B4-BE49-F238E27FC236}">
+                    <a16:creationId xmlns:a16="http://schemas.microsoft.com/office/drawing/2014/main" id="{41C2E713-FEED-828B-784C-F67174EC88F8}"/>
+                  </a:ext>
+                </a:extLst>
+              </p:cNvPr>
+              <p:cNvGrpSpPr/>
+              <p:nvPr/>
+            </p:nvGrpSpPr>
+            <p:grpSpPr>
+              <a:xfrm>
+                <a:off x="5897322" y="1853741"/>
+                <a:ext cx="3922316" cy="708234"/>
+                <a:chOff x="164209" y="1516532"/>
+                <a:chExt cx="1803699" cy="773469"/>
+              </a:xfrm>
+            </p:grpSpPr>
+            <p:sp>
+              <p:nvSpPr>
+                <p:cNvPr id="21" name="Rechteck 20">
+                  <a:extLst>
+                    <a:ext uri="{FF2B5EF4-FFF2-40B4-BE49-F238E27FC236}">
+                      <a16:creationId xmlns:a16="http://schemas.microsoft.com/office/drawing/2014/main" id="{F5734D98-A5B2-DFFF-01E1-0795FEF53E54}"/>
+                    </a:ext>
+                  </a:extLst>
+                </p:cNvPr>
+                <p:cNvSpPr/>
+                <p:nvPr/>
+              </p:nvSpPr>
+              <p:spPr>
+                <a:xfrm>
+                  <a:off x="164209" y="1524953"/>
+                  <a:ext cx="1803699" cy="765048"/>
+                </a:xfrm>
+                <a:prstGeom prst="rect">
+                  <a:avLst/>
+                </a:prstGeom>
+                <a:solidFill>
+                  <a:schemeClr val="tx2">
+                    <a:lumMod val="10000"/>
+                    <a:lumOff val="90000"/>
+                  </a:schemeClr>
+                </a:solidFill>
+                <a:ln>
+                  <a:solidFill>
+                    <a:schemeClr val="tx2">
+                      <a:lumMod val="75000"/>
+                      <a:lumOff val="25000"/>
+                    </a:schemeClr>
+                  </a:solidFill>
+                </a:ln>
+              </p:spPr>
+              <p:style>
+                <a:lnRef idx="2">
+                  <a:schemeClr val="accent1">
+                    <a:shade val="15000"/>
+                  </a:schemeClr>
+                </a:lnRef>
+                <a:fillRef idx="1">
+                  <a:schemeClr val="accent1"/>
+                </a:fillRef>
+                <a:effectRef idx="0">
+                  <a:schemeClr val="accent1"/>
+                </a:effectRef>
+                <a:fontRef idx="minor">
+                  <a:schemeClr val="lt1"/>
+                </a:fontRef>
+              </p:style>
+              <p:txBody>
+                <a:bodyPr rtlCol="0" anchor="ctr"/>
+                <a:lstStyle/>
+                <a:p>
+                  <a:pPr algn="ctr"/>
+                  <a:endParaRPr lang="de-DE"/>
+                </a:p>
+              </p:txBody>
+            </p:sp>
+            <p:sp>
+              <p:nvSpPr>
+                <p:cNvPr id="28" name="Textfeld 27">
+                  <a:extLst>
+                    <a:ext uri="{FF2B5EF4-FFF2-40B4-BE49-F238E27FC236}">
+                      <a16:creationId xmlns:a16="http://schemas.microsoft.com/office/drawing/2014/main" id="{7201EE90-CEA3-3A25-B815-CBC87BEDB594}"/>
+                    </a:ext>
+                  </a:extLst>
+                </p:cNvPr>
+                <p:cNvSpPr txBox="1"/>
+                <p:nvPr/>
+              </p:nvSpPr>
+              <p:spPr>
+                <a:xfrm>
+                  <a:off x="198602" y="1516532"/>
+                  <a:ext cx="1109599" cy="369332"/>
+                </a:xfrm>
+                <a:prstGeom prst="rect">
+                  <a:avLst/>
+                </a:prstGeom>
+                <a:noFill/>
+              </p:spPr>
+              <p:txBody>
+                <a:bodyPr wrap="none" rtlCol="0">
+                  <a:spAutoFit/>
+                </a:bodyPr>
+                <a:lstStyle/>
+                <a:p>
+                  <a:r>
+                    <a:rPr lang="de-DE" b="1">
+                      <a:solidFill>
+                        <a:schemeClr val="tx2">
+                          <a:lumMod val="75000"/>
+                          <a:lumOff val="25000"/>
+                        </a:schemeClr>
+                      </a:solidFill>
+                    </a:rPr>
+                    <a:t>Base-job</a:t>
+                  </a:r>
+                </a:p>
+              </p:txBody>
+            </p:sp>
+          </p:grpSp>
+          <p:sp>
+            <p:nvSpPr>
+              <p:cNvPr id="52" name="Textfeld 51">
+                <a:extLst>
+                  <a:ext uri="{FF2B5EF4-FFF2-40B4-BE49-F238E27FC236}">
+                    <a16:creationId xmlns:a16="http://schemas.microsoft.com/office/drawing/2014/main" id="{AB395DAA-F396-28B1-E9C1-A745386E2EEB}"/>
+                  </a:ext>
+                </a:extLst>
+              </p:cNvPr>
+              <p:cNvSpPr txBox="1"/>
+              <p:nvPr/>
+            </p:nvSpPr>
+            <p:spPr>
+              <a:xfrm>
+                <a:off x="5124305" y="2724919"/>
+                <a:ext cx="2472944" cy="1169551"/>
+              </a:xfrm>
+              <a:prstGeom prst="rect">
+                <a:avLst/>
+              </a:prstGeom>
+              <a:solidFill>
+                <a:srgbClr val="FF9999"/>
+              </a:solidFill>
+            </p:spPr>
+            <p:txBody>
+              <a:bodyPr wrap="square">
+                <a:spAutoFit/>
+              </a:bodyPr>
+              <a:lstStyle/>
+              <a:p>
+                <a:r>
+                  <a:rPr lang="de-DE" sz="1000" b="1"/>
+                  <a:t>HaevgRZ.JobSystem.SessionStore.dll</a:t>
+                </a:r>
+              </a:p>
+              <a:p>
+                <a:r>
+                  <a:rPr lang="de-DE" sz="1000" b="1"/>
+                  <a:t>HaevgRZ.JobSystem.Core.dll</a:t>
+                </a:r>
+              </a:p>
+              <a:p>
+                <a:r>
+                  <a:rPr lang="de-DE" sz="1000" b="1"/>
+                  <a:t>HaevgRZ.JobSystem.Contracts.dll</a:t>
+                </a:r>
+              </a:p>
+              <a:p>
+                <a:r>
+                  <a:rPr lang="de-DE" sz="1000" b="1"/>
+                  <a:t>HaevgRZ.JobSystem.Lib.Core.dll</a:t>
+                </a:r>
+              </a:p>
+              <a:p>
+                <a:r>
+                  <a:rPr lang="de-DE" sz="1000" b="1"/>
+                  <a:t>HaevgRZ.JobSystem.Lib.Messaging.dll</a:t>
+                </a:r>
+              </a:p>
+              <a:p>
+                <a:r>
+                  <a:rPr lang="de-DE" sz="1000" b="1"/>
+                  <a:t>„GlobalConfig“</a:t>
+                </a:r>
+              </a:p>
+              <a:p>
+                <a:r>
+                  <a:rPr lang="de-DE" sz="1000" b="1"/>
+                  <a:t>…</a:t>
+                </a:r>
+              </a:p>
+            </p:txBody>
+          </p:sp>
+          <p:sp>
+            <p:nvSpPr>
+              <p:cNvPr id="55" name="Textfeld 54">
+                <a:extLst>
+                  <a:ext uri="{FF2B5EF4-FFF2-40B4-BE49-F238E27FC236}">
+                    <a16:creationId xmlns:a16="http://schemas.microsoft.com/office/drawing/2014/main" id="{35A56320-1BAA-14D4-257E-BC2DD55217FB}"/>
+                  </a:ext>
+                </a:extLst>
+              </p:cNvPr>
+              <p:cNvSpPr txBox="1"/>
+              <p:nvPr/>
+            </p:nvSpPr>
+            <p:spPr>
+              <a:xfrm>
+                <a:off x="7927182" y="2724919"/>
+                <a:ext cx="1905009" cy="338554"/>
+              </a:xfrm>
+              <a:prstGeom prst="rect">
+                <a:avLst/>
+              </a:prstGeom>
+              <a:noFill/>
+            </p:spPr>
+            <p:txBody>
+              <a:bodyPr wrap="none" rtlCol="0">
+                <a:spAutoFit/>
+              </a:bodyPr>
+              <a:lstStyle/>
+              <a:p>
+                <a:r>
+                  <a:rPr lang="de-DE" sz="1600" b="1">
+                    <a:solidFill>
+                      <a:srgbClr val="FF0000"/>
+                    </a:solidFill>
+                  </a:rPr>
+                  <a:t>AssemblyResolve:</a:t>
+                </a:r>
+              </a:p>
+            </p:txBody>
+          </p:sp>
+          <p:grpSp>
+            <p:nvGrpSpPr>
+              <p:cNvPr id="56" name="Gruppieren 55">
+                <a:extLst>
+                  <a:ext uri="{FF2B5EF4-FFF2-40B4-BE49-F238E27FC236}">
+                    <a16:creationId xmlns:a16="http://schemas.microsoft.com/office/drawing/2014/main" id="{840FE24B-8ABF-C58F-FA7B-285D8FF784A4}"/>
+                  </a:ext>
+                </a:extLst>
+              </p:cNvPr>
+              <p:cNvGrpSpPr/>
+              <p:nvPr/>
+            </p:nvGrpSpPr>
+            <p:grpSpPr>
+              <a:xfrm>
+                <a:off x="2898340" y="1918813"/>
+                <a:ext cx="1803699" cy="643577"/>
+                <a:chOff x="164209" y="1588453"/>
+                <a:chExt cx="1803699" cy="643577"/>
+              </a:xfrm>
+            </p:grpSpPr>
+            <p:sp>
+              <p:nvSpPr>
+                <p:cNvPr id="57" name="Rechteck 56">
+                  <a:extLst>
+                    <a:ext uri="{FF2B5EF4-FFF2-40B4-BE49-F238E27FC236}">
+                      <a16:creationId xmlns:a16="http://schemas.microsoft.com/office/drawing/2014/main" id="{5339CB1C-0982-812A-5B00-A1C734F2D7B9}"/>
+                    </a:ext>
+                  </a:extLst>
+                </p:cNvPr>
+                <p:cNvSpPr/>
+                <p:nvPr/>
+              </p:nvSpPr>
+              <p:spPr>
+                <a:xfrm>
+                  <a:off x="164209" y="1588453"/>
+                  <a:ext cx="1803699" cy="643577"/>
+                </a:xfrm>
+                <a:prstGeom prst="rect">
+                  <a:avLst/>
+                </a:prstGeom>
+                <a:solidFill>
+                  <a:schemeClr val="tx2">
+                    <a:lumMod val="10000"/>
+                    <a:lumOff val="90000"/>
+                  </a:schemeClr>
+                </a:solidFill>
+                <a:ln>
+                  <a:solidFill>
+                    <a:schemeClr val="tx2">
+                      <a:lumMod val="75000"/>
+                      <a:lumOff val="25000"/>
+                    </a:schemeClr>
+                  </a:solidFill>
+                </a:ln>
+              </p:spPr>
+              <p:style>
+                <a:lnRef idx="2">
+                  <a:schemeClr val="accent1">
+                    <a:shade val="15000"/>
+                  </a:schemeClr>
+                </a:lnRef>
+                <a:fillRef idx="1">
+                  <a:schemeClr val="accent1"/>
+                </a:fillRef>
+                <a:effectRef idx="0">
+                  <a:schemeClr val="accent1"/>
+                </a:effectRef>
+                <a:fontRef idx="minor">
+                  <a:schemeClr val="lt1"/>
+                </a:fontRef>
+              </p:style>
+              <p:txBody>
+                <a:bodyPr rtlCol="0" anchor="ctr"/>
+                <a:lstStyle/>
+                <a:p>
+                  <a:pPr algn="ctr"/>
+                  <a:endParaRPr lang="de-DE"/>
+                </a:p>
+              </p:txBody>
+            </p:sp>
+            <p:sp>
+              <p:nvSpPr>
+                <p:cNvPr id="58" name="Textfeld 57">
+                  <a:extLst>
+                    <a:ext uri="{FF2B5EF4-FFF2-40B4-BE49-F238E27FC236}">
+                      <a16:creationId xmlns:a16="http://schemas.microsoft.com/office/drawing/2014/main" id="{FDA82363-6616-3120-15F7-E15ADFD3A277}"/>
+                    </a:ext>
+                  </a:extLst>
+                </p:cNvPr>
+                <p:cNvSpPr txBox="1"/>
+                <p:nvPr/>
+              </p:nvSpPr>
+              <p:spPr>
+                <a:xfrm>
+                  <a:off x="216082" y="1606413"/>
+                  <a:ext cx="1741311" cy="369332"/>
+                </a:xfrm>
+                <a:prstGeom prst="rect">
+                  <a:avLst/>
+                </a:prstGeom>
+                <a:noFill/>
+              </p:spPr>
+              <p:txBody>
+                <a:bodyPr wrap="none" rtlCol="0">
+                  <a:spAutoFit/>
+                </a:bodyPr>
+                <a:lstStyle/>
+                <a:p>
+                  <a:r>
+                    <a:rPr lang="de-DE" b="1">
+                      <a:solidFill>
+                        <a:schemeClr val="tx2">
+                          <a:lumMod val="75000"/>
+                          <a:lumOff val="25000"/>
+                        </a:schemeClr>
+                      </a:solidFill>
+                    </a:rPr>
+                    <a:t>SessionStarter</a:t>
+                  </a:r>
+                </a:p>
+              </p:txBody>
+            </p:sp>
+          </p:grpSp>
+          <p:sp>
+            <p:nvSpPr>
+              <p:cNvPr id="60" name="Pfeil: nach rechts 59">
+                <a:extLst>
+                  <a:ext uri="{FF2B5EF4-FFF2-40B4-BE49-F238E27FC236}">
+                    <a16:creationId xmlns:a16="http://schemas.microsoft.com/office/drawing/2014/main" id="{3E79FB88-779C-13F8-B2BF-A117237A18A3}"/>
+                  </a:ext>
+                </a:extLst>
+              </p:cNvPr>
+              <p:cNvSpPr/>
+              <p:nvPr/>
+            </p:nvSpPr>
+            <p:spPr>
+              <a:xfrm>
+                <a:off x="4723504" y="2146441"/>
+                <a:ext cx="841320" cy="445626"/>
+              </a:xfrm>
+              <a:prstGeom prst="rightArrow">
+                <a:avLst/>
+              </a:prstGeom>
+              <a:solidFill>
+                <a:schemeClr val="accent6"/>
+              </a:solidFill>
+              <a:ln>
+                <a:solidFill>
+                  <a:srgbClr val="0070C0"/>
+                </a:solidFill>
+              </a:ln>
+            </p:spPr>
+            <p:style>
+              <a:lnRef idx="2">
+                <a:schemeClr val="accent1">
+                  <a:shade val="15000"/>
+                </a:schemeClr>
+              </a:lnRef>
+              <a:fillRef idx="1">
+                <a:schemeClr val="accent1"/>
+              </a:fillRef>
+              <a:effectRef idx="0">
+                <a:schemeClr val="accent1"/>
+              </a:effectRef>
+              <a:fontRef idx="minor">
+                <a:schemeClr val="lt1"/>
+              </a:fontRef>
+            </p:style>
+            <p:txBody>
+              <a:bodyPr rtlCol="0" anchor="ctr"/>
+              <a:lstStyle/>
+              <a:p>
+                <a:pPr algn="ctr"/>
+                <a:endParaRPr lang="de-DE"/>
+              </a:p>
+            </p:txBody>
+          </p:sp>
+          <p:sp>
+            <p:nvSpPr>
+              <p:cNvPr id="61" name="Textfeld 60">
+                <a:extLst>
+                  <a:ext uri="{FF2B5EF4-FFF2-40B4-BE49-F238E27FC236}">
+                    <a16:creationId xmlns:a16="http://schemas.microsoft.com/office/drawing/2014/main" id="{62C7E6E6-A5E4-68DB-279A-D74781522F4F}"/>
+                  </a:ext>
+                </a:extLst>
+              </p:cNvPr>
+              <p:cNvSpPr txBox="1"/>
+              <p:nvPr/>
+            </p:nvSpPr>
+            <p:spPr>
+              <a:xfrm>
+                <a:off x="4666437" y="1778023"/>
+                <a:ext cx="955454" cy="369332"/>
+              </a:xfrm>
+              <a:prstGeom prst="rect">
+                <a:avLst/>
+              </a:prstGeom>
+              <a:noFill/>
+            </p:spPr>
+            <p:txBody>
+              <a:bodyPr wrap="none" rtlCol="0">
+                <a:spAutoFit/>
+              </a:bodyPr>
+              <a:lstStyle/>
+              <a:p>
+                <a:r>
+                  <a:rPr lang="de-DE"/>
+                  <a:t>spawns</a:t>
+                </a:r>
+              </a:p>
+            </p:txBody>
+          </p:sp>
+          <p:sp>
+            <p:nvSpPr>
+              <p:cNvPr id="70" name="Pfeil: nach links 69">
+                <a:extLst>
+                  <a:ext uri="{FF2B5EF4-FFF2-40B4-BE49-F238E27FC236}">
+                    <a16:creationId xmlns:a16="http://schemas.microsoft.com/office/drawing/2014/main" id="{1536D43B-1E69-F7B8-4F87-A0FD5F362E85}"/>
+                  </a:ext>
+                </a:extLst>
+              </p:cNvPr>
+              <p:cNvSpPr/>
+              <p:nvPr/>
+            </p:nvSpPr>
+            <p:spPr>
+              <a:xfrm>
+                <a:off x="3799699" y="2969365"/>
+                <a:ext cx="1311905" cy="707281"/>
+              </a:xfrm>
+              <a:prstGeom prst="leftArrow">
+                <a:avLst/>
+              </a:prstGeom>
+              <a:solidFill>
+                <a:srgbClr val="C00000"/>
+              </a:solidFill>
+              <a:ln>
+                <a:solidFill>
+                  <a:srgbClr val="7030A0"/>
+                </a:solidFill>
+              </a:ln>
+            </p:spPr>
+            <p:style>
+              <a:lnRef idx="2">
+                <a:schemeClr val="accent1">
+                  <a:shade val="15000"/>
+                </a:schemeClr>
+              </a:lnRef>
+              <a:fillRef idx="1">
+                <a:schemeClr val="accent1"/>
+              </a:fillRef>
+              <a:effectRef idx="0">
+                <a:schemeClr val="accent1"/>
+              </a:effectRef>
+              <a:fontRef idx="minor">
+                <a:schemeClr val="lt1"/>
+              </a:fontRef>
+            </p:style>
+            <p:txBody>
+              <a:bodyPr rtlCol="0" anchor="ctr"/>
+              <a:lstStyle/>
+              <a:p>
+                <a:pPr algn="ctr"/>
+                <a:endParaRPr lang="de-DE"/>
+              </a:p>
+            </p:txBody>
+          </p:sp>
+          <p:pic>
+            <p:nvPicPr>
+              <p:cNvPr id="73" name="Grafik 72">
+                <a:extLst>
+                  <a:ext uri="{FF2B5EF4-FFF2-40B4-BE49-F238E27FC236}">
+                    <a16:creationId xmlns:a16="http://schemas.microsoft.com/office/drawing/2014/main" id="{16156912-CE86-DB36-D615-C741938FB6F0}"/>
+                  </a:ext>
+                </a:extLst>
+              </p:cNvPr>
+              <p:cNvPicPr>
+                <a:picLocks noChangeAspect="1"/>
+              </p:cNvPicPr>
+              <p:nvPr/>
+            </p:nvPicPr>
+            <p:blipFill>
+              <a:blip r:embed="rId2">
+                <a:extLst>
+                  <a:ext uri="{28A0092B-C50C-407E-A947-70E740481C1C}">
+                    <a14:useLocalDpi xmlns:a14="http://schemas.microsoft.com/office/drawing/2010/main" val="0"/>
+                  </a:ext>
+                </a:extLst>
+              </a:blip>
+              <a:stretch>
+                <a:fillRect/>
+              </a:stretch>
+            </p:blipFill>
+            <p:spPr>
+              <a:xfrm>
+                <a:off x="1866421" y="2428990"/>
+                <a:ext cx="827913" cy="827913"/>
+              </a:xfrm>
+              <a:prstGeom prst="rect">
+                <a:avLst/>
+              </a:prstGeom>
+            </p:spPr>
+          </p:pic>
+          <p:pic>
+            <p:nvPicPr>
+              <p:cNvPr id="77" name="Grafik 76">
+                <a:extLst>
+                  <a:ext uri="{FF2B5EF4-FFF2-40B4-BE49-F238E27FC236}">
+                    <a16:creationId xmlns:a16="http://schemas.microsoft.com/office/drawing/2014/main" id="{FFFB93B2-C53C-4261-7D4C-71DCE8750523}"/>
+                  </a:ext>
+                </a:extLst>
+              </p:cNvPr>
+              <p:cNvPicPr>
+                <a:picLocks noChangeAspect="1"/>
+              </p:cNvPicPr>
+              <p:nvPr/>
+            </p:nvPicPr>
+            <p:blipFill>
+              <a:blip r:embed="rId3">
+                <a:extLst>
+                  <a:ext uri="{28A0092B-C50C-407E-A947-70E740481C1C}">
+                    <a14:useLocalDpi xmlns:a14="http://schemas.microsoft.com/office/drawing/2010/main" val="0"/>
+                  </a:ext>
+                </a:extLst>
+              </a:blip>
+              <a:stretch>
+                <a:fillRect/>
+              </a:stretch>
+            </p:blipFill>
+            <p:spPr>
+              <a:xfrm>
+                <a:off x="1792126" y="3208513"/>
+                <a:ext cx="882650" cy="882650"/>
+              </a:xfrm>
+              <a:prstGeom prst="rect">
+                <a:avLst/>
+              </a:prstGeom>
+            </p:spPr>
+          </p:pic>
+          <p:pic>
+            <p:nvPicPr>
+              <p:cNvPr id="75" name="Grafik 74">
+                <a:extLst>
+                  <a:ext uri="{FF2B5EF4-FFF2-40B4-BE49-F238E27FC236}">
+                    <a16:creationId xmlns:a16="http://schemas.microsoft.com/office/drawing/2014/main" id="{C9A9F567-C88B-8C1F-9B5C-9AF7AF1B814F}"/>
+                  </a:ext>
+                </a:extLst>
+              </p:cNvPr>
+              <p:cNvPicPr>
+                <a:picLocks noChangeAspect="1"/>
+              </p:cNvPicPr>
+              <p:nvPr/>
+            </p:nvPicPr>
+            <p:blipFill>
+              <a:blip r:embed="rId4">
+                <a:extLst>
+                  <a:ext uri="{28A0092B-C50C-407E-A947-70E740481C1C}">
+                    <a14:useLocalDpi xmlns:a14="http://schemas.microsoft.com/office/drawing/2010/main" val="0"/>
+                  </a:ext>
+                </a:extLst>
+              </a:blip>
+              <a:stretch>
+                <a:fillRect/>
+              </a:stretch>
+            </p:blipFill>
+            <p:spPr>
+              <a:xfrm>
+                <a:off x="2720198" y="2658108"/>
+                <a:ext cx="1066800" cy="1066800"/>
+              </a:xfrm>
+              <a:prstGeom prst="rect">
+                <a:avLst/>
+              </a:prstGeom>
+            </p:spPr>
+          </p:pic>
+          <p:pic>
+            <p:nvPicPr>
+              <p:cNvPr id="3" name="Grafik 2">
+                <a:extLst>
+                  <a:ext uri="{FF2B5EF4-FFF2-40B4-BE49-F238E27FC236}">
+                    <a16:creationId xmlns:a16="http://schemas.microsoft.com/office/drawing/2014/main" id="{6A00C80A-8D50-378A-0B7B-84DC8F866922}"/>
+                  </a:ext>
+                </a:extLst>
+              </p:cNvPr>
+              <p:cNvPicPr>
+                <a:picLocks noChangeAspect="1"/>
+              </p:cNvPicPr>
+              <p:nvPr/>
+            </p:nvPicPr>
+            <p:blipFill>
+              <a:blip r:embed="rId5">
+                <a:extLst>
+                  <a:ext uri="{28A0092B-C50C-407E-A947-70E740481C1C}">
+                    <a14:useLocalDpi xmlns:a14="http://schemas.microsoft.com/office/drawing/2010/main" val="0"/>
+                  </a:ext>
+                </a:extLst>
+              </a:blip>
+              <a:stretch>
+                <a:fillRect/>
+              </a:stretch>
+            </p:blipFill>
+            <p:spPr>
+              <a:xfrm>
+                <a:off x="9560435" y="2842946"/>
+                <a:ext cx="457200" cy="457200"/>
+              </a:xfrm>
+              <a:prstGeom prst="rect">
+                <a:avLst/>
+              </a:prstGeom>
+            </p:spPr>
+          </p:pic>
+          <p:pic>
+            <p:nvPicPr>
+              <p:cNvPr id="2" name="Grafik 1">
+                <a:extLst>
+                  <a:ext uri="{FF2B5EF4-FFF2-40B4-BE49-F238E27FC236}">
+                    <a16:creationId xmlns:a16="http://schemas.microsoft.com/office/drawing/2014/main" id="{D73ECB46-C9A9-DAF5-D3DE-40D24C072FC7}"/>
+                  </a:ext>
+                </a:extLst>
+              </p:cNvPr>
+              <p:cNvPicPr>
+                <a:picLocks noChangeAspect="1"/>
+              </p:cNvPicPr>
+              <p:nvPr/>
+            </p:nvPicPr>
+            <p:blipFill>
+              <a:blip r:embed="rId5">
+                <a:extLst>
+                  <a:ext uri="{28A0092B-C50C-407E-A947-70E740481C1C}">
+                    <a14:useLocalDpi xmlns:a14="http://schemas.microsoft.com/office/drawing/2010/main" val="0"/>
+                  </a:ext>
+                </a:extLst>
+              </a:blip>
+              <a:stretch>
+                <a:fillRect/>
+              </a:stretch>
+            </p:blipFill>
+            <p:spPr>
+              <a:xfrm>
+                <a:off x="4216569" y="2886721"/>
+                <a:ext cx="842786" cy="842786"/>
+              </a:xfrm>
+              <a:prstGeom prst="rect">
+                <a:avLst/>
+              </a:prstGeom>
+            </p:spPr>
+          </p:pic>
+        </p:grpSp>
+        <p:pic>
+          <p:nvPicPr>
+            <p:cNvPr id="7" name="Grafik 6">
+              <a:extLst>
+                <a:ext uri="{FF2B5EF4-FFF2-40B4-BE49-F238E27FC236}">
+                  <a16:creationId xmlns:a16="http://schemas.microsoft.com/office/drawing/2014/main" id="{F5CA87CD-B0E2-EF48-F35C-73E9BD665F2D}"/>
+                </a:ext>
+              </a:extLst>
+            </p:cNvPr>
+            <p:cNvPicPr>
+              <a:picLocks noChangeAspect="1"/>
+            </p:cNvPicPr>
+            <p:nvPr/>
+          </p:nvPicPr>
+          <p:blipFill>
+            <a:blip r:embed="rId6">
+              <a:extLst>
+                <a:ext uri="{28A0092B-C50C-407E-A947-70E740481C1C}">
+                  <a14:useLocalDpi xmlns:a14="http://schemas.microsoft.com/office/drawing/2010/main" val="0"/>
+                </a:ext>
+              </a:extLst>
+            </a:blip>
+            <a:stretch>
+              <a:fillRect/>
+            </a:stretch>
+          </p:blipFill>
+          <p:spPr>
+            <a:xfrm>
+              <a:off x="4904161" y="2732914"/>
+              <a:ext cx="424688" cy="424688"/>
+            </a:xfrm>
+            <a:prstGeom prst="rect">
+              <a:avLst/>
+            </a:prstGeom>
+          </p:spPr>
+        </p:pic>
+      </p:grpSp>
     </p:spTree>
     <p:extLst>
       <p:ext uri="{BB962C8B-B14F-4D97-AF65-F5344CB8AC3E}">
@@ -13741,11 +13975,7 @@
                                           </p:stCondLst>
                                         </p:cTn>
                                         <p:tgtEl>
-                                          <p:spTgt spid="65">
-                                            <p:txEl>
-                                              <p:pRg st="0" end="0"/>
-                                            </p:txEl>
-                                          </p:spTgt>
+                                          <p:spTgt spid="8"/>
                                         </p:tgtEl>
                                         <p:attrNameLst>
                                           <p:attrName>style.visibility</p:attrName>
@@ -13759,7 +13989,7 @@
                                 </p:cTn>
                               </p:par>
                               <p:par>
-                                <p:cTn id="7" presetID="1" presetClass="entr" presetSubtype="0" fill="hold" nodeType="withEffect">
+                                <p:cTn id="7" presetID="1" presetClass="entr" presetSubtype="0" fill="hold" grpId="0" nodeType="withEffect">
                                   <p:stCondLst>
                                     <p:cond delay="0"/>
                                   </p:stCondLst>
@@ -13772,11 +14002,7 @@
                                           </p:stCondLst>
                                         </p:cTn>
                                         <p:tgtEl>
-                                          <p:spTgt spid="65">
-                                            <p:txEl>
-                                              <p:pRg st="1" end="1"/>
-                                            </p:txEl>
-                                          </p:spTgt>
+                                          <p:spTgt spid="5"/>
                                         </p:tgtEl>
                                         <p:attrNameLst>
                                           <p:attrName>style.visibility</p:attrName>
@@ -13823,7 +14049,7 @@
                                         <p:tgtEl>
                                           <p:spTgt spid="65">
                                             <p:txEl>
-                                              <p:pRg st="2" end="2"/>
+                                              <p:pRg st="0" end="0"/>
                                             </p:txEl>
                                           </p:spTgt>
                                         </p:tgtEl>
@@ -13854,6 +14080,86 @@
                                         <p:tgtEl>
                                           <p:spTgt spid="65">
                                             <p:txEl>
+                                              <p:pRg st="1" end="1"/>
+                                            </p:txEl>
+                                          </p:spTgt>
+                                        </p:tgtEl>
+                                        <p:attrNameLst>
+                                          <p:attrName>style.visibility</p:attrName>
+                                        </p:attrNameLst>
+                                      </p:cBhvr>
+                                      <p:to>
+                                        <p:strVal val="visible"/>
+                                      </p:to>
+                                    </p:set>
+                                  </p:childTnLst>
+                                </p:cTn>
+                              </p:par>
+                            </p:childTnLst>
+                          </p:cTn>
+                        </p:par>
+                      </p:childTnLst>
+                    </p:cTn>
+                  </p:par>
+                  <p:par>
+                    <p:cTn id="15" fill="hold">
+                      <p:stCondLst>
+                        <p:cond delay="indefinite"/>
+                      </p:stCondLst>
+                      <p:childTnLst>
+                        <p:par>
+                          <p:cTn id="16" fill="hold">
+                            <p:stCondLst>
+                              <p:cond delay="0"/>
+                            </p:stCondLst>
+                            <p:childTnLst>
+                              <p:par>
+                                <p:cTn id="17" presetID="1" presetClass="entr" presetSubtype="0" fill="hold" nodeType="clickEffect">
+                                  <p:stCondLst>
+                                    <p:cond delay="0"/>
+                                  </p:stCondLst>
+                                  <p:childTnLst>
+                                    <p:set>
+                                      <p:cBhvr>
+                                        <p:cTn id="18" dur="1" fill="hold">
+                                          <p:stCondLst>
+                                            <p:cond delay="0"/>
+                                          </p:stCondLst>
+                                        </p:cTn>
+                                        <p:tgtEl>
+                                          <p:spTgt spid="65">
+                                            <p:txEl>
+                                              <p:pRg st="2" end="2"/>
+                                            </p:txEl>
+                                          </p:spTgt>
+                                        </p:tgtEl>
+                                        <p:attrNameLst>
+                                          <p:attrName>style.visibility</p:attrName>
+                                        </p:attrNameLst>
+                                      </p:cBhvr>
+                                      <p:to>
+                                        <p:strVal val="visible"/>
+                                      </p:to>
+                                    </p:set>
+                                  </p:childTnLst>
+                                </p:cTn>
+                              </p:par>
+                              <p:par>
+                                <p:cTn id="19" presetID="1" presetClass="entr" presetSubtype="0" fill="hold" nodeType="withEffect">
+                                  <p:stCondLst>
+                                    <p:cond delay="0"/>
+                                  </p:stCondLst>
+                                  <p:childTnLst>
+                                    <p:set>
+                                      <p:cBhvr>
+                                        <p:cTn id="20" dur="1" fill="hold">
+                                          <p:stCondLst>
+                                            <p:cond delay="0"/>
+                                          </p:stCondLst>
+                                        </p:cTn>
+                                        <p:tgtEl>
+                                          <p:spTgt spid="65">
+                                            <p:txEl>
                                               <p:pRg st="3" end="3"/>
                                             </p:txEl>
                                           </p:spTgt>
@@ -13870,14 +14176,14 @@
                                 </p:cTn>
                               </p:par>
                               <p:par>
-                                <p:cTn id="15" presetID="1" presetClass="entr" presetSubtype="0" fill="hold" nodeType="withEffect">
+                                <p:cTn id="21" presetID="1" presetClass="entr" presetSubtype="0" fill="hold" nodeType="withEffect">
                                   <p:stCondLst>
                                     <p:cond delay="0"/>
                                   </p:stCondLst>
                                   <p:childTnLst>
                                     <p:set>
                                       <p:cBhvr>
-                                        <p:cTn id="16" dur="1" fill="hold">
+                                        <p:cTn id="22" dur="1" fill="hold">
                                           <p:stCondLst>
                                             <p:cond delay="0"/>
                                           </p:stCondLst>
@@ -13907,26 +14213,26 @@
                     </p:cTn>
                   </p:par>
                   <p:par>
-                    <p:cTn id="17" fill="hold">
+                    <p:cTn id="23" fill="hold">
                       <p:stCondLst>
                         <p:cond delay="indefinite"/>
                       </p:stCondLst>
                       <p:childTnLst>
                         <p:par>
-                          <p:cTn id="18" fill="hold">
+                          <p:cTn id="24" fill="hold">
                             <p:stCondLst>
                               <p:cond delay="0"/>
                             </p:stCondLst>
                             <p:childTnLst>
                               <p:par>
-                                <p:cTn id="19" presetID="1" presetClass="entr" presetSubtype="0" fill="hold" nodeType="clickEffect">
+                                <p:cTn id="25" presetID="1" presetClass="entr" presetSubtype="0" fill="hold" nodeType="clickEffect">
                                   <p:stCondLst>
                                     <p:cond delay="0"/>
                                   </p:stCondLst>
                                   <p:childTnLst>
                                     <p:set>
                                       <p:cBhvr>
-                                        <p:cTn id="20" dur="1" fill="hold">
+                                        <p:cTn id="26" dur="1" fill="hold">
                                           <p:stCondLst>
                                             <p:cond delay="0"/>
                                           </p:stCondLst>
@@ -13976,6 +14282,9 @@
         </p:cTn>
       </p:par>
     </p:tnLst>
+    <p:bldLst>
+      <p:bldP spid="5" grpId="0"/>
+    </p:bldLst>
   </p:timing>
 </p:sld>
 </file>
@@ -14901,7 +15210,7 @@
             </a:r>
             <a:r>
               <a:rPr lang="de-DE" sz="2400" i="1"/>
-              <a:t>(oder reicht eine gute „Pflegestation“?)</a:t>
+              <a:t>(oder reicht ein gutes „Pflegestation“-Konzept?)</a:t>
             </a:r>
           </a:p>
           <a:p>
@@ -17125,10 +17434,10 @@
         </p:nvGrpSpPr>
         <p:grpSpPr>
           <a:xfrm>
-            <a:off x="2754884" y="1204601"/>
-            <a:ext cx="6265164" cy="2351399"/>
-            <a:chOff x="2900934" y="2068201"/>
-            <a:chExt cx="6265164" cy="2351399"/>
+            <a:off x="2816352" y="864241"/>
+            <a:ext cx="6254496" cy="2488559"/>
+            <a:chOff x="2911602" y="1931041"/>
+            <a:chExt cx="6254496" cy="2488559"/>
           </a:xfrm>
         </p:grpSpPr>
         <p:grpSp>
@@ -17557,13 +17866,15 @@
           </p:nvSpPr>
           <p:spPr>
             <a:xfrm>
-              <a:off x="2900934" y="2068201"/>
-              <a:ext cx="6137514" cy="338554"/>
+              <a:off x="3396234" y="1931041"/>
+              <a:ext cx="5369868" cy="307777"/>
             </a:xfrm>
             <a:prstGeom prst="rect">
               <a:avLst/>
             </a:prstGeom>
-            <a:noFill/>
+            <a:solidFill>
+              <a:schemeClr val="bg1"/>
+            </a:solidFill>
           </p:spPr>
           <p:txBody>
             <a:bodyPr wrap="none" rtlCol="0">
@@ -17572,12 +17883,44 @@
             <a:lstStyle/>
             <a:p>
               <a:r>
-                <a:rPr lang="de-DE" sz="1600" b="1">
+                <a:rPr lang="de-DE" sz="1400" b="1">
                   <a:solidFill>
                     <a:srgbClr val="002060"/>
                   </a:solidFill>
                 </a:rPr>
-                <a:t>one logical job-session-process in two separate process-spaces</a:t>
+                <a:t>one </a:t>
+              </a:r>
+              <a:r>
+                <a:rPr lang="de-DE" sz="1400" b="1" i="1">
+                  <a:solidFill>
+                    <a:srgbClr val="002060"/>
+                  </a:solidFill>
+                </a:rPr>
+                <a:t>logical</a:t>
+              </a:r>
+              <a:r>
+                <a:rPr lang="de-DE" sz="1400" b="1">
+                  <a:solidFill>
+                    <a:srgbClr val="002060"/>
+                  </a:solidFill>
+                </a:rPr>
+                <a:t> job-session-process in two </a:t>
+              </a:r>
+              <a:r>
+                <a:rPr lang="de-DE" sz="1400" b="1" i="1">
+                  <a:solidFill>
+                    <a:srgbClr val="002060"/>
+                  </a:solidFill>
+                </a:rPr>
+                <a:t>physical</a:t>
+              </a:r>
+              <a:r>
+                <a:rPr lang="de-DE" sz="1400" b="1">
+                  <a:solidFill>
+                    <a:srgbClr val="002060"/>
+                  </a:solidFill>
+                </a:rPr>
+                <a:t> process-spaces</a:t>
               </a:r>
             </a:p>
           </p:txBody>
@@ -17997,7 +18340,7 @@
         </p:nvSpPr>
         <p:spPr>
           <a:xfrm>
-            <a:off x="3393373" y="395109"/>
+            <a:off x="3393373" y="306209"/>
             <a:ext cx="5052923" cy="523220"/>
           </a:xfrm>
           <a:prstGeom prst="rect">
@@ -18042,8 +18385,8 @@
         </p:nvSpPr>
         <p:spPr>
           <a:xfrm>
-            <a:off x="2658820" y="3671015"/>
-            <a:ext cx="8418755" cy="830997"/>
+            <a:off x="1824755" y="4024158"/>
+            <a:ext cx="8418755" cy="954107"/>
           </a:xfrm>
           <a:prstGeom prst="rect">
             <a:avLst/>
@@ -18056,6 +18399,9 @@
           </a:bodyPr>
           <a:lstStyle/>
           <a:p>
+            <a:endParaRPr lang="de-DE" sz="800"/>
+          </a:p>
+          <a:p>
             <a:pPr marL="171450" indent="-171450">
               <a:buFont typeface="Arial" panose="020B0604020202020204" pitchFamily="34" charset="0"/>
               <a:buChar char="•"/>
@@ -18081,15 +18427,27 @@
               <a:buChar char="•"/>
             </a:pPr>
             <a:r>
-              <a:rPr lang="de-DE" sz="1600" b="1"/>
+              <a:rPr lang="de-DE" sz="1600" b="1">
+                <a:solidFill>
+                  <a:srgbClr val="0070C0"/>
+                </a:solidFill>
+              </a:rPr>
               <a:t>Schaffung eines leichtgewichtigen </a:t>
             </a:r>
             <a:r>
-              <a:rPr lang="de-DE" sz="1600" b="1" i="1"/>
+              <a:rPr lang="de-DE" sz="1600" b="1" i="1">
+                <a:solidFill>
+                  <a:srgbClr val="0070C0"/>
+                </a:solidFill>
+              </a:rPr>
               <a:t>one-to-one-IPC-Application-Protocols</a:t>
             </a:r>
             <a:r>
-              <a:rPr lang="de-DE" sz="1600" b="1"/>
+              <a:rPr lang="de-DE" sz="1600" b="1">
+                <a:solidFill>
+                  <a:srgbClr val="0070C0"/>
+                </a:solidFill>
+              </a:rPr>
               <a:t>. (JAP)</a:t>
             </a:r>
           </a:p>
@@ -18109,8 +18467,8 @@
         </p:nvSpPr>
         <p:spPr>
           <a:xfrm>
-            <a:off x="2703271" y="4573680"/>
-            <a:ext cx="8240954" cy="1477328"/>
+            <a:off x="1851449" y="5774811"/>
+            <a:ext cx="9126537" cy="646331"/>
           </a:xfrm>
           <a:prstGeom prst="rect">
             <a:avLst/>
@@ -18124,42 +18482,23 @@
           <a:lstStyle/>
           <a:p>
             <a:r>
-              <a:rPr lang="de-DE" sz="1800"/>
-              <a:t>Starke und nachhaltige Entkopplung (- nicht nur </a:t>
-            </a:r>
-            <a:r>
-              <a:rPr lang="de-DE" sz="1800" i="1"/>
-              <a:t>zur Runtime im Prozessraum</a:t>
-            </a:r>
-            <a:r>
-              <a:rPr lang="de-DE" sz="1800"/>
-              <a:t>!)</a:t>
-            </a:r>
-          </a:p>
-          <a:p>
-            <a:r>
-              <a:rPr lang="de-DE" sz="1600"/>
-              <a:t>Auf einer Maschine - unterhalb des Netzwerkstacks (keine Firewall, etc.)</a:t>
-            </a:r>
-          </a:p>
-          <a:p>
-            <a:endParaRPr lang="de-DE" sz="1800"/>
-          </a:p>
-          <a:p>
-            <a:r>
-              <a:rPr lang="de-DE" sz="1800" b="1">
+              <a:rPr lang="de-DE" b="1"/>
+              <a:t>Wir bekommen</a:t>
+            </a:r>
+            <a:r>
+              <a:rPr lang="de-DE" b="1">
                 <a:solidFill>
                   <a:srgbClr val="0070C0"/>
                 </a:solidFill>
               </a:rPr>
-              <a:t>Zwei</a:t>
-            </a:r>
-            <a:r>
-              <a:rPr lang="de-DE" sz="1800" b="1"/>
+              <a:t> zwei</a:t>
+            </a:r>
+            <a:r>
+              <a:rPr lang="de-DE" b="1"/>
               <a:t> logisch, technologisch und architekturell getrennte </a:t>
             </a:r>
             <a:r>
-              <a:rPr lang="de-DE" sz="1800" b="1" i="1">
+              <a:rPr lang="de-DE" b="1" i="1">
                 <a:solidFill>
                   <a:srgbClr val="0070C0"/>
                 </a:solidFill>
@@ -18167,18 +18506,14 @@
               <a:t>Domänen</a:t>
             </a:r>
             <a:r>
-              <a:rPr lang="de-DE" sz="1800" b="1" i="1"/>
+              <a:rPr lang="de-DE" b="1" i="1"/>
               <a:t>…</a:t>
             </a:r>
           </a:p>
           <a:p>
             <a:r>
-              <a:rPr lang="de-DE" sz="1800"/>
-              <a:t>…mit einer l</a:t>
-            </a:r>
-            <a:r>
               <a:rPr lang="de-DE"/>
-              <a:t>eichtgewichtige Kopplung über das </a:t>
+              <a:t>(…mit einer leichtgewichtige Kopplung über das </a:t>
             </a:r>
             <a:r>
               <a:rPr lang="de-DE" b="1"/>
@@ -18186,11 +18521,99 @@
             </a:r>
             <a:r>
               <a:rPr lang="de-DE"/>
-              <a:t>.</a:t>
-            </a:r>
+              <a:t>… )</a:t>
+            </a:r>
+          </a:p>
+        </p:txBody>
+      </p:sp>
+      <p:sp>
+        <p:nvSpPr>
+          <p:cNvPr id="9" name="Textfeld 8">
+            <a:extLst>
+              <a:ext uri="{FF2B5EF4-FFF2-40B4-BE49-F238E27FC236}">
+                <a16:creationId xmlns:a16="http://schemas.microsoft.com/office/drawing/2014/main" id="{F8C6DEE4-170E-61FC-5510-46EBF737CCF9}"/>
+              </a:ext>
+            </a:extLst>
+          </p:cNvPr>
+          <p:cNvSpPr txBox="1"/>
+          <p:nvPr/>
+        </p:nvSpPr>
+        <p:spPr>
+          <a:xfrm>
+            <a:off x="1853020" y="3460782"/>
+            <a:ext cx="9288463" cy="646331"/>
+          </a:xfrm>
+          <a:prstGeom prst="rect">
+            <a:avLst/>
+          </a:prstGeom>
+          <a:noFill/>
+        </p:spPr>
+        <p:txBody>
+          <a:bodyPr wrap="square">
+            <a:spAutoFit/>
+          </a:bodyPr>
+          <a:lstStyle/>
+          <a:p>
             <a:r>
               <a:rPr lang="de-DE" sz="1800"/>
-              <a:t> </a:t>
+              <a:t>Die Grundidee </a:t>
+            </a:r>
+            <a:r>
+              <a:rPr lang="de-DE" sz="1800" i="1"/>
+              <a:t>„decpoupling and isolation by spawning another process“</a:t>
+            </a:r>
+            <a:r>
+              <a:rPr lang="de-DE" sz="1800"/>
+              <a:t> wird nicht verworfen, sondern konsequent weitergeführt und „richtig implementiert:</a:t>
+            </a:r>
+          </a:p>
+        </p:txBody>
+      </p:sp>
+      <p:sp>
+        <p:nvSpPr>
+          <p:cNvPr id="11" name="Textfeld 10">
+            <a:extLst>
+              <a:ext uri="{FF2B5EF4-FFF2-40B4-BE49-F238E27FC236}">
+                <a16:creationId xmlns:a16="http://schemas.microsoft.com/office/drawing/2014/main" id="{E80A37DA-2AFA-6576-2076-87CB4BA793B6}"/>
+              </a:ext>
+            </a:extLst>
+          </p:cNvPr>
+          <p:cNvSpPr txBox="1"/>
+          <p:nvPr/>
+        </p:nvSpPr>
+        <p:spPr>
+          <a:xfrm>
+            <a:off x="1850155" y="5086947"/>
+            <a:ext cx="8534401" cy="646331"/>
+          </a:xfrm>
+          <a:prstGeom prst="rect">
+            <a:avLst/>
+          </a:prstGeom>
+          <a:noFill/>
+        </p:spPr>
+        <p:txBody>
+          <a:bodyPr wrap="square">
+            <a:spAutoFit/>
+          </a:bodyPr>
+          <a:lstStyle/>
+          <a:p>
+            <a:r>
+              <a:rPr lang="de-DE"/>
+              <a:t>Starke und nachhaltige Entkopplung (- nicht nur </a:t>
+            </a:r>
+            <a:r>
+              <a:rPr lang="de-DE" i="1"/>
+              <a:t>zur Runtime im Prozessraum</a:t>
+            </a:r>
+            <a:r>
+              <a:rPr lang="de-DE"/>
+              <a:t>!)</a:t>
+            </a:r>
+          </a:p>
+          <a:p>
+            <a:r>
+              <a:rPr lang="de-DE"/>
+              <a:t>Auf einer Maschine - unterhalb des Netzwerkstacks (keine Firewall, etc.)</a:t>
             </a:r>
           </a:p>
         </p:txBody>
@@ -18205,6 +18628,222 @@
   <p:clrMapOvr>
     <a:masterClrMapping/>
   </p:clrMapOvr>
+  <p:timing>
+    <p:tnLst>
+      <p:par>
+        <p:cTn id="1" dur="indefinite" restart="never" nodeType="tmRoot">
+          <p:childTnLst>
+            <p:seq concurrent="1" nextAc="seek">
+              <p:cTn id="2" dur="indefinite" nodeType="mainSeq">
+                <p:childTnLst>
+                  <p:par>
+                    <p:cTn id="3" fill="hold">
+                      <p:stCondLst>
+                        <p:cond delay="indefinite"/>
+                      </p:stCondLst>
+                      <p:childTnLst>
+                        <p:par>
+                          <p:cTn id="4" fill="hold">
+                            <p:stCondLst>
+                              <p:cond delay="0"/>
+                            </p:stCondLst>
+                            <p:childTnLst>
+                              <p:par>
+                                <p:cTn id="5" presetID="1" presetClass="entr" presetSubtype="0" fill="hold" grpId="0" nodeType="clickEffect">
+                                  <p:stCondLst>
+                                    <p:cond delay="0"/>
+                                  </p:stCondLst>
+                                  <p:childTnLst>
+                                    <p:set>
+                                      <p:cBhvr>
+                                        <p:cTn id="6" dur="1" fill="hold">
+                                          <p:stCondLst>
+                                            <p:cond delay="0"/>
+                                          </p:stCondLst>
+                                        </p:cTn>
+                                        <p:tgtEl>
+                                          <p:spTgt spid="9"/>
+                                        </p:tgtEl>
+                                        <p:attrNameLst>
+                                          <p:attrName>style.visibility</p:attrName>
+                                        </p:attrNameLst>
+                                      </p:cBhvr>
+                                      <p:to>
+                                        <p:strVal val="visible"/>
+                                      </p:to>
+                                    </p:set>
+                                  </p:childTnLst>
+                                </p:cTn>
+                              </p:par>
+                            </p:childTnLst>
+                          </p:cTn>
+                        </p:par>
+                      </p:childTnLst>
+                    </p:cTn>
+                  </p:par>
+                  <p:par>
+                    <p:cTn id="7" fill="hold">
+                      <p:stCondLst>
+                        <p:cond delay="indefinite"/>
+                      </p:stCondLst>
+                      <p:childTnLst>
+                        <p:par>
+                          <p:cTn id="8" fill="hold">
+                            <p:stCondLst>
+                              <p:cond delay="0"/>
+                            </p:stCondLst>
+                            <p:childTnLst>
+                              <p:par>
+                                <p:cTn id="9" presetID="1" presetClass="entr" presetSubtype="0" fill="hold" grpId="0" nodeType="clickEffect">
+                                  <p:stCondLst>
+                                    <p:cond delay="0"/>
+                                  </p:stCondLst>
+                                  <p:childTnLst>
+                                    <p:set>
+                                      <p:cBhvr>
+                                        <p:cTn id="10" dur="1" fill="hold">
+                                          <p:stCondLst>
+                                            <p:cond delay="0"/>
+                                          </p:stCondLst>
+                                        </p:cTn>
+                                        <p:tgtEl>
+                                          <p:spTgt spid="5"/>
+                                        </p:tgtEl>
+                                        <p:attrNameLst>
+                                          <p:attrName>style.visibility</p:attrName>
+                                        </p:attrNameLst>
+                                      </p:cBhvr>
+                                      <p:to>
+                                        <p:strVal val="visible"/>
+                                      </p:to>
+                                    </p:set>
+                                  </p:childTnLst>
+                                </p:cTn>
+                              </p:par>
+                            </p:childTnLst>
+                          </p:cTn>
+                        </p:par>
+                      </p:childTnLst>
+                    </p:cTn>
+                  </p:par>
+                  <p:par>
+                    <p:cTn id="11" fill="hold">
+                      <p:stCondLst>
+                        <p:cond delay="indefinite"/>
+                      </p:stCondLst>
+                      <p:childTnLst>
+                        <p:par>
+                          <p:cTn id="12" fill="hold">
+                            <p:stCondLst>
+                              <p:cond delay="0"/>
+                            </p:stCondLst>
+                            <p:childTnLst>
+                              <p:par>
+                                <p:cTn id="13" presetID="1" presetClass="entr" presetSubtype="0" fill="hold" grpId="0" nodeType="clickEffect">
+                                  <p:stCondLst>
+                                    <p:cond delay="0"/>
+                                  </p:stCondLst>
+                                  <p:childTnLst>
+                                    <p:set>
+                                      <p:cBhvr>
+                                        <p:cTn id="14" dur="1" fill="hold">
+                                          <p:stCondLst>
+                                            <p:cond delay="0"/>
+                                          </p:stCondLst>
+                                        </p:cTn>
+                                        <p:tgtEl>
+                                          <p:spTgt spid="11"/>
+                                        </p:tgtEl>
+                                        <p:attrNameLst>
+                                          <p:attrName>style.visibility</p:attrName>
+                                        </p:attrNameLst>
+                                      </p:cBhvr>
+                                      <p:to>
+                                        <p:strVal val="visible"/>
+                                      </p:to>
+                                    </p:set>
+                                  </p:childTnLst>
+                                </p:cTn>
+                              </p:par>
+                            </p:childTnLst>
+                          </p:cTn>
+                        </p:par>
+                      </p:childTnLst>
+                    </p:cTn>
+                  </p:par>
+                  <p:par>
+                    <p:cTn id="15" fill="hold">
+                      <p:stCondLst>
+                        <p:cond delay="indefinite"/>
+                      </p:stCondLst>
+                      <p:childTnLst>
+                        <p:par>
+                          <p:cTn id="16" fill="hold">
+                            <p:stCondLst>
+                              <p:cond delay="0"/>
+                            </p:stCondLst>
+                            <p:childTnLst>
+                              <p:par>
+                                <p:cTn id="17" presetID="1" presetClass="entr" presetSubtype="0" fill="hold" grpId="0" nodeType="clickEffect">
+                                  <p:stCondLst>
+                                    <p:cond delay="0"/>
+                                  </p:stCondLst>
+                                  <p:childTnLst>
+                                    <p:set>
+                                      <p:cBhvr>
+                                        <p:cTn id="18" dur="1" fill="hold">
+                                          <p:stCondLst>
+                                            <p:cond delay="0"/>
+                                          </p:stCondLst>
+                                        </p:cTn>
+                                        <p:tgtEl>
+                                          <p:spTgt spid="14"/>
+                                        </p:tgtEl>
+                                        <p:attrNameLst>
+                                          <p:attrName>style.visibility</p:attrName>
+                                        </p:attrNameLst>
+                                      </p:cBhvr>
+                                      <p:to>
+                                        <p:strVal val="visible"/>
+                                      </p:to>
+                                    </p:set>
+                                  </p:childTnLst>
+                                </p:cTn>
+                              </p:par>
+                            </p:childTnLst>
+                          </p:cTn>
+                        </p:par>
+                      </p:childTnLst>
+                    </p:cTn>
+                  </p:par>
+                </p:childTnLst>
+              </p:cTn>
+              <p:prevCondLst>
+                <p:cond evt="onPrev" delay="0">
+                  <p:tgtEl>
+                    <p:sldTgt/>
+                  </p:tgtEl>
+                </p:cond>
+              </p:prevCondLst>
+              <p:nextCondLst>
+                <p:cond evt="onNext" delay="0">
+                  <p:tgtEl>
+                    <p:sldTgt/>
+                  </p:tgtEl>
+                </p:cond>
+              </p:nextCondLst>
+            </p:seq>
+          </p:childTnLst>
+        </p:cTn>
+      </p:par>
+    </p:tnLst>
+    <p:bldLst>
+      <p:bldP spid="5" grpId="0"/>
+      <p:bldP spid="14" grpId="0"/>
+      <p:bldP spid="9" grpId="0"/>
+      <p:bldP spid="11" grpId="0"/>
+    </p:bldLst>
+  </p:timing>
 </p:sld>
 </file>
 

</xml_diff>

<commit_message>
wip: sync [2026-06-24 08:09]
</commit_message>
<xml_diff>
--- a/josyn-intro.pptx
+++ b/josyn-intro.pptx
@@ -207,7 +207,7 @@
           <a:p>
             <a:fld id="{8E5D503C-CB4E-47D2-854F-034286D1EDEF}" type="datetimeFigureOut">
               <a:rPr lang="de-DE" smtClean="0"/>
-              <a:t>23.06.2026</a:t>
+              <a:t>24.06.2026</a:t>
             </a:fld>
             <a:endParaRPr lang="de-DE"/>
           </a:p>
@@ -897,7 +897,7 @@
           <a:p>
             <a:fld id="{6670F5CD-5655-45E5-8E7F-D706B3048717}" type="datetimeFigureOut">
               <a:rPr lang="de-DE" smtClean="0"/>
-              <a:t>23.06.2026</a:t>
+              <a:t>24.06.2026</a:t>
             </a:fld>
             <a:endParaRPr lang="de-DE"/>
           </a:p>
@@ -1095,7 +1095,7 @@
           <a:p>
             <a:fld id="{6670F5CD-5655-45E5-8E7F-D706B3048717}" type="datetimeFigureOut">
               <a:rPr lang="de-DE" smtClean="0"/>
-              <a:t>23.06.2026</a:t>
+              <a:t>24.06.2026</a:t>
             </a:fld>
             <a:endParaRPr lang="de-DE"/>
           </a:p>
@@ -1303,7 +1303,7 @@
           <a:p>
             <a:fld id="{6670F5CD-5655-45E5-8E7F-D706B3048717}" type="datetimeFigureOut">
               <a:rPr lang="de-DE" smtClean="0"/>
-              <a:t>23.06.2026</a:t>
+              <a:t>24.06.2026</a:t>
             </a:fld>
             <a:endParaRPr lang="de-DE"/>
           </a:p>
@@ -1501,7 +1501,7 @@
           <a:p>
             <a:fld id="{6670F5CD-5655-45E5-8E7F-D706B3048717}" type="datetimeFigureOut">
               <a:rPr lang="de-DE" smtClean="0"/>
-              <a:t>23.06.2026</a:t>
+              <a:t>24.06.2026</a:t>
             </a:fld>
             <a:endParaRPr lang="de-DE"/>
           </a:p>
@@ -1776,7 +1776,7 @@
           <a:p>
             <a:fld id="{6670F5CD-5655-45E5-8E7F-D706B3048717}" type="datetimeFigureOut">
               <a:rPr lang="de-DE" smtClean="0"/>
-              <a:t>23.06.2026</a:t>
+              <a:t>24.06.2026</a:t>
             </a:fld>
             <a:endParaRPr lang="de-DE"/>
           </a:p>
@@ -2041,7 +2041,7 @@
           <a:p>
             <a:fld id="{6670F5CD-5655-45E5-8E7F-D706B3048717}" type="datetimeFigureOut">
               <a:rPr lang="de-DE" smtClean="0"/>
-              <a:t>23.06.2026</a:t>
+              <a:t>24.06.2026</a:t>
             </a:fld>
             <a:endParaRPr lang="de-DE"/>
           </a:p>
@@ -2453,7 +2453,7 @@
           <a:p>
             <a:fld id="{6670F5CD-5655-45E5-8E7F-D706B3048717}" type="datetimeFigureOut">
               <a:rPr lang="de-DE" smtClean="0"/>
-              <a:t>23.06.2026</a:t>
+              <a:t>24.06.2026</a:t>
             </a:fld>
             <a:endParaRPr lang="de-DE"/>
           </a:p>
@@ -2594,7 +2594,7 @@
           <a:p>
             <a:fld id="{6670F5CD-5655-45E5-8E7F-D706B3048717}" type="datetimeFigureOut">
               <a:rPr lang="de-DE" smtClean="0"/>
-              <a:t>23.06.2026</a:t>
+              <a:t>24.06.2026</a:t>
             </a:fld>
             <a:endParaRPr lang="de-DE"/>
           </a:p>
@@ -2707,7 +2707,7 @@
           <a:p>
             <a:fld id="{6670F5CD-5655-45E5-8E7F-D706B3048717}" type="datetimeFigureOut">
               <a:rPr lang="de-DE" smtClean="0"/>
-              <a:t>23.06.2026</a:t>
+              <a:t>24.06.2026</a:t>
             </a:fld>
             <a:endParaRPr lang="de-DE"/>
           </a:p>
@@ -3018,7 +3018,7 @@
           <a:p>
             <a:fld id="{6670F5CD-5655-45E5-8E7F-D706B3048717}" type="datetimeFigureOut">
               <a:rPr lang="de-DE" smtClean="0"/>
-              <a:t>23.06.2026</a:t>
+              <a:t>24.06.2026</a:t>
             </a:fld>
             <a:endParaRPr lang="de-DE"/>
           </a:p>
@@ -3306,7 +3306,7 @@
           <a:p>
             <a:fld id="{6670F5CD-5655-45E5-8E7F-D706B3048717}" type="datetimeFigureOut">
               <a:rPr lang="de-DE" smtClean="0"/>
-              <a:t>23.06.2026</a:t>
+              <a:t>24.06.2026</a:t>
             </a:fld>
             <a:endParaRPr lang="de-DE"/>
           </a:p>
@@ -3547,7 +3547,7 @@
           <a:p>
             <a:fld id="{6670F5CD-5655-45E5-8E7F-D706B3048717}" type="datetimeFigureOut">
               <a:rPr lang="de-DE" smtClean="0"/>
-              <a:t>23.06.2026</a:t>
+              <a:t>24.06.2026</a:t>
             </a:fld>
             <a:endParaRPr lang="de-DE"/>
           </a:p>
@@ -4642,7 +4642,7 @@
                     <a:srgbClr val="002060"/>
                   </a:solidFill>
                 </a:rPr>
-                <a:t> a set of maintainer-scripts (maybe </a:t>
+                <a:t> a set of maintainer-scripts (maybe a </a:t>
               </a:r>
               <a:r>
                 <a:rPr lang="de-DE" sz="1400" i="1">
@@ -4650,7 +4650,7 @@
                     <a:srgbClr val="002060"/>
                   </a:solidFill>
                 </a:rPr>
-                <a:t>ssh</a:t>
+                <a:t>ssh-like </a:t>
               </a:r>
               <a:r>
                 <a:rPr lang="de-DE" sz="1400">
@@ -4658,7 +4658,7 @@
                     <a:srgbClr val="002060"/>
                   </a:solidFill>
                 </a:rPr>
-                <a:t> or a „</a:t>
+                <a:t>„</a:t>
               </a:r>
               <a:r>
                 <a:rPr lang="de-DE" sz="1400" i="1">
@@ -6857,7 +6857,7 @@
           </p:nvSpPr>
           <p:spPr>
             <a:xfrm>
-              <a:off x="1124452" y="2701466"/>
+              <a:off x="1543552" y="2701466"/>
               <a:ext cx="531961" cy="736070"/>
             </a:xfrm>
             <a:prstGeom prst="downArrow">
@@ -7017,7 +7017,7 @@
         <p:spPr>
           <a:xfrm>
             <a:off x="9213040" y="1304386"/>
-            <a:ext cx="2220810" cy="938719"/>
+            <a:ext cx="2220810" cy="1107996"/>
           </a:xfrm>
           <a:prstGeom prst="rect">
             <a:avLst/>
@@ -7051,6 +7051,20 @@
                 </a:solidFill>
               </a:rPr>
               <a:t>start, cancel, kill a job-session</a:t>
+            </a:r>
+          </a:p>
+          <a:p>
+            <a:pPr marL="171450" indent="-171450">
+              <a:buFont typeface="Arial" panose="020B0604020202020204" pitchFamily="34" charset="0"/>
+              <a:buChar char="•"/>
+            </a:pPr>
+            <a:r>
+              <a:rPr lang="de-DE" sz="1100">
+                <a:solidFill>
+                  <a:srgbClr val="002060"/>
+                </a:solidFill>
+              </a:rPr>
+              <a:t>edit job-repository</a:t>
             </a:r>
           </a:p>
           <a:p>
@@ -12484,7 +12498,7 @@
         <p:spPr>
           <a:xfrm>
             <a:off x="1476367" y="238438"/>
-            <a:ext cx="8703280" cy="1354217"/>
+            <a:ext cx="8703280" cy="800219"/>
           </a:xfrm>
           <a:prstGeom prst="rect">
             <a:avLst/>
@@ -12577,28 +12591,6 @@
             <a:r>
               <a:rPr lang="de-DE" b="1" i="1"/>
               <a:t>JobHost.exe</a:t>
-            </a:r>
-          </a:p>
-          <a:p>
-            <a:pPr algn="ctr"/>
-            <a:r>
-              <a:rPr lang="de-DE" i="1">
-                <a:solidFill>
-                  <a:srgbClr val="00B050"/>
-                </a:solidFill>
-              </a:rPr>
-              <a:t>(prinzipiell ein sehr cooles „decoupling and isolation-concept“: </a:t>
-            </a:r>
-          </a:p>
-          <a:p>
-            <a:pPr algn="ctr"/>
-            <a:r>
-              <a:rPr lang="de-DE" i="1">
-                <a:solidFill>
-                  <a:srgbClr val="00B050"/>
-                </a:solidFill>
-              </a:rPr>
-              <a:t>session-starter fires -&gt; continuation in a fresh, isolated process-space!...)</a:t>
             </a:r>
           </a:p>
         </p:txBody>
@@ -12617,7 +12609,7 @@
         </p:nvSpPr>
         <p:spPr>
           <a:xfrm>
-            <a:off x="1476367" y="4864440"/>
+            <a:off x="1476367" y="4883816"/>
             <a:ext cx="9553817" cy="1723549"/>
           </a:xfrm>
           <a:prstGeom prst="rect">
@@ -12647,7 +12639,7 @@
                   <a:srgbClr val="FF0000"/>
                 </a:solidFill>
               </a:rPr>
-              <a:t>„Closed Dependency-Room“:</a:t>
+              <a:t>„Closed Dependency-Space“:</a:t>
             </a:r>
           </a:p>
           <a:p>
@@ -12734,8 +12726,8 @@
         </p:nvSpPr>
         <p:spPr>
           <a:xfrm>
-            <a:off x="729595" y="1563009"/>
-            <a:ext cx="10732810" cy="369332"/>
+            <a:off x="1235029" y="4454455"/>
+            <a:ext cx="9741321" cy="338554"/>
           </a:xfrm>
           <a:prstGeom prst="rect">
             <a:avLst/>
@@ -12749,56 +12741,41 @@
           <a:lstStyle/>
           <a:p>
             <a:r>
-              <a:rPr lang="de-DE">
+              <a:rPr lang="de-DE" sz="1600">
                 <a:solidFill>
-                  <a:schemeClr val="tx1">
-                    <a:lumMod val="50000"/>
-                    <a:lumOff val="50000"/>
-                  </a:schemeClr>
+                  <a:srgbClr val="FF0000"/>
                 </a:solidFill>
               </a:rPr>
               <a:t>…and then i‘m gonna spoil it all, by designing </a:t>
             </a:r>
             <a:r>
-              <a:rPr lang="de-DE" i="1">
+              <a:rPr lang="de-DE" sz="1600" i="1">
                 <a:solidFill>
-                  <a:schemeClr val="tx1">
-                    <a:lumMod val="50000"/>
-                    <a:lumOff val="50000"/>
-                  </a:schemeClr>
+                  <a:srgbClr val="FF0000"/>
                 </a:solidFill>
               </a:rPr>
               <a:t>something stupid</a:t>
             </a:r>
             <a:r>
-              <a:rPr lang="de-DE">
+              <a:rPr lang="de-DE" sz="1600">
                 <a:solidFill>
-                  <a:schemeClr val="tx1">
-                    <a:lumMod val="50000"/>
-                    <a:lumOff val="50000"/>
-                  </a:schemeClr>
+                  <a:srgbClr val="FF0000"/>
                 </a:solidFill>
               </a:rPr>
               <a:t> like </a:t>
             </a:r>
             <a:r>
-              <a:rPr lang="de-DE" i="1">
+              <a:rPr lang="de-DE" sz="1600" i="1">
                 <a:solidFill>
-                  <a:schemeClr val="tx1">
-                    <a:lumMod val="50000"/>
-                    <a:lumOff val="50000"/>
-                  </a:schemeClr>
+                  <a:srgbClr val="FF0000"/>
                 </a:solidFill>
               </a:rPr>
-              <a:t>„a shared runtime-dependency room“</a:t>
-            </a:r>
-            <a:r>
-              <a:rPr lang="de-DE">
+              <a:t>„a shared runtime-dependency space“</a:t>
+            </a:r>
+            <a:r>
+              <a:rPr lang="de-DE" sz="1600">
                 <a:solidFill>
-                  <a:schemeClr val="tx1">
-                    <a:lumMod val="50000"/>
-                    <a:lumOff val="50000"/>
-                  </a:schemeClr>
+                  <a:srgbClr val="FF0000"/>
                 </a:solidFill>
               </a:rPr>
               <a:t>… </a:t>
@@ -12808,10 +12785,10 @@
       </p:sp>
       <p:grpSp>
         <p:nvGrpSpPr>
-          <p:cNvPr id="8" name="Gruppieren 7">
+          <p:cNvPr id="13" name="Gruppieren 12">
             <a:extLst>
               <a:ext uri="{FF2B5EF4-FFF2-40B4-BE49-F238E27FC236}">
-                <a16:creationId xmlns:a16="http://schemas.microsoft.com/office/drawing/2014/main" id="{476108D6-F08B-AD38-2AD1-D94537F47EA2}"/>
+                <a16:creationId xmlns:a16="http://schemas.microsoft.com/office/drawing/2014/main" id="{A25E764E-C7B9-FCD9-7DC0-0CD5146617EA}"/>
               </a:ext>
             </a:extLst>
           </p:cNvPr>
@@ -12820,18 +12797,18 @@
         </p:nvGrpSpPr>
         <p:grpSpPr>
           <a:xfrm>
-            <a:off x="1771072" y="2072386"/>
-            <a:ext cx="8303713" cy="2713228"/>
-            <a:chOff x="1771072" y="2072386"/>
-            <a:chExt cx="8303713" cy="2713228"/>
+            <a:off x="1885965" y="1754290"/>
+            <a:ext cx="8293682" cy="2713228"/>
+            <a:chOff x="1718946" y="1754290"/>
+            <a:chExt cx="8293682" cy="2713228"/>
           </a:xfrm>
         </p:grpSpPr>
         <p:grpSp>
           <p:nvGrpSpPr>
-            <p:cNvPr id="4" name="Gruppieren 3">
+            <p:cNvPr id="66" name="Gruppieren 65">
               <a:extLst>
                 <a:ext uri="{FF2B5EF4-FFF2-40B4-BE49-F238E27FC236}">
-                  <a16:creationId xmlns:a16="http://schemas.microsoft.com/office/drawing/2014/main" id="{54B98630-6773-7B36-E819-EF331F0DEE60}"/>
+                  <a16:creationId xmlns:a16="http://schemas.microsoft.com/office/drawing/2014/main" id="{45F580C5-8F3A-EDDB-125F-5CD169EFA36D}"/>
                 </a:ext>
               </a:extLst>
             </p:cNvPr>
@@ -12840,742 +12817,23 @@
           </p:nvGrpSpPr>
           <p:grpSpPr>
             <a:xfrm>
-              <a:off x="1771072" y="2072386"/>
-              <a:ext cx="8303713" cy="2713228"/>
-              <a:chOff x="1713922" y="1439437"/>
-              <a:chExt cx="8303713" cy="2713228"/>
+              <a:off x="1718946" y="1754290"/>
+              <a:ext cx="2992631" cy="2689384"/>
+              <a:chOff x="6606124" y="632008"/>
+              <a:chExt cx="1609958" cy="3976567"/>
             </a:xfrm>
+            <a:solidFill>
+              <a:schemeClr val="bg1">
+                <a:lumMod val="95000"/>
+              </a:schemeClr>
+            </a:solidFill>
           </p:grpSpPr>
-          <p:grpSp>
-            <p:nvGrpSpPr>
-              <p:cNvPr id="66" name="Gruppieren 65">
+          <p:sp>
+            <p:nvSpPr>
+              <p:cNvPr id="67" name="Rechteck 66">
                 <a:extLst>
                   <a:ext uri="{FF2B5EF4-FFF2-40B4-BE49-F238E27FC236}">
-                    <a16:creationId xmlns:a16="http://schemas.microsoft.com/office/drawing/2014/main" id="{45F580C5-8F3A-EDDB-125F-5CD169EFA36D}"/>
-                  </a:ext>
-                </a:extLst>
-              </p:cNvPr>
-              <p:cNvGrpSpPr/>
-              <p:nvPr/>
-            </p:nvGrpSpPr>
-            <p:grpSpPr>
-              <a:xfrm>
-                <a:off x="1713922" y="1439437"/>
-                <a:ext cx="2992631" cy="2689384"/>
-                <a:chOff x="6606124" y="632008"/>
-                <a:chExt cx="1609958" cy="3976567"/>
-              </a:xfrm>
-              <a:solidFill>
-                <a:schemeClr val="bg1">
-                  <a:lumMod val="95000"/>
-                </a:schemeClr>
-              </a:solidFill>
-            </p:grpSpPr>
-            <p:sp>
-              <p:nvSpPr>
-                <p:cNvPr id="67" name="Rechteck 66">
-                  <a:extLst>
-                    <a:ext uri="{FF2B5EF4-FFF2-40B4-BE49-F238E27FC236}">
-                      <a16:creationId xmlns:a16="http://schemas.microsoft.com/office/drawing/2014/main" id="{91D6CEA9-DE63-5C3E-1FC1-F87CE5390BFE}"/>
-                    </a:ext>
-                  </a:extLst>
-                </p:cNvPr>
-                <p:cNvSpPr/>
-                <p:nvPr/>
-              </p:nvSpPr>
-              <p:spPr>
-                <a:xfrm>
-                  <a:off x="6606124" y="632008"/>
-                  <a:ext cx="1609958" cy="3976567"/>
-                </a:xfrm>
-                <a:prstGeom prst="rect">
-                  <a:avLst/>
-                </a:prstGeom>
-                <a:grpFill/>
-                <a:ln>
-                  <a:solidFill>
-                    <a:srgbClr val="7030A0"/>
-                  </a:solidFill>
-                </a:ln>
-              </p:spPr>
-              <p:style>
-                <a:lnRef idx="2">
-                  <a:schemeClr val="accent1">
-                    <a:shade val="15000"/>
-                  </a:schemeClr>
-                </a:lnRef>
-                <a:fillRef idx="1">
-                  <a:schemeClr val="accent1"/>
-                </a:fillRef>
-                <a:effectRef idx="0">
-                  <a:schemeClr val="accent1"/>
-                </a:effectRef>
-                <a:fontRef idx="minor">
-                  <a:schemeClr val="lt1"/>
-                </a:fontRef>
-              </p:style>
-              <p:txBody>
-                <a:bodyPr rtlCol="0" anchor="ctr"/>
-                <a:lstStyle/>
-                <a:p>
-                  <a:pPr algn="ctr"/>
-                  <a:endParaRPr lang="de-DE"/>
-                </a:p>
-              </p:txBody>
-            </p:sp>
-            <p:sp>
-              <p:nvSpPr>
-                <p:cNvPr id="69" name="Textfeld 68">
-                  <a:extLst>
-                    <a:ext uri="{FF2B5EF4-FFF2-40B4-BE49-F238E27FC236}">
-                      <a16:creationId xmlns:a16="http://schemas.microsoft.com/office/drawing/2014/main" id="{06971D2B-11F1-F847-86D5-A05053D8999A}"/>
-                    </a:ext>
-                  </a:extLst>
-                </p:cNvPr>
-                <p:cNvSpPr txBox="1"/>
-                <p:nvPr/>
-              </p:nvSpPr>
-              <p:spPr>
-                <a:xfrm>
-                  <a:off x="6607221" y="632143"/>
-                  <a:ext cx="1032705" cy="546100"/>
-                </a:xfrm>
-                <a:prstGeom prst="rect">
-                  <a:avLst/>
-                </a:prstGeom>
-                <a:noFill/>
-                <a:ln>
-                  <a:noFill/>
-                </a:ln>
-              </p:spPr>
-              <p:txBody>
-                <a:bodyPr wrap="square" rtlCol="0">
-                  <a:spAutoFit/>
-                </a:bodyPr>
-                <a:lstStyle/>
-                <a:p>
-                  <a:r>
-                    <a:rPr lang="de-DE" b="1">
-                      <a:solidFill>
-                        <a:srgbClr val="7030A0"/>
-                      </a:solidFill>
-                    </a:rPr>
-                    <a:t>Das Backend</a:t>
-                  </a:r>
-                </a:p>
-              </p:txBody>
-            </p:sp>
-          </p:grpSp>
-          <p:grpSp>
-            <p:nvGrpSpPr>
-              <p:cNvPr id="9" name="Gruppieren 8">
-                <a:extLst>
-                  <a:ext uri="{FF2B5EF4-FFF2-40B4-BE49-F238E27FC236}">
-                    <a16:creationId xmlns:a16="http://schemas.microsoft.com/office/drawing/2014/main" id="{B20A8C9F-F57C-4D2B-2026-E1D2C374B37C}"/>
-                  </a:ext>
-                </a:extLst>
-              </p:cNvPr>
-              <p:cNvGrpSpPr/>
-              <p:nvPr/>
-            </p:nvGrpSpPr>
-            <p:grpSpPr>
-              <a:xfrm>
-                <a:off x="5583614" y="1463281"/>
-                <a:ext cx="4423990" cy="2689384"/>
-                <a:chOff x="6606125" y="632008"/>
-                <a:chExt cx="1609958" cy="3976567"/>
-              </a:xfrm>
-              <a:solidFill>
-                <a:schemeClr val="bg1">
-                  <a:lumMod val="95000"/>
-                </a:schemeClr>
-              </a:solidFill>
-            </p:grpSpPr>
-            <p:sp>
-              <p:nvSpPr>
-                <p:cNvPr id="10" name="Rechteck 9">
-                  <a:extLst>
-                    <a:ext uri="{FF2B5EF4-FFF2-40B4-BE49-F238E27FC236}">
-                      <a16:creationId xmlns:a16="http://schemas.microsoft.com/office/drawing/2014/main" id="{6921B3CE-E7A0-EC84-AE42-D587DB52C342}"/>
-                    </a:ext>
-                  </a:extLst>
-                </p:cNvPr>
-                <p:cNvSpPr/>
-                <p:nvPr/>
-              </p:nvSpPr>
-              <p:spPr>
-                <a:xfrm>
-                  <a:off x="6606125" y="632008"/>
-                  <a:ext cx="1609958" cy="3976567"/>
-                </a:xfrm>
-                <a:prstGeom prst="rect">
-                  <a:avLst/>
-                </a:prstGeom>
-                <a:grpFill/>
-                <a:ln>
-                  <a:solidFill>
-                    <a:schemeClr val="tx2">
-                      <a:lumMod val="75000"/>
-                      <a:lumOff val="25000"/>
-                    </a:schemeClr>
-                  </a:solidFill>
-                </a:ln>
-              </p:spPr>
-              <p:style>
-                <a:lnRef idx="2">
-                  <a:schemeClr val="accent1">
-                    <a:shade val="15000"/>
-                  </a:schemeClr>
-                </a:lnRef>
-                <a:fillRef idx="1">
-                  <a:schemeClr val="accent1"/>
-                </a:fillRef>
-                <a:effectRef idx="0">
-                  <a:schemeClr val="accent1"/>
-                </a:effectRef>
-                <a:fontRef idx="minor">
-                  <a:schemeClr val="lt1"/>
-                </a:fontRef>
-              </p:style>
-              <p:txBody>
-                <a:bodyPr rtlCol="0" anchor="ctr"/>
-                <a:lstStyle/>
-                <a:p>
-                  <a:pPr algn="ctr"/>
-                  <a:endParaRPr lang="de-DE"/>
-                </a:p>
-              </p:txBody>
-            </p:sp>
-            <p:sp>
-              <p:nvSpPr>
-                <p:cNvPr id="11" name="Textfeld 10">
-                  <a:extLst>
-                    <a:ext uri="{FF2B5EF4-FFF2-40B4-BE49-F238E27FC236}">
-                      <a16:creationId xmlns:a16="http://schemas.microsoft.com/office/drawing/2014/main" id="{EC331E49-AA54-F3AD-0A2F-79D0B4B9BE38}"/>
-                    </a:ext>
-                  </a:extLst>
-                </p:cNvPr>
-                <p:cNvSpPr txBox="1"/>
-                <p:nvPr/>
-              </p:nvSpPr>
-              <p:spPr>
-                <a:xfrm>
-                  <a:off x="6607221" y="632142"/>
-                  <a:ext cx="899942" cy="659962"/>
-                </a:xfrm>
-                <a:prstGeom prst="rect">
-                  <a:avLst/>
-                </a:prstGeom>
-                <a:noFill/>
-              </p:spPr>
-              <p:txBody>
-                <a:bodyPr wrap="none" rtlCol="0">
-                  <a:spAutoFit/>
-                </a:bodyPr>
-                <a:lstStyle/>
-                <a:p>
-                  <a:r>
-                    <a:rPr lang="de-DE" b="1">
-                      <a:solidFill>
-                        <a:schemeClr val="tx2">
-                          <a:lumMod val="75000"/>
-                          <a:lumOff val="25000"/>
-                        </a:schemeClr>
-                      </a:solidFill>
-                    </a:rPr>
-                    <a:t>Jobhost.exe</a:t>
-                  </a:r>
-                </a:p>
-              </p:txBody>
-            </p:sp>
-          </p:grpSp>
-          <p:grpSp>
-            <p:nvGrpSpPr>
-              <p:cNvPr id="15" name="Gruppieren 14">
-                <a:extLst>
-                  <a:ext uri="{FF2B5EF4-FFF2-40B4-BE49-F238E27FC236}">
-                    <a16:creationId xmlns:a16="http://schemas.microsoft.com/office/drawing/2014/main" id="{00681D04-726D-1F17-2FF4-63D66A1BAB7E}"/>
-                  </a:ext>
-                </a:extLst>
-              </p:cNvPr>
-              <p:cNvGrpSpPr/>
-              <p:nvPr/>
-            </p:nvGrpSpPr>
-            <p:grpSpPr>
-              <a:xfrm>
-                <a:off x="8005905" y="3082401"/>
-                <a:ext cx="1822489" cy="765048"/>
-                <a:chOff x="164209" y="1524953"/>
-                <a:chExt cx="1822489" cy="765048"/>
-              </a:xfrm>
-            </p:grpSpPr>
-            <p:sp>
-              <p:nvSpPr>
-                <p:cNvPr id="16" name="Rechteck 15">
-                  <a:extLst>
-                    <a:ext uri="{FF2B5EF4-FFF2-40B4-BE49-F238E27FC236}">
-                      <a16:creationId xmlns:a16="http://schemas.microsoft.com/office/drawing/2014/main" id="{EE7FD0AE-ABF6-2A9B-559B-9DECBD0D518D}"/>
-                    </a:ext>
-                  </a:extLst>
-                </p:cNvPr>
-                <p:cNvSpPr/>
-                <p:nvPr/>
-              </p:nvSpPr>
-              <p:spPr>
-                <a:xfrm>
-                  <a:off x="164209" y="1524953"/>
-                  <a:ext cx="1803699" cy="765048"/>
-                </a:xfrm>
-                <a:prstGeom prst="rect">
-                  <a:avLst/>
-                </a:prstGeom>
-                <a:solidFill>
-                  <a:schemeClr val="tx2">
-                    <a:lumMod val="10000"/>
-                    <a:lumOff val="90000"/>
-                  </a:schemeClr>
-                </a:solidFill>
-                <a:ln>
-                  <a:solidFill>
-                    <a:schemeClr val="tx2">
-                      <a:lumMod val="75000"/>
-                      <a:lumOff val="25000"/>
-                    </a:schemeClr>
-                  </a:solidFill>
-                </a:ln>
-              </p:spPr>
-              <p:style>
-                <a:lnRef idx="2">
-                  <a:schemeClr val="accent1">
-                    <a:shade val="15000"/>
-                  </a:schemeClr>
-                </a:lnRef>
-                <a:fillRef idx="1">
-                  <a:schemeClr val="accent1"/>
-                </a:fillRef>
-                <a:effectRef idx="0">
-                  <a:schemeClr val="accent1"/>
-                </a:effectRef>
-                <a:fontRef idx="minor">
-                  <a:schemeClr val="lt1"/>
-                </a:fontRef>
-              </p:style>
-              <p:txBody>
-                <a:bodyPr rtlCol="0" anchor="ctr"/>
-                <a:lstStyle/>
-                <a:p>
-                  <a:pPr algn="ctr"/>
-                  <a:endParaRPr lang="de-DE"/>
-                </a:p>
-              </p:txBody>
-            </p:sp>
-            <p:sp>
-              <p:nvSpPr>
-                <p:cNvPr id="17" name="Textfeld 16">
-                  <a:extLst>
-                    <a:ext uri="{FF2B5EF4-FFF2-40B4-BE49-F238E27FC236}">
-                      <a16:creationId xmlns:a16="http://schemas.microsoft.com/office/drawing/2014/main" id="{66E59F33-9673-BF9A-2A76-B7ED8A290DEA}"/>
-                    </a:ext>
-                  </a:extLst>
-                </p:cNvPr>
-                <p:cNvSpPr txBox="1"/>
-                <p:nvPr/>
-              </p:nvSpPr>
-              <p:spPr>
-                <a:xfrm>
-                  <a:off x="182999" y="1686886"/>
-                  <a:ext cx="1803699" cy="369332"/>
-                </a:xfrm>
-                <a:prstGeom prst="rect">
-                  <a:avLst/>
-                </a:prstGeom>
-                <a:noFill/>
-              </p:spPr>
-              <p:txBody>
-                <a:bodyPr wrap="none" rtlCol="0">
-                  <a:spAutoFit/>
-                </a:bodyPr>
-                <a:lstStyle/>
-                <a:p>
-                  <a:r>
-                    <a:rPr lang="de-DE" b="1">
-                      <a:solidFill>
-                        <a:schemeClr val="tx2">
-                          <a:lumMod val="75000"/>
-                          <a:lumOff val="25000"/>
-                        </a:schemeClr>
-                      </a:solidFill>
-                    </a:rPr>
-                    <a:t>job-assemblies</a:t>
-                  </a:r>
-                </a:p>
-              </p:txBody>
-            </p:sp>
-          </p:grpSp>
-          <p:grpSp>
-            <p:nvGrpSpPr>
-              <p:cNvPr id="19" name="Gruppieren 18">
-                <a:extLst>
-                  <a:ext uri="{FF2B5EF4-FFF2-40B4-BE49-F238E27FC236}">
-                    <a16:creationId xmlns:a16="http://schemas.microsoft.com/office/drawing/2014/main" id="{41C2E713-FEED-828B-784C-F67174EC88F8}"/>
-                  </a:ext>
-                </a:extLst>
-              </p:cNvPr>
-              <p:cNvGrpSpPr/>
-              <p:nvPr/>
-            </p:nvGrpSpPr>
-            <p:grpSpPr>
-              <a:xfrm>
-                <a:off x="5897322" y="1853741"/>
-                <a:ext cx="3922316" cy="708234"/>
-                <a:chOff x="164209" y="1516532"/>
-                <a:chExt cx="1803699" cy="773469"/>
-              </a:xfrm>
-            </p:grpSpPr>
-            <p:sp>
-              <p:nvSpPr>
-                <p:cNvPr id="21" name="Rechteck 20">
-                  <a:extLst>
-                    <a:ext uri="{FF2B5EF4-FFF2-40B4-BE49-F238E27FC236}">
-                      <a16:creationId xmlns:a16="http://schemas.microsoft.com/office/drawing/2014/main" id="{F5734D98-A5B2-DFFF-01E1-0795FEF53E54}"/>
-                    </a:ext>
-                  </a:extLst>
-                </p:cNvPr>
-                <p:cNvSpPr/>
-                <p:nvPr/>
-              </p:nvSpPr>
-              <p:spPr>
-                <a:xfrm>
-                  <a:off x="164209" y="1524953"/>
-                  <a:ext cx="1803699" cy="765048"/>
-                </a:xfrm>
-                <a:prstGeom prst="rect">
-                  <a:avLst/>
-                </a:prstGeom>
-                <a:solidFill>
-                  <a:schemeClr val="tx2">
-                    <a:lumMod val="10000"/>
-                    <a:lumOff val="90000"/>
-                  </a:schemeClr>
-                </a:solidFill>
-                <a:ln>
-                  <a:solidFill>
-                    <a:schemeClr val="tx2">
-                      <a:lumMod val="75000"/>
-                      <a:lumOff val="25000"/>
-                    </a:schemeClr>
-                  </a:solidFill>
-                </a:ln>
-              </p:spPr>
-              <p:style>
-                <a:lnRef idx="2">
-                  <a:schemeClr val="accent1">
-                    <a:shade val="15000"/>
-                  </a:schemeClr>
-                </a:lnRef>
-                <a:fillRef idx="1">
-                  <a:schemeClr val="accent1"/>
-                </a:fillRef>
-                <a:effectRef idx="0">
-                  <a:schemeClr val="accent1"/>
-                </a:effectRef>
-                <a:fontRef idx="minor">
-                  <a:schemeClr val="lt1"/>
-                </a:fontRef>
-              </p:style>
-              <p:txBody>
-                <a:bodyPr rtlCol="0" anchor="ctr"/>
-                <a:lstStyle/>
-                <a:p>
-                  <a:pPr algn="ctr"/>
-                  <a:endParaRPr lang="de-DE"/>
-                </a:p>
-              </p:txBody>
-            </p:sp>
-            <p:sp>
-              <p:nvSpPr>
-                <p:cNvPr id="28" name="Textfeld 27">
-                  <a:extLst>
-                    <a:ext uri="{FF2B5EF4-FFF2-40B4-BE49-F238E27FC236}">
-                      <a16:creationId xmlns:a16="http://schemas.microsoft.com/office/drawing/2014/main" id="{7201EE90-CEA3-3A25-B815-CBC87BEDB594}"/>
-                    </a:ext>
-                  </a:extLst>
-                </p:cNvPr>
-                <p:cNvSpPr txBox="1"/>
-                <p:nvPr/>
-              </p:nvSpPr>
-              <p:spPr>
-                <a:xfrm>
-                  <a:off x="198602" y="1516532"/>
-                  <a:ext cx="1109599" cy="369332"/>
-                </a:xfrm>
-                <a:prstGeom prst="rect">
-                  <a:avLst/>
-                </a:prstGeom>
-                <a:noFill/>
-              </p:spPr>
-              <p:txBody>
-                <a:bodyPr wrap="none" rtlCol="0">
-                  <a:spAutoFit/>
-                </a:bodyPr>
-                <a:lstStyle/>
-                <a:p>
-                  <a:r>
-                    <a:rPr lang="de-DE" b="1">
-                      <a:solidFill>
-                        <a:schemeClr val="tx2">
-                          <a:lumMod val="75000"/>
-                          <a:lumOff val="25000"/>
-                        </a:schemeClr>
-                      </a:solidFill>
-                    </a:rPr>
-                    <a:t>Base-job</a:t>
-                  </a:r>
-                </a:p>
-              </p:txBody>
-            </p:sp>
-          </p:grpSp>
-          <p:sp>
-            <p:nvSpPr>
-              <p:cNvPr id="52" name="Textfeld 51">
-                <a:extLst>
-                  <a:ext uri="{FF2B5EF4-FFF2-40B4-BE49-F238E27FC236}">
-                    <a16:creationId xmlns:a16="http://schemas.microsoft.com/office/drawing/2014/main" id="{AB395DAA-F396-28B1-E9C1-A745386E2EEB}"/>
-                  </a:ext>
-                </a:extLst>
-              </p:cNvPr>
-              <p:cNvSpPr txBox="1"/>
-              <p:nvPr/>
-            </p:nvSpPr>
-            <p:spPr>
-              <a:xfrm>
-                <a:off x="5124305" y="2724919"/>
-                <a:ext cx="2472944" cy="1169551"/>
-              </a:xfrm>
-              <a:prstGeom prst="rect">
-                <a:avLst/>
-              </a:prstGeom>
-              <a:solidFill>
-                <a:srgbClr val="FF9999"/>
-              </a:solidFill>
-            </p:spPr>
-            <p:txBody>
-              <a:bodyPr wrap="square">
-                <a:spAutoFit/>
-              </a:bodyPr>
-              <a:lstStyle/>
-              <a:p>
-                <a:r>
-                  <a:rPr lang="de-DE" sz="1000" b="1"/>
-                  <a:t>HaevgRZ.JobSystem.SessionStore.dll</a:t>
-                </a:r>
-              </a:p>
-              <a:p>
-                <a:r>
-                  <a:rPr lang="de-DE" sz="1000" b="1"/>
-                  <a:t>HaevgRZ.JobSystem.Core.dll</a:t>
-                </a:r>
-              </a:p>
-              <a:p>
-                <a:r>
-                  <a:rPr lang="de-DE" sz="1000" b="1"/>
-                  <a:t>HaevgRZ.JobSystem.Contracts.dll</a:t>
-                </a:r>
-              </a:p>
-              <a:p>
-                <a:r>
-                  <a:rPr lang="de-DE" sz="1000" b="1"/>
-                  <a:t>HaevgRZ.JobSystem.Lib.Core.dll</a:t>
-                </a:r>
-              </a:p>
-              <a:p>
-                <a:r>
-                  <a:rPr lang="de-DE" sz="1000" b="1"/>
-                  <a:t>HaevgRZ.JobSystem.Lib.Messaging.dll</a:t>
-                </a:r>
-              </a:p>
-              <a:p>
-                <a:r>
-                  <a:rPr lang="de-DE" sz="1000" b="1"/>
-                  <a:t>„GlobalConfig“</a:t>
-                </a:r>
-              </a:p>
-              <a:p>
-                <a:r>
-                  <a:rPr lang="de-DE" sz="1000" b="1"/>
-                  <a:t>…</a:t>
-                </a:r>
-              </a:p>
-            </p:txBody>
-          </p:sp>
-          <p:sp>
-            <p:nvSpPr>
-              <p:cNvPr id="55" name="Textfeld 54">
-                <a:extLst>
-                  <a:ext uri="{FF2B5EF4-FFF2-40B4-BE49-F238E27FC236}">
-                    <a16:creationId xmlns:a16="http://schemas.microsoft.com/office/drawing/2014/main" id="{35A56320-1BAA-14D4-257E-BC2DD55217FB}"/>
-                  </a:ext>
-                </a:extLst>
-              </p:cNvPr>
-              <p:cNvSpPr txBox="1"/>
-              <p:nvPr/>
-            </p:nvSpPr>
-            <p:spPr>
-              <a:xfrm>
-                <a:off x="7927182" y="2724919"/>
-                <a:ext cx="1905009" cy="338554"/>
-              </a:xfrm>
-              <a:prstGeom prst="rect">
-                <a:avLst/>
-              </a:prstGeom>
-              <a:noFill/>
-            </p:spPr>
-            <p:txBody>
-              <a:bodyPr wrap="none" rtlCol="0">
-                <a:spAutoFit/>
-              </a:bodyPr>
-              <a:lstStyle/>
-              <a:p>
-                <a:r>
-                  <a:rPr lang="de-DE" sz="1600" b="1">
-                    <a:solidFill>
-                      <a:srgbClr val="FF0000"/>
-                    </a:solidFill>
-                  </a:rPr>
-                  <a:t>AssemblyResolve:</a:t>
-                </a:r>
-              </a:p>
-            </p:txBody>
-          </p:sp>
-          <p:grpSp>
-            <p:nvGrpSpPr>
-              <p:cNvPr id="56" name="Gruppieren 55">
-                <a:extLst>
-                  <a:ext uri="{FF2B5EF4-FFF2-40B4-BE49-F238E27FC236}">
-                    <a16:creationId xmlns:a16="http://schemas.microsoft.com/office/drawing/2014/main" id="{840FE24B-8ABF-C58F-FA7B-285D8FF784A4}"/>
-                  </a:ext>
-                </a:extLst>
-              </p:cNvPr>
-              <p:cNvGrpSpPr/>
-              <p:nvPr/>
-            </p:nvGrpSpPr>
-            <p:grpSpPr>
-              <a:xfrm>
-                <a:off x="2898340" y="1918813"/>
-                <a:ext cx="1803699" cy="643577"/>
-                <a:chOff x="164209" y="1588453"/>
-                <a:chExt cx="1803699" cy="643577"/>
-              </a:xfrm>
-            </p:grpSpPr>
-            <p:sp>
-              <p:nvSpPr>
-                <p:cNvPr id="57" name="Rechteck 56">
-                  <a:extLst>
-                    <a:ext uri="{FF2B5EF4-FFF2-40B4-BE49-F238E27FC236}">
-                      <a16:creationId xmlns:a16="http://schemas.microsoft.com/office/drawing/2014/main" id="{5339CB1C-0982-812A-5B00-A1C734F2D7B9}"/>
-                    </a:ext>
-                  </a:extLst>
-                </p:cNvPr>
-                <p:cNvSpPr/>
-                <p:nvPr/>
-              </p:nvSpPr>
-              <p:spPr>
-                <a:xfrm>
-                  <a:off x="164209" y="1588453"/>
-                  <a:ext cx="1803699" cy="643577"/>
-                </a:xfrm>
-                <a:prstGeom prst="rect">
-                  <a:avLst/>
-                </a:prstGeom>
-                <a:solidFill>
-                  <a:schemeClr val="tx2">
-                    <a:lumMod val="10000"/>
-                    <a:lumOff val="90000"/>
-                  </a:schemeClr>
-                </a:solidFill>
-                <a:ln>
-                  <a:solidFill>
-                    <a:schemeClr val="tx2">
-                      <a:lumMod val="75000"/>
-                      <a:lumOff val="25000"/>
-                    </a:schemeClr>
-                  </a:solidFill>
-                </a:ln>
-              </p:spPr>
-              <p:style>
-                <a:lnRef idx="2">
-                  <a:schemeClr val="accent1">
-                    <a:shade val="15000"/>
-                  </a:schemeClr>
-                </a:lnRef>
-                <a:fillRef idx="1">
-                  <a:schemeClr val="accent1"/>
-                </a:fillRef>
-                <a:effectRef idx="0">
-                  <a:schemeClr val="accent1"/>
-                </a:effectRef>
-                <a:fontRef idx="minor">
-                  <a:schemeClr val="lt1"/>
-                </a:fontRef>
-              </p:style>
-              <p:txBody>
-                <a:bodyPr rtlCol="0" anchor="ctr"/>
-                <a:lstStyle/>
-                <a:p>
-                  <a:pPr algn="ctr"/>
-                  <a:endParaRPr lang="de-DE"/>
-                </a:p>
-              </p:txBody>
-            </p:sp>
-            <p:sp>
-              <p:nvSpPr>
-                <p:cNvPr id="58" name="Textfeld 57">
-                  <a:extLst>
-                    <a:ext uri="{FF2B5EF4-FFF2-40B4-BE49-F238E27FC236}">
-                      <a16:creationId xmlns:a16="http://schemas.microsoft.com/office/drawing/2014/main" id="{FDA82363-6616-3120-15F7-E15ADFD3A277}"/>
-                    </a:ext>
-                  </a:extLst>
-                </p:cNvPr>
-                <p:cNvSpPr txBox="1"/>
-                <p:nvPr/>
-              </p:nvSpPr>
-              <p:spPr>
-                <a:xfrm>
-                  <a:off x="216082" y="1606413"/>
-                  <a:ext cx="1741311" cy="369332"/>
-                </a:xfrm>
-                <a:prstGeom prst="rect">
-                  <a:avLst/>
-                </a:prstGeom>
-                <a:noFill/>
-              </p:spPr>
-              <p:txBody>
-                <a:bodyPr wrap="none" rtlCol="0">
-                  <a:spAutoFit/>
-                </a:bodyPr>
-                <a:lstStyle/>
-                <a:p>
-                  <a:r>
-                    <a:rPr lang="de-DE" b="1">
-                      <a:solidFill>
-                        <a:schemeClr val="tx2">
-                          <a:lumMod val="75000"/>
-                          <a:lumOff val="25000"/>
-                        </a:schemeClr>
-                      </a:solidFill>
-                    </a:rPr>
-                    <a:t>SessionStarter</a:t>
-                  </a:r>
-                </a:p>
-              </p:txBody>
-            </p:sp>
-          </p:grpSp>
-          <p:sp>
-            <p:nvSpPr>
-              <p:cNvPr id="60" name="Pfeil: nach rechts 59">
-                <a:extLst>
-                  <a:ext uri="{FF2B5EF4-FFF2-40B4-BE49-F238E27FC236}">
-                    <a16:creationId xmlns:a16="http://schemas.microsoft.com/office/drawing/2014/main" id="{3E79FB88-779C-13F8-B2BF-A117237A18A3}"/>
+                    <a16:creationId xmlns:a16="http://schemas.microsoft.com/office/drawing/2014/main" id="{91D6CEA9-DE63-5C3E-1FC1-F87CE5390BFE}"/>
                   </a:ext>
                 </a:extLst>
               </p:cNvPr>
@@ -13584,104 +12842,13 @@
             </p:nvSpPr>
             <p:spPr>
               <a:xfrm>
-                <a:off x="4723504" y="2146441"/>
-                <a:ext cx="841320" cy="445626"/>
-              </a:xfrm>
-              <a:prstGeom prst="rightArrow">
-                <a:avLst/>
-              </a:prstGeom>
-              <a:solidFill>
-                <a:schemeClr val="accent6"/>
-              </a:solidFill>
-              <a:ln>
-                <a:solidFill>
-                  <a:srgbClr val="0070C0"/>
-                </a:solidFill>
-              </a:ln>
-            </p:spPr>
-            <p:style>
-              <a:lnRef idx="2">
-                <a:schemeClr val="accent1">
-                  <a:shade val="15000"/>
-                </a:schemeClr>
-              </a:lnRef>
-              <a:fillRef idx="1">
-                <a:schemeClr val="accent1"/>
-              </a:fillRef>
-              <a:effectRef idx="0">
-                <a:schemeClr val="accent1"/>
-              </a:effectRef>
-              <a:fontRef idx="minor">
-                <a:schemeClr val="lt1"/>
-              </a:fontRef>
-            </p:style>
-            <p:txBody>
-              <a:bodyPr rtlCol="0" anchor="ctr"/>
-              <a:lstStyle/>
-              <a:p>
-                <a:pPr algn="ctr"/>
-                <a:endParaRPr lang="de-DE"/>
-              </a:p>
-            </p:txBody>
-          </p:sp>
-          <p:sp>
-            <p:nvSpPr>
-              <p:cNvPr id="61" name="Textfeld 60">
-                <a:extLst>
-                  <a:ext uri="{FF2B5EF4-FFF2-40B4-BE49-F238E27FC236}">
-                    <a16:creationId xmlns:a16="http://schemas.microsoft.com/office/drawing/2014/main" id="{62C7E6E6-A5E4-68DB-279A-D74781522F4F}"/>
-                  </a:ext>
-                </a:extLst>
-              </p:cNvPr>
-              <p:cNvSpPr txBox="1"/>
-              <p:nvPr/>
-            </p:nvSpPr>
-            <p:spPr>
-              <a:xfrm>
-                <a:off x="4666437" y="1778023"/>
-                <a:ext cx="955454" cy="369332"/>
+                <a:off x="6606124" y="632008"/>
+                <a:ext cx="1609958" cy="3976567"/>
               </a:xfrm>
               <a:prstGeom prst="rect">
                 <a:avLst/>
               </a:prstGeom>
-              <a:noFill/>
-            </p:spPr>
-            <p:txBody>
-              <a:bodyPr wrap="none" rtlCol="0">
-                <a:spAutoFit/>
-              </a:bodyPr>
-              <a:lstStyle/>
-              <a:p>
-                <a:r>
-                  <a:rPr lang="de-DE"/>
-                  <a:t>spawns</a:t>
-                </a:r>
-              </a:p>
-            </p:txBody>
-          </p:sp>
-          <p:sp>
-            <p:nvSpPr>
-              <p:cNvPr id="70" name="Pfeil: nach links 69">
-                <a:extLst>
-                  <a:ext uri="{FF2B5EF4-FFF2-40B4-BE49-F238E27FC236}">
-                    <a16:creationId xmlns:a16="http://schemas.microsoft.com/office/drawing/2014/main" id="{1536D43B-1E69-F7B8-4F87-A0FD5F362E85}"/>
-                  </a:ext>
-                </a:extLst>
-              </p:cNvPr>
-              <p:cNvSpPr/>
-              <p:nvPr/>
-            </p:nvSpPr>
-            <p:spPr>
-              <a:xfrm>
-                <a:off x="3799699" y="2969365"/>
-                <a:ext cx="1311905" cy="707281"/>
-              </a:xfrm>
-              <a:prstGeom prst="leftArrow">
-                <a:avLst/>
-              </a:prstGeom>
-              <a:solidFill>
-                <a:srgbClr val="C00000"/>
-              </a:solidFill>
+              <a:grpFill/>
               <a:ln>
                 <a:solidFill>
                   <a:srgbClr val="7030A0"/>
@@ -13713,193 +12880,1015 @@
               </a:p>
             </p:txBody>
           </p:sp>
-          <p:pic>
-            <p:nvPicPr>
-              <p:cNvPr id="73" name="Grafik 72">
+          <p:sp>
+            <p:nvSpPr>
+              <p:cNvPr id="69" name="Textfeld 68">
                 <a:extLst>
                   <a:ext uri="{FF2B5EF4-FFF2-40B4-BE49-F238E27FC236}">
-                    <a16:creationId xmlns:a16="http://schemas.microsoft.com/office/drawing/2014/main" id="{16156912-CE86-DB36-D615-C741938FB6F0}"/>
+                    <a16:creationId xmlns:a16="http://schemas.microsoft.com/office/drawing/2014/main" id="{06971D2B-11F1-F847-86D5-A05053D8999A}"/>
                   </a:ext>
                 </a:extLst>
               </p:cNvPr>
-              <p:cNvPicPr>
-                <a:picLocks noChangeAspect="1"/>
-              </p:cNvPicPr>
+              <p:cNvSpPr txBox="1"/>
               <p:nvPr/>
-            </p:nvPicPr>
-            <p:blipFill>
-              <a:blip r:embed="rId2">
-                <a:extLst>
-                  <a:ext uri="{28A0092B-C50C-407E-A947-70E740481C1C}">
-                    <a14:useLocalDpi xmlns:a14="http://schemas.microsoft.com/office/drawing/2010/main" val="0"/>
-                  </a:ext>
-                </a:extLst>
-              </a:blip>
-              <a:stretch>
-                <a:fillRect/>
-              </a:stretch>
-            </p:blipFill>
+            </p:nvSpPr>
             <p:spPr>
               <a:xfrm>
-                <a:off x="1866421" y="2428990"/>
-                <a:ext cx="827913" cy="827913"/>
+                <a:off x="6607221" y="632143"/>
+                <a:ext cx="1032705" cy="546100"/>
               </a:xfrm>
               <a:prstGeom prst="rect">
                 <a:avLst/>
               </a:prstGeom>
+              <a:noFill/>
+              <a:ln>
+                <a:noFill/>
+              </a:ln>
             </p:spPr>
-          </p:pic>
-          <p:pic>
-            <p:nvPicPr>
-              <p:cNvPr id="77" name="Grafik 76">
+            <p:txBody>
+              <a:bodyPr wrap="square" rtlCol="0">
+                <a:spAutoFit/>
+              </a:bodyPr>
+              <a:lstStyle/>
+              <a:p>
+                <a:r>
+                  <a:rPr lang="de-DE" b="1">
+                    <a:solidFill>
+                      <a:srgbClr val="7030A0"/>
+                    </a:solidFill>
+                  </a:rPr>
+                  <a:t>Das Backend</a:t>
+                </a:r>
+              </a:p>
+            </p:txBody>
+          </p:sp>
+        </p:grpSp>
+        <p:grpSp>
+          <p:nvGrpSpPr>
+            <p:cNvPr id="9" name="Gruppieren 8">
+              <a:extLst>
+                <a:ext uri="{FF2B5EF4-FFF2-40B4-BE49-F238E27FC236}">
+                  <a16:creationId xmlns:a16="http://schemas.microsoft.com/office/drawing/2014/main" id="{B20A8C9F-F57C-4D2B-2026-E1D2C374B37C}"/>
+                </a:ext>
+              </a:extLst>
+            </p:cNvPr>
+            <p:cNvGrpSpPr/>
+            <p:nvPr/>
+          </p:nvGrpSpPr>
+          <p:grpSpPr>
+            <a:xfrm>
+              <a:off x="5588638" y="1778134"/>
+              <a:ext cx="4423990" cy="2689384"/>
+              <a:chOff x="6606125" y="632008"/>
+              <a:chExt cx="1609958" cy="3976567"/>
+            </a:xfrm>
+            <a:solidFill>
+              <a:schemeClr val="bg1">
+                <a:lumMod val="95000"/>
+              </a:schemeClr>
+            </a:solidFill>
+          </p:grpSpPr>
+          <p:sp>
+            <p:nvSpPr>
+              <p:cNvPr id="10" name="Rechteck 9">
                 <a:extLst>
                   <a:ext uri="{FF2B5EF4-FFF2-40B4-BE49-F238E27FC236}">
-                    <a16:creationId xmlns:a16="http://schemas.microsoft.com/office/drawing/2014/main" id="{FFFB93B2-C53C-4261-7D4C-71DCE8750523}"/>
+                    <a16:creationId xmlns:a16="http://schemas.microsoft.com/office/drawing/2014/main" id="{6921B3CE-E7A0-EC84-AE42-D587DB52C342}"/>
                   </a:ext>
                 </a:extLst>
               </p:cNvPr>
-              <p:cNvPicPr>
-                <a:picLocks noChangeAspect="1"/>
-              </p:cNvPicPr>
+              <p:cNvSpPr/>
               <p:nvPr/>
-            </p:nvPicPr>
-            <p:blipFill>
-              <a:blip r:embed="rId3">
-                <a:extLst>
-                  <a:ext uri="{28A0092B-C50C-407E-A947-70E740481C1C}">
-                    <a14:useLocalDpi xmlns:a14="http://schemas.microsoft.com/office/drawing/2010/main" val="0"/>
-                  </a:ext>
-                </a:extLst>
-              </a:blip>
-              <a:stretch>
-                <a:fillRect/>
-              </a:stretch>
-            </p:blipFill>
+            </p:nvSpPr>
             <p:spPr>
               <a:xfrm>
-                <a:off x="1792126" y="3208513"/>
-                <a:ext cx="882650" cy="882650"/>
+                <a:off x="6606125" y="632008"/>
+                <a:ext cx="1609958" cy="3976567"/>
               </a:xfrm>
               <a:prstGeom prst="rect">
                 <a:avLst/>
               </a:prstGeom>
+              <a:grpFill/>
+              <a:ln>
+                <a:solidFill>
+                  <a:schemeClr val="tx2">
+                    <a:lumMod val="75000"/>
+                    <a:lumOff val="25000"/>
+                  </a:schemeClr>
+                </a:solidFill>
+              </a:ln>
             </p:spPr>
-          </p:pic>
-          <p:pic>
-            <p:nvPicPr>
-              <p:cNvPr id="75" name="Grafik 74">
+            <p:style>
+              <a:lnRef idx="2">
+                <a:schemeClr val="accent1">
+                  <a:shade val="15000"/>
+                </a:schemeClr>
+              </a:lnRef>
+              <a:fillRef idx="1">
+                <a:schemeClr val="accent1"/>
+              </a:fillRef>
+              <a:effectRef idx="0">
+                <a:schemeClr val="accent1"/>
+              </a:effectRef>
+              <a:fontRef idx="minor">
+                <a:schemeClr val="lt1"/>
+              </a:fontRef>
+            </p:style>
+            <p:txBody>
+              <a:bodyPr rtlCol="0" anchor="ctr"/>
+              <a:lstStyle/>
+              <a:p>
+                <a:pPr algn="ctr"/>
+                <a:endParaRPr lang="de-DE"/>
+              </a:p>
+            </p:txBody>
+          </p:sp>
+          <p:sp>
+            <p:nvSpPr>
+              <p:cNvPr id="11" name="Textfeld 10">
                 <a:extLst>
                   <a:ext uri="{FF2B5EF4-FFF2-40B4-BE49-F238E27FC236}">
-                    <a16:creationId xmlns:a16="http://schemas.microsoft.com/office/drawing/2014/main" id="{C9A9F567-C88B-8C1F-9B5C-9AF7AF1B814F}"/>
+                    <a16:creationId xmlns:a16="http://schemas.microsoft.com/office/drawing/2014/main" id="{EC331E49-AA54-F3AD-0A2F-79D0B4B9BE38}"/>
                   </a:ext>
                 </a:extLst>
               </p:cNvPr>
-              <p:cNvPicPr>
-                <a:picLocks noChangeAspect="1"/>
-              </p:cNvPicPr>
+              <p:cNvSpPr txBox="1"/>
               <p:nvPr/>
-            </p:nvPicPr>
-            <p:blipFill>
-              <a:blip r:embed="rId4">
-                <a:extLst>
-                  <a:ext uri="{28A0092B-C50C-407E-A947-70E740481C1C}">
-                    <a14:useLocalDpi xmlns:a14="http://schemas.microsoft.com/office/drawing/2010/main" val="0"/>
-                  </a:ext>
-                </a:extLst>
-              </a:blip>
-              <a:stretch>
-                <a:fillRect/>
-              </a:stretch>
-            </p:blipFill>
+            </p:nvSpPr>
             <p:spPr>
               <a:xfrm>
-                <a:off x="2720198" y="2658108"/>
-                <a:ext cx="1066800" cy="1066800"/>
+                <a:off x="6607221" y="632142"/>
+                <a:ext cx="899942" cy="659962"/>
               </a:xfrm>
               <a:prstGeom prst="rect">
                 <a:avLst/>
               </a:prstGeom>
+              <a:noFill/>
             </p:spPr>
-          </p:pic>
-          <p:pic>
-            <p:nvPicPr>
-              <p:cNvPr id="3" name="Grafik 2">
+            <p:txBody>
+              <a:bodyPr wrap="none" rtlCol="0">
+                <a:spAutoFit/>
+              </a:bodyPr>
+              <a:lstStyle/>
+              <a:p>
+                <a:r>
+                  <a:rPr lang="de-DE" b="1">
+                    <a:solidFill>
+                      <a:schemeClr val="tx2">
+                        <a:lumMod val="75000"/>
+                        <a:lumOff val="25000"/>
+                      </a:schemeClr>
+                    </a:solidFill>
+                  </a:rPr>
+                  <a:t>Jobhost.exe</a:t>
+                </a:r>
+              </a:p>
+            </p:txBody>
+          </p:sp>
+        </p:grpSp>
+        <p:grpSp>
+          <p:nvGrpSpPr>
+            <p:cNvPr id="19" name="Gruppieren 18">
+              <a:extLst>
+                <a:ext uri="{FF2B5EF4-FFF2-40B4-BE49-F238E27FC236}">
+                  <a16:creationId xmlns:a16="http://schemas.microsoft.com/office/drawing/2014/main" id="{41C2E713-FEED-828B-784C-F67174EC88F8}"/>
+                </a:ext>
+              </a:extLst>
+            </p:cNvPr>
+            <p:cNvGrpSpPr/>
+            <p:nvPr/>
+          </p:nvGrpSpPr>
+          <p:grpSpPr>
+            <a:xfrm>
+              <a:off x="5902346" y="2168594"/>
+              <a:ext cx="3922316" cy="708234"/>
+              <a:chOff x="164209" y="1516532"/>
+              <a:chExt cx="1803699" cy="773469"/>
+            </a:xfrm>
+          </p:grpSpPr>
+          <p:sp>
+            <p:nvSpPr>
+              <p:cNvPr id="21" name="Rechteck 20">
                 <a:extLst>
                   <a:ext uri="{FF2B5EF4-FFF2-40B4-BE49-F238E27FC236}">
-                    <a16:creationId xmlns:a16="http://schemas.microsoft.com/office/drawing/2014/main" id="{6A00C80A-8D50-378A-0B7B-84DC8F866922}"/>
+                    <a16:creationId xmlns:a16="http://schemas.microsoft.com/office/drawing/2014/main" id="{F5734D98-A5B2-DFFF-01E1-0795FEF53E54}"/>
                   </a:ext>
                 </a:extLst>
               </p:cNvPr>
-              <p:cNvPicPr>
-                <a:picLocks noChangeAspect="1"/>
-              </p:cNvPicPr>
+              <p:cNvSpPr/>
               <p:nvPr/>
-            </p:nvPicPr>
-            <p:blipFill>
-              <a:blip r:embed="rId5">
-                <a:extLst>
-                  <a:ext uri="{28A0092B-C50C-407E-A947-70E740481C1C}">
-                    <a14:useLocalDpi xmlns:a14="http://schemas.microsoft.com/office/drawing/2010/main" val="0"/>
-                  </a:ext>
-                </a:extLst>
-              </a:blip>
-              <a:stretch>
-                <a:fillRect/>
-              </a:stretch>
-            </p:blipFill>
+            </p:nvSpPr>
             <p:spPr>
               <a:xfrm>
-                <a:off x="9560435" y="2842946"/>
-                <a:ext cx="457200" cy="457200"/>
+                <a:off x="164209" y="1524953"/>
+                <a:ext cx="1803699" cy="765048"/>
               </a:xfrm>
               <a:prstGeom prst="rect">
                 <a:avLst/>
               </a:prstGeom>
+              <a:solidFill>
+                <a:schemeClr val="tx2">
+                  <a:lumMod val="10000"/>
+                  <a:lumOff val="90000"/>
+                </a:schemeClr>
+              </a:solidFill>
+              <a:ln>
+                <a:solidFill>
+                  <a:schemeClr val="tx2">
+                    <a:lumMod val="75000"/>
+                    <a:lumOff val="25000"/>
+                  </a:schemeClr>
+                </a:solidFill>
+              </a:ln>
             </p:spPr>
-          </p:pic>
-          <p:pic>
-            <p:nvPicPr>
-              <p:cNvPr id="2" name="Grafik 1">
+            <p:style>
+              <a:lnRef idx="2">
+                <a:schemeClr val="accent1">
+                  <a:shade val="15000"/>
+                </a:schemeClr>
+              </a:lnRef>
+              <a:fillRef idx="1">
+                <a:schemeClr val="accent1"/>
+              </a:fillRef>
+              <a:effectRef idx="0">
+                <a:schemeClr val="accent1"/>
+              </a:effectRef>
+              <a:fontRef idx="minor">
+                <a:schemeClr val="lt1"/>
+              </a:fontRef>
+            </p:style>
+            <p:txBody>
+              <a:bodyPr rtlCol="0" anchor="ctr"/>
+              <a:lstStyle/>
+              <a:p>
+                <a:pPr algn="ctr"/>
+                <a:endParaRPr lang="de-DE"/>
+              </a:p>
+            </p:txBody>
+          </p:sp>
+          <p:sp>
+            <p:nvSpPr>
+              <p:cNvPr id="28" name="Textfeld 27">
                 <a:extLst>
                   <a:ext uri="{FF2B5EF4-FFF2-40B4-BE49-F238E27FC236}">
-                    <a16:creationId xmlns:a16="http://schemas.microsoft.com/office/drawing/2014/main" id="{D73ECB46-C9A9-DAF5-D3DE-40D24C072FC7}"/>
+                    <a16:creationId xmlns:a16="http://schemas.microsoft.com/office/drawing/2014/main" id="{7201EE90-CEA3-3A25-B815-CBC87BEDB594}"/>
                   </a:ext>
                 </a:extLst>
               </p:cNvPr>
-              <p:cNvPicPr>
-                <a:picLocks noChangeAspect="1"/>
-              </p:cNvPicPr>
+              <p:cNvSpPr txBox="1"/>
               <p:nvPr/>
-            </p:nvPicPr>
-            <p:blipFill>
-              <a:blip r:embed="rId5">
-                <a:extLst>
-                  <a:ext uri="{28A0092B-C50C-407E-A947-70E740481C1C}">
-                    <a14:useLocalDpi xmlns:a14="http://schemas.microsoft.com/office/drawing/2010/main" val="0"/>
-                  </a:ext>
-                </a:extLst>
-              </a:blip>
-              <a:stretch>
-                <a:fillRect/>
-              </a:stretch>
-            </p:blipFill>
+            </p:nvSpPr>
             <p:spPr>
               <a:xfrm>
-                <a:off x="4216569" y="2886721"/>
-                <a:ext cx="842786" cy="842786"/>
+                <a:off x="198602" y="1516532"/>
+                <a:ext cx="1109599" cy="369332"/>
               </a:xfrm>
               <a:prstGeom prst="rect">
                 <a:avLst/>
               </a:prstGeom>
+              <a:noFill/>
             </p:spPr>
-          </p:pic>
+            <p:txBody>
+              <a:bodyPr wrap="none" rtlCol="0">
+                <a:spAutoFit/>
+              </a:bodyPr>
+              <a:lstStyle/>
+              <a:p>
+                <a:r>
+                  <a:rPr lang="de-DE" b="1">
+                    <a:solidFill>
+                      <a:schemeClr val="tx2">
+                        <a:lumMod val="75000"/>
+                        <a:lumOff val="25000"/>
+                      </a:schemeClr>
+                    </a:solidFill>
+                  </a:rPr>
+                  <a:t>Base-job</a:t>
+                </a:r>
+              </a:p>
+            </p:txBody>
+          </p:sp>
         </p:grpSp>
+        <p:grpSp>
+          <p:nvGrpSpPr>
+            <p:cNvPr id="56" name="Gruppieren 55">
+              <a:extLst>
+                <a:ext uri="{FF2B5EF4-FFF2-40B4-BE49-F238E27FC236}">
+                  <a16:creationId xmlns:a16="http://schemas.microsoft.com/office/drawing/2014/main" id="{840FE24B-8ABF-C58F-FA7B-285D8FF784A4}"/>
+                </a:ext>
+              </a:extLst>
+            </p:cNvPr>
+            <p:cNvGrpSpPr/>
+            <p:nvPr/>
+          </p:nvGrpSpPr>
+          <p:grpSpPr>
+            <a:xfrm>
+              <a:off x="2903364" y="2233666"/>
+              <a:ext cx="1803699" cy="643577"/>
+              <a:chOff x="164209" y="1588453"/>
+              <a:chExt cx="1803699" cy="643577"/>
+            </a:xfrm>
+          </p:grpSpPr>
+          <p:sp>
+            <p:nvSpPr>
+              <p:cNvPr id="57" name="Rechteck 56">
+                <a:extLst>
+                  <a:ext uri="{FF2B5EF4-FFF2-40B4-BE49-F238E27FC236}">
+                    <a16:creationId xmlns:a16="http://schemas.microsoft.com/office/drawing/2014/main" id="{5339CB1C-0982-812A-5B00-A1C734F2D7B9}"/>
+                  </a:ext>
+                </a:extLst>
+              </p:cNvPr>
+              <p:cNvSpPr/>
+              <p:nvPr/>
+            </p:nvSpPr>
+            <p:spPr>
+              <a:xfrm>
+                <a:off x="164209" y="1588453"/>
+                <a:ext cx="1803699" cy="643577"/>
+              </a:xfrm>
+              <a:prstGeom prst="rect">
+                <a:avLst/>
+              </a:prstGeom>
+              <a:solidFill>
+                <a:schemeClr val="tx2">
+                  <a:lumMod val="10000"/>
+                  <a:lumOff val="90000"/>
+                </a:schemeClr>
+              </a:solidFill>
+              <a:ln>
+                <a:solidFill>
+                  <a:schemeClr val="tx2">
+                    <a:lumMod val="75000"/>
+                    <a:lumOff val="25000"/>
+                  </a:schemeClr>
+                </a:solidFill>
+              </a:ln>
+            </p:spPr>
+            <p:style>
+              <a:lnRef idx="2">
+                <a:schemeClr val="accent1">
+                  <a:shade val="15000"/>
+                </a:schemeClr>
+              </a:lnRef>
+              <a:fillRef idx="1">
+                <a:schemeClr val="accent1"/>
+              </a:fillRef>
+              <a:effectRef idx="0">
+                <a:schemeClr val="accent1"/>
+              </a:effectRef>
+              <a:fontRef idx="minor">
+                <a:schemeClr val="lt1"/>
+              </a:fontRef>
+            </p:style>
+            <p:txBody>
+              <a:bodyPr rtlCol="0" anchor="ctr"/>
+              <a:lstStyle/>
+              <a:p>
+                <a:pPr algn="ctr"/>
+                <a:endParaRPr lang="de-DE"/>
+              </a:p>
+            </p:txBody>
+          </p:sp>
+          <p:sp>
+            <p:nvSpPr>
+              <p:cNvPr id="58" name="Textfeld 57">
+                <a:extLst>
+                  <a:ext uri="{FF2B5EF4-FFF2-40B4-BE49-F238E27FC236}">
+                    <a16:creationId xmlns:a16="http://schemas.microsoft.com/office/drawing/2014/main" id="{FDA82363-6616-3120-15F7-E15ADFD3A277}"/>
+                  </a:ext>
+                </a:extLst>
+              </p:cNvPr>
+              <p:cNvSpPr txBox="1"/>
+              <p:nvPr/>
+            </p:nvSpPr>
+            <p:spPr>
+              <a:xfrm>
+                <a:off x="216082" y="1606413"/>
+                <a:ext cx="1741311" cy="369332"/>
+              </a:xfrm>
+              <a:prstGeom prst="rect">
+                <a:avLst/>
+              </a:prstGeom>
+              <a:noFill/>
+            </p:spPr>
+            <p:txBody>
+              <a:bodyPr wrap="none" rtlCol="0">
+                <a:spAutoFit/>
+              </a:bodyPr>
+              <a:lstStyle/>
+              <a:p>
+                <a:r>
+                  <a:rPr lang="de-DE" b="1">
+                    <a:solidFill>
+                      <a:schemeClr val="tx2">
+                        <a:lumMod val="75000"/>
+                        <a:lumOff val="25000"/>
+                      </a:schemeClr>
+                    </a:solidFill>
+                  </a:rPr>
+                  <a:t>SessionStarter</a:t>
+                </a:r>
+              </a:p>
+            </p:txBody>
+          </p:sp>
+        </p:grpSp>
+        <p:sp>
+          <p:nvSpPr>
+            <p:cNvPr id="60" name="Pfeil: nach rechts 59">
+              <a:extLst>
+                <a:ext uri="{FF2B5EF4-FFF2-40B4-BE49-F238E27FC236}">
+                  <a16:creationId xmlns:a16="http://schemas.microsoft.com/office/drawing/2014/main" id="{3E79FB88-779C-13F8-B2BF-A117237A18A3}"/>
+                </a:ext>
+              </a:extLst>
+            </p:cNvPr>
+            <p:cNvSpPr/>
+            <p:nvPr/>
+          </p:nvSpPr>
+          <p:spPr>
+            <a:xfrm>
+              <a:off x="4728528" y="2461294"/>
+              <a:ext cx="841320" cy="445626"/>
+            </a:xfrm>
+            <a:prstGeom prst="rightArrow">
+              <a:avLst/>
+            </a:prstGeom>
+            <a:solidFill>
+              <a:schemeClr val="accent6"/>
+            </a:solidFill>
+            <a:ln>
+              <a:solidFill>
+                <a:srgbClr val="0070C0"/>
+              </a:solidFill>
+            </a:ln>
+          </p:spPr>
+          <p:style>
+            <a:lnRef idx="2">
+              <a:schemeClr val="accent1">
+                <a:shade val="15000"/>
+              </a:schemeClr>
+            </a:lnRef>
+            <a:fillRef idx="1">
+              <a:schemeClr val="accent1"/>
+            </a:fillRef>
+            <a:effectRef idx="0">
+              <a:schemeClr val="accent1"/>
+            </a:effectRef>
+            <a:fontRef idx="minor">
+              <a:schemeClr val="lt1"/>
+            </a:fontRef>
+          </p:style>
+          <p:txBody>
+            <a:bodyPr rtlCol="0" anchor="ctr"/>
+            <a:lstStyle/>
+            <a:p>
+              <a:pPr algn="ctr"/>
+              <a:endParaRPr lang="de-DE"/>
+            </a:p>
+          </p:txBody>
+        </p:sp>
+        <p:sp>
+          <p:nvSpPr>
+            <p:cNvPr id="61" name="Textfeld 60">
+              <a:extLst>
+                <a:ext uri="{FF2B5EF4-FFF2-40B4-BE49-F238E27FC236}">
+                  <a16:creationId xmlns:a16="http://schemas.microsoft.com/office/drawing/2014/main" id="{62C7E6E6-A5E4-68DB-279A-D74781522F4F}"/>
+                </a:ext>
+              </a:extLst>
+            </p:cNvPr>
+            <p:cNvSpPr txBox="1"/>
+            <p:nvPr/>
+          </p:nvSpPr>
+          <p:spPr>
+            <a:xfrm>
+              <a:off x="4671461" y="2092876"/>
+              <a:ext cx="955454" cy="369332"/>
+            </a:xfrm>
+            <a:prstGeom prst="rect">
+              <a:avLst/>
+            </a:prstGeom>
+            <a:noFill/>
+          </p:spPr>
+          <p:txBody>
+            <a:bodyPr wrap="none" rtlCol="0">
+              <a:spAutoFit/>
+            </a:bodyPr>
+            <a:lstStyle/>
+            <a:p>
+              <a:r>
+                <a:rPr lang="de-DE"/>
+                <a:t>spawns</a:t>
+              </a:r>
+            </a:p>
+          </p:txBody>
+        </p:sp>
+        <p:pic>
+          <p:nvPicPr>
+            <p:cNvPr id="73" name="Grafik 72">
+              <a:extLst>
+                <a:ext uri="{FF2B5EF4-FFF2-40B4-BE49-F238E27FC236}">
+                  <a16:creationId xmlns:a16="http://schemas.microsoft.com/office/drawing/2014/main" id="{16156912-CE86-DB36-D615-C741938FB6F0}"/>
+                </a:ext>
+              </a:extLst>
+            </p:cNvPr>
+            <p:cNvPicPr>
+              <a:picLocks noChangeAspect="1"/>
+            </p:cNvPicPr>
+            <p:nvPr/>
+          </p:nvPicPr>
+          <p:blipFill>
+            <a:blip r:embed="rId2">
+              <a:extLst>
+                <a:ext uri="{28A0092B-C50C-407E-A947-70E740481C1C}">
+                  <a14:useLocalDpi xmlns:a14="http://schemas.microsoft.com/office/drawing/2010/main" val="0"/>
+                </a:ext>
+              </a:extLst>
+            </a:blip>
+            <a:stretch>
+              <a:fillRect/>
+            </a:stretch>
+          </p:blipFill>
+          <p:spPr>
+            <a:xfrm>
+              <a:off x="1871445" y="2743843"/>
+              <a:ext cx="827913" cy="827913"/>
+            </a:xfrm>
+            <a:prstGeom prst="rect">
+              <a:avLst/>
+            </a:prstGeom>
+          </p:spPr>
+        </p:pic>
+        <p:pic>
+          <p:nvPicPr>
+            <p:cNvPr id="77" name="Grafik 76">
+              <a:extLst>
+                <a:ext uri="{FF2B5EF4-FFF2-40B4-BE49-F238E27FC236}">
+                  <a16:creationId xmlns:a16="http://schemas.microsoft.com/office/drawing/2014/main" id="{FFFB93B2-C53C-4261-7D4C-71DCE8750523}"/>
+                </a:ext>
+              </a:extLst>
+            </p:cNvPr>
+            <p:cNvPicPr>
+              <a:picLocks noChangeAspect="1"/>
+            </p:cNvPicPr>
+            <p:nvPr/>
+          </p:nvPicPr>
+          <p:blipFill>
+            <a:blip r:embed="rId3">
+              <a:extLst>
+                <a:ext uri="{28A0092B-C50C-407E-A947-70E740481C1C}">
+                  <a14:useLocalDpi xmlns:a14="http://schemas.microsoft.com/office/drawing/2010/main" val="0"/>
+                </a:ext>
+              </a:extLst>
+            </a:blip>
+            <a:stretch>
+              <a:fillRect/>
+            </a:stretch>
+          </p:blipFill>
+          <p:spPr>
+            <a:xfrm>
+              <a:off x="1797150" y="3523366"/>
+              <a:ext cx="882650" cy="882650"/>
+            </a:xfrm>
+            <a:prstGeom prst="rect">
+              <a:avLst/>
+            </a:prstGeom>
+          </p:spPr>
+        </p:pic>
+        <p:pic>
+          <p:nvPicPr>
+            <p:cNvPr id="75" name="Grafik 74">
+              <a:extLst>
+                <a:ext uri="{FF2B5EF4-FFF2-40B4-BE49-F238E27FC236}">
+                  <a16:creationId xmlns:a16="http://schemas.microsoft.com/office/drawing/2014/main" id="{C9A9F567-C88B-8C1F-9B5C-9AF7AF1B814F}"/>
+                </a:ext>
+              </a:extLst>
+            </p:cNvPr>
+            <p:cNvPicPr>
+              <a:picLocks noChangeAspect="1"/>
+            </p:cNvPicPr>
+            <p:nvPr/>
+          </p:nvPicPr>
+          <p:blipFill>
+            <a:blip r:embed="rId4">
+              <a:extLst>
+                <a:ext uri="{28A0092B-C50C-407E-A947-70E740481C1C}">
+                  <a14:useLocalDpi xmlns:a14="http://schemas.microsoft.com/office/drawing/2010/main" val="0"/>
+                </a:ext>
+              </a:extLst>
+            </a:blip>
+            <a:stretch>
+              <a:fillRect/>
+            </a:stretch>
+          </p:blipFill>
+          <p:spPr>
+            <a:xfrm>
+              <a:off x="2725222" y="2972961"/>
+              <a:ext cx="1066800" cy="1066800"/>
+            </a:xfrm>
+            <a:prstGeom prst="rect">
+              <a:avLst/>
+            </a:prstGeom>
+          </p:spPr>
+        </p:pic>
         <p:pic>
           <p:nvPicPr>
             <p:cNvPr id="7" name="Grafik 6">
               <a:extLst>
                 <a:ext uri="{FF2B5EF4-FFF2-40B4-BE49-F238E27FC236}">
                   <a16:creationId xmlns:a16="http://schemas.microsoft.com/office/drawing/2014/main" id="{F5CA87CD-B0E2-EF48-F35C-73E9BD665F2D}"/>
+                </a:ext>
+              </a:extLst>
+            </p:cNvPr>
+            <p:cNvPicPr>
+              <a:picLocks noChangeAspect="1"/>
+            </p:cNvPicPr>
+            <p:nvPr/>
+          </p:nvPicPr>
+          <p:blipFill>
+            <a:blip r:embed="rId5">
+              <a:extLst>
+                <a:ext uri="{28A0092B-C50C-407E-A947-70E740481C1C}">
+                  <a14:useLocalDpi xmlns:a14="http://schemas.microsoft.com/office/drawing/2010/main" val="0"/>
+                </a:ext>
+              </a:extLst>
+            </a:blip>
+            <a:stretch>
+              <a:fillRect/>
+            </a:stretch>
+          </p:blipFill>
+          <p:spPr>
+            <a:xfrm>
+              <a:off x="4852035" y="2414818"/>
+              <a:ext cx="424688" cy="424688"/>
+            </a:xfrm>
+            <a:prstGeom prst="rect">
+              <a:avLst/>
+            </a:prstGeom>
+          </p:spPr>
+        </p:pic>
+      </p:grpSp>
+      <p:sp>
+        <p:nvSpPr>
+          <p:cNvPr id="12" name="Textfeld 11">
+            <a:extLst>
+              <a:ext uri="{FF2B5EF4-FFF2-40B4-BE49-F238E27FC236}">
+                <a16:creationId xmlns:a16="http://schemas.microsoft.com/office/drawing/2014/main" id="{C9BAA056-9695-2603-7174-263B8AE3C60F}"/>
+              </a:ext>
+            </a:extLst>
+          </p:cNvPr>
+          <p:cNvSpPr txBox="1"/>
+          <p:nvPr/>
+        </p:nvSpPr>
+        <p:spPr>
+          <a:xfrm>
+            <a:off x="711423" y="1169515"/>
+            <a:ext cx="10318761" cy="584775"/>
+          </a:xfrm>
+          <a:prstGeom prst="rect">
+            <a:avLst/>
+          </a:prstGeom>
+          <a:noFill/>
+        </p:spPr>
+        <p:txBody>
+          <a:bodyPr wrap="square">
+            <a:spAutoFit/>
+          </a:bodyPr>
+          <a:lstStyle/>
+          <a:p>
+            <a:pPr algn="ctr"/>
+            <a:r>
+              <a:rPr lang="de-DE" sz="1600" i="1">
+                <a:solidFill>
+                  <a:srgbClr val="00B050"/>
+                </a:solidFill>
+              </a:rPr>
+              <a:t>(prinzipiell ein sehr cooles „decoupling and isolation-concept“: </a:t>
+            </a:r>
+          </a:p>
+          <a:p>
+            <a:pPr algn="ctr"/>
+            <a:r>
+              <a:rPr lang="de-DE" sz="1600" i="1">
+                <a:solidFill>
+                  <a:srgbClr val="00B050"/>
+                </a:solidFill>
+              </a:rPr>
+              <a:t>session-starter fires -&gt; continuation in a fresh, isolated process-space!...)</a:t>
+            </a:r>
+          </a:p>
+        </p:txBody>
+      </p:sp>
+      <p:grpSp>
+        <p:nvGrpSpPr>
+          <p:cNvPr id="14" name="Gruppieren 13">
+            <a:extLst>
+              <a:ext uri="{FF2B5EF4-FFF2-40B4-BE49-F238E27FC236}">
+                <a16:creationId xmlns:a16="http://schemas.microsoft.com/office/drawing/2014/main" id="{6289E876-3E58-EEB0-EE5C-A21BCC6D1A3A}"/>
+              </a:ext>
+            </a:extLst>
+          </p:cNvPr>
+          <p:cNvGrpSpPr/>
+          <p:nvPr/>
+        </p:nvGrpSpPr>
+        <p:grpSpPr>
+          <a:xfrm>
+            <a:off x="3947598" y="3087397"/>
+            <a:ext cx="6217936" cy="1169551"/>
+            <a:chOff x="3804723" y="3039772"/>
+            <a:chExt cx="6217936" cy="1169551"/>
+          </a:xfrm>
+        </p:grpSpPr>
+        <p:grpSp>
+          <p:nvGrpSpPr>
+            <p:cNvPr id="15" name="Gruppieren 14">
+              <a:extLst>
+                <a:ext uri="{FF2B5EF4-FFF2-40B4-BE49-F238E27FC236}">
+                  <a16:creationId xmlns:a16="http://schemas.microsoft.com/office/drawing/2014/main" id="{00681D04-726D-1F17-2FF4-63D66A1BAB7E}"/>
+                </a:ext>
+              </a:extLst>
+            </p:cNvPr>
+            <p:cNvGrpSpPr/>
+            <p:nvPr/>
+          </p:nvGrpSpPr>
+          <p:grpSpPr>
+            <a:xfrm>
+              <a:off x="8010929" y="3397254"/>
+              <a:ext cx="1822489" cy="765048"/>
+              <a:chOff x="164209" y="1524953"/>
+              <a:chExt cx="1822489" cy="765048"/>
+            </a:xfrm>
+          </p:grpSpPr>
+          <p:sp>
+            <p:nvSpPr>
+              <p:cNvPr id="16" name="Rechteck 15">
+                <a:extLst>
+                  <a:ext uri="{FF2B5EF4-FFF2-40B4-BE49-F238E27FC236}">
+                    <a16:creationId xmlns:a16="http://schemas.microsoft.com/office/drawing/2014/main" id="{EE7FD0AE-ABF6-2A9B-559B-9DECBD0D518D}"/>
+                  </a:ext>
+                </a:extLst>
+              </p:cNvPr>
+              <p:cNvSpPr/>
+              <p:nvPr/>
+            </p:nvSpPr>
+            <p:spPr>
+              <a:xfrm>
+                <a:off x="164209" y="1524953"/>
+                <a:ext cx="1803699" cy="765048"/>
+              </a:xfrm>
+              <a:prstGeom prst="rect">
+                <a:avLst/>
+              </a:prstGeom>
+              <a:solidFill>
+                <a:schemeClr val="tx2">
+                  <a:lumMod val="10000"/>
+                  <a:lumOff val="90000"/>
+                </a:schemeClr>
+              </a:solidFill>
+              <a:ln>
+                <a:solidFill>
+                  <a:srgbClr val="C00000"/>
+                </a:solidFill>
+              </a:ln>
+            </p:spPr>
+            <p:style>
+              <a:lnRef idx="2">
+                <a:schemeClr val="accent1">
+                  <a:shade val="15000"/>
+                </a:schemeClr>
+              </a:lnRef>
+              <a:fillRef idx="1">
+                <a:schemeClr val="accent1"/>
+              </a:fillRef>
+              <a:effectRef idx="0">
+                <a:schemeClr val="accent1"/>
+              </a:effectRef>
+              <a:fontRef idx="minor">
+                <a:schemeClr val="lt1"/>
+              </a:fontRef>
+            </p:style>
+            <p:txBody>
+              <a:bodyPr rtlCol="0" anchor="ctr"/>
+              <a:lstStyle/>
+              <a:p>
+                <a:pPr algn="ctr"/>
+                <a:endParaRPr lang="de-DE"/>
+              </a:p>
+            </p:txBody>
+          </p:sp>
+          <p:sp>
+            <p:nvSpPr>
+              <p:cNvPr id="17" name="Textfeld 16">
+                <a:extLst>
+                  <a:ext uri="{FF2B5EF4-FFF2-40B4-BE49-F238E27FC236}">
+                    <a16:creationId xmlns:a16="http://schemas.microsoft.com/office/drawing/2014/main" id="{66E59F33-9673-BF9A-2A76-B7ED8A290DEA}"/>
+                  </a:ext>
+                </a:extLst>
+              </p:cNvPr>
+              <p:cNvSpPr txBox="1"/>
+              <p:nvPr/>
+            </p:nvSpPr>
+            <p:spPr>
+              <a:xfrm>
+                <a:off x="182999" y="1686886"/>
+                <a:ext cx="1803699" cy="369332"/>
+              </a:xfrm>
+              <a:prstGeom prst="rect">
+                <a:avLst/>
+              </a:prstGeom>
+              <a:noFill/>
+            </p:spPr>
+            <p:txBody>
+              <a:bodyPr wrap="none" rtlCol="0">
+                <a:spAutoFit/>
+              </a:bodyPr>
+              <a:lstStyle/>
+              <a:p>
+                <a:r>
+                  <a:rPr lang="de-DE" b="1">
+                    <a:solidFill>
+                      <a:schemeClr val="tx2">
+                        <a:lumMod val="75000"/>
+                        <a:lumOff val="25000"/>
+                      </a:schemeClr>
+                    </a:solidFill>
+                  </a:rPr>
+                  <a:t>job-assemblies</a:t>
+                </a:r>
+              </a:p>
+            </p:txBody>
+          </p:sp>
+        </p:grpSp>
+        <p:sp>
+          <p:nvSpPr>
+            <p:cNvPr id="52" name="Textfeld 51">
+              <a:extLst>
+                <a:ext uri="{FF2B5EF4-FFF2-40B4-BE49-F238E27FC236}">
+                  <a16:creationId xmlns:a16="http://schemas.microsoft.com/office/drawing/2014/main" id="{AB395DAA-F396-28B1-E9C1-A745386E2EEB}"/>
+                </a:ext>
+              </a:extLst>
+            </p:cNvPr>
+            <p:cNvSpPr txBox="1"/>
+            <p:nvPr/>
+          </p:nvSpPr>
+          <p:spPr>
+            <a:xfrm>
+              <a:off x="5129329" y="3039772"/>
+              <a:ext cx="2472944" cy="1169551"/>
+            </a:xfrm>
+            <a:prstGeom prst="rect">
+              <a:avLst/>
+            </a:prstGeom>
+            <a:solidFill>
+              <a:srgbClr val="FF9999"/>
+            </a:solidFill>
+          </p:spPr>
+          <p:txBody>
+            <a:bodyPr wrap="square">
+              <a:spAutoFit/>
+            </a:bodyPr>
+            <a:lstStyle/>
+            <a:p>
+              <a:r>
+                <a:rPr lang="de-DE" sz="1000" b="1"/>
+                <a:t>HaevgRZ.JobSystem.SessionStore.dll</a:t>
+              </a:r>
+            </a:p>
+            <a:p>
+              <a:r>
+                <a:rPr lang="de-DE" sz="1000" b="1"/>
+                <a:t>HaevgRZ.JobSystem.Core.dll</a:t>
+              </a:r>
+            </a:p>
+            <a:p>
+              <a:r>
+                <a:rPr lang="de-DE" sz="1000" b="1"/>
+                <a:t>HaevgRZ.JobSystem.Contracts.dll</a:t>
+              </a:r>
+            </a:p>
+            <a:p>
+              <a:r>
+                <a:rPr lang="de-DE" sz="1000" b="1"/>
+                <a:t>HaevgRZ.JobSystem.Lib.Core.dll</a:t>
+              </a:r>
+            </a:p>
+            <a:p>
+              <a:r>
+                <a:rPr lang="de-DE" sz="1000" b="1"/>
+                <a:t>HaevgRZ.JobSystem.Lib.Messaging.dll</a:t>
+              </a:r>
+            </a:p>
+            <a:p>
+              <a:r>
+                <a:rPr lang="de-DE" sz="1000" b="1"/>
+                <a:t>„GlobalConfig“</a:t>
+              </a:r>
+            </a:p>
+            <a:p>
+              <a:r>
+                <a:rPr lang="de-DE" sz="1000" b="1"/>
+                <a:t>…</a:t>
+              </a:r>
+            </a:p>
+          </p:txBody>
+        </p:sp>
+        <p:sp>
+          <p:nvSpPr>
+            <p:cNvPr id="55" name="Textfeld 54">
+              <a:extLst>
+                <a:ext uri="{FF2B5EF4-FFF2-40B4-BE49-F238E27FC236}">
+                  <a16:creationId xmlns:a16="http://schemas.microsoft.com/office/drawing/2014/main" id="{35A56320-1BAA-14D4-257E-BC2DD55217FB}"/>
+                </a:ext>
+              </a:extLst>
+            </p:cNvPr>
+            <p:cNvSpPr txBox="1"/>
+            <p:nvPr/>
+          </p:nvSpPr>
+          <p:spPr>
+            <a:xfrm>
+              <a:off x="7932206" y="3039772"/>
+              <a:ext cx="1905009" cy="338554"/>
+            </a:xfrm>
+            <a:prstGeom prst="rect">
+              <a:avLst/>
+            </a:prstGeom>
+            <a:noFill/>
+          </p:spPr>
+          <p:txBody>
+            <a:bodyPr wrap="none" rtlCol="0">
+              <a:spAutoFit/>
+            </a:bodyPr>
+            <a:lstStyle/>
+            <a:p>
+              <a:r>
+                <a:rPr lang="de-DE" sz="1600" b="1">
+                  <a:solidFill>
+                    <a:srgbClr val="FF0000"/>
+                  </a:solidFill>
+                </a:rPr>
+                <a:t>AssemblyResolve:</a:t>
+              </a:r>
+            </a:p>
+          </p:txBody>
+        </p:sp>
+        <p:sp>
+          <p:nvSpPr>
+            <p:cNvPr id="70" name="Pfeil: nach links 69">
+              <a:extLst>
+                <a:ext uri="{FF2B5EF4-FFF2-40B4-BE49-F238E27FC236}">
+                  <a16:creationId xmlns:a16="http://schemas.microsoft.com/office/drawing/2014/main" id="{1536D43B-1E69-F7B8-4F87-A0FD5F362E85}"/>
+                </a:ext>
+              </a:extLst>
+            </p:cNvPr>
+            <p:cNvSpPr/>
+            <p:nvPr/>
+          </p:nvSpPr>
+          <p:spPr>
+            <a:xfrm>
+              <a:off x="3804723" y="3284218"/>
+              <a:ext cx="1311905" cy="707281"/>
+            </a:xfrm>
+            <a:prstGeom prst="leftArrow">
+              <a:avLst/>
+            </a:prstGeom>
+            <a:solidFill>
+              <a:srgbClr val="C00000"/>
+            </a:solidFill>
+            <a:ln>
+              <a:solidFill>
+                <a:srgbClr val="7030A0"/>
+              </a:solidFill>
+            </a:ln>
+          </p:spPr>
+          <p:style>
+            <a:lnRef idx="2">
+              <a:schemeClr val="accent1">
+                <a:shade val="15000"/>
+              </a:schemeClr>
+            </a:lnRef>
+            <a:fillRef idx="1">
+              <a:schemeClr val="accent1"/>
+            </a:fillRef>
+            <a:effectRef idx="0">
+              <a:schemeClr val="accent1"/>
+            </a:effectRef>
+            <a:fontRef idx="minor">
+              <a:schemeClr val="lt1"/>
+            </a:fontRef>
+          </p:style>
+          <p:txBody>
+            <a:bodyPr rtlCol="0" anchor="ctr"/>
+            <a:lstStyle/>
+            <a:p>
+              <a:pPr algn="ctr"/>
+              <a:endParaRPr lang="de-DE"/>
+            </a:p>
+          </p:txBody>
+        </p:sp>
+        <p:pic>
+          <p:nvPicPr>
+            <p:cNvPr id="3" name="Grafik 2">
+              <a:extLst>
+                <a:ext uri="{FF2B5EF4-FFF2-40B4-BE49-F238E27FC236}">
+                  <a16:creationId xmlns:a16="http://schemas.microsoft.com/office/drawing/2014/main" id="{6A00C80A-8D50-378A-0B7B-84DC8F866922}"/>
                 </a:ext>
               </a:extLst>
             </p:cNvPr>
@@ -13922,8 +13911,44 @@
           </p:blipFill>
           <p:spPr>
             <a:xfrm>
-              <a:off x="4904161" y="2732914"/>
-              <a:ext cx="424688" cy="424688"/>
+              <a:off x="9565459" y="3157799"/>
+              <a:ext cx="457200" cy="457200"/>
+            </a:xfrm>
+            <a:prstGeom prst="rect">
+              <a:avLst/>
+            </a:prstGeom>
+          </p:spPr>
+        </p:pic>
+        <p:pic>
+          <p:nvPicPr>
+            <p:cNvPr id="2" name="Grafik 1">
+              <a:extLst>
+                <a:ext uri="{FF2B5EF4-FFF2-40B4-BE49-F238E27FC236}">
+                  <a16:creationId xmlns:a16="http://schemas.microsoft.com/office/drawing/2014/main" id="{D73ECB46-C9A9-DAF5-D3DE-40D24C072FC7}"/>
+                </a:ext>
+              </a:extLst>
+            </p:cNvPr>
+            <p:cNvPicPr>
+              <a:picLocks noChangeAspect="1"/>
+            </p:cNvPicPr>
+            <p:nvPr/>
+          </p:nvPicPr>
+          <p:blipFill>
+            <a:blip r:embed="rId6">
+              <a:extLst>
+                <a:ext uri="{28A0092B-C50C-407E-A947-70E740481C1C}">
+                  <a14:useLocalDpi xmlns:a14="http://schemas.microsoft.com/office/drawing/2010/main" val="0"/>
+                </a:ext>
+              </a:extLst>
+            </a:blip>
+            <a:stretch>
+              <a:fillRect/>
+            </a:stretch>
+          </p:blipFill>
+          <p:spPr>
+            <a:xfrm>
+              <a:off x="4221593" y="3201574"/>
+              <a:ext cx="842786" cy="842786"/>
             </a:xfrm>
             <a:prstGeom prst="rect">
               <a:avLst/>
@@ -13975,7 +14000,7 @@
                                           </p:stCondLst>
                                         </p:cTn>
                                         <p:tgtEl>
-                                          <p:spTgt spid="8"/>
+                                          <p:spTgt spid="13"/>
                                         </p:tgtEl>
                                         <p:attrNameLst>
                                           <p:attrName>style.visibility</p:attrName>
@@ -14002,7 +14027,7 @@
                                           </p:stCondLst>
                                         </p:cTn>
                                         <p:tgtEl>
-                                          <p:spTgt spid="5"/>
+                                          <p:spTgt spid="12"/>
                                         </p:tgtEl>
                                         <p:attrNameLst>
                                           <p:attrName>style.visibility</p:attrName>
@@ -14034,7 +14059,7 @@
                             </p:stCondLst>
                             <p:childTnLst>
                               <p:par>
-                                <p:cTn id="11" presetID="1" presetClass="entr" presetSubtype="0" fill="hold" nodeType="clickEffect">
+                                <p:cTn id="11" presetID="1" presetClass="entr" presetSubtype="0" fill="hold" grpId="0" nodeType="clickEffect">
                                   <p:stCondLst>
                                     <p:cond delay="0"/>
                                   </p:stCondLst>
@@ -14047,11 +14072,7 @@
                                           </p:stCondLst>
                                         </p:cTn>
                                         <p:tgtEl>
-                                          <p:spTgt spid="65">
-                                            <p:txEl>
-                                              <p:pRg st="0" end="0"/>
-                                            </p:txEl>
-                                          </p:spTgt>
+                                          <p:spTgt spid="5"/>
                                         </p:tgtEl>
                                         <p:attrNameLst>
                                           <p:attrName>style.visibility</p:attrName>
@@ -14078,11 +14099,7 @@
                                           </p:stCondLst>
                                         </p:cTn>
                                         <p:tgtEl>
-                                          <p:spTgt spid="65">
-                                            <p:txEl>
-                                              <p:pRg st="1" end="1"/>
-                                            </p:txEl>
-                                          </p:spTgt>
+                                          <p:spTgt spid="14"/>
                                         </p:tgtEl>
                                         <p:attrNameLst>
                                           <p:attrName>style.visibility</p:attrName>
@@ -14129,7 +14146,7 @@
                                         <p:tgtEl>
                                           <p:spTgt spid="65">
                                             <p:txEl>
-                                              <p:pRg st="2" end="2"/>
+                                              <p:pRg st="0" end="0"/>
                                             </p:txEl>
                                           </p:spTgt>
                                         </p:tgtEl>
@@ -14160,6 +14177,86 @@
                                         <p:tgtEl>
                                           <p:spTgt spid="65">
                                             <p:txEl>
+                                              <p:pRg st="1" end="1"/>
+                                            </p:txEl>
+                                          </p:spTgt>
+                                        </p:tgtEl>
+                                        <p:attrNameLst>
+                                          <p:attrName>style.visibility</p:attrName>
+                                        </p:attrNameLst>
+                                      </p:cBhvr>
+                                      <p:to>
+                                        <p:strVal val="visible"/>
+                                      </p:to>
+                                    </p:set>
+                                  </p:childTnLst>
+                                </p:cTn>
+                              </p:par>
+                            </p:childTnLst>
+                          </p:cTn>
+                        </p:par>
+                      </p:childTnLst>
+                    </p:cTn>
+                  </p:par>
+                  <p:par>
+                    <p:cTn id="21" fill="hold">
+                      <p:stCondLst>
+                        <p:cond delay="indefinite"/>
+                      </p:stCondLst>
+                      <p:childTnLst>
+                        <p:par>
+                          <p:cTn id="22" fill="hold">
+                            <p:stCondLst>
+                              <p:cond delay="0"/>
+                            </p:stCondLst>
+                            <p:childTnLst>
+                              <p:par>
+                                <p:cTn id="23" presetID="1" presetClass="entr" presetSubtype="0" fill="hold" nodeType="clickEffect">
+                                  <p:stCondLst>
+                                    <p:cond delay="0"/>
+                                  </p:stCondLst>
+                                  <p:childTnLst>
+                                    <p:set>
+                                      <p:cBhvr>
+                                        <p:cTn id="24" dur="1" fill="hold">
+                                          <p:stCondLst>
+                                            <p:cond delay="0"/>
+                                          </p:stCondLst>
+                                        </p:cTn>
+                                        <p:tgtEl>
+                                          <p:spTgt spid="65">
+                                            <p:txEl>
+                                              <p:pRg st="2" end="2"/>
+                                            </p:txEl>
+                                          </p:spTgt>
+                                        </p:tgtEl>
+                                        <p:attrNameLst>
+                                          <p:attrName>style.visibility</p:attrName>
+                                        </p:attrNameLst>
+                                      </p:cBhvr>
+                                      <p:to>
+                                        <p:strVal val="visible"/>
+                                      </p:to>
+                                    </p:set>
+                                  </p:childTnLst>
+                                </p:cTn>
+                              </p:par>
+                              <p:par>
+                                <p:cTn id="25" presetID="1" presetClass="entr" presetSubtype="0" fill="hold" nodeType="withEffect">
+                                  <p:stCondLst>
+                                    <p:cond delay="0"/>
+                                  </p:stCondLst>
+                                  <p:childTnLst>
+                                    <p:set>
+                                      <p:cBhvr>
+                                        <p:cTn id="26" dur="1" fill="hold">
+                                          <p:stCondLst>
+                                            <p:cond delay="0"/>
+                                          </p:stCondLst>
+                                        </p:cTn>
+                                        <p:tgtEl>
+                                          <p:spTgt spid="65">
+                                            <p:txEl>
                                               <p:pRg st="3" end="3"/>
                                             </p:txEl>
                                           </p:spTgt>
@@ -14176,14 +14273,14 @@
                                 </p:cTn>
                               </p:par>
                               <p:par>
-                                <p:cTn id="21" presetID="1" presetClass="entr" presetSubtype="0" fill="hold" nodeType="withEffect">
+                                <p:cTn id="27" presetID="1" presetClass="entr" presetSubtype="0" fill="hold" nodeType="withEffect">
                                   <p:stCondLst>
                                     <p:cond delay="0"/>
                                   </p:stCondLst>
                                   <p:childTnLst>
                                     <p:set>
                                       <p:cBhvr>
-                                        <p:cTn id="22" dur="1" fill="hold">
+                                        <p:cTn id="28" dur="1" fill="hold">
                                           <p:stCondLst>
                                             <p:cond delay="0"/>
                                           </p:stCondLst>
@@ -14213,26 +14310,26 @@
                     </p:cTn>
                   </p:par>
                   <p:par>
-                    <p:cTn id="23" fill="hold">
+                    <p:cTn id="29" fill="hold">
                       <p:stCondLst>
                         <p:cond delay="indefinite"/>
                       </p:stCondLst>
                       <p:childTnLst>
                         <p:par>
-                          <p:cTn id="24" fill="hold">
+                          <p:cTn id="30" fill="hold">
                             <p:stCondLst>
                               <p:cond delay="0"/>
                             </p:stCondLst>
                             <p:childTnLst>
                               <p:par>
-                                <p:cTn id="25" presetID="1" presetClass="entr" presetSubtype="0" fill="hold" nodeType="clickEffect">
+                                <p:cTn id="31" presetID="1" presetClass="entr" presetSubtype="0" fill="hold" nodeType="clickEffect">
                                   <p:stCondLst>
                                     <p:cond delay="0"/>
                                   </p:stCondLst>
                                   <p:childTnLst>
                                     <p:set>
                                       <p:cBhvr>
-                                        <p:cTn id="26" dur="1" fill="hold">
+                                        <p:cTn id="32" dur="1" fill="hold">
                                           <p:stCondLst>
                                             <p:cond delay="0"/>
                                           </p:stCondLst>
@@ -14284,6 +14381,7 @@
     </p:tnLst>
     <p:bldLst>
       <p:bldP spid="5" grpId="0"/>
+      <p:bldP spid="12" grpId="0"/>
     </p:bldLst>
   </p:timing>
 </p:sld>

</xml_diff>

<commit_message>
wip: sync [2026-07-06 18:58]
</commit_message>
<xml_diff>
--- a/josyn-intro.pptx
+++ b/josyn-intro.pptx
@@ -5,7 +5,7 @@
     <p:sldMasterId id="2147483648" r:id="rId1"/>
   </p:sldMasterIdLst>
   <p:notesMasterIdLst>
-    <p:notesMasterId r:id="rId13"/>
+    <p:notesMasterId r:id="rId14"/>
   </p:notesMasterIdLst>
   <p:sldIdLst>
     <p:sldId id="273" r:id="rId2"/>
@@ -16,9 +16,10 @@
     <p:sldId id="275" r:id="rId7"/>
     <p:sldId id="276" r:id="rId8"/>
     <p:sldId id="278" r:id="rId9"/>
-    <p:sldId id="270" r:id="rId10"/>
-    <p:sldId id="277" r:id="rId11"/>
-    <p:sldId id="269" r:id="rId12"/>
+    <p:sldId id="279" r:id="rId10"/>
+    <p:sldId id="270" r:id="rId11"/>
+    <p:sldId id="277" r:id="rId12"/>
+    <p:sldId id="269" r:id="rId13"/>
   </p:sldIdLst>
   <p:sldSz cx="12192000" cy="6858000"/>
   <p:notesSz cx="6858000" cy="9144000"/>
@@ -207,7 +208,7 @@
           <a:p>
             <a:fld id="{8E5D503C-CB4E-47D2-854F-034286D1EDEF}" type="datetimeFigureOut">
               <a:rPr lang="de-DE" smtClean="0"/>
-              <a:t>24.06.2026</a:t>
+              <a:t>06.07.2026</a:t>
             </a:fld>
             <a:endParaRPr lang="de-DE"/>
           </a:p>
@@ -647,7 +648,7 @@
           <a:p>
             <a:fld id="{274F3282-AC7F-4F04-970A-9596745FD581}" type="slidenum">
               <a:rPr lang="de-DE" smtClean="0"/>
-              <a:t>10</a:t>
+              <a:t>11</a:t>
             </a:fld>
             <a:endParaRPr lang="de-DE"/>
           </a:p>
@@ -731,7 +732,7 @@
           <a:p>
             <a:fld id="{274F3282-AC7F-4F04-970A-9596745FD581}" type="slidenum">
               <a:rPr lang="de-DE" smtClean="0"/>
-              <a:t>11</a:t>
+              <a:t>12</a:t>
             </a:fld>
             <a:endParaRPr lang="de-DE"/>
           </a:p>
@@ -897,7 +898,7 @@
           <a:p>
             <a:fld id="{6670F5CD-5655-45E5-8E7F-D706B3048717}" type="datetimeFigureOut">
               <a:rPr lang="de-DE" smtClean="0"/>
-              <a:t>24.06.2026</a:t>
+              <a:t>06.07.2026</a:t>
             </a:fld>
             <a:endParaRPr lang="de-DE"/>
           </a:p>
@@ -1095,7 +1096,7 @@
           <a:p>
             <a:fld id="{6670F5CD-5655-45E5-8E7F-D706B3048717}" type="datetimeFigureOut">
               <a:rPr lang="de-DE" smtClean="0"/>
-              <a:t>24.06.2026</a:t>
+              <a:t>06.07.2026</a:t>
             </a:fld>
             <a:endParaRPr lang="de-DE"/>
           </a:p>
@@ -1303,7 +1304,7 @@
           <a:p>
             <a:fld id="{6670F5CD-5655-45E5-8E7F-D706B3048717}" type="datetimeFigureOut">
               <a:rPr lang="de-DE" smtClean="0"/>
-              <a:t>24.06.2026</a:t>
+              <a:t>06.07.2026</a:t>
             </a:fld>
             <a:endParaRPr lang="de-DE"/>
           </a:p>
@@ -1501,7 +1502,7 @@
           <a:p>
             <a:fld id="{6670F5CD-5655-45E5-8E7F-D706B3048717}" type="datetimeFigureOut">
               <a:rPr lang="de-DE" smtClean="0"/>
-              <a:t>24.06.2026</a:t>
+              <a:t>06.07.2026</a:t>
             </a:fld>
             <a:endParaRPr lang="de-DE"/>
           </a:p>
@@ -1776,7 +1777,7 @@
           <a:p>
             <a:fld id="{6670F5CD-5655-45E5-8E7F-D706B3048717}" type="datetimeFigureOut">
               <a:rPr lang="de-DE" smtClean="0"/>
-              <a:t>24.06.2026</a:t>
+              <a:t>06.07.2026</a:t>
             </a:fld>
             <a:endParaRPr lang="de-DE"/>
           </a:p>
@@ -2041,7 +2042,7 @@
           <a:p>
             <a:fld id="{6670F5CD-5655-45E5-8E7F-D706B3048717}" type="datetimeFigureOut">
               <a:rPr lang="de-DE" smtClean="0"/>
-              <a:t>24.06.2026</a:t>
+              <a:t>06.07.2026</a:t>
             </a:fld>
             <a:endParaRPr lang="de-DE"/>
           </a:p>
@@ -2453,7 +2454,7 @@
           <a:p>
             <a:fld id="{6670F5CD-5655-45E5-8E7F-D706B3048717}" type="datetimeFigureOut">
               <a:rPr lang="de-DE" smtClean="0"/>
-              <a:t>24.06.2026</a:t>
+              <a:t>06.07.2026</a:t>
             </a:fld>
             <a:endParaRPr lang="de-DE"/>
           </a:p>
@@ -2594,7 +2595,7 @@
           <a:p>
             <a:fld id="{6670F5CD-5655-45E5-8E7F-D706B3048717}" type="datetimeFigureOut">
               <a:rPr lang="de-DE" smtClean="0"/>
-              <a:t>24.06.2026</a:t>
+              <a:t>06.07.2026</a:t>
             </a:fld>
             <a:endParaRPr lang="de-DE"/>
           </a:p>
@@ -2707,7 +2708,7 @@
           <a:p>
             <a:fld id="{6670F5CD-5655-45E5-8E7F-D706B3048717}" type="datetimeFigureOut">
               <a:rPr lang="de-DE" smtClean="0"/>
-              <a:t>24.06.2026</a:t>
+              <a:t>06.07.2026</a:t>
             </a:fld>
             <a:endParaRPr lang="de-DE"/>
           </a:p>
@@ -3018,7 +3019,7 @@
           <a:p>
             <a:fld id="{6670F5CD-5655-45E5-8E7F-D706B3048717}" type="datetimeFigureOut">
               <a:rPr lang="de-DE" smtClean="0"/>
-              <a:t>24.06.2026</a:t>
+              <a:t>06.07.2026</a:t>
             </a:fld>
             <a:endParaRPr lang="de-DE"/>
           </a:p>
@@ -3306,7 +3307,7 @@
           <a:p>
             <a:fld id="{6670F5CD-5655-45E5-8E7F-D706B3048717}" type="datetimeFigureOut">
               <a:rPr lang="de-DE" smtClean="0"/>
-              <a:t>24.06.2026</a:t>
+              <a:t>06.07.2026</a:t>
             </a:fld>
             <a:endParaRPr lang="de-DE"/>
           </a:p>
@@ -3547,7 +3548,7 @@
           <a:p>
             <a:fld id="{6670F5CD-5655-45E5-8E7F-D706B3048717}" type="datetimeFigureOut">
               <a:rPr lang="de-DE" smtClean="0"/>
-              <a:t>24.06.2026</a:t>
+              <a:t>06.07.2026</a:t>
             </a:fld>
             <a:endParaRPr lang="de-DE"/>
           </a:p>
@@ -4267,6 +4268,1456 @@
 </file>
 
 <file path=ppt/slides/slide10.xml><?xml version="1.0" encoding="utf-8"?>
+<p:sld xmlns:a="http://schemas.openxmlformats.org/drawingml/2006/main" xmlns:r="http://schemas.openxmlformats.org/officeDocument/2006/relationships" xmlns:p="http://schemas.openxmlformats.org/presentationml/2006/main">
+  <p:cSld>
+    <p:spTree>
+      <p:nvGrpSpPr>
+        <p:cNvPr id="1" name="">
+          <a:extLst>
+            <a:ext uri="{FF2B5EF4-FFF2-40B4-BE49-F238E27FC236}">
+              <a16:creationId xmlns:a16="http://schemas.microsoft.com/office/drawing/2014/main" id="{81E50BBE-18B9-1DDD-5255-D1EE6B0E5A21}"/>
+            </a:ext>
+          </a:extLst>
+        </p:cNvPr>
+        <p:cNvGrpSpPr/>
+        <p:nvPr/>
+      </p:nvGrpSpPr>
+      <p:grpSpPr>
+        <a:xfrm>
+          <a:off x="0" y="0"/>
+          <a:ext cx="0" cy="0"/>
+          <a:chOff x="0" y="0"/>
+          <a:chExt cx="0" cy="0"/>
+        </a:xfrm>
+      </p:grpSpPr>
+      <p:grpSp>
+        <p:nvGrpSpPr>
+          <p:cNvPr id="3" name="Gruppieren 2">
+            <a:extLst>
+              <a:ext uri="{FF2B5EF4-FFF2-40B4-BE49-F238E27FC236}">
+                <a16:creationId xmlns:a16="http://schemas.microsoft.com/office/drawing/2014/main" id="{B95EA94C-38F5-591E-D9FD-26E4B0482979}"/>
+              </a:ext>
+            </a:extLst>
+          </p:cNvPr>
+          <p:cNvGrpSpPr/>
+          <p:nvPr/>
+        </p:nvGrpSpPr>
+        <p:grpSpPr>
+          <a:xfrm>
+            <a:off x="2816352" y="864241"/>
+            <a:ext cx="6254496" cy="2488559"/>
+            <a:chOff x="2911602" y="1931041"/>
+            <a:chExt cx="6254496" cy="2488559"/>
+          </a:xfrm>
+        </p:grpSpPr>
+        <p:grpSp>
+          <p:nvGrpSpPr>
+            <p:cNvPr id="7" name="Gruppieren 6">
+              <a:extLst>
+                <a:ext uri="{FF2B5EF4-FFF2-40B4-BE49-F238E27FC236}">
+                  <a16:creationId xmlns:a16="http://schemas.microsoft.com/office/drawing/2014/main" id="{C4F543A1-F974-944C-7768-7BEE20598B94}"/>
+                </a:ext>
+              </a:extLst>
+            </p:cNvPr>
+            <p:cNvGrpSpPr/>
+            <p:nvPr/>
+          </p:nvGrpSpPr>
+          <p:grpSpPr>
+            <a:xfrm>
+              <a:off x="3105916" y="2584254"/>
+              <a:ext cx="1652773" cy="1632146"/>
+              <a:chOff x="2013970" y="586290"/>
+              <a:chExt cx="1652773" cy="3976566"/>
+            </a:xfrm>
+          </p:grpSpPr>
+          <p:sp>
+            <p:nvSpPr>
+              <p:cNvPr id="4" name="Rechteck 3">
+                <a:extLst>
+                  <a:ext uri="{FF2B5EF4-FFF2-40B4-BE49-F238E27FC236}">
+                    <a16:creationId xmlns:a16="http://schemas.microsoft.com/office/drawing/2014/main" id="{ACAEF261-0AFD-A473-0D38-5BB18A1354BE}"/>
+                  </a:ext>
+                </a:extLst>
+              </p:cNvPr>
+              <p:cNvSpPr/>
+              <p:nvPr/>
+            </p:nvSpPr>
+            <p:spPr>
+              <a:xfrm>
+                <a:off x="2031236" y="586290"/>
+                <a:ext cx="1635507" cy="3976566"/>
+              </a:xfrm>
+              <a:prstGeom prst="rect">
+                <a:avLst/>
+              </a:prstGeom>
+              <a:solidFill>
+                <a:schemeClr val="bg1">
+                  <a:lumMod val="95000"/>
+                </a:schemeClr>
+              </a:solidFill>
+              <a:ln>
+                <a:solidFill>
+                  <a:srgbClr val="7030A0"/>
+                </a:solidFill>
+                <a:prstDash val="sysDash"/>
+              </a:ln>
+            </p:spPr>
+            <p:style>
+              <a:lnRef idx="2">
+                <a:schemeClr val="accent1">
+                  <a:shade val="15000"/>
+                </a:schemeClr>
+              </a:lnRef>
+              <a:fillRef idx="1">
+                <a:schemeClr val="accent1"/>
+              </a:fillRef>
+              <a:effectRef idx="0">
+                <a:schemeClr val="accent1"/>
+              </a:effectRef>
+              <a:fontRef idx="minor">
+                <a:schemeClr val="lt1"/>
+              </a:fontRef>
+            </p:style>
+            <p:txBody>
+              <a:bodyPr rtlCol="0" anchor="ctr"/>
+              <a:lstStyle/>
+              <a:p>
+                <a:pPr algn="ctr"/>
+                <a:endParaRPr lang="de-DE"/>
+              </a:p>
+            </p:txBody>
+          </p:sp>
+          <p:sp>
+            <p:nvSpPr>
+              <p:cNvPr id="6" name="Textfeld 5">
+                <a:extLst>
+                  <a:ext uri="{FF2B5EF4-FFF2-40B4-BE49-F238E27FC236}">
+                    <a16:creationId xmlns:a16="http://schemas.microsoft.com/office/drawing/2014/main" id="{FE23814A-842D-A0C4-226C-84B90FC0854E}"/>
+                  </a:ext>
+                </a:extLst>
+              </p:cNvPr>
+              <p:cNvSpPr txBox="1"/>
+              <p:nvPr/>
+            </p:nvSpPr>
+            <p:spPr>
+              <a:xfrm>
+                <a:off x="2013970" y="594762"/>
+                <a:ext cx="1087029" cy="369332"/>
+              </a:xfrm>
+              <a:prstGeom prst="rect">
+                <a:avLst/>
+              </a:prstGeom>
+              <a:noFill/>
+            </p:spPr>
+            <p:txBody>
+              <a:bodyPr wrap="none" rtlCol="0">
+                <a:spAutoFit/>
+              </a:bodyPr>
+              <a:lstStyle/>
+              <a:p>
+                <a:r>
+                  <a:rPr lang="de-DE" b="1">
+                    <a:solidFill>
+                      <a:srgbClr val="7030A0"/>
+                    </a:solidFill>
+                  </a:rPr>
+                  <a:t>backend</a:t>
+                </a:r>
+              </a:p>
+            </p:txBody>
+          </p:sp>
+        </p:grpSp>
+        <p:grpSp>
+          <p:nvGrpSpPr>
+            <p:cNvPr id="20" name="Gruppieren 19">
+              <a:extLst>
+                <a:ext uri="{FF2B5EF4-FFF2-40B4-BE49-F238E27FC236}">
+                  <a16:creationId xmlns:a16="http://schemas.microsoft.com/office/drawing/2014/main" id="{766AAFB1-9BCF-A234-F93F-8BB0D3D6F669}"/>
+                </a:ext>
+              </a:extLst>
+            </p:cNvPr>
+            <p:cNvGrpSpPr/>
+            <p:nvPr/>
+          </p:nvGrpSpPr>
+          <p:grpSpPr>
+            <a:xfrm>
+              <a:off x="7402414" y="2590603"/>
+              <a:ext cx="1609958" cy="1625798"/>
+              <a:chOff x="6606124" y="632007"/>
+              <a:chExt cx="1609958" cy="3976568"/>
+            </a:xfrm>
+            <a:solidFill>
+              <a:schemeClr val="bg1">
+                <a:lumMod val="95000"/>
+              </a:schemeClr>
+            </a:solidFill>
+          </p:grpSpPr>
+          <p:sp>
+            <p:nvSpPr>
+              <p:cNvPr id="12" name="Rechteck 11">
+                <a:extLst>
+                  <a:ext uri="{FF2B5EF4-FFF2-40B4-BE49-F238E27FC236}">
+                    <a16:creationId xmlns:a16="http://schemas.microsoft.com/office/drawing/2014/main" id="{DFC07FED-600D-4DE7-5721-04134762009E}"/>
+                  </a:ext>
+                </a:extLst>
+              </p:cNvPr>
+              <p:cNvSpPr/>
+              <p:nvPr/>
+            </p:nvSpPr>
+            <p:spPr>
+              <a:xfrm>
+                <a:off x="6606124" y="632007"/>
+                <a:ext cx="1609958" cy="3976568"/>
+              </a:xfrm>
+              <a:prstGeom prst="rect">
+                <a:avLst/>
+              </a:prstGeom>
+              <a:grpFill/>
+              <a:ln>
+                <a:solidFill>
+                  <a:schemeClr val="tx2">
+                    <a:lumMod val="75000"/>
+                    <a:lumOff val="25000"/>
+                  </a:schemeClr>
+                </a:solidFill>
+              </a:ln>
+            </p:spPr>
+            <p:style>
+              <a:lnRef idx="2">
+                <a:schemeClr val="accent1">
+                  <a:shade val="15000"/>
+                </a:schemeClr>
+              </a:lnRef>
+              <a:fillRef idx="1">
+                <a:schemeClr val="accent1"/>
+              </a:fillRef>
+              <a:effectRef idx="0">
+                <a:schemeClr val="accent1"/>
+              </a:effectRef>
+              <a:fontRef idx="minor">
+                <a:schemeClr val="lt1"/>
+              </a:fontRef>
+            </p:style>
+            <p:txBody>
+              <a:bodyPr rtlCol="0" anchor="ctr"/>
+              <a:lstStyle/>
+              <a:p>
+                <a:pPr algn="ctr"/>
+                <a:endParaRPr lang="de-DE"/>
+              </a:p>
+            </p:txBody>
+          </p:sp>
+          <p:sp>
+            <p:nvSpPr>
+              <p:cNvPr id="13" name="Textfeld 12">
+                <a:extLst>
+                  <a:ext uri="{FF2B5EF4-FFF2-40B4-BE49-F238E27FC236}">
+                    <a16:creationId xmlns:a16="http://schemas.microsoft.com/office/drawing/2014/main" id="{050ED622-67A4-03A0-B579-8272ADDDDA00}"/>
+                  </a:ext>
+                </a:extLst>
+              </p:cNvPr>
+              <p:cNvSpPr txBox="1"/>
+              <p:nvPr/>
+            </p:nvSpPr>
+            <p:spPr>
+              <a:xfrm>
+                <a:off x="6607221" y="632142"/>
+                <a:ext cx="514885" cy="903356"/>
+              </a:xfrm>
+              <a:prstGeom prst="rect">
+                <a:avLst/>
+              </a:prstGeom>
+              <a:noFill/>
+            </p:spPr>
+            <p:txBody>
+              <a:bodyPr wrap="none" rtlCol="0">
+                <a:spAutoFit/>
+              </a:bodyPr>
+              <a:lstStyle/>
+              <a:p>
+                <a:r>
+                  <a:rPr lang="de-DE" b="1">
+                    <a:solidFill>
+                      <a:schemeClr val="tx2">
+                        <a:lumMod val="75000"/>
+                        <a:lumOff val="25000"/>
+                      </a:schemeClr>
+                    </a:solidFill>
+                  </a:rPr>
+                  <a:t>job</a:t>
+                </a:r>
+              </a:p>
+            </p:txBody>
+          </p:sp>
+        </p:grpSp>
+        <p:grpSp>
+          <p:nvGrpSpPr>
+            <p:cNvPr id="25" name="Gruppieren 24">
+              <a:extLst>
+                <a:ext uri="{FF2B5EF4-FFF2-40B4-BE49-F238E27FC236}">
+                  <a16:creationId xmlns:a16="http://schemas.microsoft.com/office/drawing/2014/main" id="{3656935A-914A-3594-2569-CFD4E2974623}"/>
+                </a:ext>
+              </a:extLst>
+            </p:cNvPr>
+            <p:cNvGrpSpPr/>
+            <p:nvPr/>
+          </p:nvGrpSpPr>
+          <p:grpSpPr>
+            <a:xfrm>
+              <a:off x="5389368" y="3182254"/>
+              <a:ext cx="2004894" cy="615297"/>
+              <a:chOff x="4408814" y="5346379"/>
+              <a:chExt cx="824980" cy="615297"/>
+            </a:xfrm>
+          </p:grpSpPr>
+          <p:sp>
+            <p:nvSpPr>
+              <p:cNvPr id="22" name="Pfeil: nach links und rechts 21">
+                <a:extLst>
+                  <a:ext uri="{FF2B5EF4-FFF2-40B4-BE49-F238E27FC236}">
+                    <a16:creationId xmlns:a16="http://schemas.microsoft.com/office/drawing/2014/main" id="{D250BC81-0220-4A80-8B23-D6AF68702081}"/>
+                  </a:ext>
+                </a:extLst>
+              </p:cNvPr>
+              <p:cNvSpPr/>
+              <p:nvPr/>
+            </p:nvSpPr>
+            <p:spPr>
+              <a:xfrm>
+                <a:off x="4408814" y="5346379"/>
+                <a:ext cx="786344" cy="615297"/>
+              </a:xfrm>
+              <a:prstGeom prst="leftRightArrow">
+                <a:avLst/>
+              </a:prstGeom>
+              <a:solidFill>
+                <a:schemeClr val="accent2">
+                  <a:lumMod val="20000"/>
+                  <a:lumOff val="80000"/>
+                </a:schemeClr>
+              </a:solidFill>
+              <a:ln>
+                <a:prstDash val="sysDot"/>
+              </a:ln>
+            </p:spPr>
+            <p:style>
+              <a:lnRef idx="2">
+                <a:schemeClr val="accent1">
+                  <a:shade val="15000"/>
+                </a:schemeClr>
+              </a:lnRef>
+              <a:fillRef idx="1">
+                <a:schemeClr val="accent1"/>
+              </a:fillRef>
+              <a:effectRef idx="0">
+                <a:schemeClr val="accent1"/>
+              </a:effectRef>
+              <a:fontRef idx="minor">
+                <a:schemeClr val="lt1"/>
+              </a:fontRef>
+            </p:style>
+            <p:txBody>
+              <a:bodyPr rtlCol="0" anchor="ctr"/>
+              <a:lstStyle/>
+              <a:p>
+                <a:pPr algn="ctr"/>
+                <a:endParaRPr lang="de-DE"/>
+              </a:p>
+            </p:txBody>
+          </p:sp>
+          <p:sp>
+            <p:nvSpPr>
+              <p:cNvPr id="24" name="Textfeld 23">
+                <a:extLst>
+                  <a:ext uri="{FF2B5EF4-FFF2-40B4-BE49-F238E27FC236}">
+                    <a16:creationId xmlns:a16="http://schemas.microsoft.com/office/drawing/2014/main" id="{B31D5EBB-A89F-35F1-BDFF-4FE0D37A0761}"/>
+                  </a:ext>
+                </a:extLst>
+              </p:cNvPr>
+              <p:cNvSpPr txBox="1"/>
+              <p:nvPr/>
+            </p:nvSpPr>
+            <p:spPr>
+              <a:xfrm>
+                <a:off x="4479908" y="5471494"/>
+                <a:ext cx="753886" cy="369332"/>
+              </a:xfrm>
+              <a:prstGeom prst="rect">
+                <a:avLst/>
+              </a:prstGeom>
+              <a:noFill/>
+            </p:spPr>
+            <p:txBody>
+              <a:bodyPr wrap="square" rtlCol="0">
+                <a:spAutoFit/>
+              </a:bodyPr>
+              <a:lstStyle/>
+              <a:p>
+                <a:r>
+                  <a:rPr lang="de-DE" sz="1600" i="1"/>
+                  <a:t>one-to-one</a:t>
+                </a:r>
+                <a:r>
+                  <a:rPr lang="de-DE" i="1"/>
+                  <a:t> </a:t>
+                </a:r>
+                <a:r>
+                  <a:rPr lang="de-DE" b="1" i="1"/>
+                  <a:t>IPC</a:t>
+                </a:r>
+              </a:p>
+            </p:txBody>
+          </p:sp>
+        </p:grpSp>
+        <p:sp>
+          <p:nvSpPr>
+            <p:cNvPr id="41" name="Rechteck 40">
+              <a:extLst>
+                <a:ext uri="{FF2B5EF4-FFF2-40B4-BE49-F238E27FC236}">
+                  <a16:creationId xmlns:a16="http://schemas.microsoft.com/office/drawing/2014/main" id="{BE488C41-3E39-E95D-85D1-75AE15220CA5}"/>
+                </a:ext>
+              </a:extLst>
+            </p:cNvPr>
+            <p:cNvSpPr/>
+            <p:nvPr/>
+          </p:nvSpPr>
+          <p:spPr>
+            <a:xfrm>
+              <a:off x="2911602" y="2086489"/>
+              <a:ext cx="6254496" cy="2333111"/>
+            </a:xfrm>
+            <a:prstGeom prst="rect">
+              <a:avLst/>
+            </a:prstGeom>
+            <a:noFill/>
+            <a:ln>
+              <a:solidFill>
+                <a:srgbClr val="002060"/>
+              </a:solidFill>
+              <a:prstDash val="dash"/>
+            </a:ln>
+          </p:spPr>
+          <p:style>
+            <a:lnRef idx="2">
+              <a:schemeClr val="accent1">
+                <a:shade val="15000"/>
+              </a:schemeClr>
+            </a:lnRef>
+            <a:fillRef idx="1">
+              <a:schemeClr val="accent1"/>
+            </a:fillRef>
+            <a:effectRef idx="0">
+              <a:schemeClr val="accent1"/>
+            </a:effectRef>
+            <a:fontRef idx="minor">
+              <a:schemeClr val="lt1"/>
+            </a:fontRef>
+          </p:style>
+          <p:txBody>
+            <a:bodyPr rtlCol="0" anchor="ctr"/>
+            <a:lstStyle/>
+            <a:p>
+              <a:pPr algn="ctr"/>
+              <a:endParaRPr lang="de-DE"/>
+            </a:p>
+          </p:txBody>
+        </p:sp>
+        <p:sp>
+          <p:nvSpPr>
+            <p:cNvPr id="42" name="Textfeld 41">
+              <a:extLst>
+                <a:ext uri="{FF2B5EF4-FFF2-40B4-BE49-F238E27FC236}">
+                  <a16:creationId xmlns:a16="http://schemas.microsoft.com/office/drawing/2014/main" id="{6860F192-A780-ACF2-B447-DBCED6349946}"/>
+                </a:ext>
+              </a:extLst>
+            </p:cNvPr>
+            <p:cNvSpPr txBox="1"/>
+            <p:nvPr/>
+          </p:nvSpPr>
+          <p:spPr>
+            <a:xfrm>
+              <a:off x="3396234" y="1931041"/>
+              <a:ext cx="5369868" cy="307777"/>
+            </a:xfrm>
+            <a:prstGeom prst="rect">
+              <a:avLst/>
+            </a:prstGeom>
+            <a:solidFill>
+              <a:schemeClr val="bg1"/>
+            </a:solidFill>
+          </p:spPr>
+          <p:txBody>
+            <a:bodyPr wrap="none" rtlCol="0">
+              <a:spAutoFit/>
+            </a:bodyPr>
+            <a:lstStyle/>
+            <a:p>
+              <a:r>
+                <a:rPr lang="de-DE" sz="1400" b="1">
+                  <a:solidFill>
+                    <a:srgbClr val="002060"/>
+                  </a:solidFill>
+                </a:rPr>
+                <a:t>one </a:t>
+              </a:r>
+              <a:r>
+                <a:rPr lang="de-DE" sz="1400" b="1" i="1">
+                  <a:solidFill>
+                    <a:srgbClr val="002060"/>
+                  </a:solidFill>
+                </a:rPr>
+                <a:t>logical</a:t>
+              </a:r>
+              <a:r>
+                <a:rPr lang="de-DE" sz="1400" b="1">
+                  <a:solidFill>
+                    <a:srgbClr val="002060"/>
+                  </a:solidFill>
+                </a:rPr>
+                <a:t> job-session-process in two </a:t>
+              </a:r>
+              <a:r>
+                <a:rPr lang="de-DE" sz="1400" b="1" i="1">
+                  <a:solidFill>
+                    <a:srgbClr val="002060"/>
+                  </a:solidFill>
+                </a:rPr>
+                <a:t>physical</a:t>
+              </a:r>
+              <a:r>
+                <a:rPr lang="de-DE" sz="1400" b="1">
+                  <a:solidFill>
+                    <a:srgbClr val="002060"/>
+                  </a:solidFill>
+                </a:rPr>
+                <a:t> process-spaces</a:t>
+              </a:r>
+            </a:p>
+          </p:txBody>
+        </p:sp>
+        <p:sp>
+          <p:nvSpPr>
+            <p:cNvPr id="54" name="Textfeld 53">
+              <a:extLst>
+                <a:ext uri="{FF2B5EF4-FFF2-40B4-BE49-F238E27FC236}">
+                  <a16:creationId xmlns:a16="http://schemas.microsoft.com/office/drawing/2014/main" id="{35339789-9892-8B3C-0986-3CE07F4F5B0F}"/>
+                </a:ext>
+              </a:extLst>
+            </p:cNvPr>
+            <p:cNvSpPr txBox="1"/>
+            <p:nvPr/>
+          </p:nvSpPr>
+          <p:spPr>
+            <a:xfrm>
+              <a:off x="8531784" y="3941718"/>
+              <a:ext cx="409133" cy="215444"/>
+            </a:xfrm>
+            <a:prstGeom prst="rect">
+              <a:avLst/>
+            </a:prstGeom>
+            <a:solidFill>
+              <a:srgbClr val="FFFF99"/>
+            </a:solidFill>
+            <a:ln>
+              <a:solidFill>
+                <a:schemeClr val="tx1"/>
+              </a:solidFill>
+            </a:ln>
+          </p:spPr>
+          <p:txBody>
+            <a:bodyPr wrap="none" lIns="72000" tIns="0" rIns="72000" bIns="0" rtlCol="0">
+              <a:spAutoFit/>
+            </a:bodyPr>
+            <a:lstStyle/>
+            <a:p>
+              <a:r>
+                <a:rPr lang="de-DE" sz="1400" i="1"/>
+                <a:t>exe</a:t>
+              </a:r>
+            </a:p>
+          </p:txBody>
+        </p:sp>
+        <p:grpSp>
+          <p:nvGrpSpPr>
+            <p:cNvPr id="45" name="Gruppieren 44">
+              <a:extLst>
+                <a:ext uri="{FF2B5EF4-FFF2-40B4-BE49-F238E27FC236}">
+                  <a16:creationId xmlns:a16="http://schemas.microsoft.com/office/drawing/2014/main" id="{D7D6D2AD-63E5-9095-4FC5-2C10252C76EB}"/>
+                </a:ext>
+              </a:extLst>
+            </p:cNvPr>
+            <p:cNvGrpSpPr/>
+            <p:nvPr/>
+          </p:nvGrpSpPr>
+          <p:grpSpPr>
+            <a:xfrm>
+              <a:off x="3535617" y="3049876"/>
+              <a:ext cx="1780191" cy="791538"/>
+              <a:chOff x="798604" y="351742"/>
+              <a:chExt cx="1780191" cy="791538"/>
+            </a:xfrm>
+          </p:grpSpPr>
+          <p:sp>
+            <p:nvSpPr>
+              <p:cNvPr id="30" name="Rechteck 29">
+                <a:extLst>
+                  <a:ext uri="{FF2B5EF4-FFF2-40B4-BE49-F238E27FC236}">
+                    <a16:creationId xmlns:a16="http://schemas.microsoft.com/office/drawing/2014/main" id="{2A5786B1-3FB4-0E22-8DA1-DBDDF5C888CC}"/>
+                  </a:ext>
+                </a:extLst>
+              </p:cNvPr>
+              <p:cNvSpPr/>
+              <p:nvPr/>
+            </p:nvSpPr>
+            <p:spPr>
+              <a:xfrm>
+                <a:off x="814720" y="378232"/>
+                <a:ext cx="1764075" cy="765048"/>
+              </a:xfrm>
+              <a:prstGeom prst="rect">
+                <a:avLst/>
+              </a:prstGeom>
+              <a:solidFill>
+                <a:schemeClr val="tx2">
+                  <a:lumMod val="10000"/>
+                  <a:lumOff val="90000"/>
+                </a:schemeClr>
+              </a:solidFill>
+              <a:ln>
+                <a:solidFill>
+                  <a:srgbClr val="7030A0"/>
+                </a:solidFill>
+              </a:ln>
+            </p:spPr>
+            <p:style>
+              <a:lnRef idx="2">
+                <a:schemeClr val="accent1">
+                  <a:shade val="15000"/>
+                </a:schemeClr>
+              </a:lnRef>
+              <a:fillRef idx="1">
+                <a:schemeClr val="accent1"/>
+              </a:fillRef>
+              <a:effectRef idx="0">
+                <a:schemeClr val="accent1"/>
+              </a:effectRef>
+              <a:fontRef idx="minor">
+                <a:schemeClr val="lt1"/>
+              </a:fontRef>
+            </p:style>
+            <p:txBody>
+              <a:bodyPr rtlCol="0" anchor="ctr"/>
+              <a:lstStyle/>
+              <a:p>
+                <a:pPr algn="ctr"/>
+                <a:endParaRPr lang="de-DE"/>
+              </a:p>
+            </p:txBody>
+          </p:sp>
+          <p:sp>
+            <p:nvSpPr>
+              <p:cNvPr id="29" name="Textfeld 28">
+                <a:extLst>
+                  <a:ext uri="{FF2B5EF4-FFF2-40B4-BE49-F238E27FC236}">
+                    <a16:creationId xmlns:a16="http://schemas.microsoft.com/office/drawing/2014/main" id="{3610DF32-87F5-5383-6DF3-1DE9594680FB}"/>
+                  </a:ext>
+                </a:extLst>
+              </p:cNvPr>
+              <p:cNvSpPr txBox="1"/>
+              <p:nvPr/>
+            </p:nvSpPr>
+            <p:spPr>
+              <a:xfrm>
+                <a:off x="798604" y="351742"/>
+                <a:ext cx="1757725" cy="553998"/>
+              </a:xfrm>
+              <a:prstGeom prst="rect">
+                <a:avLst/>
+              </a:prstGeom>
+              <a:noFill/>
+            </p:spPr>
+            <p:txBody>
+              <a:bodyPr wrap="none" rtlCol="0">
+                <a:spAutoFit/>
+              </a:bodyPr>
+              <a:lstStyle/>
+              <a:p>
+                <a:r>
+                  <a:rPr lang="de-DE" b="1"/>
+                  <a:t>session-broker</a:t>
+                </a:r>
+              </a:p>
+              <a:p>
+                <a:r>
+                  <a:rPr lang="de-DE" sz="1200"/>
+                  <a:t>(</a:t>
+                </a:r>
+                <a:r>
+                  <a:rPr lang="de-DE" sz="1200" i="1"/>
+                  <a:t>jap</a:t>
+                </a:r>
+                <a:r>
+                  <a:rPr lang="de-DE" sz="1200"/>
+                  <a:t>-server)</a:t>
+                </a:r>
+              </a:p>
+            </p:txBody>
+          </p:sp>
+          <p:sp>
+            <p:nvSpPr>
+              <p:cNvPr id="53" name="Textfeld 52">
+                <a:extLst>
+                  <a:ext uri="{FF2B5EF4-FFF2-40B4-BE49-F238E27FC236}">
+                    <a16:creationId xmlns:a16="http://schemas.microsoft.com/office/drawing/2014/main" id="{1D7ECD08-4890-EEC5-6F3A-A6FCD2CC016F}"/>
+                  </a:ext>
+                </a:extLst>
+              </p:cNvPr>
+              <p:cNvSpPr txBox="1"/>
+              <p:nvPr/>
+            </p:nvSpPr>
+            <p:spPr>
+              <a:xfrm>
+                <a:off x="2082650" y="855775"/>
+                <a:ext cx="409133" cy="215444"/>
+              </a:xfrm>
+              <a:prstGeom prst="rect">
+                <a:avLst/>
+              </a:prstGeom>
+              <a:solidFill>
+                <a:srgbClr val="FFFF99"/>
+              </a:solidFill>
+              <a:ln>
+                <a:solidFill>
+                  <a:schemeClr val="tx1"/>
+                </a:solidFill>
+              </a:ln>
+            </p:spPr>
+            <p:txBody>
+              <a:bodyPr wrap="none" lIns="72000" tIns="0" rIns="72000" bIns="0" rtlCol="0">
+                <a:spAutoFit/>
+              </a:bodyPr>
+              <a:lstStyle/>
+              <a:p>
+                <a:r>
+                  <a:rPr lang="de-DE" sz="1400" i="1"/>
+                  <a:t>exe</a:t>
+                </a:r>
+              </a:p>
+            </p:txBody>
+          </p:sp>
+        </p:grpSp>
+        <p:grpSp>
+          <p:nvGrpSpPr>
+            <p:cNvPr id="35" name="Gruppieren 34">
+              <a:extLst>
+                <a:ext uri="{FF2B5EF4-FFF2-40B4-BE49-F238E27FC236}">
+                  <a16:creationId xmlns:a16="http://schemas.microsoft.com/office/drawing/2014/main" id="{AF4BA5D2-C1EB-D6DF-7D31-767359EF3A5F}"/>
+                </a:ext>
+              </a:extLst>
+            </p:cNvPr>
+            <p:cNvGrpSpPr/>
+            <p:nvPr/>
+          </p:nvGrpSpPr>
+          <p:grpSpPr>
+            <a:xfrm>
+              <a:off x="7389405" y="3049876"/>
+              <a:ext cx="1485126" cy="830997"/>
+              <a:chOff x="482782" y="1498463"/>
+              <a:chExt cx="1485126" cy="830997"/>
+            </a:xfrm>
+          </p:grpSpPr>
+          <p:sp>
+            <p:nvSpPr>
+              <p:cNvPr id="31" name="Rechteck 30">
+                <a:extLst>
+                  <a:ext uri="{FF2B5EF4-FFF2-40B4-BE49-F238E27FC236}">
+                    <a16:creationId xmlns:a16="http://schemas.microsoft.com/office/drawing/2014/main" id="{78C8DC7B-384F-04A5-6923-880D90B4157B}"/>
+                  </a:ext>
+                </a:extLst>
+              </p:cNvPr>
+              <p:cNvSpPr/>
+              <p:nvPr/>
+            </p:nvSpPr>
+            <p:spPr>
+              <a:xfrm>
+                <a:off x="495724" y="1524953"/>
+                <a:ext cx="1472184" cy="765048"/>
+              </a:xfrm>
+              <a:prstGeom prst="rect">
+                <a:avLst/>
+              </a:prstGeom>
+              <a:solidFill>
+                <a:schemeClr val="tx2">
+                  <a:lumMod val="10000"/>
+                  <a:lumOff val="90000"/>
+                </a:schemeClr>
+              </a:solidFill>
+              <a:ln>
+                <a:solidFill>
+                  <a:schemeClr val="tx2">
+                    <a:lumMod val="75000"/>
+                    <a:lumOff val="25000"/>
+                  </a:schemeClr>
+                </a:solidFill>
+              </a:ln>
+            </p:spPr>
+            <p:style>
+              <a:lnRef idx="2">
+                <a:schemeClr val="accent1">
+                  <a:shade val="15000"/>
+                </a:schemeClr>
+              </a:lnRef>
+              <a:fillRef idx="1">
+                <a:schemeClr val="accent1"/>
+              </a:fillRef>
+              <a:effectRef idx="0">
+                <a:schemeClr val="accent1"/>
+              </a:effectRef>
+              <a:fontRef idx="minor">
+                <a:schemeClr val="lt1"/>
+              </a:fontRef>
+            </p:style>
+            <p:txBody>
+              <a:bodyPr rtlCol="0" anchor="ctr"/>
+              <a:lstStyle/>
+              <a:p>
+                <a:pPr algn="ctr"/>
+                <a:endParaRPr lang="de-DE"/>
+              </a:p>
+            </p:txBody>
+          </p:sp>
+          <p:sp>
+            <p:nvSpPr>
+              <p:cNvPr id="32" name="Textfeld 31">
+                <a:extLst>
+                  <a:ext uri="{FF2B5EF4-FFF2-40B4-BE49-F238E27FC236}">
+                    <a16:creationId xmlns:a16="http://schemas.microsoft.com/office/drawing/2014/main" id="{65513305-956F-6658-DBD8-D938D088654B}"/>
+                  </a:ext>
+                </a:extLst>
+              </p:cNvPr>
+              <p:cNvSpPr txBox="1"/>
+              <p:nvPr/>
+            </p:nvSpPr>
+            <p:spPr>
+              <a:xfrm>
+                <a:off x="482782" y="1498463"/>
+                <a:ext cx="1057982" cy="830997"/>
+              </a:xfrm>
+              <a:prstGeom prst="rect">
+                <a:avLst/>
+              </a:prstGeom>
+              <a:noFill/>
+            </p:spPr>
+            <p:txBody>
+              <a:bodyPr wrap="none" rtlCol="0">
+                <a:spAutoFit/>
+              </a:bodyPr>
+              <a:lstStyle/>
+              <a:p>
+                <a:r>
+                  <a:rPr lang="de-DE" b="1">
+                    <a:solidFill>
+                      <a:schemeClr val="tx2">
+                        <a:lumMod val="75000"/>
+                        <a:lumOff val="25000"/>
+                      </a:schemeClr>
+                    </a:solidFill>
+                  </a:rPr>
+                  <a:t>job-host</a:t>
+                </a:r>
+              </a:p>
+              <a:p>
+                <a:r>
+                  <a:rPr lang="de-DE" sz="1200"/>
+                  <a:t>(</a:t>
+                </a:r>
+                <a:r>
+                  <a:rPr lang="de-DE" sz="1200" i="1"/>
+                  <a:t>jap</a:t>
+                </a:r>
+                <a:r>
+                  <a:rPr lang="de-DE" sz="1200"/>
+                  <a:t>-client)</a:t>
+                </a:r>
+              </a:p>
+              <a:p>
+                <a:endParaRPr lang="de-DE" b="1">
+                  <a:solidFill>
+                    <a:schemeClr val="tx2">
+                      <a:lumMod val="75000"/>
+                      <a:lumOff val="25000"/>
+                    </a:schemeClr>
+                  </a:solidFill>
+                </a:endParaRPr>
+              </a:p>
+            </p:txBody>
+          </p:sp>
+          <p:sp>
+            <p:nvSpPr>
+              <p:cNvPr id="34" name="Textfeld 33">
+                <a:extLst>
+                  <a:ext uri="{FF2B5EF4-FFF2-40B4-BE49-F238E27FC236}">
+                    <a16:creationId xmlns:a16="http://schemas.microsoft.com/office/drawing/2014/main" id="{8E3B4212-D8F9-751B-2BDE-F0766AF188FC}"/>
+                  </a:ext>
+                </a:extLst>
+              </p:cNvPr>
+              <p:cNvSpPr txBox="1"/>
+              <p:nvPr/>
+            </p:nvSpPr>
+            <p:spPr>
+              <a:xfrm>
+                <a:off x="1332488" y="2003766"/>
+                <a:ext cx="580077" cy="215444"/>
+              </a:xfrm>
+              <a:prstGeom prst="rect">
+                <a:avLst/>
+              </a:prstGeom>
+              <a:solidFill>
+                <a:srgbClr val="FFFF99"/>
+              </a:solidFill>
+              <a:ln>
+                <a:solidFill>
+                  <a:schemeClr val="tx1"/>
+                </a:solidFill>
+              </a:ln>
+            </p:spPr>
+            <p:txBody>
+              <a:bodyPr wrap="none" lIns="72000" tIns="0" rIns="72000" bIns="0" rtlCol="0">
+                <a:spAutoFit/>
+              </a:bodyPr>
+              <a:lstStyle/>
+              <a:p>
+                <a:r>
+                  <a:rPr lang="de-DE" sz="1400" i="1"/>
+                  <a:t>nuget</a:t>
+                </a:r>
+              </a:p>
+            </p:txBody>
+          </p:sp>
+        </p:grpSp>
+      </p:grpSp>
+      <p:sp>
+        <p:nvSpPr>
+          <p:cNvPr id="2" name="Textfeld 1">
+            <a:extLst>
+              <a:ext uri="{FF2B5EF4-FFF2-40B4-BE49-F238E27FC236}">
+                <a16:creationId xmlns:a16="http://schemas.microsoft.com/office/drawing/2014/main" id="{519E1644-DBCE-0EF7-8B66-ED2E10EBBA6F}"/>
+              </a:ext>
+            </a:extLst>
+          </p:cNvPr>
+          <p:cNvSpPr txBox="1"/>
+          <p:nvPr/>
+        </p:nvSpPr>
+        <p:spPr>
+          <a:xfrm>
+            <a:off x="3393373" y="306209"/>
+            <a:ext cx="5052923" cy="523220"/>
+          </a:xfrm>
+          <a:prstGeom prst="rect">
+            <a:avLst/>
+          </a:prstGeom>
+          <a:noFill/>
+        </p:spPr>
+        <p:txBody>
+          <a:bodyPr wrap="none" rtlCol="0">
+            <a:spAutoFit/>
+          </a:bodyPr>
+          <a:lstStyle/>
+          <a:p>
+            <a:pPr algn="ctr"/>
+            <a:r>
+              <a:rPr lang="de-DE" sz="2800" b="1" i="1">
+                <a:solidFill>
+                  <a:srgbClr val="002060"/>
+                </a:solidFill>
+              </a:rPr>
+              <a:t>Proposal</a:t>
+            </a:r>
+            <a:r>
+              <a:rPr lang="de-DE" sz="2800" b="1"/>
+              <a:t> für das Kernproblem</a:t>
+            </a:r>
+            <a:endParaRPr lang="de-DE" b="1"/>
+          </a:p>
+        </p:txBody>
+      </p:sp>
+      <p:sp>
+        <p:nvSpPr>
+          <p:cNvPr id="5" name="Textfeld 4">
+            <a:extLst>
+              <a:ext uri="{FF2B5EF4-FFF2-40B4-BE49-F238E27FC236}">
+                <a16:creationId xmlns:a16="http://schemas.microsoft.com/office/drawing/2014/main" id="{31B0DD6C-1959-F561-62A6-4A45090DC6D2}"/>
+              </a:ext>
+            </a:extLst>
+          </p:cNvPr>
+          <p:cNvSpPr txBox="1"/>
+          <p:nvPr/>
+        </p:nvSpPr>
+        <p:spPr>
+          <a:xfrm>
+            <a:off x="1824755" y="4024158"/>
+            <a:ext cx="8418755" cy="954107"/>
+          </a:xfrm>
+          <a:prstGeom prst="rect">
+            <a:avLst/>
+          </a:prstGeom>
+          <a:noFill/>
+        </p:spPr>
+        <p:txBody>
+          <a:bodyPr wrap="square">
+            <a:spAutoFit/>
+          </a:bodyPr>
+          <a:lstStyle/>
+          <a:p>
+            <a:endParaRPr lang="de-DE" sz="800"/>
+          </a:p>
+          <a:p>
+            <a:pPr marL="171450" indent="-171450">
+              <a:buFont typeface="Arial" panose="020B0604020202020204" pitchFamily="34" charset="0"/>
+              <a:buChar char="•"/>
+            </a:pPr>
+            <a:r>
+              <a:rPr lang="de-DE" sz="1600"/>
+              <a:t>Trennung in zwei Prozessräume</a:t>
+            </a:r>
+          </a:p>
+          <a:p>
+            <a:pPr marL="171450" indent="-171450">
+              <a:buFont typeface="Arial" panose="020B0604020202020204" pitchFamily="34" charset="0"/>
+              <a:buChar char="•"/>
+            </a:pPr>
+            <a:r>
+              <a:rPr lang="de-DE" sz="1600"/>
+              <a:t>System.IO.Pipes (als Named-Pipes bzw. Unix-Domain-Sockets)</a:t>
+            </a:r>
+          </a:p>
+          <a:p>
+            <a:pPr marL="171450" indent="-171450">
+              <a:buFont typeface="Arial" panose="020B0604020202020204" pitchFamily="34" charset="0"/>
+              <a:buChar char="•"/>
+            </a:pPr>
+            <a:r>
+              <a:rPr lang="de-DE" sz="1600" b="1">
+                <a:solidFill>
+                  <a:srgbClr val="0070C0"/>
+                </a:solidFill>
+              </a:rPr>
+              <a:t>Schaffung eines leichtgewichtigen </a:t>
+            </a:r>
+            <a:r>
+              <a:rPr lang="de-DE" sz="1600" b="1" i="1">
+                <a:solidFill>
+                  <a:srgbClr val="0070C0"/>
+                </a:solidFill>
+              </a:rPr>
+              <a:t>one-to-one-IPC-Application-Protocols</a:t>
+            </a:r>
+            <a:r>
+              <a:rPr lang="de-DE" sz="1600" b="1">
+                <a:solidFill>
+                  <a:srgbClr val="0070C0"/>
+                </a:solidFill>
+              </a:rPr>
+              <a:t>. (JAP)</a:t>
+            </a:r>
+          </a:p>
+        </p:txBody>
+      </p:sp>
+      <p:sp>
+        <p:nvSpPr>
+          <p:cNvPr id="14" name="Textfeld 13">
+            <a:extLst>
+              <a:ext uri="{FF2B5EF4-FFF2-40B4-BE49-F238E27FC236}">
+                <a16:creationId xmlns:a16="http://schemas.microsoft.com/office/drawing/2014/main" id="{7E5349DD-7736-0A81-1AC6-477997C0DE28}"/>
+              </a:ext>
+            </a:extLst>
+          </p:cNvPr>
+          <p:cNvSpPr txBox="1"/>
+          <p:nvPr/>
+        </p:nvSpPr>
+        <p:spPr>
+          <a:xfrm>
+            <a:off x="1851449" y="5774811"/>
+            <a:ext cx="9126537" cy="646331"/>
+          </a:xfrm>
+          <a:prstGeom prst="rect">
+            <a:avLst/>
+          </a:prstGeom>
+          <a:noFill/>
+        </p:spPr>
+        <p:txBody>
+          <a:bodyPr wrap="square">
+            <a:spAutoFit/>
+          </a:bodyPr>
+          <a:lstStyle/>
+          <a:p>
+            <a:r>
+              <a:rPr lang="de-DE" b="1"/>
+              <a:t>Wir bekommen</a:t>
+            </a:r>
+            <a:r>
+              <a:rPr lang="de-DE" b="1">
+                <a:solidFill>
+                  <a:srgbClr val="0070C0"/>
+                </a:solidFill>
+              </a:rPr>
+              <a:t> zwei</a:t>
+            </a:r>
+            <a:r>
+              <a:rPr lang="de-DE" b="1"/>
+              <a:t> logisch, technologisch und architekturell getrennte </a:t>
+            </a:r>
+            <a:r>
+              <a:rPr lang="de-DE" b="1" i="1">
+                <a:solidFill>
+                  <a:srgbClr val="0070C0"/>
+                </a:solidFill>
+              </a:rPr>
+              <a:t>Domänen</a:t>
+            </a:r>
+            <a:r>
+              <a:rPr lang="de-DE" b="1" i="1"/>
+              <a:t>…</a:t>
+            </a:r>
+          </a:p>
+          <a:p>
+            <a:r>
+              <a:rPr lang="de-DE"/>
+              <a:t>(…mit einer leichtgewichtige Kopplung über das </a:t>
+            </a:r>
+            <a:r>
+              <a:rPr lang="de-DE" b="1"/>
+              <a:t>JAP-Protokoll</a:t>
+            </a:r>
+            <a:r>
+              <a:rPr lang="de-DE"/>
+              <a:t>… )</a:t>
+            </a:r>
+          </a:p>
+        </p:txBody>
+      </p:sp>
+      <p:sp>
+        <p:nvSpPr>
+          <p:cNvPr id="9" name="Textfeld 8">
+            <a:extLst>
+              <a:ext uri="{FF2B5EF4-FFF2-40B4-BE49-F238E27FC236}">
+                <a16:creationId xmlns:a16="http://schemas.microsoft.com/office/drawing/2014/main" id="{F8C6DEE4-170E-61FC-5510-46EBF737CCF9}"/>
+              </a:ext>
+            </a:extLst>
+          </p:cNvPr>
+          <p:cNvSpPr txBox="1"/>
+          <p:nvPr/>
+        </p:nvSpPr>
+        <p:spPr>
+          <a:xfrm>
+            <a:off x="1853020" y="3460782"/>
+            <a:ext cx="9288463" cy="646331"/>
+          </a:xfrm>
+          <a:prstGeom prst="rect">
+            <a:avLst/>
+          </a:prstGeom>
+          <a:noFill/>
+        </p:spPr>
+        <p:txBody>
+          <a:bodyPr wrap="square">
+            <a:spAutoFit/>
+          </a:bodyPr>
+          <a:lstStyle/>
+          <a:p>
+            <a:r>
+              <a:rPr lang="de-DE" sz="1800"/>
+              <a:t>Die Grundidee </a:t>
+            </a:r>
+            <a:r>
+              <a:rPr lang="de-DE" sz="1800" i="1"/>
+              <a:t>„decpoupling and isolation by spawning another process“</a:t>
+            </a:r>
+            <a:r>
+              <a:rPr lang="de-DE" sz="1800"/>
+              <a:t> wird nicht verworfen, sondern konsequent weitergeführt und „richtig implementiert:</a:t>
+            </a:r>
+          </a:p>
+        </p:txBody>
+      </p:sp>
+      <p:sp>
+        <p:nvSpPr>
+          <p:cNvPr id="11" name="Textfeld 10">
+            <a:extLst>
+              <a:ext uri="{FF2B5EF4-FFF2-40B4-BE49-F238E27FC236}">
+                <a16:creationId xmlns:a16="http://schemas.microsoft.com/office/drawing/2014/main" id="{E80A37DA-2AFA-6576-2076-87CB4BA793B6}"/>
+              </a:ext>
+            </a:extLst>
+          </p:cNvPr>
+          <p:cNvSpPr txBox="1"/>
+          <p:nvPr/>
+        </p:nvSpPr>
+        <p:spPr>
+          <a:xfrm>
+            <a:off x="1850155" y="5086947"/>
+            <a:ext cx="8534401" cy="646331"/>
+          </a:xfrm>
+          <a:prstGeom prst="rect">
+            <a:avLst/>
+          </a:prstGeom>
+          <a:noFill/>
+        </p:spPr>
+        <p:txBody>
+          <a:bodyPr wrap="square">
+            <a:spAutoFit/>
+          </a:bodyPr>
+          <a:lstStyle/>
+          <a:p>
+            <a:r>
+              <a:rPr lang="de-DE"/>
+              <a:t>Starke und nachhaltige Entkopplung (- nicht nur </a:t>
+            </a:r>
+            <a:r>
+              <a:rPr lang="de-DE" i="1"/>
+              <a:t>zur Runtime im Prozessraum</a:t>
+            </a:r>
+            <a:r>
+              <a:rPr lang="de-DE"/>
+              <a:t>!)</a:t>
+            </a:r>
+          </a:p>
+          <a:p>
+            <a:r>
+              <a:rPr lang="de-DE"/>
+              <a:t>Auf einer Maschine - unterhalb des Netzwerkstacks (keine Firewall, etc.)</a:t>
+            </a:r>
+          </a:p>
+        </p:txBody>
+      </p:sp>
+    </p:spTree>
+    <p:extLst>
+      <p:ext uri="{BB962C8B-B14F-4D97-AF65-F5344CB8AC3E}">
+        <p14:creationId xmlns:p14="http://schemas.microsoft.com/office/powerpoint/2010/main" val="497310861"/>
+      </p:ext>
+    </p:extLst>
+  </p:cSld>
+  <p:clrMapOvr>
+    <a:masterClrMapping/>
+  </p:clrMapOvr>
+  <p:timing>
+    <p:tnLst>
+      <p:par>
+        <p:cTn id="1" dur="indefinite" restart="never" nodeType="tmRoot">
+          <p:childTnLst>
+            <p:seq concurrent="1" nextAc="seek">
+              <p:cTn id="2" dur="indefinite" nodeType="mainSeq">
+                <p:childTnLst>
+                  <p:par>
+                    <p:cTn id="3" fill="hold">
+                      <p:stCondLst>
+                        <p:cond delay="indefinite"/>
+                      </p:stCondLst>
+                      <p:childTnLst>
+                        <p:par>
+                          <p:cTn id="4" fill="hold">
+                            <p:stCondLst>
+                              <p:cond delay="0"/>
+                            </p:stCondLst>
+                            <p:childTnLst>
+                              <p:par>
+                                <p:cTn id="5" presetID="1" presetClass="entr" presetSubtype="0" fill="hold" grpId="0" nodeType="clickEffect">
+                                  <p:stCondLst>
+                                    <p:cond delay="0"/>
+                                  </p:stCondLst>
+                                  <p:childTnLst>
+                                    <p:set>
+                                      <p:cBhvr>
+                                        <p:cTn id="6" dur="1" fill="hold">
+                                          <p:stCondLst>
+                                            <p:cond delay="0"/>
+                                          </p:stCondLst>
+                                        </p:cTn>
+                                        <p:tgtEl>
+                                          <p:spTgt spid="9"/>
+                                        </p:tgtEl>
+                                        <p:attrNameLst>
+                                          <p:attrName>style.visibility</p:attrName>
+                                        </p:attrNameLst>
+                                      </p:cBhvr>
+                                      <p:to>
+                                        <p:strVal val="visible"/>
+                                      </p:to>
+                                    </p:set>
+                                  </p:childTnLst>
+                                </p:cTn>
+                              </p:par>
+                            </p:childTnLst>
+                          </p:cTn>
+                        </p:par>
+                      </p:childTnLst>
+                    </p:cTn>
+                  </p:par>
+                  <p:par>
+                    <p:cTn id="7" fill="hold">
+                      <p:stCondLst>
+                        <p:cond delay="indefinite"/>
+                      </p:stCondLst>
+                      <p:childTnLst>
+                        <p:par>
+                          <p:cTn id="8" fill="hold">
+                            <p:stCondLst>
+                              <p:cond delay="0"/>
+                            </p:stCondLst>
+                            <p:childTnLst>
+                              <p:par>
+                                <p:cTn id="9" presetID="1" presetClass="entr" presetSubtype="0" fill="hold" grpId="0" nodeType="clickEffect">
+                                  <p:stCondLst>
+                                    <p:cond delay="0"/>
+                                  </p:stCondLst>
+                                  <p:childTnLst>
+                                    <p:set>
+                                      <p:cBhvr>
+                                        <p:cTn id="10" dur="1" fill="hold">
+                                          <p:stCondLst>
+                                            <p:cond delay="0"/>
+                                          </p:stCondLst>
+                                        </p:cTn>
+                                        <p:tgtEl>
+                                          <p:spTgt spid="5"/>
+                                        </p:tgtEl>
+                                        <p:attrNameLst>
+                                          <p:attrName>style.visibility</p:attrName>
+                                        </p:attrNameLst>
+                                      </p:cBhvr>
+                                      <p:to>
+                                        <p:strVal val="visible"/>
+                                      </p:to>
+                                    </p:set>
+                                  </p:childTnLst>
+                                </p:cTn>
+                              </p:par>
+                            </p:childTnLst>
+                          </p:cTn>
+                        </p:par>
+                      </p:childTnLst>
+                    </p:cTn>
+                  </p:par>
+                  <p:par>
+                    <p:cTn id="11" fill="hold">
+                      <p:stCondLst>
+                        <p:cond delay="indefinite"/>
+                      </p:stCondLst>
+                      <p:childTnLst>
+                        <p:par>
+                          <p:cTn id="12" fill="hold">
+                            <p:stCondLst>
+                              <p:cond delay="0"/>
+                            </p:stCondLst>
+                            <p:childTnLst>
+                              <p:par>
+                                <p:cTn id="13" presetID="1" presetClass="entr" presetSubtype="0" fill="hold" grpId="0" nodeType="clickEffect">
+                                  <p:stCondLst>
+                                    <p:cond delay="0"/>
+                                  </p:stCondLst>
+                                  <p:childTnLst>
+                                    <p:set>
+                                      <p:cBhvr>
+                                        <p:cTn id="14" dur="1" fill="hold">
+                                          <p:stCondLst>
+                                            <p:cond delay="0"/>
+                                          </p:stCondLst>
+                                        </p:cTn>
+                                        <p:tgtEl>
+                                          <p:spTgt spid="11"/>
+                                        </p:tgtEl>
+                                        <p:attrNameLst>
+                                          <p:attrName>style.visibility</p:attrName>
+                                        </p:attrNameLst>
+                                      </p:cBhvr>
+                                      <p:to>
+                                        <p:strVal val="visible"/>
+                                      </p:to>
+                                    </p:set>
+                                  </p:childTnLst>
+                                </p:cTn>
+                              </p:par>
+                            </p:childTnLst>
+                          </p:cTn>
+                        </p:par>
+                      </p:childTnLst>
+                    </p:cTn>
+                  </p:par>
+                  <p:par>
+                    <p:cTn id="15" fill="hold">
+                      <p:stCondLst>
+                        <p:cond delay="indefinite"/>
+                      </p:stCondLst>
+                      <p:childTnLst>
+                        <p:par>
+                          <p:cTn id="16" fill="hold">
+                            <p:stCondLst>
+                              <p:cond delay="0"/>
+                            </p:stCondLst>
+                            <p:childTnLst>
+                              <p:par>
+                                <p:cTn id="17" presetID="1" presetClass="entr" presetSubtype="0" fill="hold" grpId="0" nodeType="clickEffect">
+                                  <p:stCondLst>
+                                    <p:cond delay="0"/>
+                                  </p:stCondLst>
+                                  <p:childTnLst>
+                                    <p:set>
+                                      <p:cBhvr>
+                                        <p:cTn id="18" dur="1" fill="hold">
+                                          <p:stCondLst>
+                                            <p:cond delay="0"/>
+                                          </p:stCondLst>
+                                        </p:cTn>
+                                        <p:tgtEl>
+                                          <p:spTgt spid="14"/>
+                                        </p:tgtEl>
+                                        <p:attrNameLst>
+                                          <p:attrName>style.visibility</p:attrName>
+                                        </p:attrNameLst>
+                                      </p:cBhvr>
+                                      <p:to>
+                                        <p:strVal val="visible"/>
+                                      </p:to>
+                                    </p:set>
+                                  </p:childTnLst>
+                                </p:cTn>
+                              </p:par>
+                            </p:childTnLst>
+                          </p:cTn>
+                        </p:par>
+                      </p:childTnLst>
+                    </p:cTn>
+                  </p:par>
+                </p:childTnLst>
+              </p:cTn>
+              <p:prevCondLst>
+                <p:cond evt="onPrev" delay="0">
+                  <p:tgtEl>
+                    <p:sldTgt/>
+                  </p:tgtEl>
+                </p:cond>
+              </p:prevCondLst>
+              <p:nextCondLst>
+                <p:cond evt="onNext" delay="0">
+                  <p:tgtEl>
+                    <p:sldTgt/>
+                  </p:tgtEl>
+                </p:cond>
+              </p:nextCondLst>
+            </p:seq>
+          </p:childTnLst>
+        </p:cTn>
+      </p:par>
+    </p:tnLst>
+    <p:bldLst>
+      <p:bldP spid="5" grpId="0"/>
+      <p:bldP spid="14" grpId="0"/>
+      <p:bldP spid="9" grpId="0"/>
+      <p:bldP spid="11" grpId="0"/>
+    </p:bldLst>
+  </p:timing>
+</p:sld>
+</file>
+
+<file path=ppt/slides/slide11.xml><?xml version="1.0" encoding="utf-8"?>
 <p:sld xmlns:a="http://schemas.openxmlformats.org/drawingml/2006/main" xmlns:r="http://schemas.openxmlformats.org/officeDocument/2006/relationships" xmlns:p="http://schemas.openxmlformats.org/presentationml/2006/main">
   <p:cSld>
     <p:spTree>
@@ -7162,7 +8613,7 @@
 </p:sld>
 </file>
 
-<file path=ppt/slides/slide11.xml><?xml version="1.0" encoding="utf-8"?>
+<file path=ppt/slides/slide12.xml><?xml version="1.0" encoding="utf-8"?>
 <p:sld xmlns:a="http://schemas.openxmlformats.org/drawingml/2006/main" xmlns:r="http://schemas.openxmlformats.org/officeDocument/2006/relationships" xmlns:p="http://schemas.openxmlformats.org/presentationml/2006/main">
   <p:cSld>
     <p:spTree>
@@ -13947,8 +15398,8 @@
           </p:blipFill>
           <p:spPr>
             <a:xfrm>
-              <a:off x="4221593" y="3201574"/>
-              <a:ext cx="842786" cy="842786"/>
+              <a:off x="4412296" y="3215626"/>
+              <a:ext cx="520229" cy="520229"/>
             </a:xfrm>
             <a:prstGeom prst="rect">
               <a:avLst/>
@@ -17500,13 +18951,7 @@
   <p:cSld>
     <p:spTree>
       <p:nvGrpSpPr>
-        <p:cNvPr id="1" name="">
-          <a:extLst>
-            <a:ext uri="{FF2B5EF4-FFF2-40B4-BE49-F238E27FC236}">
-              <a16:creationId xmlns:a16="http://schemas.microsoft.com/office/drawing/2014/main" id="{81E50BBE-18B9-1DDD-5255-D1EE6B0E5A21}"/>
-            </a:ext>
-          </a:extLst>
-        </p:cNvPr>
+        <p:cNvPr id="1" name=""/>
         <p:cNvGrpSpPr/>
         <p:nvPr/>
       </p:nvGrpSpPr>
@@ -17518,918 +18963,42 @@
           <a:chExt cx="0" cy="0"/>
         </a:xfrm>
       </p:grpSpPr>
-      <p:grpSp>
-        <p:nvGrpSpPr>
-          <p:cNvPr id="3" name="Gruppieren 2">
+      <p:pic>
+        <p:nvPicPr>
+          <p:cNvPr id="5" name="Grafik 4">
             <a:extLst>
               <a:ext uri="{FF2B5EF4-FFF2-40B4-BE49-F238E27FC236}">
-                <a16:creationId xmlns:a16="http://schemas.microsoft.com/office/drawing/2014/main" id="{B95EA94C-38F5-591E-D9FD-26E4B0482979}"/>
+                <a16:creationId xmlns:a16="http://schemas.microsoft.com/office/drawing/2014/main" id="{41026624-F3BD-7799-E75F-2A16DFBB45C5}"/>
               </a:ext>
             </a:extLst>
           </p:cNvPr>
-          <p:cNvGrpSpPr/>
+          <p:cNvPicPr>
+            <a:picLocks noChangeAspect="1"/>
+          </p:cNvPicPr>
           <p:nvPr/>
-        </p:nvGrpSpPr>
-        <p:grpSpPr>
+        </p:nvPicPr>
+        <p:blipFill>
+          <a:blip r:embed="rId2"/>
+          <a:stretch>
+            <a:fillRect/>
+          </a:stretch>
+        </p:blipFill>
+        <p:spPr>
           <a:xfrm>
-            <a:off x="2816352" y="864241"/>
-            <a:ext cx="6254496" cy="2488559"/>
-            <a:chOff x="2911602" y="1931041"/>
-            <a:chExt cx="6254496" cy="2488559"/>
+            <a:off x="0" y="729746"/>
+            <a:ext cx="12192000" cy="6128254"/>
           </a:xfrm>
-        </p:grpSpPr>
-        <p:grpSp>
-          <p:nvGrpSpPr>
-            <p:cNvPr id="7" name="Gruppieren 6">
-              <a:extLst>
-                <a:ext uri="{FF2B5EF4-FFF2-40B4-BE49-F238E27FC236}">
-                  <a16:creationId xmlns:a16="http://schemas.microsoft.com/office/drawing/2014/main" id="{C4F543A1-F974-944C-7768-7BEE20598B94}"/>
-                </a:ext>
-              </a:extLst>
-            </p:cNvPr>
-            <p:cNvGrpSpPr/>
-            <p:nvPr/>
-          </p:nvGrpSpPr>
-          <p:grpSpPr>
-            <a:xfrm>
-              <a:off x="3105916" y="2584254"/>
-              <a:ext cx="1652773" cy="1632146"/>
-              <a:chOff x="2013970" y="586290"/>
-              <a:chExt cx="1652773" cy="3976566"/>
-            </a:xfrm>
-          </p:grpSpPr>
-          <p:sp>
-            <p:nvSpPr>
-              <p:cNvPr id="4" name="Rechteck 3">
-                <a:extLst>
-                  <a:ext uri="{FF2B5EF4-FFF2-40B4-BE49-F238E27FC236}">
-                    <a16:creationId xmlns:a16="http://schemas.microsoft.com/office/drawing/2014/main" id="{ACAEF261-0AFD-A473-0D38-5BB18A1354BE}"/>
-                  </a:ext>
-                </a:extLst>
-              </p:cNvPr>
-              <p:cNvSpPr/>
-              <p:nvPr/>
-            </p:nvSpPr>
-            <p:spPr>
-              <a:xfrm>
-                <a:off x="2031236" y="586290"/>
-                <a:ext cx="1635507" cy="3976566"/>
-              </a:xfrm>
-              <a:prstGeom prst="rect">
-                <a:avLst/>
-              </a:prstGeom>
-              <a:solidFill>
-                <a:schemeClr val="bg1">
-                  <a:lumMod val="95000"/>
-                </a:schemeClr>
-              </a:solidFill>
-              <a:ln>
-                <a:solidFill>
-                  <a:srgbClr val="7030A0"/>
-                </a:solidFill>
-                <a:prstDash val="sysDash"/>
-              </a:ln>
-            </p:spPr>
-            <p:style>
-              <a:lnRef idx="2">
-                <a:schemeClr val="accent1">
-                  <a:shade val="15000"/>
-                </a:schemeClr>
-              </a:lnRef>
-              <a:fillRef idx="1">
-                <a:schemeClr val="accent1"/>
-              </a:fillRef>
-              <a:effectRef idx="0">
-                <a:schemeClr val="accent1"/>
-              </a:effectRef>
-              <a:fontRef idx="minor">
-                <a:schemeClr val="lt1"/>
-              </a:fontRef>
-            </p:style>
-            <p:txBody>
-              <a:bodyPr rtlCol="0" anchor="ctr"/>
-              <a:lstStyle/>
-              <a:p>
-                <a:pPr algn="ctr"/>
-                <a:endParaRPr lang="de-DE"/>
-              </a:p>
-            </p:txBody>
-          </p:sp>
-          <p:sp>
-            <p:nvSpPr>
-              <p:cNvPr id="6" name="Textfeld 5">
-                <a:extLst>
-                  <a:ext uri="{FF2B5EF4-FFF2-40B4-BE49-F238E27FC236}">
-                    <a16:creationId xmlns:a16="http://schemas.microsoft.com/office/drawing/2014/main" id="{FE23814A-842D-A0C4-226C-84B90FC0854E}"/>
-                  </a:ext>
-                </a:extLst>
-              </p:cNvPr>
-              <p:cNvSpPr txBox="1"/>
-              <p:nvPr/>
-            </p:nvSpPr>
-            <p:spPr>
-              <a:xfrm>
-                <a:off x="2013970" y="594762"/>
-                <a:ext cx="1087029" cy="369332"/>
-              </a:xfrm>
-              <a:prstGeom prst="rect">
-                <a:avLst/>
-              </a:prstGeom>
-              <a:noFill/>
-            </p:spPr>
-            <p:txBody>
-              <a:bodyPr wrap="none" rtlCol="0">
-                <a:spAutoFit/>
-              </a:bodyPr>
-              <a:lstStyle/>
-              <a:p>
-                <a:r>
-                  <a:rPr lang="de-DE" b="1">
-                    <a:solidFill>
-                      <a:srgbClr val="7030A0"/>
-                    </a:solidFill>
-                  </a:rPr>
-                  <a:t>backend</a:t>
-                </a:r>
-              </a:p>
-            </p:txBody>
-          </p:sp>
-        </p:grpSp>
-        <p:grpSp>
-          <p:nvGrpSpPr>
-            <p:cNvPr id="20" name="Gruppieren 19">
-              <a:extLst>
-                <a:ext uri="{FF2B5EF4-FFF2-40B4-BE49-F238E27FC236}">
-                  <a16:creationId xmlns:a16="http://schemas.microsoft.com/office/drawing/2014/main" id="{766AAFB1-9BCF-A234-F93F-8BB0D3D6F669}"/>
-                </a:ext>
-              </a:extLst>
-            </p:cNvPr>
-            <p:cNvGrpSpPr/>
-            <p:nvPr/>
-          </p:nvGrpSpPr>
-          <p:grpSpPr>
-            <a:xfrm>
-              <a:off x="7402414" y="2590603"/>
-              <a:ext cx="1609958" cy="1625798"/>
-              <a:chOff x="6606124" y="632007"/>
-              <a:chExt cx="1609958" cy="3976568"/>
-            </a:xfrm>
-            <a:solidFill>
-              <a:schemeClr val="bg1">
-                <a:lumMod val="95000"/>
-              </a:schemeClr>
-            </a:solidFill>
-          </p:grpSpPr>
-          <p:sp>
-            <p:nvSpPr>
-              <p:cNvPr id="12" name="Rechteck 11">
-                <a:extLst>
-                  <a:ext uri="{FF2B5EF4-FFF2-40B4-BE49-F238E27FC236}">
-                    <a16:creationId xmlns:a16="http://schemas.microsoft.com/office/drawing/2014/main" id="{DFC07FED-600D-4DE7-5721-04134762009E}"/>
-                  </a:ext>
-                </a:extLst>
-              </p:cNvPr>
-              <p:cNvSpPr/>
-              <p:nvPr/>
-            </p:nvSpPr>
-            <p:spPr>
-              <a:xfrm>
-                <a:off x="6606124" y="632007"/>
-                <a:ext cx="1609958" cy="3976568"/>
-              </a:xfrm>
-              <a:prstGeom prst="rect">
-                <a:avLst/>
-              </a:prstGeom>
-              <a:grpFill/>
-              <a:ln>
-                <a:solidFill>
-                  <a:schemeClr val="tx2">
-                    <a:lumMod val="75000"/>
-                    <a:lumOff val="25000"/>
-                  </a:schemeClr>
-                </a:solidFill>
-              </a:ln>
-            </p:spPr>
-            <p:style>
-              <a:lnRef idx="2">
-                <a:schemeClr val="accent1">
-                  <a:shade val="15000"/>
-                </a:schemeClr>
-              </a:lnRef>
-              <a:fillRef idx="1">
-                <a:schemeClr val="accent1"/>
-              </a:fillRef>
-              <a:effectRef idx="0">
-                <a:schemeClr val="accent1"/>
-              </a:effectRef>
-              <a:fontRef idx="minor">
-                <a:schemeClr val="lt1"/>
-              </a:fontRef>
-            </p:style>
-            <p:txBody>
-              <a:bodyPr rtlCol="0" anchor="ctr"/>
-              <a:lstStyle/>
-              <a:p>
-                <a:pPr algn="ctr"/>
-                <a:endParaRPr lang="de-DE"/>
-              </a:p>
-            </p:txBody>
-          </p:sp>
-          <p:sp>
-            <p:nvSpPr>
-              <p:cNvPr id="13" name="Textfeld 12">
-                <a:extLst>
-                  <a:ext uri="{FF2B5EF4-FFF2-40B4-BE49-F238E27FC236}">
-                    <a16:creationId xmlns:a16="http://schemas.microsoft.com/office/drawing/2014/main" id="{050ED622-67A4-03A0-B579-8272ADDDDA00}"/>
-                  </a:ext>
-                </a:extLst>
-              </p:cNvPr>
-              <p:cNvSpPr txBox="1"/>
-              <p:nvPr/>
-            </p:nvSpPr>
-            <p:spPr>
-              <a:xfrm>
-                <a:off x="6607221" y="632142"/>
-                <a:ext cx="514885" cy="903356"/>
-              </a:xfrm>
-              <a:prstGeom prst="rect">
-                <a:avLst/>
-              </a:prstGeom>
-              <a:noFill/>
-            </p:spPr>
-            <p:txBody>
-              <a:bodyPr wrap="none" rtlCol="0">
-                <a:spAutoFit/>
-              </a:bodyPr>
-              <a:lstStyle/>
-              <a:p>
-                <a:r>
-                  <a:rPr lang="de-DE" b="1">
-                    <a:solidFill>
-                      <a:schemeClr val="tx2">
-                        <a:lumMod val="75000"/>
-                        <a:lumOff val="25000"/>
-                      </a:schemeClr>
-                    </a:solidFill>
-                  </a:rPr>
-                  <a:t>job</a:t>
-                </a:r>
-              </a:p>
-            </p:txBody>
-          </p:sp>
-        </p:grpSp>
-        <p:grpSp>
-          <p:nvGrpSpPr>
-            <p:cNvPr id="25" name="Gruppieren 24">
-              <a:extLst>
-                <a:ext uri="{FF2B5EF4-FFF2-40B4-BE49-F238E27FC236}">
-                  <a16:creationId xmlns:a16="http://schemas.microsoft.com/office/drawing/2014/main" id="{3656935A-914A-3594-2569-CFD4E2974623}"/>
-                </a:ext>
-              </a:extLst>
-            </p:cNvPr>
-            <p:cNvGrpSpPr/>
-            <p:nvPr/>
-          </p:nvGrpSpPr>
-          <p:grpSpPr>
-            <a:xfrm>
-              <a:off x="5389368" y="3182254"/>
-              <a:ext cx="2004894" cy="615297"/>
-              <a:chOff x="4408814" y="5346379"/>
-              <a:chExt cx="824980" cy="615297"/>
-            </a:xfrm>
-          </p:grpSpPr>
-          <p:sp>
-            <p:nvSpPr>
-              <p:cNvPr id="22" name="Pfeil: nach links und rechts 21">
-                <a:extLst>
-                  <a:ext uri="{FF2B5EF4-FFF2-40B4-BE49-F238E27FC236}">
-                    <a16:creationId xmlns:a16="http://schemas.microsoft.com/office/drawing/2014/main" id="{D250BC81-0220-4A80-8B23-D6AF68702081}"/>
-                  </a:ext>
-                </a:extLst>
-              </p:cNvPr>
-              <p:cNvSpPr/>
-              <p:nvPr/>
-            </p:nvSpPr>
-            <p:spPr>
-              <a:xfrm>
-                <a:off x="4408814" y="5346379"/>
-                <a:ext cx="786344" cy="615297"/>
-              </a:xfrm>
-              <a:prstGeom prst="leftRightArrow">
-                <a:avLst/>
-              </a:prstGeom>
-              <a:solidFill>
-                <a:schemeClr val="accent2">
-                  <a:lumMod val="20000"/>
-                  <a:lumOff val="80000"/>
-                </a:schemeClr>
-              </a:solidFill>
-              <a:ln>
-                <a:prstDash val="sysDot"/>
-              </a:ln>
-            </p:spPr>
-            <p:style>
-              <a:lnRef idx="2">
-                <a:schemeClr val="accent1">
-                  <a:shade val="15000"/>
-                </a:schemeClr>
-              </a:lnRef>
-              <a:fillRef idx="1">
-                <a:schemeClr val="accent1"/>
-              </a:fillRef>
-              <a:effectRef idx="0">
-                <a:schemeClr val="accent1"/>
-              </a:effectRef>
-              <a:fontRef idx="minor">
-                <a:schemeClr val="lt1"/>
-              </a:fontRef>
-            </p:style>
-            <p:txBody>
-              <a:bodyPr rtlCol="0" anchor="ctr"/>
-              <a:lstStyle/>
-              <a:p>
-                <a:pPr algn="ctr"/>
-                <a:endParaRPr lang="de-DE"/>
-              </a:p>
-            </p:txBody>
-          </p:sp>
-          <p:sp>
-            <p:nvSpPr>
-              <p:cNvPr id="24" name="Textfeld 23">
-                <a:extLst>
-                  <a:ext uri="{FF2B5EF4-FFF2-40B4-BE49-F238E27FC236}">
-                    <a16:creationId xmlns:a16="http://schemas.microsoft.com/office/drawing/2014/main" id="{B31D5EBB-A89F-35F1-BDFF-4FE0D37A0761}"/>
-                  </a:ext>
-                </a:extLst>
-              </p:cNvPr>
-              <p:cNvSpPr txBox="1"/>
-              <p:nvPr/>
-            </p:nvSpPr>
-            <p:spPr>
-              <a:xfrm>
-                <a:off x="4479908" y="5471494"/>
-                <a:ext cx="753886" cy="369332"/>
-              </a:xfrm>
-              <a:prstGeom prst="rect">
-                <a:avLst/>
-              </a:prstGeom>
-              <a:noFill/>
-            </p:spPr>
-            <p:txBody>
-              <a:bodyPr wrap="square" rtlCol="0">
-                <a:spAutoFit/>
-              </a:bodyPr>
-              <a:lstStyle/>
-              <a:p>
-                <a:r>
-                  <a:rPr lang="de-DE" sz="1600" i="1"/>
-                  <a:t>one-to-one</a:t>
-                </a:r>
-                <a:r>
-                  <a:rPr lang="de-DE" i="1"/>
-                  <a:t> </a:t>
-                </a:r>
-                <a:r>
-                  <a:rPr lang="de-DE" b="1" i="1"/>
-                  <a:t>IPC</a:t>
-                </a:r>
-              </a:p>
-            </p:txBody>
-          </p:sp>
-        </p:grpSp>
-        <p:sp>
-          <p:nvSpPr>
-            <p:cNvPr id="41" name="Rechteck 40">
-              <a:extLst>
-                <a:ext uri="{FF2B5EF4-FFF2-40B4-BE49-F238E27FC236}">
-                  <a16:creationId xmlns:a16="http://schemas.microsoft.com/office/drawing/2014/main" id="{BE488C41-3E39-E95D-85D1-75AE15220CA5}"/>
-                </a:ext>
-              </a:extLst>
-            </p:cNvPr>
-            <p:cNvSpPr/>
-            <p:nvPr/>
-          </p:nvSpPr>
-          <p:spPr>
-            <a:xfrm>
-              <a:off x="2911602" y="2086489"/>
-              <a:ext cx="6254496" cy="2333111"/>
-            </a:xfrm>
-            <a:prstGeom prst="rect">
-              <a:avLst/>
-            </a:prstGeom>
-            <a:noFill/>
-            <a:ln>
-              <a:solidFill>
-                <a:srgbClr val="002060"/>
-              </a:solidFill>
-              <a:prstDash val="dash"/>
-            </a:ln>
-          </p:spPr>
-          <p:style>
-            <a:lnRef idx="2">
-              <a:schemeClr val="accent1">
-                <a:shade val="15000"/>
-              </a:schemeClr>
-            </a:lnRef>
-            <a:fillRef idx="1">
-              <a:schemeClr val="accent1"/>
-            </a:fillRef>
-            <a:effectRef idx="0">
-              <a:schemeClr val="accent1"/>
-            </a:effectRef>
-            <a:fontRef idx="minor">
-              <a:schemeClr val="lt1"/>
-            </a:fontRef>
-          </p:style>
-          <p:txBody>
-            <a:bodyPr rtlCol="0" anchor="ctr"/>
-            <a:lstStyle/>
-            <a:p>
-              <a:pPr algn="ctr"/>
-              <a:endParaRPr lang="de-DE"/>
-            </a:p>
-          </p:txBody>
-        </p:sp>
-        <p:sp>
-          <p:nvSpPr>
-            <p:cNvPr id="42" name="Textfeld 41">
-              <a:extLst>
-                <a:ext uri="{FF2B5EF4-FFF2-40B4-BE49-F238E27FC236}">
-                  <a16:creationId xmlns:a16="http://schemas.microsoft.com/office/drawing/2014/main" id="{6860F192-A780-ACF2-B447-DBCED6349946}"/>
-                </a:ext>
-              </a:extLst>
-            </p:cNvPr>
-            <p:cNvSpPr txBox="1"/>
-            <p:nvPr/>
-          </p:nvSpPr>
-          <p:spPr>
-            <a:xfrm>
-              <a:off x="3396234" y="1931041"/>
-              <a:ext cx="5369868" cy="307777"/>
-            </a:xfrm>
-            <a:prstGeom prst="rect">
-              <a:avLst/>
-            </a:prstGeom>
-            <a:solidFill>
-              <a:schemeClr val="bg1"/>
-            </a:solidFill>
-          </p:spPr>
-          <p:txBody>
-            <a:bodyPr wrap="none" rtlCol="0">
-              <a:spAutoFit/>
-            </a:bodyPr>
-            <a:lstStyle/>
-            <a:p>
-              <a:r>
-                <a:rPr lang="de-DE" sz="1400" b="1">
-                  <a:solidFill>
-                    <a:srgbClr val="002060"/>
-                  </a:solidFill>
-                </a:rPr>
-                <a:t>one </a:t>
-              </a:r>
-              <a:r>
-                <a:rPr lang="de-DE" sz="1400" b="1" i="1">
-                  <a:solidFill>
-                    <a:srgbClr val="002060"/>
-                  </a:solidFill>
-                </a:rPr>
-                <a:t>logical</a:t>
-              </a:r>
-              <a:r>
-                <a:rPr lang="de-DE" sz="1400" b="1">
-                  <a:solidFill>
-                    <a:srgbClr val="002060"/>
-                  </a:solidFill>
-                </a:rPr>
-                <a:t> job-session-process in two </a:t>
-              </a:r>
-              <a:r>
-                <a:rPr lang="de-DE" sz="1400" b="1" i="1">
-                  <a:solidFill>
-                    <a:srgbClr val="002060"/>
-                  </a:solidFill>
-                </a:rPr>
-                <a:t>physical</a:t>
-              </a:r>
-              <a:r>
-                <a:rPr lang="de-DE" sz="1400" b="1">
-                  <a:solidFill>
-                    <a:srgbClr val="002060"/>
-                  </a:solidFill>
-                </a:rPr>
-                <a:t> process-spaces</a:t>
-              </a:r>
-            </a:p>
-          </p:txBody>
-        </p:sp>
-        <p:sp>
-          <p:nvSpPr>
-            <p:cNvPr id="54" name="Textfeld 53">
-              <a:extLst>
-                <a:ext uri="{FF2B5EF4-FFF2-40B4-BE49-F238E27FC236}">
-                  <a16:creationId xmlns:a16="http://schemas.microsoft.com/office/drawing/2014/main" id="{35339789-9892-8B3C-0986-3CE07F4F5B0F}"/>
-                </a:ext>
-              </a:extLst>
-            </p:cNvPr>
-            <p:cNvSpPr txBox="1"/>
-            <p:nvPr/>
-          </p:nvSpPr>
-          <p:spPr>
-            <a:xfrm>
-              <a:off x="8531784" y="3941718"/>
-              <a:ext cx="409133" cy="215444"/>
-            </a:xfrm>
-            <a:prstGeom prst="rect">
-              <a:avLst/>
-            </a:prstGeom>
-            <a:solidFill>
-              <a:srgbClr val="FFFF99"/>
-            </a:solidFill>
-            <a:ln>
-              <a:solidFill>
-                <a:schemeClr val="tx1"/>
-              </a:solidFill>
-            </a:ln>
-          </p:spPr>
-          <p:txBody>
-            <a:bodyPr wrap="none" lIns="72000" tIns="0" rIns="72000" bIns="0" rtlCol="0">
-              <a:spAutoFit/>
-            </a:bodyPr>
-            <a:lstStyle/>
-            <a:p>
-              <a:r>
-                <a:rPr lang="de-DE" sz="1400" i="1"/>
-                <a:t>exe</a:t>
-              </a:r>
-            </a:p>
-          </p:txBody>
-        </p:sp>
-        <p:grpSp>
-          <p:nvGrpSpPr>
-            <p:cNvPr id="45" name="Gruppieren 44">
-              <a:extLst>
-                <a:ext uri="{FF2B5EF4-FFF2-40B4-BE49-F238E27FC236}">
-                  <a16:creationId xmlns:a16="http://schemas.microsoft.com/office/drawing/2014/main" id="{D7D6D2AD-63E5-9095-4FC5-2C10252C76EB}"/>
-                </a:ext>
-              </a:extLst>
-            </p:cNvPr>
-            <p:cNvGrpSpPr/>
-            <p:nvPr/>
-          </p:nvGrpSpPr>
-          <p:grpSpPr>
-            <a:xfrm>
-              <a:off x="3535617" y="3049876"/>
-              <a:ext cx="1780191" cy="791538"/>
-              <a:chOff x="798604" y="351742"/>
-              <a:chExt cx="1780191" cy="791538"/>
-            </a:xfrm>
-          </p:grpSpPr>
-          <p:sp>
-            <p:nvSpPr>
-              <p:cNvPr id="30" name="Rechteck 29">
-                <a:extLst>
-                  <a:ext uri="{FF2B5EF4-FFF2-40B4-BE49-F238E27FC236}">
-                    <a16:creationId xmlns:a16="http://schemas.microsoft.com/office/drawing/2014/main" id="{2A5786B1-3FB4-0E22-8DA1-DBDDF5C888CC}"/>
-                  </a:ext>
-                </a:extLst>
-              </p:cNvPr>
-              <p:cNvSpPr/>
-              <p:nvPr/>
-            </p:nvSpPr>
-            <p:spPr>
-              <a:xfrm>
-                <a:off x="814720" y="378232"/>
-                <a:ext cx="1764075" cy="765048"/>
-              </a:xfrm>
-              <a:prstGeom prst="rect">
-                <a:avLst/>
-              </a:prstGeom>
-              <a:solidFill>
-                <a:schemeClr val="tx2">
-                  <a:lumMod val="10000"/>
-                  <a:lumOff val="90000"/>
-                </a:schemeClr>
-              </a:solidFill>
-              <a:ln>
-                <a:solidFill>
-                  <a:srgbClr val="7030A0"/>
-                </a:solidFill>
-              </a:ln>
-            </p:spPr>
-            <p:style>
-              <a:lnRef idx="2">
-                <a:schemeClr val="accent1">
-                  <a:shade val="15000"/>
-                </a:schemeClr>
-              </a:lnRef>
-              <a:fillRef idx="1">
-                <a:schemeClr val="accent1"/>
-              </a:fillRef>
-              <a:effectRef idx="0">
-                <a:schemeClr val="accent1"/>
-              </a:effectRef>
-              <a:fontRef idx="minor">
-                <a:schemeClr val="lt1"/>
-              </a:fontRef>
-            </p:style>
-            <p:txBody>
-              <a:bodyPr rtlCol="0" anchor="ctr"/>
-              <a:lstStyle/>
-              <a:p>
-                <a:pPr algn="ctr"/>
-                <a:endParaRPr lang="de-DE"/>
-              </a:p>
-            </p:txBody>
-          </p:sp>
-          <p:sp>
-            <p:nvSpPr>
-              <p:cNvPr id="29" name="Textfeld 28">
-                <a:extLst>
-                  <a:ext uri="{FF2B5EF4-FFF2-40B4-BE49-F238E27FC236}">
-                    <a16:creationId xmlns:a16="http://schemas.microsoft.com/office/drawing/2014/main" id="{3610DF32-87F5-5383-6DF3-1DE9594680FB}"/>
-                  </a:ext>
-                </a:extLst>
-              </p:cNvPr>
-              <p:cNvSpPr txBox="1"/>
-              <p:nvPr/>
-            </p:nvSpPr>
-            <p:spPr>
-              <a:xfrm>
-                <a:off x="798604" y="351742"/>
-                <a:ext cx="1757725" cy="553998"/>
-              </a:xfrm>
-              <a:prstGeom prst="rect">
-                <a:avLst/>
-              </a:prstGeom>
-              <a:noFill/>
-            </p:spPr>
-            <p:txBody>
-              <a:bodyPr wrap="none" rtlCol="0">
-                <a:spAutoFit/>
-              </a:bodyPr>
-              <a:lstStyle/>
-              <a:p>
-                <a:r>
-                  <a:rPr lang="de-DE" b="1"/>
-                  <a:t>session-broker</a:t>
-                </a:r>
-              </a:p>
-              <a:p>
-                <a:r>
-                  <a:rPr lang="de-DE" sz="1200"/>
-                  <a:t>(</a:t>
-                </a:r>
-                <a:r>
-                  <a:rPr lang="de-DE" sz="1200" i="1"/>
-                  <a:t>jap</a:t>
-                </a:r>
-                <a:r>
-                  <a:rPr lang="de-DE" sz="1200"/>
-                  <a:t>-server)</a:t>
-                </a:r>
-              </a:p>
-            </p:txBody>
-          </p:sp>
-          <p:sp>
-            <p:nvSpPr>
-              <p:cNvPr id="53" name="Textfeld 52">
-                <a:extLst>
-                  <a:ext uri="{FF2B5EF4-FFF2-40B4-BE49-F238E27FC236}">
-                    <a16:creationId xmlns:a16="http://schemas.microsoft.com/office/drawing/2014/main" id="{1D7ECD08-4890-EEC5-6F3A-A6FCD2CC016F}"/>
-                  </a:ext>
-                </a:extLst>
-              </p:cNvPr>
-              <p:cNvSpPr txBox="1"/>
-              <p:nvPr/>
-            </p:nvSpPr>
-            <p:spPr>
-              <a:xfrm>
-                <a:off x="2082650" y="855775"/>
-                <a:ext cx="409133" cy="215444"/>
-              </a:xfrm>
-              <a:prstGeom prst="rect">
-                <a:avLst/>
-              </a:prstGeom>
-              <a:solidFill>
-                <a:srgbClr val="FFFF99"/>
-              </a:solidFill>
-              <a:ln>
-                <a:solidFill>
-                  <a:schemeClr val="tx1"/>
-                </a:solidFill>
-              </a:ln>
-            </p:spPr>
-            <p:txBody>
-              <a:bodyPr wrap="none" lIns="72000" tIns="0" rIns="72000" bIns="0" rtlCol="0">
-                <a:spAutoFit/>
-              </a:bodyPr>
-              <a:lstStyle/>
-              <a:p>
-                <a:r>
-                  <a:rPr lang="de-DE" sz="1400" i="1"/>
-                  <a:t>exe</a:t>
-                </a:r>
-              </a:p>
-            </p:txBody>
-          </p:sp>
-        </p:grpSp>
-        <p:grpSp>
-          <p:nvGrpSpPr>
-            <p:cNvPr id="35" name="Gruppieren 34">
-              <a:extLst>
-                <a:ext uri="{FF2B5EF4-FFF2-40B4-BE49-F238E27FC236}">
-                  <a16:creationId xmlns:a16="http://schemas.microsoft.com/office/drawing/2014/main" id="{AF4BA5D2-C1EB-D6DF-7D31-767359EF3A5F}"/>
-                </a:ext>
-              </a:extLst>
-            </p:cNvPr>
-            <p:cNvGrpSpPr/>
-            <p:nvPr/>
-          </p:nvGrpSpPr>
-          <p:grpSpPr>
-            <a:xfrm>
-              <a:off x="7389405" y="3049876"/>
-              <a:ext cx="1485126" cy="830997"/>
-              <a:chOff x="482782" y="1498463"/>
-              <a:chExt cx="1485126" cy="830997"/>
-            </a:xfrm>
-          </p:grpSpPr>
-          <p:sp>
-            <p:nvSpPr>
-              <p:cNvPr id="31" name="Rechteck 30">
-                <a:extLst>
-                  <a:ext uri="{FF2B5EF4-FFF2-40B4-BE49-F238E27FC236}">
-                    <a16:creationId xmlns:a16="http://schemas.microsoft.com/office/drawing/2014/main" id="{78C8DC7B-384F-04A5-6923-880D90B4157B}"/>
-                  </a:ext>
-                </a:extLst>
-              </p:cNvPr>
-              <p:cNvSpPr/>
-              <p:nvPr/>
-            </p:nvSpPr>
-            <p:spPr>
-              <a:xfrm>
-                <a:off x="495724" y="1524953"/>
-                <a:ext cx="1472184" cy="765048"/>
-              </a:xfrm>
-              <a:prstGeom prst="rect">
-                <a:avLst/>
-              </a:prstGeom>
-              <a:solidFill>
-                <a:schemeClr val="tx2">
-                  <a:lumMod val="10000"/>
-                  <a:lumOff val="90000"/>
-                </a:schemeClr>
-              </a:solidFill>
-              <a:ln>
-                <a:solidFill>
-                  <a:schemeClr val="tx2">
-                    <a:lumMod val="75000"/>
-                    <a:lumOff val="25000"/>
-                  </a:schemeClr>
-                </a:solidFill>
-              </a:ln>
-            </p:spPr>
-            <p:style>
-              <a:lnRef idx="2">
-                <a:schemeClr val="accent1">
-                  <a:shade val="15000"/>
-                </a:schemeClr>
-              </a:lnRef>
-              <a:fillRef idx="1">
-                <a:schemeClr val="accent1"/>
-              </a:fillRef>
-              <a:effectRef idx="0">
-                <a:schemeClr val="accent1"/>
-              </a:effectRef>
-              <a:fontRef idx="minor">
-                <a:schemeClr val="lt1"/>
-              </a:fontRef>
-            </p:style>
-            <p:txBody>
-              <a:bodyPr rtlCol="0" anchor="ctr"/>
-              <a:lstStyle/>
-              <a:p>
-                <a:pPr algn="ctr"/>
-                <a:endParaRPr lang="de-DE"/>
-              </a:p>
-            </p:txBody>
-          </p:sp>
-          <p:sp>
-            <p:nvSpPr>
-              <p:cNvPr id="32" name="Textfeld 31">
-                <a:extLst>
-                  <a:ext uri="{FF2B5EF4-FFF2-40B4-BE49-F238E27FC236}">
-                    <a16:creationId xmlns:a16="http://schemas.microsoft.com/office/drawing/2014/main" id="{65513305-956F-6658-DBD8-D938D088654B}"/>
-                  </a:ext>
-                </a:extLst>
-              </p:cNvPr>
-              <p:cNvSpPr txBox="1"/>
-              <p:nvPr/>
-            </p:nvSpPr>
-            <p:spPr>
-              <a:xfrm>
-                <a:off x="482782" y="1498463"/>
-                <a:ext cx="1057982" cy="830997"/>
-              </a:xfrm>
-              <a:prstGeom prst="rect">
-                <a:avLst/>
-              </a:prstGeom>
-              <a:noFill/>
-            </p:spPr>
-            <p:txBody>
-              <a:bodyPr wrap="none" rtlCol="0">
-                <a:spAutoFit/>
-              </a:bodyPr>
-              <a:lstStyle/>
-              <a:p>
-                <a:r>
-                  <a:rPr lang="de-DE" b="1">
-                    <a:solidFill>
-                      <a:schemeClr val="tx2">
-                        <a:lumMod val="75000"/>
-                        <a:lumOff val="25000"/>
-                      </a:schemeClr>
-                    </a:solidFill>
-                  </a:rPr>
-                  <a:t>job-host</a:t>
-                </a:r>
-              </a:p>
-              <a:p>
-                <a:r>
-                  <a:rPr lang="de-DE" sz="1200"/>
-                  <a:t>(</a:t>
-                </a:r>
-                <a:r>
-                  <a:rPr lang="de-DE" sz="1200" i="1"/>
-                  <a:t>jap</a:t>
-                </a:r>
-                <a:r>
-                  <a:rPr lang="de-DE" sz="1200"/>
-                  <a:t>-client)</a:t>
-                </a:r>
-              </a:p>
-              <a:p>
-                <a:endParaRPr lang="de-DE" b="1">
-                  <a:solidFill>
-                    <a:schemeClr val="tx2">
-                      <a:lumMod val="75000"/>
-                      <a:lumOff val="25000"/>
-                    </a:schemeClr>
-                  </a:solidFill>
-                </a:endParaRPr>
-              </a:p>
-            </p:txBody>
-          </p:sp>
-          <p:sp>
-            <p:nvSpPr>
-              <p:cNvPr id="34" name="Textfeld 33">
-                <a:extLst>
-                  <a:ext uri="{FF2B5EF4-FFF2-40B4-BE49-F238E27FC236}">
-                    <a16:creationId xmlns:a16="http://schemas.microsoft.com/office/drawing/2014/main" id="{8E3B4212-D8F9-751B-2BDE-F0766AF188FC}"/>
-                  </a:ext>
-                </a:extLst>
-              </p:cNvPr>
-              <p:cNvSpPr txBox="1"/>
-              <p:nvPr/>
-            </p:nvSpPr>
-            <p:spPr>
-              <a:xfrm>
-                <a:off x="1332488" y="2003766"/>
-                <a:ext cx="580077" cy="215444"/>
-              </a:xfrm>
-              <a:prstGeom prst="rect">
-                <a:avLst/>
-              </a:prstGeom>
-              <a:solidFill>
-                <a:srgbClr val="FFFF99"/>
-              </a:solidFill>
-              <a:ln>
-                <a:solidFill>
-                  <a:schemeClr val="tx1"/>
-                </a:solidFill>
-              </a:ln>
-            </p:spPr>
-            <p:txBody>
-              <a:bodyPr wrap="none" lIns="72000" tIns="0" rIns="72000" bIns="0" rtlCol="0">
-                <a:spAutoFit/>
-              </a:bodyPr>
-              <a:lstStyle/>
-              <a:p>
-                <a:r>
-                  <a:rPr lang="de-DE" sz="1400" i="1"/>
-                  <a:t>nuget</a:t>
-                </a:r>
-              </a:p>
-            </p:txBody>
-          </p:sp>
-        </p:grpSp>
-      </p:grpSp>
+          <a:prstGeom prst="rect">
+            <a:avLst/>
+          </a:prstGeom>
+        </p:spPr>
+      </p:pic>
       <p:sp>
         <p:nvSpPr>
-          <p:cNvPr id="2" name="Textfeld 1">
+          <p:cNvPr id="6" name="Textfeld 5">
             <a:extLst>
               <a:ext uri="{FF2B5EF4-FFF2-40B4-BE49-F238E27FC236}">
-                <a16:creationId xmlns:a16="http://schemas.microsoft.com/office/drawing/2014/main" id="{519E1644-DBCE-0EF7-8B66-ED2E10EBBA6F}"/>
+                <a16:creationId xmlns:a16="http://schemas.microsoft.com/office/drawing/2014/main" id="{1771435A-28CC-0BC5-E688-10722769B9DF}"/>
               </a:ext>
             </a:extLst>
           </p:cNvPr>
@@ -18438,8 +19007,8 @@
         </p:nvSpPr>
         <p:spPr>
           <a:xfrm>
-            <a:off x="3393373" y="306209"/>
-            <a:ext cx="5052923" cy="523220"/>
+            <a:off x="3448050" y="228600"/>
+            <a:ext cx="4613955" cy="369332"/>
           </a:xfrm>
           <a:prstGeom prst="rect">
             <a:avLst/>
@@ -18452,266 +19021,9 @@
           </a:bodyPr>
           <a:lstStyle/>
           <a:p>
-            <a:pPr algn="ctr"/>
-            <a:r>
-              <a:rPr lang="de-DE" sz="2800" b="1" i="1">
-                <a:solidFill>
-                  <a:srgbClr val="002060"/>
-                </a:solidFill>
-              </a:rPr>
-              <a:t>Proposal</a:t>
-            </a:r>
-            <a:r>
-              <a:rPr lang="de-DE" sz="2800" b="1"/>
-              <a:t> für das Kernproblem</a:t>
-            </a:r>
-            <a:endParaRPr lang="de-DE" b="1"/>
-          </a:p>
-        </p:txBody>
-      </p:sp>
-      <p:sp>
-        <p:nvSpPr>
-          <p:cNvPr id="5" name="Textfeld 4">
-            <a:extLst>
-              <a:ext uri="{FF2B5EF4-FFF2-40B4-BE49-F238E27FC236}">
-                <a16:creationId xmlns:a16="http://schemas.microsoft.com/office/drawing/2014/main" id="{31B0DD6C-1959-F561-62A6-4A45090DC6D2}"/>
-              </a:ext>
-            </a:extLst>
-          </p:cNvPr>
-          <p:cNvSpPr txBox="1"/>
-          <p:nvPr/>
-        </p:nvSpPr>
-        <p:spPr>
-          <a:xfrm>
-            <a:off x="1824755" y="4024158"/>
-            <a:ext cx="8418755" cy="954107"/>
-          </a:xfrm>
-          <a:prstGeom prst="rect">
-            <a:avLst/>
-          </a:prstGeom>
-          <a:noFill/>
-        </p:spPr>
-        <p:txBody>
-          <a:bodyPr wrap="square">
-            <a:spAutoFit/>
-          </a:bodyPr>
-          <a:lstStyle/>
-          <a:p>
-            <a:endParaRPr lang="de-DE" sz="800"/>
-          </a:p>
-          <a:p>
-            <a:pPr marL="171450" indent="-171450">
-              <a:buFont typeface="Arial" panose="020B0604020202020204" pitchFamily="34" charset="0"/>
-              <a:buChar char="•"/>
-            </a:pPr>
-            <a:r>
-              <a:rPr lang="de-DE" sz="1600"/>
-              <a:t>Trennung in zwei Prozessräume</a:t>
-            </a:r>
-          </a:p>
-          <a:p>
-            <a:pPr marL="171450" indent="-171450">
-              <a:buFont typeface="Arial" panose="020B0604020202020204" pitchFamily="34" charset="0"/>
-              <a:buChar char="•"/>
-            </a:pPr>
-            <a:r>
-              <a:rPr lang="de-DE" sz="1600"/>
-              <a:t>System.IO.Pipes (als Named-Pipes bzw. Unix-Domain-Sockets)</a:t>
-            </a:r>
-          </a:p>
-          <a:p>
-            <a:pPr marL="171450" indent="-171450">
-              <a:buFont typeface="Arial" panose="020B0604020202020204" pitchFamily="34" charset="0"/>
-              <a:buChar char="•"/>
-            </a:pPr>
-            <a:r>
-              <a:rPr lang="de-DE" sz="1600" b="1">
-                <a:solidFill>
-                  <a:srgbClr val="0070C0"/>
-                </a:solidFill>
-              </a:rPr>
-              <a:t>Schaffung eines leichtgewichtigen </a:t>
-            </a:r>
-            <a:r>
-              <a:rPr lang="de-DE" sz="1600" b="1" i="1">
-                <a:solidFill>
-                  <a:srgbClr val="0070C0"/>
-                </a:solidFill>
-              </a:rPr>
-              <a:t>one-to-one-IPC-Application-Protocols</a:t>
-            </a:r>
-            <a:r>
-              <a:rPr lang="de-DE" sz="1600" b="1">
-                <a:solidFill>
-                  <a:srgbClr val="0070C0"/>
-                </a:solidFill>
-              </a:rPr>
-              <a:t>. (JAP)</a:t>
-            </a:r>
-          </a:p>
-        </p:txBody>
-      </p:sp>
-      <p:sp>
-        <p:nvSpPr>
-          <p:cNvPr id="14" name="Textfeld 13">
-            <a:extLst>
-              <a:ext uri="{FF2B5EF4-FFF2-40B4-BE49-F238E27FC236}">
-                <a16:creationId xmlns:a16="http://schemas.microsoft.com/office/drawing/2014/main" id="{7E5349DD-7736-0A81-1AC6-477997C0DE28}"/>
-              </a:ext>
-            </a:extLst>
-          </p:cNvPr>
-          <p:cNvSpPr txBox="1"/>
-          <p:nvPr/>
-        </p:nvSpPr>
-        <p:spPr>
-          <a:xfrm>
-            <a:off x="1851449" y="5774811"/>
-            <a:ext cx="9126537" cy="646331"/>
-          </a:xfrm>
-          <a:prstGeom prst="rect">
-            <a:avLst/>
-          </a:prstGeom>
-          <a:noFill/>
-        </p:spPr>
-        <p:txBody>
-          <a:bodyPr wrap="square">
-            <a:spAutoFit/>
-          </a:bodyPr>
-          <a:lstStyle/>
-          <a:p>
             <a:r>
               <a:rPr lang="de-DE" b="1"/>
-              <a:t>Wir bekommen</a:t>
-            </a:r>
-            <a:r>
-              <a:rPr lang="de-DE" b="1">
-                <a:solidFill>
-                  <a:srgbClr val="0070C0"/>
-                </a:solidFill>
-              </a:rPr>
-              <a:t> zwei</a:t>
-            </a:r>
-            <a:r>
-              <a:rPr lang="de-DE" b="1"/>
-              <a:t> logisch, technologisch und architekturell getrennte </a:t>
-            </a:r>
-            <a:r>
-              <a:rPr lang="de-DE" b="1" i="1">
-                <a:solidFill>
-                  <a:srgbClr val="0070C0"/>
-                </a:solidFill>
-              </a:rPr>
-              <a:t>Domänen</a:t>
-            </a:r>
-            <a:r>
-              <a:rPr lang="de-DE" b="1" i="1"/>
-              <a:t>…</a:t>
-            </a:r>
-          </a:p>
-          <a:p>
-            <a:r>
-              <a:rPr lang="de-DE"/>
-              <a:t>(…mit einer leichtgewichtige Kopplung über das </a:t>
-            </a:r>
-            <a:r>
-              <a:rPr lang="de-DE" b="1"/>
-              <a:t>JAP-Protokoll</a:t>
-            </a:r>
-            <a:r>
-              <a:rPr lang="de-DE"/>
-              <a:t>… )</a:t>
-            </a:r>
-          </a:p>
-        </p:txBody>
-      </p:sp>
-      <p:sp>
-        <p:nvSpPr>
-          <p:cNvPr id="9" name="Textfeld 8">
-            <a:extLst>
-              <a:ext uri="{FF2B5EF4-FFF2-40B4-BE49-F238E27FC236}">
-                <a16:creationId xmlns:a16="http://schemas.microsoft.com/office/drawing/2014/main" id="{F8C6DEE4-170E-61FC-5510-46EBF737CCF9}"/>
-              </a:ext>
-            </a:extLst>
-          </p:cNvPr>
-          <p:cNvSpPr txBox="1"/>
-          <p:nvPr/>
-        </p:nvSpPr>
-        <p:spPr>
-          <a:xfrm>
-            <a:off x="1853020" y="3460782"/>
-            <a:ext cx="9288463" cy="646331"/>
-          </a:xfrm>
-          <a:prstGeom prst="rect">
-            <a:avLst/>
-          </a:prstGeom>
-          <a:noFill/>
-        </p:spPr>
-        <p:txBody>
-          <a:bodyPr wrap="square">
-            <a:spAutoFit/>
-          </a:bodyPr>
-          <a:lstStyle/>
-          <a:p>
-            <a:r>
-              <a:rPr lang="de-DE" sz="1800"/>
-              <a:t>Die Grundidee </a:t>
-            </a:r>
-            <a:r>
-              <a:rPr lang="de-DE" sz="1800" i="1"/>
-              <a:t>„decpoupling and isolation by spawning another process“</a:t>
-            </a:r>
-            <a:r>
-              <a:rPr lang="de-DE" sz="1800"/>
-              <a:t> wird nicht verworfen, sondern konsequent weitergeführt und „richtig implementiert:</a:t>
-            </a:r>
-          </a:p>
-        </p:txBody>
-      </p:sp>
-      <p:sp>
-        <p:nvSpPr>
-          <p:cNvPr id="11" name="Textfeld 10">
-            <a:extLst>
-              <a:ext uri="{FF2B5EF4-FFF2-40B4-BE49-F238E27FC236}">
-                <a16:creationId xmlns:a16="http://schemas.microsoft.com/office/drawing/2014/main" id="{E80A37DA-2AFA-6576-2076-87CB4BA793B6}"/>
-              </a:ext>
-            </a:extLst>
-          </p:cNvPr>
-          <p:cNvSpPr txBox="1"/>
-          <p:nvPr/>
-        </p:nvSpPr>
-        <p:spPr>
-          <a:xfrm>
-            <a:off x="1850155" y="5086947"/>
-            <a:ext cx="8534401" cy="646331"/>
-          </a:xfrm>
-          <a:prstGeom prst="rect">
-            <a:avLst/>
-          </a:prstGeom>
-          <a:noFill/>
-        </p:spPr>
-        <p:txBody>
-          <a:bodyPr wrap="square">
-            <a:spAutoFit/>
-          </a:bodyPr>
-          <a:lstStyle/>
-          <a:p>
-            <a:r>
-              <a:rPr lang="de-DE"/>
-              <a:t>Starke und nachhaltige Entkopplung (- nicht nur </a:t>
-            </a:r>
-            <a:r>
-              <a:rPr lang="de-DE" i="1"/>
-              <a:t>zur Runtime im Prozessraum</a:t>
-            </a:r>
-            <a:r>
-              <a:rPr lang="de-DE"/>
-              <a:t>!)</a:t>
-            </a:r>
-          </a:p>
-          <a:p>
-            <a:r>
-              <a:rPr lang="de-DE"/>
-              <a:t>Auf einer Maschine - unterhalb des Netzwerkstacks (keine Firewall, etc.)</a:t>
+              <a:t>Erster Wurf für strukturierte Requirements</a:t>
             </a:r>
           </a:p>
         </p:txBody>
@@ -18719,229 +19031,13 @@
     </p:spTree>
     <p:extLst>
       <p:ext uri="{BB962C8B-B14F-4D97-AF65-F5344CB8AC3E}">
-        <p14:creationId xmlns:p14="http://schemas.microsoft.com/office/powerpoint/2010/main" val="497310861"/>
+        <p14:creationId xmlns:p14="http://schemas.microsoft.com/office/powerpoint/2010/main" val="465905416"/>
       </p:ext>
     </p:extLst>
   </p:cSld>
   <p:clrMapOvr>
     <a:masterClrMapping/>
   </p:clrMapOvr>
-  <p:timing>
-    <p:tnLst>
-      <p:par>
-        <p:cTn id="1" dur="indefinite" restart="never" nodeType="tmRoot">
-          <p:childTnLst>
-            <p:seq concurrent="1" nextAc="seek">
-              <p:cTn id="2" dur="indefinite" nodeType="mainSeq">
-                <p:childTnLst>
-                  <p:par>
-                    <p:cTn id="3" fill="hold">
-                      <p:stCondLst>
-                        <p:cond delay="indefinite"/>
-                      </p:stCondLst>
-                      <p:childTnLst>
-                        <p:par>
-                          <p:cTn id="4" fill="hold">
-                            <p:stCondLst>
-                              <p:cond delay="0"/>
-                            </p:stCondLst>
-                            <p:childTnLst>
-                              <p:par>
-                                <p:cTn id="5" presetID="1" presetClass="entr" presetSubtype="0" fill="hold" grpId="0" nodeType="clickEffect">
-                                  <p:stCondLst>
-                                    <p:cond delay="0"/>
-                                  </p:stCondLst>
-                                  <p:childTnLst>
-                                    <p:set>
-                                      <p:cBhvr>
-                                        <p:cTn id="6" dur="1" fill="hold">
-                                          <p:stCondLst>
-                                            <p:cond delay="0"/>
-                                          </p:stCondLst>
-                                        </p:cTn>
-                                        <p:tgtEl>
-                                          <p:spTgt spid="9"/>
-                                        </p:tgtEl>
-                                        <p:attrNameLst>
-                                          <p:attrName>style.visibility</p:attrName>
-                                        </p:attrNameLst>
-                                      </p:cBhvr>
-                                      <p:to>
-                                        <p:strVal val="visible"/>
-                                      </p:to>
-                                    </p:set>
-                                  </p:childTnLst>
-                                </p:cTn>
-                              </p:par>
-                            </p:childTnLst>
-                          </p:cTn>
-                        </p:par>
-                      </p:childTnLst>
-                    </p:cTn>
-                  </p:par>
-                  <p:par>
-                    <p:cTn id="7" fill="hold">
-                      <p:stCondLst>
-                        <p:cond delay="indefinite"/>
-                      </p:stCondLst>
-                      <p:childTnLst>
-                        <p:par>
-                          <p:cTn id="8" fill="hold">
-                            <p:stCondLst>
-                              <p:cond delay="0"/>
-                            </p:stCondLst>
-                            <p:childTnLst>
-                              <p:par>
-                                <p:cTn id="9" presetID="1" presetClass="entr" presetSubtype="0" fill="hold" grpId="0" nodeType="clickEffect">
-                                  <p:stCondLst>
-                                    <p:cond delay="0"/>
-                                  </p:stCondLst>
-                                  <p:childTnLst>
-                                    <p:set>
-                                      <p:cBhvr>
-                                        <p:cTn id="10" dur="1" fill="hold">
-                                          <p:stCondLst>
-                                            <p:cond delay="0"/>
-                                          </p:stCondLst>
-                                        </p:cTn>
-                                        <p:tgtEl>
-                                          <p:spTgt spid="5"/>
-                                        </p:tgtEl>
-                                        <p:attrNameLst>
-                                          <p:attrName>style.visibility</p:attrName>
-                                        </p:attrNameLst>
-                                      </p:cBhvr>
-                                      <p:to>
-                                        <p:strVal val="visible"/>
-                                      </p:to>
-                                    </p:set>
-                                  </p:childTnLst>
-                                </p:cTn>
-                              </p:par>
-                            </p:childTnLst>
-                          </p:cTn>
-                        </p:par>
-                      </p:childTnLst>
-                    </p:cTn>
-                  </p:par>
-                  <p:par>
-                    <p:cTn id="11" fill="hold">
-                      <p:stCondLst>
-                        <p:cond delay="indefinite"/>
-                      </p:stCondLst>
-                      <p:childTnLst>
-                        <p:par>
-                          <p:cTn id="12" fill="hold">
-                            <p:stCondLst>
-                              <p:cond delay="0"/>
-                            </p:stCondLst>
-                            <p:childTnLst>
-                              <p:par>
-                                <p:cTn id="13" presetID="1" presetClass="entr" presetSubtype="0" fill="hold" grpId="0" nodeType="clickEffect">
-                                  <p:stCondLst>
-                                    <p:cond delay="0"/>
-                                  </p:stCondLst>
-                                  <p:childTnLst>
-                                    <p:set>
-                                      <p:cBhvr>
-                                        <p:cTn id="14" dur="1" fill="hold">
-                                          <p:stCondLst>
-                                            <p:cond delay="0"/>
-                                          </p:stCondLst>
-                                        </p:cTn>
-                                        <p:tgtEl>
-                                          <p:spTgt spid="11"/>
-                                        </p:tgtEl>
-                                        <p:attrNameLst>
-                                          <p:attrName>style.visibility</p:attrName>
-                                        </p:attrNameLst>
-                                      </p:cBhvr>
-                                      <p:to>
-                                        <p:strVal val="visible"/>
-                                      </p:to>
-                                    </p:set>
-                                  </p:childTnLst>
-                                </p:cTn>
-                              </p:par>
-                            </p:childTnLst>
-                          </p:cTn>
-                        </p:par>
-                      </p:childTnLst>
-                    </p:cTn>
-                  </p:par>
-                  <p:par>
-                    <p:cTn id="15" fill="hold">
-                      <p:stCondLst>
-                        <p:cond delay="indefinite"/>
-                      </p:stCondLst>
-                      <p:childTnLst>
-                        <p:par>
-                          <p:cTn id="16" fill="hold">
-                            <p:stCondLst>
-                              <p:cond delay="0"/>
-                            </p:stCondLst>
-                            <p:childTnLst>
-                              <p:par>
-                                <p:cTn id="17" presetID="1" presetClass="entr" presetSubtype="0" fill="hold" grpId="0" nodeType="clickEffect">
-                                  <p:stCondLst>
-                                    <p:cond delay="0"/>
-                                  </p:stCondLst>
-                                  <p:childTnLst>
-                                    <p:set>
-                                      <p:cBhvr>
-                                        <p:cTn id="18" dur="1" fill="hold">
-                                          <p:stCondLst>
-                                            <p:cond delay="0"/>
-                                          </p:stCondLst>
-                                        </p:cTn>
-                                        <p:tgtEl>
-                                          <p:spTgt spid="14"/>
-                                        </p:tgtEl>
-                                        <p:attrNameLst>
-                                          <p:attrName>style.visibility</p:attrName>
-                                        </p:attrNameLst>
-                                      </p:cBhvr>
-                                      <p:to>
-                                        <p:strVal val="visible"/>
-                                      </p:to>
-                                    </p:set>
-                                  </p:childTnLst>
-                                </p:cTn>
-                              </p:par>
-                            </p:childTnLst>
-                          </p:cTn>
-                        </p:par>
-                      </p:childTnLst>
-                    </p:cTn>
-                  </p:par>
-                </p:childTnLst>
-              </p:cTn>
-              <p:prevCondLst>
-                <p:cond evt="onPrev" delay="0">
-                  <p:tgtEl>
-                    <p:sldTgt/>
-                  </p:tgtEl>
-                </p:cond>
-              </p:prevCondLst>
-              <p:nextCondLst>
-                <p:cond evt="onNext" delay="0">
-                  <p:tgtEl>
-                    <p:sldTgt/>
-                  </p:tgtEl>
-                </p:cond>
-              </p:nextCondLst>
-            </p:seq>
-          </p:childTnLst>
-        </p:cTn>
-      </p:par>
-    </p:tnLst>
-    <p:bldLst>
-      <p:bldP spid="5" grpId="0"/>
-      <p:bldP spid="14" grpId="0"/>
-      <p:bldP spid="9" grpId="0"/>
-      <p:bldP spid="11" grpId="0"/>
-    </p:bldLst>
-  </p:timing>
 </p:sld>
 </file>
 

</xml_diff>